<commit_message>
docs(pmday): add report links and slide evidence base
</commit_message>
<xml_diff>
--- a/assets/presentations/pmday-2026/ai-changes-both-sides.pptx
+++ b/assets/presentations/pmday-2026/ai-changes-both-sides.pptx
@@ -2,26 +2,26 @@
 <file path=ppt/presentation.xml><?xml version="1.0" encoding="utf-8"?>
 <p:presentation xmlns:p="http://schemas.openxmlformats.org/presentationml/2006/main">
   <p:sldMasterIdLst>
-    <p:sldMasterId xmlns:r="http://schemas.openxmlformats.org/officeDocument/2006/relationships" id="2147483648" r:id="R13d3acdc081349a5"/>
+    <p:sldMasterId xmlns:r="http://schemas.openxmlformats.org/officeDocument/2006/relationships" id="2147483648" r:id="R496859c4ee9349fe"/>
   </p:sldMasterIdLst>
   <p:notesMasterIdLst>
-    <p:notesMasterId xmlns:r="http://schemas.openxmlformats.org/officeDocument/2006/relationships" r:id="Rc1db91f7aa154e54"/>
+    <p:notesMasterId xmlns:r="http://schemas.openxmlformats.org/officeDocument/2006/relationships" r:id="R4fd85a1b130b447e"/>
   </p:notesMasterIdLst>
   <p:sldIdLst>
-    <p:sldId xmlns:r="http://schemas.openxmlformats.org/officeDocument/2006/relationships" id="256" r:id="R512bc902ff3d42e8"/>
-    <p:sldId xmlns:r="http://schemas.openxmlformats.org/officeDocument/2006/relationships" id="257" r:id="R69cbabfd669d4e8d"/>
-    <p:sldId xmlns:r="http://schemas.openxmlformats.org/officeDocument/2006/relationships" id="258" r:id="R85730ce7dc8a481f"/>
-    <p:sldId xmlns:r="http://schemas.openxmlformats.org/officeDocument/2006/relationships" id="259" r:id="R3872f71e753d4641"/>
-    <p:sldId xmlns:r="http://schemas.openxmlformats.org/officeDocument/2006/relationships" id="260" r:id="R3f362c153c944439"/>
-    <p:sldId xmlns:r="http://schemas.openxmlformats.org/officeDocument/2006/relationships" id="261" r:id="R8a364162bdcb4f24"/>
-    <p:sldId xmlns:r="http://schemas.openxmlformats.org/officeDocument/2006/relationships" id="262" r:id="Rf9881ed047ed4d6f"/>
-    <p:sldId xmlns:r="http://schemas.openxmlformats.org/officeDocument/2006/relationships" id="263" r:id="R1481d37a4433414a"/>
-    <p:sldId xmlns:r="http://schemas.openxmlformats.org/officeDocument/2006/relationships" id="264" r:id="R924fbf86fa2c4114"/>
-    <p:sldId xmlns:r="http://schemas.openxmlformats.org/officeDocument/2006/relationships" id="265" r:id="Rc301f59229e74694"/>
-    <p:sldId xmlns:r="http://schemas.openxmlformats.org/officeDocument/2006/relationships" id="266" r:id="Rf7d3068af0ec4533"/>
-    <p:sldId xmlns:r="http://schemas.openxmlformats.org/officeDocument/2006/relationships" id="267" r:id="R31dda0ff5bdd42e4"/>
-    <p:sldId xmlns:r="http://schemas.openxmlformats.org/officeDocument/2006/relationships" id="268" r:id="R89caa9f6bf314158"/>
-    <p:sldId xmlns:r="http://schemas.openxmlformats.org/officeDocument/2006/relationships" id="269" r:id="R281c5dc58a7c446f"/>
+    <p:sldId xmlns:r="http://schemas.openxmlformats.org/officeDocument/2006/relationships" id="256" r:id="R923e49171e1f443a"/>
+    <p:sldId xmlns:r="http://schemas.openxmlformats.org/officeDocument/2006/relationships" id="257" r:id="R4f038306c50a40da"/>
+    <p:sldId xmlns:r="http://schemas.openxmlformats.org/officeDocument/2006/relationships" id="258" r:id="R8b6de5764a514144"/>
+    <p:sldId xmlns:r="http://schemas.openxmlformats.org/officeDocument/2006/relationships" id="259" r:id="Ra30b16ef4ad842e8"/>
+    <p:sldId xmlns:r="http://schemas.openxmlformats.org/officeDocument/2006/relationships" id="260" r:id="Re351c7f145bb4f75"/>
+    <p:sldId xmlns:r="http://schemas.openxmlformats.org/officeDocument/2006/relationships" id="261" r:id="R4c5ac09d4a644a05"/>
+    <p:sldId xmlns:r="http://schemas.openxmlformats.org/officeDocument/2006/relationships" id="262" r:id="Rd9b556b607184f73"/>
+    <p:sldId xmlns:r="http://schemas.openxmlformats.org/officeDocument/2006/relationships" id="263" r:id="Ra9ceabe160174484"/>
+    <p:sldId xmlns:r="http://schemas.openxmlformats.org/officeDocument/2006/relationships" id="264" r:id="R0a1efa79f01542d3"/>
+    <p:sldId xmlns:r="http://schemas.openxmlformats.org/officeDocument/2006/relationships" id="265" r:id="R10d6ead121e24b33"/>
+    <p:sldId xmlns:r="http://schemas.openxmlformats.org/officeDocument/2006/relationships" id="266" r:id="R9551b9a659c34ed3"/>
+    <p:sldId xmlns:r="http://schemas.openxmlformats.org/officeDocument/2006/relationships" id="267" r:id="Rdb09cdb168fc4cba"/>
+    <p:sldId xmlns:r="http://schemas.openxmlformats.org/officeDocument/2006/relationships" id="268" r:id="R5eb35372120f4cbe"/>
+    <p:sldId xmlns:r="http://schemas.openxmlformats.org/officeDocument/2006/relationships" id="269" r:id="R85906c0d26d54b48"/>
   </p:sldIdLst>
   <p:sldSz cx="12192000" cy="6858000"/>
   <p:notesSz cx="6858000" cy="9144000"/>
@@ -1568,7 +1568,7 @@
   </p:cSld>
   <p:clrMap bg1="lt1" tx1="dk1" bg2="lt2" tx2="dk2" accent1="accent1" accent2="accent2" accent3="accent3" accent4="accent4" accent5="accent5" accent6="accent6" hlink="hlink" folHlink="folHlink"/>
   <p:sldLayoutIdLst>
-    <p:sldLayoutId xmlns:r="http://schemas.openxmlformats.org/officeDocument/2006/relationships" id="2147483649" r:id="R6abffc809b6d4aa6"/>
+    <p:sldLayoutId xmlns:r="http://schemas.openxmlformats.org/officeDocument/2006/relationships" id="2147483649" r:id="Rf2544e11b0534def"/>
   </p:sldLayoutIdLst>
   <p:txStyles>
     <p:titleStyle>
@@ -2119,7 +2119,7 @@
           <p:cNvPr id="12" name="">
             <a:extLst xmlns:a="http://schemas.openxmlformats.org/drawingml/2006/main">
               <a:ext uri="{FF2B5EF4-FFF2-40B4-BE49-F238E27FC236}">
-                <a16:creationId xmlns:a16="http://schemas.microsoft.com/office/drawing/2014/main" id="{F2D1B201-1ADC-437D-B6A6-FAFB860A0BF1}"/>
+                <a16:creationId xmlns:a16="http://schemas.microsoft.com/office/drawing/2014/main" id="{FA839367-A863-4325-AB59-210851452075}"/>
               </a:ext>
             </a:extLst>
           </p:cNvPr>
@@ -2176,7 +2176,7 @@
           <p:cNvPr id="2" name="">
             <a:extLst xmlns:a="http://schemas.openxmlformats.org/drawingml/2006/main">
               <a:ext uri="{FF2B5EF4-FFF2-40B4-BE49-F238E27FC236}">
-                <a16:creationId xmlns:a16="http://schemas.microsoft.com/office/drawing/2014/main" id="{D6F640BA-16BD-433E-9C27-7252EDD3894F}"/>
+                <a16:creationId xmlns:a16="http://schemas.microsoft.com/office/drawing/2014/main" id="{1FD86F25-7CCF-4F05-993E-C30C13759B56}"/>
               </a:ext>
             </a:extLst>
           </p:cNvPr>
@@ -2256,7 +2256,7 @@
           <p:cNvPr id="3" name="">
             <a:extLst xmlns:a="http://schemas.openxmlformats.org/drawingml/2006/main">
               <a:ext uri="{FF2B5EF4-FFF2-40B4-BE49-F238E27FC236}">
-                <a16:creationId xmlns:a16="http://schemas.microsoft.com/office/drawing/2014/main" id="{E03ECDC9-3BD8-4554-BEE3-3A7B43931CC1}"/>
+                <a16:creationId xmlns:a16="http://schemas.microsoft.com/office/drawing/2014/main" id="{1E80951D-73B8-44D9-8374-FD8020810D16}"/>
               </a:ext>
             </a:extLst>
           </p:cNvPr>
@@ -2313,7 +2313,7 @@
           <p:cNvPr id="4" name="">
             <a:extLst xmlns:a="http://schemas.openxmlformats.org/drawingml/2006/main">
               <a:ext uri="{FF2B5EF4-FFF2-40B4-BE49-F238E27FC236}">
-                <a16:creationId xmlns:a16="http://schemas.microsoft.com/office/drawing/2014/main" id="{4A7E5DF4-1D1C-4B62-AFDD-D0E6AB570093}"/>
+                <a16:creationId xmlns:a16="http://schemas.microsoft.com/office/drawing/2014/main" id="{D9BEF086-59F9-4A54-B843-3703CCCD23D6}"/>
               </a:ext>
             </a:extLst>
           </p:cNvPr>
@@ -2370,7 +2370,7 @@
           <p:cNvPr id="5" name="">
             <a:extLst xmlns:a="http://schemas.openxmlformats.org/drawingml/2006/main">
               <a:ext uri="{FF2B5EF4-FFF2-40B4-BE49-F238E27FC236}">
-                <a16:creationId xmlns:a16="http://schemas.microsoft.com/office/drawing/2014/main" id="{00793873-32B4-4EFF-BD8D-8C0FB96279F4}"/>
+                <a16:creationId xmlns:a16="http://schemas.microsoft.com/office/drawing/2014/main" id="{E281890C-5A25-4548-9F91-FB7043ABE5D9}"/>
               </a:ext>
             </a:extLst>
           </p:cNvPr>
@@ -2400,7 +2400,7 @@
           <p:cNvPr id="6" name="">
             <a:extLst xmlns:a="http://schemas.openxmlformats.org/drawingml/2006/main">
               <a:ext uri="{FF2B5EF4-FFF2-40B4-BE49-F238E27FC236}">
-                <a16:creationId xmlns:a16="http://schemas.microsoft.com/office/drawing/2014/main" id="{E069C8FE-ABA0-47AC-8A49-6E49E55D5B74}"/>
+                <a16:creationId xmlns:a16="http://schemas.microsoft.com/office/drawing/2014/main" id="{5BA8FF3B-F9A1-4D77-9097-6533A6759C60}"/>
               </a:ext>
             </a:extLst>
           </p:cNvPr>
@@ -2457,7 +2457,7 @@
           <p:cNvPr id="7" name="">
             <a:extLst xmlns:a="http://schemas.openxmlformats.org/drawingml/2006/main">
               <a:ext uri="{FF2B5EF4-FFF2-40B4-BE49-F238E27FC236}">
-                <a16:creationId xmlns:a16="http://schemas.microsoft.com/office/drawing/2014/main" id="{9B2D9C08-F244-4D77-BD7B-F864371FCE61}"/>
+                <a16:creationId xmlns:a16="http://schemas.microsoft.com/office/drawing/2014/main" id="{D69A97FF-41F7-4475-A798-7C5FC0A754EE}"/>
               </a:ext>
             </a:extLst>
           </p:cNvPr>
@@ -2514,7 +2514,7 @@
           <p:cNvPr id="8" name="">
             <a:extLst xmlns:a="http://schemas.openxmlformats.org/drawingml/2006/main">
               <a:ext uri="{FF2B5EF4-FFF2-40B4-BE49-F238E27FC236}">
-                <a16:creationId xmlns:a16="http://schemas.microsoft.com/office/drawing/2014/main" id="{8AB0D5C8-4486-444E-B47D-A7790F021F28}"/>
+                <a16:creationId xmlns:a16="http://schemas.microsoft.com/office/drawing/2014/main" id="{7B46CDF5-DFE3-476A-97D5-2E485F3085CF}"/>
               </a:ext>
             </a:extLst>
           </p:cNvPr>
@@ -2544,7 +2544,7 @@
           <p:cNvPr id="9" name="">
             <a:extLst xmlns:a="http://schemas.openxmlformats.org/drawingml/2006/main">
               <a:ext uri="{FF2B5EF4-FFF2-40B4-BE49-F238E27FC236}">
-                <a16:creationId xmlns:a16="http://schemas.microsoft.com/office/drawing/2014/main" id="{F83B51C3-887C-4FFA-97D6-3DEDB47020EE}"/>
+                <a16:creationId xmlns:a16="http://schemas.microsoft.com/office/drawing/2014/main" id="{D262E0B4-D6DE-4F98-8730-ABA331309AC3}"/>
               </a:ext>
             </a:extLst>
           </p:cNvPr>
@@ -2601,7 +2601,7 @@
           <p:cNvPr id="10" name="">
             <a:extLst xmlns:a="http://schemas.openxmlformats.org/drawingml/2006/main">
               <a:ext uri="{FF2B5EF4-FFF2-40B4-BE49-F238E27FC236}">
-                <a16:creationId xmlns:a16="http://schemas.microsoft.com/office/drawing/2014/main" id="{5D3B0FC3-E4ED-4C50-9ABF-95857E0EBF94}"/>
+                <a16:creationId xmlns:a16="http://schemas.microsoft.com/office/drawing/2014/main" id="{267A3BDC-2D1C-4160-9E3E-552EF6EF7141}"/>
               </a:ext>
             </a:extLst>
           </p:cNvPr>
@@ -2658,7 +2658,7 @@
           <p:cNvPr id="11" name="">
             <a:extLst xmlns:a="http://schemas.openxmlformats.org/drawingml/2006/main">
               <a:ext uri="{FF2B5EF4-FFF2-40B4-BE49-F238E27FC236}">
-                <a16:creationId xmlns:a16="http://schemas.microsoft.com/office/drawing/2014/main" id="{97E2EA93-706A-4F8B-ADAC-3FC0B604F204}"/>
+                <a16:creationId xmlns:a16="http://schemas.microsoft.com/office/drawing/2014/main" id="{0C2290EE-208B-482A-A4A1-EB2CD2831FFB}"/>
               </a:ext>
             </a:extLst>
           </p:cNvPr>
@@ -2713,7 +2713,7 @@
     </p:spTree>
     <p:extLst>
       <p:ext uri="{BB962C8B-B14F-4D97-AF65-F5344CB8AC3E}">
-        <p14:creationId xmlns:p14="http://schemas.microsoft.com/office/powerpoint/2010/main" val="1346493126"/>
+        <p14:creationId xmlns:p14="http://schemas.microsoft.com/office/powerpoint/2010/main" val="954493836"/>
       </p:ext>
     </p:extLst>
   </p:cSld>
@@ -2744,7 +2744,7 @@
           <p:cNvPr id="25" name="">
             <a:extLst xmlns:a="http://schemas.openxmlformats.org/drawingml/2006/main">
               <a:ext uri="{FF2B5EF4-FFF2-40B4-BE49-F238E27FC236}">
-                <a16:creationId xmlns:a16="http://schemas.microsoft.com/office/drawing/2014/main" id="{4598A0A5-B11C-44A6-A40C-4D34B72D6851}"/>
+                <a16:creationId xmlns:a16="http://schemas.microsoft.com/office/drawing/2014/main" id="{EDF28E19-5BBC-48ED-9D7B-5944CA686DD1}"/>
               </a:ext>
             </a:extLst>
           </p:cNvPr>
@@ -2801,7 +2801,7 @@
           <p:cNvPr id="2" name="">
             <a:extLst xmlns:a="http://schemas.openxmlformats.org/drawingml/2006/main">
               <a:ext uri="{FF2B5EF4-FFF2-40B4-BE49-F238E27FC236}">
-                <a16:creationId xmlns:a16="http://schemas.microsoft.com/office/drawing/2014/main" id="{04448320-D88D-4E43-A99B-7A57B689C21E}"/>
+                <a16:creationId xmlns:a16="http://schemas.microsoft.com/office/drawing/2014/main" id="{02C80F99-6B7B-4F6E-BEDE-8CCE082CC200}"/>
               </a:ext>
             </a:extLst>
           </p:cNvPr>
@@ -2832,7 +2832,7 @@
           <p:cNvPr id="3" name="">
             <a:extLst xmlns:a="http://schemas.openxmlformats.org/drawingml/2006/main">
               <a:ext uri="{FF2B5EF4-FFF2-40B4-BE49-F238E27FC236}">
-                <a16:creationId xmlns:a16="http://schemas.microsoft.com/office/drawing/2014/main" id="{2A1441BF-1ACA-4F7A-B5CB-9CDBAE37E915}"/>
+                <a16:creationId xmlns:a16="http://schemas.microsoft.com/office/drawing/2014/main" id="{B14AC92B-6101-433F-A4FD-3B53C1403C64}"/>
               </a:ext>
             </a:extLst>
           </p:cNvPr>
@@ -2889,7 +2889,7 @@
           <p:cNvPr id="4" name="">
             <a:extLst xmlns:a="http://schemas.openxmlformats.org/drawingml/2006/main">
               <a:ext uri="{FF2B5EF4-FFF2-40B4-BE49-F238E27FC236}">
-                <a16:creationId xmlns:a16="http://schemas.microsoft.com/office/drawing/2014/main" id="{1F67CF40-EB60-4993-9253-FFCFEE6BD996}"/>
+                <a16:creationId xmlns:a16="http://schemas.microsoft.com/office/drawing/2014/main" id="{8261A1C1-EBEC-493A-B11E-BF6A1425B1FF}"/>
               </a:ext>
             </a:extLst>
           </p:cNvPr>
@@ -2946,7 +2946,7 @@
           <p:cNvPr id="5" name="">
             <a:extLst xmlns:a="http://schemas.openxmlformats.org/drawingml/2006/main">
               <a:ext uri="{FF2B5EF4-FFF2-40B4-BE49-F238E27FC236}">
-                <a16:creationId xmlns:a16="http://schemas.microsoft.com/office/drawing/2014/main" id="{31AED75B-AB6C-446E-94AC-C8CE3A3E8991}"/>
+                <a16:creationId xmlns:a16="http://schemas.microsoft.com/office/drawing/2014/main" id="{1403D3E1-107B-46F3-8158-FCD659265FCF}"/>
               </a:ext>
             </a:extLst>
           </p:cNvPr>
@@ -2979,7 +2979,7 @@
           <p:cNvPr id="6" name="">
             <a:extLst xmlns:a="http://schemas.openxmlformats.org/drawingml/2006/main">
               <a:ext uri="{FF2B5EF4-FFF2-40B4-BE49-F238E27FC236}">
-                <a16:creationId xmlns:a16="http://schemas.microsoft.com/office/drawing/2014/main" id="{12BE143F-C936-4C82-95DA-C63211B80EBA}"/>
+                <a16:creationId xmlns:a16="http://schemas.microsoft.com/office/drawing/2014/main" id="{7DB485AA-8735-4E68-8DBD-9E9178474115}"/>
               </a:ext>
             </a:extLst>
           </p:cNvPr>
@@ -3036,7 +3036,7 @@
           <p:cNvPr id="7" name="">
             <a:extLst xmlns:a="http://schemas.openxmlformats.org/drawingml/2006/main">
               <a:ext uri="{FF2B5EF4-FFF2-40B4-BE49-F238E27FC236}">
-                <a16:creationId xmlns:a16="http://schemas.microsoft.com/office/drawing/2014/main" id="{C8AD6278-16BC-4341-BC26-75BA0FDF29C4}"/>
+                <a16:creationId xmlns:a16="http://schemas.microsoft.com/office/drawing/2014/main" id="{2BC2B5CA-9C52-4193-99A4-CEFAF7C48E42}"/>
               </a:ext>
             </a:extLst>
           </p:cNvPr>
@@ -3069,7 +3069,7 @@
           <p:cNvPr id="8" name="">
             <a:extLst xmlns:a="http://schemas.openxmlformats.org/drawingml/2006/main">
               <a:ext uri="{FF2B5EF4-FFF2-40B4-BE49-F238E27FC236}">
-                <a16:creationId xmlns:a16="http://schemas.microsoft.com/office/drawing/2014/main" id="{E6EA7050-0B36-46F9-9F0C-38CE02EE3026}"/>
+                <a16:creationId xmlns:a16="http://schemas.microsoft.com/office/drawing/2014/main" id="{FCC90027-FBEB-4C21-B6D3-7C83A067C919}"/>
               </a:ext>
             </a:extLst>
           </p:cNvPr>
@@ -3126,7 +3126,7 @@
           <p:cNvPr id="9" name="">
             <a:extLst xmlns:a="http://schemas.openxmlformats.org/drawingml/2006/main">
               <a:ext uri="{FF2B5EF4-FFF2-40B4-BE49-F238E27FC236}">
-                <a16:creationId xmlns:a16="http://schemas.microsoft.com/office/drawing/2014/main" id="{FDA341BD-224C-44EF-BDF3-50F1573B358F}"/>
+                <a16:creationId xmlns:a16="http://schemas.microsoft.com/office/drawing/2014/main" id="{EC5AA601-24C8-4257-828B-510C5AC9DA74}"/>
               </a:ext>
             </a:extLst>
           </p:cNvPr>
@@ -3159,7 +3159,7 @@
           <p:cNvPr id="10" name="">
             <a:extLst xmlns:a="http://schemas.openxmlformats.org/drawingml/2006/main">
               <a:ext uri="{FF2B5EF4-FFF2-40B4-BE49-F238E27FC236}">
-                <a16:creationId xmlns:a16="http://schemas.microsoft.com/office/drawing/2014/main" id="{B21C555D-ABDE-44E5-ACB6-CD5DCC3EA286}"/>
+                <a16:creationId xmlns:a16="http://schemas.microsoft.com/office/drawing/2014/main" id="{CE956828-1370-4194-AC6C-A331FA1BCEF2}"/>
               </a:ext>
             </a:extLst>
           </p:cNvPr>
@@ -3216,7 +3216,7 @@
           <p:cNvPr id="11" name="">
             <a:extLst xmlns:a="http://schemas.openxmlformats.org/drawingml/2006/main">
               <a:ext uri="{FF2B5EF4-FFF2-40B4-BE49-F238E27FC236}">
-                <a16:creationId xmlns:a16="http://schemas.microsoft.com/office/drawing/2014/main" id="{BB74F944-AEA2-484E-B82C-76C208FC368C}"/>
+                <a16:creationId xmlns:a16="http://schemas.microsoft.com/office/drawing/2014/main" id="{0F681FE4-60B5-4669-A9FD-F1A1865E7D99}"/>
               </a:ext>
             </a:extLst>
           </p:cNvPr>
@@ -3249,7 +3249,7 @@
           <p:cNvPr id="12" name="">
             <a:extLst xmlns:a="http://schemas.openxmlformats.org/drawingml/2006/main">
               <a:ext uri="{FF2B5EF4-FFF2-40B4-BE49-F238E27FC236}">
-                <a16:creationId xmlns:a16="http://schemas.microsoft.com/office/drawing/2014/main" id="{7553B584-86E0-44CE-88D0-59F670A4F7DB}"/>
+                <a16:creationId xmlns:a16="http://schemas.microsoft.com/office/drawing/2014/main" id="{021AADA4-24CB-4BDB-A3C4-B89EB45589B7}"/>
               </a:ext>
             </a:extLst>
           </p:cNvPr>
@@ -3306,7 +3306,7 @@
           <p:cNvPr id="13" name="">
             <a:extLst xmlns:a="http://schemas.openxmlformats.org/drawingml/2006/main">
               <a:ext uri="{FF2B5EF4-FFF2-40B4-BE49-F238E27FC236}">
-                <a16:creationId xmlns:a16="http://schemas.microsoft.com/office/drawing/2014/main" id="{73BEBDE0-98E5-44E9-B16F-16BFC4514D51}"/>
+                <a16:creationId xmlns:a16="http://schemas.microsoft.com/office/drawing/2014/main" id="{5DE25C60-5243-4D9A-BDDF-41CBE64AD695}"/>
               </a:ext>
             </a:extLst>
           </p:cNvPr>
@@ -3339,7 +3339,7 @@
           <p:cNvPr id="14" name="">
             <a:extLst xmlns:a="http://schemas.openxmlformats.org/drawingml/2006/main">
               <a:ext uri="{FF2B5EF4-FFF2-40B4-BE49-F238E27FC236}">
-                <a16:creationId xmlns:a16="http://schemas.microsoft.com/office/drawing/2014/main" id="{1B21F93E-19ED-4845-99A5-F608D865A0A7}"/>
+                <a16:creationId xmlns:a16="http://schemas.microsoft.com/office/drawing/2014/main" id="{101137C5-31C5-40A4-986E-18CC799601CD}"/>
               </a:ext>
             </a:extLst>
           </p:cNvPr>
@@ -3500,7 +3500,7 @@
           <p:cNvPr id="19" name="">
             <a:extLst xmlns:a="http://schemas.openxmlformats.org/drawingml/2006/main">
               <a:ext uri="{FF2B5EF4-FFF2-40B4-BE49-F238E27FC236}">
-                <a16:creationId xmlns:a16="http://schemas.microsoft.com/office/drawing/2014/main" id="{1B06C00E-5432-4F36-8D07-918363ACA54B}"/>
+                <a16:creationId xmlns:a16="http://schemas.microsoft.com/office/drawing/2014/main" id="{D3937689-7EC9-4BA5-A44D-C581D06A2142}"/>
               </a:ext>
             </a:extLst>
           </p:cNvPr>
@@ -3557,7 +3557,7 @@
           <p:cNvPr id="20" name="">
             <a:extLst xmlns:a="http://schemas.openxmlformats.org/drawingml/2006/main">
               <a:ext uri="{FF2B5EF4-FFF2-40B4-BE49-F238E27FC236}">
-                <a16:creationId xmlns:a16="http://schemas.microsoft.com/office/drawing/2014/main" id="{C7817D22-4286-46FA-B5C2-25FD595D5C9B}"/>
+                <a16:creationId xmlns:a16="http://schemas.microsoft.com/office/drawing/2014/main" id="{46E5DCEF-8AC4-4620-916C-DD6B48B460B2}"/>
               </a:ext>
             </a:extLst>
           </p:cNvPr>
@@ -3614,7 +3614,7 @@
           <p:cNvPr id="21" name="">
             <a:extLst xmlns:a="http://schemas.openxmlformats.org/drawingml/2006/main">
               <a:ext uri="{FF2B5EF4-FFF2-40B4-BE49-F238E27FC236}">
-                <a16:creationId xmlns:a16="http://schemas.microsoft.com/office/drawing/2014/main" id="{26E93C63-04B1-49A5-8D32-D9AF1B37A22B}"/>
+                <a16:creationId xmlns:a16="http://schemas.microsoft.com/office/drawing/2014/main" id="{EFD802AB-01CA-4AF3-8C0B-3AAA378A2661}"/>
               </a:ext>
             </a:extLst>
           </p:cNvPr>
@@ -3671,7 +3671,7 @@
           <p:cNvPr id="22" name="">
             <a:extLst xmlns:a="http://schemas.openxmlformats.org/drawingml/2006/main">
               <a:ext uri="{FF2B5EF4-FFF2-40B4-BE49-F238E27FC236}">
-                <a16:creationId xmlns:a16="http://schemas.microsoft.com/office/drawing/2014/main" id="{80C47845-8058-4702-8C08-D913D80180B6}"/>
+                <a16:creationId xmlns:a16="http://schemas.microsoft.com/office/drawing/2014/main" id="{8A2A8DF9-7E7C-4741-BDAC-0D7FA65D04F2}"/>
               </a:ext>
             </a:extLst>
           </p:cNvPr>
@@ -3728,7 +3728,7 @@
           <p:cNvPr id="23" name="">
             <a:extLst xmlns:a="http://schemas.openxmlformats.org/drawingml/2006/main">
               <a:ext uri="{FF2B5EF4-FFF2-40B4-BE49-F238E27FC236}">
-                <a16:creationId xmlns:a16="http://schemas.microsoft.com/office/drawing/2014/main" id="{A1899528-C814-4F7C-8993-6B5947F140E6}"/>
+                <a16:creationId xmlns:a16="http://schemas.microsoft.com/office/drawing/2014/main" id="{452315B9-36DE-47E5-9693-62CD1DFE0EB9}"/>
               </a:ext>
             </a:extLst>
           </p:cNvPr>
@@ -3759,7 +3759,7 @@
           <p:cNvPr id="24" name="">
             <a:extLst xmlns:a="http://schemas.openxmlformats.org/drawingml/2006/main">
               <a:ext uri="{FF2B5EF4-FFF2-40B4-BE49-F238E27FC236}">
-                <a16:creationId xmlns:a16="http://schemas.microsoft.com/office/drawing/2014/main" id="{AEC3899C-565F-4806-B5D4-0CEF51D24D74}"/>
+                <a16:creationId xmlns:a16="http://schemas.microsoft.com/office/drawing/2014/main" id="{88F4B0C4-6643-41EA-9AF0-9B8746A89E2B}"/>
               </a:ext>
             </a:extLst>
           </p:cNvPr>
@@ -3814,7 +3814,7 @@
     </p:spTree>
     <p:extLst>
       <p:ext uri="{BB962C8B-B14F-4D97-AF65-F5344CB8AC3E}">
-        <p14:creationId xmlns:p14="http://schemas.microsoft.com/office/powerpoint/2010/main" val="680930229"/>
+        <p14:creationId xmlns:p14="http://schemas.microsoft.com/office/powerpoint/2010/main" val="1177299668"/>
       </p:ext>
     </p:extLst>
   </p:cSld>
@@ -3845,7 +3845,7 @@
           <p:cNvPr id="8" name="">
             <a:extLst xmlns:a="http://schemas.openxmlformats.org/drawingml/2006/main">
               <a:ext uri="{FF2B5EF4-FFF2-40B4-BE49-F238E27FC236}">
-                <a16:creationId xmlns:a16="http://schemas.microsoft.com/office/drawing/2014/main" id="{003A2F0A-65AC-4690-AC30-E262BD38A1B4}"/>
+                <a16:creationId xmlns:a16="http://schemas.microsoft.com/office/drawing/2014/main" id="{0A207C99-91D7-44E5-B4CB-96CB5F76598F}"/>
               </a:ext>
             </a:extLst>
           </p:cNvPr>
@@ -3902,7 +3902,7 @@
           <p:cNvPr id="2" name="">
             <a:extLst xmlns:a="http://schemas.openxmlformats.org/drawingml/2006/main">
               <a:ext uri="{FF2B5EF4-FFF2-40B4-BE49-F238E27FC236}">
-                <a16:creationId xmlns:a16="http://schemas.microsoft.com/office/drawing/2014/main" id="{7B4B6390-CFA8-4763-B8C0-331E72644D6F}"/>
+                <a16:creationId xmlns:a16="http://schemas.microsoft.com/office/drawing/2014/main" id="{6C0A7241-BC08-4410-82AC-EE977A821887}"/>
               </a:ext>
             </a:extLst>
           </p:cNvPr>
@@ -3933,7 +3933,7 @@
           <p:cNvPr id="3" name="">
             <a:extLst xmlns:a="http://schemas.openxmlformats.org/drawingml/2006/main">
               <a:ext uri="{FF2B5EF4-FFF2-40B4-BE49-F238E27FC236}">
-                <a16:creationId xmlns:a16="http://schemas.microsoft.com/office/drawing/2014/main" id="{CBEC3859-004C-4164-A145-BD7435D466EC}"/>
+                <a16:creationId xmlns:a16="http://schemas.microsoft.com/office/drawing/2014/main" id="{692BB619-4C0E-43DA-8DCD-BDA1D4633B85}"/>
               </a:ext>
             </a:extLst>
           </p:cNvPr>
@@ -4333,7 +4333,7 @@
           <p:cNvPr id="5" name="">
             <a:extLst xmlns:a="http://schemas.openxmlformats.org/drawingml/2006/main">
               <a:ext uri="{FF2B5EF4-FFF2-40B4-BE49-F238E27FC236}">
-                <a16:creationId xmlns:a16="http://schemas.microsoft.com/office/drawing/2014/main" id="{5AE62637-B381-42B9-B062-211638C25795}"/>
+                <a16:creationId xmlns:a16="http://schemas.microsoft.com/office/drawing/2014/main" id="{958610E5-AC90-4674-8C81-618B9CB7C18C}"/>
               </a:ext>
             </a:extLst>
           </p:cNvPr>
@@ -4390,7 +4390,7 @@
           <p:cNvPr id="6" name="">
             <a:extLst xmlns:a="http://schemas.openxmlformats.org/drawingml/2006/main">
               <a:ext uri="{FF2B5EF4-FFF2-40B4-BE49-F238E27FC236}">
-                <a16:creationId xmlns:a16="http://schemas.microsoft.com/office/drawing/2014/main" id="{D22A76CB-3D9B-47FF-9071-477273A86668}"/>
+                <a16:creationId xmlns:a16="http://schemas.microsoft.com/office/drawing/2014/main" id="{D7EFFEBB-E0BC-4E14-8A10-AA0D432F5A9C}"/>
               </a:ext>
             </a:extLst>
           </p:cNvPr>
@@ -4421,7 +4421,7 @@
           <p:cNvPr id="7" name="">
             <a:extLst xmlns:a="http://schemas.openxmlformats.org/drawingml/2006/main">
               <a:ext uri="{FF2B5EF4-FFF2-40B4-BE49-F238E27FC236}">
-                <a16:creationId xmlns:a16="http://schemas.microsoft.com/office/drawing/2014/main" id="{3C0B7077-2A65-47CD-97E7-5DF8A78DFEA1}"/>
+                <a16:creationId xmlns:a16="http://schemas.microsoft.com/office/drawing/2014/main" id="{08FF74D7-CBC1-47B8-89AE-054FF0343799}"/>
               </a:ext>
             </a:extLst>
           </p:cNvPr>
@@ -4476,7 +4476,7 @@
     </p:spTree>
     <p:extLst>
       <p:ext uri="{BB962C8B-B14F-4D97-AF65-F5344CB8AC3E}">
-        <p14:creationId xmlns:p14="http://schemas.microsoft.com/office/powerpoint/2010/main" val="1912073586"/>
+        <p14:creationId xmlns:p14="http://schemas.microsoft.com/office/powerpoint/2010/main" val="1152151155"/>
       </p:ext>
     </p:extLst>
   </p:cSld>
@@ -4507,7 +4507,7 @@
           <p:cNvPr id="32" name="">
             <a:extLst xmlns:a="http://schemas.openxmlformats.org/drawingml/2006/main">
               <a:ext uri="{FF2B5EF4-FFF2-40B4-BE49-F238E27FC236}">
-                <a16:creationId xmlns:a16="http://schemas.microsoft.com/office/drawing/2014/main" id="{2366DA4D-0A65-4601-BCC0-1C08792D7AFB}"/>
+                <a16:creationId xmlns:a16="http://schemas.microsoft.com/office/drawing/2014/main" id="{378B86C4-B917-4814-80A1-63F646AC3E93}"/>
               </a:ext>
             </a:extLst>
           </p:cNvPr>
@@ -4564,7 +4564,7 @@
           <p:cNvPr id="2" name="">
             <a:extLst xmlns:a="http://schemas.openxmlformats.org/drawingml/2006/main">
               <a:ext uri="{FF2B5EF4-FFF2-40B4-BE49-F238E27FC236}">
-                <a16:creationId xmlns:a16="http://schemas.microsoft.com/office/drawing/2014/main" id="{9F6DCCF3-9CAC-41E1-9E8A-E6D8041B2EDC}"/>
+                <a16:creationId xmlns:a16="http://schemas.microsoft.com/office/drawing/2014/main" id="{49241266-98A8-4E68-9787-D48CB9C9A4BD}"/>
               </a:ext>
             </a:extLst>
           </p:cNvPr>
@@ -4595,7 +4595,7 @@
           <p:cNvPr id="3" name="">
             <a:extLst xmlns:a="http://schemas.openxmlformats.org/drawingml/2006/main">
               <a:ext uri="{FF2B5EF4-FFF2-40B4-BE49-F238E27FC236}">
-                <a16:creationId xmlns:a16="http://schemas.microsoft.com/office/drawing/2014/main" id="{496206CC-8029-4C9B-A39A-52D9777F8027}"/>
+                <a16:creationId xmlns:a16="http://schemas.microsoft.com/office/drawing/2014/main" id="{88C7CF71-BEA6-4905-A08A-63A0D341F519}"/>
               </a:ext>
             </a:extLst>
           </p:cNvPr>
@@ -4652,7 +4652,7 @@
           <p:cNvPr id="4" name="">
             <a:extLst xmlns:a="http://schemas.openxmlformats.org/drawingml/2006/main">
               <a:ext uri="{FF2B5EF4-FFF2-40B4-BE49-F238E27FC236}">
-                <a16:creationId xmlns:a16="http://schemas.microsoft.com/office/drawing/2014/main" id="{C068A27C-6AC5-4472-907D-F973F6D52B0D}"/>
+                <a16:creationId xmlns:a16="http://schemas.microsoft.com/office/drawing/2014/main" id="{4D3905FE-5713-4E8B-8CD6-5AE56239F2F2}"/>
               </a:ext>
             </a:extLst>
           </p:cNvPr>
@@ -4685,7 +4685,7 @@
           <p:cNvPr id="5" name="">
             <a:extLst xmlns:a="http://schemas.openxmlformats.org/drawingml/2006/main">
               <a:ext uri="{FF2B5EF4-FFF2-40B4-BE49-F238E27FC236}">
-                <a16:creationId xmlns:a16="http://schemas.microsoft.com/office/drawing/2014/main" id="{178042C9-FC1E-499D-8BDC-EA1BE62640D4}"/>
+                <a16:creationId xmlns:a16="http://schemas.microsoft.com/office/drawing/2014/main" id="{6A63C8AE-D190-42A3-A808-0F3933F00FCC}"/>
               </a:ext>
             </a:extLst>
           </p:cNvPr>
@@ -4742,7 +4742,7 @@
           <p:cNvPr id="6" name="">
             <a:extLst xmlns:a="http://schemas.openxmlformats.org/drawingml/2006/main">
               <a:ext uri="{FF2B5EF4-FFF2-40B4-BE49-F238E27FC236}">
-                <a16:creationId xmlns:a16="http://schemas.microsoft.com/office/drawing/2014/main" id="{89494FED-BA86-4F99-9FB7-895F7B6B952B}"/>
+                <a16:creationId xmlns:a16="http://schemas.microsoft.com/office/drawing/2014/main" id="{84F5D3A7-92C9-47AB-8FEF-9358AFAF55F2}"/>
               </a:ext>
             </a:extLst>
           </p:cNvPr>
@@ -4775,7 +4775,7 @@
           <p:cNvPr id="7" name="">
             <a:extLst xmlns:a="http://schemas.openxmlformats.org/drawingml/2006/main">
               <a:ext uri="{FF2B5EF4-FFF2-40B4-BE49-F238E27FC236}">
-                <a16:creationId xmlns:a16="http://schemas.microsoft.com/office/drawing/2014/main" id="{6890FBDD-D559-4302-8B05-6D31B45C3B1F}"/>
+                <a16:creationId xmlns:a16="http://schemas.microsoft.com/office/drawing/2014/main" id="{45307267-E16C-448B-BA92-A923E175EC13}"/>
               </a:ext>
             </a:extLst>
           </p:cNvPr>
@@ -4832,7 +4832,7 @@
           <p:cNvPr id="8" name="">
             <a:extLst xmlns:a="http://schemas.openxmlformats.org/drawingml/2006/main">
               <a:ext uri="{FF2B5EF4-FFF2-40B4-BE49-F238E27FC236}">
-                <a16:creationId xmlns:a16="http://schemas.microsoft.com/office/drawing/2014/main" id="{B7984546-C221-49C1-A906-8203C2428D77}"/>
+                <a16:creationId xmlns:a16="http://schemas.microsoft.com/office/drawing/2014/main" id="{2DAFC8A9-0D88-4A0A-AA2B-9CFA7651FE4B}"/>
               </a:ext>
             </a:extLst>
           </p:cNvPr>
@@ -4865,7 +4865,7 @@
           <p:cNvPr id="9" name="">
             <a:extLst xmlns:a="http://schemas.openxmlformats.org/drawingml/2006/main">
               <a:ext uri="{FF2B5EF4-FFF2-40B4-BE49-F238E27FC236}">
-                <a16:creationId xmlns:a16="http://schemas.microsoft.com/office/drawing/2014/main" id="{A49F9DFA-95C6-4B17-96BD-08E3C46497A9}"/>
+                <a16:creationId xmlns:a16="http://schemas.microsoft.com/office/drawing/2014/main" id="{021C4F41-C31D-41BE-9A46-C6F57419623E}"/>
               </a:ext>
             </a:extLst>
           </p:cNvPr>
@@ -4922,7 +4922,7 @@
           <p:cNvPr id="10" name="">
             <a:extLst xmlns:a="http://schemas.openxmlformats.org/drawingml/2006/main">
               <a:ext uri="{FF2B5EF4-FFF2-40B4-BE49-F238E27FC236}">
-                <a16:creationId xmlns:a16="http://schemas.microsoft.com/office/drawing/2014/main" id="{978D3C10-06DA-4288-A058-A0F692EDDE0C}"/>
+                <a16:creationId xmlns:a16="http://schemas.microsoft.com/office/drawing/2014/main" id="{A6285A73-1F7C-436C-B1C4-36DA0BCECD3A}"/>
               </a:ext>
             </a:extLst>
           </p:cNvPr>
@@ -4955,7 +4955,7 @@
           <p:cNvPr id="11" name="">
             <a:extLst xmlns:a="http://schemas.openxmlformats.org/drawingml/2006/main">
               <a:ext uri="{FF2B5EF4-FFF2-40B4-BE49-F238E27FC236}">
-                <a16:creationId xmlns:a16="http://schemas.microsoft.com/office/drawing/2014/main" id="{4CAAC1D8-3E1C-4398-AE80-C81C0748D334}"/>
+                <a16:creationId xmlns:a16="http://schemas.microsoft.com/office/drawing/2014/main" id="{B85D8584-B35A-4768-BCBA-AAD9934D9F5D}"/>
               </a:ext>
             </a:extLst>
           </p:cNvPr>
@@ -5012,7 +5012,7 @@
           <p:cNvPr id="12" name="">
             <a:extLst xmlns:a="http://schemas.openxmlformats.org/drawingml/2006/main">
               <a:ext uri="{FF2B5EF4-FFF2-40B4-BE49-F238E27FC236}">
-                <a16:creationId xmlns:a16="http://schemas.microsoft.com/office/drawing/2014/main" id="{7D6AFE3E-2494-4619-ACDB-5357DCBD6A8D}"/>
+                <a16:creationId xmlns:a16="http://schemas.microsoft.com/office/drawing/2014/main" id="{124B8EC7-17EE-413D-BF28-E44795E697C0}"/>
               </a:ext>
             </a:extLst>
           </p:cNvPr>
@@ -5045,7 +5045,7 @@
           <p:cNvPr id="13" name="">
             <a:extLst xmlns:a="http://schemas.openxmlformats.org/drawingml/2006/main">
               <a:ext uri="{FF2B5EF4-FFF2-40B4-BE49-F238E27FC236}">
-                <a16:creationId xmlns:a16="http://schemas.microsoft.com/office/drawing/2014/main" id="{2F9B878D-FB87-4B83-8F4F-F57B7C5D1092}"/>
+                <a16:creationId xmlns:a16="http://schemas.microsoft.com/office/drawing/2014/main" id="{5017CBE9-DF80-4D44-AFBE-F70AB313C33D}"/>
               </a:ext>
             </a:extLst>
           </p:cNvPr>
@@ -5206,7 +5206,7 @@
           <p:cNvPr id="18" name="">
             <a:extLst xmlns:a="http://schemas.openxmlformats.org/drawingml/2006/main">
               <a:ext uri="{FF2B5EF4-FFF2-40B4-BE49-F238E27FC236}">
-                <a16:creationId xmlns:a16="http://schemas.microsoft.com/office/drawing/2014/main" id="{7A9E7BFE-776A-4D96-858F-B8A4AF8675DB}"/>
+                <a16:creationId xmlns:a16="http://schemas.microsoft.com/office/drawing/2014/main" id="{4C6F3D6C-BE55-4358-AF2B-EAFF5881AAA2}"/>
               </a:ext>
             </a:extLst>
           </p:cNvPr>
@@ -5239,7 +5239,7 @@
           <p:cNvPr id="19" name="">
             <a:extLst xmlns:a="http://schemas.openxmlformats.org/drawingml/2006/main">
               <a:ext uri="{FF2B5EF4-FFF2-40B4-BE49-F238E27FC236}">
-                <a16:creationId xmlns:a16="http://schemas.microsoft.com/office/drawing/2014/main" id="{66023EFD-DDBE-40A5-89F2-63161BE287AA}"/>
+                <a16:creationId xmlns:a16="http://schemas.microsoft.com/office/drawing/2014/main" id="{1FAC484C-F247-46D0-A68D-DBD5F8BB0F85}"/>
               </a:ext>
             </a:extLst>
           </p:cNvPr>
@@ -5296,7 +5296,7 @@
           <p:cNvPr id="20" name="">
             <a:extLst xmlns:a="http://schemas.openxmlformats.org/drawingml/2006/main">
               <a:ext uri="{FF2B5EF4-FFF2-40B4-BE49-F238E27FC236}">
-                <a16:creationId xmlns:a16="http://schemas.microsoft.com/office/drawing/2014/main" id="{7F31F24C-2B55-4387-B9E9-47034078E56A}"/>
+                <a16:creationId xmlns:a16="http://schemas.microsoft.com/office/drawing/2014/main" id="{8F7CDE89-4BCB-4169-87AD-833F4C22A620}"/>
               </a:ext>
             </a:extLst>
           </p:cNvPr>
@@ -5329,7 +5329,7 @@
           <p:cNvPr id="21" name="">
             <a:extLst xmlns:a="http://schemas.openxmlformats.org/drawingml/2006/main">
               <a:ext uri="{FF2B5EF4-FFF2-40B4-BE49-F238E27FC236}">
-                <a16:creationId xmlns:a16="http://schemas.microsoft.com/office/drawing/2014/main" id="{C03FAE3D-CD1B-46C0-933F-59769CE04852}"/>
+                <a16:creationId xmlns:a16="http://schemas.microsoft.com/office/drawing/2014/main" id="{F0E52DF2-3231-4AC8-9224-C6BC9B27B6CD}"/>
               </a:ext>
             </a:extLst>
           </p:cNvPr>
@@ -5386,7 +5386,7 @@
           <p:cNvPr id="22" name="">
             <a:extLst xmlns:a="http://schemas.openxmlformats.org/drawingml/2006/main">
               <a:ext uri="{FF2B5EF4-FFF2-40B4-BE49-F238E27FC236}">
-                <a16:creationId xmlns:a16="http://schemas.microsoft.com/office/drawing/2014/main" id="{8C089089-B523-4F47-957E-A6ADCE5EBD97}"/>
+                <a16:creationId xmlns:a16="http://schemas.microsoft.com/office/drawing/2014/main" id="{D07003CB-47AF-4B7C-8C43-1AC3BD1426EE}"/>
               </a:ext>
             </a:extLst>
           </p:cNvPr>
@@ -5419,7 +5419,7 @@
           <p:cNvPr id="23" name="">
             <a:extLst xmlns:a="http://schemas.openxmlformats.org/drawingml/2006/main">
               <a:ext uri="{FF2B5EF4-FFF2-40B4-BE49-F238E27FC236}">
-                <a16:creationId xmlns:a16="http://schemas.microsoft.com/office/drawing/2014/main" id="{02619AA8-9E04-494F-9C2C-4375A2894CFA}"/>
+                <a16:creationId xmlns:a16="http://schemas.microsoft.com/office/drawing/2014/main" id="{EE3744E8-5FFA-4FAE-A8D7-20C3DB9C7E9F}"/>
               </a:ext>
             </a:extLst>
           </p:cNvPr>
@@ -5583,7 +5583,7 @@
           <p:cNvPr id="28" name="">
             <a:extLst xmlns:a="http://schemas.openxmlformats.org/drawingml/2006/main">
               <a:ext uri="{FF2B5EF4-FFF2-40B4-BE49-F238E27FC236}">
-                <a16:creationId xmlns:a16="http://schemas.microsoft.com/office/drawing/2014/main" id="{07F0A63F-BB1D-42E0-8A1A-BA7DFC827DBD}"/>
+                <a16:creationId xmlns:a16="http://schemas.microsoft.com/office/drawing/2014/main" id="{ADE7DD24-BEFA-4B5A-BF3B-53FBEF73FB63}"/>
               </a:ext>
             </a:extLst>
           </p:cNvPr>
@@ -5640,7 +5640,7 @@
           <p:cNvPr id="29" name="">
             <a:extLst xmlns:a="http://schemas.openxmlformats.org/drawingml/2006/main">
               <a:ext uri="{FF2B5EF4-FFF2-40B4-BE49-F238E27FC236}">
-                <a16:creationId xmlns:a16="http://schemas.microsoft.com/office/drawing/2014/main" id="{93B2AEFF-6AFD-4326-BEEC-A39B71B23650}"/>
+                <a16:creationId xmlns:a16="http://schemas.microsoft.com/office/drawing/2014/main" id="{07C15867-BC4E-4A9B-A386-81B9A83CD5C1}"/>
               </a:ext>
             </a:extLst>
           </p:cNvPr>
@@ -5697,7 +5697,7 @@
           <p:cNvPr id="30" name="">
             <a:extLst xmlns:a="http://schemas.openxmlformats.org/drawingml/2006/main">
               <a:ext uri="{FF2B5EF4-FFF2-40B4-BE49-F238E27FC236}">
-                <a16:creationId xmlns:a16="http://schemas.microsoft.com/office/drawing/2014/main" id="{4198630A-6132-4F99-814A-A496065279FE}"/>
+                <a16:creationId xmlns:a16="http://schemas.microsoft.com/office/drawing/2014/main" id="{12E1DA32-0436-4134-8FD4-486A434485C8}"/>
               </a:ext>
             </a:extLst>
           </p:cNvPr>
@@ -5728,7 +5728,7 @@
           <p:cNvPr id="31" name="">
             <a:extLst xmlns:a="http://schemas.openxmlformats.org/drawingml/2006/main">
               <a:ext uri="{FF2B5EF4-FFF2-40B4-BE49-F238E27FC236}">
-                <a16:creationId xmlns:a16="http://schemas.microsoft.com/office/drawing/2014/main" id="{0F1B4427-07A0-4798-883D-2BC885E8A778}"/>
+                <a16:creationId xmlns:a16="http://schemas.microsoft.com/office/drawing/2014/main" id="{D11F4671-AA7F-492B-9E81-1BC3046780D3}"/>
               </a:ext>
             </a:extLst>
           </p:cNvPr>
@@ -5783,7 +5783,7 @@
     </p:spTree>
     <p:extLst>
       <p:ext uri="{BB962C8B-B14F-4D97-AF65-F5344CB8AC3E}">
-        <p14:creationId xmlns:p14="http://schemas.microsoft.com/office/powerpoint/2010/main" val="1282361897"/>
+        <p14:creationId xmlns:p14="http://schemas.microsoft.com/office/powerpoint/2010/main" val="490854975"/>
       </p:ext>
     </p:extLst>
   </p:cSld>
@@ -5814,7 +5814,7 @@
           <p:cNvPr id="7" name="">
             <a:extLst xmlns:a="http://schemas.openxmlformats.org/drawingml/2006/main">
               <a:ext uri="{FF2B5EF4-FFF2-40B4-BE49-F238E27FC236}">
-                <a16:creationId xmlns:a16="http://schemas.microsoft.com/office/drawing/2014/main" id="{31F9D716-EC61-444E-85C9-D0A0783BBFBC}"/>
+                <a16:creationId xmlns:a16="http://schemas.microsoft.com/office/drawing/2014/main" id="{608EC4F2-1ACD-4917-8204-2FD16CA65AD4}"/>
               </a:ext>
             </a:extLst>
           </p:cNvPr>
@@ -5871,7 +5871,7 @@
           <p:cNvPr id="2" name="">
             <a:extLst xmlns:a="http://schemas.openxmlformats.org/drawingml/2006/main">
               <a:ext uri="{FF2B5EF4-FFF2-40B4-BE49-F238E27FC236}">
-                <a16:creationId xmlns:a16="http://schemas.microsoft.com/office/drawing/2014/main" id="{B5B029CF-CBC1-4C17-993C-68EDEC72B0EB}"/>
+                <a16:creationId xmlns:a16="http://schemas.microsoft.com/office/drawing/2014/main" id="{95DEC756-EE8B-4DF3-B900-6B3F60AB1B3F}"/>
               </a:ext>
             </a:extLst>
           </p:cNvPr>
@@ -5902,7 +5902,7 @@
           <p:cNvPr id="3" name="">
             <a:extLst xmlns:a="http://schemas.openxmlformats.org/drawingml/2006/main">
               <a:ext uri="{FF2B5EF4-FFF2-40B4-BE49-F238E27FC236}">
-                <a16:creationId xmlns:a16="http://schemas.microsoft.com/office/drawing/2014/main" id="{9A415200-AF5A-4E63-BBA6-C033D4CFEB4D}"/>
+                <a16:creationId xmlns:a16="http://schemas.microsoft.com/office/drawing/2014/main" id="{91A596EB-B5F6-486E-BA5D-77A64F38F7F5}"/>
               </a:ext>
             </a:extLst>
           </p:cNvPr>
@@ -6382,7 +6382,7 @@
           <p:cNvPr id="5" name="">
             <a:extLst xmlns:a="http://schemas.openxmlformats.org/drawingml/2006/main">
               <a:ext uri="{FF2B5EF4-FFF2-40B4-BE49-F238E27FC236}">
-                <a16:creationId xmlns:a16="http://schemas.microsoft.com/office/drawing/2014/main" id="{CC56726E-37ED-400C-B3CD-20EAFAB24B93}"/>
+                <a16:creationId xmlns:a16="http://schemas.microsoft.com/office/drawing/2014/main" id="{1D692A83-6049-4FCC-9882-B85AA11431E3}"/>
               </a:ext>
             </a:extLst>
           </p:cNvPr>
@@ -6413,7 +6413,7 @@
           <p:cNvPr id="6" name="">
             <a:extLst xmlns:a="http://schemas.openxmlformats.org/drawingml/2006/main">
               <a:ext uri="{FF2B5EF4-FFF2-40B4-BE49-F238E27FC236}">
-                <a16:creationId xmlns:a16="http://schemas.microsoft.com/office/drawing/2014/main" id="{303E08BE-F5A9-4CAD-8901-28CDCEABAD31}"/>
+                <a16:creationId xmlns:a16="http://schemas.microsoft.com/office/drawing/2014/main" id="{8BDF9B82-DE3E-45E1-8B31-F14C67DA36D5}"/>
               </a:ext>
             </a:extLst>
           </p:cNvPr>
@@ -6468,7 +6468,7 @@
     </p:spTree>
     <p:extLst>
       <p:ext uri="{BB962C8B-B14F-4D97-AF65-F5344CB8AC3E}">
-        <p14:creationId xmlns:p14="http://schemas.microsoft.com/office/powerpoint/2010/main" val="78445682"/>
+        <p14:creationId xmlns:p14="http://schemas.microsoft.com/office/powerpoint/2010/main" val="2102884936"/>
       </p:ext>
     </p:extLst>
   </p:cSld>
@@ -6499,7 +6499,7 @@
           <p:cNvPr id="21" name="">
             <a:extLst xmlns:a="http://schemas.openxmlformats.org/drawingml/2006/main">
               <a:ext uri="{FF2B5EF4-FFF2-40B4-BE49-F238E27FC236}">
-                <a16:creationId xmlns:a16="http://schemas.microsoft.com/office/drawing/2014/main" id="{192E401D-B2DD-4844-9403-F1C6B13509CB}"/>
+                <a16:creationId xmlns:a16="http://schemas.microsoft.com/office/drawing/2014/main" id="{31844766-2A49-4F14-93FD-12A31A189D92}"/>
               </a:ext>
             </a:extLst>
           </p:cNvPr>
@@ -6579,7 +6579,7 @@
           <p:cNvPr id="2" name="">
             <a:extLst xmlns:a="http://schemas.openxmlformats.org/drawingml/2006/main">
               <a:ext uri="{FF2B5EF4-FFF2-40B4-BE49-F238E27FC236}">
-                <a16:creationId xmlns:a16="http://schemas.microsoft.com/office/drawing/2014/main" id="{1803A223-D3E3-41EA-B700-12EA1AC229AF}"/>
+                <a16:creationId xmlns:a16="http://schemas.microsoft.com/office/drawing/2014/main" id="{54FF341D-935A-4783-AE09-7F6AD2BB1F2D}"/>
               </a:ext>
             </a:extLst>
           </p:cNvPr>
@@ -6610,7 +6610,7 @@
           <p:cNvPr id="3" name="">
             <a:extLst xmlns:a="http://schemas.openxmlformats.org/drawingml/2006/main">
               <a:ext uri="{FF2B5EF4-FFF2-40B4-BE49-F238E27FC236}">
-                <a16:creationId xmlns:a16="http://schemas.microsoft.com/office/drawing/2014/main" id="{AD784B5C-9A9E-47DF-AB15-D351F0488C65}"/>
+                <a16:creationId xmlns:a16="http://schemas.microsoft.com/office/drawing/2014/main" id="{74EA614A-3B6C-4333-864C-CA34A015BABF}"/>
               </a:ext>
             </a:extLst>
           </p:cNvPr>
@@ -6667,7 +6667,7 @@
           <p:cNvPr id="4" name="">
             <a:extLst xmlns:a="http://schemas.openxmlformats.org/drawingml/2006/main">
               <a:ext uri="{FF2B5EF4-FFF2-40B4-BE49-F238E27FC236}">
-                <a16:creationId xmlns:a16="http://schemas.microsoft.com/office/drawing/2014/main" id="{E456A417-6E25-48ED-801C-D844EE03A255}"/>
+                <a16:creationId xmlns:a16="http://schemas.microsoft.com/office/drawing/2014/main" id="{D92CDE5B-F546-4715-B090-575F8AA469DE}"/>
               </a:ext>
             </a:extLst>
           </p:cNvPr>
@@ -6724,7 +6724,7 @@
           <p:cNvPr id="5" name="">
             <a:extLst xmlns:a="http://schemas.openxmlformats.org/drawingml/2006/main">
               <a:ext uri="{FF2B5EF4-FFF2-40B4-BE49-F238E27FC236}">
-                <a16:creationId xmlns:a16="http://schemas.microsoft.com/office/drawing/2014/main" id="{21BEB784-F110-48D9-BF2D-8C8C657FAC28}"/>
+                <a16:creationId xmlns:a16="http://schemas.microsoft.com/office/drawing/2014/main" id="{59944AC9-5692-48EA-948F-4086DC33B291}"/>
               </a:ext>
             </a:extLst>
           </p:cNvPr>
@@ -6781,7 +6781,7 @@
           <p:cNvPr id="6" name="">
             <a:extLst xmlns:a="http://schemas.openxmlformats.org/drawingml/2006/main">
               <a:ext uri="{FF2B5EF4-FFF2-40B4-BE49-F238E27FC236}">
-                <a16:creationId xmlns:a16="http://schemas.microsoft.com/office/drawing/2014/main" id="{BD73DFC1-E59E-4A5A-B471-129AE5AE7C43}"/>
+                <a16:creationId xmlns:a16="http://schemas.microsoft.com/office/drawing/2014/main" id="{AC947633-5F7E-4B37-9199-9868DCD0BE5C}"/>
               </a:ext>
             </a:extLst>
           </p:cNvPr>
@@ -6812,7 +6812,7 @@
           <p:cNvPr id="7" name="">
             <a:extLst xmlns:a="http://schemas.openxmlformats.org/drawingml/2006/main">
               <a:ext uri="{FF2B5EF4-FFF2-40B4-BE49-F238E27FC236}">
-                <a16:creationId xmlns:a16="http://schemas.microsoft.com/office/drawing/2014/main" id="{E9EDD04B-1E6C-493C-B1A1-CCE39D9DB229}"/>
+                <a16:creationId xmlns:a16="http://schemas.microsoft.com/office/drawing/2014/main" id="{9AB2019C-30ED-4DDD-8ADE-A8A008533D71}"/>
               </a:ext>
             </a:extLst>
           </p:cNvPr>
@@ -6869,7 +6869,7 @@
           <p:cNvPr id="8" name="">
             <a:extLst xmlns:a="http://schemas.openxmlformats.org/drawingml/2006/main">
               <a:ext uri="{FF2B5EF4-FFF2-40B4-BE49-F238E27FC236}">
-                <a16:creationId xmlns:a16="http://schemas.microsoft.com/office/drawing/2014/main" id="{13FF19B5-904F-45AD-A932-E9CA0E8EFC05}"/>
+                <a16:creationId xmlns:a16="http://schemas.microsoft.com/office/drawing/2014/main" id="{96E63868-1B1F-435E-BE62-95547CE464AD}"/>
               </a:ext>
             </a:extLst>
           </p:cNvPr>
@@ -6926,7 +6926,7 @@
           <p:cNvPr id="9" name="">
             <a:extLst xmlns:a="http://schemas.openxmlformats.org/drawingml/2006/main">
               <a:ext uri="{FF2B5EF4-FFF2-40B4-BE49-F238E27FC236}">
-                <a16:creationId xmlns:a16="http://schemas.microsoft.com/office/drawing/2014/main" id="{6455B920-7511-4725-9523-0E5DAA2F03BA}"/>
+                <a16:creationId xmlns:a16="http://schemas.microsoft.com/office/drawing/2014/main" id="{1BF819B4-00BA-4C00-A218-470B68902534}"/>
               </a:ext>
             </a:extLst>
           </p:cNvPr>
@@ -6983,7 +6983,7 @@
           <p:cNvPr id="10" name="">
             <a:extLst xmlns:a="http://schemas.openxmlformats.org/drawingml/2006/main">
               <a:ext uri="{FF2B5EF4-FFF2-40B4-BE49-F238E27FC236}">
-                <a16:creationId xmlns:a16="http://schemas.microsoft.com/office/drawing/2014/main" id="{2127118A-8461-4FA8-8B0A-B86F67DBE300}"/>
+                <a16:creationId xmlns:a16="http://schemas.microsoft.com/office/drawing/2014/main" id="{EC10001C-E131-4D8D-AEA1-7339352F1AE3}"/>
               </a:ext>
             </a:extLst>
           </p:cNvPr>
@@ -7040,7 +7040,7 @@
           <p:cNvPr id="11" name="">
             <a:extLst xmlns:a="http://schemas.openxmlformats.org/drawingml/2006/main">
               <a:ext uri="{FF2B5EF4-FFF2-40B4-BE49-F238E27FC236}">
-                <a16:creationId xmlns:a16="http://schemas.microsoft.com/office/drawing/2014/main" id="{B71E8DD4-6169-4AEC-9BE2-F83F869FD5F3}"/>
+                <a16:creationId xmlns:a16="http://schemas.microsoft.com/office/drawing/2014/main" id="{9F982464-3C27-421B-AD8A-2D703997F212}"/>
               </a:ext>
             </a:extLst>
           </p:cNvPr>
@@ -7097,7 +7097,7 @@
           <p:cNvPr id="12" name="">
             <a:extLst xmlns:a="http://schemas.openxmlformats.org/drawingml/2006/main">
               <a:ext uri="{FF2B5EF4-FFF2-40B4-BE49-F238E27FC236}">
-                <a16:creationId xmlns:a16="http://schemas.microsoft.com/office/drawing/2014/main" id="{64846A1F-CB8E-43FD-B430-1162FEA4178E}"/>
+                <a16:creationId xmlns:a16="http://schemas.microsoft.com/office/drawing/2014/main" id="{51C1F780-5173-4416-B7D2-AB51ED3EDD8C}"/>
               </a:ext>
             </a:extLst>
           </p:cNvPr>
@@ -7154,7 +7154,7 @@
           <p:cNvPr id="13" name="">
             <a:extLst xmlns:a="http://schemas.openxmlformats.org/drawingml/2006/main">
               <a:ext uri="{FF2B5EF4-FFF2-40B4-BE49-F238E27FC236}">
-                <a16:creationId xmlns:a16="http://schemas.microsoft.com/office/drawing/2014/main" id="{A3284BDA-8F6B-4B3E-9F3C-C41D26C0921D}"/>
+                <a16:creationId xmlns:a16="http://schemas.microsoft.com/office/drawing/2014/main" id="{8E3FDD2C-168A-4F00-8EAD-0677F17254DD}"/>
               </a:ext>
             </a:extLst>
           </p:cNvPr>
@@ -7185,7 +7185,7 @@
           <p:cNvPr id="14" name="">
             <a:extLst xmlns:a="http://schemas.openxmlformats.org/drawingml/2006/main">
               <a:ext uri="{FF2B5EF4-FFF2-40B4-BE49-F238E27FC236}">
-                <a16:creationId xmlns:a16="http://schemas.microsoft.com/office/drawing/2014/main" id="{0E34433D-7271-4985-9DCF-C7EBBCBCEF58}"/>
+                <a16:creationId xmlns:a16="http://schemas.microsoft.com/office/drawing/2014/main" id="{48CF000C-328F-4282-8253-1FACCA9F082F}"/>
               </a:ext>
             </a:extLst>
           </p:cNvPr>
@@ -7242,7 +7242,7 @@
           <p:cNvPr id="15" name="">
             <a:extLst xmlns:a="http://schemas.openxmlformats.org/drawingml/2006/main">
               <a:ext uri="{FF2B5EF4-FFF2-40B4-BE49-F238E27FC236}">
-                <a16:creationId xmlns:a16="http://schemas.microsoft.com/office/drawing/2014/main" id="{7C3085DB-1BF7-44F2-A446-08260235615D}"/>
+                <a16:creationId xmlns:a16="http://schemas.microsoft.com/office/drawing/2014/main" id="{F236F49D-929D-419E-B0E1-F5893FEF813A}"/>
               </a:ext>
             </a:extLst>
           </p:cNvPr>
@@ -7299,7 +7299,7 @@
           <p:cNvPr id="16" name="">
             <a:extLst xmlns:a="http://schemas.openxmlformats.org/drawingml/2006/main">
               <a:ext uri="{FF2B5EF4-FFF2-40B4-BE49-F238E27FC236}">
-                <a16:creationId xmlns:a16="http://schemas.microsoft.com/office/drawing/2014/main" id="{BCF6E13A-3FF5-41FE-B2D4-163DC1F284CE}"/>
+                <a16:creationId xmlns:a16="http://schemas.microsoft.com/office/drawing/2014/main" id="{95AA632F-A412-4726-B13B-9B3078A185F1}"/>
               </a:ext>
             </a:extLst>
           </p:cNvPr>
@@ -7356,7 +7356,7 @@
           <p:cNvPr id="17" name="">
             <a:extLst xmlns:a="http://schemas.openxmlformats.org/drawingml/2006/main">
               <a:ext uri="{FF2B5EF4-FFF2-40B4-BE49-F238E27FC236}">
-                <a16:creationId xmlns:a16="http://schemas.microsoft.com/office/drawing/2014/main" id="{AE3F7E92-0379-40B4-B5C9-2FCF447C355E}"/>
+                <a16:creationId xmlns:a16="http://schemas.microsoft.com/office/drawing/2014/main" id="{1B203E18-71E7-4E8D-90A5-68B04957C04D}"/>
               </a:ext>
             </a:extLst>
           </p:cNvPr>
@@ -7413,7 +7413,7 @@
           <p:cNvPr id="18" name="">
             <a:extLst xmlns:a="http://schemas.openxmlformats.org/drawingml/2006/main">
               <a:ext uri="{FF2B5EF4-FFF2-40B4-BE49-F238E27FC236}">
-                <a16:creationId xmlns:a16="http://schemas.microsoft.com/office/drawing/2014/main" id="{D78BA5E0-172B-47A2-90CD-F87181D1E682}"/>
+                <a16:creationId xmlns:a16="http://schemas.microsoft.com/office/drawing/2014/main" id="{A38A500A-06B3-48F9-8741-E8C3FB0DC74C}"/>
               </a:ext>
             </a:extLst>
           </p:cNvPr>
@@ -7470,7 +7470,7 @@
           <p:cNvPr id="19" name="">
             <a:extLst xmlns:a="http://schemas.openxmlformats.org/drawingml/2006/main">
               <a:ext uri="{FF2B5EF4-FFF2-40B4-BE49-F238E27FC236}">
-                <a16:creationId xmlns:a16="http://schemas.microsoft.com/office/drawing/2014/main" id="{4D669CB0-7884-4245-B972-CABEB818E009}"/>
+                <a16:creationId xmlns:a16="http://schemas.microsoft.com/office/drawing/2014/main" id="{5CE3149F-E972-460D-AF44-5599291FE57A}"/>
               </a:ext>
             </a:extLst>
           </p:cNvPr>
@@ -7501,7 +7501,7 @@
           <p:cNvPr id="20" name="">
             <a:extLst xmlns:a="http://schemas.openxmlformats.org/drawingml/2006/main">
               <a:ext uri="{FF2B5EF4-FFF2-40B4-BE49-F238E27FC236}">
-                <a16:creationId xmlns:a16="http://schemas.microsoft.com/office/drawing/2014/main" id="{F3111E13-2D35-4551-A56E-F26E9C53EA94}"/>
+                <a16:creationId xmlns:a16="http://schemas.microsoft.com/office/drawing/2014/main" id="{0E9D99FE-D71F-47A4-94D8-198AE32B6A73}"/>
               </a:ext>
             </a:extLst>
           </p:cNvPr>
@@ -7556,7 +7556,7 @@
     </p:spTree>
     <p:extLst>
       <p:ext uri="{BB962C8B-B14F-4D97-AF65-F5344CB8AC3E}">
-        <p14:creationId xmlns:p14="http://schemas.microsoft.com/office/powerpoint/2010/main" val="1520862756"/>
+        <p14:creationId xmlns:p14="http://schemas.microsoft.com/office/powerpoint/2010/main" val="922229421"/>
       </p:ext>
     </p:extLst>
   </p:cSld>
@@ -7587,7 +7587,7 @@
           <p:cNvPr id="19" name="">
             <a:extLst xmlns:a="http://schemas.openxmlformats.org/drawingml/2006/main">
               <a:ext uri="{FF2B5EF4-FFF2-40B4-BE49-F238E27FC236}">
-                <a16:creationId xmlns:a16="http://schemas.microsoft.com/office/drawing/2014/main" id="{C5F9A673-4253-455A-BDCB-EB7183FD389B}"/>
+                <a16:creationId xmlns:a16="http://schemas.microsoft.com/office/drawing/2014/main" id="{48A6DB59-F77C-42B2-8C0A-05E1E054D33C}"/>
               </a:ext>
             </a:extLst>
           </p:cNvPr>
@@ -7644,7 +7644,7 @@
           <p:cNvPr id="2" name="">
             <a:extLst xmlns:a="http://schemas.openxmlformats.org/drawingml/2006/main">
               <a:ext uri="{FF2B5EF4-FFF2-40B4-BE49-F238E27FC236}">
-                <a16:creationId xmlns:a16="http://schemas.microsoft.com/office/drawing/2014/main" id="{CCD3867C-2E98-412F-9F2B-A130AAC1A524}"/>
+                <a16:creationId xmlns:a16="http://schemas.microsoft.com/office/drawing/2014/main" id="{0A0675DE-D521-4897-877D-AD3A8F8E1696}"/>
               </a:ext>
             </a:extLst>
           </p:cNvPr>
@@ -7675,7 +7675,7 @@
           <p:cNvPr id="3" name="">
             <a:extLst xmlns:a="http://schemas.openxmlformats.org/drawingml/2006/main">
               <a:ext uri="{FF2B5EF4-FFF2-40B4-BE49-F238E27FC236}">
-                <a16:creationId xmlns:a16="http://schemas.microsoft.com/office/drawing/2014/main" id="{982E618B-52EE-4D81-A332-5A9436759014}"/>
+                <a16:creationId xmlns:a16="http://schemas.microsoft.com/office/drawing/2014/main" id="{5952E6FB-46FD-44CB-BC82-91693B036635}"/>
               </a:ext>
             </a:extLst>
           </p:cNvPr>
@@ -7732,7 +7732,7 @@
           <p:cNvPr id="4" name="">
             <a:extLst xmlns:a="http://schemas.openxmlformats.org/drawingml/2006/main">
               <a:ext uri="{FF2B5EF4-FFF2-40B4-BE49-F238E27FC236}">
-                <a16:creationId xmlns:a16="http://schemas.microsoft.com/office/drawing/2014/main" id="{8A4DF935-1132-49CA-BF23-99C2FFD05531}"/>
+                <a16:creationId xmlns:a16="http://schemas.microsoft.com/office/drawing/2014/main" id="{C91B51B9-F38A-4C50-AC67-961E970816EB}"/>
               </a:ext>
             </a:extLst>
           </p:cNvPr>
@@ -7789,7 +7789,7 @@
           <p:cNvPr id="5" name="">
             <a:extLst xmlns:a="http://schemas.openxmlformats.org/drawingml/2006/main">
               <a:ext uri="{FF2B5EF4-FFF2-40B4-BE49-F238E27FC236}">
-                <a16:creationId xmlns:a16="http://schemas.microsoft.com/office/drawing/2014/main" id="{0E09D044-97E2-4C03-A187-F181AAE1EB96}"/>
+                <a16:creationId xmlns:a16="http://schemas.microsoft.com/office/drawing/2014/main" id="{70DDAE52-E122-4BA0-804E-633E68C52A40}"/>
               </a:ext>
             </a:extLst>
           </p:cNvPr>
@@ -7820,7 +7820,7 @@
           <p:cNvPr id="6" name="">
             <a:extLst xmlns:a="http://schemas.openxmlformats.org/drawingml/2006/main">
               <a:ext uri="{FF2B5EF4-FFF2-40B4-BE49-F238E27FC236}">
-                <a16:creationId xmlns:a16="http://schemas.microsoft.com/office/drawing/2014/main" id="{C61D72EE-51EA-4708-90E9-AA0DDFB140FF}"/>
+                <a16:creationId xmlns:a16="http://schemas.microsoft.com/office/drawing/2014/main" id="{F1C15E5D-A4FE-4651-AB01-BF0A2FCFC8B3}"/>
               </a:ext>
             </a:extLst>
           </p:cNvPr>
@@ -7877,7 +7877,7 @@
           <p:cNvPr id="7" name="">
             <a:extLst xmlns:a="http://schemas.openxmlformats.org/drawingml/2006/main">
               <a:ext uri="{FF2B5EF4-FFF2-40B4-BE49-F238E27FC236}">
-                <a16:creationId xmlns:a16="http://schemas.microsoft.com/office/drawing/2014/main" id="{BA2AA542-15BA-406C-95AE-92CB806BC5C4}"/>
+                <a16:creationId xmlns:a16="http://schemas.microsoft.com/office/drawing/2014/main" id="{523C6ECA-0F66-448A-ADC1-1E07DEFC3636}"/>
               </a:ext>
             </a:extLst>
           </p:cNvPr>
@@ -7957,7 +7957,7 @@
           <p:cNvPr id="8" name="">
             <a:extLst xmlns:a="http://schemas.openxmlformats.org/drawingml/2006/main">
               <a:ext uri="{FF2B5EF4-FFF2-40B4-BE49-F238E27FC236}">
-                <a16:creationId xmlns:a16="http://schemas.microsoft.com/office/drawing/2014/main" id="{04512CC0-E45F-4625-905E-34FFDB78BEDD}"/>
+                <a16:creationId xmlns:a16="http://schemas.microsoft.com/office/drawing/2014/main" id="{F6098386-32F2-49C5-B874-83A3D9C822C3}"/>
               </a:ext>
             </a:extLst>
           </p:cNvPr>
@@ -8014,7 +8014,7 @@
           <p:cNvPr id="9" name="">
             <a:extLst xmlns:a="http://schemas.openxmlformats.org/drawingml/2006/main">
               <a:ext uri="{FF2B5EF4-FFF2-40B4-BE49-F238E27FC236}">
-                <a16:creationId xmlns:a16="http://schemas.microsoft.com/office/drawing/2014/main" id="{03D1C664-FC29-476C-B2B5-5D07D53BB64A}"/>
+                <a16:creationId xmlns:a16="http://schemas.microsoft.com/office/drawing/2014/main" id="{A838B9F7-C3EB-41D1-A18C-817D4A2C6433}"/>
               </a:ext>
             </a:extLst>
           </p:cNvPr>
@@ -8045,7 +8045,7 @@
           <p:cNvPr id="10" name="">
             <a:extLst xmlns:a="http://schemas.openxmlformats.org/drawingml/2006/main">
               <a:ext uri="{FF2B5EF4-FFF2-40B4-BE49-F238E27FC236}">
-                <a16:creationId xmlns:a16="http://schemas.microsoft.com/office/drawing/2014/main" id="{DEB46D3F-34E4-43E1-9006-AC879BC3F91A}"/>
+                <a16:creationId xmlns:a16="http://schemas.microsoft.com/office/drawing/2014/main" id="{4DF1297F-0B13-4A8E-91A6-BCFC99BE618E}"/>
               </a:ext>
             </a:extLst>
           </p:cNvPr>
@@ -8102,7 +8102,7 @@
           <p:cNvPr id="11" name="">
             <a:extLst xmlns:a="http://schemas.openxmlformats.org/drawingml/2006/main">
               <a:ext uri="{FF2B5EF4-FFF2-40B4-BE49-F238E27FC236}">
-                <a16:creationId xmlns:a16="http://schemas.microsoft.com/office/drawing/2014/main" id="{F6A0CB60-B96D-4469-BD7B-566159D4DBF5}"/>
+                <a16:creationId xmlns:a16="http://schemas.microsoft.com/office/drawing/2014/main" id="{9F98E7B7-C9D0-42F2-8C02-592C12FFD931}"/>
               </a:ext>
             </a:extLst>
           </p:cNvPr>
@@ -8182,7 +8182,7 @@
           <p:cNvPr id="12" name="">
             <a:extLst xmlns:a="http://schemas.openxmlformats.org/drawingml/2006/main">
               <a:ext uri="{FF2B5EF4-FFF2-40B4-BE49-F238E27FC236}">
-                <a16:creationId xmlns:a16="http://schemas.microsoft.com/office/drawing/2014/main" id="{9EE5F2A4-FC91-4A70-A1D7-D067408EFAC0}"/>
+                <a16:creationId xmlns:a16="http://schemas.microsoft.com/office/drawing/2014/main" id="{F280967F-063E-4B51-8BF5-45271995F90C}"/>
               </a:ext>
             </a:extLst>
           </p:cNvPr>
@@ -8239,7 +8239,7 @@
           <p:cNvPr id="13" name="">
             <a:extLst xmlns:a="http://schemas.openxmlformats.org/drawingml/2006/main">
               <a:ext uri="{FF2B5EF4-FFF2-40B4-BE49-F238E27FC236}">
-                <a16:creationId xmlns:a16="http://schemas.microsoft.com/office/drawing/2014/main" id="{C468B971-C876-42C1-8590-1F2412583BE7}"/>
+                <a16:creationId xmlns:a16="http://schemas.microsoft.com/office/drawing/2014/main" id="{27C1D283-B333-4A67-A16A-88618F0E739D}"/>
               </a:ext>
             </a:extLst>
           </p:cNvPr>
@@ -8270,7 +8270,7 @@
           <p:cNvPr id="14" name="">
             <a:extLst xmlns:a="http://schemas.openxmlformats.org/drawingml/2006/main">
               <a:ext uri="{FF2B5EF4-FFF2-40B4-BE49-F238E27FC236}">
-                <a16:creationId xmlns:a16="http://schemas.microsoft.com/office/drawing/2014/main" id="{1A4598BF-BF75-43E7-9535-E739498CB6FF}"/>
+                <a16:creationId xmlns:a16="http://schemas.microsoft.com/office/drawing/2014/main" id="{11BC5A3B-7A97-48B4-A21C-D140B3EA3FC6}"/>
               </a:ext>
             </a:extLst>
           </p:cNvPr>
@@ -8327,7 +8327,7 @@
           <p:cNvPr id="15" name="">
             <a:extLst xmlns:a="http://schemas.openxmlformats.org/drawingml/2006/main">
               <a:ext uri="{FF2B5EF4-FFF2-40B4-BE49-F238E27FC236}">
-                <a16:creationId xmlns:a16="http://schemas.microsoft.com/office/drawing/2014/main" id="{9EAAB9D9-357F-4D21-909C-6C152877B3BA}"/>
+                <a16:creationId xmlns:a16="http://schemas.microsoft.com/office/drawing/2014/main" id="{C8FDE2A5-698D-47B8-AD87-9F6B583F658A}"/>
               </a:ext>
             </a:extLst>
           </p:cNvPr>
@@ -8407,7 +8407,7 @@
           <p:cNvPr id="16" name="">
             <a:extLst xmlns:a="http://schemas.openxmlformats.org/drawingml/2006/main">
               <a:ext uri="{FF2B5EF4-FFF2-40B4-BE49-F238E27FC236}">
-                <a16:creationId xmlns:a16="http://schemas.microsoft.com/office/drawing/2014/main" id="{D3C9CAF7-68F7-4801-A15E-C405E0B33A48}"/>
+                <a16:creationId xmlns:a16="http://schemas.microsoft.com/office/drawing/2014/main" id="{DBFBFC44-51DD-4BBA-86A9-13C3317D8F74}"/>
               </a:ext>
             </a:extLst>
           </p:cNvPr>
@@ -8464,7 +8464,7 @@
           <p:cNvPr id="17" name="">
             <a:extLst xmlns:a="http://schemas.openxmlformats.org/drawingml/2006/main">
               <a:ext uri="{FF2B5EF4-FFF2-40B4-BE49-F238E27FC236}">
-                <a16:creationId xmlns:a16="http://schemas.microsoft.com/office/drawing/2014/main" id="{DF88957D-939A-4A36-8C56-847414E4CF0C}"/>
+                <a16:creationId xmlns:a16="http://schemas.microsoft.com/office/drawing/2014/main" id="{31022745-19E2-4DF8-9907-493C0EDA165C}"/>
               </a:ext>
             </a:extLst>
           </p:cNvPr>
@@ -8495,7 +8495,7 @@
           <p:cNvPr id="18" name="">
             <a:extLst xmlns:a="http://schemas.openxmlformats.org/drawingml/2006/main">
               <a:ext uri="{FF2B5EF4-FFF2-40B4-BE49-F238E27FC236}">
-                <a16:creationId xmlns:a16="http://schemas.microsoft.com/office/drawing/2014/main" id="{CD236F92-9F27-46C2-B2E4-A55C454373F1}"/>
+                <a16:creationId xmlns:a16="http://schemas.microsoft.com/office/drawing/2014/main" id="{89E68167-DB16-4CF0-B188-84DC532B94B6}"/>
               </a:ext>
             </a:extLst>
           </p:cNvPr>
@@ -8550,7 +8550,7 @@
     </p:spTree>
     <p:extLst>
       <p:ext uri="{BB962C8B-B14F-4D97-AF65-F5344CB8AC3E}">
-        <p14:creationId xmlns:p14="http://schemas.microsoft.com/office/powerpoint/2010/main" val="363480729"/>
+        <p14:creationId xmlns:p14="http://schemas.microsoft.com/office/powerpoint/2010/main" val="1116355971"/>
       </p:ext>
     </p:extLst>
   </p:cSld>
@@ -8581,7 +8581,7 @@
           <p:cNvPr id="35" name="">
             <a:extLst xmlns:a="http://schemas.openxmlformats.org/drawingml/2006/main">
               <a:ext uri="{FF2B5EF4-FFF2-40B4-BE49-F238E27FC236}">
-                <a16:creationId xmlns:a16="http://schemas.microsoft.com/office/drawing/2014/main" id="{69352FEA-FC77-4EE9-AF95-7EF275DCCC53}"/>
+                <a16:creationId xmlns:a16="http://schemas.microsoft.com/office/drawing/2014/main" id="{E1B726A9-5FD1-4A71-BACB-95C1E602A9B2}"/>
               </a:ext>
             </a:extLst>
           </p:cNvPr>
@@ -8638,7 +8638,7 @@
           <p:cNvPr id="2" name="">
             <a:extLst xmlns:a="http://schemas.openxmlformats.org/drawingml/2006/main">
               <a:ext uri="{FF2B5EF4-FFF2-40B4-BE49-F238E27FC236}">
-                <a16:creationId xmlns:a16="http://schemas.microsoft.com/office/drawing/2014/main" id="{DBBA6DAF-F916-4511-A515-B68A7456E141}"/>
+                <a16:creationId xmlns:a16="http://schemas.microsoft.com/office/drawing/2014/main" id="{E170F26A-F0D1-48D4-8A9B-D56F14CEA778}"/>
               </a:ext>
             </a:extLst>
           </p:cNvPr>
@@ -8669,7 +8669,7 @@
           <p:cNvPr id="3" name="">
             <a:extLst xmlns:a="http://schemas.openxmlformats.org/drawingml/2006/main">
               <a:ext uri="{FF2B5EF4-FFF2-40B4-BE49-F238E27FC236}">
-                <a16:creationId xmlns:a16="http://schemas.microsoft.com/office/drawing/2014/main" id="{5BB678AC-295F-406D-9B42-64A4528BF317}"/>
+                <a16:creationId xmlns:a16="http://schemas.microsoft.com/office/drawing/2014/main" id="{EA88A481-3388-405E-B44A-0D2979338325}"/>
               </a:ext>
             </a:extLst>
           </p:cNvPr>
@@ -8726,7 +8726,7 @@
           <p:cNvPr id="4" name="">
             <a:extLst xmlns:a="http://schemas.openxmlformats.org/drawingml/2006/main">
               <a:ext uri="{FF2B5EF4-FFF2-40B4-BE49-F238E27FC236}">
-                <a16:creationId xmlns:a16="http://schemas.microsoft.com/office/drawing/2014/main" id="{C63BF1ED-8D29-4480-9324-04C6299231E0}"/>
+                <a16:creationId xmlns:a16="http://schemas.microsoft.com/office/drawing/2014/main" id="{C64138BA-F77A-478E-BAEE-033AC19B0400}"/>
               </a:ext>
             </a:extLst>
           </p:cNvPr>
@@ -8759,7 +8759,7 @@
           <p:cNvPr id="5" name="">
             <a:extLst xmlns:a="http://schemas.openxmlformats.org/drawingml/2006/main">
               <a:ext uri="{FF2B5EF4-FFF2-40B4-BE49-F238E27FC236}">
-                <a16:creationId xmlns:a16="http://schemas.microsoft.com/office/drawing/2014/main" id="{75552113-9F53-4274-A83F-16CF5BDF811D}"/>
+                <a16:creationId xmlns:a16="http://schemas.microsoft.com/office/drawing/2014/main" id="{9887522F-E0B0-4A96-832F-9316A6EBC59C}"/>
               </a:ext>
             </a:extLst>
           </p:cNvPr>
@@ -8816,7 +8816,7 @@
           <p:cNvPr id="6" name="">
             <a:extLst xmlns:a="http://schemas.openxmlformats.org/drawingml/2006/main">
               <a:ext uri="{FF2B5EF4-FFF2-40B4-BE49-F238E27FC236}">
-                <a16:creationId xmlns:a16="http://schemas.microsoft.com/office/drawing/2014/main" id="{64F96272-56B9-4014-8FD3-046C5C69316F}"/>
+                <a16:creationId xmlns:a16="http://schemas.microsoft.com/office/drawing/2014/main" id="{F9EC576A-3109-45DA-914C-7A45AD3160FC}"/>
               </a:ext>
             </a:extLst>
           </p:cNvPr>
@@ -8849,7 +8849,7 @@
           <p:cNvPr id="7" name="">
             <a:extLst xmlns:a="http://schemas.openxmlformats.org/drawingml/2006/main">
               <a:ext uri="{FF2B5EF4-FFF2-40B4-BE49-F238E27FC236}">
-                <a16:creationId xmlns:a16="http://schemas.microsoft.com/office/drawing/2014/main" id="{106D2023-6C5E-49E1-B6ED-795502FC7939}"/>
+                <a16:creationId xmlns:a16="http://schemas.microsoft.com/office/drawing/2014/main" id="{BC3FBA16-314F-4E89-BE9D-8BE98F08F0F2}"/>
               </a:ext>
             </a:extLst>
           </p:cNvPr>
@@ -8906,7 +8906,7 @@
           <p:cNvPr id="8" name="">
             <a:extLst xmlns:a="http://schemas.openxmlformats.org/drawingml/2006/main">
               <a:ext uri="{FF2B5EF4-FFF2-40B4-BE49-F238E27FC236}">
-                <a16:creationId xmlns:a16="http://schemas.microsoft.com/office/drawing/2014/main" id="{E39B738C-3513-4E64-8A48-008B87072D64}"/>
+                <a16:creationId xmlns:a16="http://schemas.microsoft.com/office/drawing/2014/main" id="{9AC98739-B03D-4F91-BA9C-D02725AA25ED}"/>
               </a:ext>
             </a:extLst>
           </p:cNvPr>
@@ -8939,7 +8939,7 @@
           <p:cNvPr id="9" name="">
             <a:extLst xmlns:a="http://schemas.openxmlformats.org/drawingml/2006/main">
               <a:ext uri="{FF2B5EF4-FFF2-40B4-BE49-F238E27FC236}">
-                <a16:creationId xmlns:a16="http://schemas.microsoft.com/office/drawing/2014/main" id="{430E7A16-4996-4BD1-9AF8-A5142EFF63E2}"/>
+                <a16:creationId xmlns:a16="http://schemas.microsoft.com/office/drawing/2014/main" id="{F12B762E-2262-44B7-B7AB-C9739F6E708E}"/>
               </a:ext>
             </a:extLst>
           </p:cNvPr>
@@ -8996,7 +8996,7 @@
           <p:cNvPr id="10" name="">
             <a:extLst xmlns:a="http://schemas.openxmlformats.org/drawingml/2006/main">
               <a:ext uri="{FF2B5EF4-FFF2-40B4-BE49-F238E27FC236}">
-                <a16:creationId xmlns:a16="http://schemas.microsoft.com/office/drawing/2014/main" id="{E6E9DEFC-8472-47EC-BFB0-59AD62CBF822}"/>
+                <a16:creationId xmlns:a16="http://schemas.microsoft.com/office/drawing/2014/main" id="{C0B59863-CDD1-4BB7-A52C-3376CA481308}"/>
               </a:ext>
             </a:extLst>
           </p:cNvPr>
@@ -9029,7 +9029,7 @@
           <p:cNvPr id="11" name="">
             <a:extLst xmlns:a="http://schemas.openxmlformats.org/drawingml/2006/main">
               <a:ext uri="{FF2B5EF4-FFF2-40B4-BE49-F238E27FC236}">
-                <a16:creationId xmlns:a16="http://schemas.microsoft.com/office/drawing/2014/main" id="{086DD73A-658A-4A51-988F-894716513E9D}"/>
+                <a16:creationId xmlns:a16="http://schemas.microsoft.com/office/drawing/2014/main" id="{A31D3222-FD12-4C40-91DD-5D05031E06E8}"/>
               </a:ext>
             </a:extLst>
           </p:cNvPr>
@@ -9086,7 +9086,7 @@
           <p:cNvPr id="12" name="">
             <a:extLst xmlns:a="http://schemas.openxmlformats.org/drawingml/2006/main">
               <a:ext uri="{FF2B5EF4-FFF2-40B4-BE49-F238E27FC236}">
-                <a16:creationId xmlns:a16="http://schemas.microsoft.com/office/drawing/2014/main" id="{7C91CADB-0819-4913-8B30-B1B500129A39}"/>
+                <a16:creationId xmlns:a16="http://schemas.microsoft.com/office/drawing/2014/main" id="{813F41B8-D04A-4711-BB7B-E79B018CA751}"/>
               </a:ext>
             </a:extLst>
           </p:cNvPr>
@@ -9119,7 +9119,7 @@
           <p:cNvPr id="13" name="">
             <a:extLst xmlns:a="http://schemas.openxmlformats.org/drawingml/2006/main">
               <a:ext uri="{FF2B5EF4-FFF2-40B4-BE49-F238E27FC236}">
-                <a16:creationId xmlns:a16="http://schemas.microsoft.com/office/drawing/2014/main" id="{F71DF474-8742-42C6-8474-D69D42F3C45B}"/>
+                <a16:creationId xmlns:a16="http://schemas.microsoft.com/office/drawing/2014/main" id="{EFE800E6-B53D-4123-AAE9-614270BEE3A2}"/>
               </a:ext>
             </a:extLst>
           </p:cNvPr>
@@ -9176,7 +9176,7 @@
           <p:cNvPr id="14" name="">
             <a:extLst xmlns:a="http://schemas.openxmlformats.org/drawingml/2006/main">
               <a:ext uri="{FF2B5EF4-FFF2-40B4-BE49-F238E27FC236}">
-                <a16:creationId xmlns:a16="http://schemas.microsoft.com/office/drawing/2014/main" id="{3C54140C-CE85-49B5-82A2-E7B83710DEFB}"/>
+                <a16:creationId xmlns:a16="http://schemas.microsoft.com/office/drawing/2014/main" id="{15B2D5D3-2B1E-40C2-A3C0-A4839DC97253}"/>
               </a:ext>
             </a:extLst>
           </p:cNvPr>
@@ -9209,7 +9209,7 @@
           <p:cNvPr id="15" name="">
             <a:extLst xmlns:a="http://schemas.openxmlformats.org/drawingml/2006/main">
               <a:ext uri="{FF2B5EF4-FFF2-40B4-BE49-F238E27FC236}">
-                <a16:creationId xmlns:a16="http://schemas.microsoft.com/office/drawing/2014/main" id="{509A6C16-2DF4-49E0-8273-433032E79366}"/>
+                <a16:creationId xmlns:a16="http://schemas.microsoft.com/office/drawing/2014/main" id="{14340E6A-7834-4C90-B3E9-00D01469FB8D}"/>
               </a:ext>
             </a:extLst>
           </p:cNvPr>
@@ -9266,7 +9266,7 @@
           <p:cNvPr id="16" name="">
             <a:extLst xmlns:a="http://schemas.openxmlformats.org/drawingml/2006/main">
               <a:ext uri="{FF2B5EF4-FFF2-40B4-BE49-F238E27FC236}">
-                <a16:creationId xmlns:a16="http://schemas.microsoft.com/office/drawing/2014/main" id="{508561C4-A31C-4D4E-99D6-3FB093C4874E}"/>
+                <a16:creationId xmlns:a16="http://schemas.microsoft.com/office/drawing/2014/main" id="{420C5769-8030-4A37-8A21-8669CC1324BE}"/>
               </a:ext>
             </a:extLst>
           </p:cNvPr>
@@ -9299,7 +9299,7 @@
           <p:cNvPr id="17" name="">
             <a:extLst xmlns:a="http://schemas.openxmlformats.org/drawingml/2006/main">
               <a:ext uri="{FF2B5EF4-FFF2-40B4-BE49-F238E27FC236}">
-                <a16:creationId xmlns:a16="http://schemas.microsoft.com/office/drawing/2014/main" id="{DDC1D5E4-B2AE-497C-9B8D-4D54C9177316}"/>
+                <a16:creationId xmlns:a16="http://schemas.microsoft.com/office/drawing/2014/main" id="{F0452E88-4F91-44E9-AFA9-829F0DAD37DC}"/>
               </a:ext>
             </a:extLst>
           </p:cNvPr>
@@ -9356,7 +9356,7 @@
           <p:cNvPr id="18" name="">
             <a:extLst xmlns:a="http://schemas.openxmlformats.org/drawingml/2006/main">
               <a:ext uri="{FF2B5EF4-FFF2-40B4-BE49-F238E27FC236}">
-                <a16:creationId xmlns:a16="http://schemas.microsoft.com/office/drawing/2014/main" id="{5085CE94-DF86-447B-BFDE-B2D12121EAFE}"/>
+                <a16:creationId xmlns:a16="http://schemas.microsoft.com/office/drawing/2014/main" id="{DCD744FA-1410-465D-9823-86FABF89087F}"/>
               </a:ext>
             </a:extLst>
           </p:cNvPr>
@@ -9389,7 +9389,7 @@
           <p:cNvPr id="19" name="">
             <a:extLst xmlns:a="http://schemas.openxmlformats.org/drawingml/2006/main">
               <a:ext uri="{FF2B5EF4-FFF2-40B4-BE49-F238E27FC236}">
-                <a16:creationId xmlns:a16="http://schemas.microsoft.com/office/drawing/2014/main" id="{ACDF89C7-51D7-4BF2-8D75-31405F4574DA}"/>
+                <a16:creationId xmlns:a16="http://schemas.microsoft.com/office/drawing/2014/main" id="{7ACB06A9-14AB-499A-BF02-C24AD021EF66}"/>
               </a:ext>
             </a:extLst>
           </p:cNvPr>
@@ -9628,7 +9628,7 @@
           <p:cNvPr id="27" name="">
             <a:extLst xmlns:a="http://schemas.openxmlformats.org/drawingml/2006/main">
               <a:ext uri="{FF2B5EF4-FFF2-40B4-BE49-F238E27FC236}">
-                <a16:creationId xmlns:a16="http://schemas.microsoft.com/office/drawing/2014/main" id="{2B67B224-76CE-40F0-B490-152D7CF5F044}"/>
+                <a16:creationId xmlns:a16="http://schemas.microsoft.com/office/drawing/2014/main" id="{4B291C75-3615-446E-8699-69B40CA8FCBC}"/>
               </a:ext>
             </a:extLst>
           </p:cNvPr>
@@ -9685,7 +9685,7 @@
           <p:cNvPr id="28" name="">
             <a:extLst xmlns:a="http://schemas.openxmlformats.org/drawingml/2006/main">
               <a:ext uri="{FF2B5EF4-FFF2-40B4-BE49-F238E27FC236}">
-                <a16:creationId xmlns:a16="http://schemas.microsoft.com/office/drawing/2014/main" id="{39CCF84E-35FD-4E1B-8E38-072AD22697C4}"/>
+                <a16:creationId xmlns:a16="http://schemas.microsoft.com/office/drawing/2014/main" id="{EEE26A74-3834-4428-BD37-7242A515297D}"/>
               </a:ext>
             </a:extLst>
           </p:cNvPr>
@@ -9742,7 +9742,7 @@
           <p:cNvPr id="29" name="">
             <a:extLst xmlns:a="http://schemas.openxmlformats.org/drawingml/2006/main">
               <a:ext uri="{FF2B5EF4-FFF2-40B4-BE49-F238E27FC236}">
-                <a16:creationId xmlns:a16="http://schemas.microsoft.com/office/drawing/2014/main" id="{D8A1DB16-A566-47C4-A20B-C2E488018F59}"/>
+                <a16:creationId xmlns:a16="http://schemas.microsoft.com/office/drawing/2014/main" id="{8B2069AA-8E99-4DF1-A929-567552E769A4}"/>
               </a:ext>
             </a:extLst>
           </p:cNvPr>
@@ -9799,7 +9799,7 @@
           <p:cNvPr id="30" name="">
             <a:extLst xmlns:a="http://schemas.openxmlformats.org/drawingml/2006/main">
               <a:ext uri="{FF2B5EF4-FFF2-40B4-BE49-F238E27FC236}">
-                <a16:creationId xmlns:a16="http://schemas.microsoft.com/office/drawing/2014/main" id="{09D7D2BA-E4B5-4285-ACC4-2FFB5C27468D}"/>
+                <a16:creationId xmlns:a16="http://schemas.microsoft.com/office/drawing/2014/main" id="{13680318-A6BE-433C-8CB0-7CC83100C771}"/>
               </a:ext>
             </a:extLst>
           </p:cNvPr>
@@ -9856,7 +9856,7 @@
           <p:cNvPr id="31" name="">
             <a:extLst xmlns:a="http://schemas.openxmlformats.org/drawingml/2006/main">
               <a:ext uri="{FF2B5EF4-FFF2-40B4-BE49-F238E27FC236}">
-                <a16:creationId xmlns:a16="http://schemas.microsoft.com/office/drawing/2014/main" id="{D8879384-4878-4871-920C-9B7155BAA9B0}"/>
+                <a16:creationId xmlns:a16="http://schemas.microsoft.com/office/drawing/2014/main" id="{0789981C-5FDB-4CCB-9A72-1E35243195CC}"/>
               </a:ext>
             </a:extLst>
           </p:cNvPr>
@@ -9913,7 +9913,7 @@
           <p:cNvPr id="32" name="">
             <a:extLst xmlns:a="http://schemas.openxmlformats.org/drawingml/2006/main">
               <a:ext uri="{FF2B5EF4-FFF2-40B4-BE49-F238E27FC236}">
-                <a16:creationId xmlns:a16="http://schemas.microsoft.com/office/drawing/2014/main" id="{00E4C570-E1FA-4D99-B0D3-611299887E1D}"/>
+                <a16:creationId xmlns:a16="http://schemas.microsoft.com/office/drawing/2014/main" id="{669650C0-D7DA-404B-BD69-B5C59F2B51EA}"/>
               </a:ext>
             </a:extLst>
           </p:cNvPr>
@@ -9970,7 +9970,7 @@
           <p:cNvPr id="33" name="">
             <a:extLst xmlns:a="http://schemas.openxmlformats.org/drawingml/2006/main">
               <a:ext uri="{FF2B5EF4-FFF2-40B4-BE49-F238E27FC236}">
-                <a16:creationId xmlns:a16="http://schemas.microsoft.com/office/drawing/2014/main" id="{169D6491-55D0-4086-89B9-6B763DAA2BFB}"/>
+                <a16:creationId xmlns:a16="http://schemas.microsoft.com/office/drawing/2014/main" id="{2FAD8A52-3C9E-451E-BCEE-58A8C392DAFA}"/>
               </a:ext>
             </a:extLst>
           </p:cNvPr>
@@ -10001,7 +10001,7 @@
           <p:cNvPr id="34" name="">
             <a:extLst xmlns:a="http://schemas.openxmlformats.org/drawingml/2006/main">
               <a:ext uri="{FF2B5EF4-FFF2-40B4-BE49-F238E27FC236}">
-                <a16:creationId xmlns:a16="http://schemas.microsoft.com/office/drawing/2014/main" id="{DB624A75-37A9-4D66-8BE5-19005A30EC40}"/>
+                <a16:creationId xmlns:a16="http://schemas.microsoft.com/office/drawing/2014/main" id="{EA3BD866-6762-4FB1-9381-238A931986E0}"/>
               </a:ext>
             </a:extLst>
           </p:cNvPr>
@@ -10056,7 +10056,7 @@
     </p:spTree>
     <p:extLst>
       <p:ext uri="{BB962C8B-B14F-4D97-AF65-F5344CB8AC3E}">
-        <p14:creationId xmlns:p14="http://schemas.microsoft.com/office/powerpoint/2010/main" val="497608112"/>
+        <p14:creationId xmlns:p14="http://schemas.microsoft.com/office/powerpoint/2010/main" val="1150965629"/>
       </p:ext>
     </p:extLst>
   </p:cSld>
@@ -10087,7 +10087,7 @@
           <p:cNvPr id="40" name="">
             <a:extLst xmlns:a="http://schemas.openxmlformats.org/drawingml/2006/main">
               <a:ext uri="{FF2B5EF4-FFF2-40B4-BE49-F238E27FC236}">
-                <a16:creationId xmlns:a16="http://schemas.microsoft.com/office/drawing/2014/main" id="{AB1CF91A-91D1-46A6-941F-A5E3B8613523}"/>
+                <a16:creationId xmlns:a16="http://schemas.microsoft.com/office/drawing/2014/main" id="{306CA492-F75E-44AA-BB9B-DE3CED8B9E56}"/>
               </a:ext>
             </a:extLst>
           </p:cNvPr>
@@ -10144,7 +10144,7 @@
           <p:cNvPr id="2" name="">
             <a:extLst xmlns:a="http://schemas.openxmlformats.org/drawingml/2006/main">
               <a:ext uri="{FF2B5EF4-FFF2-40B4-BE49-F238E27FC236}">
-                <a16:creationId xmlns:a16="http://schemas.microsoft.com/office/drawing/2014/main" id="{617E10F5-2E15-4D0E-A808-4DE02BE2053E}"/>
+                <a16:creationId xmlns:a16="http://schemas.microsoft.com/office/drawing/2014/main" id="{E21ACA5A-D16D-41A1-B94C-CCD500175498}"/>
               </a:ext>
             </a:extLst>
           </p:cNvPr>
@@ -10175,7 +10175,7 @@
           <p:cNvPr id="3" name="">
             <a:extLst xmlns:a="http://schemas.openxmlformats.org/drawingml/2006/main">
               <a:ext uri="{FF2B5EF4-FFF2-40B4-BE49-F238E27FC236}">
-                <a16:creationId xmlns:a16="http://schemas.microsoft.com/office/drawing/2014/main" id="{2D5EAE41-DD24-45A8-8F8E-62987CB44F87}"/>
+                <a16:creationId xmlns:a16="http://schemas.microsoft.com/office/drawing/2014/main" id="{5118D90C-3C73-4FF0-887C-F327E8B756B0}"/>
               </a:ext>
             </a:extLst>
           </p:cNvPr>
@@ -10232,7 +10232,7 @@
           <p:cNvPr id="4" name="">
             <a:extLst xmlns:a="http://schemas.openxmlformats.org/drawingml/2006/main">
               <a:ext uri="{FF2B5EF4-FFF2-40B4-BE49-F238E27FC236}">
-                <a16:creationId xmlns:a16="http://schemas.microsoft.com/office/drawing/2014/main" id="{45E1EC1A-204C-49C6-9712-06017AEF7518}"/>
+                <a16:creationId xmlns:a16="http://schemas.microsoft.com/office/drawing/2014/main" id="{9B1537B1-57B2-47F0-AFE1-0DA15966D006}"/>
               </a:ext>
             </a:extLst>
           </p:cNvPr>
@@ -10265,7 +10265,7 @@
           <p:cNvPr id="5" name="">
             <a:extLst xmlns:a="http://schemas.openxmlformats.org/drawingml/2006/main">
               <a:ext uri="{FF2B5EF4-FFF2-40B4-BE49-F238E27FC236}">
-                <a16:creationId xmlns:a16="http://schemas.microsoft.com/office/drawing/2014/main" id="{E002F664-81BF-4843-AF60-0761381AE2EC}"/>
+                <a16:creationId xmlns:a16="http://schemas.microsoft.com/office/drawing/2014/main" id="{6EBC6D43-912A-489D-90A1-255DF6CAA551}"/>
               </a:ext>
             </a:extLst>
           </p:cNvPr>
@@ -10322,7 +10322,7 @@
           <p:cNvPr id="6" name="">
             <a:extLst xmlns:a="http://schemas.openxmlformats.org/drawingml/2006/main">
               <a:ext uri="{FF2B5EF4-FFF2-40B4-BE49-F238E27FC236}">
-                <a16:creationId xmlns:a16="http://schemas.microsoft.com/office/drawing/2014/main" id="{9674DAF3-0F48-4F87-9ECB-94374AAC0304}"/>
+                <a16:creationId xmlns:a16="http://schemas.microsoft.com/office/drawing/2014/main" id="{ECED1936-6E98-43AC-B765-450083C5D96C}"/>
               </a:ext>
             </a:extLst>
           </p:cNvPr>
@@ -10379,7 +10379,7 @@
           <p:cNvPr id="7" name="">
             <a:extLst xmlns:a="http://schemas.openxmlformats.org/drawingml/2006/main">
               <a:ext uri="{FF2B5EF4-FFF2-40B4-BE49-F238E27FC236}">
-                <a16:creationId xmlns:a16="http://schemas.microsoft.com/office/drawing/2014/main" id="{DCCD93BA-D3BA-468A-917B-2ADE490723D7}"/>
+                <a16:creationId xmlns:a16="http://schemas.microsoft.com/office/drawing/2014/main" id="{18D541EA-E259-4490-B385-1126A6E2897C}"/>
               </a:ext>
             </a:extLst>
           </p:cNvPr>
@@ -10436,7 +10436,7 @@
           <p:cNvPr id="8" name="">
             <a:extLst xmlns:a="http://schemas.openxmlformats.org/drawingml/2006/main">
               <a:ext uri="{FF2B5EF4-FFF2-40B4-BE49-F238E27FC236}">
-                <a16:creationId xmlns:a16="http://schemas.microsoft.com/office/drawing/2014/main" id="{66E14073-89A1-4B02-B9CA-A1EF1F6A54D3}"/>
+                <a16:creationId xmlns:a16="http://schemas.microsoft.com/office/drawing/2014/main" id="{799313F0-D678-4B90-80CF-6D635D9B8530}"/>
               </a:ext>
             </a:extLst>
           </p:cNvPr>
@@ -10467,7 +10467,7 @@
           <p:cNvPr id="9" name="">
             <a:extLst xmlns:a="http://schemas.openxmlformats.org/drawingml/2006/main">
               <a:ext uri="{FF2B5EF4-FFF2-40B4-BE49-F238E27FC236}">
-                <a16:creationId xmlns:a16="http://schemas.microsoft.com/office/drawing/2014/main" id="{678F5A5A-6F44-4EDF-81BC-A62C98733708}"/>
+                <a16:creationId xmlns:a16="http://schemas.microsoft.com/office/drawing/2014/main" id="{98BB36D1-229A-417D-B3A8-92CBA364229B}"/>
               </a:ext>
             </a:extLst>
           </p:cNvPr>
@@ -10524,7 +10524,7 @@
           <p:cNvPr id="10" name="">
             <a:extLst xmlns:a="http://schemas.openxmlformats.org/drawingml/2006/main">
               <a:ext uri="{FF2B5EF4-FFF2-40B4-BE49-F238E27FC236}">
-                <a16:creationId xmlns:a16="http://schemas.microsoft.com/office/drawing/2014/main" id="{9E806D86-FF6E-4B7B-9429-5C5D84787B5A}"/>
+                <a16:creationId xmlns:a16="http://schemas.microsoft.com/office/drawing/2014/main" id="{C1284336-C9B1-4367-8DD2-D6B4779D1E8E}"/>
               </a:ext>
             </a:extLst>
           </p:cNvPr>
@@ -10581,7 +10581,7 @@
           <p:cNvPr id="11" name="">
             <a:extLst xmlns:a="http://schemas.openxmlformats.org/drawingml/2006/main">
               <a:ext uri="{FF2B5EF4-FFF2-40B4-BE49-F238E27FC236}">
-                <a16:creationId xmlns:a16="http://schemas.microsoft.com/office/drawing/2014/main" id="{A1525433-5F47-4005-ADE2-7FA3258DE819}"/>
+                <a16:creationId xmlns:a16="http://schemas.microsoft.com/office/drawing/2014/main" id="{6E598E1E-295B-42E9-87F1-352CE6F3DBF0}"/>
               </a:ext>
             </a:extLst>
           </p:cNvPr>
@@ -10612,7 +10612,7 @@
           <p:cNvPr id="12" name="">
             <a:extLst xmlns:a="http://schemas.openxmlformats.org/drawingml/2006/main">
               <a:ext uri="{FF2B5EF4-FFF2-40B4-BE49-F238E27FC236}">
-                <a16:creationId xmlns:a16="http://schemas.microsoft.com/office/drawing/2014/main" id="{BA184412-86AE-497B-B72C-4A794850CE57}"/>
+                <a16:creationId xmlns:a16="http://schemas.microsoft.com/office/drawing/2014/main" id="{00387AFE-8A48-41B6-AFC4-15BCC4043B97}"/>
               </a:ext>
             </a:extLst>
           </p:cNvPr>
@@ -10669,7 +10669,7 @@
           <p:cNvPr id="13" name="">
             <a:extLst xmlns:a="http://schemas.openxmlformats.org/drawingml/2006/main">
               <a:ext uri="{FF2B5EF4-FFF2-40B4-BE49-F238E27FC236}">
-                <a16:creationId xmlns:a16="http://schemas.microsoft.com/office/drawing/2014/main" id="{74E6ECDB-ED5F-44AC-B112-EA3D965584D5}"/>
+                <a16:creationId xmlns:a16="http://schemas.microsoft.com/office/drawing/2014/main" id="{1BC88615-55F0-4C8B-B69B-F22724EEE6CE}"/>
               </a:ext>
             </a:extLst>
           </p:cNvPr>
@@ -10726,7 +10726,7 @@
           <p:cNvPr id="14" name="">
             <a:extLst xmlns:a="http://schemas.openxmlformats.org/drawingml/2006/main">
               <a:ext uri="{FF2B5EF4-FFF2-40B4-BE49-F238E27FC236}">
-                <a16:creationId xmlns:a16="http://schemas.microsoft.com/office/drawing/2014/main" id="{D0533D85-BC51-4849-8F3D-A82180EB894E}"/>
+                <a16:creationId xmlns:a16="http://schemas.microsoft.com/office/drawing/2014/main" id="{3DE64480-C0E1-45FB-B56F-D6D8021DD1E8}"/>
               </a:ext>
             </a:extLst>
           </p:cNvPr>
@@ -10783,7 +10783,7 @@
           <p:cNvPr id="15" name="">
             <a:extLst xmlns:a="http://schemas.openxmlformats.org/drawingml/2006/main">
               <a:ext uri="{FF2B5EF4-FFF2-40B4-BE49-F238E27FC236}">
-                <a16:creationId xmlns:a16="http://schemas.microsoft.com/office/drawing/2014/main" id="{42DD3693-1A1E-4B2E-A419-38B4939357D7}"/>
+                <a16:creationId xmlns:a16="http://schemas.microsoft.com/office/drawing/2014/main" id="{64EBDB1D-628C-4732-A150-88568E066ABB}"/>
               </a:ext>
             </a:extLst>
           </p:cNvPr>
@@ -10863,7 +10863,7 @@
           <p:cNvPr id="16" name="">
             <a:extLst xmlns:a="http://schemas.openxmlformats.org/drawingml/2006/main">
               <a:ext uri="{FF2B5EF4-FFF2-40B4-BE49-F238E27FC236}">
-                <a16:creationId xmlns:a16="http://schemas.microsoft.com/office/drawing/2014/main" id="{39EB0D17-0CF8-4405-8A2B-A1B3DAF7DE29}"/>
+                <a16:creationId xmlns:a16="http://schemas.microsoft.com/office/drawing/2014/main" id="{A7D7B3D9-797A-4C56-80AE-1F9A611C053A}"/>
               </a:ext>
             </a:extLst>
           </p:cNvPr>
@@ -10894,7 +10894,7 @@
           <p:cNvPr id="17" name="">
             <a:extLst xmlns:a="http://schemas.openxmlformats.org/drawingml/2006/main">
               <a:ext uri="{FF2B5EF4-FFF2-40B4-BE49-F238E27FC236}">
-                <a16:creationId xmlns:a16="http://schemas.microsoft.com/office/drawing/2014/main" id="{B0766A06-B6F2-42C4-A09B-8BB90179E807}"/>
+                <a16:creationId xmlns:a16="http://schemas.microsoft.com/office/drawing/2014/main" id="{54EF9AE1-0282-4BEA-989E-F7ED42045038}"/>
               </a:ext>
             </a:extLst>
           </p:cNvPr>
@@ -10974,7 +10974,7 @@
           <p:cNvPr id="18" name="">
             <a:extLst xmlns:a="http://schemas.openxmlformats.org/drawingml/2006/main">
               <a:ext uri="{FF2B5EF4-FFF2-40B4-BE49-F238E27FC236}">
-                <a16:creationId xmlns:a16="http://schemas.microsoft.com/office/drawing/2014/main" id="{663E9065-A2DE-4059-A24B-18CC447B002C}"/>
+                <a16:creationId xmlns:a16="http://schemas.microsoft.com/office/drawing/2014/main" id="{31B9340B-191E-4C5B-A993-C052A8FF5BB6}"/>
               </a:ext>
             </a:extLst>
           </p:cNvPr>
@@ -11007,7 +11007,7 @@
           <p:cNvPr id="19" name="">
             <a:extLst xmlns:a="http://schemas.openxmlformats.org/drawingml/2006/main">
               <a:ext uri="{FF2B5EF4-FFF2-40B4-BE49-F238E27FC236}">
-                <a16:creationId xmlns:a16="http://schemas.microsoft.com/office/drawing/2014/main" id="{EF8F2146-FB28-45B4-A6BE-EC9432A8E35C}"/>
+                <a16:creationId xmlns:a16="http://schemas.microsoft.com/office/drawing/2014/main" id="{147320DC-62BA-4E3B-9F82-2F94D7467B12}"/>
               </a:ext>
             </a:extLst>
           </p:cNvPr>
@@ -11064,7 +11064,7 @@
           <p:cNvPr id="20" name="">
             <a:extLst xmlns:a="http://schemas.openxmlformats.org/drawingml/2006/main">
               <a:ext uri="{FF2B5EF4-FFF2-40B4-BE49-F238E27FC236}">
-                <a16:creationId xmlns:a16="http://schemas.microsoft.com/office/drawing/2014/main" id="{B07ADC32-2AF0-4314-B096-72B14243A68D}"/>
+                <a16:creationId xmlns:a16="http://schemas.microsoft.com/office/drawing/2014/main" id="{5219698C-AC53-4644-AE13-D62A5782EAE7}"/>
               </a:ext>
             </a:extLst>
           </p:cNvPr>
@@ -11121,7 +11121,7 @@
           <p:cNvPr id="21" name="">
             <a:extLst xmlns:a="http://schemas.openxmlformats.org/drawingml/2006/main">
               <a:ext uri="{FF2B5EF4-FFF2-40B4-BE49-F238E27FC236}">
-                <a16:creationId xmlns:a16="http://schemas.microsoft.com/office/drawing/2014/main" id="{015CCAF8-3BDC-4E68-90AF-A314E713268B}"/>
+                <a16:creationId xmlns:a16="http://schemas.microsoft.com/office/drawing/2014/main" id="{48D951AB-65CB-4A16-8A6A-724111067A94}"/>
               </a:ext>
             </a:extLst>
           </p:cNvPr>
@@ -11178,7 +11178,7 @@
           <p:cNvPr id="22" name="">
             <a:extLst xmlns:a="http://schemas.openxmlformats.org/drawingml/2006/main">
               <a:ext uri="{FF2B5EF4-FFF2-40B4-BE49-F238E27FC236}">
-                <a16:creationId xmlns:a16="http://schemas.microsoft.com/office/drawing/2014/main" id="{2552B065-8047-464A-AFC9-9190E60E279D}"/>
+                <a16:creationId xmlns:a16="http://schemas.microsoft.com/office/drawing/2014/main" id="{FF0BD951-CD88-475B-8DD2-DC71230479CE}"/>
               </a:ext>
             </a:extLst>
           </p:cNvPr>
@@ -11211,7 +11211,7 @@
           <p:cNvPr id="23" name="">
             <a:extLst xmlns:a="http://schemas.openxmlformats.org/drawingml/2006/main">
               <a:ext uri="{FF2B5EF4-FFF2-40B4-BE49-F238E27FC236}">
-                <a16:creationId xmlns:a16="http://schemas.microsoft.com/office/drawing/2014/main" id="{574243A2-A334-48F5-96B8-D762673963A9}"/>
+                <a16:creationId xmlns:a16="http://schemas.microsoft.com/office/drawing/2014/main" id="{91B0CB2B-650B-4451-B69A-13BEF9D73B9C}"/>
               </a:ext>
             </a:extLst>
           </p:cNvPr>
@@ -11268,7 +11268,7 @@
           <p:cNvPr id="24" name="">
             <a:extLst xmlns:a="http://schemas.openxmlformats.org/drawingml/2006/main">
               <a:ext uri="{FF2B5EF4-FFF2-40B4-BE49-F238E27FC236}">
-                <a16:creationId xmlns:a16="http://schemas.microsoft.com/office/drawing/2014/main" id="{46AF68FE-B0E1-414D-984E-0665C2A2578F}"/>
+                <a16:creationId xmlns:a16="http://schemas.microsoft.com/office/drawing/2014/main" id="{791F75F7-2C15-4DAB-93ED-7C0368104BE9}"/>
               </a:ext>
             </a:extLst>
           </p:cNvPr>
@@ -11325,7 +11325,7 @@
           <p:cNvPr id="25" name="">
             <a:extLst xmlns:a="http://schemas.openxmlformats.org/drawingml/2006/main">
               <a:ext uri="{FF2B5EF4-FFF2-40B4-BE49-F238E27FC236}">
-                <a16:creationId xmlns:a16="http://schemas.microsoft.com/office/drawing/2014/main" id="{505061FE-538E-449E-8B2A-16158508D54C}"/>
+                <a16:creationId xmlns:a16="http://schemas.microsoft.com/office/drawing/2014/main" id="{4ED7482C-D978-4C19-812E-9F684C5249F9}"/>
               </a:ext>
             </a:extLst>
           </p:cNvPr>
@@ -11382,7 +11382,7 @@
           <p:cNvPr id="26" name="">
             <a:extLst xmlns:a="http://schemas.openxmlformats.org/drawingml/2006/main">
               <a:ext uri="{FF2B5EF4-FFF2-40B4-BE49-F238E27FC236}">
-                <a16:creationId xmlns:a16="http://schemas.microsoft.com/office/drawing/2014/main" id="{1C280DA1-CFB2-4880-967B-8BC77E935A4A}"/>
+                <a16:creationId xmlns:a16="http://schemas.microsoft.com/office/drawing/2014/main" id="{705DE4AC-66F5-4251-B1EA-B8AA3F66E0EF}"/>
               </a:ext>
             </a:extLst>
           </p:cNvPr>
@@ -11415,7 +11415,7 @@
           <p:cNvPr id="27" name="">
             <a:extLst xmlns:a="http://schemas.openxmlformats.org/drawingml/2006/main">
               <a:ext uri="{FF2B5EF4-FFF2-40B4-BE49-F238E27FC236}">
-                <a16:creationId xmlns:a16="http://schemas.microsoft.com/office/drawing/2014/main" id="{B92B8CEB-04CD-4FEC-898F-6CCCFDC56E75}"/>
+                <a16:creationId xmlns:a16="http://schemas.microsoft.com/office/drawing/2014/main" id="{BF1CD846-C9CD-4CE6-8543-A6B220F5DACE}"/>
               </a:ext>
             </a:extLst>
           </p:cNvPr>
@@ -11472,7 +11472,7 @@
           <p:cNvPr id="28" name="">
             <a:extLst xmlns:a="http://schemas.openxmlformats.org/drawingml/2006/main">
               <a:ext uri="{FF2B5EF4-FFF2-40B4-BE49-F238E27FC236}">
-                <a16:creationId xmlns:a16="http://schemas.microsoft.com/office/drawing/2014/main" id="{325E85DB-A43A-4CF6-B059-C05DD2B0BB3D}"/>
+                <a16:creationId xmlns:a16="http://schemas.microsoft.com/office/drawing/2014/main" id="{0F253525-28CD-4116-B369-16A32E2934B9}"/>
               </a:ext>
             </a:extLst>
           </p:cNvPr>
@@ -11529,7 +11529,7 @@
           <p:cNvPr id="29" name="">
             <a:extLst xmlns:a="http://schemas.openxmlformats.org/drawingml/2006/main">
               <a:ext uri="{FF2B5EF4-FFF2-40B4-BE49-F238E27FC236}">
-                <a16:creationId xmlns:a16="http://schemas.microsoft.com/office/drawing/2014/main" id="{C915679E-BE62-4F48-B834-4DE87704C8E7}"/>
+                <a16:creationId xmlns:a16="http://schemas.microsoft.com/office/drawing/2014/main" id="{DF732AC1-D1C3-42DD-A10C-D30F7972FA8D}"/>
               </a:ext>
             </a:extLst>
           </p:cNvPr>
@@ -11586,7 +11586,7 @@
           <p:cNvPr id="30" name="">
             <a:extLst xmlns:a="http://schemas.openxmlformats.org/drawingml/2006/main">
               <a:ext uri="{FF2B5EF4-FFF2-40B4-BE49-F238E27FC236}">
-                <a16:creationId xmlns:a16="http://schemas.microsoft.com/office/drawing/2014/main" id="{2199B04F-898D-45E1-9242-5474C564EA7D}"/>
+                <a16:creationId xmlns:a16="http://schemas.microsoft.com/office/drawing/2014/main" id="{018D4C8C-5F1D-4E7B-846D-B75C3BA04DDE}"/>
               </a:ext>
             </a:extLst>
           </p:cNvPr>
@@ -11619,7 +11619,7 @@
           <p:cNvPr id="31" name="">
             <a:extLst xmlns:a="http://schemas.openxmlformats.org/drawingml/2006/main">
               <a:ext uri="{FF2B5EF4-FFF2-40B4-BE49-F238E27FC236}">
-                <a16:creationId xmlns:a16="http://schemas.microsoft.com/office/drawing/2014/main" id="{27EA5C69-AC03-4369-8235-1D7C8076AD8D}"/>
+                <a16:creationId xmlns:a16="http://schemas.microsoft.com/office/drawing/2014/main" id="{9A3A349D-958D-447B-B290-88498CDC4705}"/>
               </a:ext>
             </a:extLst>
           </p:cNvPr>
@@ -11676,7 +11676,7 @@
           <p:cNvPr id="32" name="">
             <a:extLst xmlns:a="http://schemas.openxmlformats.org/drawingml/2006/main">
               <a:ext uri="{FF2B5EF4-FFF2-40B4-BE49-F238E27FC236}">
-                <a16:creationId xmlns:a16="http://schemas.microsoft.com/office/drawing/2014/main" id="{5C77F472-4195-45F7-B569-109CDD96A281}"/>
+                <a16:creationId xmlns:a16="http://schemas.microsoft.com/office/drawing/2014/main" id="{F58CEB16-58AA-4F07-98B7-AA4F6A4829A1}"/>
               </a:ext>
             </a:extLst>
           </p:cNvPr>
@@ -11733,7 +11733,7 @@
           <p:cNvPr id="33" name="">
             <a:extLst xmlns:a="http://schemas.openxmlformats.org/drawingml/2006/main">
               <a:ext uri="{FF2B5EF4-FFF2-40B4-BE49-F238E27FC236}">
-                <a16:creationId xmlns:a16="http://schemas.microsoft.com/office/drawing/2014/main" id="{0CE1DDC5-C5BB-45DB-9475-4E21F72A4AB1}"/>
+                <a16:creationId xmlns:a16="http://schemas.microsoft.com/office/drawing/2014/main" id="{C555F85E-C9F0-4F8F-8086-E1F3C1CDEC42}"/>
               </a:ext>
             </a:extLst>
           </p:cNvPr>
@@ -11813,7 +11813,7 @@
           <p:cNvPr id="34" name="">
             <a:extLst xmlns:a="http://schemas.openxmlformats.org/drawingml/2006/main">
               <a:ext uri="{FF2B5EF4-FFF2-40B4-BE49-F238E27FC236}">
-                <a16:creationId xmlns:a16="http://schemas.microsoft.com/office/drawing/2014/main" id="{D6C55E66-0584-4D5A-AA43-AD4CA0980B97}"/>
+                <a16:creationId xmlns:a16="http://schemas.microsoft.com/office/drawing/2014/main" id="{15E479F5-237B-457A-9F17-EA23231FACFC}"/>
               </a:ext>
             </a:extLst>
           </p:cNvPr>
@@ -11870,7 +11870,7 @@
           <p:cNvPr id="35" name="">
             <a:extLst xmlns:a="http://schemas.openxmlformats.org/drawingml/2006/main">
               <a:ext uri="{FF2B5EF4-FFF2-40B4-BE49-F238E27FC236}">
-                <a16:creationId xmlns:a16="http://schemas.microsoft.com/office/drawing/2014/main" id="{4DAE7B18-1A85-424F-8A0D-9BE47B400EF5}"/>
+                <a16:creationId xmlns:a16="http://schemas.microsoft.com/office/drawing/2014/main" id="{40E8AA75-664E-49EA-9AA7-E666A2546EA7}"/>
               </a:ext>
             </a:extLst>
           </p:cNvPr>
@@ -11927,7 +11927,7 @@
           <p:cNvPr id="36" name="">
             <a:extLst xmlns:a="http://schemas.openxmlformats.org/drawingml/2006/main">
               <a:ext uri="{FF2B5EF4-FFF2-40B4-BE49-F238E27FC236}">
-                <a16:creationId xmlns:a16="http://schemas.microsoft.com/office/drawing/2014/main" id="{8A9CCC68-74FA-48F5-AA47-10EE65FF3069}"/>
+                <a16:creationId xmlns:a16="http://schemas.microsoft.com/office/drawing/2014/main" id="{74AC1F57-BD1F-494C-B1E9-21927CE93B99}"/>
               </a:ext>
             </a:extLst>
           </p:cNvPr>
@@ -11984,7 +11984,7 @@
           <p:cNvPr id="37" name="">
             <a:extLst xmlns:a="http://schemas.openxmlformats.org/drawingml/2006/main">
               <a:ext uri="{FF2B5EF4-FFF2-40B4-BE49-F238E27FC236}">
-                <a16:creationId xmlns:a16="http://schemas.microsoft.com/office/drawing/2014/main" id="{176BC27C-BB86-472E-8EE5-6C17245D70D5}"/>
+                <a16:creationId xmlns:a16="http://schemas.microsoft.com/office/drawing/2014/main" id="{0DFC88DE-912B-47C1-9BAF-4ADC93534F2A}"/>
               </a:ext>
             </a:extLst>
           </p:cNvPr>
@@ -12041,7 +12041,7 @@
           <p:cNvPr id="38" name="">
             <a:extLst xmlns:a="http://schemas.openxmlformats.org/drawingml/2006/main">
               <a:ext uri="{FF2B5EF4-FFF2-40B4-BE49-F238E27FC236}">
-                <a16:creationId xmlns:a16="http://schemas.microsoft.com/office/drawing/2014/main" id="{37353EFA-4131-4173-A146-FF33C474AFF2}"/>
+                <a16:creationId xmlns:a16="http://schemas.microsoft.com/office/drawing/2014/main" id="{74709EC7-5596-41BC-BDEC-E280662F8F5D}"/>
               </a:ext>
             </a:extLst>
           </p:cNvPr>
@@ -12098,7 +12098,7 @@
           <p:cNvPr id="39" name="">
             <a:extLst xmlns:a="http://schemas.openxmlformats.org/drawingml/2006/main">
               <a:ext uri="{FF2B5EF4-FFF2-40B4-BE49-F238E27FC236}">
-                <a16:creationId xmlns:a16="http://schemas.microsoft.com/office/drawing/2014/main" id="{03F5A46B-C323-4DF9-AF91-3D420CD81BE6}"/>
+                <a16:creationId xmlns:a16="http://schemas.microsoft.com/office/drawing/2014/main" id="{3335C7AC-C601-46A4-91F0-B5376CC46914}"/>
               </a:ext>
             </a:extLst>
           </p:cNvPr>
@@ -12153,7 +12153,7 @@
     </p:spTree>
     <p:extLst>
       <p:ext uri="{BB962C8B-B14F-4D97-AF65-F5344CB8AC3E}">
-        <p14:creationId xmlns:p14="http://schemas.microsoft.com/office/powerpoint/2010/main" val="569034835"/>
+        <p14:creationId xmlns:p14="http://schemas.microsoft.com/office/powerpoint/2010/main" val="341373732"/>
       </p:ext>
     </p:extLst>
   </p:cSld>
@@ -12184,7 +12184,7 @@
           <p:cNvPr id="23" name="">
             <a:extLst xmlns:a="http://schemas.openxmlformats.org/drawingml/2006/main">
               <a:ext uri="{FF2B5EF4-FFF2-40B4-BE49-F238E27FC236}">
-                <a16:creationId xmlns:a16="http://schemas.microsoft.com/office/drawing/2014/main" id="{4EF06D9C-568B-44E7-96C3-F133C8C20802}"/>
+                <a16:creationId xmlns:a16="http://schemas.microsoft.com/office/drawing/2014/main" id="{67BF8B59-6E0F-40F0-9A96-22D44EFB1223}"/>
               </a:ext>
             </a:extLst>
           </p:cNvPr>
@@ -12241,7 +12241,7 @@
           <p:cNvPr id="2" name="">
             <a:extLst xmlns:a="http://schemas.openxmlformats.org/drawingml/2006/main">
               <a:ext uri="{FF2B5EF4-FFF2-40B4-BE49-F238E27FC236}">
-                <a16:creationId xmlns:a16="http://schemas.microsoft.com/office/drawing/2014/main" id="{8F1279A4-3E3F-494F-B292-89E46695C0B9}"/>
+                <a16:creationId xmlns:a16="http://schemas.microsoft.com/office/drawing/2014/main" id="{7076F486-CF88-4E76-BC7F-DA21110C67F9}"/>
               </a:ext>
             </a:extLst>
           </p:cNvPr>
@@ -12272,7 +12272,7 @@
           <p:cNvPr id="3" name="">
             <a:extLst xmlns:a="http://schemas.openxmlformats.org/drawingml/2006/main">
               <a:ext uri="{FF2B5EF4-FFF2-40B4-BE49-F238E27FC236}">
-                <a16:creationId xmlns:a16="http://schemas.microsoft.com/office/drawing/2014/main" id="{A862D4BA-BD8E-4C19-8158-F5AB1196D3CA}"/>
+                <a16:creationId xmlns:a16="http://schemas.microsoft.com/office/drawing/2014/main" id="{C802B9E3-7B6C-47AD-8D17-AE956E85252E}"/>
               </a:ext>
             </a:extLst>
           </p:cNvPr>
@@ -12329,7 +12329,7 @@
           <p:cNvPr id="4" name="">
             <a:extLst xmlns:a="http://schemas.openxmlformats.org/drawingml/2006/main">
               <a:ext uri="{FF2B5EF4-FFF2-40B4-BE49-F238E27FC236}">
-                <a16:creationId xmlns:a16="http://schemas.microsoft.com/office/drawing/2014/main" id="{A789EE4F-2588-4750-A1F6-F6C1DCCB6BEB}"/>
+                <a16:creationId xmlns:a16="http://schemas.microsoft.com/office/drawing/2014/main" id="{1C204B36-40FF-4256-B2D3-E09ED4D51A2D}"/>
               </a:ext>
             </a:extLst>
           </p:cNvPr>
@@ -12360,7 +12360,7 @@
           <p:cNvPr id="5" name="">
             <a:extLst xmlns:a="http://schemas.openxmlformats.org/drawingml/2006/main">
               <a:ext uri="{FF2B5EF4-FFF2-40B4-BE49-F238E27FC236}">
-                <a16:creationId xmlns:a16="http://schemas.microsoft.com/office/drawing/2014/main" id="{7A36594C-C9B9-422E-A9B6-C74763AD40AA}"/>
+                <a16:creationId xmlns:a16="http://schemas.microsoft.com/office/drawing/2014/main" id="{6615961D-AC62-4F72-A0E5-94440CCD2183}"/>
               </a:ext>
             </a:extLst>
           </p:cNvPr>
@@ -12391,7 +12391,7 @@
           <p:cNvPr id="6" name="">
             <a:extLst xmlns:a="http://schemas.openxmlformats.org/drawingml/2006/main">
               <a:ext uri="{FF2B5EF4-FFF2-40B4-BE49-F238E27FC236}">
-                <a16:creationId xmlns:a16="http://schemas.microsoft.com/office/drawing/2014/main" id="{7106FF02-07B2-48A0-8298-173667F63233}"/>
+                <a16:creationId xmlns:a16="http://schemas.microsoft.com/office/drawing/2014/main" id="{D0B9A2D3-A829-4A5B-8643-D22DF59EC873}"/>
               </a:ext>
             </a:extLst>
           </p:cNvPr>
@@ -12422,7 +12422,7 @@
           <p:cNvPr id="7" name="">
             <a:extLst xmlns:a="http://schemas.openxmlformats.org/drawingml/2006/main">
               <a:ext uri="{FF2B5EF4-FFF2-40B4-BE49-F238E27FC236}">
-                <a16:creationId xmlns:a16="http://schemas.microsoft.com/office/drawing/2014/main" id="{7F9174E4-BF3F-47B7-B741-2C447E7966F1}"/>
+                <a16:creationId xmlns:a16="http://schemas.microsoft.com/office/drawing/2014/main" id="{21E1B065-6082-4737-B5B4-4FA55B1DA655}"/>
               </a:ext>
             </a:extLst>
           </p:cNvPr>
@@ -12453,7 +12453,7 @@
           <p:cNvPr id="8" name="">
             <a:extLst xmlns:a="http://schemas.openxmlformats.org/drawingml/2006/main">
               <a:ext uri="{FF2B5EF4-FFF2-40B4-BE49-F238E27FC236}">
-                <a16:creationId xmlns:a16="http://schemas.microsoft.com/office/drawing/2014/main" id="{1E84A55B-5AB4-4C99-A1FF-21BD1CBBC590}"/>
+                <a16:creationId xmlns:a16="http://schemas.microsoft.com/office/drawing/2014/main" id="{05171195-4027-4A5C-9AA2-5454BFC4EBF4}"/>
               </a:ext>
             </a:extLst>
           </p:cNvPr>
@@ -12484,7 +12484,7 @@
           <p:cNvPr id="9" name="">
             <a:extLst xmlns:a="http://schemas.openxmlformats.org/drawingml/2006/main">
               <a:ext uri="{FF2B5EF4-FFF2-40B4-BE49-F238E27FC236}">
-                <a16:creationId xmlns:a16="http://schemas.microsoft.com/office/drawing/2014/main" id="{2478BE43-781C-4449-9029-D1CC31640322}"/>
+                <a16:creationId xmlns:a16="http://schemas.microsoft.com/office/drawing/2014/main" id="{B6432490-D512-48D1-A70E-DF83A365ED11}"/>
               </a:ext>
             </a:extLst>
           </p:cNvPr>
@@ -12515,7 +12515,7 @@
           <p:cNvPr id="10" name="">
             <a:extLst xmlns:a="http://schemas.openxmlformats.org/drawingml/2006/main">
               <a:ext uri="{FF2B5EF4-FFF2-40B4-BE49-F238E27FC236}">
-                <a16:creationId xmlns:a16="http://schemas.microsoft.com/office/drawing/2014/main" id="{2D91D91D-107C-407D-8CD5-047BF2FD4747}"/>
+                <a16:creationId xmlns:a16="http://schemas.microsoft.com/office/drawing/2014/main" id="{4C2302C1-55C7-49FE-9046-FD265B429BCB}"/>
               </a:ext>
             </a:extLst>
           </p:cNvPr>
@@ -12546,7 +12546,7 @@
           <p:cNvPr id="11" name="">
             <a:extLst xmlns:a="http://schemas.openxmlformats.org/drawingml/2006/main">
               <a:ext uri="{FF2B5EF4-FFF2-40B4-BE49-F238E27FC236}">
-                <a16:creationId xmlns:a16="http://schemas.microsoft.com/office/drawing/2014/main" id="{1FA5D183-EC05-4C8D-B164-5D4848818BE5}"/>
+                <a16:creationId xmlns:a16="http://schemas.microsoft.com/office/drawing/2014/main" id="{34108906-6D10-4FA5-8571-CE8B86715B73}"/>
               </a:ext>
             </a:extLst>
           </p:cNvPr>
@@ -12577,7 +12577,7 @@
           <p:cNvPr id="12" name="">
             <a:extLst xmlns:a="http://schemas.openxmlformats.org/drawingml/2006/main">
               <a:ext uri="{FF2B5EF4-FFF2-40B4-BE49-F238E27FC236}">
-                <a16:creationId xmlns:a16="http://schemas.microsoft.com/office/drawing/2014/main" id="{ADD827AB-7881-4A95-BD77-B6EA284A178F}"/>
+                <a16:creationId xmlns:a16="http://schemas.microsoft.com/office/drawing/2014/main" id="{8BEA07AE-B353-4E49-A35D-9186CFB0E1CD}"/>
               </a:ext>
             </a:extLst>
           </p:cNvPr>
@@ -12608,7 +12608,7 @@
           <p:cNvPr id="13" name="">
             <a:extLst xmlns:a="http://schemas.openxmlformats.org/drawingml/2006/main">
               <a:ext uri="{FF2B5EF4-FFF2-40B4-BE49-F238E27FC236}">
-                <a16:creationId xmlns:a16="http://schemas.microsoft.com/office/drawing/2014/main" id="{BD23DE0C-56BC-43DD-BCF6-02CCEE11F2CE}"/>
+                <a16:creationId xmlns:a16="http://schemas.microsoft.com/office/drawing/2014/main" id="{B32806E6-83B1-45F4-B481-0D3EB243EDC6}"/>
               </a:ext>
             </a:extLst>
           </p:cNvPr>
@@ -12639,7 +12639,7 @@
           <p:cNvPr id="14" name="">
             <a:extLst xmlns:a="http://schemas.openxmlformats.org/drawingml/2006/main">
               <a:ext uri="{FF2B5EF4-FFF2-40B4-BE49-F238E27FC236}">
-                <a16:creationId xmlns:a16="http://schemas.microsoft.com/office/drawing/2014/main" id="{261B5B29-D17F-446A-8FFF-7A2A83B81371}"/>
+                <a16:creationId xmlns:a16="http://schemas.microsoft.com/office/drawing/2014/main" id="{7EBEFD30-E9E9-4DC0-97F1-839E7C65C9E1}"/>
               </a:ext>
             </a:extLst>
           </p:cNvPr>
@@ -12696,7 +12696,7 @@
           <p:cNvPr id="15" name="">
             <a:extLst xmlns:a="http://schemas.openxmlformats.org/drawingml/2006/main">
               <a:ext uri="{FF2B5EF4-FFF2-40B4-BE49-F238E27FC236}">
-                <a16:creationId xmlns:a16="http://schemas.microsoft.com/office/drawing/2014/main" id="{A25C5FE4-B000-4308-902F-7C33E9C38379}"/>
+                <a16:creationId xmlns:a16="http://schemas.microsoft.com/office/drawing/2014/main" id="{FF7437F7-EDE0-4591-B867-0431DA2055FF}"/>
               </a:ext>
             </a:extLst>
           </p:cNvPr>
@@ -12753,7 +12753,7 @@
           <p:cNvPr id="16" name="">
             <a:extLst xmlns:a="http://schemas.openxmlformats.org/drawingml/2006/main">
               <a:ext uri="{FF2B5EF4-FFF2-40B4-BE49-F238E27FC236}">
-                <a16:creationId xmlns:a16="http://schemas.microsoft.com/office/drawing/2014/main" id="{D4EF5233-977F-4A32-9BB1-223774B12ED7}"/>
+                <a16:creationId xmlns:a16="http://schemas.microsoft.com/office/drawing/2014/main" id="{DE0DF600-CC58-4FDB-AE8D-E652EF322B4D}"/>
               </a:ext>
             </a:extLst>
           </p:cNvPr>
@@ -12833,7 +12833,7 @@
           <p:cNvPr id="17" name="">
             <a:extLst xmlns:a="http://schemas.openxmlformats.org/drawingml/2006/main">
               <a:ext uri="{FF2B5EF4-FFF2-40B4-BE49-F238E27FC236}">
-                <a16:creationId xmlns:a16="http://schemas.microsoft.com/office/drawing/2014/main" id="{EE1157E7-3563-45CD-AC05-48DF24C8DC88}"/>
+                <a16:creationId xmlns:a16="http://schemas.microsoft.com/office/drawing/2014/main" id="{06225251-C23C-400A-9134-3F7DE17B706E}"/>
               </a:ext>
             </a:extLst>
           </p:cNvPr>
@@ -12890,7 +12890,7 @@
           <p:cNvPr id="18" name="">
             <a:extLst xmlns:a="http://schemas.openxmlformats.org/drawingml/2006/main">
               <a:ext uri="{FF2B5EF4-FFF2-40B4-BE49-F238E27FC236}">
-                <a16:creationId xmlns:a16="http://schemas.microsoft.com/office/drawing/2014/main" id="{DC3EE533-8E53-48D8-8507-CC8180D3DC0B}"/>
+                <a16:creationId xmlns:a16="http://schemas.microsoft.com/office/drawing/2014/main" id="{027C465C-4798-4BDE-BF20-D5693E29A2A1}"/>
               </a:ext>
             </a:extLst>
           </p:cNvPr>
@@ -12947,7 +12947,7 @@
           <p:cNvPr id="19" name="">
             <a:extLst xmlns:a="http://schemas.openxmlformats.org/drawingml/2006/main">
               <a:ext uri="{FF2B5EF4-FFF2-40B4-BE49-F238E27FC236}">
-                <a16:creationId xmlns:a16="http://schemas.microsoft.com/office/drawing/2014/main" id="{3D7AEA8B-85D7-4F58-9DCF-86A7D93C85BB}"/>
+                <a16:creationId xmlns:a16="http://schemas.microsoft.com/office/drawing/2014/main" id="{2E9966DF-5BD7-4B5F-953F-677B51B7BD20}"/>
               </a:ext>
             </a:extLst>
           </p:cNvPr>
@@ -13004,7 +13004,7 @@
           <p:cNvPr id="20" name="">
             <a:extLst xmlns:a="http://schemas.openxmlformats.org/drawingml/2006/main">
               <a:ext uri="{FF2B5EF4-FFF2-40B4-BE49-F238E27FC236}">
-                <a16:creationId xmlns:a16="http://schemas.microsoft.com/office/drawing/2014/main" id="{BBE7F6BF-2BBC-4D7B-9F47-15F9BBC3969A}"/>
+                <a16:creationId xmlns:a16="http://schemas.microsoft.com/office/drawing/2014/main" id="{0956C147-A6CC-4DF2-9790-D105B58DF671}"/>
               </a:ext>
             </a:extLst>
           </p:cNvPr>
@@ -13061,7 +13061,7 @@
           <p:cNvPr id="21" name="">
             <a:extLst xmlns:a="http://schemas.openxmlformats.org/drawingml/2006/main">
               <a:ext uri="{FF2B5EF4-FFF2-40B4-BE49-F238E27FC236}">
-                <a16:creationId xmlns:a16="http://schemas.microsoft.com/office/drawing/2014/main" id="{81DE26F8-DFF6-4A1A-8315-875ABB437EDC}"/>
+                <a16:creationId xmlns:a16="http://schemas.microsoft.com/office/drawing/2014/main" id="{DA3B45B3-E7EA-4005-9868-52C0F04F040A}"/>
               </a:ext>
             </a:extLst>
           </p:cNvPr>
@@ -13092,7 +13092,7 @@
           <p:cNvPr id="22" name="">
             <a:extLst xmlns:a="http://schemas.openxmlformats.org/drawingml/2006/main">
               <a:ext uri="{FF2B5EF4-FFF2-40B4-BE49-F238E27FC236}">
-                <a16:creationId xmlns:a16="http://schemas.microsoft.com/office/drawing/2014/main" id="{AE8C47EC-AD33-4A12-9BF9-0E64E0F7F3FB}"/>
+                <a16:creationId xmlns:a16="http://schemas.microsoft.com/office/drawing/2014/main" id="{30857A5D-9FDB-405F-B706-71567E5B9062}"/>
               </a:ext>
             </a:extLst>
           </p:cNvPr>
@@ -13147,7 +13147,7 @@
     </p:spTree>
     <p:extLst>
       <p:ext uri="{BB962C8B-B14F-4D97-AF65-F5344CB8AC3E}">
-        <p14:creationId xmlns:p14="http://schemas.microsoft.com/office/powerpoint/2010/main" val="722455598"/>
+        <p14:creationId xmlns:p14="http://schemas.microsoft.com/office/powerpoint/2010/main" val="308255621"/>
       </p:ext>
     </p:extLst>
   </p:cSld>
@@ -13178,7 +13178,7 @@
           <p:cNvPr id="20" name="">
             <a:extLst xmlns:a="http://schemas.openxmlformats.org/drawingml/2006/main">
               <a:ext uri="{FF2B5EF4-FFF2-40B4-BE49-F238E27FC236}">
-                <a16:creationId xmlns:a16="http://schemas.microsoft.com/office/drawing/2014/main" id="{7F104A93-625C-4C31-9C89-230BF02598CC}"/>
+                <a16:creationId xmlns:a16="http://schemas.microsoft.com/office/drawing/2014/main" id="{B59197EA-6680-43EA-A76D-2011EB6391D5}"/>
               </a:ext>
             </a:extLst>
           </p:cNvPr>
@@ -13235,7 +13235,7 @@
           <p:cNvPr id="2" name="">
             <a:extLst xmlns:a="http://schemas.openxmlformats.org/drawingml/2006/main">
               <a:ext uri="{FF2B5EF4-FFF2-40B4-BE49-F238E27FC236}">
-                <a16:creationId xmlns:a16="http://schemas.microsoft.com/office/drawing/2014/main" id="{12E59810-C4EF-487D-8039-0DC88D3C8E24}"/>
+                <a16:creationId xmlns:a16="http://schemas.microsoft.com/office/drawing/2014/main" id="{DB2D57A7-4122-4A1D-AF18-37FC713AC887}"/>
               </a:ext>
             </a:extLst>
           </p:cNvPr>
@@ -13266,7 +13266,7 @@
           <p:cNvPr id="3" name="">
             <a:extLst xmlns:a="http://schemas.openxmlformats.org/drawingml/2006/main">
               <a:ext uri="{FF2B5EF4-FFF2-40B4-BE49-F238E27FC236}">
-                <a16:creationId xmlns:a16="http://schemas.microsoft.com/office/drawing/2014/main" id="{0A453008-D39A-401A-B2B7-7B3F27795423}"/>
+                <a16:creationId xmlns:a16="http://schemas.microsoft.com/office/drawing/2014/main" id="{88DE52B3-FBD5-4156-9514-344686A508AE}"/>
               </a:ext>
             </a:extLst>
           </p:cNvPr>
@@ -13323,7 +13323,7 @@
           <p:cNvPr id="4" name="">
             <a:extLst xmlns:a="http://schemas.openxmlformats.org/drawingml/2006/main">
               <a:ext uri="{FF2B5EF4-FFF2-40B4-BE49-F238E27FC236}">
-                <a16:creationId xmlns:a16="http://schemas.microsoft.com/office/drawing/2014/main" id="{42D2B376-6B2D-4BD2-8039-24D8972839C6}"/>
+                <a16:creationId xmlns:a16="http://schemas.microsoft.com/office/drawing/2014/main" id="{3C2EC4C7-CA0A-48A8-B7F6-6DD17191FD9F}"/>
               </a:ext>
             </a:extLst>
           </p:cNvPr>
@@ -13380,7 +13380,7 @@
           <p:cNvPr id="5" name="">
             <a:extLst xmlns:a="http://schemas.openxmlformats.org/drawingml/2006/main">
               <a:ext uri="{FF2B5EF4-FFF2-40B4-BE49-F238E27FC236}">
-                <a16:creationId xmlns:a16="http://schemas.microsoft.com/office/drawing/2014/main" id="{AFB9A089-F27A-47ED-9397-AB7E1641266C}"/>
+                <a16:creationId xmlns:a16="http://schemas.microsoft.com/office/drawing/2014/main" id="{CF382E93-2DE0-452C-95FF-31D85371FA19}"/>
               </a:ext>
             </a:extLst>
           </p:cNvPr>
@@ -13437,7 +13437,7 @@
           <p:cNvPr id="6" name="">
             <a:extLst xmlns:a="http://schemas.openxmlformats.org/drawingml/2006/main">
               <a:ext uri="{FF2B5EF4-FFF2-40B4-BE49-F238E27FC236}">
-                <a16:creationId xmlns:a16="http://schemas.microsoft.com/office/drawing/2014/main" id="{5C2AB771-F4FE-4846-A0A9-B1F160BBAED7}"/>
+                <a16:creationId xmlns:a16="http://schemas.microsoft.com/office/drawing/2014/main" id="{E707532C-AC4C-4AEE-9041-AC12A56B3C8C}"/>
               </a:ext>
             </a:extLst>
           </p:cNvPr>
@@ -13494,7 +13494,7 @@
           <p:cNvPr id="7" name="">
             <a:extLst xmlns:a="http://schemas.openxmlformats.org/drawingml/2006/main">
               <a:ext uri="{FF2B5EF4-FFF2-40B4-BE49-F238E27FC236}">
-                <a16:creationId xmlns:a16="http://schemas.microsoft.com/office/drawing/2014/main" id="{239F99C1-5A99-4D0F-89F9-D421B017ED86}"/>
+                <a16:creationId xmlns:a16="http://schemas.microsoft.com/office/drawing/2014/main" id="{CF738EED-66A0-4F79-91EA-C7CF8D42438D}"/>
               </a:ext>
             </a:extLst>
           </p:cNvPr>
@@ -13527,7 +13527,7 @@
           <p:cNvPr id="8" name="">
             <a:extLst xmlns:a="http://schemas.openxmlformats.org/drawingml/2006/main">
               <a:ext uri="{FF2B5EF4-FFF2-40B4-BE49-F238E27FC236}">
-                <a16:creationId xmlns:a16="http://schemas.microsoft.com/office/drawing/2014/main" id="{53B64194-C980-402D-9976-C92204118BCC}"/>
+                <a16:creationId xmlns:a16="http://schemas.microsoft.com/office/drawing/2014/main" id="{E2BB7D33-2B72-467B-9D2A-5DAAC1C806BD}"/>
               </a:ext>
             </a:extLst>
           </p:cNvPr>
@@ -13584,7 +13584,7 @@
           <p:cNvPr id="9" name="">
             <a:extLst xmlns:a="http://schemas.openxmlformats.org/drawingml/2006/main">
               <a:ext uri="{FF2B5EF4-FFF2-40B4-BE49-F238E27FC236}">
-                <a16:creationId xmlns:a16="http://schemas.microsoft.com/office/drawing/2014/main" id="{EDD0B152-76FA-4006-8C50-C88BE7CB6882}"/>
+                <a16:creationId xmlns:a16="http://schemas.microsoft.com/office/drawing/2014/main" id="{D3F154AC-0CE1-41A1-8AD7-44AE76C64929}"/>
               </a:ext>
             </a:extLst>
           </p:cNvPr>
@@ -13617,7 +13617,7 @@
           <p:cNvPr id="10" name="">
             <a:extLst xmlns:a="http://schemas.openxmlformats.org/drawingml/2006/main">
               <a:ext uri="{FF2B5EF4-FFF2-40B4-BE49-F238E27FC236}">
-                <a16:creationId xmlns:a16="http://schemas.microsoft.com/office/drawing/2014/main" id="{B2ECA8BC-BA9E-4545-8CBE-3678055DB3AD}"/>
+                <a16:creationId xmlns:a16="http://schemas.microsoft.com/office/drawing/2014/main" id="{23A81BB3-74A3-4B5E-99B2-195479D2C936}"/>
               </a:ext>
             </a:extLst>
           </p:cNvPr>
@@ -13700,7 +13700,7 @@
           <p:cNvPr id="12" name="">
             <a:extLst xmlns:a="http://schemas.openxmlformats.org/drawingml/2006/main">
               <a:ext uri="{FF2B5EF4-FFF2-40B4-BE49-F238E27FC236}">
-                <a16:creationId xmlns:a16="http://schemas.microsoft.com/office/drawing/2014/main" id="{93EFE890-08CF-4A44-A1E1-FE03A00F1241}"/>
+                <a16:creationId xmlns:a16="http://schemas.microsoft.com/office/drawing/2014/main" id="{E8F086DC-08F4-4121-9AEE-B4F9CDC012A9}"/>
               </a:ext>
             </a:extLst>
           </p:cNvPr>
@@ -13780,7 +13780,7 @@
           <p:cNvPr id="13" name="">
             <a:extLst xmlns:a="http://schemas.openxmlformats.org/drawingml/2006/main">
               <a:ext uri="{FF2B5EF4-FFF2-40B4-BE49-F238E27FC236}">
-                <a16:creationId xmlns:a16="http://schemas.microsoft.com/office/drawing/2014/main" id="{D74E9226-7F37-4E8C-9B9F-0E10D178CE7D}"/>
+                <a16:creationId xmlns:a16="http://schemas.microsoft.com/office/drawing/2014/main" id="{C4E45B17-2387-4AB7-AA2B-BC5208A47CC5}"/>
               </a:ext>
             </a:extLst>
           </p:cNvPr>
@@ -13837,7 +13837,7 @@
           <p:cNvPr id="14" name="">
             <a:extLst xmlns:a="http://schemas.openxmlformats.org/drawingml/2006/main">
               <a:ext uri="{FF2B5EF4-FFF2-40B4-BE49-F238E27FC236}">
-                <a16:creationId xmlns:a16="http://schemas.microsoft.com/office/drawing/2014/main" id="{5DCD1BDD-5777-4199-86DD-EA0ED6C95640}"/>
+                <a16:creationId xmlns:a16="http://schemas.microsoft.com/office/drawing/2014/main" id="{FDA5FF34-9775-46DB-9917-AA7B384F7679}"/>
               </a:ext>
             </a:extLst>
           </p:cNvPr>
@@ -13894,7 +13894,7 @@
           <p:cNvPr id="15" name="">
             <a:extLst xmlns:a="http://schemas.openxmlformats.org/drawingml/2006/main">
               <a:ext uri="{FF2B5EF4-FFF2-40B4-BE49-F238E27FC236}">
-                <a16:creationId xmlns:a16="http://schemas.microsoft.com/office/drawing/2014/main" id="{93767B1D-B609-49EC-8F6E-E1ED318647C1}"/>
+                <a16:creationId xmlns:a16="http://schemas.microsoft.com/office/drawing/2014/main" id="{1A0A9802-9959-4BA0-809B-1313A5B81F19}"/>
               </a:ext>
             </a:extLst>
           </p:cNvPr>
@@ -13951,7 +13951,7 @@
           <p:cNvPr id="16" name="">
             <a:extLst xmlns:a="http://schemas.openxmlformats.org/drawingml/2006/main">
               <a:ext uri="{FF2B5EF4-FFF2-40B4-BE49-F238E27FC236}">
-                <a16:creationId xmlns:a16="http://schemas.microsoft.com/office/drawing/2014/main" id="{A8151A32-1CD3-4ED3-9EAF-51B6BC75821F}"/>
+                <a16:creationId xmlns:a16="http://schemas.microsoft.com/office/drawing/2014/main" id="{F986E9B5-9DB9-46C6-8605-4ADC727121FF}"/>
               </a:ext>
             </a:extLst>
           </p:cNvPr>
@@ -14008,7 +14008,7 @@
           <p:cNvPr id="17" name="">
             <a:extLst xmlns:a="http://schemas.openxmlformats.org/drawingml/2006/main">
               <a:ext uri="{FF2B5EF4-FFF2-40B4-BE49-F238E27FC236}">
-                <a16:creationId xmlns:a16="http://schemas.microsoft.com/office/drawing/2014/main" id="{78C8459F-2E1B-42AD-85F1-EAB56C4BB2E1}"/>
+                <a16:creationId xmlns:a16="http://schemas.microsoft.com/office/drawing/2014/main" id="{24224078-8138-4FE8-8E8D-0A6647623E41}"/>
               </a:ext>
             </a:extLst>
           </p:cNvPr>
@@ -14065,7 +14065,7 @@
           <p:cNvPr id="18" name="">
             <a:extLst xmlns:a="http://schemas.openxmlformats.org/drawingml/2006/main">
               <a:ext uri="{FF2B5EF4-FFF2-40B4-BE49-F238E27FC236}">
-                <a16:creationId xmlns:a16="http://schemas.microsoft.com/office/drawing/2014/main" id="{CD9618CA-60B9-4531-93D0-F33B5C9F1950}"/>
+                <a16:creationId xmlns:a16="http://schemas.microsoft.com/office/drawing/2014/main" id="{D44FAD2F-405A-44E1-857D-9674308B7ABE}"/>
               </a:ext>
             </a:extLst>
           </p:cNvPr>
@@ -14096,7 +14096,7 @@
           <p:cNvPr id="19" name="">
             <a:extLst xmlns:a="http://schemas.openxmlformats.org/drawingml/2006/main">
               <a:ext uri="{FF2B5EF4-FFF2-40B4-BE49-F238E27FC236}">
-                <a16:creationId xmlns:a16="http://schemas.microsoft.com/office/drawing/2014/main" id="{87B74B1F-7C59-4125-A3CC-34596996456E}"/>
+                <a16:creationId xmlns:a16="http://schemas.microsoft.com/office/drawing/2014/main" id="{F484E58C-BF18-4C2C-9CEA-490F246CFBF7}"/>
               </a:ext>
             </a:extLst>
           </p:cNvPr>
@@ -14151,7 +14151,7 @@
     </p:spTree>
     <p:extLst>
       <p:ext uri="{BB962C8B-B14F-4D97-AF65-F5344CB8AC3E}">
-        <p14:creationId xmlns:p14="http://schemas.microsoft.com/office/powerpoint/2010/main" val="663390554"/>
+        <p14:creationId xmlns:p14="http://schemas.microsoft.com/office/powerpoint/2010/main" val="30907407"/>
       </p:ext>
     </p:extLst>
   </p:cSld>
@@ -14182,7 +14182,7 @@
           <p:cNvPr id="22" name="">
             <a:extLst xmlns:a="http://schemas.openxmlformats.org/drawingml/2006/main">
               <a:ext uri="{FF2B5EF4-FFF2-40B4-BE49-F238E27FC236}">
-                <a16:creationId xmlns:a16="http://schemas.microsoft.com/office/drawing/2014/main" id="{2F257AAC-4C4F-4078-80D1-84A976E463B8}"/>
+                <a16:creationId xmlns:a16="http://schemas.microsoft.com/office/drawing/2014/main" id="{2F0A1A73-8F63-464F-B3E3-A85D2CF8CB3C}"/>
               </a:ext>
             </a:extLst>
           </p:cNvPr>
@@ -14262,7 +14262,7 @@
           <p:cNvPr id="2" name="">
             <a:extLst xmlns:a="http://schemas.openxmlformats.org/drawingml/2006/main">
               <a:ext uri="{FF2B5EF4-FFF2-40B4-BE49-F238E27FC236}">
-                <a16:creationId xmlns:a16="http://schemas.microsoft.com/office/drawing/2014/main" id="{5A64F980-4DBF-422C-A32D-5B9860DFC335}"/>
+                <a16:creationId xmlns:a16="http://schemas.microsoft.com/office/drawing/2014/main" id="{DCE48C41-5F63-4BB8-9C41-7D891A4F3F4E}"/>
               </a:ext>
             </a:extLst>
           </p:cNvPr>
@@ -14293,7 +14293,7 @@
           <p:cNvPr id="3" name="">
             <a:extLst xmlns:a="http://schemas.openxmlformats.org/drawingml/2006/main">
               <a:ext uri="{FF2B5EF4-FFF2-40B4-BE49-F238E27FC236}">
-                <a16:creationId xmlns:a16="http://schemas.microsoft.com/office/drawing/2014/main" id="{EA373210-7498-46D4-BA3E-43870463835E}"/>
+                <a16:creationId xmlns:a16="http://schemas.microsoft.com/office/drawing/2014/main" id="{003E1E73-D188-4EB5-BCAB-6FD6D9F5593D}"/>
               </a:ext>
             </a:extLst>
           </p:cNvPr>
@@ -14350,7 +14350,7 @@
           <p:cNvPr id="4" name="">
             <a:extLst xmlns:a="http://schemas.openxmlformats.org/drawingml/2006/main">
               <a:ext uri="{FF2B5EF4-FFF2-40B4-BE49-F238E27FC236}">
-                <a16:creationId xmlns:a16="http://schemas.microsoft.com/office/drawing/2014/main" id="{CB9C7B64-D61F-4803-95F3-74C4956D44F9}"/>
+                <a16:creationId xmlns:a16="http://schemas.microsoft.com/office/drawing/2014/main" id="{E395B5FF-537A-423C-BF5C-C20E846C31EF}"/>
               </a:ext>
             </a:extLst>
           </p:cNvPr>
@@ -14407,7 +14407,7 @@
           <p:cNvPr id="5" name="">
             <a:extLst xmlns:a="http://schemas.openxmlformats.org/drawingml/2006/main">
               <a:ext uri="{FF2B5EF4-FFF2-40B4-BE49-F238E27FC236}">
-                <a16:creationId xmlns:a16="http://schemas.microsoft.com/office/drawing/2014/main" id="{2A6BA014-36C5-4A82-A22E-00A8B39E4478}"/>
+                <a16:creationId xmlns:a16="http://schemas.microsoft.com/office/drawing/2014/main" id="{078BD4F1-C96A-4414-B865-B0D9B74E5501}"/>
               </a:ext>
             </a:extLst>
           </p:cNvPr>
@@ -14438,7 +14438,7 @@
           <p:cNvPr id="6" name="">
             <a:extLst xmlns:a="http://schemas.openxmlformats.org/drawingml/2006/main">
               <a:ext uri="{FF2B5EF4-FFF2-40B4-BE49-F238E27FC236}">
-                <a16:creationId xmlns:a16="http://schemas.microsoft.com/office/drawing/2014/main" id="{253F69FE-6511-4BEB-B53F-C030D345FE1B}"/>
+                <a16:creationId xmlns:a16="http://schemas.microsoft.com/office/drawing/2014/main" id="{17795297-06E7-472B-92C7-412682A2395E}"/>
               </a:ext>
             </a:extLst>
           </p:cNvPr>
@@ -14495,7 +14495,7 @@
           <p:cNvPr id="7" name="">
             <a:extLst xmlns:a="http://schemas.openxmlformats.org/drawingml/2006/main">
               <a:ext uri="{FF2B5EF4-FFF2-40B4-BE49-F238E27FC236}">
-                <a16:creationId xmlns:a16="http://schemas.microsoft.com/office/drawing/2014/main" id="{DA010A8C-9581-4F08-B678-793E1557FA6C}"/>
+                <a16:creationId xmlns:a16="http://schemas.microsoft.com/office/drawing/2014/main" id="{3F71D555-651F-41F8-8F38-97BE560C8653}"/>
               </a:ext>
             </a:extLst>
           </p:cNvPr>
@@ -14552,7 +14552,7 @@
           <p:cNvPr id="8" name="">
             <a:extLst xmlns:a="http://schemas.openxmlformats.org/drawingml/2006/main">
               <a:ext uri="{FF2B5EF4-FFF2-40B4-BE49-F238E27FC236}">
-                <a16:creationId xmlns:a16="http://schemas.microsoft.com/office/drawing/2014/main" id="{8CFEE917-DAEC-4624-AB4C-E8AB5D90B4E5}"/>
+                <a16:creationId xmlns:a16="http://schemas.microsoft.com/office/drawing/2014/main" id="{BA54902E-0214-47B0-B801-356B36440B7B}"/>
               </a:ext>
             </a:extLst>
           </p:cNvPr>
@@ -14609,7 +14609,7 @@
           <p:cNvPr id="9" name="">
             <a:extLst xmlns:a="http://schemas.openxmlformats.org/drawingml/2006/main">
               <a:ext uri="{FF2B5EF4-FFF2-40B4-BE49-F238E27FC236}">
-                <a16:creationId xmlns:a16="http://schemas.microsoft.com/office/drawing/2014/main" id="{86F6E18E-8AA2-484F-8ABF-337EB8DB31EB}"/>
+                <a16:creationId xmlns:a16="http://schemas.microsoft.com/office/drawing/2014/main" id="{EF00C471-7DAE-44DD-ACC8-C37DC18C5A11}"/>
               </a:ext>
             </a:extLst>
           </p:cNvPr>
@@ -14666,7 +14666,7 @@
           <p:cNvPr id="10" name="">
             <a:extLst xmlns:a="http://schemas.openxmlformats.org/drawingml/2006/main">
               <a:ext uri="{FF2B5EF4-FFF2-40B4-BE49-F238E27FC236}">
-                <a16:creationId xmlns:a16="http://schemas.microsoft.com/office/drawing/2014/main" id="{4D663C15-359E-479D-BFAC-9B3544F384DE}"/>
+                <a16:creationId xmlns:a16="http://schemas.microsoft.com/office/drawing/2014/main" id="{186A86FC-4868-46C3-BDCD-7446A16EE909}"/>
               </a:ext>
             </a:extLst>
           </p:cNvPr>
@@ -14723,7 +14723,7 @@
           <p:cNvPr id="11" name="">
             <a:extLst xmlns:a="http://schemas.openxmlformats.org/drawingml/2006/main">
               <a:ext uri="{FF2B5EF4-FFF2-40B4-BE49-F238E27FC236}">
-                <a16:creationId xmlns:a16="http://schemas.microsoft.com/office/drawing/2014/main" id="{D9FA42C2-6493-4D6D-958E-59CB76EDC318}"/>
+                <a16:creationId xmlns:a16="http://schemas.microsoft.com/office/drawing/2014/main" id="{DE63346C-FDAC-4C5E-8D22-06101EB5A982}"/>
               </a:ext>
             </a:extLst>
           </p:cNvPr>
@@ -14754,7 +14754,7 @@
           <p:cNvPr id="12" name="">
             <a:extLst xmlns:a="http://schemas.openxmlformats.org/drawingml/2006/main">
               <a:ext uri="{FF2B5EF4-FFF2-40B4-BE49-F238E27FC236}">
-                <a16:creationId xmlns:a16="http://schemas.microsoft.com/office/drawing/2014/main" id="{EA04E271-DB3E-4087-A8F0-C2385D2F9EDC}"/>
+                <a16:creationId xmlns:a16="http://schemas.microsoft.com/office/drawing/2014/main" id="{17562353-A2ED-4DE3-91D4-7E9B25A28A0F}"/>
               </a:ext>
             </a:extLst>
           </p:cNvPr>
@@ -14811,7 +14811,7 @@
           <p:cNvPr id="13" name="">
             <a:extLst xmlns:a="http://schemas.openxmlformats.org/drawingml/2006/main">
               <a:ext uri="{FF2B5EF4-FFF2-40B4-BE49-F238E27FC236}">
-                <a16:creationId xmlns:a16="http://schemas.microsoft.com/office/drawing/2014/main" id="{8108E90E-C1B1-47A2-839E-40CC75F35D01}"/>
+                <a16:creationId xmlns:a16="http://schemas.microsoft.com/office/drawing/2014/main" id="{57A4309A-5239-438A-9D2A-DB55C2CF47B8}"/>
               </a:ext>
             </a:extLst>
           </p:cNvPr>
@@ -14868,7 +14868,7 @@
           <p:cNvPr id="14" name="">
             <a:extLst xmlns:a="http://schemas.openxmlformats.org/drawingml/2006/main">
               <a:ext uri="{FF2B5EF4-FFF2-40B4-BE49-F238E27FC236}">
-                <a16:creationId xmlns:a16="http://schemas.microsoft.com/office/drawing/2014/main" id="{696C8A1E-E42E-4A3C-9F04-887A7DC9C87F}"/>
+                <a16:creationId xmlns:a16="http://schemas.microsoft.com/office/drawing/2014/main" id="{2CDD511D-6111-4292-AFA1-BE12A52EDA4B}"/>
               </a:ext>
             </a:extLst>
           </p:cNvPr>
@@ -14925,7 +14925,7 @@
           <p:cNvPr id="15" name="">
             <a:extLst xmlns:a="http://schemas.openxmlformats.org/drawingml/2006/main">
               <a:ext uri="{FF2B5EF4-FFF2-40B4-BE49-F238E27FC236}">
-                <a16:creationId xmlns:a16="http://schemas.microsoft.com/office/drawing/2014/main" id="{6A21E45C-62CA-4F41-94C4-F4F9E7E620A4}"/>
+                <a16:creationId xmlns:a16="http://schemas.microsoft.com/office/drawing/2014/main" id="{E03D89B6-71DB-439D-92D5-63E0BB93F399}"/>
               </a:ext>
             </a:extLst>
           </p:cNvPr>
@@ -14982,7 +14982,7 @@
           <p:cNvPr id="16" name="">
             <a:extLst xmlns:a="http://schemas.openxmlformats.org/drawingml/2006/main">
               <a:ext uri="{FF2B5EF4-FFF2-40B4-BE49-F238E27FC236}">
-                <a16:creationId xmlns:a16="http://schemas.microsoft.com/office/drawing/2014/main" id="{34ECA3EA-56AA-44ED-8285-D0930684FD9B}"/>
+                <a16:creationId xmlns:a16="http://schemas.microsoft.com/office/drawing/2014/main" id="{FA3B1398-CED0-43D2-A4FD-A1AB93F3E576}"/>
               </a:ext>
             </a:extLst>
           </p:cNvPr>
@@ -15039,7 +15039,7 @@
           <p:cNvPr id="17" name="">
             <a:extLst xmlns:a="http://schemas.openxmlformats.org/drawingml/2006/main">
               <a:ext uri="{FF2B5EF4-FFF2-40B4-BE49-F238E27FC236}">
-                <a16:creationId xmlns:a16="http://schemas.microsoft.com/office/drawing/2014/main" id="{46E999B9-2ADF-4D57-9DEB-72A719D13D8C}"/>
+                <a16:creationId xmlns:a16="http://schemas.microsoft.com/office/drawing/2014/main" id="{2C1FE53D-B528-4893-93A3-8938BFC62045}"/>
               </a:ext>
             </a:extLst>
           </p:cNvPr>
@@ -15070,7 +15070,7 @@
           <p:cNvPr id="18" name="">
             <a:extLst xmlns:a="http://schemas.openxmlformats.org/drawingml/2006/main">
               <a:ext uri="{FF2B5EF4-FFF2-40B4-BE49-F238E27FC236}">
-                <a16:creationId xmlns:a16="http://schemas.microsoft.com/office/drawing/2014/main" id="{D92DDFD3-7F9C-4D68-97BA-45156CFFABD8}"/>
+                <a16:creationId xmlns:a16="http://schemas.microsoft.com/office/drawing/2014/main" id="{A3FA4DF7-13F0-4599-9F6A-62F92DA24AD1}"/>
               </a:ext>
             </a:extLst>
           </p:cNvPr>
@@ -15127,7 +15127,7 @@
           <p:cNvPr id="19" name="">
             <a:extLst xmlns:a="http://schemas.openxmlformats.org/drawingml/2006/main">
               <a:ext uri="{FF2B5EF4-FFF2-40B4-BE49-F238E27FC236}">
-                <a16:creationId xmlns:a16="http://schemas.microsoft.com/office/drawing/2014/main" id="{3EE36A48-42FB-460D-891C-7711CE96D21C}"/>
+                <a16:creationId xmlns:a16="http://schemas.microsoft.com/office/drawing/2014/main" id="{E9CC9FD9-3DDB-450A-9E95-F76B65750CFF}"/>
               </a:ext>
             </a:extLst>
           </p:cNvPr>
@@ -15158,7 +15158,7 @@
           <p:cNvPr id="20" name="">
             <a:extLst xmlns:a="http://schemas.openxmlformats.org/drawingml/2006/main">
               <a:ext uri="{FF2B5EF4-FFF2-40B4-BE49-F238E27FC236}">
-                <a16:creationId xmlns:a16="http://schemas.microsoft.com/office/drawing/2014/main" id="{7A3AA268-144D-420E-87D5-298B5539E092}"/>
+                <a16:creationId xmlns:a16="http://schemas.microsoft.com/office/drawing/2014/main" id="{2DB31188-7112-4A1A-8ADA-8A30C0B0209F}"/>
               </a:ext>
             </a:extLst>
           </p:cNvPr>
@@ -15215,7 +15215,7 @@
           <p:cNvPr id="21" name="">
             <a:extLst xmlns:a="http://schemas.openxmlformats.org/drawingml/2006/main">
               <a:ext uri="{FF2B5EF4-FFF2-40B4-BE49-F238E27FC236}">
-                <a16:creationId xmlns:a16="http://schemas.microsoft.com/office/drawing/2014/main" id="{374802F4-4B7A-4B7B-9C51-D89DA3C053F9}"/>
+                <a16:creationId xmlns:a16="http://schemas.microsoft.com/office/drawing/2014/main" id="{0C701978-DCF4-4725-BFB5-A1325B2E118C}"/>
               </a:ext>
             </a:extLst>
           </p:cNvPr>
@@ -15270,7 +15270,7 @@
     </p:spTree>
     <p:extLst>
       <p:ext uri="{BB962C8B-B14F-4D97-AF65-F5344CB8AC3E}">
-        <p14:creationId xmlns:p14="http://schemas.microsoft.com/office/powerpoint/2010/main" val="1005439598"/>
+        <p14:creationId xmlns:p14="http://schemas.microsoft.com/office/powerpoint/2010/main" val="565923428"/>
       </p:ext>
     </p:extLst>
   </p:cSld>
@@ -15301,7 +15301,7 @@
           <p:cNvPr id="13" name="">
             <a:extLst xmlns:a="http://schemas.openxmlformats.org/drawingml/2006/main">
               <a:ext uri="{FF2B5EF4-FFF2-40B4-BE49-F238E27FC236}">
-                <a16:creationId xmlns:a16="http://schemas.microsoft.com/office/drawing/2014/main" id="{A168239A-FBB7-44D2-88C3-6724874B5836}"/>
+                <a16:creationId xmlns:a16="http://schemas.microsoft.com/office/drawing/2014/main" id="{C16AA865-FE26-49A8-B72B-335B52F415D8}"/>
               </a:ext>
             </a:extLst>
           </p:cNvPr>
@@ -15358,7 +15358,7 @@
           <p:cNvPr id="2" name="">
             <a:extLst xmlns:a="http://schemas.openxmlformats.org/drawingml/2006/main">
               <a:ext uri="{FF2B5EF4-FFF2-40B4-BE49-F238E27FC236}">
-                <a16:creationId xmlns:a16="http://schemas.microsoft.com/office/drawing/2014/main" id="{E4FBABC3-22DF-4946-B279-7323490AF57B}"/>
+                <a16:creationId xmlns:a16="http://schemas.microsoft.com/office/drawing/2014/main" id="{79A49568-D7B3-448C-9FF8-18162A96926E}"/>
               </a:ext>
             </a:extLst>
           </p:cNvPr>
@@ -15389,7 +15389,7 @@
           <p:cNvPr id="3" name="">
             <a:extLst xmlns:a="http://schemas.openxmlformats.org/drawingml/2006/main">
               <a:ext uri="{FF2B5EF4-FFF2-40B4-BE49-F238E27FC236}">
-                <a16:creationId xmlns:a16="http://schemas.microsoft.com/office/drawing/2014/main" id="{5E831531-51D7-45C7-A691-E21A30637383}"/>
+                <a16:creationId xmlns:a16="http://schemas.microsoft.com/office/drawing/2014/main" id="{95AF1DBA-329C-4D84-ACB1-85ADEF3AAD38}"/>
               </a:ext>
             </a:extLst>
           </p:cNvPr>
@@ -15446,7 +15446,7 @@
           <p:cNvPr id="4" name="">
             <a:extLst xmlns:a="http://schemas.openxmlformats.org/drawingml/2006/main">
               <a:ext uri="{FF2B5EF4-FFF2-40B4-BE49-F238E27FC236}">
-                <a16:creationId xmlns:a16="http://schemas.microsoft.com/office/drawing/2014/main" id="{85F7C6CE-579D-4D08-B449-DED66F2490B6}"/>
+                <a16:creationId xmlns:a16="http://schemas.microsoft.com/office/drawing/2014/main" id="{99CEC481-3A9F-43D3-BD0C-BF7A8087704E}"/>
               </a:ext>
             </a:extLst>
           </p:cNvPr>
@@ -15503,7 +15503,7 @@
           <p:cNvPr id="5" name="">
             <a:extLst xmlns:a="http://schemas.openxmlformats.org/drawingml/2006/main">
               <a:ext uri="{FF2B5EF4-FFF2-40B4-BE49-F238E27FC236}">
-                <a16:creationId xmlns:a16="http://schemas.microsoft.com/office/drawing/2014/main" id="{2DBA1ED8-AD9D-4167-BEF0-14226731F9DB}"/>
+                <a16:creationId xmlns:a16="http://schemas.microsoft.com/office/drawing/2014/main" id="{557FA0E0-8351-474B-AB94-237B0C2923B6}"/>
               </a:ext>
             </a:extLst>
           </p:cNvPr>
@@ -15560,7 +15560,7 @@
           <p:cNvPr id="6" name="">
             <a:extLst xmlns:a="http://schemas.openxmlformats.org/drawingml/2006/main">
               <a:ext uri="{FF2B5EF4-FFF2-40B4-BE49-F238E27FC236}">
-                <a16:creationId xmlns:a16="http://schemas.microsoft.com/office/drawing/2014/main" id="{A525777B-1C1A-4E2E-A4EF-7869FF79E0DE}"/>
+                <a16:creationId xmlns:a16="http://schemas.microsoft.com/office/drawing/2014/main" id="{637917FB-7DF1-4B32-BE79-590D2DC58BB6}"/>
               </a:ext>
             </a:extLst>
           </p:cNvPr>
@@ -15617,7 +15617,7 @@
           <p:cNvPr id="7" name="">
             <a:extLst xmlns:a="http://schemas.openxmlformats.org/drawingml/2006/main">
               <a:ext uri="{FF2B5EF4-FFF2-40B4-BE49-F238E27FC236}">
-                <a16:creationId xmlns:a16="http://schemas.microsoft.com/office/drawing/2014/main" id="{AB12A076-E81A-412B-91C6-6ED8EA920F72}"/>
+                <a16:creationId xmlns:a16="http://schemas.microsoft.com/office/drawing/2014/main" id="{07F6EF4E-F5FB-457C-B7E1-E6631FA5D49A}"/>
               </a:ext>
             </a:extLst>
           </p:cNvPr>
@@ -15674,7 +15674,7 @@
           <p:cNvPr id="8" name="">
             <a:extLst xmlns:a="http://schemas.openxmlformats.org/drawingml/2006/main">
               <a:ext uri="{FF2B5EF4-FFF2-40B4-BE49-F238E27FC236}">
-                <a16:creationId xmlns:a16="http://schemas.microsoft.com/office/drawing/2014/main" id="{E696B824-3DC4-42B5-8466-6F4EFA66D5BB}"/>
+                <a16:creationId xmlns:a16="http://schemas.microsoft.com/office/drawing/2014/main" id="{7CAD02FB-6233-4C6F-9EEA-54C774A3E3F0}"/>
               </a:ext>
             </a:extLst>
           </p:cNvPr>
@@ -15731,7 +15731,7 @@
           <p:cNvPr id="9" name="">
             <a:extLst xmlns:a="http://schemas.openxmlformats.org/drawingml/2006/main">
               <a:ext uri="{FF2B5EF4-FFF2-40B4-BE49-F238E27FC236}">
-                <a16:creationId xmlns:a16="http://schemas.microsoft.com/office/drawing/2014/main" id="{A5A347DB-85F5-44BD-87C5-9190E3DFC5B5}"/>
+                <a16:creationId xmlns:a16="http://schemas.microsoft.com/office/drawing/2014/main" id="{A5F8153D-63D4-46FD-93E3-24E758432A97}"/>
               </a:ext>
             </a:extLst>
           </p:cNvPr>
@@ -15788,7 +15788,7 @@
           <p:cNvPr id="10" name="">
             <a:extLst xmlns:a="http://schemas.openxmlformats.org/drawingml/2006/main">
               <a:ext uri="{FF2B5EF4-FFF2-40B4-BE49-F238E27FC236}">
-                <a16:creationId xmlns:a16="http://schemas.microsoft.com/office/drawing/2014/main" id="{D449B3E5-9BDD-46D5-A125-17A7C87E2EC4}"/>
+                <a16:creationId xmlns:a16="http://schemas.microsoft.com/office/drawing/2014/main" id="{4E0B87B9-2D56-405C-B95B-E809B64EC058}"/>
               </a:ext>
             </a:extLst>
           </p:cNvPr>
@@ -15845,7 +15845,7 @@
           <p:cNvPr id="11" name="">
             <a:extLst xmlns:a="http://schemas.openxmlformats.org/drawingml/2006/main">
               <a:ext uri="{FF2B5EF4-FFF2-40B4-BE49-F238E27FC236}">
-                <a16:creationId xmlns:a16="http://schemas.microsoft.com/office/drawing/2014/main" id="{F1767C01-E6D7-4D88-99F0-30BFADB489BE}"/>
+                <a16:creationId xmlns:a16="http://schemas.microsoft.com/office/drawing/2014/main" id="{C0B1B467-51DF-4036-8591-2F4C58062268}"/>
               </a:ext>
             </a:extLst>
           </p:cNvPr>
@@ -15876,7 +15876,7 @@
           <p:cNvPr id="12" name="">
             <a:extLst xmlns:a="http://schemas.openxmlformats.org/drawingml/2006/main">
               <a:ext uri="{FF2B5EF4-FFF2-40B4-BE49-F238E27FC236}">
-                <a16:creationId xmlns:a16="http://schemas.microsoft.com/office/drawing/2014/main" id="{EA482165-6E4C-4CD4-A727-EC288256F827}"/>
+                <a16:creationId xmlns:a16="http://schemas.microsoft.com/office/drawing/2014/main" id="{00796DD5-B26C-4D16-BF4D-1A0C5DFE1AF6}"/>
               </a:ext>
             </a:extLst>
           </p:cNvPr>
@@ -15931,7 +15931,7 @@
     </p:spTree>
     <p:extLst>
       <p:ext uri="{BB962C8B-B14F-4D97-AF65-F5344CB8AC3E}">
-        <p14:creationId xmlns:p14="http://schemas.microsoft.com/office/powerpoint/2010/main" val="324925214"/>
+        <p14:creationId xmlns:p14="http://schemas.microsoft.com/office/powerpoint/2010/main" val="336562536"/>
       </p:ext>
     </p:extLst>
   </p:cSld>
@@ -15962,7 +15962,7 @@
           <p:cNvPr id="19" name="">
             <a:extLst xmlns:a="http://schemas.openxmlformats.org/drawingml/2006/main">
               <a:ext uri="{FF2B5EF4-FFF2-40B4-BE49-F238E27FC236}">
-                <a16:creationId xmlns:a16="http://schemas.microsoft.com/office/drawing/2014/main" id="{4A1738E0-E14B-4FB8-B75A-05D1B68D7B92}"/>
+                <a16:creationId xmlns:a16="http://schemas.microsoft.com/office/drawing/2014/main" id="{7CDACA27-66E1-4A67-A637-530859728115}"/>
               </a:ext>
             </a:extLst>
           </p:cNvPr>
@@ -16019,7 +16019,7 @@
           <p:cNvPr id="2" name="">
             <a:extLst xmlns:a="http://schemas.openxmlformats.org/drawingml/2006/main">
               <a:ext uri="{FF2B5EF4-FFF2-40B4-BE49-F238E27FC236}">
-                <a16:creationId xmlns:a16="http://schemas.microsoft.com/office/drawing/2014/main" id="{5A1FADC6-AA83-43BC-8B8D-8BCF35CC5DB7}"/>
+                <a16:creationId xmlns:a16="http://schemas.microsoft.com/office/drawing/2014/main" id="{886426A5-FE12-4847-AEE0-55A432CC8B86}"/>
               </a:ext>
             </a:extLst>
           </p:cNvPr>
@@ -16050,7 +16050,7 @@
           <p:cNvPr id="3" name="">
             <a:extLst xmlns:a="http://schemas.openxmlformats.org/drawingml/2006/main">
               <a:ext uri="{FF2B5EF4-FFF2-40B4-BE49-F238E27FC236}">
-                <a16:creationId xmlns:a16="http://schemas.microsoft.com/office/drawing/2014/main" id="{593907EF-DB4D-4AAF-8449-E10AB8EC35EE}"/>
+                <a16:creationId xmlns:a16="http://schemas.microsoft.com/office/drawing/2014/main" id="{9B747D2D-3FE7-43F3-9311-F7AF86318579}"/>
               </a:ext>
             </a:extLst>
           </p:cNvPr>
@@ -16107,7 +16107,7 @@
           <p:cNvPr id="4" name="">
             <a:extLst xmlns:a="http://schemas.openxmlformats.org/drawingml/2006/main">
               <a:ext uri="{FF2B5EF4-FFF2-40B4-BE49-F238E27FC236}">
-                <a16:creationId xmlns:a16="http://schemas.microsoft.com/office/drawing/2014/main" id="{75F68F7C-EAF8-4324-BF83-6A4C6B09E4BD}"/>
+                <a16:creationId xmlns:a16="http://schemas.microsoft.com/office/drawing/2014/main" id="{99C59E01-291B-4BC8-A430-C0760D3530E8}"/>
               </a:ext>
             </a:extLst>
           </p:cNvPr>
@@ -16164,7 +16164,7 @@
           <p:cNvPr id="5" name="">
             <a:extLst xmlns:a="http://schemas.openxmlformats.org/drawingml/2006/main">
               <a:ext uri="{FF2B5EF4-FFF2-40B4-BE49-F238E27FC236}">
-                <a16:creationId xmlns:a16="http://schemas.microsoft.com/office/drawing/2014/main" id="{C05A9DD0-FB49-471A-9327-6441A18ADF96}"/>
+                <a16:creationId xmlns:a16="http://schemas.microsoft.com/office/drawing/2014/main" id="{1AC8D3F1-0D13-483C-B7DB-40A18531CFFD}"/>
               </a:ext>
             </a:extLst>
           </p:cNvPr>
@@ -16244,7 +16244,7 @@
           <p:cNvPr id="6" name="">
             <a:extLst xmlns:a="http://schemas.openxmlformats.org/drawingml/2006/main">
               <a:ext uri="{FF2B5EF4-FFF2-40B4-BE49-F238E27FC236}">
-                <a16:creationId xmlns:a16="http://schemas.microsoft.com/office/drawing/2014/main" id="{C9C9B4A6-EBF2-4A30-A2AB-E0C19725C5D2}"/>
+                <a16:creationId xmlns:a16="http://schemas.microsoft.com/office/drawing/2014/main" id="{50AB536F-865E-4510-B79C-C1C249145BC7}"/>
               </a:ext>
             </a:extLst>
           </p:cNvPr>
@@ -16301,7 +16301,7 @@
           <p:cNvPr id="7" name="">
             <a:extLst xmlns:a="http://schemas.openxmlformats.org/drawingml/2006/main">
               <a:ext uri="{FF2B5EF4-FFF2-40B4-BE49-F238E27FC236}">
-                <a16:creationId xmlns:a16="http://schemas.microsoft.com/office/drawing/2014/main" id="{BD1F67E3-658E-4DC8-8D99-AAE009E8E735}"/>
+                <a16:creationId xmlns:a16="http://schemas.microsoft.com/office/drawing/2014/main" id="{601E79B8-6045-4B77-8247-4859EDD34FA0}"/>
               </a:ext>
             </a:extLst>
           </p:cNvPr>
@@ -16334,7 +16334,7 @@
           <p:cNvPr id="8" name="">
             <a:extLst xmlns:a="http://schemas.openxmlformats.org/drawingml/2006/main">
               <a:ext uri="{FF2B5EF4-FFF2-40B4-BE49-F238E27FC236}">
-                <a16:creationId xmlns:a16="http://schemas.microsoft.com/office/drawing/2014/main" id="{979C9A65-526B-4CAF-BFE2-7A233980986D}"/>
+                <a16:creationId xmlns:a16="http://schemas.microsoft.com/office/drawing/2014/main" id="{448BDF74-425E-4811-9039-7551CF87BC24}"/>
               </a:ext>
             </a:extLst>
           </p:cNvPr>
@@ -16391,7 +16391,7 @@
           <p:cNvPr id="9" name="">
             <a:extLst xmlns:a="http://schemas.openxmlformats.org/drawingml/2006/main">
               <a:ext uri="{FF2B5EF4-FFF2-40B4-BE49-F238E27FC236}">
-                <a16:creationId xmlns:a16="http://schemas.microsoft.com/office/drawing/2014/main" id="{63E3C72D-1B56-49F1-BDF7-322DC9259A4F}"/>
+                <a16:creationId xmlns:a16="http://schemas.microsoft.com/office/drawing/2014/main" id="{CEB17CAB-0885-4E9B-B880-3514D9C72F03}"/>
               </a:ext>
             </a:extLst>
           </p:cNvPr>
@@ -16424,7 +16424,7 @@
           <p:cNvPr id="10" name="">
             <a:extLst xmlns:a="http://schemas.openxmlformats.org/drawingml/2006/main">
               <a:ext uri="{FF2B5EF4-FFF2-40B4-BE49-F238E27FC236}">
-                <a16:creationId xmlns:a16="http://schemas.microsoft.com/office/drawing/2014/main" id="{E207C711-BDD2-475F-882C-0C96DD79D45A}"/>
+                <a16:creationId xmlns:a16="http://schemas.microsoft.com/office/drawing/2014/main" id="{CC0916F4-F7AC-46A9-8083-854ED65C5E77}"/>
               </a:ext>
             </a:extLst>
           </p:cNvPr>
@@ -16481,7 +16481,7 @@
           <p:cNvPr id="11" name="">
             <a:extLst xmlns:a="http://schemas.openxmlformats.org/drawingml/2006/main">
               <a:ext uri="{FF2B5EF4-FFF2-40B4-BE49-F238E27FC236}">
-                <a16:creationId xmlns:a16="http://schemas.microsoft.com/office/drawing/2014/main" id="{91CDD937-C026-40B5-9BF4-5B151074058E}"/>
+                <a16:creationId xmlns:a16="http://schemas.microsoft.com/office/drawing/2014/main" id="{F1F289B5-40F4-4F63-A5D4-524D36DDB47C}"/>
               </a:ext>
             </a:extLst>
           </p:cNvPr>
@@ -16538,7 +16538,7 @@
           <p:cNvPr id="12" name="">
             <a:extLst xmlns:a="http://schemas.openxmlformats.org/drawingml/2006/main">
               <a:ext uri="{FF2B5EF4-FFF2-40B4-BE49-F238E27FC236}">
-                <a16:creationId xmlns:a16="http://schemas.microsoft.com/office/drawing/2014/main" id="{4D78CA56-DE20-405C-A0A9-1B7782146B00}"/>
+                <a16:creationId xmlns:a16="http://schemas.microsoft.com/office/drawing/2014/main" id="{88BF7AE6-AD11-419B-AB24-F782845C6859}"/>
               </a:ext>
             </a:extLst>
           </p:cNvPr>
@@ -16595,7 +16595,7 @@
           <p:cNvPr id="13" name="">
             <a:extLst xmlns:a="http://schemas.openxmlformats.org/drawingml/2006/main">
               <a:ext uri="{FF2B5EF4-FFF2-40B4-BE49-F238E27FC236}">
-                <a16:creationId xmlns:a16="http://schemas.microsoft.com/office/drawing/2014/main" id="{96F9E7CB-FC32-4D6D-B32C-A31ACEBCB944}"/>
+                <a16:creationId xmlns:a16="http://schemas.microsoft.com/office/drawing/2014/main" id="{AD2D733C-F37C-4440-93DC-25F778B23E0B}"/>
               </a:ext>
             </a:extLst>
           </p:cNvPr>
@@ -16652,7 +16652,7 @@
           <p:cNvPr id="14" name="">
             <a:extLst xmlns:a="http://schemas.openxmlformats.org/drawingml/2006/main">
               <a:ext uri="{FF2B5EF4-FFF2-40B4-BE49-F238E27FC236}">
-                <a16:creationId xmlns:a16="http://schemas.microsoft.com/office/drawing/2014/main" id="{C600F18C-5413-4D0A-AB2A-4913AD82E4D5}"/>
+                <a16:creationId xmlns:a16="http://schemas.microsoft.com/office/drawing/2014/main" id="{61785CB9-D768-4E73-B234-C4CF20C2705B}"/>
               </a:ext>
             </a:extLst>
           </p:cNvPr>
@@ -16709,7 +16709,7 @@
           <p:cNvPr id="15" name="">
             <a:extLst xmlns:a="http://schemas.openxmlformats.org/drawingml/2006/main">
               <a:ext uri="{FF2B5EF4-FFF2-40B4-BE49-F238E27FC236}">
-                <a16:creationId xmlns:a16="http://schemas.microsoft.com/office/drawing/2014/main" id="{0F8AADCF-C678-4CAB-8E19-DE68E29DA600}"/>
+                <a16:creationId xmlns:a16="http://schemas.microsoft.com/office/drawing/2014/main" id="{841CB9AB-23A9-4872-8D36-52C2D2ED6DDD}"/>
               </a:ext>
             </a:extLst>
           </p:cNvPr>
@@ -16742,7 +16742,7 @@
           <p:cNvPr id="16" name="">
             <a:extLst xmlns:a="http://schemas.openxmlformats.org/drawingml/2006/main">
               <a:ext uri="{FF2B5EF4-FFF2-40B4-BE49-F238E27FC236}">
-                <a16:creationId xmlns:a16="http://schemas.microsoft.com/office/drawing/2014/main" id="{30F0B595-669A-499D-9296-4B651AA92F8D}"/>
+                <a16:creationId xmlns:a16="http://schemas.microsoft.com/office/drawing/2014/main" id="{A6F26962-1400-462A-8D22-BBD6CBC9E0F7}"/>
               </a:ext>
             </a:extLst>
           </p:cNvPr>
@@ -16799,7 +16799,7 @@
           <p:cNvPr id="17" name="">
             <a:extLst xmlns:a="http://schemas.openxmlformats.org/drawingml/2006/main">
               <a:ext uri="{FF2B5EF4-FFF2-40B4-BE49-F238E27FC236}">
-                <a16:creationId xmlns:a16="http://schemas.microsoft.com/office/drawing/2014/main" id="{EAACB131-1DF2-477A-8A83-D1AF63CCCDA4}"/>
+                <a16:creationId xmlns:a16="http://schemas.microsoft.com/office/drawing/2014/main" id="{B3AA26D8-3EE8-4631-8A8E-59ADAC60D7AA}"/>
               </a:ext>
             </a:extLst>
           </p:cNvPr>
@@ -16830,7 +16830,7 @@
           <p:cNvPr id="18" name="">
             <a:extLst xmlns:a="http://schemas.openxmlformats.org/drawingml/2006/main">
               <a:ext uri="{FF2B5EF4-FFF2-40B4-BE49-F238E27FC236}">
-                <a16:creationId xmlns:a16="http://schemas.microsoft.com/office/drawing/2014/main" id="{6FA92429-3CCE-4BED-86D5-FE583D217684}"/>
+                <a16:creationId xmlns:a16="http://schemas.microsoft.com/office/drawing/2014/main" id="{5EAA6A83-5D50-4858-8E92-1D63D060FA0B}"/>
               </a:ext>
             </a:extLst>
           </p:cNvPr>
@@ -16885,7 +16885,7 @@
     </p:spTree>
     <p:extLst>
       <p:ext uri="{BB962C8B-B14F-4D97-AF65-F5344CB8AC3E}">
-        <p14:creationId xmlns:p14="http://schemas.microsoft.com/office/powerpoint/2010/main" val="1626156943"/>
+        <p14:creationId xmlns:p14="http://schemas.microsoft.com/office/powerpoint/2010/main" val="951931673"/>
       </p:ext>
     </p:extLst>
   </p:cSld>

</xml_diff>

<commit_message>
fix(presentation): verify slide 4 figures against current sources
Update NBER to the September 2026 revision, distinguish published precision from chart readings, and preserve Agarwal Table 2 values with group labels.

Agent assistance: used (Codex).
</commit_message>
<xml_diff>
--- a/assets/presentations/pmday-2026/ai-changes-both-sides.pptx
+++ b/assets/presentations/pmday-2026/ai-changes-both-sides.pptx
@@ -2,26 +2,26 @@
 <file path=ppt/presentation.xml><?xml version="1.0" encoding="utf-8"?>
 <p:presentation xmlns:p="http://schemas.openxmlformats.org/presentationml/2006/main">
   <p:sldMasterIdLst>
-    <p:sldMasterId xmlns:r="http://schemas.openxmlformats.org/officeDocument/2006/relationships" id="2147483648" r:id="R5d8fcc0c389644af"/>
+    <p:sldMasterId xmlns:r="http://schemas.openxmlformats.org/officeDocument/2006/relationships" id="2147483648" r:id="Re236cfbcd8de495b"/>
   </p:sldMasterIdLst>
   <p:notesMasterIdLst>
-    <p:notesMasterId xmlns:r="http://schemas.openxmlformats.org/officeDocument/2006/relationships" r:id="R10ade2a4823645cc"/>
+    <p:notesMasterId xmlns:r="http://schemas.openxmlformats.org/officeDocument/2006/relationships" r:id="R68bf61bd34734cd8"/>
   </p:notesMasterIdLst>
   <p:sldIdLst>
-    <p:sldId xmlns:r="http://schemas.openxmlformats.org/officeDocument/2006/relationships" id="256" r:id="Ra111139d2e0c4bfd"/>
-    <p:sldId xmlns:r="http://schemas.openxmlformats.org/officeDocument/2006/relationships" id="257" r:id="Recc21c0419f642d8"/>
-    <p:sldId xmlns:r="http://schemas.openxmlformats.org/officeDocument/2006/relationships" id="258" r:id="Re7fff0aecef74d9e"/>
-    <p:sldId xmlns:r="http://schemas.openxmlformats.org/officeDocument/2006/relationships" id="259" r:id="Re5cb8de3c4a24157"/>
-    <p:sldId xmlns:r="http://schemas.openxmlformats.org/officeDocument/2006/relationships" id="260" r:id="R2002f9702749494e"/>
-    <p:sldId xmlns:r="http://schemas.openxmlformats.org/officeDocument/2006/relationships" id="261" r:id="R1530516c06294ff5"/>
-    <p:sldId xmlns:r="http://schemas.openxmlformats.org/officeDocument/2006/relationships" id="262" r:id="Rb66b3c6e1d1640a5"/>
-    <p:sldId xmlns:r="http://schemas.openxmlformats.org/officeDocument/2006/relationships" id="263" r:id="Re34f95b9f6f742fa"/>
-    <p:sldId xmlns:r="http://schemas.openxmlformats.org/officeDocument/2006/relationships" id="264" r:id="Rc437afb9f74e4be1"/>
-    <p:sldId xmlns:r="http://schemas.openxmlformats.org/officeDocument/2006/relationships" id="265" r:id="R1a44bccfe5e5431d"/>
-    <p:sldId xmlns:r="http://schemas.openxmlformats.org/officeDocument/2006/relationships" id="266" r:id="R3181d128e00949c1"/>
-    <p:sldId xmlns:r="http://schemas.openxmlformats.org/officeDocument/2006/relationships" id="267" r:id="R98afc8bb7086423d"/>
-    <p:sldId xmlns:r="http://schemas.openxmlformats.org/officeDocument/2006/relationships" id="268" r:id="R5fec5151696d485f"/>
-    <p:sldId xmlns:r="http://schemas.openxmlformats.org/officeDocument/2006/relationships" id="269" r:id="R5ed276a104504c3f"/>
+    <p:sldId xmlns:r="http://schemas.openxmlformats.org/officeDocument/2006/relationships" id="256" r:id="R56f5734e083f4d03"/>
+    <p:sldId xmlns:r="http://schemas.openxmlformats.org/officeDocument/2006/relationships" id="257" r:id="Rc170d078b3a74250"/>
+    <p:sldId xmlns:r="http://schemas.openxmlformats.org/officeDocument/2006/relationships" id="258" r:id="Raaded7f471a24c13"/>
+    <p:sldId xmlns:r="http://schemas.openxmlformats.org/officeDocument/2006/relationships" id="259" r:id="R6d8b65e51f9e4778"/>
+    <p:sldId xmlns:r="http://schemas.openxmlformats.org/officeDocument/2006/relationships" id="260" r:id="Rdea9830c010b4378"/>
+    <p:sldId xmlns:r="http://schemas.openxmlformats.org/officeDocument/2006/relationships" id="261" r:id="R51e7469559b7483e"/>
+    <p:sldId xmlns:r="http://schemas.openxmlformats.org/officeDocument/2006/relationships" id="262" r:id="R5ad7da01d4ca43b5"/>
+    <p:sldId xmlns:r="http://schemas.openxmlformats.org/officeDocument/2006/relationships" id="263" r:id="R936332774b7340ed"/>
+    <p:sldId xmlns:r="http://schemas.openxmlformats.org/officeDocument/2006/relationships" id="264" r:id="R8f54d043439d463d"/>
+    <p:sldId xmlns:r="http://schemas.openxmlformats.org/officeDocument/2006/relationships" id="265" r:id="R21f67659b6d04b47"/>
+    <p:sldId xmlns:r="http://schemas.openxmlformats.org/officeDocument/2006/relationships" id="266" r:id="Rc3dee2fcd6194cfa"/>
+    <p:sldId xmlns:r="http://schemas.openxmlformats.org/officeDocument/2006/relationships" id="267" r:id="Rc6be020d0cbe4434"/>
+    <p:sldId xmlns:r="http://schemas.openxmlformats.org/officeDocument/2006/relationships" id="268" r:id="Re57599d4dd75408a"/>
+    <p:sldId xmlns:r="http://schemas.openxmlformats.org/officeDocument/2006/relationships" id="269" r:id="R3566406c5e634149"/>
   </p:sldIdLst>
   <p:sldSz cx="12192000" cy="6858000"/>
   <p:notesSz cx="6858000" cy="9144000"/>
@@ -1090,17 +1090,22 @@
           <a:lstStyle xmlns:a="http://schemas.openxmlformats.org/drawingml/2006/main"/>
           <a:p xmlns:a="http://schemas.openxmlformats.org/drawingml/2006/main">
             <a:r>
-              <a:t>NBER: понад 100 тисяч GitHub developers; matched event study, не RCT. Changed LOC = additions + deletions, не чисте зростання кодової бази.</a:t>
-            </a:r>
-          </a:p>
-          <a:p xmlns:a="http://schemas.openxmlformats.org/drawingml/2006/main">
-            <a:r>
-              <a:t>Table 5, друкована с. 33, тижні 21–30: Autocomplete — LOC +228.2%, commits +35.9%, PRs +11.0%, releases +10.2%. Synchronous agents — LOC +741.3%, commits +109.1%, PRs +65.5%, releases +20.3%. Asynchronous agents — LOC +658.3%, commits +33.6%, PRs +71.8%; releases не оцінено окремо. Figure 1, с. 3: cumulative LOC 17.3×, files 3.9×, commits 2.8×, PRs 2.5×, repos 1.5×, releases 1.3×. Не перемножувати компоненти.</a:t>
-            </a:r>
-          </a:p>
-          <a:p xmlns:a="http://schemas.openxmlformats.org/drawingml/2006/main">
-            <a:r>
-              <a:t>Figure 12, с. 41; §8.2, с. 42–43: iOS — 30–50 тисяч нових apps/month → близько 100 тисяч у квітні 2026; Android — 42 тисячі у січні 2025 → близько 60 тисяч у середині 2026; Chrome — 5 тисяч у 2023 → близько 13 тисяч у середині 2026. Total cohort usage за перші 3 місяці стабільне або знижується. Частка iOS apps із &lt;10 ratings: 79→86%; Chrome extensions із &lt;10 downloads: 18→31%. SourceForge без прискорення entry, не входить у три usage panels. Це не всі existing apps, не весь software market і не пряме вимірювання consumer welfare. Chrome decline передував agentic era.</a:t>
+              <a:t>NBER WP 35275: May 2026, revised September 2026; current official PDF downloaded 2026-09-21. Понад 500 тисяч GitHub developers; matched event study, не RCT. Попередні 17.3× / 2.8×, 79→86% та 18→31% належали старій редакції й замінені. Changed LOC = additions + deletions, не чисте зростання кодової бази.</a:t>
+            </a:r>
+          </a:p>
+          <a:p xmlns:a="http://schemas.openxmlformats.org/drawingml/2006/main">
+            <a:r>
+              <a:t>Table 6, друкована с.33 / PDF p.35, тижні 21–30: Autocomplete — LOC +234.3%, files +50.0%, commits +30.2%, PRs +18.3%, repos +11.9%, releases +9.0%. Sync — LOC +957.5%, files +265.0%, commits +153.2%, PRs +86.0%, repos +47.3%, releases +19.8%. Async — LOC +1254.9%, files +83.3%, commits +60.7%, PRs +68.5%, repos +19.2%; releases не оцінено окремо. Figure 1, друкована с.2 / PDF p.4: авторські округлені cumulative levels — LOC 25.5×, files 5.0×, commits 3.4×, PRs 2.7×, repos 1.8×, releases 1.3×. Арифметика за округленою Table 6: 1+(234.3+957.5+1254.9)/100=25.467; commits 1+(30.2+153.2+60.7)/100=3.441; releases 1+(9.0+19.8)/100=1.288. Не перемножувати компоненти і не видавати ці суми за точні raw-data estimates. Прочерк async releases не означає нульового ефекту.</a:t>
+            </a:r>
+          </a:p>
+          <a:p xmlns:a="http://schemas.openxmlformats.org/drawingml/2006/main">
+            <a:r>
+              <a:t>Figure 11, друкована с.44 / PDF p.46; §7.2, с.43–46: iOS нові apps/month приблизно 33–45 тисяч у 2023–early 2025 → 108 тисяч у квітні 2026; Android 42 тисячі у січні 2025 → 99 тисяч у mid-2026; Chrome приблизно семикратне зростання від 2023, що почалося до agentic era. SourceForge показує невелике зростання new projects і винесений у Figure OA-17, без надійної usage-панелі. Usage за перші 3 місяці: iOS cohort ratings приблизно стабільні; Android downloads помірно зростають, але значно повільніше за entry; Chrome downloads падають. Тому коректно «usage does not keep pace», а не «usage ніде не зростає».</a:t>
+            </a:r>
+          </a:p>
+          <a:p xmlns:a="http://schemas.openxmlformats.org/drawingml/2006/main">
+            <a:r>
+              <a:t>§7.2.3, друкована с.46 / PDF p.48: January 2025 → April 2026, частка iOS із &lt;10 ratings приблизно 78% → 87%; Chrome із &lt;10 downloads 19% → 33%; Android із ≤100 downloads приблизно 22% → 26%. Авторські цілі відсотки; не точні частки з raw data. Це порівняння нових когорт за перші 3 місяці, не всіх existing apps, не весь software market і не пряме вимірювання consumer welfare. Зміни часток приблизно +9/+14/+4 відсоткових пункти відповідно.</a:t>
             </a:r>
           </a:p>
           <a:p xmlns:a="http://schemas.openxmlformats.org/drawingml/2006/main">
@@ -1110,7 +1115,7 @@
           </a:p>
           <a:p xmlns:a="http://schemas.openxmlformats.org/drawingml/2006/main">
             <a:r>
-              <a:t>METR, травень 2026: 349 technical workers; 1.4–2× median self-reported work value залежно від питання, 3× self-reported speed; є selection bias. Старий RCT 2025 із +19% часу — лише історичний контекст.</a:t>
+              <a:t>METR, 11 травня 2026: 349 technical workers; 1.4–2× medians across 3 self-reported work-value questions; це не credible/confidence interval, 3× self-reported speed; є selection bias. Старий RCT 2025 із +19% часу — лише історичний контекст.</a:t>
             </a:r>
           </a:p>
           <a:p xmlns:a="http://schemas.openxmlformats.org/drawingml/2006/main">
@@ -1125,12 +1130,17 @@
           </a:p>
           <a:p xmlns:a="http://schemas.openxmlformats.org/drawingml/2006/main">
             <a:r>
-              <a:t>Agarwal, v2, Table 2: complexity +34.85/+42.87%, warnings +17.73/+19.00%; зміна IDE-first warnings статистично незначуща. Не трактувати це як борг на одну фічу.</a:t>
+              <a:t>Agarwal, v2, Table 2: complexity Agent-first +34.85% / IDE-first +42.87%, warnings +17.73/+19.00%; зміна IDE-first warnings статистично незначуща. Не трактувати це як борг на одну фічу.</a:t>
             </a:r>
           </a:p>
           <a:p xmlns:a="http://schemas.openxmlformats.org/drawingml/2006/main">
             <a:r>
               <a:t>DORA: позитивний зв’язок AI adoption з throughput одночасно з негативним зі stability. Small batches, p.58: сильніший позитивний зв’язок AI із product performance та менше friction, хоча індивідуальні gains можуть бути меншими. ToC / review-testing-integration queues, p.81. Це мотивує системну оптимізацію на слайді 7, не доводить універсальну причинність.</a:t>
+            </a:r>
+          </a:p>
+          <a:p xmlns:a="http://schemas.openxmlformats.org/drawingml/2006/main">
+            <a:r>
+              <a:t>Повторна числова перевірка 2026-09-21: DORA Fig.28 vector coordinates та сторінку звірено повторно; коефіцієнт і межі лише приблизні. &gt;80% збережено як авторський поріг: сума округлених bars 41+31+13=85 не встановлює точного агрегату. GitClear calls 343→223 дають приблизно −35%; +81% — авторське округлення, +15% churn — число з резюме без окремої baseline-пари. Точний місяць публікації GitClear не підтверджено на перевіреній сторінці, тому на екрані лише 2026. Див. EVIDENCE.md та відповідні локальні нотатки.</a:t>
             </a:r>
           </a:p>
           <a:p xmlns:a="http://schemas.openxmlformats.org/drawingml/2006/main">
@@ -1658,7 +1668,7 @@
   </p:cSld>
   <p:clrMap bg1="lt1" tx1="dk1" bg2="lt2" tx2="dk2" accent1="accent1" accent2="accent2" accent3="accent3" accent4="accent4" accent5="accent5" accent6="accent6" hlink="hlink" folHlink="folHlink"/>
   <p:sldLayoutIdLst>
-    <p:sldLayoutId xmlns:r="http://schemas.openxmlformats.org/officeDocument/2006/relationships" id="2147483649" r:id="R717928390e7e4388"/>
+    <p:sldLayoutId xmlns:r="http://schemas.openxmlformats.org/officeDocument/2006/relationships" id="2147483649" r:id="R39cf953be6ca4bfa"/>
   </p:sldLayoutIdLst>
   <p:txStyles>
     <p:titleStyle>
@@ -2209,7 +2219,7 @@
           <p:cNvPr id="10" name="">
             <a:extLst xmlns:a="http://schemas.openxmlformats.org/drawingml/2006/main">
               <a:ext uri="{FF2B5EF4-FFF2-40B4-BE49-F238E27FC236}">
-                <a16:creationId xmlns:a16="http://schemas.microsoft.com/office/drawing/2014/main" id="{64993F33-AA7F-43E9-A9B1-0C10DF03F246}"/>
+                <a16:creationId xmlns:a16="http://schemas.microsoft.com/office/drawing/2014/main" id="{433D9586-CA0E-411F-8CF9-AC646562074E}"/>
               </a:ext>
             </a:extLst>
           </p:cNvPr>
@@ -2266,7 +2276,7 @@
           <p:cNvPr id="2" name="">
             <a:extLst xmlns:a="http://schemas.openxmlformats.org/drawingml/2006/main">
               <a:ext uri="{FF2B5EF4-FFF2-40B4-BE49-F238E27FC236}">
-                <a16:creationId xmlns:a16="http://schemas.microsoft.com/office/drawing/2014/main" id="{384F4B5C-36C0-4830-AD20-3C84CA994A9E}"/>
+                <a16:creationId xmlns:a16="http://schemas.microsoft.com/office/drawing/2014/main" id="{9F4AB7D5-D652-4F45-B8BE-9F9D302CE7F6}"/>
               </a:ext>
             </a:extLst>
           </p:cNvPr>
@@ -2346,7 +2356,7 @@
           <p:cNvPr id="3" name="">
             <a:extLst xmlns:a="http://schemas.openxmlformats.org/drawingml/2006/main">
               <a:ext uri="{FF2B5EF4-FFF2-40B4-BE49-F238E27FC236}">
-                <a16:creationId xmlns:a16="http://schemas.microsoft.com/office/drawing/2014/main" id="{41DB12ED-A520-41C0-9AFB-8DE8C2241AE2}"/>
+                <a16:creationId xmlns:a16="http://schemas.microsoft.com/office/drawing/2014/main" id="{03466D3D-491C-4292-990F-47A838A71D0B}"/>
               </a:ext>
             </a:extLst>
           </p:cNvPr>
@@ -2407,7 +2417,7 @@
           <p:nvPr/>
         </p:nvPicPr>
         <p:blipFill>
-          <a:blip xmlns:r="http://schemas.openxmlformats.org/officeDocument/2006/relationships" xmlns:a="http://schemas.openxmlformats.org/drawingml/2006/main" r:embed="R2ef7a0b80e1c4e84"/>
+          <a:blip xmlns:r="http://schemas.openxmlformats.org/officeDocument/2006/relationships" xmlns:a="http://schemas.openxmlformats.org/drawingml/2006/main" r:embed="R93a8465d1ed74d84"/>
           <a:stretch xmlns:a="http://schemas.openxmlformats.org/drawingml/2006/main"/>
         </p:blipFill>
         <p:spPr>
@@ -2425,7 +2435,7 @@
           <p:cNvPr id="5" name="">
             <a:extLst xmlns:a="http://schemas.openxmlformats.org/drawingml/2006/main">
               <a:ext uri="{FF2B5EF4-FFF2-40B4-BE49-F238E27FC236}">
-                <a16:creationId xmlns:a16="http://schemas.microsoft.com/office/drawing/2014/main" id="{2E7A07D4-49E6-4EE7-9C75-259FFCD6D548}"/>
+                <a16:creationId xmlns:a16="http://schemas.microsoft.com/office/drawing/2014/main" id="{9E3D5945-30DE-4E69-8EB0-745EFC3FC808}"/>
               </a:ext>
             </a:extLst>
           </p:cNvPr>
@@ -2482,7 +2492,7 @@
           <p:cNvPr id="6" name="">
             <a:extLst xmlns:a="http://schemas.openxmlformats.org/drawingml/2006/main">
               <a:ext uri="{FF2B5EF4-FFF2-40B4-BE49-F238E27FC236}">
-                <a16:creationId xmlns:a16="http://schemas.microsoft.com/office/drawing/2014/main" id="{A932991C-E037-4ACD-BEC4-104DD7B820D1}"/>
+                <a16:creationId xmlns:a16="http://schemas.microsoft.com/office/drawing/2014/main" id="{2A36A5E0-88FF-4851-9F4E-E6A726C636A6}"/>
               </a:ext>
             </a:extLst>
           </p:cNvPr>
@@ -2539,7 +2549,7 @@
           <p:cNvPr id="7" name="">
             <a:extLst xmlns:a="http://schemas.openxmlformats.org/drawingml/2006/main">
               <a:ext uri="{FF2B5EF4-FFF2-40B4-BE49-F238E27FC236}">
-                <a16:creationId xmlns:a16="http://schemas.microsoft.com/office/drawing/2014/main" id="{8A678390-23E1-480C-86D9-107EC68B8D7A}"/>
+                <a16:creationId xmlns:a16="http://schemas.microsoft.com/office/drawing/2014/main" id="{E99FD36D-374D-42D9-B35E-760321CF0A80}"/>
               </a:ext>
             </a:extLst>
           </p:cNvPr>
@@ -2596,7 +2606,7 @@
           <p:cNvPr id="8" name="">
             <a:extLst xmlns:a="http://schemas.openxmlformats.org/drawingml/2006/main">
               <a:ext uri="{FF2B5EF4-FFF2-40B4-BE49-F238E27FC236}">
-                <a16:creationId xmlns:a16="http://schemas.microsoft.com/office/drawing/2014/main" id="{BEDDF72A-EA4B-4B9B-8A86-0082F8F241D8}"/>
+                <a16:creationId xmlns:a16="http://schemas.microsoft.com/office/drawing/2014/main" id="{A83E2D34-1297-483D-9246-948A551D387C}"/>
               </a:ext>
             </a:extLst>
           </p:cNvPr>
@@ -2653,7 +2663,7 @@
           <p:cNvPr id="9" name="">
             <a:extLst xmlns:a="http://schemas.openxmlformats.org/drawingml/2006/main">
               <a:ext uri="{FF2B5EF4-FFF2-40B4-BE49-F238E27FC236}">
-                <a16:creationId xmlns:a16="http://schemas.microsoft.com/office/drawing/2014/main" id="{4E944CBC-CFB3-427E-A0F4-9A7050235618}"/>
+                <a16:creationId xmlns:a16="http://schemas.microsoft.com/office/drawing/2014/main" id="{9C253FE1-75CA-439A-95B1-975765FECCBA}"/>
               </a:ext>
             </a:extLst>
           </p:cNvPr>
@@ -2708,7 +2718,7 @@
     </p:spTree>
     <p:extLst>
       <p:ext uri="{BB962C8B-B14F-4D97-AF65-F5344CB8AC3E}">
-        <p14:creationId xmlns:p14="http://schemas.microsoft.com/office/powerpoint/2010/main" val="1103237118"/>
+        <p14:creationId xmlns:p14="http://schemas.microsoft.com/office/powerpoint/2010/main" val="1290162583"/>
       </p:ext>
     </p:extLst>
   </p:cSld>
@@ -2739,7 +2749,7 @@
           <p:cNvPr id="25" name="">
             <a:extLst xmlns:a="http://schemas.openxmlformats.org/drawingml/2006/main">
               <a:ext uri="{FF2B5EF4-FFF2-40B4-BE49-F238E27FC236}">
-                <a16:creationId xmlns:a16="http://schemas.microsoft.com/office/drawing/2014/main" id="{0657578B-4246-41C2-8D2B-649547E87744}"/>
+                <a16:creationId xmlns:a16="http://schemas.microsoft.com/office/drawing/2014/main" id="{2934BDA3-28E6-4A83-BE30-C1F6C1F2C1F2}"/>
               </a:ext>
             </a:extLst>
           </p:cNvPr>
@@ -2796,7 +2806,7 @@
           <p:cNvPr id="2" name="">
             <a:extLst xmlns:a="http://schemas.openxmlformats.org/drawingml/2006/main">
               <a:ext uri="{FF2B5EF4-FFF2-40B4-BE49-F238E27FC236}">
-                <a16:creationId xmlns:a16="http://schemas.microsoft.com/office/drawing/2014/main" id="{7518D657-E920-46C9-945C-34B990647DD3}"/>
+                <a16:creationId xmlns:a16="http://schemas.microsoft.com/office/drawing/2014/main" id="{1ED277C5-BBDB-4710-B077-666F9D94048A}"/>
               </a:ext>
             </a:extLst>
           </p:cNvPr>
@@ -2827,7 +2837,7 @@
           <p:cNvPr id="3" name="">
             <a:extLst xmlns:a="http://schemas.openxmlformats.org/drawingml/2006/main">
               <a:ext uri="{FF2B5EF4-FFF2-40B4-BE49-F238E27FC236}">
-                <a16:creationId xmlns:a16="http://schemas.microsoft.com/office/drawing/2014/main" id="{F80D1767-8C6D-42CB-B8F5-B5ED11FFF959}"/>
+                <a16:creationId xmlns:a16="http://schemas.microsoft.com/office/drawing/2014/main" id="{409119FC-6CD7-4A58-BCA1-AA4867E8E293}"/>
               </a:ext>
             </a:extLst>
           </p:cNvPr>
@@ -2884,7 +2894,7 @@
           <p:cNvPr id="4" name="">
             <a:extLst xmlns:a="http://schemas.openxmlformats.org/drawingml/2006/main">
               <a:ext uri="{FF2B5EF4-FFF2-40B4-BE49-F238E27FC236}">
-                <a16:creationId xmlns:a16="http://schemas.microsoft.com/office/drawing/2014/main" id="{E0BBCA44-8EF3-4B35-8822-E64D6835BEDB}"/>
+                <a16:creationId xmlns:a16="http://schemas.microsoft.com/office/drawing/2014/main" id="{E78798CC-5A80-4B1D-8005-9F381BEA1524}"/>
               </a:ext>
             </a:extLst>
           </p:cNvPr>
@@ -2941,7 +2951,7 @@
           <p:cNvPr id="5" name="">
             <a:extLst xmlns:a="http://schemas.openxmlformats.org/drawingml/2006/main">
               <a:ext uri="{FF2B5EF4-FFF2-40B4-BE49-F238E27FC236}">
-                <a16:creationId xmlns:a16="http://schemas.microsoft.com/office/drawing/2014/main" id="{C56E5204-C34A-4520-A229-AAABDEFAD8EE}"/>
+                <a16:creationId xmlns:a16="http://schemas.microsoft.com/office/drawing/2014/main" id="{459559C5-0C7E-4F2D-A2CD-D306E130F6C1}"/>
               </a:ext>
             </a:extLst>
           </p:cNvPr>
@@ -2974,7 +2984,7 @@
           <p:cNvPr id="6" name="">
             <a:extLst xmlns:a="http://schemas.openxmlformats.org/drawingml/2006/main">
               <a:ext uri="{FF2B5EF4-FFF2-40B4-BE49-F238E27FC236}">
-                <a16:creationId xmlns:a16="http://schemas.microsoft.com/office/drawing/2014/main" id="{85D77815-6D15-4C55-ACC4-F630989F9A2E}"/>
+                <a16:creationId xmlns:a16="http://schemas.microsoft.com/office/drawing/2014/main" id="{E860CE39-ECBD-4BF9-A2F7-2409EBA04F11}"/>
               </a:ext>
             </a:extLst>
           </p:cNvPr>
@@ -3031,7 +3041,7 @@
           <p:cNvPr id="7" name="">
             <a:extLst xmlns:a="http://schemas.openxmlformats.org/drawingml/2006/main">
               <a:ext uri="{FF2B5EF4-FFF2-40B4-BE49-F238E27FC236}">
-                <a16:creationId xmlns:a16="http://schemas.microsoft.com/office/drawing/2014/main" id="{5F75A075-3455-472E-9A41-7CCBEEC7CE33}"/>
+                <a16:creationId xmlns:a16="http://schemas.microsoft.com/office/drawing/2014/main" id="{15FB34AD-0350-494B-B02B-915964C5BEE1}"/>
               </a:ext>
             </a:extLst>
           </p:cNvPr>
@@ -3064,7 +3074,7 @@
           <p:cNvPr id="8" name="">
             <a:extLst xmlns:a="http://schemas.openxmlformats.org/drawingml/2006/main">
               <a:ext uri="{FF2B5EF4-FFF2-40B4-BE49-F238E27FC236}">
-                <a16:creationId xmlns:a16="http://schemas.microsoft.com/office/drawing/2014/main" id="{85D52076-6CF4-43A5-9793-22CDC05762FD}"/>
+                <a16:creationId xmlns:a16="http://schemas.microsoft.com/office/drawing/2014/main" id="{8CC2BF37-85B6-40C8-B21A-D6CAB711B7AD}"/>
               </a:ext>
             </a:extLst>
           </p:cNvPr>
@@ -3121,7 +3131,7 @@
           <p:cNvPr id="9" name="">
             <a:extLst xmlns:a="http://schemas.openxmlformats.org/drawingml/2006/main">
               <a:ext uri="{FF2B5EF4-FFF2-40B4-BE49-F238E27FC236}">
-                <a16:creationId xmlns:a16="http://schemas.microsoft.com/office/drawing/2014/main" id="{01D4FEFE-3EBC-4EC4-96F1-F606BFE7FC08}"/>
+                <a16:creationId xmlns:a16="http://schemas.microsoft.com/office/drawing/2014/main" id="{69DE54E7-FDB3-4CD9-A13E-44C91720AF54}"/>
               </a:ext>
             </a:extLst>
           </p:cNvPr>
@@ -3154,7 +3164,7 @@
           <p:cNvPr id="10" name="">
             <a:extLst xmlns:a="http://schemas.openxmlformats.org/drawingml/2006/main">
               <a:ext uri="{FF2B5EF4-FFF2-40B4-BE49-F238E27FC236}">
-                <a16:creationId xmlns:a16="http://schemas.microsoft.com/office/drawing/2014/main" id="{42AAABB7-1B1E-4BD5-A6A2-78E157C282B5}"/>
+                <a16:creationId xmlns:a16="http://schemas.microsoft.com/office/drawing/2014/main" id="{5AD5D2B0-8802-4213-99C0-2C8576E1A453}"/>
               </a:ext>
             </a:extLst>
           </p:cNvPr>
@@ -3211,7 +3221,7 @@
           <p:cNvPr id="11" name="">
             <a:extLst xmlns:a="http://schemas.openxmlformats.org/drawingml/2006/main">
               <a:ext uri="{FF2B5EF4-FFF2-40B4-BE49-F238E27FC236}">
-                <a16:creationId xmlns:a16="http://schemas.microsoft.com/office/drawing/2014/main" id="{2237652C-AA29-48EC-BF08-DF916EF4F031}"/>
+                <a16:creationId xmlns:a16="http://schemas.microsoft.com/office/drawing/2014/main" id="{32FC07BD-BF9E-4230-8FF2-52FEB41B58D4}"/>
               </a:ext>
             </a:extLst>
           </p:cNvPr>
@@ -3244,7 +3254,7 @@
           <p:cNvPr id="12" name="">
             <a:extLst xmlns:a="http://schemas.openxmlformats.org/drawingml/2006/main">
               <a:ext uri="{FF2B5EF4-FFF2-40B4-BE49-F238E27FC236}">
-                <a16:creationId xmlns:a16="http://schemas.microsoft.com/office/drawing/2014/main" id="{34B35BFA-9D24-49C7-AA22-D601E6754655}"/>
+                <a16:creationId xmlns:a16="http://schemas.microsoft.com/office/drawing/2014/main" id="{4A19CBD3-5640-4B9A-9D20-5B9766F2D1F7}"/>
               </a:ext>
             </a:extLst>
           </p:cNvPr>
@@ -3301,7 +3311,7 @@
           <p:cNvPr id="13" name="">
             <a:extLst xmlns:a="http://schemas.openxmlformats.org/drawingml/2006/main">
               <a:ext uri="{FF2B5EF4-FFF2-40B4-BE49-F238E27FC236}">
-                <a16:creationId xmlns:a16="http://schemas.microsoft.com/office/drawing/2014/main" id="{97F3E113-8945-4B59-B1C0-9A3237B4A147}"/>
+                <a16:creationId xmlns:a16="http://schemas.microsoft.com/office/drawing/2014/main" id="{296DADCA-68CF-4C1B-8BA2-504FF4302C29}"/>
               </a:ext>
             </a:extLst>
           </p:cNvPr>
@@ -3334,7 +3344,7 @@
           <p:cNvPr id="14" name="">
             <a:extLst xmlns:a="http://schemas.openxmlformats.org/drawingml/2006/main">
               <a:ext uri="{FF2B5EF4-FFF2-40B4-BE49-F238E27FC236}">
-                <a16:creationId xmlns:a16="http://schemas.microsoft.com/office/drawing/2014/main" id="{857F6404-43DB-4D4F-8D3B-60677A3FE39C}"/>
+                <a16:creationId xmlns:a16="http://schemas.microsoft.com/office/drawing/2014/main" id="{AF4244F0-D12F-4D22-8C6C-CF9B19FCC1ED}"/>
               </a:ext>
             </a:extLst>
           </p:cNvPr>
@@ -3495,7 +3505,7 @@
           <p:cNvPr id="19" name="">
             <a:extLst xmlns:a="http://schemas.openxmlformats.org/drawingml/2006/main">
               <a:ext uri="{FF2B5EF4-FFF2-40B4-BE49-F238E27FC236}">
-                <a16:creationId xmlns:a16="http://schemas.microsoft.com/office/drawing/2014/main" id="{D96D144B-509B-40E4-BF55-9D7775E0CBBD}"/>
+                <a16:creationId xmlns:a16="http://schemas.microsoft.com/office/drawing/2014/main" id="{390D0B4C-660F-406C-990F-CF07E989C785}"/>
               </a:ext>
             </a:extLst>
           </p:cNvPr>
@@ -3552,7 +3562,7 @@
           <p:cNvPr id="20" name="">
             <a:extLst xmlns:a="http://schemas.openxmlformats.org/drawingml/2006/main">
               <a:ext uri="{FF2B5EF4-FFF2-40B4-BE49-F238E27FC236}">
-                <a16:creationId xmlns:a16="http://schemas.microsoft.com/office/drawing/2014/main" id="{203494CC-AAB3-4302-9A03-C2585C7752BF}"/>
+                <a16:creationId xmlns:a16="http://schemas.microsoft.com/office/drawing/2014/main" id="{318F8134-9209-459C-96D9-C1D6C34A01E2}"/>
               </a:ext>
             </a:extLst>
           </p:cNvPr>
@@ -3609,7 +3619,7 @@
           <p:cNvPr id="21" name="">
             <a:extLst xmlns:a="http://schemas.openxmlformats.org/drawingml/2006/main">
               <a:ext uri="{FF2B5EF4-FFF2-40B4-BE49-F238E27FC236}">
-                <a16:creationId xmlns:a16="http://schemas.microsoft.com/office/drawing/2014/main" id="{27E1099E-2E2C-479F-8CD1-F204F3403741}"/>
+                <a16:creationId xmlns:a16="http://schemas.microsoft.com/office/drawing/2014/main" id="{68960C85-786E-4D68-B862-A930652357FD}"/>
               </a:ext>
             </a:extLst>
           </p:cNvPr>
@@ -3666,7 +3676,7 @@
           <p:cNvPr id="22" name="">
             <a:extLst xmlns:a="http://schemas.openxmlformats.org/drawingml/2006/main">
               <a:ext uri="{FF2B5EF4-FFF2-40B4-BE49-F238E27FC236}">
-                <a16:creationId xmlns:a16="http://schemas.microsoft.com/office/drawing/2014/main" id="{E05118AD-2F1A-4AF1-B24C-0B436C039508}"/>
+                <a16:creationId xmlns:a16="http://schemas.microsoft.com/office/drawing/2014/main" id="{3B2948AD-AB22-48A3-B726-0E459B5D0BE6}"/>
               </a:ext>
             </a:extLst>
           </p:cNvPr>
@@ -3723,7 +3733,7 @@
           <p:cNvPr id="23" name="">
             <a:extLst xmlns:a="http://schemas.openxmlformats.org/drawingml/2006/main">
               <a:ext uri="{FF2B5EF4-FFF2-40B4-BE49-F238E27FC236}">
-                <a16:creationId xmlns:a16="http://schemas.microsoft.com/office/drawing/2014/main" id="{9401799D-695C-4E8D-98D5-E854909666C5}"/>
+                <a16:creationId xmlns:a16="http://schemas.microsoft.com/office/drawing/2014/main" id="{35084420-1248-4527-A416-6A9D23C7E87B}"/>
               </a:ext>
             </a:extLst>
           </p:cNvPr>
@@ -3754,7 +3764,7 @@
           <p:cNvPr id="24" name="">
             <a:extLst xmlns:a="http://schemas.openxmlformats.org/drawingml/2006/main">
               <a:ext uri="{FF2B5EF4-FFF2-40B4-BE49-F238E27FC236}">
-                <a16:creationId xmlns:a16="http://schemas.microsoft.com/office/drawing/2014/main" id="{FEBE13A9-23A2-4DE3-83AD-47FF536542C1}"/>
+                <a16:creationId xmlns:a16="http://schemas.microsoft.com/office/drawing/2014/main" id="{5D4FD366-0E52-4934-A2CB-50CB57915C51}"/>
               </a:ext>
             </a:extLst>
           </p:cNvPr>
@@ -3809,7 +3819,7 @@
     </p:spTree>
     <p:extLst>
       <p:ext uri="{BB962C8B-B14F-4D97-AF65-F5344CB8AC3E}">
-        <p14:creationId xmlns:p14="http://schemas.microsoft.com/office/powerpoint/2010/main" val="174314789"/>
+        <p14:creationId xmlns:p14="http://schemas.microsoft.com/office/powerpoint/2010/main" val="264847720"/>
       </p:ext>
     </p:extLst>
   </p:cSld>
@@ -3840,7 +3850,7 @@
           <p:cNvPr id="8" name="">
             <a:extLst xmlns:a="http://schemas.openxmlformats.org/drawingml/2006/main">
               <a:ext uri="{FF2B5EF4-FFF2-40B4-BE49-F238E27FC236}">
-                <a16:creationId xmlns:a16="http://schemas.microsoft.com/office/drawing/2014/main" id="{AF00E282-EDB9-43D2-A4BB-C6F5CCB0D10E}"/>
+                <a16:creationId xmlns:a16="http://schemas.microsoft.com/office/drawing/2014/main" id="{496FC24C-6EC7-49C6-9D5C-78A65E741E53}"/>
               </a:ext>
             </a:extLst>
           </p:cNvPr>
@@ -3897,7 +3907,7 @@
           <p:cNvPr id="2" name="">
             <a:extLst xmlns:a="http://schemas.openxmlformats.org/drawingml/2006/main">
               <a:ext uri="{FF2B5EF4-FFF2-40B4-BE49-F238E27FC236}">
-                <a16:creationId xmlns:a16="http://schemas.microsoft.com/office/drawing/2014/main" id="{A39800C3-919A-4BBD-AFA6-452C3C5B57C7}"/>
+                <a16:creationId xmlns:a16="http://schemas.microsoft.com/office/drawing/2014/main" id="{341A2C7E-0BEA-4F2D-8EF0-59D9B3E26C31}"/>
               </a:ext>
             </a:extLst>
           </p:cNvPr>
@@ -3928,7 +3938,7 @@
           <p:cNvPr id="3" name="">
             <a:extLst xmlns:a="http://schemas.openxmlformats.org/drawingml/2006/main">
               <a:ext uri="{FF2B5EF4-FFF2-40B4-BE49-F238E27FC236}">
-                <a16:creationId xmlns:a16="http://schemas.microsoft.com/office/drawing/2014/main" id="{AB24B5B6-C244-430D-B97C-7A803C4B2636}"/>
+                <a16:creationId xmlns:a16="http://schemas.microsoft.com/office/drawing/2014/main" id="{4FACA426-4733-4CBF-AA4B-6E86935DE4EE}"/>
               </a:ext>
             </a:extLst>
           </p:cNvPr>
@@ -4328,7 +4338,7 @@
           <p:cNvPr id="5" name="">
             <a:extLst xmlns:a="http://schemas.openxmlformats.org/drawingml/2006/main">
               <a:ext uri="{FF2B5EF4-FFF2-40B4-BE49-F238E27FC236}">
-                <a16:creationId xmlns:a16="http://schemas.microsoft.com/office/drawing/2014/main" id="{378EA4B1-AF39-4D9F-8D7D-7606A2A38707}"/>
+                <a16:creationId xmlns:a16="http://schemas.microsoft.com/office/drawing/2014/main" id="{136F8BC4-C119-43E3-A02A-6197D2914B8F}"/>
               </a:ext>
             </a:extLst>
           </p:cNvPr>
@@ -4385,7 +4395,7 @@
           <p:cNvPr id="6" name="">
             <a:extLst xmlns:a="http://schemas.openxmlformats.org/drawingml/2006/main">
               <a:ext uri="{FF2B5EF4-FFF2-40B4-BE49-F238E27FC236}">
-                <a16:creationId xmlns:a16="http://schemas.microsoft.com/office/drawing/2014/main" id="{612528BE-BBE4-403F-A168-34751E10988A}"/>
+                <a16:creationId xmlns:a16="http://schemas.microsoft.com/office/drawing/2014/main" id="{458AFE5E-E53C-4E24-A0CE-23172575CAF3}"/>
               </a:ext>
             </a:extLst>
           </p:cNvPr>
@@ -4416,7 +4426,7 @@
           <p:cNvPr id="7" name="">
             <a:extLst xmlns:a="http://schemas.openxmlformats.org/drawingml/2006/main">
               <a:ext uri="{FF2B5EF4-FFF2-40B4-BE49-F238E27FC236}">
-                <a16:creationId xmlns:a16="http://schemas.microsoft.com/office/drawing/2014/main" id="{2F5E5206-442F-4897-930A-F3395DAF18D2}"/>
+                <a16:creationId xmlns:a16="http://schemas.microsoft.com/office/drawing/2014/main" id="{DAD3A4F0-9A38-479B-927C-924FBB0967AF}"/>
               </a:ext>
             </a:extLst>
           </p:cNvPr>
@@ -4471,7 +4481,7 @@
     </p:spTree>
     <p:extLst>
       <p:ext uri="{BB962C8B-B14F-4D97-AF65-F5344CB8AC3E}">
-        <p14:creationId xmlns:p14="http://schemas.microsoft.com/office/powerpoint/2010/main" val="2137794210"/>
+        <p14:creationId xmlns:p14="http://schemas.microsoft.com/office/powerpoint/2010/main" val="1223876052"/>
       </p:ext>
     </p:extLst>
   </p:cSld>
@@ -4502,7 +4512,7 @@
           <p:cNvPr id="32" name="">
             <a:extLst xmlns:a="http://schemas.openxmlformats.org/drawingml/2006/main">
               <a:ext uri="{FF2B5EF4-FFF2-40B4-BE49-F238E27FC236}">
-                <a16:creationId xmlns:a16="http://schemas.microsoft.com/office/drawing/2014/main" id="{42E6D622-1D1D-4631-B352-B2E0A43F4C05}"/>
+                <a16:creationId xmlns:a16="http://schemas.microsoft.com/office/drawing/2014/main" id="{13C8C6AF-A5E9-4749-B48C-C05FB43D2971}"/>
               </a:ext>
             </a:extLst>
           </p:cNvPr>
@@ -4559,7 +4569,7 @@
           <p:cNvPr id="2" name="">
             <a:extLst xmlns:a="http://schemas.openxmlformats.org/drawingml/2006/main">
               <a:ext uri="{FF2B5EF4-FFF2-40B4-BE49-F238E27FC236}">
-                <a16:creationId xmlns:a16="http://schemas.microsoft.com/office/drawing/2014/main" id="{46FF5450-1E0B-49E8-991B-C74DBF6E75EA}"/>
+                <a16:creationId xmlns:a16="http://schemas.microsoft.com/office/drawing/2014/main" id="{69CFF263-20B3-477A-B077-D36384856E51}"/>
               </a:ext>
             </a:extLst>
           </p:cNvPr>
@@ -4590,7 +4600,7 @@
           <p:cNvPr id="3" name="">
             <a:extLst xmlns:a="http://schemas.openxmlformats.org/drawingml/2006/main">
               <a:ext uri="{FF2B5EF4-FFF2-40B4-BE49-F238E27FC236}">
-                <a16:creationId xmlns:a16="http://schemas.microsoft.com/office/drawing/2014/main" id="{BC66A3D4-F361-4921-AF07-7EAA9CB72313}"/>
+                <a16:creationId xmlns:a16="http://schemas.microsoft.com/office/drawing/2014/main" id="{0918869A-F28A-4660-84E6-02681326D7D7}"/>
               </a:ext>
             </a:extLst>
           </p:cNvPr>
@@ -4647,7 +4657,7 @@
           <p:cNvPr id="4" name="">
             <a:extLst xmlns:a="http://schemas.openxmlformats.org/drawingml/2006/main">
               <a:ext uri="{FF2B5EF4-FFF2-40B4-BE49-F238E27FC236}">
-                <a16:creationId xmlns:a16="http://schemas.microsoft.com/office/drawing/2014/main" id="{E4B10553-522D-4397-9306-434A0B500B95}"/>
+                <a16:creationId xmlns:a16="http://schemas.microsoft.com/office/drawing/2014/main" id="{5DB15A46-3502-42FF-8005-D3AD49A666C0}"/>
               </a:ext>
             </a:extLst>
           </p:cNvPr>
@@ -4680,7 +4690,7 @@
           <p:cNvPr id="5" name="">
             <a:extLst xmlns:a="http://schemas.openxmlformats.org/drawingml/2006/main">
               <a:ext uri="{FF2B5EF4-FFF2-40B4-BE49-F238E27FC236}">
-                <a16:creationId xmlns:a16="http://schemas.microsoft.com/office/drawing/2014/main" id="{F66D6C04-AB7B-4599-AF98-2B41A2460EFE}"/>
+                <a16:creationId xmlns:a16="http://schemas.microsoft.com/office/drawing/2014/main" id="{4B648074-C46D-4191-A6EC-34F10305A425}"/>
               </a:ext>
             </a:extLst>
           </p:cNvPr>
@@ -4737,7 +4747,7 @@
           <p:cNvPr id="6" name="">
             <a:extLst xmlns:a="http://schemas.openxmlformats.org/drawingml/2006/main">
               <a:ext uri="{FF2B5EF4-FFF2-40B4-BE49-F238E27FC236}">
-                <a16:creationId xmlns:a16="http://schemas.microsoft.com/office/drawing/2014/main" id="{1992D63F-2F09-4BC5-B4EE-94C3DC141531}"/>
+                <a16:creationId xmlns:a16="http://schemas.microsoft.com/office/drawing/2014/main" id="{6AED620E-F042-456C-8DED-BDE1AFFA0806}"/>
               </a:ext>
             </a:extLst>
           </p:cNvPr>
@@ -4770,7 +4780,7 @@
           <p:cNvPr id="7" name="">
             <a:extLst xmlns:a="http://schemas.openxmlformats.org/drawingml/2006/main">
               <a:ext uri="{FF2B5EF4-FFF2-40B4-BE49-F238E27FC236}">
-                <a16:creationId xmlns:a16="http://schemas.microsoft.com/office/drawing/2014/main" id="{2F1AF8DF-46FA-458C-A6A1-769857F83CF6}"/>
+                <a16:creationId xmlns:a16="http://schemas.microsoft.com/office/drawing/2014/main" id="{6111C9A8-C2D3-4428-B4BC-CE596DA6EC8D}"/>
               </a:ext>
             </a:extLst>
           </p:cNvPr>
@@ -4827,7 +4837,7 @@
           <p:cNvPr id="8" name="">
             <a:extLst xmlns:a="http://schemas.openxmlformats.org/drawingml/2006/main">
               <a:ext uri="{FF2B5EF4-FFF2-40B4-BE49-F238E27FC236}">
-                <a16:creationId xmlns:a16="http://schemas.microsoft.com/office/drawing/2014/main" id="{07F2F772-AA2C-4EEA-AB90-C632932B490F}"/>
+                <a16:creationId xmlns:a16="http://schemas.microsoft.com/office/drawing/2014/main" id="{90F1C674-1598-4A12-93CC-F0218E4B4198}"/>
               </a:ext>
             </a:extLst>
           </p:cNvPr>
@@ -4860,7 +4870,7 @@
           <p:cNvPr id="9" name="">
             <a:extLst xmlns:a="http://schemas.openxmlformats.org/drawingml/2006/main">
               <a:ext uri="{FF2B5EF4-FFF2-40B4-BE49-F238E27FC236}">
-                <a16:creationId xmlns:a16="http://schemas.microsoft.com/office/drawing/2014/main" id="{082869A7-25D4-4E51-8F58-AAFFA0B99902}"/>
+                <a16:creationId xmlns:a16="http://schemas.microsoft.com/office/drawing/2014/main" id="{986D905A-2E02-462E-9BAD-D83C7014E4C6}"/>
               </a:ext>
             </a:extLst>
           </p:cNvPr>
@@ -4917,7 +4927,7 @@
           <p:cNvPr id="10" name="">
             <a:extLst xmlns:a="http://schemas.openxmlformats.org/drawingml/2006/main">
               <a:ext uri="{FF2B5EF4-FFF2-40B4-BE49-F238E27FC236}">
-                <a16:creationId xmlns:a16="http://schemas.microsoft.com/office/drawing/2014/main" id="{26269ACE-D69E-4D35-9BF1-8D1C9BF17F86}"/>
+                <a16:creationId xmlns:a16="http://schemas.microsoft.com/office/drawing/2014/main" id="{CE30363C-907E-4FF1-89C4-D90A5D32DFC8}"/>
               </a:ext>
             </a:extLst>
           </p:cNvPr>
@@ -4950,7 +4960,7 @@
           <p:cNvPr id="11" name="">
             <a:extLst xmlns:a="http://schemas.openxmlformats.org/drawingml/2006/main">
               <a:ext uri="{FF2B5EF4-FFF2-40B4-BE49-F238E27FC236}">
-                <a16:creationId xmlns:a16="http://schemas.microsoft.com/office/drawing/2014/main" id="{21E9717D-21FF-4053-A973-97F208BB432C}"/>
+                <a16:creationId xmlns:a16="http://schemas.microsoft.com/office/drawing/2014/main" id="{F9980455-647E-4E3A-8176-639EA4CFECB0}"/>
               </a:ext>
             </a:extLst>
           </p:cNvPr>
@@ -5007,7 +5017,7 @@
           <p:cNvPr id="12" name="">
             <a:extLst xmlns:a="http://schemas.openxmlformats.org/drawingml/2006/main">
               <a:ext uri="{FF2B5EF4-FFF2-40B4-BE49-F238E27FC236}">
-                <a16:creationId xmlns:a16="http://schemas.microsoft.com/office/drawing/2014/main" id="{8847E2D9-FF37-4437-8851-972EAC0C62E6}"/>
+                <a16:creationId xmlns:a16="http://schemas.microsoft.com/office/drawing/2014/main" id="{75BB8B12-5ADB-43C5-8AEE-AF34A343A7E2}"/>
               </a:ext>
             </a:extLst>
           </p:cNvPr>
@@ -5040,7 +5050,7 @@
           <p:cNvPr id="13" name="">
             <a:extLst xmlns:a="http://schemas.openxmlformats.org/drawingml/2006/main">
               <a:ext uri="{FF2B5EF4-FFF2-40B4-BE49-F238E27FC236}">
-                <a16:creationId xmlns:a16="http://schemas.microsoft.com/office/drawing/2014/main" id="{0E7EEE24-F292-4546-84E1-4E634EA26093}"/>
+                <a16:creationId xmlns:a16="http://schemas.microsoft.com/office/drawing/2014/main" id="{E4A88C1A-91F1-4ED2-9530-131FDCCAE00B}"/>
               </a:ext>
             </a:extLst>
           </p:cNvPr>
@@ -5201,7 +5211,7 @@
           <p:cNvPr id="18" name="">
             <a:extLst xmlns:a="http://schemas.openxmlformats.org/drawingml/2006/main">
               <a:ext uri="{FF2B5EF4-FFF2-40B4-BE49-F238E27FC236}">
-                <a16:creationId xmlns:a16="http://schemas.microsoft.com/office/drawing/2014/main" id="{FC1B7F88-91BD-4B7D-AB91-EB5E24C182F5}"/>
+                <a16:creationId xmlns:a16="http://schemas.microsoft.com/office/drawing/2014/main" id="{E45A984A-B169-498D-953A-89A2FD47757B}"/>
               </a:ext>
             </a:extLst>
           </p:cNvPr>
@@ -5234,7 +5244,7 @@
           <p:cNvPr id="19" name="">
             <a:extLst xmlns:a="http://schemas.openxmlformats.org/drawingml/2006/main">
               <a:ext uri="{FF2B5EF4-FFF2-40B4-BE49-F238E27FC236}">
-                <a16:creationId xmlns:a16="http://schemas.microsoft.com/office/drawing/2014/main" id="{CDA4C618-72A7-4C71-AF91-C8D7DC28C9E5}"/>
+                <a16:creationId xmlns:a16="http://schemas.microsoft.com/office/drawing/2014/main" id="{DC625860-A7F4-4516-A9B0-BD45749C2F1E}"/>
               </a:ext>
             </a:extLst>
           </p:cNvPr>
@@ -5291,7 +5301,7 @@
           <p:cNvPr id="20" name="">
             <a:extLst xmlns:a="http://schemas.openxmlformats.org/drawingml/2006/main">
               <a:ext uri="{FF2B5EF4-FFF2-40B4-BE49-F238E27FC236}">
-                <a16:creationId xmlns:a16="http://schemas.microsoft.com/office/drawing/2014/main" id="{BD70EE2F-8B0F-45D0-8D48-49E2FCE37D16}"/>
+                <a16:creationId xmlns:a16="http://schemas.microsoft.com/office/drawing/2014/main" id="{7D816891-4F03-44D4-B8B0-5E53E6651AB0}"/>
               </a:ext>
             </a:extLst>
           </p:cNvPr>
@@ -5324,7 +5334,7 @@
           <p:cNvPr id="21" name="">
             <a:extLst xmlns:a="http://schemas.openxmlformats.org/drawingml/2006/main">
               <a:ext uri="{FF2B5EF4-FFF2-40B4-BE49-F238E27FC236}">
-                <a16:creationId xmlns:a16="http://schemas.microsoft.com/office/drawing/2014/main" id="{162D168F-7FFD-4869-BFED-229108B0BABB}"/>
+                <a16:creationId xmlns:a16="http://schemas.microsoft.com/office/drawing/2014/main" id="{3A745B2C-543A-44C3-A321-CD4BBCC06F70}"/>
               </a:ext>
             </a:extLst>
           </p:cNvPr>
@@ -5381,7 +5391,7 @@
           <p:cNvPr id="22" name="">
             <a:extLst xmlns:a="http://schemas.openxmlformats.org/drawingml/2006/main">
               <a:ext uri="{FF2B5EF4-FFF2-40B4-BE49-F238E27FC236}">
-                <a16:creationId xmlns:a16="http://schemas.microsoft.com/office/drawing/2014/main" id="{3CE842E6-207D-4750-8541-EEB6A6BCD30F}"/>
+                <a16:creationId xmlns:a16="http://schemas.microsoft.com/office/drawing/2014/main" id="{8A83F9E9-85CF-4CA4-94F0-7B72F184D9B8}"/>
               </a:ext>
             </a:extLst>
           </p:cNvPr>
@@ -5414,7 +5424,7 @@
           <p:cNvPr id="23" name="">
             <a:extLst xmlns:a="http://schemas.openxmlformats.org/drawingml/2006/main">
               <a:ext uri="{FF2B5EF4-FFF2-40B4-BE49-F238E27FC236}">
-                <a16:creationId xmlns:a16="http://schemas.microsoft.com/office/drawing/2014/main" id="{D96F5C55-9B40-48AE-9B74-FFD8E993DA01}"/>
+                <a16:creationId xmlns:a16="http://schemas.microsoft.com/office/drawing/2014/main" id="{6E25CEE6-69AD-421E-B95E-FAECE3585EB7}"/>
               </a:ext>
             </a:extLst>
           </p:cNvPr>
@@ -5578,7 +5588,7 @@
           <p:cNvPr id="28" name="">
             <a:extLst xmlns:a="http://schemas.openxmlformats.org/drawingml/2006/main">
               <a:ext uri="{FF2B5EF4-FFF2-40B4-BE49-F238E27FC236}">
-                <a16:creationId xmlns:a16="http://schemas.microsoft.com/office/drawing/2014/main" id="{BCEE45B9-3D15-4AC8-AE70-5AFD412DA271}"/>
+                <a16:creationId xmlns:a16="http://schemas.microsoft.com/office/drawing/2014/main" id="{4F011E6A-5D08-48E0-8AE5-BD0CAE3CD25F}"/>
               </a:ext>
             </a:extLst>
           </p:cNvPr>
@@ -5635,7 +5645,7 @@
           <p:cNvPr id="29" name="">
             <a:extLst xmlns:a="http://schemas.openxmlformats.org/drawingml/2006/main">
               <a:ext uri="{FF2B5EF4-FFF2-40B4-BE49-F238E27FC236}">
-                <a16:creationId xmlns:a16="http://schemas.microsoft.com/office/drawing/2014/main" id="{1EFEDCE2-F407-4F83-9B92-28E85F6C1AC2}"/>
+                <a16:creationId xmlns:a16="http://schemas.microsoft.com/office/drawing/2014/main" id="{F4098478-930C-48BD-BA00-9C42A20FC314}"/>
               </a:ext>
             </a:extLst>
           </p:cNvPr>
@@ -5692,7 +5702,7 @@
           <p:cNvPr id="30" name="">
             <a:extLst xmlns:a="http://schemas.openxmlformats.org/drawingml/2006/main">
               <a:ext uri="{FF2B5EF4-FFF2-40B4-BE49-F238E27FC236}">
-                <a16:creationId xmlns:a16="http://schemas.microsoft.com/office/drawing/2014/main" id="{45786761-AF50-4868-8DC8-A5C6F5970C1E}"/>
+                <a16:creationId xmlns:a16="http://schemas.microsoft.com/office/drawing/2014/main" id="{A7A62D12-FF37-4B5D-B8E6-F5AE993CCF12}"/>
               </a:ext>
             </a:extLst>
           </p:cNvPr>
@@ -5723,7 +5733,7 @@
           <p:cNvPr id="31" name="">
             <a:extLst xmlns:a="http://schemas.openxmlformats.org/drawingml/2006/main">
               <a:ext uri="{FF2B5EF4-FFF2-40B4-BE49-F238E27FC236}">
-                <a16:creationId xmlns:a16="http://schemas.microsoft.com/office/drawing/2014/main" id="{2DAF3526-4519-402F-BCF9-69E1C8229D6C}"/>
+                <a16:creationId xmlns:a16="http://schemas.microsoft.com/office/drawing/2014/main" id="{D91A7991-C374-400F-9FE5-362961170F1D}"/>
               </a:ext>
             </a:extLst>
           </p:cNvPr>
@@ -5778,7 +5788,7 @@
     </p:spTree>
     <p:extLst>
       <p:ext uri="{BB962C8B-B14F-4D97-AF65-F5344CB8AC3E}">
-        <p14:creationId xmlns:p14="http://schemas.microsoft.com/office/powerpoint/2010/main" val="415600603"/>
+        <p14:creationId xmlns:p14="http://schemas.microsoft.com/office/powerpoint/2010/main" val="93176709"/>
       </p:ext>
     </p:extLst>
   </p:cSld>
@@ -5809,7 +5819,7 @@
           <p:cNvPr id="7" name="">
             <a:extLst xmlns:a="http://schemas.openxmlformats.org/drawingml/2006/main">
               <a:ext uri="{FF2B5EF4-FFF2-40B4-BE49-F238E27FC236}">
-                <a16:creationId xmlns:a16="http://schemas.microsoft.com/office/drawing/2014/main" id="{BB74AF8D-6A57-4EFC-BEF5-B46BDA20798F}"/>
+                <a16:creationId xmlns:a16="http://schemas.microsoft.com/office/drawing/2014/main" id="{26E86F8F-AF7C-4988-806F-61FA7BC42C7C}"/>
               </a:ext>
             </a:extLst>
           </p:cNvPr>
@@ -5866,7 +5876,7 @@
           <p:cNvPr id="2" name="">
             <a:extLst xmlns:a="http://schemas.openxmlformats.org/drawingml/2006/main">
               <a:ext uri="{FF2B5EF4-FFF2-40B4-BE49-F238E27FC236}">
-                <a16:creationId xmlns:a16="http://schemas.microsoft.com/office/drawing/2014/main" id="{C88E2438-D823-4197-82E5-D99171946BEA}"/>
+                <a16:creationId xmlns:a16="http://schemas.microsoft.com/office/drawing/2014/main" id="{721AD406-ECFF-4E9C-A472-E99E430652FA}"/>
               </a:ext>
             </a:extLst>
           </p:cNvPr>
@@ -5897,7 +5907,7 @@
           <p:cNvPr id="3" name="">
             <a:extLst xmlns:a="http://schemas.openxmlformats.org/drawingml/2006/main">
               <a:ext uri="{FF2B5EF4-FFF2-40B4-BE49-F238E27FC236}">
-                <a16:creationId xmlns:a16="http://schemas.microsoft.com/office/drawing/2014/main" id="{192ED037-8CA7-4AC6-9232-BE06F2AD522E}"/>
+                <a16:creationId xmlns:a16="http://schemas.microsoft.com/office/drawing/2014/main" id="{324396A9-CF5E-4BE7-9CAD-09FDEE17470D}"/>
               </a:ext>
             </a:extLst>
           </p:cNvPr>
@@ -6377,7 +6387,7 @@
           <p:cNvPr id="5" name="">
             <a:extLst xmlns:a="http://schemas.openxmlformats.org/drawingml/2006/main">
               <a:ext uri="{FF2B5EF4-FFF2-40B4-BE49-F238E27FC236}">
-                <a16:creationId xmlns:a16="http://schemas.microsoft.com/office/drawing/2014/main" id="{5CC1F57A-A9B0-4475-9581-A390EE363AA6}"/>
+                <a16:creationId xmlns:a16="http://schemas.microsoft.com/office/drawing/2014/main" id="{EEA98B04-98CA-41A9-962E-B59420024E31}"/>
               </a:ext>
             </a:extLst>
           </p:cNvPr>
@@ -6408,7 +6418,7 @@
           <p:cNvPr id="6" name="">
             <a:extLst xmlns:a="http://schemas.openxmlformats.org/drawingml/2006/main">
               <a:ext uri="{FF2B5EF4-FFF2-40B4-BE49-F238E27FC236}">
-                <a16:creationId xmlns:a16="http://schemas.microsoft.com/office/drawing/2014/main" id="{FC36E7D1-9274-4D01-A92B-A225EAB103D6}"/>
+                <a16:creationId xmlns:a16="http://schemas.microsoft.com/office/drawing/2014/main" id="{DDB33D7B-5415-4E32-B919-6B1F84FA7625}"/>
               </a:ext>
             </a:extLst>
           </p:cNvPr>
@@ -6463,7 +6473,7 @@
     </p:spTree>
     <p:extLst>
       <p:ext uri="{BB962C8B-B14F-4D97-AF65-F5344CB8AC3E}">
-        <p14:creationId xmlns:p14="http://schemas.microsoft.com/office/powerpoint/2010/main" val="53369033"/>
+        <p14:creationId xmlns:p14="http://schemas.microsoft.com/office/powerpoint/2010/main" val="1623132250"/>
       </p:ext>
     </p:extLst>
   </p:cSld>
@@ -6494,7 +6504,7 @@
           <p:cNvPr id="21" name="">
             <a:extLst xmlns:a="http://schemas.openxmlformats.org/drawingml/2006/main">
               <a:ext uri="{FF2B5EF4-FFF2-40B4-BE49-F238E27FC236}">
-                <a16:creationId xmlns:a16="http://schemas.microsoft.com/office/drawing/2014/main" id="{457D86F9-D1E3-4880-BFDE-9DA716606671}"/>
+                <a16:creationId xmlns:a16="http://schemas.microsoft.com/office/drawing/2014/main" id="{41E9B2DB-643C-440E-ACEA-231CAEA1CA37}"/>
               </a:ext>
             </a:extLst>
           </p:cNvPr>
@@ -6574,7 +6584,7 @@
           <p:cNvPr id="2" name="">
             <a:extLst xmlns:a="http://schemas.openxmlformats.org/drawingml/2006/main">
               <a:ext uri="{FF2B5EF4-FFF2-40B4-BE49-F238E27FC236}">
-                <a16:creationId xmlns:a16="http://schemas.microsoft.com/office/drawing/2014/main" id="{D99184FC-157D-4F50-BA19-C23C4DDD112A}"/>
+                <a16:creationId xmlns:a16="http://schemas.microsoft.com/office/drawing/2014/main" id="{1F0717E3-0A5F-4782-ABCC-043C0EB20ABE}"/>
               </a:ext>
             </a:extLst>
           </p:cNvPr>
@@ -6605,7 +6615,7 @@
           <p:cNvPr id="3" name="">
             <a:extLst xmlns:a="http://schemas.openxmlformats.org/drawingml/2006/main">
               <a:ext uri="{FF2B5EF4-FFF2-40B4-BE49-F238E27FC236}">
-                <a16:creationId xmlns:a16="http://schemas.microsoft.com/office/drawing/2014/main" id="{6D2FB3B5-C462-4AFF-B7C5-EF1AB2FFC9E4}"/>
+                <a16:creationId xmlns:a16="http://schemas.microsoft.com/office/drawing/2014/main" id="{3F33A32E-DE73-4E56-B52D-577779A047B7}"/>
               </a:ext>
             </a:extLst>
           </p:cNvPr>
@@ -6662,7 +6672,7 @@
           <p:cNvPr id="4" name="">
             <a:extLst xmlns:a="http://schemas.openxmlformats.org/drawingml/2006/main">
               <a:ext uri="{FF2B5EF4-FFF2-40B4-BE49-F238E27FC236}">
-                <a16:creationId xmlns:a16="http://schemas.microsoft.com/office/drawing/2014/main" id="{8959CF0F-1EEB-4C62-8EEB-4686CDF05991}"/>
+                <a16:creationId xmlns:a16="http://schemas.microsoft.com/office/drawing/2014/main" id="{B5D630FE-1261-4724-BF38-DA27DFC237FB}"/>
               </a:ext>
             </a:extLst>
           </p:cNvPr>
@@ -6719,7 +6729,7 @@
           <p:cNvPr id="5" name="">
             <a:extLst xmlns:a="http://schemas.openxmlformats.org/drawingml/2006/main">
               <a:ext uri="{FF2B5EF4-FFF2-40B4-BE49-F238E27FC236}">
-                <a16:creationId xmlns:a16="http://schemas.microsoft.com/office/drawing/2014/main" id="{9F28F117-4E9C-4BA9-9514-472CC4BFFEEB}"/>
+                <a16:creationId xmlns:a16="http://schemas.microsoft.com/office/drawing/2014/main" id="{F20014B9-1D24-4718-A4D2-750010556009}"/>
               </a:ext>
             </a:extLst>
           </p:cNvPr>
@@ -6776,7 +6786,7 @@
           <p:cNvPr id="6" name="">
             <a:extLst xmlns:a="http://schemas.openxmlformats.org/drawingml/2006/main">
               <a:ext uri="{FF2B5EF4-FFF2-40B4-BE49-F238E27FC236}">
-                <a16:creationId xmlns:a16="http://schemas.microsoft.com/office/drawing/2014/main" id="{90FA0A31-09B9-4D1F-92F9-552C1523AA29}"/>
+                <a16:creationId xmlns:a16="http://schemas.microsoft.com/office/drawing/2014/main" id="{A1ADAA30-2270-46F3-92CB-0C13181FAFB4}"/>
               </a:ext>
             </a:extLst>
           </p:cNvPr>
@@ -6807,7 +6817,7 @@
           <p:cNvPr id="7" name="">
             <a:extLst xmlns:a="http://schemas.openxmlformats.org/drawingml/2006/main">
               <a:ext uri="{FF2B5EF4-FFF2-40B4-BE49-F238E27FC236}">
-                <a16:creationId xmlns:a16="http://schemas.microsoft.com/office/drawing/2014/main" id="{AFECFFA5-0939-4584-B7AD-E9D4D8200179}"/>
+                <a16:creationId xmlns:a16="http://schemas.microsoft.com/office/drawing/2014/main" id="{31886E7D-8F1B-4D43-AA74-EB94D8B9F5D1}"/>
               </a:ext>
             </a:extLst>
           </p:cNvPr>
@@ -6864,7 +6874,7 @@
           <p:cNvPr id="8" name="">
             <a:extLst xmlns:a="http://schemas.openxmlformats.org/drawingml/2006/main">
               <a:ext uri="{FF2B5EF4-FFF2-40B4-BE49-F238E27FC236}">
-                <a16:creationId xmlns:a16="http://schemas.microsoft.com/office/drawing/2014/main" id="{27002E90-9C4E-43FF-956A-8EFEDA3ED77B}"/>
+                <a16:creationId xmlns:a16="http://schemas.microsoft.com/office/drawing/2014/main" id="{F8C2EF94-5749-4192-848B-35417E28082E}"/>
               </a:ext>
             </a:extLst>
           </p:cNvPr>
@@ -6921,7 +6931,7 @@
           <p:cNvPr id="9" name="">
             <a:extLst xmlns:a="http://schemas.openxmlformats.org/drawingml/2006/main">
               <a:ext uri="{FF2B5EF4-FFF2-40B4-BE49-F238E27FC236}">
-                <a16:creationId xmlns:a16="http://schemas.microsoft.com/office/drawing/2014/main" id="{44454CA9-DDAD-47ED-9B68-AF801AF19007}"/>
+                <a16:creationId xmlns:a16="http://schemas.microsoft.com/office/drawing/2014/main" id="{B8BA126B-05A5-46DE-A58C-A943A06D7955}"/>
               </a:ext>
             </a:extLst>
           </p:cNvPr>
@@ -6978,7 +6988,7 @@
           <p:cNvPr id="10" name="">
             <a:extLst xmlns:a="http://schemas.openxmlformats.org/drawingml/2006/main">
               <a:ext uri="{FF2B5EF4-FFF2-40B4-BE49-F238E27FC236}">
-                <a16:creationId xmlns:a16="http://schemas.microsoft.com/office/drawing/2014/main" id="{DF1E67AC-745C-48C1-B517-B5CA04C801A7}"/>
+                <a16:creationId xmlns:a16="http://schemas.microsoft.com/office/drawing/2014/main" id="{573764B7-66B8-47B3-9BFA-6A40C755C883}"/>
               </a:ext>
             </a:extLst>
           </p:cNvPr>
@@ -7035,7 +7045,7 @@
           <p:cNvPr id="11" name="">
             <a:extLst xmlns:a="http://schemas.openxmlformats.org/drawingml/2006/main">
               <a:ext uri="{FF2B5EF4-FFF2-40B4-BE49-F238E27FC236}">
-                <a16:creationId xmlns:a16="http://schemas.microsoft.com/office/drawing/2014/main" id="{338FDD35-C08C-4AD7-93C7-9A11D61302CC}"/>
+                <a16:creationId xmlns:a16="http://schemas.microsoft.com/office/drawing/2014/main" id="{1DB51FA7-9DC6-4771-B41B-0D84EF0B0F1D}"/>
               </a:ext>
             </a:extLst>
           </p:cNvPr>
@@ -7092,7 +7102,7 @@
           <p:cNvPr id="12" name="">
             <a:extLst xmlns:a="http://schemas.openxmlformats.org/drawingml/2006/main">
               <a:ext uri="{FF2B5EF4-FFF2-40B4-BE49-F238E27FC236}">
-                <a16:creationId xmlns:a16="http://schemas.microsoft.com/office/drawing/2014/main" id="{86E0CC7E-12DF-43A5-B8D9-9B3FF405D169}"/>
+                <a16:creationId xmlns:a16="http://schemas.microsoft.com/office/drawing/2014/main" id="{6BA6AC91-C0C8-4FE3-9E5E-F383F7B8CCF5}"/>
               </a:ext>
             </a:extLst>
           </p:cNvPr>
@@ -7149,7 +7159,7 @@
           <p:cNvPr id="13" name="">
             <a:extLst xmlns:a="http://schemas.openxmlformats.org/drawingml/2006/main">
               <a:ext uri="{FF2B5EF4-FFF2-40B4-BE49-F238E27FC236}">
-                <a16:creationId xmlns:a16="http://schemas.microsoft.com/office/drawing/2014/main" id="{9E6F00B1-4764-4765-B2E9-A1A265A2F27B}"/>
+                <a16:creationId xmlns:a16="http://schemas.microsoft.com/office/drawing/2014/main" id="{69C2E13A-8DBD-4AF6-AEE2-C74FA4DB4FA4}"/>
               </a:ext>
             </a:extLst>
           </p:cNvPr>
@@ -7180,7 +7190,7 @@
           <p:cNvPr id="14" name="">
             <a:extLst xmlns:a="http://schemas.openxmlformats.org/drawingml/2006/main">
               <a:ext uri="{FF2B5EF4-FFF2-40B4-BE49-F238E27FC236}">
-                <a16:creationId xmlns:a16="http://schemas.microsoft.com/office/drawing/2014/main" id="{2D22A654-877A-4CE3-B975-03DEAA18B930}"/>
+                <a16:creationId xmlns:a16="http://schemas.microsoft.com/office/drawing/2014/main" id="{90D74532-F315-40E3-BDDC-60379C5ED0E7}"/>
               </a:ext>
             </a:extLst>
           </p:cNvPr>
@@ -7237,7 +7247,7 @@
           <p:cNvPr id="15" name="">
             <a:extLst xmlns:a="http://schemas.openxmlformats.org/drawingml/2006/main">
               <a:ext uri="{FF2B5EF4-FFF2-40B4-BE49-F238E27FC236}">
-                <a16:creationId xmlns:a16="http://schemas.microsoft.com/office/drawing/2014/main" id="{CE666907-A5ED-4C0A-A404-3A7367F58916}"/>
+                <a16:creationId xmlns:a16="http://schemas.microsoft.com/office/drawing/2014/main" id="{B87639FF-E7E3-4CD5-9A33-34698F092398}"/>
               </a:ext>
             </a:extLst>
           </p:cNvPr>
@@ -7294,7 +7304,7 @@
           <p:cNvPr id="16" name="">
             <a:extLst xmlns:a="http://schemas.openxmlformats.org/drawingml/2006/main">
               <a:ext uri="{FF2B5EF4-FFF2-40B4-BE49-F238E27FC236}">
-                <a16:creationId xmlns:a16="http://schemas.microsoft.com/office/drawing/2014/main" id="{9AFD0DE6-7608-4E51-951D-89B9D8089232}"/>
+                <a16:creationId xmlns:a16="http://schemas.microsoft.com/office/drawing/2014/main" id="{EFC6400B-C1C3-4D9B-9536-98A4F921BDCC}"/>
               </a:ext>
             </a:extLst>
           </p:cNvPr>
@@ -7351,7 +7361,7 @@
           <p:cNvPr id="17" name="">
             <a:extLst xmlns:a="http://schemas.openxmlformats.org/drawingml/2006/main">
               <a:ext uri="{FF2B5EF4-FFF2-40B4-BE49-F238E27FC236}">
-                <a16:creationId xmlns:a16="http://schemas.microsoft.com/office/drawing/2014/main" id="{6B8669FA-E6F1-49A9-93CA-CF2A81F8407B}"/>
+                <a16:creationId xmlns:a16="http://schemas.microsoft.com/office/drawing/2014/main" id="{4A4CFB3F-C079-40B8-B8EB-99C503E9D748}"/>
               </a:ext>
             </a:extLst>
           </p:cNvPr>
@@ -7408,7 +7418,7 @@
           <p:cNvPr id="18" name="">
             <a:extLst xmlns:a="http://schemas.openxmlformats.org/drawingml/2006/main">
               <a:ext uri="{FF2B5EF4-FFF2-40B4-BE49-F238E27FC236}">
-                <a16:creationId xmlns:a16="http://schemas.microsoft.com/office/drawing/2014/main" id="{5A1AC03A-9BAE-47C9-9AFE-1F0021820A6B}"/>
+                <a16:creationId xmlns:a16="http://schemas.microsoft.com/office/drawing/2014/main" id="{891A143A-C5EA-4B2B-A13F-43C73B1DA6C8}"/>
               </a:ext>
             </a:extLst>
           </p:cNvPr>
@@ -7465,7 +7475,7 @@
           <p:cNvPr id="19" name="">
             <a:extLst xmlns:a="http://schemas.openxmlformats.org/drawingml/2006/main">
               <a:ext uri="{FF2B5EF4-FFF2-40B4-BE49-F238E27FC236}">
-                <a16:creationId xmlns:a16="http://schemas.microsoft.com/office/drawing/2014/main" id="{7A05A8EF-D10A-4521-9E51-C4EC3E92DBE7}"/>
+                <a16:creationId xmlns:a16="http://schemas.microsoft.com/office/drawing/2014/main" id="{FF156E55-06F0-455B-A2B4-5117E70ADBAB}"/>
               </a:ext>
             </a:extLst>
           </p:cNvPr>
@@ -7496,7 +7506,7 @@
           <p:cNvPr id="20" name="">
             <a:extLst xmlns:a="http://schemas.openxmlformats.org/drawingml/2006/main">
               <a:ext uri="{FF2B5EF4-FFF2-40B4-BE49-F238E27FC236}">
-                <a16:creationId xmlns:a16="http://schemas.microsoft.com/office/drawing/2014/main" id="{4C5882E7-6F77-4F10-978C-66FCD155D6E8}"/>
+                <a16:creationId xmlns:a16="http://schemas.microsoft.com/office/drawing/2014/main" id="{550FDE2A-EBD5-4563-AE6B-DEFED39B1622}"/>
               </a:ext>
             </a:extLst>
           </p:cNvPr>
@@ -7551,7 +7561,7 @@
     </p:spTree>
     <p:extLst>
       <p:ext uri="{BB962C8B-B14F-4D97-AF65-F5344CB8AC3E}">
-        <p14:creationId xmlns:p14="http://schemas.microsoft.com/office/powerpoint/2010/main" val="1075498167"/>
+        <p14:creationId xmlns:p14="http://schemas.microsoft.com/office/powerpoint/2010/main" val="970810297"/>
       </p:ext>
     </p:extLst>
   </p:cSld>
@@ -7582,7 +7592,7 @@
           <p:cNvPr id="21" name="">
             <a:extLst xmlns:a="http://schemas.openxmlformats.org/drawingml/2006/main">
               <a:ext uri="{FF2B5EF4-FFF2-40B4-BE49-F238E27FC236}">
-                <a16:creationId xmlns:a16="http://schemas.microsoft.com/office/drawing/2014/main" id="{33EE68E6-D4F2-45EA-AF87-9C038A8155FD}"/>
+                <a16:creationId xmlns:a16="http://schemas.microsoft.com/office/drawing/2014/main" id="{ACE5E03B-C13A-4D8F-92DC-2B3D4C784D5F}"/>
               </a:ext>
             </a:extLst>
           </p:cNvPr>
@@ -7639,7 +7649,7 @@
           <p:cNvPr id="2" name="">
             <a:extLst xmlns:a="http://schemas.openxmlformats.org/drawingml/2006/main">
               <a:ext uri="{FF2B5EF4-FFF2-40B4-BE49-F238E27FC236}">
-                <a16:creationId xmlns:a16="http://schemas.microsoft.com/office/drawing/2014/main" id="{54C063C2-2B70-4E07-94E3-76D27EA1CA17}"/>
+                <a16:creationId xmlns:a16="http://schemas.microsoft.com/office/drawing/2014/main" id="{6B487388-8F63-435A-B154-30D9E1B233C2}"/>
               </a:ext>
             </a:extLst>
           </p:cNvPr>
@@ -7670,7 +7680,7 @@
           <p:cNvPr id="3" name="">
             <a:extLst xmlns:a="http://schemas.openxmlformats.org/drawingml/2006/main">
               <a:ext uri="{FF2B5EF4-FFF2-40B4-BE49-F238E27FC236}">
-                <a16:creationId xmlns:a16="http://schemas.microsoft.com/office/drawing/2014/main" id="{00A453BA-2859-4977-B51B-D420747DD85A}"/>
+                <a16:creationId xmlns:a16="http://schemas.microsoft.com/office/drawing/2014/main" id="{2A22C287-AC15-4FF6-9046-3B8299F34A1D}"/>
               </a:ext>
             </a:extLst>
           </p:cNvPr>
@@ -7727,7 +7737,7 @@
           <p:cNvPr id="4" name="">
             <a:extLst xmlns:a="http://schemas.openxmlformats.org/drawingml/2006/main">
               <a:ext uri="{FF2B5EF4-FFF2-40B4-BE49-F238E27FC236}">
-                <a16:creationId xmlns:a16="http://schemas.microsoft.com/office/drawing/2014/main" id="{A5F39C5B-337C-42CB-BAD2-6708983375FE}"/>
+                <a16:creationId xmlns:a16="http://schemas.microsoft.com/office/drawing/2014/main" id="{614829E3-F90D-4B7A-BBED-D3052F7FCE55}"/>
               </a:ext>
             </a:extLst>
           </p:cNvPr>
@@ -7760,7 +7770,7 @@
           <p:cNvPr id="5" name="">
             <a:extLst xmlns:a="http://schemas.openxmlformats.org/drawingml/2006/main">
               <a:ext uri="{FF2B5EF4-FFF2-40B4-BE49-F238E27FC236}">
-                <a16:creationId xmlns:a16="http://schemas.microsoft.com/office/drawing/2014/main" id="{597BD4DB-E5F0-4A7B-BA26-182BADBB6B14}"/>
+                <a16:creationId xmlns:a16="http://schemas.microsoft.com/office/drawing/2014/main" id="{090C7CC3-C9FB-41C0-A077-FCAD36068E95}"/>
               </a:ext>
             </a:extLst>
           </p:cNvPr>
@@ -7817,7 +7827,7 @@
           <p:cNvPr id="6" name="">
             <a:extLst xmlns:a="http://schemas.openxmlformats.org/drawingml/2006/main">
               <a:ext uri="{FF2B5EF4-FFF2-40B4-BE49-F238E27FC236}">
-                <a16:creationId xmlns:a16="http://schemas.microsoft.com/office/drawing/2014/main" id="{4EABD9B8-AE2D-44A4-9292-2513D73A509C}"/>
+                <a16:creationId xmlns:a16="http://schemas.microsoft.com/office/drawing/2014/main" id="{F2E9C6BA-53E5-4D41-8443-40356FC16E4D}"/>
               </a:ext>
             </a:extLst>
           </p:cNvPr>
@@ -7897,7 +7907,7 @@
           <p:cNvPr id="7" name="">
             <a:extLst xmlns:a="http://schemas.openxmlformats.org/drawingml/2006/main">
               <a:ext uri="{FF2B5EF4-FFF2-40B4-BE49-F238E27FC236}">
-                <a16:creationId xmlns:a16="http://schemas.microsoft.com/office/drawing/2014/main" id="{472806F0-2D59-4839-A154-65259696D139}"/>
+                <a16:creationId xmlns:a16="http://schemas.microsoft.com/office/drawing/2014/main" id="{3216F2EF-3652-4B68-AEDD-6865A2203451}"/>
               </a:ext>
             </a:extLst>
           </p:cNvPr>
@@ -7977,7 +7987,7 @@
           <p:cNvPr id="8" name="">
             <a:extLst xmlns:a="http://schemas.openxmlformats.org/drawingml/2006/main">
               <a:ext uri="{FF2B5EF4-FFF2-40B4-BE49-F238E27FC236}">
-                <a16:creationId xmlns:a16="http://schemas.microsoft.com/office/drawing/2014/main" id="{86EB014B-F21D-441E-87BB-11FD19433CAF}"/>
+                <a16:creationId xmlns:a16="http://schemas.microsoft.com/office/drawing/2014/main" id="{C1E2CC17-B8C5-4CE0-9B26-C9606DB087EE}"/>
               </a:ext>
             </a:extLst>
           </p:cNvPr>
@@ -8010,7 +8020,7 @@
           <p:cNvPr id="9" name="">
             <a:extLst xmlns:a="http://schemas.openxmlformats.org/drawingml/2006/main">
               <a:ext uri="{FF2B5EF4-FFF2-40B4-BE49-F238E27FC236}">
-                <a16:creationId xmlns:a16="http://schemas.microsoft.com/office/drawing/2014/main" id="{4D86422D-F686-4D5F-947C-7A89A231EE6E}"/>
+                <a16:creationId xmlns:a16="http://schemas.microsoft.com/office/drawing/2014/main" id="{7DE38FF1-6FAB-49D5-A4A4-E6D00C2EDACE}"/>
               </a:ext>
             </a:extLst>
           </p:cNvPr>
@@ -8067,7 +8077,7 @@
           <p:cNvPr id="10" name="">
             <a:extLst xmlns:a="http://schemas.openxmlformats.org/drawingml/2006/main">
               <a:ext uri="{FF2B5EF4-FFF2-40B4-BE49-F238E27FC236}">
-                <a16:creationId xmlns:a16="http://schemas.microsoft.com/office/drawing/2014/main" id="{6B7D0A80-1DA0-4218-8ABE-083CDD653C93}"/>
+                <a16:creationId xmlns:a16="http://schemas.microsoft.com/office/drawing/2014/main" id="{B108BFC4-DE8D-4C5F-A602-1BD0B009468A}"/>
               </a:ext>
             </a:extLst>
           </p:cNvPr>
@@ -8147,7 +8157,7 @@
           <p:cNvPr id="11" name="">
             <a:extLst xmlns:a="http://schemas.openxmlformats.org/drawingml/2006/main">
               <a:ext uri="{FF2B5EF4-FFF2-40B4-BE49-F238E27FC236}">
-                <a16:creationId xmlns:a16="http://schemas.microsoft.com/office/drawing/2014/main" id="{09F83EA2-1D04-40B2-B2FE-B09B6C6C4C3F}"/>
+                <a16:creationId xmlns:a16="http://schemas.microsoft.com/office/drawing/2014/main" id="{4384744C-795E-4A49-9B42-6AEB437B9512}"/>
               </a:ext>
             </a:extLst>
           </p:cNvPr>
@@ -8227,7 +8237,7 @@
           <p:cNvPr id="12" name="">
             <a:extLst xmlns:a="http://schemas.openxmlformats.org/drawingml/2006/main">
               <a:ext uri="{FF2B5EF4-FFF2-40B4-BE49-F238E27FC236}">
-                <a16:creationId xmlns:a16="http://schemas.microsoft.com/office/drawing/2014/main" id="{B8ABB109-8423-4D4D-8A8B-D22D53FAA5AF}"/>
+                <a16:creationId xmlns:a16="http://schemas.microsoft.com/office/drawing/2014/main" id="{575C24AE-EF17-44A5-8C56-9324458F5CF0}"/>
               </a:ext>
             </a:extLst>
           </p:cNvPr>
@@ -8260,7 +8270,7 @@
           <p:cNvPr id="13" name="">
             <a:extLst xmlns:a="http://schemas.openxmlformats.org/drawingml/2006/main">
               <a:ext uri="{FF2B5EF4-FFF2-40B4-BE49-F238E27FC236}">
-                <a16:creationId xmlns:a16="http://schemas.microsoft.com/office/drawing/2014/main" id="{FC47528D-9256-476F-9878-249BB07780CE}"/>
+                <a16:creationId xmlns:a16="http://schemas.microsoft.com/office/drawing/2014/main" id="{D47C7F9C-6CD0-4E1A-9569-3ACFE6AF6B87}"/>
               </a:ext>
             </a:extLst>
           </p:cNvPr>
@@ -8317,7 +8327,7 @@
           <p:cNvPr id="14" name="">
             <a:extLst xmlns:a="http://schemas.openxmlformats.org/drawingml/2006/main">
               <a:ext uri="{FF2B5EF4-FFF2-40B4-BE49-F238E27FC236}">
-                <a16:creationId xmlns:a16="http://schemas.microsoft.com/office/drawing/2014/main" id="{C7D7E87F-B516-4E42-B262-2D508D4FF2C9}"/>
+                <a16:creationId xmlns:a16="http://schemas.microsoft.com/office/drawing/2014/main" id="{3335F5DF-BB9C-4BE7-ABE5-BA041AA5E86A}"/>
               </a:ext>
             </a:extLst>
           </p:cNvPr>
@@ -8397,7 +8407,7 @@
           <p:cNvPr id="15" name="">
             <a:extLst xmlns:a="http://schemas.openxmlformats.org/drawingml/2006/main">
               <a:ext uri="{FF2B5EF4-FFF2-40B4-BE49-F238E27FC236}">
-                <a16:creationId xmlns:a16="http://schemas.microsoft.com/office/drawing/2014/main" id="{38FAF65A-98A8-41A2-BD33-6AFC76F5C676}"/>
+                <a16:creationId xmlns:a16="http://schemas.microsoft.com/office/drawing/2014/main" id="{DD427B2C-1D15-4315-AE47-073447CE467B}"/>
               </a:ext>
             </a:extLst>
           </p:cNvPr>
@@ -8529,7 +8539,7 @@
           <p:cNvPr id="18" name="">
             <a:extLst xmlns:a="http://schemas.openxmlformats.org/drawingml/2006/main">
               <a:ext uri="{FF2B5EF4-FFF2-40B4-BE49-F238E27FC236}">
-                <a16:creationId xmlns:a16="http://schemas.microsoft.com/office/drawing/2014/main" id="{CD44B4AC-536F-4947-992F-7371DAC2BCC3}"/>
+                <a16:creationId xmlns:a16="http://schemas.microsoft.com/office/drawing/2014/main" id="{62FC3679-BAE4-4D9F-AA4F-FB921C4F84BB}"/>
               </a:ext>
             </a:extLst>
           </p:cNvPr>
@@ -8586,7 +8596,7 @@
           <p:cNvPr id="19" name="">
             <a:extLst xmlns:a="http://schemas.openxmlformats.org/drawingml/2006/main">
               <a:ext uri="{FF2B5EF4-FFF2-40B4-BE49-F238E27FC236}">
-                <a16:creationId xmlns:a16="http://schemas.microsoft.com/office/drawing/2014/main" id="{01FA73E0-9529-4C1F-A98A-73104343436F}"/>
+                <a16:creationId xmlns:a16="http://schemas.microsoft.com/office/drawing/2014/main" id="{00569DF3-F674-4007-B8DC-FBFE77A209B4}"/>
               </a:ext>
             </a:extLst>
           </p:cNvPr>
@@ -8617,7 +8627,7 @@
           <p:cNvPr id="20" name="">
             <a:extLst xmlns:a="http://schemas.openxmlformats.org/drawingml/2006/main">
               <a:ext uri="{FF2B5EF4-FFF2-40B4-BE49-F238E27FC236}">
-                <a16:creationId xmlns:a16="http://schemas.microsoft.com/office/drawing/2014/main" id="{A94C2F45-EC82-4509-802E-EF61FD943B78}"/>
+                <a16:creationId xmlns:a16="http://schemas.microsoft.com/office/drawing/2014/main" id="{2E4A15EE-4D1C-45DE-B78C-F647FA55EC3E}"/>
               </a:ext>
             </a:extLst>
           </p:cNvPr>
@@ -8672,7 +8682,7 @@
     </p:spTree>
     <p:extLst>
       <p:ext uri="{BB962C8B-B14F-4D97-AF65-F5344CB8AC3E}">
-        <p14:creationId xmlns:p14="http://schemas.microsoft.com/office/powerpoint/2010/main" val="135374681"/>
+        <p14:creationId xmlns:p14="http://schemas.microsoft.com/office/powerpoint/2010/main" val="1094194874"/>
       </p:ext>
     </p:extLst>
   </p:cSld>
@@ -8703,7 +8713,7 @@
           <p:cNvPr id="68" name="">
             <a:extLst xmlns:a="http://schemas.openxmlformats.org/drawingml/2006/main">
               <a:ext uri="{FF2B5EF4-FFF2-40B4-BE49-F238E27FC236}">
-                <a16:creationId xmlns:a16="http://schemas.microsoft.com/office/drawing/2014/main" id="{F956A45D-BA8C-40A0-87E7-83039AA8A16C}"/>
+                <a16:creationId xmlns:a16="http://schemas.microsoft.com/office/drawing/2014/main" id="{DDAAA0C6-DDB3-4165-8609-87BBEB0D8208}"/>
               </a:ext>
             </a:extLst>
           </p:cNvPr>
@@ -8760,7 +8770,7 @@
           <p:cNvPr id="2" name="">
             <a:extLst xmlns:a="http://schemas.openxmlformats.org/drawingml/2006/main">
               <a:ext uri="{FF2B5EF4-FFF2-40B4-BE49-F238E27FC236}">
-                <a16:creationId xmlns:a16="http://schemas.microsoft.com/office/drawing/2014/main" id="{5E12D6D8-4DAE-4D18-9ECD-7AF83C8E8741}"/>
+                <a16:creationId xmlns:a16="http://schemas.microsoft.com/office/drawing/2014/main" id="{1E72C741-8CEC-4ACD-84BA-8D61ACC45F34}"/>
               </a:ext>
             </a:extLst>
           </p:cNvPr>
@@ -8791,7 +8801,7 @@
           <p:cNvPr id="3" name="">
             <a:extLst xmlns:a="http://schemas.openxmlformats.org/drawingml/2006/main">
               <a:ext uri="{FF2B5EF4-FFF2-40B4-BE49-F238E27FC236}">
-                <a16:creationId xmlns:a16="http://schemas.microsoft.com/office/drawing/2014/main" id="{5B067776-706D-408F-A56B-CA7D824915CF}"/>
+                <a16:creationId xmlns:a16="http://schemas.microsoft.com/office/drawing/2014/main" id="{3019C8A7-53E6-4E0D-8ECD-BA2433991E78}"/>
               </a:ext>
             </a:extLst>
           </p:cNvPr>
@@ -8848,7 +8858,7 @@
           <p:cNvPr id="4" name="">
             <a:extLst xmlns:a="http://schemas.openxmlformats.org/drawingml/2006/main">
               <a:ext uri="{FF2B5EF4-FFF2-40B4-BE49-F238E27FC236}">
-                <a16:creationId xmlns:a16="http://schemas.microsoft.com/office/drawing/2014/main" id="{641CCB41-0326-444F-93D8-C495DB85A101}"/>
+                <a16:creationId xmlns:a16="http://schemas.microsoft.com/office/drawing/2014/main" id="{850D2980-D248-44F0-9169-B94723C53ABD}"/>
               </a:ext>
             </a:extLst>
           </p:cNvPr>
@@ -8905,7 +8915,7 @@
           <p:cNvPr id="5" name="">
             <a:extLst xmlns:a="http://schemas.openxmlformats.org/drawingml/2006/main">
               <a:ext uri="{FF2B5EF4-FFF2-40B4-BE49-F238E27FC236}">
-                <a16:creationId xmlns:a16="http://schemas.microsoft.com/office/drawing/2014/main" id="{F9693E2D-0BFF-4422-B73B-DC2B8662226E}"/>
+                <a16:creationId xmlns:a16="http://schemas.microsoft.com/office/drawing/2014/main" id="{1D32B1E1-275E-40A2-92D2-883C7E8DFA95}"/>
               </a:ext>
             </a:extLst>
           </p:cNvPr>
@@ -8938,7 +8948,7 @@
           <p:cNvPr id="6" name="">
             <a:extLst xmlns:a="http://schemas.openxmlformats.org/drawingml/2006/main">
               <a:ext uri="{FF2B5EF4-FFF2-40B4-BE49-F238E27FC236}">
-                <a16:creationId xmlns:a16="http://schemas.microsoft.com/office/drawing/2014/main" id="{700F7A59-688D-4114-81AA-E0F423A5027F}"/>
+                <a16:creationId xmlns:a16="http://schemas.microsoft.com/office/drawing/2014/main" id="{610709A0-E509-454E-BF74-C3D7C0E5177E}"/>
               </a:ext>
             </a:extLst>
           </p:cNvPr>
@@ -8995,7 +9005,7 @@
           <p:cNvPr id="7" name="">
             <a:extLst xmlns:a="http://schemas.openxmlformats.org/drawingml/2006/main">
               <a:ext uri="{FF2B5EF4-FFF2-40B4-BE49-F238E27FC236}">
-                <a16:creationId xmlns:a16="http://schemas.microsoft.com/office/drawing/2014/main" id="{ED873C37-88CF-4ABB-9430-252A2597A874}"/>
+                <a16:creationId xmlns:a16="http://schemas.microsoft.com/office/drawing/2014/main" id="{88BDCF18-F41B-4D34-B78A-E8751E3F50ED}"/>
               </a:ext>
             </a:extLst>
           </p:cNvPr>
@@ -9028,7 +9038,7 @@
           <p:cNvPr id="8" name="">
             <a:extLst xmlns:a="http://schemas.openxmlformats.org/drawingml/2006/main">
               <a:ext uri="{FF2B5EF4-FFF2-40B4-BE49-F238E27FC236}">
-                <a16:creationId xmlns:a16="http://schemas.microsoft.com/office/drawing/2014/main" id="{2A886099-0493-4E4A-AB84-1F07F5DAE926}"/>
+                <a16:creationId xmlns:a16="http://schemas.microsoft.com/office/drawing/2014/main" id="{925A8029-FCEC-458F-BFC6-66A3DF9F2A84}"/>
               </a:ext>
             </a:extLst>
           </p:cNvPr>
@@ -9085,7 +9095,7 @@
           <p:cNvPr id="9" name="">
             <a:extLst xmlns:a="http://schemas.openxmlformats.org/drawingml/2006/main">
               <a:ext uri="{FF2B5EF4-FFF2-40B4-BE49-F238E27FC236}">
-                <a16:creationId xmlns:a16="http://schemas.microsoft.com/office/drawing/2014/main" id="{0864EA53-9E0E-4173-8D89-D75B174CE3E5}"/>
+                <a16:creationId xmlns:a16="http://schemas.microsoft.com/office/drawing/2014/main" id="{4A33CFB0-47E9-4F6D-88D6-EBD5D362CB79}"/>
               </a:ext>
             </a:extLst>
           </p:cNvPr>
@@ -9118,7 +9128,7 @@
           <p:cNvPr id="10" name="">
             <a:extLst xmlns:a="http://schemas.openxmlformats.org/drawingml/2006/main">
               <a:ext uri="{FF2B5EF4-FFF2-40B4-BE49-F238E27FC236}">
-                <a16:creationId xmlns:a16="http://schemas.microsoft.com/office/drawing/2014/main" id="{C390F390-58CF-4D0B-B735-8AFB129B7339}"/>
+                <a16:creationId xmlns:a16="http://schemas.microsoft.com/office/drawing/2014/main" id="{6EE60F58-7800-423B-81E3-228922D162E4}"/>
               </a:ext>
             </a:extLst>
           </p:cNvPr>
@@ -9175,7 +9185,7 @@
           <p:cNvPr id="11" name="">
             <a:extLst xmlns:a="http://schemas.openxmlformats.org/drawingml/2006/main">
               <a:ext uri="{FF2B5EF4-FFF2-40B4-BE49-F238E27FC236}">
-                <a16:creationId xmlns:a16="http://schemas.microsoft.com/office/drawing/2014/main" id="{D37729C8-4B2B-4FE7-B4C5-A56450A6C68D}"/>
+                <a16:creationId xmlns:a16="http://schemas.microsoft.com/office/drawing/2014/main" id="{51716EF4-940E-4E91-AAEF-E4E581D6801A}"/>
               </a:ext>
             </a:extLst>
           </p:cNvPr>
@@ -9208,7 +9218,7 @@
           <p:cNvPr id="12" name="">
             <a:extLst xmlns:a="http://schemas.openxmlformats.org/drawingml/2006/main">
               <a:ext uri="{FF2B5EF4-FFF2-40B4-BE49-F238E27FC236}">
-                <a16:creationId xmlns:a16="http://schemas.microsoft.com/office/drawing/2014/main" id="{BA63EAB3-2074-4E01-A807-2E8383CD26A5}"/>
+                <a16:creationId xmlns:a16="http://schemas.microsoft.com/office/drawing/2014/main" id="{5377ACDD-BEFC-4BCC-97F7-2DD61C424EFB}"/>
               </a:ext>
             </a:extLst>
           </p:cNvPr>
@@ -9265,7 +9275,7 @@
           <p:cNvPr id="13" name="">
             <a:extLst xmlns:a="http://schemas.openxmlformats.org/drawingml/2006/main">
               <a:ext uri="{FF2B5EF4-FFF2-40B4-BE49-F238E27FC236}">
-                <a16:creationId xmlns:a16="http://schemas.microsoft.com/office/drawing/2014/main" id="{E93BF5F0-5F06-4286-B08A-7400E3956250}"/>
+                <a16:creationId xmlns:a16="http://schemas.microsoft.com/office/drawing/2014/main" id="{A046E72D-559D-40B2-9AA0-0A9735F90E50}"/>
               </a:ext>
             </a:extLst>
           </p:cNvPr>
@@ -9298,7 +9308,7 @@
           <p:cNvPr id="14" name="">
             <a:extLst xmlns:a="http://schemas.openxmlformats.org/drawingml/2006/main">
               <a:ext uri="{FF2B5EF4-FFF2-40B4-BE49-F238E27FC236}">
-                <a16:creationId xmlns:a16="http://schemas.microsoft.com/office/drawing/2014/main" id="{FEB5D73C-55AB-415A-A926-7854630AACAF}"/>
+                <a16:creationId xmlns:a16="http://schemas.microsoft.com/office/drawing/2014/main" id="{73AE2115-5386-4AB8-ADFF-DCE7BACF0F5C}"/>
               </a:ext>
             </a:extLst>
           </p:cNvPr>
@@ -9355,7 +9365,7 @@
           <p:cNvPr id="15" name="">
             <a:extLst xmlns:a="http://schemas.openxmlformats.org/drawingml/2006/main">
               <a:ext uri="{FF2B5EF4-FFF2-40B4-BE49-F238E27FC236}">
-                <a16:creationId xmlns:a16="http://schemas.microsoft.com/office/drawing/2014/main" id="{2606EDD2-2CF5-406B-BD6F-2D2414FA4A42}"/>
+                <a16:creationId xmlns:a16="http://schemas.microsoft.com/office/drawing/2014/main" id="{21CE3474-E6E1-43BA-BE6C-117C1798DB73}"/>
               </a:ext>
             </a:extLst>
           </p:cNvPr>
@@ -9388,7 +9398,7 @@
           <p:cNvPr id="16" name="">
             <a:extLst xmlns:a="http://schemas.openxmlformats.org/drawingml/2006/main">
               <a:ext uri="{FF2B5EF4-FFF2-40B4-BE49-F238E27FC236}">
-                <a16:creationId xmlns:a16="http://schemas.microsoft.com/office/drawing/2014/main" id="{4CF2C0CA-6BA4-4E91-9D0C-6376CF30353F}"/>
+                <a16:creationId xmlns:a16="http://schemas.microsoft.com/office/drawing/2014/main" id="{B27B0486-E40F-43F6-A649-63FFA51F4FFF}"/>
               </a:ext>
             </a:extLst>
           </p:cNvPr>
@@ -9445,7 +9455,7 @@
           <p:cNvPr id="17" name="">
             <a:extLst xmlns:a="http://schemas.openxmlformats.org/drawingml/2006/main">
               <a:ext uri="{FF2B5EF4-FFF2-40B4-BE49-F238E27FC236}">
-                <a16:creationId xmlns:a16="http://schemas.microsoft.com/office/drawing/2014/main" id="{DEC3530F-DE20-4B60-8C9F-C1DEDB1CF9FE}"/>
+                <a16:creationId xmlns:a16="http://schemas.microsoft.com/office/drawing/2014/main" id="{CCB72435-481F-436F-B7A0-ED68D66BB0FA}"/>
               </a:ext>
             </a:extLst>
           </p:cNvPr>
@@ -9478,7 +9488,7 @@
           <p:cNvPr id="18" name="">
             <a:extLst xmlns:a="http://schemas.openxmlformats.org/drawingml/2006/main">
               <a:ext uri="{FF2B5EF4-FFF2-40B4-BE49-F238E27FC236}">
-                <a16:creationId xmlns:a16="http://schemas.microsoft.com/office/drawing/2014/main" id="{2A3DD20A-B9BA-4D19-AC56-4B0041B27BE1}"/>
+                <a16:creationId xmlns:a16="http://schemas.microsoft.com/office/drawing/2014/main" id="{C0F13EDC-8C96-4C05-A082-4EF760A503E6}"/>
               </a:ext>
             </a:extLst>
           </p:cNvPr>
@@ -9535,7 +9545,7 @@
           <p:cNvPr id="19" name="">
             <a:extLst xmlns:a="http://schemas.openxmlformats.org/drawingml/2006/main">
               <a:ext uri="{FF2B5EF4-FFF2-40B4-BE49-F238E27FC236}">
-                <a16:creationId xmlns:a16="http://schemas.microsoft.com/office/drawing/2014/main" id="{9385FA65-85BD-40B9-93AF-C703C7F22BAF}"/>
+                <a16:creationId xmlns:a16="http://schemas.microsoft.com/office/drawing/2014/main" id="{14113902-4315-4E75-BF43-FE9A715ECAAC}"/>
               </a:ext>
             </a:extLst>
           </p:cNvPr>
@@ -9568,7 +9578,7 @@
           <p:cNvPr id="20" name="">
             <a:extLst xmlns:a="http://schemas.openxmlformats.org/drawingml/2006/main">
               <a:ext uri="{FF2B5EF4-FFF2-40B4-BE49-F238E27FC236}">
-                <a16:creationId xmlns:a16="http://schemas.microsoft.com/office/drawing/2014/main" id="{0809ED2C-C89E-46FF-BA88-B1F8CFA5C085}"/>
+                <a16:creationId xmlns:a16="http://schemas.microsoft.com/office/drawing/2014/main" id="{CB0EF4B6-202B-4586-9722-DFC4FE5D46C0}"/>
               </a:ext>
             </a:extLst>
           </p:cNvPr>
@@ -9625,7 +9635,7 @@
           <p:cNvPr id="21" name="">
             <a:extLst xmlns:a="http://schemas.openxmlformats.org/drawingml/2006/main">
               <a:ext uri="{FF2B5EF4-FFF2-40B4-BE49-F238E27FC236}">
-                <a16:creationId xmlns:a16="http://schemas.microsoft.com/office/drawing/2014/main" id="{04E3575D-4D2F-4D94-9F42-B3AC78EFA6E4}"/>
+                <a16:creationId xmlns:a16="http://schemas.microsoft.com/office/drawing/2014/main" id="{0449FC4C-1A24-410B-BECD-B8C7BE4F4356}"/>
               </a:ext>
             </a:extLst>
           </p:cNvPr>
@@ -9656,7 +9666,7 @@
           <p:cNvPr id="22" name="">
             <a:extLst xmlns:a="http://schemas.openxmlformats.org/drawingml/2006/main">
               <a:ext uri="{FF2B5EF4-FFF2-40B4-BE49-F238E27FC236}">
-                <a16:creationId xmlns:a16="http://schemas.microsoft.com/office/drawing/2014/main" id="{BC4A71F6-1918-4E92-A5FD-E0638563DB03}"/>
+                <a16:creationId xmlns:a16="http://schemas.microsoft.com/office/drawing/2014/main" id="{41502BED-4272-490F-BD6F-F3A263D7BB1B}"/>
               </a:ext>
             </a:extLst>
           </p:cNvPr>
@@ -9687,7 +9697,7 @@
           <p:cNvPr id="23" name="">
             <a:extLst xmlns:a="http://schemas.openxmlformats.org/drawingml/2006/main">
               <a:ext uri="{FF2B5EF4-FFF2-40B4-BE49-F238E27FC236}">
-                <a16:creationId xmlns:a16="http://schemas.microsoft.com/office/drawing/2014/main" id="{30170334-82BD-41ED-B153-D63805339837}"/>
+                <a16:creationId xmlns:a16="http://schemas.microsoft.com/office/drawing/2014/main" id="{7FFAF795-CD79-460B-8A78-35CFA1A24E3A}"/>
               </a:ext>
             </a:extLst>
           </p:cNvPr>
@@ -9718,7 +9728,7 @@
           <p:cNvPr id="24" name="">
             <a:extLst xmlns:a="http://schemas.openxmlformats.org/drawingml/2006/main">
               <a:ext uri="{FF2B5EF4-FFF2-40B4-BE49-F238E27FC236}">
-                <a16:creationId xmlns:a16="http://schemas.microsoft.com/office/drawing/2014/main" id="{ED09DF8C-1A22-4DB5-9B6A-B109FC7556C0}"/>
+                <a16:creationId xmlns:a16="http://schemas.microsoft.com/office/drawing/2014/main" id="{2D8B0E24-9B6E-4688-98B7-80814EFD9C36}"/>
               </a:ext>
             </a:extLst>
           </p:cNvPr>
@@ -9749,7 +9759,7 @@
           <p:cNvPr id="25" name="">
             <a:extLst xmlns:a="http://schemas.openxmlformats.org/drawingml/2006/main">
               <a:ext uri="{FF2B5EF4-FFF2-40B4-BE49-F238E27FC236}">
-                <a16:creationId xmlns:a16="http://schemas.microsoft.com/office/drawing/2014/main" id="{AC184259-2B14-45AF-A19B-B0A8323CB754}"/>
+                <a16:creationId xmlns:a16="http://schemas.microsoft.com/office/drawing/2014/main" id="{E4878F89-AC79-4B5A-B7E2-844C07593343}"/>
               </a:ext>
             </a:extLst>
           </p:cNvPr>
@@ -9780,7 +9790,7 @@
           <p:cNvPr id="26" name="">
             <a:extLst xmlns:a="http://schemas.openxmlformats.org/drawingml/2006/main">
               <a:ext uri="{FF2B5EF4-FFF2-40B4-BE49-F238E27FC236}">
-                <a16:creationId xmlns:a16="http://schemas.microsoft.com/office/drawing/2014/main" id="{801015C6-B2E5-430C-9CD3-CCD05FEA35D4}"/>
+                <a16:creationId xmlns:a16="http://schemas.microsoft.com/office/drawing/2014/main" id="{1C7D8CBD-6317-41B7-B0C0-2FCE0F065AE2}"/>
               </a:ext>
             </a:extLst>
           </p:cNvPr>
@@ -9811,7 +9821,7 @@
           <p:cNvPr id="27" name="">
             <a:extLst xmlns:a="http://schemas.openxmlformats.org/drawingml/2006/main">
               <a:ext uri="{FF2B5EF4-FFF2-40B4-BE49-F238E27FC236}">
-                <a16:creationId xmlns:a16="http://schemas.microsoft.com/office/drawing/2014/main" id="{A95A4920-7A11-4FEE-B5C5-A1249998F51C}"/>
+                <a16:creationId xmlns:a16="http://schemas.microsoft.com/office/drawing/2014/main" id="{3AEB435B-70EA-4C16-BD6A-F92E197B6DE8}"/>
               </a:ext>
             </a:extLst>
           </p:cNvPr>
@@ -9842,7 +9852,7 @@
           <p:cNvPr id="28" name="">
             <a:extLst xmlns:a="http://schemas.openxmlformats.org/drawingml/2006/main">
               <a:ext uri="{FF2B5EF4-FFF2-40B4-BE49-F238E27FC236}">
-                <a16:creationId xmlns:a16="http://schemas.microsoft.com/office/drawing/2014/main" id="{D5D28CC6-CC95-47B9-B966-B988636106FC}"/>
+                <a16:creationId xmlns:a16="http://schemas.microsoft.com/office/drawing/2014/main" id="{039DF332-C727-41E0-BDF4-55774EAC2090}"/>
               </a:ext>
             </a:extLst>
           </p:cNvPr>
@@ -9899,7 +9909,7 @@
           <p:cNvPr id="29" name="">
             <a:extLst xmlns:a="http://schemas.openxmlformats.org/drawingml/2006/main">
               <a:ext uri="{FF2B5EF4-FFF2-40B4-BE49-F238E27FC236}">
-                <a16:creationId xmlns:a16="http://schemas.microsoft.com/office/drawing/2014/main" id="{EC324559-D462-47B7-B6A9-316C168D6BA2}"/>
+                <a16:creationId xmlns:a16="http://schemas.microsoft.com/office/drawing/2014/main" id="{E7257718-12D7-4301-AA67-2D199F183365}"/>
               </a:ext>
             </a:extLst>
           </p:cNvPr>
@@ -9956,7 +9966,7 @@
           <p:cNvPr id="30" name="">
             <a:extLst xmlns:a="http://schemas.openxmlformats.org/drawingml/2006/main">
               <a:ext uri="{FF2B5EF4-FFF2-40B4-BE49-F238E27FC236}">
-                <a16:creationId xmlns:a16="http://schemas.microsoft.com/office/drawing/2014/main" id="{A2357A1C-C50A-460F-A3AC-28D944CE562E}"/>
+                <a16:creationId xmlns:a16="http://schemas.microsoft.com/office/drawing/2014/main" id="{6244509D-2B1B-400A-A717-98E270C58C87}"/>
               </a:ext>
             </a:extLst>
           </p:cNvPr>
@@ -10013,7 +10023,7 @@
           <p:cNvPr id="31" name="">
             <a:extLst xmlns:a="http://schemas.openxmlformats.org/drawingml/2006/main">
               <a:ext uri="{FF2B5EF4-FFF2-40B4-BE49-F238E27FC236}">
-                <a16:creationId xmlns:a16="http://schemas.microsoft.com/office/drawing/2014/main" id="{10E6BA4D-D953-43EC-A8BB-0128239C3F1C}"/>
+                <a16:creationId xmlns:a16="http://schemas.microsoft.com/office/drawing/2014/main" id="{0A92537E-8430-42DD-818F-492B75165A55}"/>
               </a:ext>
             </a:extLst>
           </p:cNvPr>
@@ -10070,7 +10080,7 @@
           <p:cNvPr id="32" name="">
             <a:extLst xmlns:a="http://schemas.openxmlformats.org/drawingml/2006/main">
               <a:ext uri="{FF2B5EF4-FFF2-40B4-BE49-F238E27FC236}">
-                <a16:creationId xmlns:a16="http://schemas.microsoft.com/office/drawing/2014/main" id="{F6ACB435-CB77-4AC0-B7F3-86BCA69C4B3F}"/>
+                <a16:creationId xmlns:a16="http://schemas.microsoft.com/office/drawing/2014/main" id="{B85E4242-55ED-4C31-88C7-5AC50809A36A}"/>
               </a:ext>
             </a:extLst>
           </p:cNvPr>
@@ -10127,7 +10137,7 @@
           <p:cNvPr id="33" name="">
             <a:extLst xmlns:a="http://schemas.openxmlformats.org/drawingml/2006/main">
               <a:ext uri="{FF2B5EF4-FFF2-40B4-BE49-F238E27FC236}">
-                <a16:creationId xmlns:a16="http://schemas.microsoft.com/office/drawing/2014/main" id="{0DDCABF2-21CA-41AD-A6EA-7AC850CFE9F0}"/>
+                <a16:creationId xmlns:a16="http://schemas.microsoft.com/office/drawing/2014/main" id="{6CA1F079-D723-415C-89A6-6246BD062A5C}"/>
               </a:ext>
             </a:extLst>
           </p:cNvPr>
@@ -10184,7 +10194,7 @@
           <p:cNvPr id="34" name="">
             <a:extLst xmlns:a="http://schemas.openxmlformats.org/drawingml/2006/main">
               <a:ext uri="{FF2B5EF4-FFF2-40B4-BE49-F238E27FC236}">
-                <a16:creationId xmlns:a16="http://schemas.microsoft.com/office/drawing/2014/main" id="{08F561B8-2337-4BBC-BDDA-73722D6E48BF}"/>
+                <a16:creationId xmlns:a16="http://schemas.microsoft.com/office/drawing/2014/main" id="{7FB98EBA-8D46-449C-A3FB-12087A5B2161}"/>
               </a:ext>
             </a:extLst>
           </p:cNvPr>
@@ -10241,7 +10251,7 @@
           <p:cNvPr id="35" name="">
             <a:extLst xmlns:a="http://schemas.openxmlformats.org/drawingml/2006/main">
               <a:ext uri="{FF2B5EF4-FFF2-40B4-BE49-F238E27FC236}">
-                <a16:creationId xmlns:a16="http://schemas.microsoft.com/office/drawing/2014/main" id="{79967EF0-067C-4359-AB98-51DBAF746E28}"/>
+                <a16:creationId xmlns:a16="http://schemas.microsoft.com/office/drawing/2014/main" id="{383E0E43-3E7C-41E4-9154-392F5C11E2B2}"/>
               </a:ext>
             </a:extLst>
           </p:cNvPr>
@@ -10298,7 +10308,7 @@
           <p:cNvPr id="36" name="">
             <a:extLst xmlns:a="http://schemas.openxmlformats.org/drawingml/2006/main">
               <a:ext uri="{FF2B5EF4-FFF2-40B4-BE49-F238E27FC236}">
-                <a16:creationId xmlns:a16="http://schemas.microsoft.com/office/drawing/2014/main" id="{B6F6B98C-7D65-4A54-8BE7-517DE00D1423}"/>
+                <a16:creationId xmlns:a16="http://schemas.microsoft.com/office/drawing/2014/main" id="{4258C02F-026C-4A22-B9C7-A78A3AE83DF2}"/>
               </a:ext>
             </a:extLst>
           </p:cNvPr>
@@ -10355,7 +10365,7 @@
           <p:cNvPr id="37" name="">
             <a:extLst xmlns:a="http://schemas.openxmlformats.org/drawingml/2006/main">
               <a:ext uri="{FF2B5EF4-FFF2-40B4-BE49-F238E27FC236}">
-                <a16:creationId xmlns:a16="http://schemas.microsoft.com/office/drawing/2014/main" id="{DB0F1FB4-8931-4E51-B070-C7EAD3487B48}"/>
+                <a16:creationId xmlns:a16="http://schemas.microsoft.com/office/drawing/2014/main" id="{193269A6-8E22-4A5E-93B6-ABF611FCBB73}"/>
               </a:ext>
             </a:extLst>
           </p:cNvPr>
@@ -10412,7 +10422,7 @@
           <p:cNvPr id="38" name="">
             <a:extLst xmlns:a="http://schemas.openxmlformats.org/drawingml/2006/main">
               <a:ext uri="{FF2B5EF4-FFF2-40B4-BE49-F238E27FC236}">
-                <a16:creationId xmlns:a16="http://schemas.microsoft.com/office/drawing/2014/main" id="{5972D063-CF64-42B6-B999-7AA4E3A1EDDA}"/>
+                <a16:creationId xmlns:a16="http://schemas.microsoft.com/office/drawing/2014/main" id="{EA917623-A3FC-4EF4-9131-8798B581690F}"/>
               </a:ext>
             </a:extLst>
           </p:cNvPr>
@@ -10469,7 +10479,7 @@
           <p:cNvPr id="39" name="">
             <a:extLst xmlns:a="http://schemas.openxmlformats.org/drawingml/2006/main">
               <a:ext uri="{FF2B5EF4-FFF2-40B4-BE49-F238E27FC236}">
-                <a16:creationId xmlns:a16="http://schemas.microsoft.com/office/drawing/2014/main" id="{7B1ECD5A-DF17-4D19-8C9B-BB4AB5E456A9}"/>
+                <a16:creationId xmlns:a16="http://schemas.microsoft.com/office/drawing/2014/main" id="{33365B40-EA1C-4D84-ACE6-9E4F98EB9102}"/>
               </a:ext>
             </a:extLst>
           </p:cNvPr>
@@ -10526,7 +10536,7 @@
           <p:cNvPr id="40" name="">
             <a:extLst xmlns:a="http://schemas.openxmlformats.org/drawingml/2006/main">
               <a:ext uri="{FF2B5EF4-FFF2-40B4-BE49-F238E27FC236}">
-                <a16:creationId xmlns:a16="http://schemas.microsoft.com/office/drawing/2014/main" id="{33B1B275-D272-452A-BEF1-387C14760E9A}"/>
+                <a16:creationId xmlns:a16="http://schemas.microsoft.com/office/drawing/2014/main" id="{639FEBA1-8499-4D9F-B472-80ED68059B06}"/>
               </a:ext>
             </a:extLst>
           </p:cNvPr>
@@ -10583,7 +10593,7 @@
           <p:cNvPr id="41" name="">
             <a:extLst xmlns:a="http://schemas.openxmlformats.org/drawingml/2006/main">
               <a:ext uri="{FF2B5EF4-FFF2-40B4-BE49-F238E27FC236}">
-                <a16:creationId xmlns:a16="http://schemas.microsoft.com/office/drawing/2014/main" id="{CCD25E0D-7588-416E-B912-423387754408}"/>
+                <a16:creationId xmlns:a16="http://schemas.microsoft.com/office/drawing/2014/main" id="{F3ED3325-D643-402B-912C-0F424125350B}"/>
               </a:ext>
             </a:extLst>
           </p:cNvPr>
@@ -10640,7 +10650,7 @@
           <p:cNvPr id="42" name="">
             <a:extLst xmlns:a="http://schemas.openxmlformats.org/drawingml/2006/main">
               <a:ext uri="{FF2B5EF4-FFF2-40B4-BE49-F238E27FC236}">
-                <a16:creationId xmlns:a16="http://schemas.microsoft.com/office/drawing/2014/main" id="{850EAC4C-8082-4F59-83D5-0DE7AC67BD2A}"/>
+                <a16:creationId xmlns:a16="http://schemas.microsoft.com/office/drawing/2014/main" id="{3B395B1F-F60F-477E-96AF-BA5E770BFFB1}"/>
               </a:ext>
             </a:extLst>
           </p:cNvPr>
@@ -10673,7 +10683,7 @@
           <p:cNvPr id="43" name="">
             <a:extLst xmlns:a="http://schemas.openxmlformats.org/drawingml/2006/main">
               <a:ext uri="{FF2B5EF4-FFF2-40B4-BE49-F238E27FC236}">
-                <a16:creationId xmlns:a16="http://schemas.microsoft.com/office/drawing/2014/main" id="{1197C83A-A653-4BD2-91A8-63FA6C154E01}"/>
+                <a16:creationId xmlns:a16="http://schemas.microsoft.com/office/drawing/2014/main" id="{AD8430CC-412C-4944-BDC2-31C73BF7CD40}"/>
               </a:ext>
             </a:extLst>
           </p:cNvPr>
@@ -10730,7 +10740,7 @@
           <p:cNvPr id="44" name="">
             <a:extLst xmlns:a="http://schemas.openxmlformats.org/drawingml/2006/main">
               <a:ext uri="{FF2B5EF4-FFF2-40B4-BE49-F238E27FC236}">
-                <a16:creationId xmlns:a16="http://schemas.microsoft.com/office/drawing/2014/main" id="{49492FFB-CD4C-44FD-B312-2E6E5C3849BA}"/>
+                <a16:creationId xmlns:a16="http://schemas.microsoft.com/office/drawing/2014/main" id="{F2CFA8BF-5D7E-4D19-8819-156134BE52D4}"/>
               </a:ext>
             </a:extLst>
           </p:cNvPr>
@@ -10763,7 +10773,7 @@
           <p:cNvPr id="45" name="">
             <a:extLst xmlns:a="http://schemas.openxmlformats.org/drawingml/2006/main">
               <a:ext uri="{FF2B5EF4-FFF2-40B4-BE49-F238E27FC236}">
-                <a16:creationId xmlns:a16="http://schemas.microsoft.com/office/drawing/2014/main" id="{A4018D93-B241-4DAE-B1A2-D877C3E15E60}"/>
+                <a16:creationId xmlns:a16="http://schemas.microsoft.com/office/drawing/2014/main" id="{16810AED-DDC4-4A26-8874-B92B71C0F333}"/>
               </a:ext>
             </a:extLst>
           </p:cNvPr>
@@ -10820,7 +10830,7 @@
           <p:cNvPr id="46" name="">
             <a:extLst xmlns:a="http://schemas.openxmlformats.org/drawingml/2006/main">
               <a:ext uri="{FF2B5EF4-FFF2-40B4-BE49-F238E27FC236}">
-                <a16:creationId xmlns:a16="http://schemas.microsoft.com/office/drawing/2014/main" id="{B790BC6B-7AB4-46E5-880B-AD621C02B9A0}"/>
+                <a16:creationId xmlns:a16="http://schemas.microsoft.com/office/drawing/2014/main" id="{1A165016-81CE-4B29-9816-C5C43649385C}"/>
               </a:ext>
             </a:extLst>
           </p:cNvPr>
@@ -10853,7 +10863,7 @@
           <p:cNvPr id="47" name="">
             <a:extLst xmlns:a="http://schemas.openxmlformats.org/drawingml/2006/main">
               <a:ext uri="{FF2B5EF4-FFF2-40B4-BE49-F238E27FC236}">
-                <a16:creationId xmlns:a16="http://schemas.microsoft.com/office/drawing/2014/main" id="{66DAA835-B8D6-48CF-94FB-5DCEFE6A0855}"/>
+                <a16:creationId xmlns:a16="http://schemas.microsoft.com/office/drawing/2014/main" id="{D95BA70A-446B-42EB-B456-EDF52F38E04E}"/>
               </a:ext>
             </a:extLst>
           </p:cNvPr>
@@ -10910,7 +10920,7 @@
           <p:cNvPr id="48" name="">
             <a:extLst xmlns:a="http://schemas.openxmlformats.org/drawingml/2006/main">
               <a:ext uri="{FF2B5EF4-FFF2-40B4-BE49-F238E27FC236}">
-                <a16:creationId xmlns:a16="http://schemas.microsoft.com/office/drawing/2014/main" id="{DEC6F310-2B86-4464-AF7C-6AFE59AB86E2}"/>
+                <a16:creationId xmlns:a16="http://schemas.microsoft.com/office/drawing/2014/main" id="{D0907226-60F9-4118-8097-0AEFC9254320}"/>
               </a:ext>
             </a:extLst>
           </p:cNvPr>
@@ -10941,7 +10951,7 @@
           <p:cNvPr id="49" name="">
             <a:extLst xmlns:a="http://schemas.openxmlformats.org/drawingml/2006/main">
               <a:ext uri="{FF2B5EF4-FFF2-40B4-BE49-F238E27FC236}">
-                <a16:creationId xmlns:a16="http://schemas.microsoft.com/office/drawing/2014/main" id="{D9A54453-C7BE-43C8-A172-BD12D1CFBB22}"/>
+                <a16:creationId xmlns:a16="http://schemas.microsoft.com/office/drawing/2014/main" id="{B6AE0B66-CFAE-408C-BB40-AB29744237D8}"/>
               </a:ext>
             </a:extLst>
           </p:cNvPr>
@@ -10972,7 +10982,7 @@
           <p:cNvPr id="50" name="">
             <a:extLst xmlns:a="http://schemas.openxmlformats.org/drawingml/2006/main">
               <a:ext uri="{FF2B5EF4-FFF2-40B4-BE49-F238E27FC236}">
-                <a16:creationId xmlns:a16="http://schemas.microsoft.com/office/drawing/2014/main" id="{A7310CD8-853D-4517-804E-65C4E28C9003}"/>
+                <a16:creationId xmlns:a16="http://schemas.microsoft.com/office/drawing/2014/main" id="{09EC4EB0-A93C-4705-AF50-172801D08FCB}"/>
               </a:ext>
             </a:extLst>
           </p:cNvPr>
@@ -11029,7 +11039,7 @@
           <p:cNvPr id="51" name="">
             <a:extLst xmlns:a="http://schemas.openxmlformats.org/drawingml/2006/main">
               <a:ext uri="{FF2B5EF4-FFF2-40B4-BE49-F238E27FC236}">
-                <a16:creationId xmlns:a16="http://schemas.microsoft.com/office/drawing/2014/main" id="{7EE0F90A-997C-4BFC-B07E-FB64C5BC4B24}"/>
+                <a16:creationId xmlns:a16="http://schemas.microsoft.com/office/drawing/2014/main" id="{5652CC55-B0B1-4679-BF42-6154A32425D6}"/>
               </a:ext>
             </a:extLst>
           </p:cNvPr>
@@ -11086,7 +11096,7 @@
           <p:cNvPr id="52" name="">
             <a:extLst xmlns:a="http://schemas.openxmlformats.org/drawingml/2006/main">
               <a:ext uri="{FF2B5EF4-FFF2-40B4-BE49-F238E27FC236}">
-                <a16:creationId xmlns:a16="http://schemas.microsoft.com/office/drawing/2014/main" id="{C7FA2AD6-F310-4582-9AB8-E2785CFDB88B}"/>
+                <a16:creationId xmlns:a16="http://schemas.microsoft.com/office/drawing/2014/main" id="{A65C1DDA-6E07-4F3B-9171-0F6D0598289A}"/>
               </a:ext>
             </a:extLst>
           </p:cNvPr>
@@ -11143,7 +11153,7 @@
           <p:cNvPr id="53" name="">
             <a:extLst xmlns:a="http://schemas.openxmlformats.org/drawingml/2006/main">
               <a:ext uri="{FF2B5EF4-FFF2-40B4-BE49-F238E27FC236}">
-                <a16:creationId xmlns:a16="http://schemas.microsoft.com/office/drawing/2014/main" id="{77998EAC-5546-46F9-8F53-745ADE657CB9}"/>
+                <a16:creationId xmlns:a16="http://schemas.microsoft.com/office/drawing/2014/main" id="{F7F00F5F-F130-4031-99D5-0611DF2EEAE9}"/>
               </a:ext>
             </a:extLst>
           </p:cNvPr>
@@ -11223,7 +11233,7 @@
           <p:cNvPr id="54" name="">
             <a:extLst xmlns:a="http://schemas.openxmlformats.org/drawingml/2006/main">
               <a:ext uri="{FF2B5EF4-FFF2-40B4-BE49-F238E27FC236}">
-                <a16:creationId xmlns:a16="http://schemas.microsoft.com/office/drawing/2014/main" id="{DAC9C497-8FB4-4DB9-9DD7-4FC22E076861}"/>
+                <a16:creationId xmlns:a16="http://schemas.microsoft.com/office/drawing/2014/main" id="{9C420BD5-CF01-4E9E-A657-86EA724009C1}"/>
               </a:ext>
             </a:extLst>
           </p:cNvPr>
@@ -11256,7 +11266,7 @@
           <p:cNvPr id="55" name="">
             <a:extLst xmlns:a="http://schemas.openxmlformats.org/drawingml/2006/main">
               <a:ext uri="{FF2B5EF4-FFF2-40B4-BE49-F238E27FC236}">
-                <a16:creationId xmlns:a16="http://schemas.microsoft.com/office/drawing/2014/main" id="{B8A7E032-33EB-4BB2-8A4D-9179FD0BF053}"/>
+                <a16:creationId xmlns:a16="http://schemas.microsoft.com/office/drawing/2014/main" id="{B9188751-4DC0-4681-85E7-A82149099762}"/>
               </a:ext>
             </a:extLst>
           </p:cNvPr>
@@ -11313,7 +11323,7 @@
           <p:cNvPr id="56" name="">
             <a:extLst xmlns:a="http://schemas.openxmlformats.org/drawingml/2006/main">
               <a:ext uri="{FF2B5EF4-FFF2-40B4-BE49-F238E27FC236}">
-                <a16:creationId xmlns:a16="http://schemas.microsoft.com/office/drawing/2014/main" id="{C621CAD3-5392-44A9-81CC-15CC873DFD8E}"/>
+                <a16:creationId xmlns:a16="http://schemas.microsoft.com/office/drawing/2014/main" id="{FE0CB03C-D5E6-47BF-8B9A-A923E4BC10DD}"/>
               </a:ext>
             </a:extLst>
           </p:cNvPr>
@@ -11346,7 +11356,7 @@
           <p:cNvPr id="57" name="">
             <a:extLst xmlns:a="http://schemas.openxmlformats.org/drawingml/2006/main">
               <a:ext uri="{FF2B5EF4-FFF2-40B4-BE49-F238E27FC236}">
-                <a16:creationId xmlns:a16="http://schemas.microsoft.com/office/drawing/2014/main" id="{6772B283-A7F4-45DC-B556-8AA369187C23}"/>
+                <a16:creationId xmlns:a16="http://schemas.microsoft.com/office/drawing/2014/main" id="{843EB952-557A-4B85-B092-A18C73182791}"/>
               </a:ext>
             </a:extLst>
           </p:cNvPr>
@@ -11403,7 +11413,7 @@
           <p:cNvPr id="58" name="">
             <a:extLst xmlns:a="http://schemas.openxmlformats.org/drawingml/2006/main">
               <a:ext uri="{FF2B5EF4-FFF2-40B4-BE49-F238E27FC236}">
-                <a16:creationId xmlns:a16="http://schemas.microsoft.com/office/drawing/2014/main" id="{AD385E86-7A8F-4A00-B94C-84973D632C75}"/>
+                <a16:creationId xmlns:a16="http://schemas.microsoft.com/office/drawing/2014/main" id="{FA59DAA5-5565-468B-926E-A3B9FD789FE9}"/>
               </a:ext>
             </a:extLst>
           </p:cNvPr>
@@ -11436,7 +11446,7 @@
           <p:cNvPr id="59" name="">
             <a:extLst xmlns:a="http://schemas.openxmlformats.org/drawingml/2006/main">
               <a:ext uri="{FF2B5EF4-FFF2-40B4-BE49-F238E27FC236}">
-                <a16:creationId xmlns:a16="http://schemas.microsoft.com/office/drawing/2014/main" id="{EDD1F9DD-DF89-4EA0-9C8A-15AE7115C933}"/>
+                <a16:creationId xmlns:a16="http://schemas.microsoft.com/office/drawing/2014/main" id="{A1F2D2F7-EE8A-410B-B132-063130423C7E}"/>
               </a:ext>
             </a:extLst>
           </p:cNvPr>
@@ -11493,7 +11503,7 @@
           <p:cNvPr id="60" name="">
             <a:extLst xmlns:a="http://schemas.openxmlformats.org/drawingml/2006/main">
               <a:ext uri="{FF2B5EF4-FFF2-40B4-BE49-F238E27FC236}">
-                <a16:creationId xmlns:a16="http://schemas.microsoft.com/office/drawing/2014/main" id="{97170FF0-0DB3-4888-BCCC-3EF1A3606488}"/>
+                <a16:creationId xmlns:a16="http://schemas.microsoft.com/office/drawing/2014/main" id="{E5E3841E-A28C-4FA2-871B-82B1E375DF22}"/>
               </a:ext>
             </a:extLst>
           </p:cNvPr>
@@ -11524,7 +11534,7 @@
           <p:cNvPr id="61" name="">
             <a:extLst xmlns:a="http://schemas.openxmlformats.org/drawingml/2006/main">
               <a:ext uri="{FF2B5EF4-FFF2-40B4-BE49-F238E27FC236}">
-                <a16:creationId xmlns:a16="http://schemas.microsoft.com/office/drawing/2014/main" id="{B28AFE3D-76DA-4789-8637-3BAC7781075C}"/>
+                <a16:creationId xmlns:a16="http://schemas.microsoft.com/office/drawing/2014/main" id="{DE604B14-6B27-4AAD-9B01-1CA9CC73C7FA}"/>
               </a:ext>
             </a:extLst>
           </p:cNvPr>
@@ -11555,7 +11565,7 @@
           <p:cNvPr id="62" name="">
             <a:extLst xmlns:a="http://schemas.openxmlformats.org/drawingml/2006/main">
               <a:ext uri="{FF2B5EF4-FFF2-40B4-BE49-F238E27FC236}">
-                <a16:creationId xmlns:a16="http://schemas.microsoft.com/office/drawing/2014/main" id="{B9B85F70-C6B6-4209-94D1-FCE09E9EF98E}"/>
+                <a16:creationId xmlns:a16="http://schemas.microsoft.com/office/drawing/2014/main" id="{29536A47-6C34-4F76-9619-3464625ABD25}"/>
               </a:ext>
             </a:extLst>
           </p:cNvPr>
@@ -11612,7 +11622,7 @@
           <p:cNvPr id="63" name="">
             <a:extLst xmlns:a="http://schemas.openxmlformats.org/drawingml/2006/main">
               <a:ext uri="{FF2B5EF4-FFF2-40B4-BE49-F238E27FC236}">
-                <a16:creationId xmlns:a16="http://schemas.microsoft.com/office/drawing/2014/main" id="{722D8F83-D143-4C5F-841F-3B9860046846}"/>
+                <a16:creationId xmlns:a16="http://schemas.microsoft.com/office/drawing/2014/main" id="{8A1702A8-FE80-475A-9FE7-275EE471BC07}"/>
               </a:ext>
             </a:extLst>
           </p:cNvPr>
@@ -11669,7 +11679,7 @@
           <p:cNvPr id="64" name="">
             <a:extLst xmlns:a="http://schemas.openxmlformats.org/drawingml/2006/main">
               <a:ext uri="{FF2B5EF4-FFF2-40B4-BE49-F238E27FC236}">
-                <a16:creationId xmlns:a16="http://schemas.microsoft.com/office/drawing/2014/main" id="{35E905C4-EED3-4BD2-A1BD-B840B43CFFE5}"/>
+                <a16:creationId xmlns:a16="http://schemas.microsoft.com/office/drawing/2014/main" id="{E8518028-B0C8-4ACA-BE9D-E8932F2AA8D9}"/>
               </a:ext>
             </a:extLst>
           </p:cNvPr>
@@ -11700,7 +11710,7 @@
           <p:cNvPr id="65" name="">
             <a:extLst xmlns:a="http://schemas.openxmlformats.org/drawingml/2006/main">
               <a:ext uri="{FF2B5EF4-FFF2-40B4-BE49-F238E27FC236}">
-                <a16:creationId xmlns:a16="http://schemas.microsoft.com/office/drawing/2014/main" id="{DCCCAC18-7F9A-4CBC-B0A4-005ABDC95A5A}"/>
+                <a16:creationId xmlns:a16="http://schemas.microsoft.com/office/drawing/2014/main" id="{463D5A1D-23EF-4FEF-8A38-9F994F1F4CC9}"/>
               </a:ext>
             </a:extLst>
           </p:cNvPr>
@@ -11757,7 +11767,7 @@
           <p:cNvPr id="66" name="">
             <a:extLst xmlns:a="http://schemas.openxmlformats.org/drawingml/2006/main">
               <a:ext uri="{FF2B5EF4-FFF2-40B4-BE49-F238E27FC236}">
-                <a16:creationId xmlns:a16="http://schemas.microsoft.com/office/drawing/2014/main" id="{DD52E734-784E-413B-9149-356BAFB525FA}"/>
+                <a16:creationId xmlns:a16="http://schemas.microsoft.com/office/drawing/2014/main" id="{53D108B7-EA56-4213-A80D-5AB95F158739}"/>
               </a:ext>
             </a:extLst>
           </p:cNvPr>
@@ -11814,7 +11824,7 @@
           <p:cNvPr id="67" name="">
             <a:extLst xmlns:a="http://schemas.openxmlformats.org/drawingml/2006/main">
               <a:ext uri="{FF2B5EF4-FFF2-40B4-BE49-F238E27FC236}">
-                <a16:creationId xmlns:a16="http://schemas.microsoft.com/office/drawing/2014/main" id="{499599A3-5DFE-43E3-A7CA-AD4DC6DCC281}"/>
+                <a16:creationId xmlns:a16="http://schemas.microsoft.com/office/drawing/2014/main" id="{5A96461D-7465-464F-BA64-D4E8F53D062B}"/>
               </a:ext>
             </a:extLst>
           </p:cNvPr>
@@ -11869,7 +11879,7 @@
     </p:spTree>
     <p:extLst>
       <p:ext uri="{BB962C8B-B14F-4D97-AF65-F5344CB8AC3E}">
-        <p14:creationId xmlns:p14="http://schemas.microsoft.com/office/powerpoint/2010/main" val="1488332322"/>
+        <p14:creationId xmlns:p14="http://schemas.microsoft.com/office/powerpoint/2010/main" val="2069666540"/>
       </p:ext>
     </p:extLst>
   </p:cSld>
@@ -11900,7 +11910,7 @@
           <p:cNvPr id="46" name="">
             <a:extLst xmlns:a="http://schemas.openxmlformats.org/drawingml/2006/main">
               <a:ext uri="{FF2B5EF4-FFF2-40B4-BE49-F238E27FC236}">
-                <a16:creationId xmlns:a16="http://schemas.microsoft.com/office/drawing/2014/main" id="{B1D81563-C56E-4994-9317-3CD109561BF2}"/>
+                <a16:creationId xmlns:a16="http://schemas.microsoft.com/office/drawing/2014/main" id="{BB9B2193-6489-4321-A210-A412036BA0A7}"/>
               </a:ext>
             </a:extLst>
           </p:cNvPr>
@@ -11957,7 +11967,7 @@
           <p:cNvPr id="2" name="">
             <a:extLst xmlns:a="http://schemas.openxmlformats.org/drawingml/2006/main">
               <a:ext uri="{FF2B5EF4-FFF2-40B4-BE49-F238E27FC236}">
-                <a16:creationId xmlns:a16="http://schemas.microsoft.com/office/drawing/2014/main" id="{5F69D1C0-8824-436B-92CB-9031A0FF9001}"/>
+                <a16:creationId xmlns:a16="http://schemas.microsoft.com/office/drawing/2014/main" id="{F468E70C-F617-4DA0-81A2-EA37D6A495BF}"/>
               </a:ext>
             </a:extLst>
           </p:cNvPr>
@@ -11988,7 +11998,7 @@
           <p:cNvPr id="3" name="">
             <a:extLst xmlns:a="http://schemas.openxmlformats.org/drawingml/2006/main">
               <a:ext uri="{FF2B5EF4-FFF2-40B4-BE49-F238E27FC236}">
-                <a16:creationId xmlns:a16="http://schemas.microsoft.com/office/drawing/2014/main" id="{BB1575C0-E038-4BAE-A2A2-337610BCBCA8}"/>
+                <a16:creationId xmlns:a16="http://schemas.microsoft.com/office/drawing/2014/main" id="{5A6F0219-E244-41FE-A79E-9C0502187029}"/>
               </a:ext>
             </a:extLst>
           </p:cNvPr>
@@ -12045,7 +12055,7 @@
           <p:cNvPr id="4" name="">
             <a:extLst xmlns:a="http://schemas.openxmlformats.org/drawingml/2006/main">
               <a:ext uri="{FF2B5EF4-FFF2-40B4-BE49-F238E27FC236}">
-                <a16:creationId xmlns:a16="http://schemas.microsoft.com/office/drawing/2014/main" id="{B54E7535-2535-46FC-BEA3-8A66CBCBAD9D}"/>
+                <a16:creationId xmlns:a16="http://schemas.microsoft.com/office/drawing/2014/main" id="{404667B7-73C5-4142-B290-AAD68E6AE2FD}"/>
               </a:ext>
             </a:extLst>
           </p:cNvPr>
@@ -12076,7 +12086,7 @@
           <p:cNvPr id="5" name="">
             <a:extLst xmlns:a="http://schemas.openxmlformats.org/drawingml/2006/main">
               <a:ext uri="{FF2B5EF4-FFF2-40B4-BE49-F238E27FC236}">
-                <a16:creationId xmlns:a16="http://schemas.microsoft.com/office/drawing/2014/main" id="{D5686C32-5DE8-410D-8B38-EE3453091BA4}"/>
+                <a16:creationId xmlns:a16="http://schemas.microsoft.com/office/drawing/2014/main" id="{9BB1D8E0-945F-4936-B114-1EC894880443}"/>
               </a:ext>
             </a:extLst>
           </p:cNvPr>
@@ -12123,7 +12133,7 @@
                 <a:ea typeface="DejaVu Sans"/>
                 <a:cs typeface="DejaVu Sans"/>
               </a:rPr>
-              <a:t>NBER · 2026</a:t>
+              <a:t>NBER · SEP 2026 REVISION</a:t>
             </a:r>
           </a:p>
         </p:txBody>
@@ -12133,7 +12143,7 @@
           <p:cNvPr id="6" name="">
             <a:extLst xmlns:a="http://schemas.openxmlformats.org/drawingml/2006/main">
               <a:ext uri="{FF2B5EF4-FFF2-40B4-BE49-F238E27FC236}">
-                <a16:creationId xmlns:a16="http://schemas.microsoft.com/office/drawing/2014/main" id="{7E3B7303-E251-458C-8C47-C90003CBE38D}"/>
+                <a16:creationId xmlns:a16="http://schemas.microsoft.com/office/drawing/2014/main" id="{5522FA1F-2F0E-44C7-9E6B-93BA2F03DFB9}"/>
               </a:ext>
             </a:extLst>
           </p:cNvPr>
@@ -12180,7 +12190,7 @@
                 <a:ea typeface="DejaVu Sans"/>
                 <a:cs typeface="DejaVu Sans"/>
               </a:rPr>
-              <a:t>17.3×</a:t>
+              <a:t>25.5×</a:t>
             </a:r>
           </a:p>
         </p:txBody>
@@ -12190,7 +12200,7 @@
           <p:cNvPr id="7" name="">
             <a:extLst xmlns:a="http://schemas.openxmlformats.org/drawingml/2006/main">
               <a:ext uri="{FF2B5EF4-FFF2-40B4-BE49-F238E27FC236}">
-                <a16:creationId xmlns:a16="http://schemas.microsoft.com/office/drawing/2014/main" id="{E55B1111-2273-4ACA-A020-F839B2C3C136}"/>
+                <a16:creationId xmlns:a16="http://schemas.microsoft.com/office/drawing/2014/main" id="{93C59127-4D91-46E5-B0C3-6BA98BBF8BAC}"/>
               </a:ext>
             </a:extLst>
           </p:cNvPr>
@@ -12247,7 +12257,7 @@
           <p:cNvPr id="8" name="">
             <a:extLst xmlns:a="http://schemas.openxmlformats.org/drawingml/2006/main">
               <a:ext uri="{FF2B5EF4-FFF2-40B4-BE49-F238E27FC236}">
-                <a16:creationId xmlns:a16="http://schemas.microsoft.com/office/drawing/2014/main" id="{C4E2FE82-0B48-458E-AB0B-BECCF803F4C1}"/>
+                <a16:creationId xmlns:a16="http://schemas.microsoft.com/office/drawing/2014/main" id="{7EAFE741-0C72-49AE-93D8-1315C317AE50}"/>
               </a:ext>
             </a:extLst>
           </p:cNvPr>
@@ -12294,7 +12304,7 @@
                 <a:ea typeface="DejaVu Sans"/>
                 <a:cs typeface="DejaVu Sans"/>
               </a:rPr>
-              <a:t>2.8×</a:t>
+              <a:t>3.4×</a:t>
             </a:r>
           </a:p>
         </p:txBody>
@@ -12304,7 +12314,7 @@
           <p:cNvPr id="9" name="">
             <a:extLst xmlns:a="http://schemas.openxmlformats.org/drawingml/2006/main">
               <a:ext uri="{FF2B5EF4-FFF2-40B4-BE49-F238E27FC236}">
-                <a16:creationId xmlns:a16="http://schemas.microsoft.com/office/drawing/2014/main" id="{EAAFAC70-F20D-4967-87CB-1F7D0FA46F3A}"/>
+                <a16:creationId xmlns:a16="http://schemas.microsoft.com/office/drawing/2014/main" id="{DCAAEE87-86AE-4AFB-8107-CFC7B4EC9E05}"/>
               </a:ext>
             </a:extLst>
           </p:cNvPr>
@@ -12361,7 +12371,7 @@
           <p:cNvPr id="10" name="">
             <a:extLst xmlns:a="http://schemas.openxmlformats.org/drawingml/2006/main">
               <a:ext uri="{FF2B5EF4-FFF2-40B4-BE49-F238E27FC236}">
-                <a16:creationId xmlns:a16="http://schemas.microsoft.com/office/drawing/2014/main" id="{33D1F367-6372-4271-9C8F-5C52E7E2D570}"/>
+                <a16:creationId xmlns:a16="http://schemas.microsoft.com/office/drawing/2014/main" id="{7F755B50-E5E1-43DE-A6B3-30D194C1DFF4}"/>
               </a:ext>
             </a:extLst>
           </p:cNvPr>
@@ -12418,7 +12428,7 @@
           <p:cNvPr id="11" name="">
             <a:extLst xmlns:a="http://schemas.openxmlformats.org/drawingml/2006/main">
               <a:ext uri="{FF2B5EF4-FFF2-40B4-BE49-F238E27FC236}">
-                <a16:creationId xmlns:a16="http://schemas.microsoft.com/office/drawing/2014/main" id="{AAB23C4D-2149-4874-B022-93FD796F2C03}"/>
+                <a16:creationId xmlns:a16="http://schemas.microsoft.com/office/drawing/2014/main" id="{066B57FD-94FA-4B02-BFF6-91C4D2BE0D53}"/>
               </a:ext>
             </a:extLst>
           </p:cNvPr>
@@ -12475,7 +12485,7 @@
           <p:cNvPr id="12" name="">
             <a:extLst xmlns:a="http://schemas.openxmlformats.org/drawingml/2006/main">
               <a:ext uri="{FF2B5EF4-FFF2-40B4-BE49-F238E27FC236}">
-                <a16:creationId xmlns:a16="http://schemas.microsoft.com/office/drawing/2014/main" id="{74610405-5208-4155-A752-F9A15FF9FFD7}"/>
+                <a16:creationId xmlns:a16="http://schemas.microsoft.com/office/drawing/2014/main" id="{1222BDCB-2B12-485A-9F90-441C8224DDA5}"/>
               </a:ext>
             </a:extLst>
           </p:cNvPr>
@@ -12532,7 +12542,7 @@
           <p:cNvPr id="13" name="">
             <a:extLst xmlns:a="http://schemas.openxmlformats.org/drawingml/2006/main">
               <a:ext uri="{FF2B5EF4-FFF2-40B4-BE49-F238E27FC236}">
-                <a16:creationId xmlns:a16="http://schemas.microsoft.com/office/drawing/2014/main" id="{79D66AD7-DC0A-4027-BC9E-63B098EC55BD}"/>
+                <a16:creationId xmlns:a16="http://schemas.microsoft.com/office/drawing/2014/main" id="{44FBE73A-42A4-4B4C-80B3-B57D2DA6C9C0}"/>
               </a:ext>
             </a:extLst>
           </p:cNvPr>
@@ -12579,7 +12589,7 @@
                 <a:ea typeface="DejaVu Sans"/>
                 <a:cs typeface="DejaVu Sans"/>
               </a:rPr>
-              <a:t>Changed LOC = additions + deletions.</a:t>
+              <a:t>Fig. 1 rounded; LOC = additions + deletions.</a:t>
             </a:r>
           </a:p>
           <a:p xmlns:a="http://schemas.openxmlformats.org/drawingml/2006/main">
@@ -12612,7 +12622,7 @@
           <p:cNvPr id="14" name="">
             <a:extLst xmlns:a="http://schemas.openxmlformats.org/drawingml/2006/main">
               <a:ext uri="{FF2B5EF4-FFF2-40B4-BE49-F238E27FC236}">
-                <a16:creationId xmlns:a16="http://schemas.microsoft.com/office/drawing/2014/main" id="{ECC5F0A4-9678-4020-993F-EA54635E7004}"/>
+                <a16:creationId xmlns:a16="http://schemas.microsoft.com/office/drawing/2014/main" id="{FD9D0A36-67B1-461C-BF64-B9B54DCFC5E2}"/>
               </a:ext>
             </a:extLst>
           </p:cNvPr>
@@ -12659,7 +12669,7 @@
                 <a:ea typeface="DejaVu Sans"/>
                 <a:cs typeface="DejaVu Sans"/>
               </a:rPr>
-              <a:t>More apps. Aggregate usage</a:t>
+              <a:t>More apps. Usage does not</a:t>
             </a:r>
           </a:p>
           <a:p xmlns:a="http://schemas.openxmlformats.org/drawingml/2006/main">
@@ -12682,7 +12692,7 @@
                 <a:ea typeface="DejaVu Sans"/>
                 <a:cs typeface="DejaVu Sans"/>
               </a:rPr>
-              <a:t>flat or lower in these cohorts.</a:t>
+              <a:t>keep pace with new releases.</a:t>
             </a:r>
           </a:p>
         </p:txBody>
@@ -12692,7 +12702,7 @@
           <p:cNvPr id="15" name="">
             <a:extLst xmlns:a="http://schemas.openxmlformats.org/drawingml/2006/main">
               <a:ext uri="{FF2B5EF4-FFF2-40B4-BE49-F238E27FC236}">
-                <a16:creationId xmlns:a16="http://schemas.microsoft.com/office/drawing/2014/main" id="{2A0806F9-E9F3-482E-A58F-551E7775C734}"/>
+                <a16:creationId xmlns:a16="http://schemas.microsoft.com/office/drawing/2014/main" id="{392CCC39-9E5D-4FCE-9E68-EB7497DBD4C0}"/>
               </a:ext>
             </a:extLst>
           </p:cNvPr>
@@ -12749,7 +12759,7 @@
           <p:cNvPr id="16" name="">
             <a:extLst xmlns:a="http://schemas.openxmlformats.org/drawingml/2006/main">
               <a:ext uri="{FF2B5EF4-FFF2-40B4-BE49-F238E27FC236}">
-                <a16:creationId xmlns:a16="http://schemas.microsoft.com/office/drawing/2014/main" id="{1B989595-E2A1-46AF-9E23-57C27DEE04EA}"/>
+                <a16:creationId xmlns:a16="http://schemas.microsoft.com/office/drawing/2014/main" id="{87210894-86B9-4629-A82C-166C70D12AD7}"/>
               </a:ext>
             </a:extLst>
           </p:cNvPr>
@@ -12796,7 +12806,7 @@
                 <a:ea typeface="DejaVu Sans"/>
                 <a:cs typeface="DejaVu Sans"/>
               </a:rPr>
-              <a:t>79% → 86%</a:t>
+              <a:t>≈78% → 87%</a:t>
             </a:r>
           </a:p>
         </p:txBody>
@@ -12806,7 +12816,7 @@
           <p:cNvPr id="17" name="">
             <a:extLst xmlns:a="http://schemas.openxmlformats.org/drawingml/2006/main">
               <a:ext uri="{FF2B5EF4-FFF2-40B4-BE49-F238E27FC236}">
-                <a16:creationId xmlns:a16="http://schemas.microsoft.com/office/drawing/2014/main" id="{2809B229-0342-4787-AFF5-C3E88558960C}"/>
+                <a16:creationId xmlns:a16="http://schemas.microsoft.com/office/drawing/2014/main" id="{97AF7967-F81F-407A-BE09-2B0A32DBC865}"/>
               </a:ext>
             </a:extLst>
           </p:cNvPr>
@@ -12863,7 +12873,7 @@
           <p:cNvPr id="18" name="">
             <a:extLst xmlns:a="http://schemas.openxmlformats.org/drawingml/2006/main">
               <a:ext uri="{FF2B5EF4-FFF2-40B4-BE49-F238E27FC236}">
-                <a16:creationId xmlns:a16="http://schemas.microsoft.com/office/drawing/2014/main" id="{B1951F57-24C8-40C4-90CA-655A6B934851}"/>
+                <a16:creationId xmlns:a16="http://schemas.microsoft.com/office/drawing/2014/main" id="{75E750E9-D00C-4BBD-A60E-72FD4FACD6F6}"/>
               </a:ext>
             </a:extLst>
           </p:cNvPr>
@@ -12910,7 +12920,7 @@
                 <a:ea typeface="DejaVu Sans"/>
                 <a:cs typeface="DejaVu Sans"/>
               </a:rPr>
-              <a:t>18% → 31%</a:t>
+              <a:t>19% → 33%</a:t>
             </a:r>
           </a:p>
         </p:txBody>
@@ -12920,7 +12930,7 @@
           <p:cNvPr id="19" name="">
             <a:extLst xmlns:a="http://schemas.openxmlformats.org/drawingml/2006/main">
               <a:ext uri="{FF2B5EF4-FFF2-40B4-BE49-F238E27FC236}">
-                <a16:creationId xmlns:a16="http://schemas.microsoft.com/office/drawing/2014/main" id="{EAA2BF86-A236-4623-8D6D-DBF35C24F05D}"/>
+                <a16:creationId xmlns:a16="http://schemas.microsoft.com/office/drawing/2014/main" id="{1895FB02-CC91-4A82-B5A7-812A5252577A}"/>
               </a:ext>
             </a:extLst>
           </p:cNvPr>
@@ -12967,7 +12977,7 @@
                 <a:ea typeface="DejaVu Sans"/>
                 <a:cs typeface="DejaVu Sans"/>
               </a:rPr>
-              <a:t>New cohorts; first 3 months. Usage proxies.</a:t>
+              <a:t>Jan 2025 → Apr 2026; first 3 months.</a:t>
             </a:r>
           </a:p>
         </p:txBody>
@@ -12977,7 +12987,7 @@
           <p:cNvPr id="20" name="">
             <a:extLst xmlns:a="http://schemas.openxmlformats.org/drawingml/2006/main">
               <a:ext uri="{FF2B5EF4-FFF2-40B4-BE49-F238E27FC236}">
-                <a16:creationId xmlns:a16="http://schemas.microsoft.com/office/drawing/2014/main" id="{FF4E2760-DD67-4197-8D3C-320B2A1CD8F4}"/>
+                <a16:creationId xmlns:a16="http://schemas.microsoft.com/office/drawing/2014/main" id="{DC5A7E1A-9D32-4AF0-A702-FC0B63987E74}"/>
               </a:ext>
             </a:extLst>
           </p:cNvPr>
@@ -13034,7 +13044,7 @@
           <p:cNvPr id="21" name="">
             <a:extLst xmlns:a="http://schemas.openxmlformats.org/drawingml/2006/main">
               <a:ext uri="{FF2B5EF4-FFF2-40B4-BE49-F238E27FC236}">
-                <a16:creationId xmlns:a16="http://schemas.microsoft.com/office/drawing/2014/main" id="{C8BD9B78-4E4A-4306-B545-598B7F516611}"/>
+                <a16:creationId xmlns:a16="http://schemas.microsoft.com/office/drawing/2014/main" id="{DEF76610-66C0-441F-B0C1-88DD2571DDF7}"/>
               </a:ext>
             </a:extLst>
           </p:cNvPr>
@@ -13091,7 +13101,7 @@
           <p:cNvPr id="22" name="">
             <a:extLst xmlns:a="http://schemas.openxmlformats.org/drawingml/2006/main">
               <a:ext uri="{FF2B5EF4-FFF2-40B4-BE49-F238E27FC236}">
-                <a16:creationId xmlns:a16="http://schemas.microsoft.com/office/drawing/2014/main" id="{DE0EDBA4-0BE2-4AB2-A7FA-DC8643EF7BA7}"/>
+                <a16:creationId xmlns:a16="http://schemas.microsoft.com/office/drawing/2014/main" id="{F516D23C-2C4B-4BDE-815D-9707B51DB0D2}"/>
               </a:ext>
             </a:extLst>
           </p:cNvPr>
@@ -13148,7 +13158,7 @@
           <p:cNvPr id="23" name="">
             <a:extLst xmlns:a="http://schemas.openxmlformats.org/drawingml/2006/main">
               <a:ext uri="{FF2B5EF4-FFF2-40B4-BE49-F238E27FC236}">
-                <a16:creationId xmlns:a16="http://schemas.microsoft.com/office/drawing/2014/main" id="{C5E770D1-9A1B-490A-84F2-4EA44D681EBC}"/>
+                <a16:creationId xmlns:a16="http://schemas.microsoft.com/office/drawing/2014/main" id="{62675F50-C290-4D11-B3EE-3D8AECF37D87}"/>
               </a:ext>
             </a:extLst>
           </p:cNvPr>
@@ -13205,7 +13215,7 @@
           <p:cNvPr id="24" name="">
             <a:extLst xmlns:a="http://schemas.openxmlformats.org/drawingml/2006/main">
               <a:ext uri="{FF2B5EF4-FFF2-40B4-BE49-F238E27FC236}">
-                <a16:creationId xmlns:a16="http://schemas.microsoft.com/office/drawing/2014/main" id="{45574296-6797-45A6-BA85-723189B5A95E}"/>
+                <a16:creationId xmlns:a16="http://schemas.microsoft.com/office/drawing/2014/main" id="{9EEF1418-1BCC-4961-B3F0-CF14E22B2C04}"/>
               </a:ext>
             </a:extLst>
           </p:cNvPr>
@@ -13262,7 +13272,7 @@
           <p:cNvPr id="25" name="">
             <a:extLst xmlns:a="http://schemas.openxmlformats.org/drawingml/2006/main">
               <a:ext uri="{FF2B5EF4-FFF2-40B4-BE49-F238E27FC236}">
-                <a16:creationId xmlns:a16="http://schemas.microsoft.com/office/drawing/2014/main" id="{D633509B-A5EC-4B09-BA03-93AB84CD0E8A}"/>
+                <a16:creationId xmlns:a16="http://schemas.microsoft.com/office/drawing/2014/main" id="{10E11E63-EFA1-405F-A56F-B5753CAE9386}"/>
               </a:ext>
             </a:extLst>
           </p:cNvPr>
@@ -13342,7 +13352,7 @@
           <p:cNvPr id="26" name="">
             <a:extLst xmlns:a="http://schemas.openxmlformats.org/drawingml/2006/main">
               <a:ext uri="{FF2B5EF4-FFF2-40B4-BE49-F238E27FC236}">
-                <a16:creationId xmlns:a16="http://schemas.microsoft.com/office/drawing/2014/main" id="{6737E127-2563-4C59-821E-D369CF411BF3}"/>
+                <a16:creationId xmlns:a16="http://schemas.microsoft.com/office/drawing/2014/main" id="{4A32CBA8-2143-4A5A-B3B1-601478FF95E2}"/>
               </a:ext>
             </a:extLst>
           </p:cNvPr>
@@ -13389,7 +13399,7 @@
                 <a:ea typeface="DejaVu Sans"/>
                 <a:cs typeface="DejaVu Sans"/>
               </a:rPr>
-              <a:t>Report improvement: &gt;80% productivity; 59% code quality.</a:t>
+              <a:t>Respondents reporting improvement: &gt;80% productivity; 59% quality.</a:t>
             </a:r>
           </a:p>
         </p:txBody>
@@ -13399,7 +13409,7 @@
           <p:cNvPr id="27" name="">
             <a:extLst xmlns:a="http://schemas.openxmlformats.org/drawingml/2006/main">
               <a:ext uri="{FF2B5EF4-FFF2-40B4-BE49-F238E27FC236}">
-                <a16:creationId xmlns:a16="http://schemas.microsoft.com/office/drawing/2014/main" id="{BDB8E301-D8B8-4C2D-A9D3-F3049DE5E187}"/>
+                <a16:creationId xmlns:a16="http://schemas.microsoft.com/office/drawing/2014/main" id="{989B8691-522A-4F97-A61B-256205E6E7AB}"/>
               </a:ext>
             </a:extLst>
           </p:cNvPr>
@@ -13430,7 +13440,7 @@
           <p:cNvPr id="28" name="">
             <a:extLst xmlns:a="http://schemas.openxmlformats.org/drawingml/2006/main">
               <a:ext uri="{FF2B5EF4-FFF2-40B4-BE49-F238E27FC236}">
-                <a16:creationId xmlns:a16="http://schemas.microsoft.com/office/drawing/2014/main" id="{BD30590A-5D4F-41AB-8D3A-033C47635C24}"/>
+                <a16:creationId xmlns:a16="http://schemas.microsoft.com/office/drawing/2014/main" id="{AAD44F22-40C1-44EA-9F07-74FDD9790672}"/>
               </a:ext>
             </a:extLst>
           </p:cNvPr>
@@ -13477,7 +13487,7 @@
                 <a:ea typeface="DejaVu Sans"/>
                 <a:cs typeface="DejaVu Sans"/>
               </a:rPr>
-              <a:t>GITCLEAR · JUN 2026</a:t>
+              <a:t>GITCLEAR · 2026 SUMMARY</a:t>
             </a:r>
           </a:p>
         </p:txBody>
@@ -13487,7 +13497,7 @@
           <p:cNvPr id="29" name="">
             <a:extLst xmlns:a="http://schemas.openxmlformats.org/drawingml/2006/main">
               <a:ext uri="{FF2B5EF4-FFF2-40B4-BE49-F238E27FC236}">
-                <a16:creationId xmlns:a16="http://schemas.microsoft.com/office/drawing/2014/main" id="{A153B523-162D-415D-AD60-A82BAD997874}"/>
+                <a16:creationId xmlns:a16="http://schemas.microsoft.com/office/drawing/2014/main" id="{72382F8D-1922-4F54-9FAC-EBCC641BB3E9}"/>
               </a:ext>
             </a:extLst>
           </p:cNvPr>
@@ -13544,7 +13554,7 @@
           <p:cNvPr id="30" name="">
             <a:extLst xmlns:a="http://schemas.openxmlformats.org/drawingml/2006/main">
               <a:ext uri="{FF2B5EF4-FFF2-40B4-BE49-F238E27FC236}">
-                <a16:creationId xmlns:a16="http://schemas.microsoft.com/office/drawing/2014/main" id="{E2E4014A-300B-4757-B6B8-3FE4BD111208}"/>
+                <a16:creationId xmlns:a16="http://schemas.microsoft.com/office/drawing/2014/main" id="{A30D65EF-C32B-4498-A988-65C4252F5251}"/>
               </a:ext>
             </a:extLst>
           </p:cNvPr>
@@ -13601,7 +13611,7 @@
           <p:cNvPr id="31" name="">
             <a:extLst xmlns:a="http://schemas.openxmlformats.org/drawingml/2006/main">
               <a:ext uri="{FF2B5EF4-FFF2-40B4-BE49-F238E27FC236}">
-                <a16:creationId xmlns:a16="http://schemas.microsoft.com/office/drawing/2014/main" id="{F066C3A5-4C27-455B-95B2-02A3962CCDFF}"/>
+                <a16:creationId xmlns:a16="http://schemas.microsoft.com/office/drawing/2014/main" id="{ADBC052E-80EA-4910-9A4A-63D55AC2D449}"/>
               </a:ext>
             </a:extLst>
           </p:cNvPr>
@@ -13658,7 +13668,7 @@
           <p:cNvPr id="32" name="">
             <a:extLst xmlns:a="http://schemas.openxmlformats.org/drawingml/2006/main">
               <a:ext uri="{FF2B5EF4-FFF2-40B4-BE49-F238E27FC236}">
-                <a16:creationId xmlns:a16="http://schemas.microsoft.com/office/drawing/2014/main" id="{0477650C-DE1A-4876-B1BA-273CBED17300}"/>
+                <a16:creationId xmlns:a16="http://schemas.microsoft.com/office/drawing/2014/main" id="{F8045808-0D1F-43B1-9D5C-482239D462A1}"/>
               </a:ext>
             </a:extLst>
           </p:cNvPr>
@@ -13705,7 +13715,7 @@
                 <a:ea typeface="DejaVu Sans"/>
                 <a:cs typeface="DejaVu Sans"/>
               </a:rPr>
-              <a:t>−35%</a:t>
+              <a:t>343 → 223</a:t>
             </a:r>
           </a:p>
         </p:txBody>
@@ -13715,7 +13725,7 @@
           <p:cNvPr id="33" name="">
             <a:extLst xmlns:a="http://schemas.openxmlformats.org/drawingml/2006/main">
               <a:ext uri="{FF2B5EF4-FFF2-40B4-BE49-F238E27FC236}">
-                <a16:creationId xmlns:a16="http://schemas.microsoft.com/office/drawing/2014/main" id="{F1EA8228-E56C-4887-B69B-1C77F07B523C}"/>
+                <a16:creationId xmlns:a16="http://schemas.microsoft.com/office/drawing/2014/main" id="{0FA0E384-4A87-49AB-9FBB-DD4AB4BCB82C}"/>
               </a:ext>
             </a:extLst>
           </p:cNvPr>
@@ -13772,7 +13782,7 @@
           <p:cNvPr id="34" name="">
             <a:extLst xmlns:a="http://schemas.openxmlformats.org/drawingml/2006/main">
               <a:ext uri="{FF2B5EF4-FFF2-40B4-BE49-F238E27FC236}">
-                <a16:creationId xmlns:a16="http://schemas.microsoft.com/office/drawing/2014/main" id="{4D34EF9B-9E79-47EA-846E-A9F0600FB797}"/>
+                <a16:creationId xmlns:a16="http://schemas.microsoft.com/office/drawing/2014/main" id="{7670474E-4F3A-49EE-A502-72D61D8EDD33}"/>
               </a:ext>
             </a:extLst>
           </p:cNvPr>
@@ -13819,7 +13829,7 @@
                 <a:ea typeface="DejaVu Sans"/>
                 <a:cs typeface="DejaVu Sans"/>
               </a:rPr>
-              <a:t>+81%</a:t>
+              <a:t>≈+81%</a:t>
             </a:r>
           </a:p>
         </p:txBody>
@@ -13829,7 +13839,7 @@
           <p:cNvPr id="35" name="">
             <a:extLst xmlns:a="http://schemas.openxmlformats.org/drawingml/2006/main">
               <a:ext uri="{FF2B5EF4-FFF2-40B4-BE49-F238E27FC236}">
-                <a16:creationId xmlns:a16="http://schemas.microsoft.com/office/drawing/2014/main" id="{45296008-26A7-4155-B9F1-09148DB061AA}"/>
+                <a16:creationId xmlns:a16="http://schemas.microsoft.com/office/drawing/2014/main" id="{A89B2D42-73E7-4543-9190-8760070A3927}"/>
               </a:ext>
             </a:extLst>
           </p:cNvPr>
@@ -13876,7 +13886,7 @@
                 <a:ea typeface="DejaVu Sans"/>
                 <a:cs typeface="DejaVu Sans"/>
               </a:rPr>
-              <a:t>Two-week code churn</a:t>
+              <a:t>Two-week churn (reported)</a:t>
             </a:r>
           </a:p>
         </p:txBody>
@@ -13886,7 +13896,7 @@
           <p:cNvPr id="36" name="">
             <a:extLst xmlns:a="http://schemas.openxmlformats.org/drawingml/2006/main">
               <a:ext uri="{FF2B5EF4-FFF2-40B4-BE49-F238E27FC236}">
-                <a16:creationId xmlns:a16="http://schemas.microsoft.com/office/drawing/2014/main" id="{EE7BC32F-05BA-49AE-934F-48B241E422CD}"/>
+                <a16:creationId xmlns:a16="http://schemas.microsoft.com/office/drawing/2014/main" id="{35175BBE-4848-4A31-8A25-C4C1D4FCB566}"/>
               </a:ext>
             </a:extLst>
           </p:cNvPr>
@@ -13943,7 +13953,7 @@
           <p:cNvPr id="37" name="">
             <a:extLst xmlns:a="http://schemas.openxmlformats.org/drawingml/2006/main">
               <a:ext uri="{FF2B5EF4-FFF2-40B4-BE49-F238E27FC236}">
-                <a16:creationId xmlns:a16="http://schemas.microsoft.com/office/drawing/2014/main" id="{8A54CEB0-E879-47EF-B136-B59A3A3A0BDC}"/>
+                <a16:creationId xmlns:a16="http://schemas.microsoft.com/office/drawing/2014/main" id="{581260C8-2621-41CE-B432-95667BF38215}"/>
               </a:ext>
             </a:extLst>
           </p:cNvPr>
@@ -13990,7 +14000,7 @@
                 <a:ea typeface="DejaVu Sans"/>
                 <a:cs typeface="DejaVu Sans"/>
               </a:rPr>
-              <a:t>Observed code proxies; not a causal AI estimate.</a:t>
+              <a:t>2023 → YTD 2026; churn baseline unstated. Observational.</a:t>
             </a:r>
           </a:p>
         </p:txBody>
@@ -14000,7 +14010,7 @@
           <p:cNvPr id="38" name="">
             <a:extLst xmlns:a="http://schemas.openxmlformats.org/drawingml/2006/main">
               <a:ext uri="{FF2B5EF4-FFF2-40B4-BE49-F238E27FC236}">
-                <a16:creationId xmlns:a16="http://schemas.microsoft.com/office/drawing/2014/main" id="{D6749B61-53B3-4D14-95DA-7B3C870817EF}"/>
+                <a16:creationId xmlns:a16="http://schemas.microsoft.com/office/drawing/2014/main" id="{70EAA8D8-0E28-4141-A9B7-39223DB2860E}"/>
               </a:ext>
             </a:extLst>
           </p:cNvPr>
@@ -14031,7 +14041,7 @@
           <p:cNvPr id="39" name="">
             <a:extLst xmlns:a="http://schemas.openxmlformats.org/drawingml/2006/main">
               <a:ext uri="{FF2B5EF4-FFF2-40B4-BE49-F238E27FC236}">
-                <a16:creationId xmlns:a16="http://schemas.microsoft.com/office/drawing/2014/main" id="{BFD6C9D1-6732-494A-9F9B-2E7BC67EEAF0}"/>
+                <a16:creationId xmlns:a16="http://schemas.microsoft.com/office/drawing/2014/main" id="{5FAA1CDC-F1BA-43A7-8507-C53CC5715A71}"/>
               </a:ext>
             </a:extLst>
           </p:cNvPr>
@@ -14088,7 +14098,7 @@
           <p:cNvPr id="40" name="">
             <a:extLst xmlns:a="http://schemas.openxmlformats.org/drawingml/2006/main">
               <a:ext uri="{FF2B5EF4-FFF2-40B4-BE49-F238E27FC236}">
-                <a16:creationId xmlns:a16="http://schemas.microsoft.com/office/drawing/2014/main" id="{ACE93ABC-0C05-479E-8A43-8F55844EE14B}"/>
+                <a16:creationId xmlns:a16="http://schemas.microsoft.com/office/drawing/2014/main" id="{E265188D-167F-4CAF-A128-BDE1D0A417C0}"/>
               </a:ext>
             </a:extLst>
           </p:cNvPr>
@@ -14145,7 +14155,7 @@
           <p:cNvPr id="41" name="">
             <a:extLst xmlns:a="http://schemas.openxmlformats.org/drawingml/2006/main">
               <a:ext uri="{FF2B5EF4-FFF2-40B4-BE49-F238E27FC236}">
-                <a16:creationId xmlns:a16="http://schemas.microsoft.com/office/drawing/2014/main" id="{F6682437-B164-4B62-B29E-3B2082A5853B}"/>
+                <a16:creationId xmlns:a16="http://schemas.microsoft.com/office/drawing/2014/main" id="{C91D6A3F-F158-4518-9241-C78A10F914DB}"/>
               </a:ext>
             </a:extLst>
           </p:cNvPr>
@@ -14192,7 +14202,7 @@
                 <a:ea typeface="DejaVu Sans"/>
                 <a:cs typeface="DejaVu Sans"/>
               </a:rPr>
-              <a:t>Median self-reported work value; survey, not causal uplift</a:t>
+              <a:t>Medians across 3 questions; self-reported, not causal.</a:t>
             </a:r>
           </a:p>
         </p:txBody>
@@ -14202,7 +14212,7 @@
           <p:cNvPr id="42" name="">
             <a:extLst xmlns:a="http://schemas.openxmlformats.org/drawingml/2006/main">
               <a:ext uri="{FF2B5EF4-FFF2-40B4-BE49-F238E27FC236}">
-                <a16:creationId xmlns:a16="http://schemas.microsoft.com/office/drawing/2014/main" id="{672C4459-6FC4-40DC-AE24-3A8BD6804970}"/>
+                <a16:creationId xmlns:a16="http://schemas.microsoft.com/office/drawing/2014/main" id="{A2DBB079-3373-4598-B4F2-798AD7B06BBD}"/>
               </a:ext>
             </a:extLst>
           </p:cNvPr>
@@ -14249,7 +14259,7 @@
                 <a:ea typeface="DejaVu Sans"/>
                 <a:cs typeface="DejaVu Sans"/>
               </a:rPr>
-              <a:t>XU + AGARWAL · 2026</a:t>
+              <a:t>AGARWAL · JAN 2026</a:t>
             </a:r>
           </a:p>
         </p:txBody>
@@ -14259,7 +14269,7 @@
           <p:cNvPr id="43" name="">
             <a:extLst xmlns:a="http://schemas.openxmlformats.org/drawingml/2006/main">
               <a:ext uri="{FF2B5EF4-FFF2-40B4-BE49-F238E27FC236}">
-                <a16:creationId xmlns:a16="http://schemas.microsoft.com/office/drawing/2014/main" id="{2F3D3845-F581-4862-A39E-0338D98CBFF7}"/>
+                <a16:creationId xmlns:a16="http://schemas.microsoft.com/office/drawing/2014/main" id="{74A04938-1C68-4948-9CB5-BE2824401D0D}"/>
               </a:ext>
             </a:extLst>
           </p:cNvPr>
@@ -14288,25 +14298,25 @@
           <a:lstStyle xmlns:a="http://schemas.openxmlformats.org/drawingml/2006/main"/>
           <a:p xmlns:a="http://schemas.openxmlformats.org/drawingml/2006/main">
             <a:pPr algn="r">
-              <a:defRPr sz="1725" b="1">
-                <a:solidFill>
-                  <a:srgbClr val="F4F7FA"/>
-                </a:solidFill>
-                <a:latin typeface="DejaVu Sans"/>
-                <a:ea typeface="DejaVu Sans"/>
-                <a:cs typeface="DejaVu Sans"/>
-              </a:defRPr>
-            </a:pPr>
-            <a:r>
-              <a:rPr sz="1725" b="1">
-                <a:solidFill>
-                  <a:srgbClr val="F4F7FA"/>
-                </a:solidFill>
-                <a:latin typeface="DejaVu Sans"/>
-                <a:ea typeface="DejaVu Sans"/>
-                <a:cs typeface="DejaVu Sans"/>
-              </a:rPr>
-              <a:t>+35% / +43%</a:t>
+              <a:defRPr sz="1575" b="1">
+                <a:solidFill>
+                  <a:srgbClr val="F4F7FA"/>
+                </a:solidFill>
+                <a:latin typeface="DejaVu Sans"/>
+                <a:ea typeface="DejaVu Sans"/>
+                <a:cs typeface="DejaVu Sans"/>
+              </a:defRPr>
+            </a:pPr>
+            <a:r>
+              <a:rPr sz="1575" b="1">
+                <a:solidFill>
+                  <a:srgbClr val="F4F7FA"/>
+                </a:solidFill>
+                <a:latin typeface="DejaVu Sans"/>
+                <a:ea typeface="DejaVu Sans"/>
+                <a:cs typeface="DejaVu Sans"/>
+              </a:rPr>
+              <a:t>+34.85% / +42.87%</a:t>
             </a:r>
           </a:p>
         </p:txBody>
@@ -14316,7 +14326,7 @@
           <p:cNvPr id="44" name="">
             <a:extLst xmlns:a="http://schemas.openxmlformats.org/drawingml/2006/main">
               <a:ext uri="{FF2B5EF4-FFF2-40B4-BE49-F238E27FC236}">
-                <a16:creationId xmlns:a16="http://schemas.microsoft.com/office/drawing/2014/main" id="{10870B62-C1A4-47BC-8B6F-540A349C6717}"/>
+                <a16:creationId xmlns:a16="http://schemas.microsoft.com/office/drawing/2014/main" id="{762B7AF6-4109-44A5-B5C6-774F9017B577}"/>
               </a:ext>
             </a:extLst>
           </p:cNvPr>
@@ -14363,7 +14373,7 @@
                 <a:ea typeface="DejaVu Sans"/>
                 <a:cs typeface="DejaVu Sans"/>
               </a:rPr>
-              <a:t>Agarwal: complexity proxy. Xu: contributor workload shifts.</a:t>
+              <a:t>Complexity: Agent-first / IDE-first. Xu: workload shifts.</a:t>
             </a:r>
           </a:p>
         </p:txBody>
@@ -14373,7 +14383,7 @@
           <p:cNvPr id="45" name="">
             <a:extLst xmlns:a="http://schemas.openxmlformats.org/drawingml/2006/main">
               <a:ext uri="{FF2B5EF4-FFF2-40B4-BE49-F238E27FC236}">
-                <a16:creationId xmlns:a16="http://schemas.microsoft.com/office/drawing/2014/main" id="{53B673D2-C086-4BB0-8A1E-9CAB8E31F8D2}"/>
+                <a16:creationId xmlns:a16="http://schemas.microsoft.com/office/drawing/2014/main" id="{27558AFD-09D6-4244-9333-F6DCED5B7161}"/>
               </a:ext>
             </a:extLst>
           </p:cNvPr>
@@ -14428,7 +14438,7 @@
     </p:spTree>
     <p:extLst>
       <p:ext uri="{BB962C8B-B14F-4D97-AF65-F5344CB8AC3E}">
-        <p14:creationId xmlns:p14="http://schemas.microsoft.com/office/powerpoint/2010/main" val="652858348"/>
+        <p14:creationId xmlns:p14="http://schemas.microsoft.com/office/powerpoint/2010/main" val="586916912"/>
       </p:ext>
     </p:extLst>
   </p:cSld>
@@ -14459,7 +14469,7 @@
           <p:cNvPr id="21" name="">
             <a:extLst xmlns:a="http://schemas.openxmlformats.org/drawingml/2006/main">
               <a:ext uri="{FF2B5EF4-FFF2-40B4-BE49-F238E27FC236}">
-                <a16:creationId xmlns:a16="http://schemas.microsoft.com/office/drawing/2014/main" id="{8CDCAED2-C079-43E2-B2F3-309A4C7AA644}"/>
+                <a16:creationId xmlns:a16="http://schemas.microsoft.com/office/drawing/2014/main" id="{AD0438DD-0743-48CC-B6D9-5246D82B9449}"/>
               </a:ext>
             </a:extLst>
           </p:cNvPr>
@@ -14516,7 +14526,7 @@
           <p:cNvPr id="2" name="">
             <a:extLst xmlns:a="http://schemas.openxmlformats.org/drawingml/2006/main">
               <a:ext uri="{FF2B5EF4-FFF2-40B4-BE49-F238E27FC236}">
-                <a16:creationId xmlns:a16="http://schemas.microsoft.com/office/drawing/2014/main" id="{4A24FF51-7083-4A83-8751-D03416CF180D}"/>
+                <a16:creationId xmlns:a16="http://schemas.microsoft.com/office/drawing/2014/main" id="{3AB995F6-D4DF-4189-A4DC-920FAB913C52}"/>
               </a:ext>
             </a:extLst>
           </p:cNvPr>
@@ -14547,7 +14557,7 @@
           <p:cNvPr id="3" name="">
             <a:extLst xmlns:a="http://schemas.openxmlformats.org/drawingml/2006/main">
               <a:ext uri="{FF2B5EF4-FFF2-40B4-BE49-F238E27FC236}">
-                <a16:creationId xmlns:a16="http://schemas.microsoft.com/office/drawing/2014/main" id="{DD8C0301-12E7-4061-AFB1-FE7FEF6A3A4D}"/>
+                <a16:creationId xmlns:a16="http://schemas.microsoft.com/office/drawing/2014/main" id="{B8CACF29-AECD-48DD-9793-914169465D5B}"/>
               </a:ext>
             </a:extLst>
           </p:cNvPr>
@@ -14604,7 +14614,7 @@
           <p:cNvPr id="4" name="">
             <a:extLst xmlns:a="http://schemas.openxmlformats.org/drawingml/2006/main">
               <a:ext uri="{FF2B5EF4-FFF2-40B4-BE49-F238E27FC236}">
-                <a16:creationId xmlns:a16="http://schemas.microsoft.com/office/drawing/2014/main" id="{A1521179-50EF-4C0F-A805-DD64DEB1FD70}"/>
+                <a16:creationId xmlns:a16="http://schemas.microsoft.com/office/drawing/2014/main" id="{1531D7E0-C531-4D7D-B15F-11D904C67B3B}"/>
               </a:ext>
             </a:extLst>
           </p:cNvPr>
@@ -14635,7 +14645,7 @@
           <p:cNvPr id="5" name="">
             <a:extLst xmlns:a="http://schemas.openxmlformats.org/drawingml/2006/main">
               <a:ext uri="{FF2B5EF4-FFF2-40B4-BE49-F238E27FC236}">
-                <a16:creationId xmlns:a16="http://schemas.microsoft.com/office/drawing/2014/main" id="{39C19E7C-A27A-42A0-9ABB-CD074F05D5F2}"/>
+                <a16:creationId xmlns:a16="http://schemas.microsoft.com/office/drawing/2014/main" id="{70B2695D-990A-4212-8B27-415FF73BCC6C}"/>
               </a:ext>
             </a:extLst>
           </p:cNvPr>
@@ -14666,7 +14676,7 @@
           <p:cNvPr id="6" name="">
             <a:extLst xmlns:a="http://schemas.openxmlformats.org/drawingml/2006/main">
               <a:ext uri="{FF2B5EF4-FFF2-40B4-BE49-F238E27FC236}">
-                <a16:creationId xmlns:a16="http://schemas.microsoft.com/office/drawing/2014/main" id="{41F4CF03-0746-4CC3-B7AE-CA9C220BE0AD}"/>
+                <a16:creationId xmlns:a16="http://schemas.microsoft.com/office/drawing/2014/main" id="{50F24B08-38FF-473D-B260-787637E24C52}"/>
               </a:ext>
             </a:extLst>
           </p:cNvPr>
@@ -15063,7 +15073,7 @@
           <p:cNvPr id="7" name="">
             <a:extLst xmlns:a="http://schemas.openxmlformats.org/drawingml/2006/main">
               <a:ext uri="{FF2B5EF4-FFF2-40B4-BE49-F238E27FC236}">
-                <a16:creationId xmlns:a16="http://schemas.microsoft.com/office/drawing/2014/main" id="{33D913F4-84BC-4A07-BFA4-1FA819C4371F}"/>
+                <a16:creationId xmlns:a16="http://schemas.microsoft.com/office/drawing/2014/main" id="{6B1DC226-D562-41EF-84CE-FB7FD4D91C4C}"/>
               </a:ext>
             </a:extLst>
           </p:cNvPr>
@@ -15094,7 +15104,7 @@
           <p:cNvPr id="8" name="">
             <a:extLst xmlns:a="http://schemas.openxmlformats.org/drawingml/2006/main">
               <a:ext uri="{FF2B5EF4-FFF2-40B4-BE49-F238E27FC236}">
-                <a16:creationId xmlns:a16="http://schemas.microsoft.com/office/drawing/2014/main" id="{4B4A008A-30A5-412E-A784-6AF8F886C11C}"/>
+                <a16:creationId xmlns:a16="http://schemas.microsoft.com/office/drawing/2014/main" id="{72992E83-B019-4B59-8DCC-981A09F48C06}"/>
               </a:ext>
             </a:extLst>
           </p:cNvPr>
@@ -15151,7 +15161,7 @@
           <p:cNvPr id="9" name="">
             <a:extLst xmlns:a="http://schemas.openxmlformats.org/drawingml/2006/main">
               <a:ext uri="{FF2B5EF4-FFF2-40B4-BE49-F238E27FC236}">
-                <a16:creationId xmlns:a16="http://schemas.microsoft.com/office/drawing/2014/main" id="{92740204-2AA6-49C4-BB36-D6E0491AB37F}"/>
+                <a16:creationId xmlns:a16="http://schemas.microsoft.com/office/drawing/2014/main" id="{8A076380-8FF9-4C45-BE8E-C12F28535F80}"/>
               </a:ext>
             </a:extLst>
           </p:cNvPr>
@@ -15208,7 +15218,7 @@
           <p:cNvPr id="10" name="">
             <a:extLst xmlns:a="http://schemas.openxmlformats.org/drawingml/2006/main">
               <a:ext uri="{FF2B5EF4-FFF2-40B4-BE49-F238E27FC236}">
-                <a16:creationId xmlns:a16="http://schemas.microsoft.com/office/drawing/2014/main" id="{031DC1D9-7C1E-4238-BE91-B34A4AEDF61E}"/>
+                <a16:creationId xmlns:a16="http://schemas.microsoft.com/office/drawing/2014/main" id="{7EADE54B-C2C2-49FF-9CB1-565FD4ACA7DC}"/>
               </a:ext>
             </a:extLst>
           </p:cNvPr>
@@ -15288,7 +15298,7 @@
           <p:cNvPr id="11" name="">
             <a:extLst xmlns:a="http://schemas.openxmlformats.org/drawingml/2006/main">
               <a:ext uri="{FF2B5EF4-FFF2-40B4-BE49-F238E27FC236}">
-                <a16:creationId xmlns:a16="http://schemas.microsoft.com/office/drawing/2014/main" id="{2258070B-34BE-4A91-902F-CA481BAE0E96}"/>
+                <a16:creationId xmlns:a16="http://schemas.microsoft.com/office/drawing/2014/main" id="{EB33BF52-8D75-4494-A599-CE748EE5D6AE}"/>
               </a:ext>
             </a:extLst>
           </p:cNvPr>
@@ -15345,7 +15355,7 @@
           <p:cNvPr id="12" name="">
             <a:extLst xmlns:a="http://schemas.openxmlformats.org/drawingml/2006/main">
               <a:ext uri="{FF2B5EF4-FFF2-40B4-BE49-F238E27FC236}">
-                <a16:creationId xmlns:a16="http://schemas.microsoft.com/office/drawing/2014/main" id="{8B7E5F23-A6C9-495C-BB52-E6DA7AB9D8FE}"/>
+                <a16:creationId xmlns:a16="http://schemas.microsoft.com/office/drawing/2014/main" id="{9A48B593-42FD-45C7-9CB8-516877003359}"/>
               </a:ext>
             </a:extLst>
           </p:cNvPr>
@@ -15402,7 +15412,7 @@
           <p:cNvPr id="13" name="">
             <a:extLst xmlns:a="http://schemas.openxmlformats.org/drawingml/2006/main">
               <a:ext uri="{FF2B5EF4-FFF2-40B4-BE49-F238E27FC236}">
-                <a16:creationId xmlns:a16="http://schemas.microsoft.com/office/drawing/2014/main" id="{93C5E641-F28C-40E3-8D08-BB9138A7BA24}"/>
+                <a16:creationId xmlns:a16="http://schemas.microsoft.com/office/drawing/2014/main" id="{7AD981BA-9267-4738-83F5-1834493CAEA7}"/>
               </a:ext>
             </a:extLst>
           </p:cNvPr>
@@ -15459,7 +15469,7 @@
           <p:cNvPr id="14" name="">
             <a:extLst xmlns:a="http://schemas.openxmlformats.org/drawingml/2006/main">
               <a:ext uri="{FF2B5EF4-FFF2-40B4-BE49-F238E27FC236}">
-                <a16:creationId xmlns:a16="http://schemas.microsoft.com/office/drawing/2014/main" id="{042A0DEB-4DCF-4918-B10F-926B54A2D23B}"/>
+                <a16:creationId xmlns:a16="http://schemas.microsoft.com/office/drawing/2014/main" id="{CAC69F5B-B349-468B-8CC7-14A73FEC1753}"/>
               </a:ext>
             </a:extLst>
           </p:cNvPr>
@@ -15516,7 +15526,7 @@
           <p:cNvPr id="15" name="">
             <a:extLst xmlns:a="http://schemas.openxmlformats.org/drawingml/2006/main">
               <a:ext uri="{FF2B5EF4-FFF2-40B4-BE49-F238E27FC236}">
-                <a16:creationId xmlns:a16="http://schemas.microsoft.com/office/drawing/2014/main" id="{750F38AB-088B-4528-92E4-01F536C35002}"/>
+                <a16:creationId xmlns:a16="http://schemas.microsoft.com/office/drawing/2014/main" id="{A6C197F0-FF85-4D49-B79F-BBEF1077A63B}"/>
               </a:ext>
             </a:extLst>
           </p:cNvPr>
@@ -15573,7 +15583,7 @@
           <p:cNvPr id="16" name="">
             <a:extLst xmlns:a="http://schemas.openxmlformats.org/drawingml/2006/main">
               <a:ext uri="{FF2B5EF4-FFF2-40B4-BE49-F238E27FC236}">
-                <a16:creationId xmlns:a16="http://schemas.microsoft.com/office/drawing/2014/main" id="{24ED7B37-7E05-4352-B1A4-FD4EF3B9E412}"/>
+                <a16:creationId xmlns:a16="http://schemas.microsoft.com/office/drawing/2014/main" id="{D75091AD-AF8E-4674-9B5D-385B063B96E4}"/>
               </a:ext>
             </a:extLst>
           </p:cNvPr>
@@ -15653,7 +15663,7 @@
           <p:cNvPr id="17" name="">
             <a:extLst xmlns:a="http://schemas.openxmlformats.org/drawingml/2006/main">
               <a:ext uri="{FF2B5EF4-FFF2-40B4-BE49-F238E27FC236}">
-                <a16:creationId xmlns:a16="http://schemas.microsoft.com/office/drawing/2014/main" id="{999A732D-495A-4F79-9E4F-70EBC9B1E9BA}"/>
+                <a16:creationId xmlns:a16="http://schemas.microsoft.com/office/drawing/2014/main" id="{50C2082E-0979-42B7-82DE-DB4217D78444}"/>
               </a:ext>
             </a:extLst>
           </p:cNvPr>
@@ -15710,7 +15720,7 @@
           <p:cNvPr id="18" name="">
             <a:extLst xmlns:a="http://schemas.openxmlformats.org/drawingml/2006/main">
               <a:ext uri="{FF2B5EF4-FFF2-40B4-BE49-F238E27FC236}">
-                <a16:creationId xmlns:a16="http://schemas.microsoft.com/office/drawing/2014/main" id="{0B3C0977-2FD7-4374-BBBD-4BBBFCCD24D9}"/>
+                <a16:creationId xmlns:a16="http://schemas.microsoft.com/office/drawing/2014/main" id="{0DD3CFD9-8B04-413D-9FE0-422FD4F6BD25}"/>
               </a:ext>
             </a:extLst>
           </p:cNvPr>
@@ -15767,7 +15777,7 @@
           <p:cNvPr id="19" name="">
             <a:extLst xmlns:a="http://schemas.openxmlformats.org/drawingml/2006/main">
               <a:ext uri="{FF2B5EF4-FFF2-40B4-BE49-F238E27FC236}">
-                <a16:creationId xmlns:a16="http://schemas.microsoft.com/office/drawing/2014/main" id="{BEBD4B82-C0B2-42FC-A55C-76BE8B063B6E}"/>
+                <a16:creationId xmlns:a16="http://schemas.microsoft.com/office/drawing/2014/main" id="{E553B1E7-2A27-4A29-8C2F-006A3D99A03E}"/>
               </a:ext>
             </a:extLst>
           </p:cNvPr>
@@ -15798,7 +15808,7 @@
           <p:cNvPr id="20" name="">
             <a:extLst xmlns:a="http://schemas.openxmlformats.org/drawingml/2006/main">
               <a:ext uri="{FF2B5EF4-FFF2-40B4-BE49-F238E27FC236}">
-                <a16:creationId xmlns:a16="http://schemas.microsoft.com/office/drawing/2014/main" id="{045BA6B2-0CE3-4903-9446-BAAF18793D84}"/>
+                <a16:creationId xmlns:a16="http://schemas.microsoft.com/office/drawing/2014/main" id="{81D579F6-D585-481A-A5A0-C950EB7FFBF7}"/>
               </a:ext>
             </a:extLst>
           </p:cNvPr>
@@ -15853,7 +15863,7 @@
     </p:spTree>
     <p:extLst>
       <p:ext uri="{BB962C8B-B14F-4D97-AF65-F5344CB8AC3E}">
-        <p14:creationId xmlns:p14="http://schemas.microsoft.com/office/powerpoint/2010/main" val="1801804329"/>
+        <p14:creationId xmlns:p14="http://schemas.microsoft.com/office/powerpoint/2010/main" val="1172285752"/>
       </p:ext>
     </p:extLst>
   </p:cSld>
@@ -15884,7 +15894,7 @@
           <p:cNvPr id="24" name="">
             <a:extLst xmlns:a="http://schemas.openxmlformats.org/drawingml/2006/main">
               <a:ext uri="{FF2B5EF4-FFF2-40B4-BE49-F238E27FC236}">
-                <a16:creationId xmlns:a16="http://schemas.microsoft.com/office/drawing/2014/main" id="{9EF7427B-5147-4461-A3F5-A414D68495FA}"/>
+                <a16:creationId xmlns:a16="http://schemas.microsoft.com/office/drawing/2014/main" id="{1D915CE9-1A70-431C-9B5F-3F804F94316B}"/>
               </a:ext>
             </a:extLst>
           </p:cNvPr>
@@ -15941,7 +15951,7 @@
           <p:cNvPr id="2" name="">
             <a:extLst xmlns:a="http://schemas.openxmlformats.org/drawingml/2006/main">
               <a:ext uri="{FF2B5EF4-FFF2-40B4-BE49-F238E27FC236}">
-                <a16:creationId xmlns:a16="http://schemas.microsoft.com/office/drawing/2014/main" id="{54584BCD-FDBF-4D3B-9A7E-B448862DB63C}"/>
+                <a16:creationId xmlns:a16="http://schemas.microsoft.com/office/drawing/2014/main" id="{70041C53-10FC-471E-94EB-5E62E770D108}"/>
               </a:ext>
             </a:extLst>
           </p:cNvPr>
@@ -15972,7 +15982,7 @@
           <p:cNvPr id="3" name="">
             <a:extLst xmlns:a="http://schemas.openxmlformats.org/drawingml/2006/main">
               <a:ext uri="{FF2B5EF4-FFF2-40B4-BE49-F238E27FC236}">
-                <a16:creationId xmlns:a16="http://schemas.microsoft.com/office/drawing/2014/main" id="{2C8BC1B4-62C9-4E48-B1B6-18F906580B34}"/>
+                <a16:creationId xmlns:a16="http://schemas.microsoft.com/office/drawing/2014/main" id="{DDF22393-6DF9-41BB-B0D1-196FA54337AA}"/>
               </a:ext>
             </a:extLst>
           </p:cNvPr>
@@ -16029,7 +16039,7 @@
           <p:cNvPr id="4" name="">
             <a:extLst xmlns:a="http://schemas.openxmlformats.org/drawingml/2006/main">
               <a:ext uri="{FF2B5EF4-FFF2-40B4-BE49-F238E27FC236}">
-                <a16:creationId xmlns:a16="http://schemas.microsoft.com/office/drawing/2014/main" id="{AB098F30-6978-4022-A059-EAA56A170A2D}"/>
+                <a16:creationId xmlns:a16="http://schemas.microsoft.com/office/drawing/2014/main" id="{F5C24FD7-75BD-4C19-B1DE-E133AB8177F9}"/>
               </a:ext>
             </a:extLst>
           </p:cNvPr>
@@ -16086,7 +16096,7 @@
           <p:cNvPr id="5" name="">
             <a:extLst xmlns:a="http://schemas.openxmlformats.org/drawingml/2006/main">
               <a:ext uri="{FF2B5EF4-FFF2-40B4-BE49-F238E27FC236}">
-                <a16:creationId xmlns:a16="http://schemas.microsoft.com/office/drawing/2014/main" id="{279314B9-1FAC-4A24-B414-559BB72F0CFD}"/>
+                <a16:creationId xmlns:a16="http://schemas.microsoft.com/office/drawing/2014/main" id="{44A57D47-9974-4E64-8F78-4748B5C748C3}"/>
               </a:ext>
             </a:extLst>
           </p:cNvPr>
@@ -16143,7 +16153,7 @@
           <p:cNvPr id="6" name="">
             <a:extLst xmlns:a="http://schemas.openxmlformats.org/drawingml/2006/main">
               <a:ext uri="{FF2B5EF4-FFF2-40B4-BE49-F238E27FC236}">
-                <a16:creationId xmlns:a16="http://schemas.microsoft.com/office/drawing/2014/main" id="{0330D391-9D43-4442-8D86-B073C76E4400}"/>
+                <a16:creationId xmlns:a16="http://schemas.microsoft.com/office/drawing/2014/main" id="{366F3340-18F8-481E-BCD8-411E93A63542}"/>
               </a:ext>
             </a:extLst>
           </p:cNvPr>
@@ -16176,7 +16186,7 @@
           <p:cNvPr id="7" name="">
             <a:extLst xmlns:a="http://schemas.openxmlformats.org/drawingml/2006/main">
               <a:ext uri="{FF2B5EF4-FFF2-40B4-BE49-F238E27FC236}">
-                <a16:creationId xmlns:a16="http://schemas.microsoft.com/office/drawing/2014/main" id="{7FEF8001-1CE6-4240-AE07-2F6C99D57F80}"/>
+                <a16:creationId xmlns:a16="http://schemas.microsoft.com/office/drawing/2014/main" id="{CFA5B6EC-A9DC-4C93-8B1E-006F61D161BA}"/>
               </a:ext>
             </a:extLst>
           </p:cNvPr>
@@ -16256,7 +16266,7 @@
           <p:cNvPr id="8" name="">
             <a:extLst xmlns:a="http://schemas.openxmlformats.org/drawingml/2006/main">
               <a:ext uri="{FF2B5EF4-FFF2-40B4-BE49-F238E27FC236}">
-                <a16:creationId xmlns:a16="http://schemas.microsoft.com/office/drawing/2014/main" id="{3F095A59-D111-4392-8071-F541ADB8388B}"/>
+                <a16:creationId xmlns:a16="http://schemas.microsoft.com/office/drawing/2014/main" id="{846A72D3-7E32-4CD5-B201-82DD04C0BCD1}"/>
               </a:ext>
             </a:extLst>
           </p:cNvPr>
@@ -16359,7 +16369,7 @@
           <p:cNvPr id="9" name="">
             <a:extLst xmlns:a="http://schemas.openxmlformats.org/drawingml/2006/main">
               <a:ext uri="{FF2B5EF4-FFF2-40B4-BE49-F238E27FC236}">
-                <a16:creationId xmlns:a16="http://schemas.microsoft.com/office/drawing/2014/main" id="{407ADCA6-007F-45F9-82CE-91D09CA8751A}"/>
+                <a16:creationId xmlns:a16="http://schemas.microsoft.com/office/drawing/2014/main" id="{4DE3185C-6A9D-45DC-85FD-F30828E450C1}"/>
               </a:ext>
             </a:extLst>
           </p:cNvPr>
@@ -16392,7 +16402,7 @@
           <p:cNvPr id="10" name="">
             <a:extLst xmlns:a="http://schemas.openxmlformats.org/drawingml/2006/main">
               <a:ext uri="{FF2B5EF4-FFF2-40B4-BE49-F238E27FC236}">
-                <a16:creationId xmlns:a16="http://schemas.microsoft.com/office/drawing/2014/main" id="{44E0D7A2-BC09-471C-905C-945C5A017320}"/>
+                <a16:creationId xmlns:a16="http://schemas.microsoft.com/office/drawing/2014/main" id="{D3123DAF-5207-41D5-8670-FA953AF03877}"/>
               </a:ext>
             </a:extLst>
           </p:cNvPr>
@@ -16472,7 +16482,7 @@
           <p:cNvPr id="11" name="">
             <a:extLst xmlns:a="http://schemas.openxmlformats.org/drawingml/2006/main">
               <a:ext uri="{FF2B5EF4-FFF2-40B4-BE49-F238E27FC236}">
-                <a16:creationId xmlns:a16="http://schemas.microsoft.com/office/drawing/2014/main" id="{6887609A-BB16-47D6-8660-F233CF2EE74A}"/>
+                <a16:creationId xmlns:a16="http://schemas.microsoft.com/office/drawing/2014/main" id="{C875A0FA-613E-4B6C-A847-951C0D0D93CF}"/>
               </a:ext>
             </a:extLst>
           </p:cNvPr>
@@ -16575,7 +16585,7 @@
           <p:cNvPr id="12" name="">
             <a:extLst xmlns:a="http://schemas.openxmlformats.org/drawingml/2006/main">
               <a:ext uri="{FF2B5EF4-FFF2-40B4-BE49-F238E27FC236}">
-                <a16:creationId xmlns:a16="http://schemas.microsoft.com/office/drawing/2014/main" id="{FF32C3CD-FC89-4A34-A24C-DE0320A98180}"/>
+                <a16:creationId xmlns:a16="http://schemas.microsoft.com/office/drawing/2014/main" id="{2AB86B81-7C78-4EDA-A0B1-80F97E02FC1A}"/>
               </a:ext>
             </a:extLst>
           </p:cNvPr>
@@ -16608,7 +16618,7 @@
           <p:cNvPr id="13" name="">
             <a:extLst xmlns:a="http://schemas.openxmlformats.org/drawingml/2006/main">
               <a:ext uri="{FF2B5EF4-FFF2-40B4-BE49-F238E27FC236}">
-                <a16:creationId xmlns:a16="http://schemas.microsoft.com/office/drawing/2014/main" id="{76ECA203-E40B-44A2-9AB6-EF1A898A783C}"/>
+                <a16:creationId xmlns:a16="http://schemas.microsoft.com/office/drawing/2014/main" id="{902E3E13-7701-4899-BFD7-0D0F8B39CA2F}"/>
               </a:ext>
             </a:extLst>
           </p:cNvPr>
@@ -16688,7 +16698,7 @@
           <p:cNvPr id="14" name="">
             <a:extLst xmlns:a="http://schemas.openxmlformats.org/drawingml/2006/main">
               <a:ext uri="{FF2B5EF4-FFF2-40B4-BE49-F238E27FC236}">
-                <a16:creationId xmlns:a16="http://schemas.microsoft.com/office/drawing/2014/main" id="{3832DC54-17C7-4D06-9574-1A632053AB93}"/>
+                <a16:creationId xmlns:a16="http://schemas.microsoft.com/office/drawing/2014/main" id="{16255EF2-E85A-43F5-A8F1-AEEAF9C24182}"/>
               </a:ext>
             </a:extLst>
           </p:cNvPr>
@@ -16791,7 +16801,7 @@
           <p:cNvPr id="15" name="">
             <a:extLst xmlns:a="http://schemas.openxmlformats.org/drawingml/2006/main">
               <a:ext uri="{FF2B5EF4-FFF2-40B4-BE49-F238E27FC236}">
-                <a16:creationId xmlns:a16="http://schemas.microsoft.com/office/drawing/2014/main" id="{0F856338-26AF-4182-9701-EDDD4FDE9D79}"/>
+                <a16:creationId xmlns:a16="http://schemas.microsoft.com/office/drawing/2014/main" id="{80CB47E1-4453-43F2-9983-BE8C6408687F}"/>
               </a:ext>
             </a:extLst>
           </p:cNvPr>
@@ -16824,7 +16834,7 @@
           <p:cNvPr id="16" name="">
             <a:extLst xmlns:a="http://schemas.openxmlformats.org/drawingml/2006/main">
               <a:ext uri="{FF2B5EF4-FFF2-40B4-BE49-F238E27FC236}">
-                <a16:creationId xmlns:a16="http://schemas.microsoft.com/office/drawing/2014/main" id="{E02C66CE-FBD3-4B33-BD14-58A917D4CA45}"/>
+                <a16:creationId xmlns:a16="http://schemas.microsoft.com/office/drawing/2014/main" id="{03D08823-1207-40CC-90B8-DA53245A4545}"/>
               </a:ext>
             </a:extLst>
           </p:cNvPr>
@@ -16904,7 +16914,7 @@
           <p:cNvPr id="17" name="">
             <a:extLst xmlns:a="http://schemas.openxmlformats.org/drawingml/2006/main">
               <a:ext uri="{FF2B5EF4-FFF2-40B4-BE49-F238E27FC236}">
-                <a16:creationId xmlns:a16="http://schemas.microsoft.com/office/drawing/2014/main" id="{DE3379DD-F2C3-43CB-AC8A-2BC702905461}"/>
+                <a16:creationId xmlns:a16="http://schemas.microsoft.com/office/drawing/2014/main" id="{8201C107-98B2-488C-8790-C6661BB53189}"/>
               </a:ext>
             </a:extLst>
           </p:cNvPr>
@@ -17085,7 +17095,7 @@
           <p:cNvPr id="21" name="">
             <a:extLst xmlns:a="http://schemas.openxmlformats.org/drawingml/2006/main">
               <a:ext uri="{FF2B5EF4-FFF2-40B4-BE49-F238E27FC236}">
-                <a16:creationId xmlns:a16="http://schemas.microsoft.com/office/drawing/2014/main" id="{4D9EB0F1-6814-40E7-B3E3-CB3526FA65EC}"/>
+                <a16:creationId xmlns:a16="http://schemas.microsoft.com/office/drawing/2014/main" id="{1117D6EA-6113-4FA1-9883-FCD7A9607484}"/>
               </a:ext>
             </a:extLst>
           </p:cNvPr>
@@ -17142,7 +17152,7 @@
           <p:cNvPr id="22" name="">
             <a:extLst xmlns:a="http://schemas.openxmlformats.org/drawingml/2006/main">
               <a:ext uri="{FF2B5EF4-FFF2-40B4-BE49-F238E27FC236}">
-                <a16:creationId xmlns:a16="http://schemas.microsoft.com/office/drawing/2014/main" id="{8ED286AA-5B0F-4AFC-80DE-4959B5D4E47C}"/>
+                <a16:creationId xmlns:a16="http://schemas.microsoft.com/office/drawing/2014/main" id="{E74CE51D-22E6-4BA1-A6BE-4387A9E99F10}"/>
               </a:ext>
             </a:extLst>
           </p:cNvPr>
@@ -17173,7 +17183,7 @@
           <p:cNvPr id="23" name="">
             <a:extLst xmlns:a="http://schemas.openxmlformats.org/drawingml/2006/main">
               <a:ext uri="{FF2B5EF4-FFF2-40B4-BE49-F238E27FC236}">
-                <a16:creationId xmlns:a16="http://schemas.microsoft.com/office/drawing/2014/main" id="{DD896936-EAFB-42A1-9C5C-885A010FAD84}"/>
+                <a16:creationId xmlns:a16="http://schemas.microsoft.com/office/drawing/2014/main" id="{2F5189A1-F94A-41D2-9206-D26F74CBBB5C}"/>
               </a:ext>
             </a:extLst>
           </p:cNvPr>
@@ -17228,7 +17238,7 @@
     </p:spTree>
     <p:extLst>
       <p:ext uri="{BB962C8B-B14F-4D97-AF65-F5344CB8AC3E}">
-        <p14:creationId xmlns:p14="http://schemas.microsoft.com/office/powerpoint/2010/main" val="651339990"/>
+        <p14:creationId xmlns:p14="http://schemas.microsoft.com/office/powerpoint/2010/main" val="1609656176"/>
       </p:ext>
     </p:extLst>
   </p:cSld>
@@ -17259,7 +17269,7 @@
           <p:cNvPr id="32" name="">
             <a:extLst xmlns:a="http://schemas.openxmlformats.org/drawingml/2006/main">
               <a:ext uri="{FF2B5EF4-FFF2-40B4-BE49-F238E27FC236}">
-                <a16:creationId xmlns:a16="http://schemas.microsoft.com/office/drawing/2014/main" id="{01ABF768-B3A6-43F1-B03D-F1725935840C}"/>
+                <a16:creationId xmlns:a16="http://schemas.microsoft.com/office/drawing/2014/main" id="{8C1D3574-6D4F-4163-A91D-8A040D9F746D}"/>
               </a:ext>
             </a:extLst>
           </p:cNvPr>
@@ -17339,7 +17349,7 @@
           <p:cNvPr id="2" name="">
             <a:extLst xmlns:a="http://schemas.openxmlformats.org/drawingml/2006/main">
               <a:ext uri="{FF2B5EF4-FFF2-40B4-BE49-F238E27FC236}">
-                <a16:creationId xmlns:a16="http://schemas.microsoft.com/office/drawing/2014/main" id="{6192726A-4541-40B4-9543-F7B1D22CAA48}"/>
+                <a16:creationId xmlns:a16="http://schemas.microsoft.com/office/drawing/2014/main" id="{E786CB6A-2DF7-4E22-9C3D-DC281A96DF65}"/>
               </a:ext>
             </a:extLst>
           </p:cNvPr>
@@ -17370,7 +17380,7 @@
           <p:cNvPr id="3" name="">
             <a:extLst xmlns:a="http://schemas.openxmlformats.org/drawingml/2006/main">
               <a:ext uri="{FF2B5EF4-FFF2-40B4-BE49-F238E27FC236}">
-                <a16:creationId xmlns:a16="http://schemas.microsoft.com/office/drawing/2014/main" id="{10AFA2B6-9CB6-45F5-8104-DD82BC4F9613}"/>
+                <a16:creationId xmlns:a16="http://schemas.microsoft.com/office/drawing/2014/main" id="{5B76330E-BB83-42E5-A860-716656783739}"/>
               </a:ext>
             </a:extLst>
           </p:cNvPr>
@@ -17427,7 +17437,7 @@
           <p:cNvPr id="4" name="">
             <a:extLst xmlns:a="http://schemas.openxmlformats.org/drawingml/2006/main">
               <a:ext uri="{FF2B5EF4-FFF2-40B4-BE49-F238E27FC236}">
-                <a16:creationId xmlns:a16="http://schemas.microsoft.com/office/drawing/2014/main" id="{37CB5E65-E02B-4576-B585-FEE9BC31C7A6}"/>
+                <a16:creationId xmlns:a16="http://schemas.microsoft.com/office/drawing/2014/main" id="{ECD91F2D-7FDA-4F6C-820F-63C57E8F8F04}"/>
               </a:ext>
             </a:extLst>
           </p:cNvPr>
@@ -17484,7 +17494,7 @@
           <p:cNvPr id="5" name="">
             <a:extLst xmlns:a="http://schemas.openxmlformats.org/drawingml/2006/main">
               <a:ext uri="{FF2B5EF4-FFF2-40B4-BE49-F238E27FC236}">
-                <a16:creationId xmlns:a16="http://schemas.microsoft.com/office/drawing/2014/main" id="{0D08CB82-4DF1-4FFC-BC63-A6C7B22005C3}"/>
+                <a16:creationId xmlns:a16="http://schemas.microsoft.com/office/drawing/2014/main" id="{D3CABF32-FACD-45B7-B6EB-86CD8EFE9886}"/>
               </a:ext>
             </a:extLst>
           </p:cNvPr>
@@ -17541,7 +17551,7 @@
           <p:cNvPr id="6" name="">
             <a:extLst xmlns:a="http://schemas.openxmlformats.org/drawingml/2006/main">
               <a:ext uri="{FF2B5EF4-FFF2-40B4-BE49-F238E27FC236}">
-                <a16:creationId xmlns:a16="http://schemas.microsoft.com/office/drawing/2014/main" id="{3FF01222-DC52-4B84-B49F-A85AA46D506F}"/>
+                <a16:creationId xmlns:a16="http://schemas.microsoft.com/office/drawing/2014/main" id="{4177584B-51D6-47A4-92FF-7E7F5E7E6693}"/>
               </a:ext>
             </a:extLst>
           </p:cNvPr>
@@ -17598,7 +17608,7 @@
           <p:cNvPr id="7" name="">
             <a:extLst xmlns:a="http://schemas.openxmlformats.org/drawingml/2006/main">
               <a:ext uri="{FF2B5EF4-FFF2-40B4-BE49-F238E27FC236}">
-                <a16:creationId xmlns:a16="http://schemas.microsoft.com/office/drawing/2014/main" id="{8E9437CF-04C2-4FD5-8EE8-4270668EB1DC}"/>
+                <a16:creationId xmlns:a16="http://schemas.microsoft.com/office/drawing/2014/main" id="{63097131-9CDD-4CFA-AA89-56F5F294CF9A}"/>
               </a:ext>
             </a:extLst>
           </p:cNvPr>
@@ -17655,7 +17665,7 @@
           <p:cNvPr id="8" name="">
             <a:extLst xmlns:a="http://schemas.openxmlformats.org/drawingml/2006/main">
               <a:ext uri="{FF2B5EF4-FFF2-40B4-BE49-F238E27FC236}">
-                <a16:creationId xmlns:a16="http://schemas.microsoft.com/office/drawing/2014/main" id="{1DFDE493-CC49-4472-B785-1C1C80DE5FF7}"/>
+                <a16:creationId xmlns:a16="http://schemas.microsoft.com/office/drawing/2014/main" id="{8E93DE9A-8C01-4A5C-B6B7-4485BF847310}"/>
               </a:ext>
             </a:extLst>
           </p:cNvPr>
@@ -17712,7 +17722,7 @@
           <p:cNvPr id="9" name="">
             <a:extLst xmlns:a="http://schemas.openxmlformats.org/drawingml/2006/main">
               <a:ext uri="{FF2B5EF4-FFF2-40B4-BE49-F238E27FC236}">
-                <a16:creationId xmlns:a16="http://schemas.microsoft.com/office/drawing/2014/main" id="{70F026D6-BD59-4B59-B68D-E772938CC7AE}"/>
+                <a16:creationId xmlns:a16="http://schemas.microsoft.com/office/drawing/2014/main" id="{9CB7E5CD-BD57-4087-81A3-A17ADE340B39}"/>
               </a:ext>
             </a:extLst>
           </p:cNvPr>
@@ -17769,7 +17779,7 @@
           <p:cNvPr id="10" name="">
             <a:extLst xmlns:a="http://schemas.openxmlformats.org/drawingml/2006/main">
               <a:ext uri="{FF2B5EF4-FFF2-40B4-BE49-F238E27FC236}">
-                <a16:creationId xmlns:a16="http://schemas.microsoft.com/office/drawing/2014/main" id="{74F34E97-821F-42BC-B27A-F8D019C9E19A}"/>
+                <a16:creationId xmlns:a16="http://schemas.microsoft.com/office/drawing/2014/main" id="{C068A848-ABF6-497A-B7F3-0B02A08B2D3D}"/>
               </a:ext>
             </a:extLst>
           </p:cNvPr>
@@ -17800,7 +17810,7 @@
           <p:cNvPr id="11" name="">
             <a:extLst xmlns:a="http://schemas.openxmlformats.org/drawingml/2006/main">
               <a:ext uri="{FF2B5EF4-FFF2-40B4-BE49-F238E27FC236}">
-                <a16:creationId xmlns:a16="http://schemas.microsoft.com/office/drawing/2014/main" id="{3844B907-9924-4991-8780-FB16C7D470BB}"/>
+                <a16:creationId xmlns:a16="http://schemas.microsoft.com/office/drawing/2014/main" id="{1ABE8123-4A60-43BD-9688-2045E43B0936}"/>
               </a:ext>
             </a:extLst>
           </p:cNvPr>
@@ -17857,7 +17867,7 @@
           <p:cNvPr id="12" name="">
             <a:extLst xmlns:a="http://schemas.openxmlformats.org/drawingml/2006/main">
               <a:ext uri="{FF2B5EF4-FFF2-40B4-BE49-F238E27FC236}">
-                <a16:creationId xmlns:a16="http://schemas.microsoft.com/office/drawing/2014/main" id="{E4F23F36-80DD-47A8-AFBE-CCA72F1B5637}"/>
+                <a16:creationId xmlns:a16="http://schemas.microsoft.com/office/drawing/2014/main" id="{B039B597-CD36-47A1-B647-F4622B946FF5}"/>
               </a:ext>
             </a:extLst>
           </p:cNvPr>
@@ -17914,7 +17924,7 @@
           <p:cNvPr id="13" name="">
             <a:extLst xmlns:a="http://schemas.openxmlformats.org/drawingml/2006/main">
               <a:ext uri="{FF2B5EF4-FFF2-40B4-BE49-F238E27FC236}">
-                <a16:creationId xmlns:a16="http://schemas.microsoft.com/office/drawing/2014/main" id="{AE37F604-3724-4C3C-B9C3-89443951C5E3}"/>
+                <a16:creationId xmlns:a16="http://schemas.microsoft.com/office/drawing/2014/main" id="{6F825A41-90F6-4061-8666-6F28CF82814F}"/>
               </a:ext>
             </a:extLst>
           </p:cNvPr>
@@ -17971,7 +17981,7 @@
           <p:cNvPr id="14" name="">
             <a:extLst xmlns:a="http://schemas.openxmlformats.org/drawingml/2006/main">
               <a:ext uri="{FF2B5EF4-FFF2-40B4-BE49-F238E27FC236}">
-                <a16:creationId xmlns:a16="http://schemas.microsoft.com/office/drawing/2014/main" id="{4BBE2A3B-30E4-41E1-B661-82C717796D3E}"/>
+                <a16:creationId xmlns:a16="http://schemas.microsoft.com/office/drawing/2014/main" id="{132C31C1-6772-4B92-B6B2-4C65DE330D5A}"/>
               </a:ext>
             </a:extLst>
           </p:cNvPr>
@@ -18028,7 +18038,7 @@
           <p:cNvPr id="15" name="">
             <a:extLst xmlns:a="http://schemas.openxmlformats.org/drawingml/2006/main">
               <a:ext uri="{FF2B5EF4-FFF2-40B4-BE49-F238E27FC236}">
-                <a16:creationId xmlns:a16="http://schemas.microsoft.com/office/drawing/2014/main" id="{74DFB657-2240-4B15-8566-C714D69BD59A}"/>
+                <a16:creationId xmlns:a16="http://schemas.microsoft.com/office/drawing/2014/main" id="{87354A19-307F-47C7-90F4-C28F82267FEC}"/>
               </a:ext>
             </a:extLst>
           </p:cNvPr>
@@ -18085,7 +18095,7 @@
           <p:cNvPr id="16" name="">
             <a:extLst xmlns:a="http://schemas.openxmlformats.org/drawingml/2006/main">
               <a:ext uri="{FF2B5EF4-FFF2-40B4-BE49-F238E27FC236}">
-                <a16:creationId xmlns:a16="http://schemas.microsoft.com/office/drawing/2014/main" id="{5C378DE2-B466-4CC1-9238-7E3FB3ACE5D5}"/>
+                <a16:creationId xmlns:a16="http://schemas.microsoft.com/office/drawing/2014/main" id="{A23BB8B1-5C90-43E5-B361-1A6E37D71EFA}"/>
               </a:ext>
             </a:extLst>
           </p:cNvPr>
@@ -18142,7 +18152,7 @@
           <p:cNvPr id="17" name="">
             <a:extLst xmlns:a="http://schemas.openxmlformats.org/drawingml/2006/main">
               <a:ext uri="{FF2B5EF4-FFF2-40B4-BE49-F238E27FC236}">
-                <a16:creationId xmlns:a16="http://schemas.microsoft.com/office/drawing/2014/main" id="{D89E5EB3-12F1-46F6-BE9D-95DF980ECD5C}"/>
+                <a16:creationId xmlns:a16="http://schemas.microsoft.com/office/drawing/2014/main" id="{9334D397-C5E4-428C-9E86-DEDFE05E96FB}"/>
               </a:ext>
             </a:extLst>
           </p:cNvPr>
@@ -18199,7 +18209,7 @@
           <p:cNvPr id="18" name="">
             <a:extLst xmlns:a="http://schemas.openxmlformats.org/drawingml/2006/main">
               <a:ext uri="{FF2B5EF4-FFF2-40B4-BE49-F238E27FC236}">
-                <a16:creationId xmlns:a16="http://schemas.microsoft.com/office/drawing/2014/main" id="{29F558D2-A42C-4B54-B384-9F5DDC23DAD4}"/>
+                <a16:creationId xmlns:a16="http://schemas.microsoft.com/office/drawing/2014/main" id="{1482239B-62C3-4DBD-8D10-D87E2821083D}"/>
               </a:ext>
             </a:extLst>
           </p:cNvPr>
@@ -18256,7 +18266,7 @@
           <p:cNvPr id="19" name="">
             <a:extLst xmlns:a="http://schemas.openxmlformats.org/drawingml/2006/main">
               <a:ext uri="{FF2B5EF4-FFF2-40B4-BE49-F238E27FC236}">
-                <a16:creationId xmlns:a16="http://schemas.microsoft.com/office/drawing/2014/main" id="{BF2CA8E6-7547-4BD0-BA3D-3E2E3F037510}"/>
+                <a16:creationId xmlns:a16="http://schemas.microsoft.com/office/drawing/2014/main" id="{7E0B86F3-F4EF-4141-AEF0-1C6EA8D2E95C}"/>
               </a:ext>
             </a:extLst>
           </p:cNvPr>
@@ -18313,7 +18323,7 @@
           <p:cNvPr id="20" name="">
             <a:extLst xmlns:a="http://schemas.openxmlformats.org/drawingml/2006/main">
               <a:ext uri="{FF2B5EF4-FFF2-40B4-BE49-F238E27FC236}">
-                <a16:creationId xmlns:a16="http://schemas.microsoft.com/office/drawing/2014/main" id="{599C27A7-919D-4F30-9C82-8A6B8D5B98C8}"/>
+                <a16:creationId xmlns:a16="http://schemas.microsoft.com/office/drawing/2014/main" id="{08972BDA-6B66-4DE3-87F9-841754FDA988}"/>
               </a:ext>
             </a:extLst>
           </p:cNvPr>
@@ -18370,7 +18380,7 @@
           <p:cNvPr id="21" name="">
             <a:extLst xmlns:a="http://schemas.openxmlformats.org/drawingml/2006/main">
               <a:ext uri="{FF2B5EF4-FFF2-40B4-BE49-F238E27FC236}">
-                <a16:creationId xmlns:a16="http://schemas.microsoft.com/office/drawing/2014/main" id="{D5705578-2841-413B-993F-A55D9F00EC63}"/>
+                <a16:creationId xmlns:a16="http://schemas.microsoft.com/office/drawing/2014/main" id="{EAF32317-CAA6-41D1-A69C-546F92AACFA7}"/>
               </a:ext>
             </a:extLst>
           </p:cNvPr>
@@ -18427,7 +18437,7 @@
           <p:cNvPr id="22" name="">
             <a:extLst xmlns:a="http://schemas.openxmlformats.org/drawingml/2006/main">
               <a:ext uri="{FF2B5EF4-FFF2-40B4-BE49-F238E27FC236}">
-                <a16:creationId xmlns:a16="http://schemas.microsoft.com/office/drawing/2014/main" id="{CFE1A348-308E-4546-A686-B6B53A65C9DF}"/>
+                <a16:creationId xmlns:a16="http://schemas.microsoft.com/office/drawing/2014/main" id="{A70A2A55-F637-46F2-A2FA-9AAE0FA6C8C5}"/>
               </a:ext>
             </a:extLst>
           </p:cNvPr>
@@ -18484,7 +18494,7 @@
           <p:cNvPr id="23" name="">
             <a:extLst xmlns:a="http://schemas.openxmlformats.org/drawingml/2006/main">
               <a:ext uri="{FF2B5EF4-FFF2-40B4-BE49-F238E27FC236}">
-                <a16:creationId xmlns:a16="http://schemas.microsoft.com/office/drawing/2014/main" id="{BA0BC734-0027-4348-97D3-7825C1AE6798}"/>
+                <a16:creationId xmlns:a16="http://schemas.microsoft.com/office/drawing/2014/main" id="{DA641BD9-C7DE-4BDE-995D-4568D72F96FC}"/>
               </a:ext>
             </a:extLst>
           </p:cNvPr>
@@ -18541,7 +18551,7 @@
           <p:cNvPr id="24" name="">
             <a:extLst xmlns:a="http://schemas.openxmlformats.org/drawingml/2006/main">
               <a:ext uri="{FF2B5EF4-FFF2-40B4-BE49-F238E27FC236}">
-                <a16:creationId xmlns:a16="http://schemas.microsoft.com/office/drawing/2014/main" id="{83692943-6133-4180-80A5-68E63663E426}"/>
+                <a16:creationId xmlns:a16="http://schemas.microsoft.com/office/drawing/2014/main" id="{A8CB017E-EA05-4735-A200-7F54FEEFC37F}"/>
               </a:ext>
             </a:extLst>
           </p:cNvPr>
@@ -18598,7 +18608,7 @@
           <p:cNvPr id="25" name="">
             <a:extLst xmlns:a="http://schemas.openxmlformats.org/drawingml/2006/main">
               <a:ext uri="{FF2B5EF4-FFF2-40B4-BE49-F238E27FC236}">
-                <a16:creationId xmlns:a16="http://schemas.microsoft.com/office/drawing/2014/main" id="{28B024ED-6D0F-4985-8209-95B7288B4BB3}"/>
+                <a16:creationId xmlns:a16="http://schemas.microsoft.com/office/drawing/2014/main" id="{255AE024-7B31-4ECB-9E34-086E94788480}"/>
               </a:ext>
             </a:extLst>
           </p:cNvPr>
@@ -18655,7 +18665,7 @@
           <p:cNvPr id="26" name="">
             <a:extLst xmlns:a="http://schemas.openxmlformats.org/drawingml/2006/main">
               <a:ext uri="{FF2B5EF4-FFF2-40B4-BE49-F238E27FC236}">
-                <a16:creationId xmlns:a16="http://schemas.microsoft.com/office/drawing/2014/main" id="{A8F53A12-910D-4264-9B1B-F3A7787FFDE0}"/>
+                <a16:creationId xmlns:a16="http://schemas.microsoft.com/office/drawing/2014/main" id="{3CDC307A-2DD5-4933-981C-25B1F35058B5}"/>
               </a:ext>
             </a:extLst>
           </p:cNvPr>
@@ -18712,7 +18722,7 @@
           <p:cNvPr id="27" name="">
             <a:extLst xmlns:a="http://schemas.openxmlformats.org/drawingml/2006/main">
               <a:ext uri="{FF2B5EF4-FFF2-40B4-BE49-F238E27FC236}">
-                <a16:creationId xmlns:a16="http://schemas.microsoft.com/office/drawing/2014/main" id="{912B34E9-00BC-4714-AE0B-8246C2365D6B}"/>
+                <a16:creationId xmlns:a16="http://schemas.microsoft.com/office/drawing/2014/main" id="{D037374D-2D8A-4CD9-9F79-FD722F5B021C}"/>
               </a:ext>
             </a:extLst>
           </p:cNvPr>
@@ -18769,7 +18779,7 @@
           <p:cNvPr id="28" name="">
             <a:extLst xmlns:a="http://schemas.openxmlformats.org/drawingml/2006/main">
               <a:ext uri="{FF2B5EF4-FFF2-40B4-BE49-F238E27FC236}">
-                <a16:creationId xmlns:a16="http://schemas.microsoft.com/office/drawing/2014/main" id="{62B6B943-A8BB-445A-81D7-DC5A87D311DF}"/>
+                <a16:creationId xmlns:a16="http://schemas.microsoft.com/office/drawing/2014/main" id="{6FF33164-DBD4-438E-B503-06E78DFC4372}"/>
               </a:ext>
             </a:extLst>
           </p:cNvPr>
@@ -18826,7 +18836,7 @@
           <p:cNvPr id="29" name="">
             <a:extLst xmlns:a="http://schemas.openxmlformats.org/drawingml/2006/main">
               <a:ext uri="{FF2B5EF4-FFF2-40B4-BE49-F238E27FC236}">
-                <a16:creationId xmlns:a16="http://schemas.microsoft.com/office/drawing/2014/main" id="{9C538ACF-1782-490E-8FC8-780F574F004C}"/>
+                <a16:creationId xmlns:a16="http://schemas.microsoft.com/office/drawing/2014/main" id="{754229C7-F408-47FE-BC3A-7B89F5805CEA}"/>
               </a:ext>
             </a:extLst>
           </p:cNvPr>
@@ -18857,7 +18867,7 @@
           <p:cNvPr id="30" name="">
             <a:extLst xmlns:a="http://schemas.openxmlformats.org/drawingml/2006/main">
               <a:ext uri="{FF2B5EF4-FFF2-40B4-BE49-F238E27FC236}">
-                <a16:creationId xmlns:a16="http://schemas.microsoft.com/office/drawing/2014/main" id="{D3608966-998F-4258-8CD9-BBE7C3AE9759}"/>
+                <a16:creationId xmlns:a16="http://schemas.microsoft.com/office/drawing/2014/main" id="{3CE0FA7F-1F1D-409B-9C08-29903271B469}"/>
               </a:ext>
             </a:extLst>
           </p:cNvPr>
@@ -18914,7 +18924,7 @@
           <p:cNvPr id="31" name="">
             <a:extLst xmlns:a="http://schemas.openxmlformats.org/drawingml/2006/main">
               <a:ext uri="{FF2B5EF4-FFF2-40B4-BE49-F238E27FC236}">
-                <a16:creationId xmlns:a16="http://schemas.microsoft.com/office/drawing/2014/main" id="{51BF388A-E6F2-4104-AD59-D3F67281B2C8}"/>
+                <a16:creationId xmlns:a16="http://schemas.microsoft.com/office/drawing/2014/main" id="{9869D33C-B8AE-4958-BA24-E78CD0E002B3}"/>
               </a:ext>
             </a:extLst>
           </p:cNvPr>
@@ -18969,7 +18979,7 @@
     </p:spTree>
     <p:extLst>
       <p:ext uri="{BB962C8B-B14F-4D97-AF65-F5344CB8AC3E}">
-        <p14:creationId xmlns:p14="http://schemas.microsoft.com/office/powerpoint/2010/main" val="37158302"/>
+        <p14:creationId xmlns:p14="http://schemas.microsoft.com/office/powerpoint/2010/main" val="325607186"/>
       </p:ext>
     </p:extLst>
   </p:cSld>
@@ -19000,7 +19010,7 @@
           <p:cNvPr id="13" name="">
             <a:extLst xmlns:a="http://schemas.openxmlformats.org/drawingml/2006/main">
               <a:ext uri="{FF2B5EF4-FFF2-40B4-BE49-F238E27FC236}">
-                <a16:creationId xmlns:a16="http://schemas.microsoft.com/office/drawing/2014/main" id="{A0A2160D-6EA6-48A1-81CC-6CD987A0B36B}"/>
+                <a16:creationId xmlns:a16="http://schemas.microsoft.com/office/drawing/2014/main" id="{7AE9B6A7-A90F-4EB6-8778-DB1D7E155BD3}"/>
               </a:ext>
             </a:extLst>
           </p:cNvPr>
@@ -19057,7 +19067,7 @@
           <p:cNvPr id="2" name="">
             <a:extLst xmlns:a="http://schemas.openxmlformats.org/drawingml/2006/main">
               <a:ext uri="{FF2B5EF4-FFF2-40B4-BE49-F238E27FC236}">
-                <a16:creationId xmlns:a16="http://schemas.microsoft.com/office/drawing/2014/main" id="{BD2E84F7-BE80-4525-BC99-A6410F1DA3F7}"/>
+                <a16:creationId xmlns:a16="http://schemas.microsoft.com/office/drawing/2014/main" id="{EC11FADB-C515-40EC-B3B7-494ED163CC22}"/>
               </a:ext>
             </a:extLst>
           </p:cNvPr>
@@ -19088,7 +19098,7 @@
           <p:cNvPr id="3" name="">
             <a:extLst xmlns:a="http://schemas.openxmlformats.org/drawingml/2006/main">
               <a:ext uri="{FF2B5EF4-FFF2-40B4-BE49-F238E27FC236}">
-                <a16:creationId xmlns:a16="http://schemas.microsoft.com/office/drawing/2014/main" id="{CAEC155B-26CE-43EB-A0D5-3A513D48FA70}"/>
+                <a16:creationId xmlns:a16="http://schemas.microsoft.com/office/drawing/2014/main" id="{526A9B82-B63E-4BEE-95BF-141FBB4738AA}"/>
               </a:ext>
             </a:extLst>
           </p:cNvPr>
@@ -19145,7 +19155,7 @@
           <p:cNvPr id="4" name="">
             <a:extLst xmlns:a="http://schemas.openxmlformats.org/drawingml/2006/main">
               <a:ext uri="{FF2B5EF4-FFF2-40B4-BE49-F238E27FC236}">
-                <a16:creationId xmlns:a16="http://schemas.microsoft.com/office/drawing/2014/main" id="{10FF0476-119E-47F3-BB9C-182B3CC78C5C}"/>
+                <a16:creationId xmlns:a16="http://schemas.microsoft.com/office/drawing/2014/main" id="{675D2CFE-C711-4569-A87F-6038CD025B7D}"/>
               </a:ext>
             </a:extLst>
           </p:cNvPr>
@@ -19202,7 +19212,7 @@
           <p:cNvPr id="5" name="">
             <a:extLst xmlns:a="http://schemas.openxmlformats.org/drawingml/2006/main">
               <a:ext uri="{FF2B5EF4-FFF2-40B4-BE49-F238E27FC236}">
-                <a16:creationId xmlns:a16="http://schemas.microsoft.com/office/drawing/2014/main" id="{A6B5BE9C-C3F5-498A-AEE1-131CD7228D52}"/>
+                <a16:creationId xmlns:a16="http://schemas.microsoft.com/office/drawing/2014/main" id="{599889B8-0690-4AE5-B7B2-468E8E3B5AB9}"/>
               </a:ext>
             </a:extLst>
           </p:cNvPr>
@@ -19259,7 +19269,7 @@
           <p:cNvPr id="6" name="">
             <a:extLst xmlns:a="http://schemas.openxmlformats.org/drawingml/2006/main">
               <a:ext uri="{FF2B5EF4-FFF2-40B4-BE49-F238E27FC236}">
-                <a16:creationId xmlns:a16="http://schemas.microsoft.com/office/drawing/2014/main" id="{0C4003EA-D2B0-431A-B446-A9276DDCDAB9}"/>
+                <a16:creationId xmlns:a16="http://schemas.microsoft.com/office/drawing/2014/main" id="{ABAC7CE7-8FC1-4EFA-A2E9-62D5C2C034CB}"/>
               </a:ext>
             </a:extLst>
           </p:cNvPr>
@@ -19316,7 +19326,7 @@
           <p:cNvPr id="7" name="">
             <a:extLst xmlns:a="http://schemas.openxmlformats.org/drawingml/2006/main">
               <a:ext uri="{FF2B5EF4-FFF2-40B4-BE49-F238E27FC236}">
-                <a16:creationId xmlns:a16="http://schemas.microsoft.com/office/drawing/2014/main" id="{3C0808F7-36A6-46DB-B91C-0E07244C7C2A}"/>
+                <a16:creationId xmlns:a16="http://schemas.microsoft.com/office/drawing/2014/main" id="{D4CE2CE5-8CD3-4A06-886B-1B062D47A0AD}"/>
               </a:ext>
             </a:extLst>
           </p:cNvPr>
@@ -19373,7 +19383,7 @@
           <p:cNvPr id="8" name="">
             <a:extLst xmlns:a="http://schemas.openxmlformats.org/drawingml/2006/main">
               <a:ext uri="{FF2B5EF4-FFF2-40B4-BE49-F238E27FC236}">
-                <a16:creationId xmlns:a16="http://schemas.microsoft.com/office/drawing/2014/main" id="{04E0A51F-135B-47D7-8B99-B1CAE8378C9C}"/>
+                <a16:creationId xmlns:a16="http://schemas.microsoft.com/office/drawing/2014/main" id="{3AD9B918-B2F0-47F5-82FA-9FE7542136BF}"/>
               </a:ext>
             </a:extLst>
           </p:cNvPr>
@@ -19430,7 +19440,7 @@
           <p:cNvPr id="9" name="">
             <a:extLst xmlns:a="http://schemas.openxmlformats.org/drawingml/2006/main">
               <a:ext uri="{FF2B5EF4-FFF2-40B4-BE49-F238E27FC236}">
-                <a16:creationId xmlns:a16="http://schemas.microsoft.com/office/drawing/2014/main" id="{0F7CE378-E27A-47CF-9C87-324C3E5920D1}"/>
+                <a16:creationId xmlns:a16="http://schemas.microsoft.com/office/drawing/2014/main" id="{560BAF99-8D0C-4F8A-B293-BBA4940E800D}"/>
               </a:ext>
             </a:extLst>
           </p:cNvPr>
@@ -19487,7 +19497,7 @@
           <p:cNvPr id="10" name="">
             <a:extLst xmlns:a="http://schemas.openxmlformats.org/drawingml/2006/main">
               <a:ext uri="{FF2B5EF4-FFF2-40B4-BE49-F238E27FC236}">
-                <a16:creationId xmlns:a16="http://schemas.microsoft.com/office/drawing/2014/main" id="{0C10A195-B033-47DC-8E04-DDD83FBC00B6}"/>
+                <a16:creationId xmlns:a16="http://schemas.microsoft.com/office/drawing/2014/main" id="{3F438168-3A45-4E2F-8972-615039320EDD}"/>
               </a:ext>
             </a:extLst>
           </p:cNvPr>
@@ -19544,7 +19554,7 @@
           <p:cNvPr id="11" name="">
             <a:extLst xmlns:a="http://schemas.openxmlformats.org/drawingml/2006/main">
               <a:ext uri="{FF2B5EF4-FFF2-40B4-BE49-F238E27FC236}">
-                <a16:creationId xmlns:a16="http://schemas.microsoft.com/office/drawing/2014/main" id="{2E4F82FE-B038-4688-A1A1-ADCCDD8B56EA}"/>
+                <a16:creationId xmlns:a16="http://schemas.microsoft.com/office/drawing/2014/main" id="{953A5C78-1E26-4460-8B1E-68D1BB5D39D2}"/>
               </a:ext>
             </a:extLst>
           </p:cNvPr>
@@ -19575,7 +19585,7 @@
           <p:cNvPr id="12" name="">
             <a:extLst xmlns:a="http://schemas.openxmlformats.org/drawingml/2006/main">
               <a:ext uri="{FF2B5EF4-FFF2-40B4-BE49-F238E27FC236}">
-                <a16:creationId xmlns:a16="http://schemas.microsoft.com/office/drawing/2014/main" id="{7062B5D2-E45D-4163-8BBE-2E35E65B238A}"/>
+                <a16:creationId xmlns:a16="http://schemas.microsoft.com/office/drawing/2014/main" id="{E1515BF2-D057-474E-AEA0-EAEA85AD2C7B}"/>
               </a:ext>
             </a:extLst>
           </p:cNvPr>
@@ -19630,7 +19640,7 @@
     </p:spTree>
     <p:extLst>
       <p:ext uri="{BB962C8B-B14F-4D97-AF65-F5344CB8AC3E}">
-        <p14:creationId xmlns:p14="http://schemas.microsoft.com/office/powerpoint/2010/main" val="1010104369"/>
+        <p14:creationId xmlns:p14="http://schemas.microsoft.com/office/powerpoint/2010/main" val="377141941"/>
       </p:ext>
     </p:extLst>
   </p:cSld>
@@ -19661,7 +19671,7 @@
           <p:cNvPr id="19" name="">
             <a:extLst xmlns:a="http://schemas.openxmlformats.org/drawingml/2006/main">
               <a:ext uri="{FF2B5EF4-FFF2-40B4-BE49-F238E27FC236}">
-                <a16:creationId xmlns:a16="http://schemas.microsoft.com/office/drawing/2014/main" id="{7F8C494D-50CA-4A95-B9FF-56628330FF0C}"/>
+                <a16:creationId xmlns:a16="http://schemas.microsoft.com/office/drawing/2014/main" id="{4F950A4C-7639-4709-BD4A-827D4997A321}"/>
               </a:ext>
             </a:extLst>
           </p:cNvPr>
@@ -19718,7 +19728,7 @@
           <p:cNvPr id="2" name="">
             <a:extLst xmlns:a="http://schemas.openxmlformats.org/drawingml/2006/main">
               <a:ext uri="{FF2B5EF4-FFF2-40B4-BE49-F238E27FC236}">
-                <a16:creationId xmlns:a16="http://schemas.microsoft.com/office/drawing/2014/main" id="{C52A8733-7B72-4C7B-BCC3-A8B3D37F7F36}"/>
+                <a16:creationId xmlns:a16="http://schemas.microsoft.com/office/drawing/2014/main" id="{3B5D382E-3C3B-4294-8513-3318BF94DB28}"/>
               </a:ext>
             </a:extLst>
           </p:cNvPr>
@@ -19749,7 +19759,7 @@
           <p:cNvPr id="3" name="">
             <a:extLst xmlns:a="http://schemas.openxmlformats.org/drawingml/2006/main">
               <a:ext uri="{FF2B5EF4-FFF2-40B4-BE49-F238E27FC236}">
-                <a16:creationId xmlns:a16="http://schemas.microsoft.com/office/drawing/2014/main" id="{73580599-876F-458E-B099-BCC545D2674E}"/>
+                <a16:creationId xmlns:a16="http://schemas.microsoft.com/office/drawing/2014/main" id="{AD1DDAEC-721B-403D-8D9B-FAC1617E7459}"/>
               </a:ext>
             </a:extLst>
           </p:cNvPr>
@@ -19806,7 +19816,7 @@
           <p:cNvPr id="4" name="">
             <a:extLst xmlns:a="http://schemas.openxmlformats.org/drawingml/2006/main">
               <a:ext uri="{FF2B5EF4-FFF2-40B4-BE49-F238E27FC236}">
-                <a16:creationId xmlns:a16="http://schemas.microsoft.com/office/drawing/2014/main" id="{661075AC-F3EA-4AF2-B76F-0E37CBDF5ED3}"/>
+                <a16:creationId xmlns:a16="http://schemas.microsoft.com/office/drawing/2014/main" id="{7FCDD981-044A-48AB-B6FC-ED0BE1C441C8}"/>
               </a:ext>
             </a:extLst>
           </p:cNvPr>
@@ -19863,7 +19873,7 @@
           <p:cNvPr id="5" name="">
             <a:extLst xmlns:a="http://schemas.openxmlformats.org/drawingml/2006/main">
               <a:ext uri="{FF2B5EF4-FFF2-40B4-BE49-F238E27FC236}">
-                <a16:creationId xmlns:a16="http://schemas.microsoft.com/office/drawing/2014/main" id="{4B44D3D5-103F-40CC-A5EA-A505964EC26E}"/>
+                <a16:creationId xmlns:a16="http://schemas.microsoft.com/office/drawing/2014/main" id="{6C96F0E4-5E4C-4793-81F9-A5E1B7D92278}"/>
               </a:ext>
             </a:extLst>
           </p:cNvPr>
@@ -19943,7 +19953,7 @@
           <p:cNvPr id="6" name="">
             <a:extLst xmlns:a="http://schemas.openxmlformats.org/drawingml/2006/main">
               <a:ext uri="{FF2B5EF4-FFF2-40B4-BE49-F238E27FC236}">
-                <a16:creationId xmlns:a16="http://schemas.microsoft.com/office/drawing/2014/main" id="{456BEAA9-8395-4FE8-B6CB-C15F989A68AE}"/>
+                <a16:creationId xmlns:a16="http://schemas.microsoft.com/office/drawing/2014/main" id="{A13D70CE-7FEC-4163-8799-2B51009C4020}"/>
               </a:ext>
             </a:extLst>
           </p:cNvPr>
@@ -20000,7 +20010,7 @@
           <p:cNvPr id="7" name="">
             <a:extLst xmlns:a="http://schemas.openxmlformats.org/drawingml/2006/main">
               <a:ext uri="{FF2B5EF4-FFF2-40B4-BE49-F238E27FC236}">
-                <a16:creationId xmlns:a16="http://schemas.microsoft.com/office/drawing/2014/main" id="{7DCE09A8-757A-4733-B53E-273B14B08220}"/>
+                <a16:creationId xmlns:a16="http://schemas.microsoft.com/office/drawing/2014/main" id="{A94E690B-1BEB-4F17-8E5D-8C669E07D654}"/>
               </a:ext>
             </a:extLst>
           </p:cNvPr>
@@ -20033,7 +20043,7 @@
           <p:cNvPr id="8" name="">
             <a:extLst xmlns:a="http://schemas.openxmlformats.org/drawingml/2006/main">
               <a:ext uri="{FF2B5EF4-FFF2-40B4-BE49-F238E27FC236}">
-                <a16:creationId xmlns:a16="http://schemas.microsoft.com/office/drawing/2014/main" id="{45B5CBDE-FB4C-4FD9-884C-ADC4B8AE34D7}"/>
+                <a16:creationId xmlns:a16="http://schemas.microsoft.com/office/drawing/2014/main" id="{B0E922DA-8288-408B-B6CD-E1B1EB36E4A7}"/>
               </a:ext>
             </a:extLst>
           </p:cNvPr>
@@ -20090,7 +20100,7 @@
           <p:cNvPr id="9" name="">
             <a:extLst xmlns:a="http://schemas.openxmlformats.org/drawingml/2006/main">
               <a:ext uri="{FF2B5EF4-FFF2-40B4-BE49-F238E27FC236}">
-                <a16:creationId xmlns:a16="http://schemas.microsoft.com/office/drawing/2014/main" id="{D3F13BD8-4B25-4D50-A138-F3A75387CA16}"/>
+                <a16:creationId xmlns:a16="http://schemas.microsoft.com/office/drawing/2014/main" id="{C0826683-5AC5-46C8-B37F-5B2D0894C500}"/>
               </a:ext>
             </a:extLst>
           </p:cNvPr>
@@ -20123,7 +20133,7 @@
           <p:cNvPr id="10" name="">
             <a:extLst xmlns:a="http://schemas.openxmlformats.org/drawingml/2006/main">
               <a:ext uri="{FF2B5EF4-FFF2-40B4-BE49-F238E27FC236}">
-                <a16:creationId xmlns:a16="http://schemas.microsoft.com/office/drawing/2014/main" id="{9F3D225B-FF37-451C-B3D2-C5A9A44116BC}"/>
+                <a16:creationId xmlns:a16="http://schemas.microsoft.com/office/drawing/2014/main" id="{27141085-DD8A-4ECB-AB57-C6E742F00050}"/>
               </a:ext>
             </a:extLst>
           </p:cNvPr>
@@ -20180,7 +20190,7 @@
           <p:cNvPr id="11" name="">
             <a:extLst xmlns:a="http://schemas.openxmlformats.org/drawingml/2006/main">
               <a:ext uri="{FF2B5EF4-FFF2-40B4-BE49-F238E27FC236}">
-                <a16:creationId xmlns:a16="http://schemas.microsoft.com/office/drawing/2014/main" id="{F47B2249-DD2E-411C-813D-1F2A9FFC53A5}"/>
+                <a16:creationId xmlns:a16="http://schemas.microsoft.com/office/drawing/2014/main" id="{3649D383-FD8E-4E5F-8CAA-F3A196C4E597}"/>
               </a:ext>
             </a:extLst>
           </p:cNvPr>
@@ -20237,7 +20247,7 @@
           <p:cNvPr id="12" name="">
             <a:extLst xmlns:a="http://schemas.openxmlformats.org/drawingml/2006/main">
               <a:ext uri="{FF2B5EF4-FFF2-40B4-BE49-F238E27FC236}">
-                <a16:creationId xmlns:a16="http://schemas.microsoft.com/office/drawing/2014/main" id="{5E4F96D2-260C-4BA6-99B0-3A500BB38AB7}"/>
+                <a16:creationId xmlns:a16="http://schemas.microsoft.com/office/drawing/2014/main" id="{1B80E947-5C83-4E02-9A79-0DE675D742D1}"/>
               </a:ext>
             </a:extLst>
           </p:cNvPr>
@@ -20294,7 +20304,7 @@
           <p:cNvPr id="13" name="">
             <a:extLst xmlns:a="http://schemas.openxmlformats.org/drawingml/2006/main">
               <a:ext uri="{FF2B5EF4-FFF2-40B4-BE49-F238E27FC236}">
-                <a16:creationId xmlns:a16="http://schemas.microsoft.com/office/drawing/2014/main" id="{DDFEDB49-19A4-46A5-9FE0-67AB4B879EC9}"/>
+                <a16:creationId xmlns:a16="http://schemas.microsoft.com/office/drawing/2014/main" id="{512222E7-AD88-4FBD-BF35-04EBDB697AB9}"/>
               </a:ext>
             </a:extLst>
           </p:cNvPr>
@@ -20351,7 +20361,7 @@
           <p:cNvPr id="14" name="">
             <a:extLst xmlns:a="http://schemas.openxmlformats.org/drawingml/2006/main">
               <a:ext uri="{FF2B5EF4-FFF2-40B4-BE49-F238E27FC236}">
-                <a16:creationId xmlns:a16="http://schemas.microsoft.com/office/drawing/2014/main" id="{0B2E479C-64AE-48F3-821D-A19ED4B7EBB0}"/>
+                <a16:creationId xmlns:a16="http://schemas.microsoft.com/office/drawing/2014/main" id="{DA682149-530A-494A-A454-026C97A40583}"/>
               </a:ext>
             </a:extLst>
           </p:cNvPr>
@@ -20408,7 +20418,7 @@
           <p:cNvPr id="15" name="">
             <a:extLst xmlns:a="http://schemas.openxmlformats.org/drawingml/2006/main">
               <a:ext uri="{FF2B5EF4-FFF2-40B4-BE49-F238E27FC236}">
-                <a16:creationId xmlns:a16="http://schemas.microsoft.com/office/drawing/2014/main" id="{151B41DD-4AE9-418E-BB96-C72D2CDE7AA3}"/>
+                <a16:creationId xmlns:a16="http://schemas.microsoft.com/office/drawing/2014/main" id="{2F9BA2C4-F55A-4C35-BB56-B70C7C28717D}"/>
               </a:ext>
             </a:extLst>
           </p:cNvPr>
@@ -20441,7 +20451,7 @@
           <p:cNvPr id="16" name="">
             <a:extLst xmlns:a="http://schemas.openxmlformats.org/drawingml/2006/main">
               <a:ext uri="{FF2B5EF4-FFF2-40B4-BE49-F238E27FC236}">
-                <a16:creationId xmlns:a16="http://schemas.microsoft.com/office/drawing/2014/main" id="{69E1FAB0-0357-4E94-BFC4-E03CE4F00B32}"/>
+                <a16:creationId xmlns:a16="http://schemas.microsoft.com/office/drawing/2014/main" id="{7C5C0FF7-B135-46A9-A815-8DFCA8E18B4E}"/>
               </a:ext>
             </a:extLst>
           </p:cNvPr>
@@ -20498,7 +20508,7 @@
           <p:cNvPr id="17" name="">
             <a:extLst xmlns:a="http://schemas.openxmlformats.org/drawingml/2006/main">
               <a:ext uri="{FF2B5EF4-FFF2-40B4-BE49-F238E27FC236}">
-                <a16:creationId xmlns:a16="http://schemas.microsoft.com/office/drawing/2014/main" id="{0BF8BF89-C90D-4926-AF0F-C5BC7B9E8363}"/>
+                <a16:creationId xmlns:a16="http://schemas.microsoft.com/office/drawing/2014/main" id="{754276ED-966F-4BB2-9D48-7F39E7B9594A}"/>
               </a:ext>
             </a:extLst>
           </p:cNvPr>
@@ -20529,7 +20539,7 @@
           <p:cNvPr id="18" name="">
             <a:extLst xmlns:a="http://schemas.openxmlformats.org/drawingml/2006/main">
               <a:ext uri="{FF2B5EF4-FFF2-40B4-BE49-F238E27FC236}">
-                <a16:creationId xmlns:a16="http://schemas.microsoft.com/office/drawing/2014/main" id="{981E2074-E953-44BD-8880-780FE023CB17}"/>
+                <a16:creationId xmlns:a16="http://schemas.microsoft.com/office/drawing/2014/main" id="{AE7835B7-7488-4BFA-89AA-45249531221C}"/>
               </a:ext>
             </a:extLst>
           </p:cNvPr>
@@ -20584,7 +20594,7 @@
     </p:spTree>
     <p:extLst>
       <p:ext uri="{BB962C8B-B14F-4D97-AF65-F5344CB8AC3E}">
-        <p14:creationId xmlns:p14="http://schemas.microsoft.com/office/powerpoint/2010/main" val="615758645"/>
+        <p14:creationId xmlns:p14="http://schemas.microsoft.com/office/powerpoint/2010/main" val="764084816"/>
       </p:ext>
     </p:extLst>
   </p:cSld>

</xml_diff>

<commit_message>
Protect PMDay slides 1 through 11 and record narrative proposal
</commit_message>
<xml_diff>
--- a/assets/presentations/pmday-2026/ai-changes-both-sides.pptx
+++ b/assets/presentations/pmday-2026/ai-changes-both-sides.pptx
@@ -2,26 +2,26 @@
 <file path=ppt/presentation.xml><?xml version="1.0" encoding="utf-8"?>
 <p:presentation xmlns:p="http://schemas.openxmlformats.org/presentationml/2006/main">
   <p:sldMasterIdLst>
-    <p:sldMasterId xmlns:r="http://schemas.openxmlformats.org/officeDocument/2006/relationships" id="2147483648" r:id="Rd16cce49c2bc4311"/>
+    <p:sldMasterId xmlns:r="http://schemas.openxmlformats.org/officeDocument/2006/relationships" id="2147483648" r:id="R0151db1dee034aeb"/>
   </p:sldMasterIdLst>
   <p:notesMasterIdLst>
-    <p:notesMasterId xmlns:r="http://schemas.openxmlformats.org/officeDocument/2006/relationships" r:id="R09d81b496dcf450b"/>
+    <p:notesMasterId xmlns:r="http://schemas.openxmlformats.org/officeDocument/2006/relationships" r:id="R858b13ff945f44a9"/>
   </p:notesMasterIdLst>
   <p:sldIdLst>
-    <p:sldId xmlns:r="http://schemas.openxmlformats.org/officeDocument/2006/relationships" id="256" r:id="R6ab2ac02c3a44572"/>
-    <p:sldId xmlns:r="http://schemas.openxmlformats.org/officeDocument/2006/relationships" id="257" r:id="Ref869b5fe3904fcc"/>
-    <p:sldId xmlns:r="http://schemas.openxmlformats.org/officeDocument/2006/relationships" id="258" r:id="R889337fa20564d5b"/>
-    <p:sldId xmlns:r="http://schemas.openxmlformats.org/officeDocument/2006/relationships" id="259" r:id="R5f8203332c3542f3"/>
-    <p:sldId xmlns:r="http://schemas.openxmlformats.org/officeDocument/2006/relationships" id="260" r:id="R728444f5982c47e6"/>
-    <p:sldId xmlns:r="http://schemas.openxmlformats.org/officeDocument/2006/relationships" id="261" r:id="R94636823f9e448c1"/>
-    <p:sldId xmlns:r="http://schemas.openxmlformats.org/officeDocument/2006/relationships" id="262" r:id="Re4c45875d8f54e94"/>
-    <p:sldId xmlns:r="http://schemas.openxmlformats.org/officeDocument/2006/relationships" id="263" r:id="R83171ac28c634f47"/>
-    <p:sldId xmlns:r="http://schemas.openxmlformats.org/officeDocument/2006/relationships" id="264" r:id="R70d0c1fc259c4440"/>
-    <p:sldId xmlns:r="http://schemas.openxmlformats.org/officeDocument/2006/relationships" id="265" r:id="R280e88125b294806"/>
-    <p:sldId xmlns:r="http://schemas.openxmlformats.org/officeDocument/2006/relationships" id="266" r:id="R4d0212b418a74b65"/>
-    <p:sldId xmlns:r="http://schemas.openxmlformats.org/officeDocument/2006/relationships" id="267" r:id="R8ed5810187ca43bb"/>
-    <p:sldId xmlns:r="http://schemas.openxmlformats.org/officeDocument/2006/relationships" id="268" r:id="R7b513ec8cf21449a"/>
-    <p:sldId xmlns:r="http://schemas.openxmlformats.org/officeDocument/2006/relationships" id="269" r:id="R7cdd14243922415c"/>
+    <p:sldId xmlns:r="http://schemas.openxmlformats.org/officeDocument/2006/relationships" id="256" r:id="R7052cec219674b41"/>
+    <p:sldId xmlns:r="http://schemas.openxmlformats.org/officeDocument/2006/relationships" id="257" r:id="R746a4464ed7a49de"/>
+    <p:sldId xmlns:r="http://schemas.openxmlformats.org/officeDocument/2006/relationships" id="258" r:id="R8d7f0ec998674295"/>
+    <p:sldId xmlns:r="http://schemas.openxmlformats.org/officeDocument/2006/relationships" id="259" r:id="Rf55e0c6469854ee6"/>
+    <p:sldId xmlns:r="http://schemas.openxmlformats.org/officeDocument/2006/relationships" id="260" r:id="R0167def12030471b"/>
+    <p:sldId xmlns:r="http://schemas.openxmlformats.org/officeDocument/2006/relationships" id="261" r:id="R71e066491ccf4c1f"/>
+    <p:sldId xmlns:r="http://schemas.openxmlformats.org/officeDocument/2006/relationships" id="262" r:id="R437681ad2655404b"/>
+    <p:sldId xmlns:r="http://schemas.openxmlformats.org/officeDocument/2006/relationships" id="263" r:id="R137fc34aa87b43c1"/>
+    <p:sldId xmlns:r="http://schemas.openxmlformats.org/officeDocument/2006/relationships" id="264" r:id="R4c861553dbdc475d"/>
+    <p:sldId xmlns:r="http://schemas.openxmlformats.org/officeDocument/2006/relationships" id="265" r:id="Rb7325872cd23468f"/>
+    <p:sldId xmlns:r="http://schemas.openxmlformats.org/officeDocument/2006/relationships" id="266" r:id="R4069cdc71e79473a"/>
+    <p:sldId xmlns:r="http://schemas.openxmlformats.org/officeDocument/2006/relationships" id="267" r:id="R01c7a19c25ba436c"/>
+    <p:sldId xmlns:r="http://schemas.openxmlformats.org/officeDocument/2006/relationships" id="268" r:id="Rae0c134a67d84f2c"/>
+    <p:sldId xmlns:r="http://schemas.openxmlformats.org/officeDocument/2006/relationships" id="269" r:id="Rb7d10a8f522b4fe9"/>
   </p:sldIdLst>
   <p:sldSz cx="12192000" cy="6858000"/>
   <p:notesSz cx="6858000" cy="9144000"/>
@@ -2193,7 +2193,7 @@
   </p:cSld>
   <p:clrMap bg1="lt1" tx1="dk1" bg2="lt2" tx2="dk2" accent1="accent1" accent2="accent2" accent3="accent3" accent4="accent4" accent5="accent5" accent6="accent6" hlink="hlink" folHlink="folHlink"/>
   <p:sldLayoutIdLst>
-    <p:sldLayoutId id="2147483649" r:id="Raa4cc6a8767f4ff7"/>
+    <p:sldLayoutId id="2147483649" r:id="R4a37ac5f9b70465a"/>
   </p:sldLayoutIdLst>
   <p:txStyles>
     <p:titleStyle>
@@ -3112,7 +3112,7 @@
           <p:cNvPr id="10" name="">
             <a:extLst xmlns:a="http://schemas.openxmlformats.org/drawingml/2006/main">
               <a:ext uri="{FF2B5EF4-FFF2-40B4-BE49-F238E27FC236}">
-                <a16:creationId xmlns:a16="http://schemas.microsoft.com/office/drawing/2014/main" id="{122CD03F-2458-4B99-829D-7E039D5514DB}"/>
+                <a16:creationId xmlns:a16="http://schemas.microsoft.com/office/drawing/2014/main" id="{45982EA4-CE4B-45B4-B184-CE85ABD849E1}"/>
               </a:ext>
             </a:extLst>
           </p:cNvPr>
@@ -3169,7 +3169,7 @@
           <p:cNvPr id="2" name="">
             <a:extLst xmlns:a="http://schemas.openxmlformats.org/drawingml/2006/main">
               <a:ext uri="{FF2B5EF4-FFF2-40B4-BE49-F238E27FC236}">
-                <a16:creationId xmlns:a16="http://schemas.microsoft.com/office/drawing/2014/main" id="{50D28FC8-AD3E-4868-8EC6-98454AA1686A}"/>
+                <a16:creationId xmlns:a16="http://schemas.microsoft.com/office/drawing/2014/main" id="{F9268FD6-F050-4304-9C86-E7323F54F950}"/>
               </a:ext>
             </a:extLst>
           </p:cNvPr>
@@ -3249,7 +3249,7 @@
           <p:cNvPr id="3" name="">
             <a:extLst xmlns:a="http://schemas.openxmlformats.org/drawingml/2006/main">
               <a:ext uri="{FF2B5EF4-FFF2-40B4-BE49-F238E27FC236}">
-                <a16:creationId xmlns:a16="http://schemas.microsoft.com/office/drawing/2014/main" id="{4BAD9580-E504-40CB-AC6B-783DD7C7CF34}"/>
+                <a16:creationId xmlns:a16="http://schemas.microsoft.com/office/drawing/2014/main" id="{3C0220A0-0643-4EE7-A62F-1C8BF8D65B3C}"/>
               </a:ext>
             </a:extLst>
           </p:cNvPr>
@@ -3310,7 +3310,7 @@
           <p:nvPr/>
         </p:nvPicPr>
         <p:blipFill>
-          <a:blip xmlns:r="http://schemas.openxmlformats.org/officeDocument/2006/relationships" xmlns:a="http://schemas.openxmlformats.org/drawingml/2006/main" r:embed="R57d9f54852394f01"/>
+          <a:blip xmlns:r="http://schemas.openxmlformats.org/officeDocument/2006/relationships" xmlns:a="http://schemas.openxmlformats.org/drawingml/2006/main" r:embed="Ra7392916fd524628"/>
           <a:stretch xmlns:a="http://schemas.openxmlformats.org/drawingml/2006/main"/>
         </p:blipFill>
         <p:spPr>
@@ -3328,7 +3328,7 @@
           <p:cNvPr id="5" name="">
             <a:extLst xmlns:a="http://schemas.openxmlformats.org/drawingml/2006/main">
               <a:ext uri="{FF2B5EF4-FFF2-40B4-BE49-F238E27FC236}">
-                <a16:creationId xmlns:a16="http://schemas.microsoft.com/office/drawing/2014/main" id="{CD252CFB-E0D4-4E68-A432-81553113E693}"/>
+                <a16:creationId xmlns:a16="http://schemas.microsoft.com/office/drawing/2014/main" id="{0A082CCF-6AD6-4092-A62D-C17F8C3921FD}"/>
               </a:ext>
             </a:extLst>
           </p:cNvPr>
@@ -3385,7 +3385,7 @@
           <p:cNvPr id="6" name="">
             <a:extLst xmlns:a="http://schemas.openxmlformats.org/drawingml/2006/main">
               <a:ext uri="{FF2B5EF4-FFF2-40B4-BE49-F238E27FC236}">
-                <a16:creationId xmlns:a16="http://schemas.microsoft.com/office/drawing/2014/main" id="{F26B04CF-B371-4A4F-918A-D37FC51E4201}"/>
+                <a16:creationId xmlns:a16="http://schemas.microsoft.com/office/drawing/2014/main" id="{BBCBAE38-EE2F-46F2-B110-F15895262B2F}"/>
               </a:ext>
             </a:extLst>
           </p:cNvPr>
@@ -3442,7 +3442,7 @@
           <p:cNvPr id="7" name="">
             <a:extLst xmlns:a="http://schemas.openxmlformats.org/drawingml/2006/main">
               <a:ext uri="{FF2B5EF4-FFF2-40B4-BE49-F238E27FC236}">
-                <a16:creationId xmlns:a16="http://schemas.microsoft.com/office/drawing/2014/main" id="{9FD937DD-647C-4C13-8B0E-58DA5A5BE779}"/>
+                <a16:creationId xmlns:a16="http://schemas.microsoft.com/office/drawing/2014/main" id="{2E9D6FC9-443A-4361-BD1A-E685A9A5C70F}"/>
               </a:ext>
             </a:extLst>
           </p:cNvPr>
@@ -3499,7 +3499,7 @@
           <p:cNvPr id="8" name="">
             <a:extLst xmlns:a="http://schemas.openxmlformats.org/drawingml/2006/main">
               <a:ext uri="{FF2B5EF4-FFF2-40B4-BE49-F238E27FC236}">
-                <a16:creationId xmlns:a16="http://schemas.microsoft.com/office/drawing/2014/main" id="{FC5CF782-03ED-4393-BB1A-A1B90D0D0C36}"/>
+                <a16:creationId xmlns:a16="http://schemas.microsoft.com/office/drawing/2014/main" id="{F1D95438-3288-4B72-8B17-0B0A104956DE}"/>
               </a:ext>
             </a:extLst>
           </p:cNvPr>
@@ -3556,7 +3556,7 @@
           <p:cNvPr id="9" name="">
             <a:extLst xmlns:a="http://schemas.openxmlformats.org/drawingml/2006/main">
               <a:ext uri="{FF2B5EF4-FFF2-40B4-BE49-F238E27FC236}">
-                <a16:creationId xmlns:a16="http://schemas.microsoft.com/office/drawing/2014/main" id="{12B74BA0-5C68-472F-A5DC-9C6128938A55}"/>
+                <a16:creationId xmlns:a16="http://schemas.microsoft.com/office/drawing/2014/main" id="{13A6DB2B-D75D-4EBE-85FC-6088B8B8CF0D}"/>
               </a:ext>
             </a:extLst>
           </p:cNvPr>
@@ -3611,7 +3611,7 @@
     </p:spTree>
     <p:extLst>
       <p:ext uri="{BB962C8B-B14F-4D97-AF65-F5344CB8AC3E}">
-        <p14:creationId xmlns:p14="http://schemas.microsoft.com/office/powerpoint/2010/main" val="1881552192"/>
+        <p14:creationId xmlns:p14="http://schemas.microsoft.com/office/powerpoint/2010/main" val="124501376"/>
       </p:ext>
     </p:extLst>
   </p:cSld>
@@ -3642,7 +3642,7 @@
           <p:cNvPr id="46" name="">
             <a:extLst xmlns:a="http://schemas.openxmlformats.org/drawingml/2006/main">
               <a:ext uri="{FF2B5EF4-FFF2-40B4-BE49-F238E27FC236}">
-                <a16:creationId xmlns:a16="http://schemas.microsoft.com/office/drawing/2014/main" id="{25D778C1-DD8E-45FC-8FB1-F24E7DF3D2AF}"/>
+                <a16:creationId xmlns:a16="http://schemas.microsoft.com/office/drawing/2014/main" id="{88D71E00-F1B6-47FE-9E7F-F70045FE7FE6}"/>
               </a:ext>
             </a:extLst>
           </p:cNvPr>
@@ -3699,7 +3699,7 @@
           <p:cNvPr id="2" name="">
             <a:extLst xmlns:a="http://schemas.openxmlformats.org/drawingml/2006/main">
               <a:ext uri="{FF2B5EF4-FFF2-40B4-BE49-F238E27FC236}">
-                <a16:creationId xmlns:a16="http://schemas.microsoft.com/office/drawing/2014/main" id="{81DD9BD0-6C06-4BEF-9326-9354A8267F25}"/>
+                <a16:creationId xmlns:a16="http://schemas.microsoft.com/office/drawing/2014/main" id="{E3AAC84E-14F8-43B8-9CC8-89845AB8891D}"/>
               </a:ext>
             </a:extLst>
           </p:cNvPr>
@@ -3730,7 +3730,7 @@
           <p:cNvPr id="3" name="">
             <a:extLst xmlns:a="http://schemas.openxmlformats.org/drawingml/2006/main">
               <a:ext uri="{FF2B5EF4-FFF2-40B4-BE49-F238E27FC236}">
-                <a16:creationId xmlns:a16="http://schemas.microsoft.com/office/drawing/2014/main" id="{EC93935D-A503-4BDA-AD9F-62EB21E5F6BF}"/>
+                <a16:creationId xmlns:a16="http://schemas.microsoft.com/office/drawing/2014/main" id="{E75B1097-1E22-45C8-A4BF-99386C18A267}"/>
               </a:ext>
             </a:extLst>
           </p:cNvPr>
@@ -3787,7 +3787,7 @@
           <p:cNvPr id="4" name="">
             <a:extLst xmlns:a="http://schemas.openxmlformats.org/drawingml/2006/main">
               <a:ext uri="{FF2B5EF4-FFF2-40B4-BE49-F238E27FC236}">
-                <a16:creationId xmlns:a16="http://schemas.microsoft.com/office/drawing/2014/main" id="{F22FFD71-D8BC-49AA-A79A-E3DAF7A1C723}"/>
+                <a16:creationId xmlns:a16="http://schemas.microsoft.com/office/drawing/2014/main" id="{4401F8FE-676D-4032-A485-4DAC9C707F10}"/>
               </a:ext>
             </a:extLst>
           </p:cNvPr>
@@ -3844,7 +3844,7 @@
           <p:cNvPr id="5" name="">
             <a:extLst xmlns:a="http://schemas.openxmlformats.org/drawingml/2006/main">
               <a:ext uri="{FF2B5EF4-FFF2-40B4-BE49-F238E27FC236}">
-                <a16:creationId xmlns:a16="http://schemas.microsoft.com/office/drawing/2014/main" id="{56716FD9-442B-4CE8-A2EE-0C9EDFE554CD}"/>
+                <a16:creationId xmlns:a16="http://schemas.microsoft.com/office/drawing/2014/main" id="{584138C9-F83C-4832-9B43-A6182D4C4A74}"/>
               </a:ext>
             </a:extLst>
           </p:cNvPr>
@@ -3901,7 +3901,7 @@
           <p:cNvPr id="6" name="">
             <a:extLst xmlns:a="http://schemas.openxmlformats.org/drawingml/2006/main">
               <a:ext uri="{FF2B5EF4-FFF2-40B4-BE49-F238E27FC236}">
-                <a16:creationId xmlns:a16="http://schemas.microsoft.com/office/drawing/2014/main" id="{52EF2606-8910-49DF-B471-01940E506C3B}"/>
+                <a16:creationId xmlns:a16="http://schemas.microsoft.com/office/drawing/2014/main" id="{7DD00523-E8EC-4A31-B768-425F9626BE46}"/>
               </a:ext>
             </a:extLst>
           </p:cNvPr>
@@ -3981,7 +3981,7 @@
           <p:cNvPr id="7" name="">
             <a:extLst xmlns:a="http://schemas.openxmlformats.org/drawingml/2006/main">
               <a:ext uri="{FF2B5EF4-FFF2-40B4-BE49-F238E27FC236}">
-                <a16:creationId xmlns:a16="http://schemas.microsoft.com/office/drawing/2014/main" id="{F0D9FD0C-259D-487D-8D5F-0BC87C1F6D45}"/>
+                <a16:creationId xmlns:a16="http://schemas.microsoft.com/office/drawing/2014/main" id="{DCD3594A-3A2C-495D-920F-4CC7F4458288}"/>
               </a:ext>
             </a:extLst>
           </p:cNvPr>
@@ -4061,7 +4061,7 @@
           <p:cNvPr id="8" name="">
             <a:extLst xmlns:a="http://schemas.openxmlformats.org/drawingml/2006/main">
               <a:ext uri="{FF2B5EF4-FFF2-40B4-BE49-F238E27FC236}">
-                <a16:creationId xmlns:a16="http://schemas.microsoft.com/office/drawing/2014/main" id="{F6191158-7470-457C-8507-8E40F7ABECBA}"/>
+                <a16:creationId xmlns:a16="http://schemas.microsoft.com/office/drawing/2014/main" id="{A009E286-4F66-4657-9FD1-532C86F89F3F}"/>
               </a:ext>
             </a:extLst>
           </p:cNvPr>
@@ -4118,7 +4118,7 @@
           <p:cNvPr id="9" name="">
             <a:extLst xmlns:a="http://schemas.openxmlformats.org/drawingml/2006/main">
               <a:ext uri="{FF2B5EF4-FFF2-40B4-BE49-F238E27FC236}">
-                <a16:creationId xmlns:a16="http://schemas.microsoft.com/office/drawing/2014/main" id="{1D57D416-BC13-402C-BFD2-037825123CC1}"/>
+                <a16:creationId xmlns:a16="http://schemas.microsoft.com/office/drawing/2014/main" id="{950DCCC8-B88E-469D-99A6-A56BB3DBA3FD}"/>
               </a:ext>
             </a:extLst>
           </p:cNvPr>
@@ -4175,7 +4175,7 @@
           <p:cNvPr id="10" name="">
             <a:extLst xmlns:a="http://schemas.openxmlformats.org/drawingml/2006/main">
               <a:ext uri="{FF2B5EF4-FFF2-40B4-BE49-F238E27FC236}">
-                <a16:creationId xmlns:a16="http://schemas.microsoft.com/office/drawing/2014/main" id="{4AD03FCB-195E-45C7-8297-6DF2164DB570}"/>
+                <a16:creationId xmlns:a16="http://schemas.microsoft.com/office/drawing/2014/main" id="{1737EF7B-986D-4224-9FE5-119C64269AB7}"/>
               </a:ext>
             </a:extLst>
           </p:cNvPr>
@@ -4206,7 +4206,7 @@
           <p:cNvPr id="11" name="">
             <a:extLst xmlns:a="http://schemas.openxmlformats.org/drawingml/2006/main">
               <a:ext uri="{FF2B5EF4-FFF2-40B4-BE49-F238E27FC236}">
-                <a16:creationId xmlns:a16="http://schemas.microsoft.com/office/drawing/2014/main" id="{C7CA33C8-314F-4AA6-B367-4399F413798D}"/>
+                <a16:creationId xmlns:a16="http://schemas.microsoft.com/office/drawing/2014/main" id="{A8F1930F-961C-4A89-A8E2-A844E5E95335}"/>
               </a:ext>
             </a:extLst>
           </p:cNvPr>
@@ -4239,7 +4239,7 @@
           <p:cNvPr id="12" name="">
             <a:extLst xmlns:a="http://schemas.openxmlformats.org/drawingml/2006/main">
               <a:ext uri="{FF2B5EF4-FFF2-40B4-BE49-F238E27FC236}">
-                <a16:creationId xmlns:a16="http://schemas.microsoft.com/office/drawing/2014/main" id="{A3B84A68-157E-4341-9F2E-746A9C3C3252}"/>
+                <a16:creationId xmlns:a16="http://schemas.microsoft.com/office/drawing/2014/main" id="{63B4632C-643B-4257-AFB1-67F6C3C31D34}"/>
               </a:ext>
             </a:extLst>
           </p:cNvPr>
@@ -4272,7 +4272,7 @@
           <p:cNvPr id="13" name="">
             <a:extLst xmlns:a="http://schemas.openxmlformats.org/drawingml/2006/main">
               <a:ext uri="{FF2B5EF4-FFF2-40B4-BE49-F238E27FC236}">
-                <a16:creationId xmlns:a16="http://schemas.microsoft.com/office/drawing/2014/main" id="{1CEC3EF3-1E3B-44EE-9D7B-7F179D023BF8}"/>
+                <a16:creationId xmlns:a16="http://schemas.microsoft.com/office/drawing/2014/main" id="{D5A98AFC-AF10-45A8-B16E-715BE64EEE21}"/>
               </a:ext>
             </a:extLst>
           </p:cNvPr>
@@ -4305,7 +4305,7 @@
           <p:cNvPr id="14" name="">
             <a:extLst xmlns:a="http://schemas.openxmlformats.org/drawingml/2006/main">
               <a:ext uri="{FF2B5EF4-FFF2-40B4-BE49-F238E27FC236}">
-                <a16:creationId xmlns:a16="http://schemas.microsoft.com/office/drawing/2014/main" id="{CB661F33-B6D2-4A11-ADBB-CCE7F2072DE5}"/>
+                <a16:creationId xmlns:a16="http://schemas.microsoft.com/office/drawing/2014/main" id="{C0ECBD63-9168-40A0-98E7-D1438DA2AFA1}"/>
               </a:ext>
             </a:extLst>
           </p:cNvPr>
@@ -4338,7 +4338,7 @@
           <p:cNvPr id="15" name="">
             <a:extLst xmlns:a="http://schemas.openxmlformats.org/drawingml/2006/main">
               <a:ext uri="{FF2B5EF4-FFF2-40B4-BE49-F238E27FC236}">
-                <a16:creationId xmlns:a16="http://schemas.microsoft.com/office/drawing/2014/main" id="{22AB96E5-9385-4654-954E-8FBA164C8437}"/>
+                <a16:creationId xmlns:a16="http://schemas.microsoft.com/office/drawing/2014/main" id="{8B131308-A483-43D8-B8D0-EA330A71A389}"/>
               </a:ext>
             </a:extLst>
           </p:cNvPr>
@@ -4371,7 +4371,7 @@
           <p:cNvPr id="16" name="">
             <a:extLst xmlns:a="http://schemas.openxmlformats.org/drawingml/2006/main">
               <a:ext uri="{FF2B5EF4-FFF2-40B4-BE49-F238E27FC236}">
-                <a16:creationId xmlns:a16="http://schemas.microsoft.com/office/drawing/2014/main" id="{B4A412B8-217C-45BC-B682-FDE0132647E5}"/>
+                <a16:creationId xmlns:a16="http://schemas.microsoft.com/office/drawing/2014/main" id="{865A620B-AA65-49E5-AB9D-843915108A3D}"/>
               </a:ext>
             </a:extLst>
           </p:cNvPr>
@@ -4404,7 +4404,7 @@
           <p:cNvPr id="17" name="">
             <a:extLst xmlns:a="http://schemas.openxmlformats.org/drawingml/2006/main">
               <a:ext uri="{FF2B5EF4-FFF2-40B4-BE49-F238E27FC236}">
-                <a16:creationId xmlns:a16="http://schemas.microsoft.com/office/drawing/2014/main" id="{71F0FA08-8B40-4F26-9391-E1558A7BC762}"/>
+                <a16:creationId xmlns:a16="http://schemas.microsoft.com/office/drawing/2014/main" id="{1992D043-4BD1-4D3B-AC09-2054BA2CEE10}"/>
               </a:ext>
             </a:extLst>
           </p:cNvPr>
@@ -4437,7 +4437,7 @@
           <p:cNvPr id="18" name="">
             <a:extLst xmlns:a="http://schemas.openxmlformats.org/drawingml/2006/main">
               <a:ext uri="{FF2B5EF4-FFF2-40B4-BE49-F238E27FC236}">
-                <a16:creationId xmlns:a16="http://schemas.microsoft.com/office/drawing/2014/main" id="{1CDB3264-5C2B-4883-AC8E-D4C01E031B05}"/>
+                <a16:creationId xmlns:a16="http://schemas.microsoft.com/office/drawing/2014/main" id="{D4B0519C-F59F-4342-B7CC-A95DAB6D3CD1}"/>
               </a:ext>
             </a:extLst>
           </p:cNvPr>
@@ -4470,7 +4470,7 @@
           <p:cNvPr id="19" name="">
             <a:extLst xmlns:a="http://schemas.openxmlformats.org/drawingml/2006/main">
               <a:ext uri="{FF2B5EF4-FFF2-40B4-BE49-F238E27FC236}">
-                <a16:creationId xmlns:a16="http://schemas.microsoft.com/office/drawing/2014/main" id="{3BA798F1-EDEB-4D9D-83FE-3AAEC2F452DC}"/>
+                <a16:creationId xmlns:a16="http://schemas.microsoft.com/office/drawing/2014/main" id="{E3730CED-41AB-4558-9101-B7B8D0CA5A3B}"/>
               </a:ext>
             </a:extLst>
           </p:cNvPr>
@@ -4503,7 +4503,7 @@
           <p:cNvPr id="20" name="">
             <a:extLst xmlns:a="http://schemas.openxmlformats.org/drawingml/2006/main">
               <a:ext uri="{FF2B5EF4-FFF2-40B4-BE49-F238E27FC236}">
-                <a16:creationId xmlns:a16="http://schemas.microsoft.com/office/drawing/2014/main" id="{46A36C22-47DA-4CC5-9FBA-8436400E01A8}"/>
+                <a16:creationId xmlns:a16="http://schemas.microsoft.com/office/drawing/2014/main" id="{5AEA58C5-30A3-41B3-BC3B-DC730B891A21}"/>
               </a:ext>
             </a:extLst>
           </p:cNvPr>
@@ -4536,7 +4536,7 @@
           <p:cNvPr id="21" name="">
             <a:extLst xmlns:a="http://schemas.openxmlformats.org/drawingml/2006/main">
               <a:ext uri="{FF2B5EF4-FFF2-40B4-BE49-F238E27FC236}">
-                <a16:creationId xmlns:a16="http://schemas.microsoft.com/office/drawing/2014/main" id="{46EB5A79-0C48-4268-B10E-017AD96F7017}"/>
+                <a16:creationId xmlns:a16="http://schemas.microsoft.com/office/drawing/2014/main" id="{06F1E3A4-01B8-4658-9FFC-60D4DBD7FE70}"/>
               </a:ext>
             </a:extLst>
           </p:cNvPr>
@@ -4569,7 +4569,7 @@
           <p:cNvPr id="22" name="">
             <a:extLst xmlns:a="http://schemas.openxmlformats.org/drawingml/2006/main">
               <a:ext uri="{FF2B5EF4-FFF2-40B4-BE49-F238E27FC236}">
-                <a16:creationId xmlns:a16="http://schemas.microsoft.com/office/drawing/2014/main" id="{070C60B4-4B82-43DF-9D48-2B53608EB040}"/>
+                <a16:creationId xmlns:a16="http://schemas.microsoft.com/office/drawing/2014/main" id="{55792460-4E60-4367-9B93-C19ECFD32DCF}"/>
               </a:ext>
             </a:extLst>
           </p:cNvPr>
@@ -4602,7 +4602,7 @@
           <p:cNvPr id="23" name="">
             <a:extLst xmlns:a="http://schemas.openxmlformats.org/drawingml/2006/main">
               <a:ext uri="{FF2B5EF4-FFF2-40B4-BE49-F238E27FC236}">
-                <a16:creationId xmlns:a16="http://schemas.microsoft.com/office/drawing/2014/main" id="{6AC3D972-6EF8-40ED-B4FF-A47AE9B0DF39}"/>
+                <a16:creationId xmlns:a16="http://schemas.microsoft.com/office/drawing/2014/main" id="{FD4D2EA5-4A18-4AE4-AD09-D4274072A3A8}"/>
               </a:ext>
             </a:extLst>
           </p:cNvPr>
@@ -4635,7 +4635,7 @@
           <p:cNvPr id="24" name="">
             <a:extLst xmlns:a="http://schemas.openxmlformats.org/drawingml/2006/main">
               <a:ext uri="{FF2B5EF4-FFF2-40B4-BE49-F238E27FC236}">
-                <a16:creationId xmlns:a16="http://schemas.microsoft.com/office/drawing/2014/main" id="{FC4E0CFD-6AD5-4367-880C-D2149FCBEBAC}"/>
+                <a16:creationId xmlns:a16="http://schemas.microsoft.com/office/drawing/2014/main" id="{616AE507-E605-4025-999A-CF798852FACE}"/>
               </a:ext>
             </a:extLst>
           </p:cNvPr>
@@ -4666,7 +4666,7 @@
           <p:cNvPr id="25" name="">
             <a:extLst xmlns:a="http://schemas.openxmlformats.org/drawingml/2006/main">
               <a:ext uri="{FF2B5EF4-FFF2-40B4-BE49-F238E27FC236}">
-                <a16:creationId xmlns:a16="http://schemas.microsoft.com/office/drawing/2014/main" id="{327426F2-47F8-47E9-8D75-8FFD993934F0}"/>
+                <a16:creationId xmlns:a16="http://schemas.microsoft.com/office/drawing/2014/main" id="{B9C5015B-6DA4-446A-8E20-84F79EFDF7DB}"/>
               </a:ext>
             </a:extLst>
           </p:cNvPr>
@@ -4697,7 +4697,7 @@
           <p:cNvPr id="26" name="">
             <a:extLst xmlns:a="http://schemas.openxmlformats.org/drawingml/2006/main">
               <a:ext uri="{FF2B5EF4-FFF2-40B4-BE49-F238E27FC236}">
-                <a16:creationId xmlns:a16="http://schemas.microsoft.com/office/drawing/2014/main" id="{9840DD1B-73DF-4C10-A602-437630B04F2C}"/>
+                <a16:creationId xmlns:a16="http://schemas.microsoft.com/office/drawing/2014/main" id="{1889247F-C93F-42F3-93E2-428634B7AC5D}"/>
               </a:ext>
             </a:extLst>
           </p:cNvPr>
@@ -4728,7 +4728,7 @@
           <p:cNvPr id="27" name="">
             <a:extLst xmlns:a="http://schemas.openxmlformats.org/drawingml/2006/main">
               <a:ext uri="{FF2B5EF4-FFF2-40B4-BE49-F238E27FC236}">
-                <a16:creationId xmlns:a16="http://schemas.microsoft.com/office/drawing/2014/main" id="{20D0E27C-2FA0-4B03-9A43-B742BD72B852}"/>
+                <a16:creationId xmlns:a16="http://schemas.microsoft.com/office/drawing/2014/main" id="{F5D55212-CD85-463D-8F4E-8F0156745D73}"/>
               </a:ext>
             </a:extLst>
           </p:cNvPr>
@@ -4759,7 +4759,7 @@
           <p:cNvPr id="28" name="">
             <a:extLst xmlns:a="http://schemas.openxmlformats.org/drawingml/2006/main">
               <a:ext uri="{FF2B5EF4-FFF2-40B4-BE49-F238E27FC236}">
-                <a16:creationId xmlns:a16="http://schemas.microsoft.com/office/drawing/2014/main" id="{9DD9EFC2-F8E9-487A-ABF4-D1B51168E0DB}"/>
+                <a16:creationId xmlns:a16="http://schemas.microsoft.com/office/drawing/2014/main" id="{9A9A764F-35FC-4617-BA04-4411F6411C88}"/>
               </a:ext>
             </a:extLst>
           </p:cNvPr>
@@ -4862,7 +4862,7 @@
           <p:cNvPr id="29" name="">
             <a:extLst xmlns:a="http://schemas.openxmlformats.org/drawingml/2006/main">
               <a:ext uri="{FF2B5EF4-FFF2-40B4-BE49-F238E27FC236}">
-                <a16:creationId xmlns:a16="http://schemas.microsoft.com/office/drawing/2014/main" id="{EB6F4764-DD27-46F0-9B3D-E842892E1DCB}"/>
+                <a16:creationId xmlns:a16="http://schemas.microsoft.com/office/drawing/2014/main" id="{8844A858-1416-4C43-8D85-06B392AA59A1}"/>
               </a:ext>
             </a:extLst>
           </p:cNvPr>
@@ -4919,7 +4919,7 @@
           <p:cNvPr id="30" name="">
             <a:extLst xmlns:a="http://schemas.openxmlformats.org/drawingml/2006/main">
               <a:ext uri="{FF2B5EF4-FFF2-40B4-BE49-F238E27FC236}">
-                <a16:creationId xmlns:a16="http://schemas.microsoft.com/office/drawing/2014/main" id="{5EB1D22D-2342-415C-B37C-4B3CB98AB3F4}"/>
+                <a16:creationId xmlns:a16="http://schemas.microsoft.com/office/drawing/2014/main" id="{6CA74778-1242-404C-8189-69C1BA6F51BB}"/>
               </a:ext>
             </a:extLst>
           </p:cNvPr>
@@ -4976,7 +4976,7 @@
           <p:cNvPr id="31" name="">
             <a:extLst xmlns:a="http://schemas.openxmlformats.org/drawingml/2006/main">
               <a:ext uri="{FF2B5EF4-FFF2-40B4-BE49-F238E27FC236}">
-                <a16:creationId xmlns:a16="http://schemas.microsoft.com/office/drawing/2014/main" id="{1ABCA95F-E651-4FAE-B2EC-E168DF49D524}"/>
+                <a16:creationId xmlns:a16="http://schemas.microsoft.com/office/drawing/2014/main" id="{E62E2C27-AC01-49C3-AB87-876D30A3687F}"/>
               </a:ext>
             </a:extLst>
           </p:cNvPr>
@@ -5033,7 +5033,7 @@
           <p:cNvPr id="32" name="">
             <a:extLst xmlns:a="http://schemas.openxmlformats.org/drawingml/2006/main">
               <a:ext uri="{FF2B5EF4-FFF2-40B4-BE49-F238E27FC236}">
-                <a16:creationId xmlns:a16="http://schemas.microsoft.com/office/drawing/2014/main" id="{E40061CF-7918-489D-AD4B-508DF3802595}"/>
+                <a16:creationId xmlns:a16="http://schemas.microsoft.com/office/drawing/2014/main" id="{7C9F6AEB-D4C1-4CAC-A6B3-8E0439852FE3}"/>
               </a:ext>
             </a:extLst>
           </p:cNvPr>
@@ -5090,7 +5090,7 @@
           <p:cNvPr id="33" name="">
             <a:extLst xmlns:a="http://schemas.openxmlformats.org/drawingml/2006/main">
               <a:ext uri="{FF2B5EF4-FFF2-40B4-BE49-F238E27FC236}">
-                <a16:creationId xmlns:a16="http://schemas.microsoft.com/office/drawing/2014/main" id="{ED817C3C-22B0-4DD4-9759-BCD6FD930733}"/>
+                <a16:creationId xmlns:a16="http://schemas.microsoft.com/office/drawing/2014/main" id="{909FFAEA-B74F-4E28-914B-3D43FC258FC3}"/>
               </a:ext>
             </a:extLst>
           </p:cNvPr>
@@ -5121,7 +5121,7 @@
           <p:cNvPr id="34" name="">
             <a:extLst xmlns:a="http://schemas.openxmlformats.org/drawingml/2006/main">
               <a:ext uri="{FF2B5EF4-FFF2-40B4-BE49-F238E27FC236}">
-                <a16:creationId xmlns:a16="http://schemas.microsoft.com/office/drawing/2014/main" id="{F7CC3954-7157-4E2F-B26D-0C23B8147183}"/>
+                <a16:creationId xmlns:a16="http://schemas.microsoft.com/office/drawing/2014/main" id="{D766A13A-A7D9-421C-B0E0-E710371F6CFC}"/>
               </a:ext>
             </a:extLst>
           </p:cNvPr>
@@ -5185,7 +5185,7 @@
         </p:xfrm>
         <a:graphic xmlns:a="http://schemas.openxmlformats.org/drawingml/2006/main">
           <a:graphicData uri="http://schemas.openxmlformats.org/drawingml/2006/chart">
-            <c:chart xmlns:r="http://schemas.openxmlformats.org/officeDocument/2006/relationships" xmlns:c="http://schemas.openxmlformats.org/drawingml/2006/chart" r:id="R0f139ec6901146a1"/>
+            <c:chart xmlns:r="http://schemas.openxmlformats.org/officeDocument/2006/relationships" xmlns:c="http://schemas.openxmlformats.org/drawingml/2006/chart" r:id="Rf9ec41015da84701"/>
           </a:graphicData>
         </a:graphic>
       </p:graphicFrame>
@@ -5194,7 +5194,7 @@
           <p:cNvPr id="36" name="">
             <a:extLst xmlns:a="http://schemas.openxmlformats.org/drawingml/2006/main">
               <a:ext uri="{FF2B5EF4-FFF2-40B4-BE49-F238E27FC236}">
-                <a16:creationId xmlns:a16="http://schemas.microsoft.com/office/drawing/2014/main" id="{2AF54B9E-243C-4083-AEC1-B8E677525400}"/>
+                <a16:creationId xmlns:a16="http://schemas.microsoft.com/office/drawing/2014/main" id="{D274F3C3-8EF8-41F8-B77B-6DD3155AFF9E}"/>
               </a:ext>
             </a:extLst>
           </p:cNvPr>
@@ -5225,7 +5225,7 @@
           <p:cNvPr id="37" name="">
             <a:extLst xmlns:a="http://schemas.openxmlformats.org/drawingml/2006/main">
               <a:ext uri="{FF2B5EF4-FFF2-40B4-BE49-F238E27FC236}">
-                <a16:creationId xmlns:a16="http://schemas.microsoft.com/office/drawing/2014/main" id="{F9083982-C275-44DB-B695-A34933EA3953}"/>
+                <a16:creationId xmlns:a16="http://schemas.microsoft.com/office/drawing/2014/main" id="{A2A9E2D3-5F03-4C90-B2DE-F70EA8D9F171}"/>
               </a:ext>
             </a:extLst>
           </p:cNvPr>
@@ -5282,7 +5282,7 @@
           <p:cNvPr id="38" name="">
             <a:extLst xmlns:a="http://schemas.openxmlformats.org/drawingml/2006/main">
               <a:ext uri="{FF2B5EF4-FFF2-40B4-BE49-F238E27FC236}">
-                <a16:creationId xmlns:a16="http://schemas.microsoft.com/office/drawing/2014/main" id="{EAD42C54-E43C-4D8B-92A8-87BD26D2FC4E}"/>
+                <a16:creationId xmlns:a16="http://schemas.microsoft.com/office/drawing/2014/main" id="{DFC246C4-75ED-4316-96E6-5D107F6C7447}"/>
               </a:ext>
             </a:extLst>
           </p:cNvPr>
@@ -5339,7 +5339,7 @@
           <p:cNvPr id="39" name="">
             <a:extLst xmlns:a="http://schemas.openxmlformats.org/drawingml/2006/main">
               <a:ext uri="{FF2B5EF4-FFF2-40B4-BE49-F238E27FC236}">
-                <a16:creationId xmlns:a16="http://schemas.microsoft.com/office/drawing/2014/main" id="{84AEC26E-1C5B-40E9-A133-009F6BE72B53}"/>
+                <a16:creationId xmlns:a16="http://schemas.microsoft.com/office/drawing/2014/main" id="{C55786C0-80FB-4262-A2A7-BCBE90F9F423}"/>
               </a:ext>
             </a:extLst>
           </p:cNvPr>
@@ -5396,7 +5396,7 @@
           <p:cNvPr id="40" name="">
             <a:extLst xmlns:a="http://schemas.openxmlformats.org/drawingml/2006/main">
               <a:ext uri="{FF2B5EF4-FFF2-40B4-BE49-F238E27FC236}">
-                <a16:creationId xmlns:a16="http://schemas.microsoft.com/office/drawing/2014/main" id="{9ECC2887-1883-4698-BA53-B486670EF996}"/>
+                <a16:creationId xmlns:a16="http://schemas.microsoft.com/office/drawing/2014/main" id="{81C92086-6D95-4199-B6D9-96A14CDE540A}"/>
               </a:ext>
             </a:extLst>
           </p:cNvPr>
@@ -5453,7 +5453,7 @@
           <p:cNvPr id="41" name="">
             <a:extLst xmlns:a="http://schemas.openxmlformats.org/drawingml/2006/main">
               <a:ext uri="{FF2B5EF4-FFF2-40B4-BE49-F238E27FC236}">
-                <a16:creationId xmlns:a16="http://schemas.microsoft.com/office/drawing/2014/main" id="{ED93C8EC-CC5E-4009-9E37-13B1098CDCCA}"/>
+                <a16:creationId xmlns:a16="http://schemas.microsoft.com/office/drawing/2014/main" id="{959A7C62-1DB2-46FD-92DB-F46D86AAA97D}"/>
               </a:ext>
             </a:extLst>
           </p:cNvPr>
@@ -5510,7 +5510,7 @@
           <p:cNvPr id="42" name="">
             <a:extLst xmlns:a="http://schemas.openxmlformats.org/drawingml/2006/main">
               <a:ext uri="{FF2B5EF4-FFF2-40B4-BE49-F238E27FC236}">
-                <a16:creationId xmlns:a16="http://schemas.microsoft.com/office/drawing/2014/main" id="{8718287E-C4BA-4C5C-A752-D8404A2F08C4}"/>
+                <a16:creationId xmlns:a16="http://schemas.microsoft.com/office/drawing/2014/main" id="{264CF075-7DB3-456E-BF4B-B568A092009B}"/>
               </a:ext>
             </a:extLst>
           </p:cNvPr>
@@ -5567,7 +5567,7 @@
           <p:cNvPr id="43" name="">
             <a:extLst xmlns:a="http://schemas.openxmlformats.org/drawingml/2006/main">
               <a:ext uri="{FF2B5EF4-FFF2-40B4-BE49-F238E27FC236}">
-                <a16:creationId xmlns:a16="http://schemas.microsoft.com/office/drawing/2014/main" id="{55A93034-74EC-42A1-87E0-DCB36E6FC39F}"/>
+                <a16:creationId xmlns:a16="http://schemas.microsoft.com/office/drawing/2014/main" id="{5CA20663-D176-41CE-8DFE-A1080A1988A2}"/>
               </a:ext>
             </a:extLst>
           </p:cNvPr>
@@ -5624,7 +5624,7 @@
           <p:cNvPr id="44" name="">
             <a:extLst xmlns:a="http://schemas.openxmlformats.org/drawingml/2006/main">
               <a:ext uri="{FF2B5EF4-FFF2-40B4-BE49-F238E27FC236}">
-                <a16:creationId xmlns:a16="http://schemas.microsoft.com/office/drawing/2014/main" id="{E9909154-BAAB-4416-A18E-8EDF45256F05}"/>
+                <a16:creationId xmlns:a16="http://schemas.microsoft.com/office/drawing/2014/main" id="{D84F0CB0-5FD9-48AA-BCFC-A3A0BB44C59B}"/>
               </a:ext>
             </a:extLst>
           </p:cNvPr>
@@ -5681,7 +5681,7 @@
           <p:cNvPr id="45" name="">
             <a:extLst xmlns:a="http://schemas.openxmlformats.org/drawingml/2006/main">
               <a:ext uri="{FF2B5EF4-FFF2-40B4-BE49-F238E27FC236}">
-                <a16:creationId xmlns:a16="http://schemas.microsoft.com/office/drawing/2014/main" id="{CA3B1FC3-9F10-4BDA-92CF-114DE4B77ACA}"/>
+                <a16:creationId xmlns:a16="http://schemas.microsoft.com/office/drawing/2014/main" id="{25BE9A04-20B7-4A7A-822C-91B802B32D8D}"/>
               </a:ext>
             </a:extLst>
           </p:cNvPr>
@@ -5736,7 +5736,7 @@
     </p:spTree>
     <p:extLst>
       <p:ext uri="{BB962C8B-B14F-4D97-AF65-F5344CB8AC3E}">
-        <p14:creationId xmlns:p14="http://schemas.microsoft.com/office/powerpoint/2010/main" val="12852074"/>
+        <p14:creationId xmlns:p14="http://schemas.microsoft.com/office/powerpoint/2010/main" val="1961936349"/>
       </p:ext>
     </p:extLst>
   </p:cSld>
@@ -5767,7 +5767,7 @@
           <p:cNvPr id="10" name="">
             <a:extLst xmlns:a="http://schemas.openxmlformats.org/drawingml/2006/main">
               <a:ext uri="{FF2B5EF4-FFF2-40B4-BE49-F238E27FC236}">
-                <a16:creationId xmlns:a16="http://schemas.microsoft.com/office/drawing/2014/main" id="{C99634F2-FE04-481B-8316-B59449356CB1}"/>
+                <a16:creationId xmlns:a16="http://schemas.microsoft.com/office/drawing/2014/main" id="{BC3E50E5-4139-4C68-A65C-23378B778636}"/>
               </a:ext>
             </a:extLst>
           </p:cNvPr>
@@ -5824,7 +5824,7 @@
           <p:cNvPr id="2" name="">
             <a:extLst xmlns:a="http://schemas.openxmlformats.org/drawingml/2006/main">
               <a:ext uri="{FF2B5EF4-FFF2-40B4-BE49-F238E27FC236}">
-                <a16:creationId xmlns:a16="http://schemas.microsoft.com/office/drawing/2014/main" id="{732668D4-7F1D-4175-82CD-7276F24818AC}"/>
+                <a16:creationId xmlns:a16="http://schemas.microsoft.com/office/drawing/2014/main" id="{F61EF5AE-ADB4-4B9E-B138-DE82F9FB0F95}"/>
               </a:ext>
             </a:extLst>
           </p:cNvPr>
@@ -5855,7 +5855,7 @@
           <p:cNvPr id="3" name="">
             <a:extLst xmlns:a="http://schemas.openxmlformats.org/drawingml/2006/main">
               <a:ext uri="{FF2B5EF4-FFF2-40B4-BE49-F238E27FC236}">
-                <a16:creationId xmlns:a16="http://schemas.microsoft.com/office/drawing/2014/main" id="{08DC1222-83BB-43C9-AA6C-B7DDC064CA69}"/>
+                <a16:creationId xmlns:a16="http://schemas.microsoft.com/office/drawing/2014/main" id="{E0CFDEBE-2048-41B6-95C8-6F45492D1C79}"/>
               </a:ext>
             </a:extLst>
           </p:cNvPr>
@@ -5912,7 +5912,7 @@
           <p:cNvPr id="4" name="">
             <a:extLst xmlns:a="http://schemas.openxmlformats.org/drawingml/2006/main">
               <a:ext uri="{FF2B5EF4-FFF2-40B4-BE49-F238E27FC236}">
-                <a16:creationId xmlns:a16="http://schemas.microsoft.com/office/drawing/2014/main" id="{3A4B5DC3-609A-4C75-BC8B-115C2CE583A0}"/>
+                <a16:creationId xmlns:a16="http://schemas.microsoft.com/office/drawing/2014/main" id="{4A1B5F58-D3D6-47C4-8F95-A1EC68EDE479}"/>
               </a:ext>
             </a:extLst>
           </p:cNvPr>
@@ -5969,7 +5969,7 @@
           <p:cNvPr id="5" name="">
             <a:extLst xmlns:a="http://schemas.openxmlformats.org/drawingml/2006/main">
               <a:ext uri="{FF2B5EF4-FFF2-40B4-BE49-F238E27FC236}">
-                <a16:creationId xmlns:a16="http://schemas.microsoft.com/office/drawing/2014/main" id="{360D88B4-F686-4E40-81D5-8C527811E4CD}"/>
+                <a16:creationId xmlns:a16="http://schemas.microsoft.com/office/drawing/2014/main" id="{E949A618-4935-4E33-9C7A-470788D1011C}"/>
               </a:ext>
             </a:extLst>
           </p:cNvPr>
@@ -6840,7 +6840,7 @@
           <p:cNvPr id="7" name="">
             <a:extLst xmlns:a="http://schemas.openxmlformats.org/drawingml/2006/main">
               <a:ext uri="{FF2B5EF4-FFF2-40B4-BE49-F238E27FC236}">
-                <a16:creationId xmlns:a16="http://schemas.microsoft.com/office/drawing/2014/main" id="{CA08C843-E78C-4952-AFA4-87CC34320D5E}"/>
+                <a16:creationId xmlns:a16="http://schemas.microsoft.com/office/drawing/2014/main" id="{5E1CB62F-6404-47A3-8739-EA5A448C83D9}"/>
               </a:ext>
             </a:extLst>
           </p:cNvPr>
@@ -6897,7 +6897,7 @@
           <p:cNvPr id="8" name="">
             <a:extLst xmlns:a="http://schemas.openxmlformats.org/drawingml/2006/main">
               <a:ext uri="{FF2B5EF4-FFF2-40B4-BE49-F238E27FC236}">
-                <a16:creationId xmlns:a16="http://schemas.microsoft.com/office/drawing/2014/main" id="{7F041A1F-6D94-47C5-92E2-EE9BA2900A24}"/>
+                <a16:creationId xmlns:a16="http://schemas.microsoft.com/office/drawing/2014/main" id="{7FB74D9F-8C4C-4427-B352-BBD30F2A8F4F}"/>
               </a:ext>
             </a:extLst>
           </p:cNvPr>
@@ -6954,7 +6954,7 @@
           <p:cNvPr id="9" name="">
             <a:extLst xmlns:a="http://schemas.openxmlformats.org/drawingml/2006/main">
               <a:ext uri="{FF2B5EF4-FFF2-40B4-BE49-F238E27FC236}">
-                <a16:creationId xmlns:a16="http://schemas.microsoft.com/office/drawing/2014/main" id="{175997B0-0B77-4B33-B7AC-BBE8E6963862}"/>
+                <a16:creationId xmlns:a16="http://schemas.microsoft.com/office/drawing/2014/main" id="{002B6DD4-F199-479A-8CE5-6E26C56E7584}"/>
               </a:ext>
             </a:extLst>
           </p:cNvPr>
@@ -7009,7 +7009,7 @@
     </p:spTree>
     <p:extLst>
       <p:ext uri="{BB962C8B-B14F-4D97-AF65-F5344CB8AC3E}">
-        <p14:creationId xmlns:p14="http://schemas.microsoft.com/office/powerpoint/2010/main" val="519591481"/>
+        <p14:creationId xmlns:p14="http://schemas.microsoft.com/office/powerpoint/2010/main" val="1589561089"/>
       </p:ext>
     </p:extLst>
   </p:cSld>
@@ -7040,7 +7040,7 @@
           <p:cNvPr id="52" name="">
             <a:extLst xmlns:a="http://schemas.openxmlformats.org/drawingml/2006/main">
               <a:ext uri="{FF2B5EF4-FFF2-40B4-BE49-F238E27FC236}">
-                <a16:creationId xmlns:a16="http://schemas.microsoft.com/office/drawing/2014/main" id="{D83FE62C-DE07-491A-9F7C-0304D2425AFB}"/>
+                <a16:creationId xmlns:a16="http://schemas.microsoft.com/office/drawing/2014/main" id="{68E66601-7CEF-4952-B3D1-2B79062A6A4B}"/>
               </a:ext>
             </a:extLst>
           </p:cNvPr>
@@ -7097,7 +7097,7 @@
           <p:cNvPr id="2" name="">
             <a:extLst xmlns:a="http://schemas.openxmlformats.org/drawingml/2006/main">
               <a:ext uri="{FF2B5EF4-FFF2-40B4-BE49-F238E27FC236}">
-                <a16:creationId xmlns:a16="http://schemas.microsoft.com/office/drawing/2014/main" id="{4102CD68-E04B-4581-9305-160DB2ED5062}"/>
+                <a16:creationId xmlns:a16="http://schemas.microsoft.com/office/drawing/2014/main" id="{FC884DA2-9A88-465B-9308-6E23D62CF14D}"/>
               </a:ext>
             </a:extLst>
           </p:cNvPr>
@@ -7128,7 +7128,7 @@
           <p:cNvPr id="3" name="">
             <a:extLst xmlns:a="http://schemas.openxmlformats.org/drawingml/2006/main">
               <a:ext uri="{FF2B5EF4-FFF2-40B4-BE49-F238E27FC236}">
-                <a16:creationId xmlns:a16="http://schemas.microsoft.com/office/drawing/2014/main" id="{379B5780-FD70-4EB6-9C13-0738F9B4F700}"/>
+                <a16:creationId xmlns:a16="http://schemas.microsoft.com/office/drawing/2014/main" id="{E839AD60-43D1-4266-A69E-FA6EBA2BF719}"/>
               </a:ext>
             </a:extLst>
           </p:cNvPr>
@@ -7185,7 +7185,7 @@
           <p:cNvPr id="4" name="">
             <a:extLst xmlns:a="http://schemas.openxmlformats.org/drawingml/2006/main">
               <a:ext uri="{FF2B5EF4-FFF2-40B4-BE49-F238E27FC236}">
-                <a16:creationId xmlns:a16="http://schemas.microsoft.com/office/drawing/2014/main" id="{421136CD-9DC5-40A2-B968-8943372714E8}"/>
+                <a16:creationId xmlns:a16="http://schemas.microsoft.com/office/drawing/2014/main" id="{286F32CD-8BC4-481C-8AD1-70A57C10C61F}"/>
               </a:ext>
             </a:extLst>
           </p:cNvPr>
@@ -7242,7 +7242,7 @@
           <p:cNvPr id="5" name="">
             <a:extLst xmlns:a="http://schemas.openxmlformats.org/drawingml/2006/main">
               <a:ext uri="{FF2B5EF4-FFF2-40B4-BE49-F238E27FC236}">
-                <a16:creationId xmlns:a16="http://schemas.microsoft.com/office/drawing/2014/main" id="{4B1C2E85-BEE6-44F3-8327-7F0417BB36B5}"/>
+                <a16:creationId xmlns:a16="http://schemas.microsoft.com/office/drawing/2014/main" id="{A3213B5D-F409-476E-8978-1DE4971D4C67}"/>
               </a:ext>
             </a:extLst>
           </p:cNvPr>
@@ -7299,7 +7299,7 @@
           <p:cNvPr id="6" name="">
             <a:extLst xmlns:a="http://schemas.openxmlformats.org/drawingml/2006/main">
               <a:ext uri="{FF2B5EF4-FFF2-40B4-BE49-F238E27FC236}">
-                <a16:creationId xmlns:a16="http://schemas.microsoft.com/office/drawing/2014/main" id="{DE03CCCF-BC67-48B3-94AA-3846CB16778A}"/>
+                <a16:creationId xmlns:a16="http://schemas.microsoft.com/office/drawing/2014/main" id="{D9E04C06-1B86-4D48-AA0B-725A5E0F6DD1}"/>
               </a:ext>
             </a:extLst>
           </p:cNvPr>
@@ -7332,7 +7332,7 @@
           <p:cNvPr id="7" name="">
             <a:extLst xmlns:a="http://schemas.openxmlformats.org/drawingml/2006/main">
               <a:ext uri="{FF2B5EF4-FFF2-40B4-BE49-F238E27FC236}">
-                <a16:creationId xmlns:a16="http://schemas.microsoft.com/office/drawing/2014/main" id="{C3DC97FD-6015-481A-B04F-A2D8154F72C0}"/>
+                <a16:creationId xmlns:a16="http://schemas.microsoft.com/office/drawing/2014/main" id="{6B9D7445-88D2-4EF1-B0D0-E83CAFC0BB19}"/>
               </a:ext>
             </a:extLst>
           </p:cNvPr>
@@ -7389,7 +7389,7 @@
           <p:cNvPr id="8" name="">
             <a:extLst xmlns:a="http://schemas.openxmlformats.org/drawingml/2006/main">
               <a:ext uri="{FF2B5EF4-FFF2-40B4-BE49-F238E27FC236}">
-                <a16:creationId xmlns:a16="http://schemas.microsoft.com/office/drawing/2014/main" id="{B688775A-4E72-4711-9CE7-3E2993435A6C}"/>
+                <a16:creationId xmlns:a16="http://schemas.microsoft.com/office/drawing/2014/main" id="{BF853283-93C1-496C-A791-8ADCC1A80757}"/>
               </a:ext>
             </a:extLst>
           </p:cNvPr>
@@ -7422,7 +7422,7 @@
           <p:cNvPr id="9" name="">
             <a:extLst xmlns:a="http://schemas.openxmlformats.org/drawingml/2006/main">
               <a:ext uri="{FF2B5EF4-FFF2-40B4-BE49-F238E27FC236}">
-                <a16:creationId xmlns:a16="http://schemas.microsoft.com/office/drawing/2014/main" id="{E0443C68-3DF7-45B0-BD26-6A66E63B98CC}"/>
+                <a16:creationId xmlns:a16="http://schemas.microsoft.com/office/drawing/2014/main" id="{6FEC427B-0B51-4C23-8F9A-71C8FF044602}"/>
               </a:ext>
             </a:extLst>
           </p:cNvPr>
@@ -7502,7 +7502,7 @@
           <p:cNvPr id="10" name="">
             <a:extLst xmlns:a="http://schemas.openxmlformats.org/drawingml/2006/main">
               <a:ext uri="{FF2B5EF4-FFF2-40B4-BE49-F238E27FC236}">
-                <a16:creationId xmlns:a16="http://schemas.microsoft.com/office/drawing/2014/main" id="{1562B24B-71A5-4411-B0FD-844F2D600AFF}"/>
+                <a16:creationId xmlns:a16="http://schemas.microsoft.com/office/drawing/2014/main" id="{1775B2BA-B16F-4A74-AC5A-4CEA7BF05D7B}"/>
               </a:ext>
             </a:extLst>
           </p:cNvPr>
@@ -7535,7 +7535,7 @@
           <p:cNvPr id="11" name="">
             <a:extLst xmlns:a="http://schemas.openxmlformats.org/drawingml/2006/main">
               <a:ext uri="{FF2B5EF4-FFF2-40B4-BE49-F238E27FC236}">
-                <a16:creationId xmlns:a16="http://schemas.microsoft.com/office/drawing/2014/main" id="{62BA3AE9-2386-484E-9E9E-1BFD1E085F18}"/>
+                <a16:creationId xmlns:a16="http://schemas.microsoft.com/office/drawing/2014/main" id="{C928819F-9440-4F26-800C-64188113CD4D}"/>
               </a:ext>
             </a:extLst>
           </p:cNvPr>
@@ -7615,7 +7615,7 @@
           <p:cNvPr id="12" name="">
             <a:extLst xmlns:a="http://schemas.openxmlformats.org/drawingml/2006/main">
               <a:ext uri="{FF2B5EF4-FFF2-40B4-BE49-F238E27FC236}">
-                <a16:creationId xmlns:a16="http://schemas.microsoft.com/office/drawing/2014/main" id="{5327D404-3E45-486D-91D6-8630DC16B32A}"/>
+                <a16:creationId xmlns:a16="http://schemas.microsoft.com/office/drawing/2014/main" id="{5BFAC706-599E-4AD5-AF76-A10421E5C843}"/>
               </a:ext>
             </a:extLst>
           </p:cNvPr>
@@ -7648,7 +7648,7 @@
           <p:cNvPr id="13" name="">
             <a:extLst xmlns:a="http://schemas.openxmlformats.org/drawingml/2006/main">
               <a:ext uri="{FF2B5EF4-FFF2-40B4-BE49-F238E27FC236}">
-                <a16:creationId xmlns:a16="http://schemas.microsoft.com/office/drawing/2014/main" id="{9B5CDA2A-289F-454F-ACEC-F1B9F250AA03}"/>
+                <a16:creationId xmlns:a16="http://schemas.microsoft.com/office/drawing/2014/main" id="{3E9FAA01-84C7-493D-A0D1-1710ABE32D49}"/>
               </a:ext>
             </a:extLst>
           </p:cNvPr>
@@ -7728,7 +7728,7 @@
           <p:cNvPr id="14" name="">
             <a:extLst xmlns:a="http://schemas.openxmlformats.org/drawingml/2006/main">
               <a:ext uri="{FF2B5EF4-FFF2-40B4-BE49-F238E27FC236}">
-                <a16:creationId xmlns:a16="http://schemas.microsoft.com/office/drawing/2014/main" id="{8B54BC13-9537-4D93-95DA-DB459C5249B8}"/>
+                <a16:creationId xmlns:a16="http://schemas.microsoft.com/office/drawing/2014/main" id="{06EFEC3D-B1DC-4BFE-8F79-7AEA460CDDF0}"/>
               </a:ext>
             </a:extLst>
           </p:cNvPr>
@@ -7761,7 +7761,7 @@
           <p:cNvPr id="15" name="">
             <a:extLst xmlns:a="http://schemas.openxmlformats.org/drawingml/2006/main">
               <a:ext uri="{FF2B5EF4-FFF2-40B4-BE49-F238E27FC236}">
-                <a16:creationId xmlns:a16="http://schemas.microsoft.com/office/drawing/2014/main" id="{99625DA4-6710-42CB-9ADD-6B251B07B755}"/>
+                <a16:creationId xmlns:a16="http://schemas.microsoft.com/office/drawing/2014/main" id="{AABFFD00-2999-4974-BCE0-8ABF4D441E39}"/>
               </a:ext>
             </a:extLst>
           </p:cNvPr>
@@ -7945,7 +7945,7 @@
           <p:cNvPr id="20" name="">
             <a:extLst xmlns:a="http://schemas.openxmlformats.org/drawingml/2006/main">
               <a:ext uri="{FF2B5EF4-FFF2-40B4-BE49-F238E27FC236}">
-                <a16:creationId xmlns:a16="http://schemas.microsoft.com/office/drawing/2014/main" id="{D2E3E9AC-4402-4AEC-8671-C95407B2B7D0}"/>
+                <a16:creationId xmlns:a16="http://schemas.microsoft.com/office/drawing/2014/main" id="{491FBFC2-B023-4ED8-AB2E-9740FA7BF5AC}"/>
               </a:ext>
             </a:extLst>
           </p:cNvPr>
@@ -8002,7 +8002,7 @@
           <p:cNvPr id="21" name="">
             <a:extLst xmlns:a="http://schemas.openxmlformats.org/drawingml/2006/main">
               <a:ext uri="{FF2B5EF4-FFF2-40B4-BE49-F238E27FC236}">
-                <a16:creationId xmlns:a16="http://schemas.microsoft.com/office/drawing/2014/main" id="{735676EB-8872-49B1-A709-0767D33E3FE2}"/>
+                <a16:creationId xmlns:a16="http://schemas.microsoft.com/office/drawing/2014/main" id="{4972418F-9413-4D3D-8505-CB12F5E8C418}"/>
               </a:ext>
             </a:extLst>
           </p:cNvPr>
@@ -8035,7 +8035,7 @@
           <p:cNvPr id="22" name="">
             <a:extLst xmlns:a="http://schemas.openxmlformats.org/drawingml/2006/main">
               <a:ext uri="{FF2B5EF4-FFF2-40B4-BE49-F238E27FC236}">
-                <a16:creationId xmlns:a16="http://schemas.microsoft.com/office/drawing/2014/main" id="{1D9265C2-540E-41D2-9F77-DA2762961F80}"/>
+                <a16:creationId xmlns:a16="http://schemas.microsoft.com/office/drawing/2014/main" id="{7E9AF8BA-C12B-4592-A246-C4FA615C11E1}"/>
               </a:ext>
             </a:extLst>
           </p:cNvPr>
@@ -8092,7 +8092,7 @@
           <p:cNvPr id="23" name="">
             <a:extLst xmlns:a="http://schemas.openxmlformats.org/drawingml/2006/main">
               <a:ext uri="{FF2B5EF4-FFF2-40B4-BE49-F238E27FC236}">
-                <a16:creationId xmlns:a16="http://schemas.microsoft.com/office/drawing/2014/main" id="{9842E47D-49C1-47A7-979C-65BCE183F30C}"/>
+                <a16:creationId xmlns:a16="http://schemas.microsoft.com/office/drawing/2014/main" id="{6B379E56-539B-42BD-A3BA-E1773837DAC9}"/>
               </a:ext>
             </a:extLst>
           </p:cNvPr>
@@ -8125,7 +8125,7 @@
           <p:cNvPr id="24" name="">
             <a:extLst xmlns:a="http://schemas.openxmlformats.org/drawingml/2006/main">
               <a:ext uri="{FF2B5EF4-FFF2-40B4-BE49-F238E27FC236}">
-                <a16:creationId xmlns:a16="http://schemas.microsoft.com/office/drawing/2014/main" id="{C722CFBD-996D-4A1F-A592-2A79D28DB194}"/>
+                <a16:creationId xmlns:a16="http://schemas.microsoft.com/office/drawing/2014/main" id="{DC6B52D4-2A4E-41C1-9162-6EE25838138F}"/>
               </a:ext>
             </a:extLst>
           </p:cNvPr>
@@ -8231,7 +8231,7 @@
           <p:cNvPr id="26" name="">
             <a:extLst xmlns:a="http://schemas.openxmlformats.org/drawingml/2006/main">
               <a:ext uri="{FF2B5EF4-FFF2-40B4-BE49-F238E27FC236}">
-                <a16:creationId xmlns:a16="http://schemas.microsoft.com/office/drawing/2014/main" id="{4AB4BDCE-1191-4972-8507-6323659FB313}"/>
+                <a16:creationId xmlns:a16="http://schemas.microsoft.com/office/drawing/2014/main" id="{8F488E1C-C477-472C-829E-02BAFF460AAE}"/>
               </a:ext>
             </a:extLst>
           </p:cNvPr>
@@ -8314,7 +8314,7 @@
           <p:cNvPr id="28" name="">
             <a:extLst xmlns:a="http://schemas.openxmlformats.org/drawingml/2006/main">
               <a:ext uri="{FF2B5EF4-FFF2-40B4-BE49-F238E27FC236}">
-                <a16:creationId xmlns:a16="http://schemas.microsoft.com/office/drawing/2014/main" id="{66AE456D-1BB8-4B49-A8FA-BDDACCB738AB}"/>
+                <a16:creationId xmlns:a16="http://schemas.microsoft.com/office/drawing/2014/main" id="{35A2797C-73C6-4ABA-AA88-866B9EEDB666}"/>
               </a:ext>
             </a:extLst>
           </p:cNvPr>
@@ -8347,7 +8347,7 @@
           <p:cNvPr id="29" name="">
             <a:extLst xmlns:a="http://schemas.openxmlformats.org/drawingml/2006/main">
               <a:ext uri="{FF2B5EF4-FFF2-40B4-BE49-F238E27FC236}">
-                <a16:creationId xmlns:a16="http://schemas.microsoft.com/office/drawing/2014/main" id="{D700B04F-F45B-4714-ADFB-CAE22AFA9835}"/>
+                <a16:creationId xmlns:a16="http://schemas.microsoft.com/office/drawing/2014/main" id="{5E3E9329-5149-4374-ABD3-BDF7B9AA7A91}"/>
               </a:ext>
             </a:extLst>
           </p:cNvPr>
@@ -8453,7 +8453,7 @@
           <p:cNvPr id="31" name="">
             <a:extLst xmlns:a="http://schemas.openxmlformats.org/drawingml/2006/main">
               <a:ext uri="{FF2B5EF4-FFF2-40B4-BE49-F238E27FC236}">
-                <a16:creationId xmlns:a16="http://schemas.microsoft.com/office/drawing/2014/main" id="{E82066BC-E831-4B06-BD1F-0CB8E8872121}"/>
+                <a16:creationId xmlns:a16="http://schemas.microsoft.com/office/drawing/2014/main" id="{8BBFAA7D-E626-4D8A-802F-2BB407ED9075}"/>
               </a:ext>
             </a:extLst>
           </p:cNvPr>
@@ -8484,7 +8484,7 @@
           <p:cNvPr id="32" name="">
             <a:extLst xmlns:a="http://schemas.openxmlformats.org/drawingml/2006/main">
               <a:ext uri="{FF2B5EF4-FFF2-40B4-BE49-F238E27FC236}">
-                <a16:creationId xmlns:a16="http://schemas.microsoft.com/office/drawing/2014/main" id="{B4EDF8C6-9BC3-4C15-A492-3BBFAE49AD8B}"/>
+                <a16:creationId xmlns:a16="http://schemas.microsoft.com/office/drawing/2014/main" id="{79E31619-720F-4A76-B465-ED81821B136D}"/>
               </a:ext>
             </a:extLst>
           </p:cNvPr>
@@ -8515,7 +8515,7 @@
           <p:cNvPr id="33" name="">
             <a:extLst xmlns:a="http://schemas.openxmlformats.org/drawingml/2006/main">
               <a:ext uri="{FF2B5EF4-FFF2-40B4-BE49-F238E27FC236}">
-                <a16:creationId xmlns:a16="http://schemas.microsoft.com/office/drawing/2014/main" id="{68B5F98C-0E51-42EF-88D9-D17311EFC306}"/>
+                <a16:creationId xmlns:a16="http://schemas.microsoft.com/office/drawing/2014/main" id="{784769AD-8DD8-4FC7-88EA-9B1B2BCE0738}"/>
               </a:ext>
             </a:extLst>
           </p:cNvPr>
@@ -8546,7 +8546,7 @@
           <p:cNvPr id="34" name="">
             <a:extLst xmlns:a="http://schemas.openxmlformats.org/drawingml/2006/main">
               <a:ext uri="{FF2B5EF4-FFF2-40B4-BE49-F238E27FC236}">
-                <a16:creationId xmlns:a16="http://schemas.microsoft.com/office/drawing/2014/main" id="{D54C0A01-2FEB-4533-9362-90463855A52E}"/>
+                <a16:creationId xmlns:a16="http://schemas.microsoft.com/office/drawing/2014/main" id="{2185C2BD-ECFA-46E2-836E-8073DE0B68C0}"/>
               </a:ext>
             </a:extLst>
           </p:cNvPr>
@@ -8601,7 +8601,7 @@
           <p:cNvPr id="36" name="">
             <a:extLst xmlns:a="http://schemas.openxmlformats.org/drawingml/2006/main">
               <a:ext uri="{FF2B5EF4-FFF2-40B4-BE49-F238E27FC236}">
-                <a16:creationId xmlns:a16="http://schemas.microsoft.com/office/drawing/2014/main" id="{9EBC218C-0098-4AD9-AB63-0179E50065BA}"/>
+                <a16:creationId xmlns:a16="http://schemas.microsoft.com/office/drawing/2014/main" id="{591B059D-2276-4A0E-9402-999E0A76ABE7}"/>
               </a:ext>
             </a:extLst>
           </p:cNvPr>
@@ -8658,7 +8658,7 @@
           <p:cNvPr id="37" name="">
             <a:extLst xmlns:a="http://schemas.openxmlformats.org/drawingml/2006/main">
               <a:ext uri="{FF2B5EF4-FFF2-40B4-BE49-F238E27FC236}">
-                <a16:creationId xmlns:a16="http://schemas.microsoft.com/office/drawing/2014/main" id="{F41C9085-9B17-472A-A792-4165B9AEC3CC}"/>
+                <a16:creationId xmlns:a16="http://schemas.microsoft.com/office/drawing/2014/main" id="{82531DA0-82AE-421C-97AD-B29297E4FA94}"/>
               </a:ext>
             </a:extLst>
           </p:cNvPr>
@@ -8689,7 +8689,7 @@
           <p:cNvPr id="38" name="">
             <a:extLst xmlns:a="http://schemas.openxmlformats.org/drawingml/2006/main">
               <a:ext uri="{FF2B5EF4-FFF2-40B4-BE49-F238E27FC236}">
-                <a16:creationId xmlns:a16="http://schemas.microsoft.com/office/drawing/2014/main" id="{A61372A2-AB8A-46E1-9007-3117FED984CE}"/>
+                <a16:creationId xmlns:a16="http://schemas.microsoft.com/office/drawing/2014/main" id="{733883D4-444F-46A8-86D2-A87FC9FBDF38}"/>
               </a:ext>
             </a:extLst>
           </p:cNvPr>
@@ -8746,7 +8746,7 @@
           <p:cNvPr id="39" name="">
             <a:extLst xmlns:a="http://schemas.openxmlformats.org/drawingml/2006/main">
               <a:ext uri="{FF2B5EF4-FFF2-40B4-BE49-F238E27FC236}">
-                <a16:creationId xmlns:a16="http://schemas.microsoft.com/office/drawing/2014/main" id="{6FF0A0AC-1EC9-429B-80D1-830FAE7381FD}"/>
+                <a16:creationId xmlns:a16="http://schemas.microsoft.com/office/drawing/2014/main" id="{FECA69DF-DB07-4E0F-B9CD-88B93995ECB1}"/>
               </a:ext>
             </a:extLst>
           </p:cNvPr>
@@ -8803,7 +8803,7 @@
           <p:cNvPr id="40" name="">
             <a:extLst xmlns:a="http://schemas.openxmlformats.org/drawingml/2006/main">
               <a:ext uri="{FF2B5EF4-FFF2-40B4-BE49-F238E27FC236}">
-                <a16:creationId xmlns:a16="http://schemas.microsoft.com/office/drawing/2014/main" id="{9630D711-E8B6-4C0B-BA6F-277E165CDE82}"/>
+                <a16:creationId xmlns:a16="http://schemas.microsoft.com/office/drawing/2014/main" id="{76A931C2-EC48-4CD8-863A-FE9672C680D1}"/>
               </a:ext>
             </a:extLst>
           </p:cNvPr>
@@ -8860,7 +8860,7 @@
           <p:cNvPr id="41" name="">
             <a:extLst xmlns:a="http://schemas.openxmlformats.org/drawingml/2006/main">
               <a:ext uri="{FF2B5EF4-FFF2-40B4-BE49-F238E27FC236}">
-                <a16:creationId xmlns:a16="http://schemas.microsoft.com/office/drawing/2014/main" id="{87FDED27-9A96-4627-9785-06C43080E4AD}"/>
+                <a16:creationId xmlns:a16="http://schemas.microsoft.com/office/drawing/2014/main" id="{712E23D7-D9A6-48D7-8C35-63632C5A282D}"/>
               </a:ext>
             </a:extLst>
           </p:cNvPr>
@@ -8917,7 +8917,7 @@
           <p:cNvPr id="42" name="">
             <a:extLst xmlns:a="http://schemas.openxmlformats.org/drawingml/2006/main">
               <a:ext uri="{FF2B5EF4-FFF2-40B4-BE49-F238E27FC236}">
-                <a16:creationId xmlns:a16="http://schemas.microsoft.com/office/drawing/2014/main" id="{E7B8EA7E-FDBE-4593-8D97-D912A0ADDDAB}"/>
+                <a16:creationId xmlns:a16="http://schemas.microsoft.com/office/drawing/2014/main" id="{0147EA97-D521-4CF5-9280-7B71BE5B4FBE}"/>
               </a:ext>
             </a:extLst>
           </p:cNvPr>
@@ -8974,7 +8974,7 @@
           <p:cNvPr id="43" name="">
             <a:extLst xmlns:a="http://schemas.openxmlformats.org/drawingml/2006/main">
               <a:ext uri="{FF2B5EF4-FFF2-40B4-BE49-F238E27FC236}">
-                <a16:creationId xmlns:a16="http://schemas.microsoft.com/office/drawing/2014/main" id="{D200B01F-3960-4D40-882B-15F26090F45E}"/>
+                <a16:creationId xmlns:a16="http://schemas.microsoft.com/office/drawing/2014/main" id="{5F970075-B63B-4105-8795-A297E22A5DE4}"/>
               </a:ext>
             </a:extLst>
           </p:cNvPr>
@@ -9031,7 +9031,7 @@
           <p:cNvPr id="44" name="">
             <a:extLst xmlns:a="http://schemas.openxmlformats.org/drawingml/2006/main">
               <a:ext uri="{FF2B5EF4-FFF2-40B4-BE49-F238E27FC236}">
-                <a16:creationId xmlns:a16="http://schemas.microsoft.com/office/drawing/2014/main" id="{9FB46BE2-3620-4D53-89FD-6B335B772577}"/>
+                <a16:creationId xmlns:a16="http://schemas.microsoft.com/office/drawing/2014/main" id="{4D717334-88CE-44B6-84AA-10B4AFFF8292}"/>
               </a:ext>
             </a:extLst>
           </p:cNvPr>
@@ -9088,7 +9088,7 @@
           <p:cNvPr id="45" name="">
             <a:extLst xmlns:a="http://schemas.openxmlformats.org/drawingml/2006/main">
               <a:ext uri="{FF2B5EF4-FFF2-40B4-BE49-F238E27FC236}">
-                <a16:creationId xmlns:a16="http://schemas.microsoft.com/office/drawing/2014/main" id="{041D06F2-2842-4CD3-82BB-30E3C111CF4C}"/>
+                <a16:creationId xmlns:a16="http://schemas.microsoft.com/office/drawing/2014/main" id="{CAB9A3B5-A9FC-4E68-A5E6-440A8E6B54AA}"/>
               </a:ext>
             </a:extLst>
           </p:cNvPr>
@@ -9168,7 +9168,7 @@
           <p:cNvPr id="46" name="">
             <a:extLst xmlns:a="http://schemas.openxmlformats.org/drawingml/2006/main">
               <a:ext uri="{FF2B5EF4-FFF2-40B4-BE49-F238E27FC236}">
-                <a16:creationId xmlns:a16="http://schemas.microsoft.com/office/drawing/2014/main" id="{6D57BAC9-E146-42E9-925B-EF5372F97D6C}"/>
+                <a16:creationId xmlns:a16="http://schemas.microsoft.com/office/drawing/2014/main" id="{BD1E0792-4010-4537-8DC2-27C60328DF49}"/>
               </a:ext>
             </a:extLst>
           </p:cNvPr>
@@ -9199,7 +9199,7 @@
           <p:cNvPr id="47" name="">
             <a:extLst xmlns:a="http://schemas.openxmlformats.org/drawingml/2006/main">
               <a:ext uri="{FF2B5EF4-FFF2-40B4-BE49-F238E27FC236}">
-                <a16:creationId xmlns:a16="http://schemas.microsoft.com/office/drawing/2014/main" id="{8066ED9B-AAF8-401E-B450-1B64FC4C7667}"/>
+                <a16:creationId xmlns:a16="http://schemas.microsoft.com/office/drawing/2014/main" id="{6FE00E35-AB97-4EC3-A9A7-357485DC38DF}"/>
               </a:ext>
             </a:extLst>
           </p:cNvPr>
@@ -9256,7 +9256,7 @@
           <p:cNvPr id="48" name="">
             <a:extLst xmlns:a="http://schemas.openxmlformats.org/drawingml/2006/main">
               <a:ext uri="{FF2B5EF4-FFF2-40B4-BE49-F238E27FC236}">
-                <a16:creationId xmlns:a16="http://schemas.microsoft.com/office/drawing/2014/main" id="{84519E7D-8677-4BA3-907E-DEEF55A9F6F2}"/>
+                <a16:creationId xmlns:a16="http://schemas.microsoft.com/office/drawing/2014/main" id="{1DB843B7-EE83-4DC9-BEA5-FB5686192BDA}"/>
               </a:ext>
             </a:extLst>
           </p:cNvPr>
@@ -9313,7 +9313,7 @@
           <p:cNvPr id="49" name="">
             <a:extLst xmlns:a="http://schemas.openxmlformats.org/drawingml/2006/main">
               <a:ext uri="{FF2B5EF4-FFF2-40B4-BE49-F238E27FC236}">
-                <a16:creationId xmlns:a16="http://schemas.microsoft.com/office/drawing/2014/main" id="{F7D50B77-5C65-4074-A559-8CC9A33DEF79}"/>
+                <a16:creationId xmlns:a16="http://schemas.microsoft.com/office/drawing/2014/main" id="{FCE04821-4CB7-4A0F-ACEF-3C4E59645C15}"/>
               </a:ext>
             </a:extLst>
           </p:cNvPr>
@@ -9370,7 +9370,7 @@
           <p:cNvPr id="50" name="">
             <a:extLst xmlns:a="http://schemas.openxmlformats.org/drawingml/2006/main">
               <a:ext uri="{FF2B5EF4-FFF2-40B4-BE49-F238E27FC236}">
-                <a16:creationId xmlns:a16="http://schemas.microsoft.com/office/drawing/2014/main" id="{38BC649D-C4CF-4566-927A-181733A44A0B}"/>
+                <a16:creationId xmlns:a16="http://schemas.microsoft.com/office/drawing/2014/main" id="{CCC3FAE3-02C5-4842-AED0-15574D503C8C}"/>
               </a:ext>
             </a:extLst>
           </p:cNvPr>
@@ -9427,7 +9427,7 @@
           <p:cNvPr id="51" name="">
             <a:extLst xmlns:a="http://schemas.openxmlformats.org/drawingml/2006/main">
               <a:ext uri="{FF2B5EF4-FFF2-40B4-BE49-F238E27FC236}">
-                <a16:creationId xmlns:a16="http://schemas.microsoft.com/office/drawing/2014/main" id="{0EEC670E-22AA-4D06-8F91-F74BD1AD531A}"/>
+                <a16:creationId xmlns:a16="http://schemas.microsoft.com/office/drawing/2014/main" id="{FC3FC666-BECD-4248-99EF-0CD0D2D17AF6}"/>
               </a:ext>
             </a:extLst>
           </p:cNvPr>
@@ -9482,7 +9482,7 @@
     </p:spTree>
     <p:extLst>
       <p:ext uri="{BB962C8B-B14F-4D97-AF65-F5344CB8AC3E}">
-        <p14:creationId xmlns:p14="http://schemas.microsoft.com/office/powerpoint/2010/main" val="16236861"/>
+        <p14:creationId xmlns:p14="http://schemas.microsoft.com/office/powerpoint/2010/main" val="1028379437"/>
       </p:ext>
     </p:extLst>
   </p:cSld>
@@ -9513,7 +9513,7 @@
           <p:cNvPr id="11" name="">
             <a:extLst xmlns:a="http://schemas.openxmlformats.org/drawingml/2006/main">
               <a:ext uri="{FF2B5EF4-FFF2-40B4-BE49-F238E27FC236}">
-                <a16:creationId xmlns:a16="http://schemas.microsoft.com/office/drawing/2014/main" id="{87422FF4-485F-40BF-B784-BF398EB7FB58}"/>
+                <a16:creationId xmlns:a16="http://schemas.microsoft.com/office/drawing/2014/main" id="{ECC24AD9-6C5E-453F-BFEE-A4F66C1B63ED}"/>
               </a:ext>
             </a:extLst>
           </p:cNvPr>
@@ -9570,7 +9570,7 @@
           <p:cNvPr id="2" name="">
             <a:extLst xmlns:a="http://schemas.openxmlformats.org/drawingml/2006/main">
               <a:ext uri="{FF2B5EF4-FFF2-40B4-BE49-F238E27FC236}">
-                <a16:creationId xmlns:a16="http://schemas.microsoft.com/office/drawing/2014/main" id="{01614579-A1C3-4F6E-AA64-D2976E97C4DF}"/>
+                <a16:creationId xmlns:a16="http://schemas.microsoft.com/office/drawing/2014/main" id="{422A591A-11F4-4128-9FC3-6579F51B8583}"/>
               </a:ext>
             </a:extLst>
           </p:cNvPr>
@@ -9601,7 +9601,7 @@
           <p:cNvPr id="3" name="">
             <a:extLst xmlns:a="http://schemas.openxmlformats.org/drawingml/2006/main">
               <a:ext uri="{FF2B5EF4-FFF2-40B4-BE49-F238E27FC236}">
-                <a16:creationId xmlns:a16="http://schemas.microsoft.com/office/drawing/2014/main" id="{32410C20-FB42-425B-AA1C-CDDFE42BAACC}"/>
+                <a16:creationId xmlns:a16="http://schemas.microsoft.com/office/drawing/2014/main" id="{DE7CF957-4C05-4FE3-8C8E-FEBE1927EFF7}"/>
               </a:ext>
             </a:extLst>
           </p:cNvPr>
@@ -9658,7 +9658,7 @@
           <p:cNvPr id="4" name="">
             <a:extLst xmlns:a="http://schemas.openxmlformats.org/drawingml/2006/main">
               <a:ext uri="{FF2B5EF4-FFF2-40B4-BE49-F238E27FC236}">
-                <a16:creationId xmlns:a16="http://schemas.microsoft.com/office/drawing/2014/main" id="{08304F37-1932-48CE-AF04-F1D76A92C20E}"/>
+                <a16:creationId xmlns:a16="http://schemas.microsoft.com/office/drawing/2014/main" id="{B951E870-1948-4761-A0F7-775382D4FC3D}"/>
               </a:ext>
             </a:extLst>
           </p:cNvPr>
@@ -9715,7 +9715,7 @@
           <p:cNvPr id="5" name="">
             <a:extLst xmlns:a="http://schemas.openxmlformats.org/drawingml/2006/main">
               <a:ext uri="{FF2B5EF4-FFF2-40B4-BE49-F238E27FC236}">
-                <a16:creationId xmlns:a16="http://schemas.microsoft.com/office/drawing/2014/main" id="{BA6D0828-0F18-49CC-AD99-DD289E1614E6}"/>
+                <a16:creationId xmlns:a16="http://schemas.microsoft.com/office/drawing/2014/main" id="{5AA9DCDB-9B3C-435B-BDB8-A96B89D4799D}"/>
               </a:ext>
             </a:extLst>
           </p:cNvPr>
@@ -9772,7 +9772,7 @@
           <p:cNvPr id="6" name="">
             <a:extLst xmlns:a="http://schemas.openxmlformats.org/drawingml/2006/main">
               <a:ext uri="{FF2B5EF4-FFF2-40B4-BE49-F238E27FC236}">
-                <a16:creationId xmlns:a16="http://schemas.microsoft.com/office/drawing/2014/main" id="{3A91BF09-758B-4F5C-B9FC-B5AA1256027D}"/>
+                <a16:creationId xmlns:a16="http://schemas.microsoft.com/office/drawing/2014/main" id="{1A7E559D-203E-4EE5-8025-B50A8F4CB553}"/>
               </a:ext>
             </a:extLst>
           </p:cNvPr>
@@ -10263,7 +10263,7 @@
           <p:cNvPr id="8" name="">
             <a:extLst xmlns:a="http://schemas.openxmlformats.org/drawingml/2006/main">
               <a:ext uri="{FF2B5EF4-FFF2-40B4-BE49-F238E27FC236}">
-                <a16:creationId xmlns:a16="http://schemas.microsoft.com/office/drawing/2014/main" id="{6DFFFA43-C48D-41F9-A779-3A3CA10B547E}"/>
+                <a16:creationId xmlns:a16="http://schemas.microsoft.com/office/drawing/2014/main" id="{EE502553-986D-46EC-B51C-4BDCFCB8CD00}"/>
               </a:ext>
             </a:extLst>
           </p:cNvPr>
@@ -10320,7 +10320,7 @@
           <p:cNvPr id="9" name="">
             <a:extLst xmlns:a="http://schemas.openxmlformats.org/drawingml/2006/main">
               <a:ext uri="{FF2B5EF4-FFF2-40B4-BE49-F238E27FC236}">
-                <a16:creationId xmlns:a16="http://schemas.microsoft.com/office/drawing/2014/main" id="{CE2029FB-4478-411D-A355-E30DF6E3CC08}"/>
+                <a16:creationId xmlns:a16="http://schemas.microsoft.com/office/drawing/2014/main" id="{65F0B545-0324-4F76-911F-E12FD18E6364}"/>
               </a:ext>
             </a:extLst>
           </p:cNvPr>
@@ -10377,7 +10377,7 @@
           <p:cNvPr id="10" name="">
             <a:extLst xmlns:a="http://schemas.openxmlformats.org/drawingml/2006/main">
               <a:ext uri="{FF2B5EF4-FFF2-40B4-BE49-F238E27FC236}">
-                <a16:creationId xmlns:a16="http://schemas.microsoft.com/office/drawing/2014/main" id="{59225618-FBE7-46CA-8A31-43E311622B77}"/>
+                <a16:creationId xmlns:a16="http://schemas.microsoft.com/office/drawing/2014/main" id="{E60533BA-6806-4E12-B4B5-A397B299937E}"/>
               </a:ext>
             </a:extLst>
           </p:cNvPr>
@@ -10432,7 +10432,7 @@
     </p:spTree>
     <p:extLst>
       <p:ext uri="{BB962C8B-B14F-4D97-AF65-F5344CB8AC3E}">
-        <p14:creationId xmlns:p14="http://schemas.microsoft.com/office/powerpoint/2010/main" val="1634807806"/>
+        <p14:creationId xmlns:p14="http://schemas.microsoft.com/office/powerpoint/2010/main" val="1408176735"/>
       </p:ext>
     </p:extLst>
   </p:cSld>
@@ -10463,7 +10463,7 @@
           <p:cNvPr id="29" name="">
             <a:extLst xmlns:a="http://schemas.openxmlformats.org/drawingml/2006/main">
               <a:ext uri="{FF2B5EF4-FFF2-40B4-BE49-F238E27FC236}">
-                <a16:creationId xmlns:a16="http://schemas.microsoft.com/office/drawing/2014/main" id="{E361D878-A6BA-4BF0-97F4-E1A8EADFB847}"/>
+                <a16:creationId xmlns:a16="http://schemas.microsoft.com/office/drawing/2014/main" id="{BE62EC11-611E-4EE1-9755-64F079CEAB2C}"/>
               </a:ext>
             </a:extLst>
           </p:cNvPr>
@@ -10543,7 +10543,7 @@
           <p:cNvPr id="2" name="">
             <a:extLst xmlns:a="http://schemas.openxmlformats.org/drawingml/2006/main">
               <a:ext uri="{FF2B5EF4-FFF2-40B4-BE49-F238E27FC236}">
-                <a16:creationId xmlns:a16="http://schemas.microsoft.com/office/drawing/2014/main" id="{7E866DD4-14F2-4A93-8791-3AC84C0CDBB2}"/>
+                <a16:creationId xmlns:a16="http://schemas.microsoft.com/office/drawing/2014/main" id="{308D53B4-5CB0-4CB5-9E4A-53B12BD5D769}"/>
               </a:ext>
             </a:extLst>
           </p:cNvPr>
@@ -10574,7 +10574,7 @@
           <p:cNvPr id="3" name="">
             <a:extLst xmlns:a="http://schemas.openxmlformats.org/drawingml/2006/main">
               <a:ext uri="{FF2B5EF4-FFF2-40B4-BE49-F238E27FC236}">
-                <a16:creationId xmlns:a16="http://schemas.microsoft.com/office/drawing/2014/main" id="{5DD72FE2-458A-4D3A-8B51-B94FD65FF93F}"/>
+                <a16:creationId xmlns:a16="http://schemas.microsoft.com/office/drawing/2014/main" id="{DDF08697-C5E3-4C61-99EF-A32FED90EF59}"/>
               </a:ext>
             </a:extLst>
           </p:cNvPr>
@@ -10631,7 +10631,7 @@
           <p:cNvPr id="4" name="">
             <a:extLst xmlns:a="http://schemas.openxmlformats.org/drawingml/2006/main">
               <a:ext uri="{FF2B5EF4-FFF2-40B4-BE49-F238E27FC236}">
-                <a16:creationId xmlns:a16="http://schemas.microsoft.com/office/drawing/2014/main" id="{46D3E3DB-EA75-4FB3-B60A-762A14C43519}"/>
+                <a16:creationId xmlns:a16="http://schemas.microsoft.com/office/drawing/2014/main" id="{6B4E92BA-8049-4DD6-ADB3-1BE75A95A257}"/>
               </a:ext>
             </a:extLst>
           </p:cNvPr>
@@ -10688,7 +10688,7 @@
           <p:cNvPr id="5" name="">
             <a:extLst xmlns:a="http://schemas.openxmlformats.org/drawingml/2006/main">
               <a:ext uri="{FF2B5EF4-FFF2-40B4-BE49-F238E27FC236}">
-                <a16:creationId xmlns:a16="http://schemas.microsoft.com/office/drawing/2014/main" id="{63F68BDE-ACE8-4C6A-84D5-19C77B105BE2}"/>
+                <a16:creationId xmlns:a16="http://schemas.microsoft.com/office/drawing/2014/main" id="{D0AFF972-371A-477E-AC3E-5DD09159DFEB}"/>
               </a:ext>
             </a:extLst>
           </p:cNvPr>
@@ -10745,7 +10745,7 @@
           <p:cNvPr id="6" name="">
             <a:extLst xmlns:a="http://schemas.openxmlformats.org/drawingml/2006/main">
               <a:ext uri="{FF2B5EF4-FFF2-40B4-BE49-F238E27FC236}">
-                <a16:creationId xmlns:a16="http://schemas.microsoft.com/office/drawing/2014/main" id="{4D834DB4-4375-4667-AACF-B980A82156D3}"/>
+                <a16:creationId xmlns:a16="http://schemas.microsoft.com/office/drawing/2014/main" id="{A51F2167-571F-4E86-908E-A060F256C77C}"/>
               </a:ext>
             </a:extLst>
           </p:cNvPr>
@@ -10825,7 +10825,7 @@
           <p:cNvPr id="7" name="">
             <a:extLst xmlns:a="http://schemas.openxmlformats.org/drawingml/2006/main">
               <a:ext uri="{FF2B5EF4-FFF2-40B4-BE49-F238E27FC236}">
-                <a16:creationId xmlns:a16="http://schemas.microsoft.com/office/drawing/2014/main" id="{CAD85327-4734-43A7-ABAD-E3268097F9E9}"/>
+                <a16:creationId xmlns:a16="http://schemas.microsoft.com/office/drawing/2014/main" id="{56D0948B-A640-47E4-BA6E-A750F6FA7EF6}"/>
               </a:ext>
             </a:extLst>
           </p:cNvPr>
@@ -10882,7 +10882,7 @@
           <p:cNvPr id="8" name="">
             <a:extLst xmlns:a="http://schemas.openxmlformats.org/drawingml/2006/main">
               <a:ext uri="{FF2B5EF4-FFF2-40B4-BE49-F238E27FC236}">
-                <a16:creationId xmlns:a16="http://schemas.microsoft.com/office/drawing/2014/main" id="{C7E511BE-48D7-442B-A4DB-031A73CF08C9}"/>
+                <a16:creationId xmlns:a16="http://schemas.microsoft.com/office/drawing/2014/main" id="{9CF9B339-0F29-40BE-9ACC-49A973D9835F}"/>
               </a:ext>
             </a:extLst>
           </p:cNvPr>
@@ -10962,7 +10962,7 @@
           <p:cNvPr id="9" name="">
             <a:extLst xmlns:a="http://schemas.openxmlformats.org/drawingml/2006/main">
               <a:ext uri="{FF2B5EF4-FFF2-40B4-BE49-F238E27FC236}">
-                <a16:creationId xmlns:a16="http://schemas.microsoft.com/office/drawing/2014/main" id="{0A5D724C-B7D8-4852-9A4D-8D2C0A34FFB0}"/>
+                <a16:creationId xmlns:a16="http://schemas.microsoft.com/office/drawing/2014/main" id="{B7A6E2AA-9714-4DE2-9778-EE9C78CE9960}"/>
               </a:ext>
             </a:extLst>
           </p:cNvPr>
@@ -10993,7 +10993,7 @@
           <p:cNvPr id="10" name="">
             <a:extLst xmlns:a="http://schemas.openxmlformats.org/drawingml/2006/main">
               <a:ext uri="{FF2B5EF4-FFF2-40B4-BE49-F238E27FC236}">
-                <a16:creationId xmlns:a16="http://schemas.microsoft.com/office/drawing/2014/main" id="{E0B05AAC-D214-4FD7-A262-8483820A4D80}"/>
+                <a16:creationId xmlns:a16="http://schemas.microsoft.com/office/drawing/2014/main" id="{830C304C-04E3-42A6-9CF9-7756FF09D950}"/>
               </a:ext>
             </a:extLst>
           </p:cNvPr>
@@ -11026,7 +11026,7 @@
           <p:cNvPr id="11" name="">
             <a:extLst xmlns:a="http://schemas.openxmlformats.org/drawingml/2006/main">
               <a:ext uri="{FF2B5EF4-FFF2-40B4-BE49-F238E27FC236}">
-                <a16:creationId xmlns:a16="http://schemas.microsoft.com/office/drawing/2014/main" id="{B4C530B0-21FF-40E6-8054-ECC853C70FA7}"/>
+                <a16:creationId xmlns:a16="http://schemas.microsoft.com/office/drawing/2014/main" id="{927A79FE-DEFA-46D2-A9C4-DAB5E234F8D5}"/>
               </a:ext>
             </a:extLst>
           </p:cNvPr>
@@ -11106,7 +11106,7 @@
           <p:cNvPr id="12" name="">
             <a:extLst xmlns:a="http://schemas.openxmlformats.org/drawingml/2006/main">
               <a:ext uri="{FF2B5EF4-FFF2-40B4-BE49-F238E27FC236}">
-                <a16:creationId xmlns:a16="http://schemas.microsoft.com/office/drawing/2014/main" id="{8C12F330-2426-44C1-B06B-309B001574B6}"/>
+                <a16:creationId xmlns:a16="http://schemas.microsoft.com/office/drawing/2014/main" id="{0375FADF-9DB2-4137-B94C-CE7EAD614531}"/>
               </a:ext>
             </a:extLst>
           </p:cNvPr>
@@ -11139,7 +11139,7 @@
           <p:cNvPr id="13" name="">
             <a:extLst xmlns:a="http://schemas.openxmlformats.org/drawingml/2006/main">
               <a:ext uri="{FF2B5EF4-FFF2-40B4-BE49-F238E27FC236}">
-                <a16:creationId xmlns:a16="http://schemas.microsoft.com/office/drawing/2014/main" id="{69DF921B-F228-4C66-AB14-39959C131970}"/>
+                <a16:creationId xmlns:a16="http://schemas.microsoft.com/office/drawing/2014/main" id="{5DAE7C9D-27FA-4D2E-A16A-C3FCD48D3CCB}"/>
               </a:ext>
             </a:extLst>
           </p:cNvPr>
@@ -11196,7 +11196,7 @@
           <p:cNvPr id="14" name="">
             <a:extLst xmlns:a="http://schemas.openxmlformats.org/drawingml/2006/main">
               <a:ext uri="{FF2B5EF4-FFF2-40B4-BE49-F238E27FC236}">
-                <a16:creationId xmlns:a16="http://schemas.microsoft.com/office/drawing/2014/main" id="{ABEE611C-A255-4729-BCF1-E81A659AE786}"/>
+                <a16:creationId xmlns:a16="http://schemas.microsoft.com/office/drawing/2014/main" id="{EC1F2F72-EA4A-4615-BE37-4180173FF275}"/>
               </a:ext>
             </a:extLst>
           </p:cNvPr>
@@ -11229,7 +11229,7 @@
           <p:cNvPr id="15" name="">
             <a:extLst xmlns:a="http://schemas.openxmlformats.org/drawingml/2006/main">
               <a:ext uri="{FF2B5EF4-FFF2-40B4-BE49-F238E27FC236}">
-                <a16:creationId xmlns:a16="http://schemas.microsoft.com/office/drawing/2014/main" id="{15ED43F4-CD35-4893-B798-02D88CD7BCC9}"/>
+                <a16:creationId xmlns:a16="http://schemas.microsoft.com/office/drawing/2014/main" id="{E81E3650-6267-4F9F-86DE-4154A0931EE8}"/>
               </a:ext>
             </a:extLst>
           </p:cNvPr>
@@ -11286,7 +11286,7 @@
           <p:cNvPr id="16" name="">
             <a:extLst xmlns:a="http://schemas.openxmlformats.org/drawingml/2006/main">
               <a:ext uri="{FF2B5EF4-FFF2-40B4-BE49-F238E27FC236}">
-                <a16:creationId xmlns:a16="http://schemas.microsoft.com/office/drawing/2014/main" id="{F804838F-88F7-41AB-8C68-C90840598364}"/>
+                <a16:creationId xmlns:a16="http://schemas.microsoft.com/office/drawing/2014/main" id="{4F4EBFC4-1FA9-4EA9-9868-B5F4EAC704D6}"/>
               </a:ext>
             </a:extLst>
           </p:cNvPr>
@@ -11319,7 +11319,7 @@
           <p:cNvPr id="17" name="">
             <a:extLst xmlns:a="http://schemas.openxmlformats.org/drawingml/2006/main">
               <a:ext uri="{FF2B5EF4-FFF2-40B4-BE49-F238E27FC236}">
-                <a16:creationId xmlns:a16="http://schemas.microsoft.com/office/drawing/2014/main" id="{392CA472-5553-450F-9004-C4512659FC08}"/>
+                <a16:creationId xmlns:a16="http://schemas.microsoft.com/office/drawing/2014/main" id="{46BA3C68-E642-4C02-8628-3FC2A5D08D55}"/>
               </a:ext>
             </a:extLst>
           </p:cNvPr>
@@ -11480,7 +11480,7 @@
           <p:cNvPr id="22" name="">
             <a:extLst xmlns:a="http://schemas.openxmlformats.org/drawingml/2006/main">
               <a:ext uri="{FF2B5EF4-FFF2-40B4-BE49-F238E27FC236}">
-                <a16:creationId xmlns:a16="http://schemas.microsoft.com/office/drawing/2014/main" id="{18ECDD37-10F2-4FEA-8BBB-6EB450F5FE56}"/>
+                <a16:creationId xmlns:a16="http://schemas.microsoft.com/office/drawing/2014/main" id="{F336C7B0-2E36-4DF8-B547-CB48955357E8}"/>
               </a:ext>
             </a:extLst>
           </p:cNvPr>
@@ -11560,7 +11560,7 @@
           <p:cNvPr id="23" name="">
             <a:extLst xmlns:a="http://schemas.openxmlformats.org/drawingml/2006/main">
               <a:ext uri="{FF2B5EF4-FFF2-40B4-BE49-F238E27FC236}">
-                <a16:creationId xmlns:a16="http://schemas.microsoft.com/office/drawing/2014/main" id="{7FE929C3-C58B-46B5-9B95-D190092C3D1E}"/>
+                <a16:creationId xmlns:a16="http://schemas.microsoft.com/office/drawing/2014/main" id="{183DDEDD-4F83-4549-9A43-5E8F10FCDB23}"/>
               </a:ext>
             </a:extLst>
           </p:cNvPr>
@@ -11591,7 +11591,7 @@
           <p:cNvPr id="24" name="">
             <a:extLst xmlns:a="http://schemas.openxmlformats.org/drawingml/2006/main">
               <a:ext uri="{FF2B5EF4-FFF2-40B4-BE49-F238E27FC236}">
-                <a16:creationId xmlns:a16="http://schemas.microsoft.com/office/drawing/2014/main" id="{C7CC1C1F-FAB9-4C7C-B192-49F26F2F7094}"/>
+                <a16:creationId xmlns:a16="http://schemas.microsoft.com/office/drawing/2014/main" id="{7C9F84D3-9820-462F-9DA6-5FF1D7BB70B3}"/>
               </a:ext>
             </a:extLst>
           </p:cNvPr>
@@ -11648,7 +11648,7 @@
           <p:cNvPr id="25" name="">
             <a:extLst xmlns:a="http://schemas.openxmlformats.org/drawingml/2006/main">
               <a:ext uri="{FF2B5EF4-FFF2-40B4-BE49-F238E27FC236}">
-                <a16:creationId xmlns:a16="http://schemas.microsoft.com/office/drawing/2014/main" id="{58CB6FF0-3AE2-4830-B643-C83D2BACAA05}"/>
+                <a16:creationId xmlns:a16="http://schemas.microsoft.com/office/drawing/2014/main" id="{A2E380D9-9C1E-44B0-9951-23FC0D02D1E7}"/>
               </a:ext>
             </a:extLst>
           </p:cNvPr>
@@ -11705,7 +11705,7 @@
           <p:cNvPr id="26" name="">
             <a:extLst xmlns:a="http://schemas.openxmlformats.org/drawingml/2006/main">
               <a:ext uri="{FF2B5EF4-FFF2-40B4-BE49-F238E27FC236}">
-                <a16:creationId xmlns:a16="http://schemas.microsoft.com/office/drawing/2014/main" id="{62F6ED21-F568-4D3E-B82A-F848695940B2}"/>
+                <a16:creationId xmlns:a16="http://schemas.microsoft.com/office/drawing/2014/main" id="{A74301B7-B76E-4962-8D2C-589ABFAB7A56}"/>
               </a:ext>
             </a:extLst>
           </p:cNvPr>
@@ -11762,7 +11762,7 @@
           <p:cNvPr id="27" name="">
             <a:extLst xmlns:a="http://schemas.openxmlformats.org/drawingml/2006/main">
               <a:ext uri="{FF2B5EF4-FFF2-40B4-BE49-F238E27FC236}">
-                <a16:creationId xmlns:a16="http://schemas.microsoft.com/office/drawing/2014/main" id="{C882ECB0-0071-47CF-A2A2-A514A2B887DE}"/>
+                <a16:creationId xmlns:a16="http://schemas.microsoft.com/office/drawing/2014/main" id="{A6865D0B-0851-4352-A8BA-A9347028492F}"/>
               </a:ext>
             </a:extLst>
           </p:cNvPr>
@@ -11819,7 +11819,7 @@
           <p:cNvPr id="28" name="">
             <a:extLst xmlns:a="http://schemas.openxmlformats.org/drawingml/2006/main">
               <a:ext uri="{FF2B5EF4-FFF2-40B4-BE49-F238E27FC236}">
-                <a16:creationId xmlns:a16="http://schemas.microsoft.com/office/drawing/2014/main" id="{A73E9687-2D0E-49A3-8FEE-BB525FC341F3}"/>
+                <a16:creationId xmlns:a16="http://schemas.microsoft.com/office/drawing/2014/main" id="{656DA926-3D6A-489C-A21F-627560A27F62}"/>
               </a:ext>
             </a:extLst>
           </p:cNvPr>
@@ -11874,7 +11874,7 @@
     </p:spTree>
     <p:extLst>
       <p:ext uri="{BB962C8B-B14F-4D97-AF65-F5344CB8AC3E}">
-        <p14:creationId xmlns:p14="http://schemas.microsoft.com/office/powerpoint/2010/main" val="1550109051"/>
+        <p14:creationId xmlns:p14="http://schemas.microsoft.com/office/powerpoint/2010/main" val="1721697551"/>
       </p:ext>
     </p:extLst>
   </p:cSld>
@@ -11905,7 +11905,7 @@
           <p:cNvPr id="21" name="">
             <a:extLst xmlns:a="http://schemas.openxmlformats.org/drawingml/2006/main">
               <a:ext uri="{FF2B5EF4-FFF2-40B4-BE49-F238E27FC236}">
-                <a16:creationId xmlns:a16="http://schemas.microsoft.com/office/drawing/2014/main" id="{DE033112-3C7A-43E3-9827-4592F7CF6C66}"/>
+                <a16:creationId xmlns:a16="http://schemas.microsoft.com/office/drawing/2014/main" id="{7AF852BF-76C3-40B7-B9F3-BF3EB82BF827}"/>
               </a:ext>
             </a:extLst>
           </p:cNvPr>
@@ -11962,7 +11962,7 @@
           <p:cNvPr id="2" name="">
             <a:extLst xmlns:a="http://schemas.openxmlformats.org/drawingml/2006/main">
               <a:ext uri="{FF2B5EF4-FFF2-40B4-BE49-F238E27FC236}">
-                <a16:creationId xmlns:a16="http://schemas.microsoft.com/office/drawing/2014/main" id="{5F0D7836-47D8-4233-B8A6-9D502DE17A60}"/>
+                <a16:creationId xmlns:a16="http://schemas.microsoft.com/office/drawing/2014/main" id="{AB718000-F77A-4F9A-A364-173246918F6A}"/>
               </a:ext>
             </a:extLst>
           </p:cNvPr>
@@ -11993,7 +11993,7 @@
           <p:cNvPr id="3" name="">
             <a:extLst xmlns:a="http://schemas.openxmlformats.org/drawingml/2006/main">
               <a:ext uri="{FF2B5EF4-FFF2-40B4-BE49-F238E27FC236}">
-                <a16:creationId xmlns:a16="http://schemas.microsoft.com/office/drawing/2014/main" id="{8D9EFBD3-3FEC-4A0C-88E9-DE6FB13508DF}"/>
+                <a16:creationId xmlns:a16="http://schemas.microsoft.com/office/drawing/2014/main" id="{1CA55506-499B-49BC-BDE7-506B7FCF1F31}"/>
               </a:ext>
             </a:extLst>
           </p:cNvPr>
@@ -12050,7 +12050,7 @@
           <p:cNvPr id="4" name="">
             <a:extLst xmlns:a="http://schemas.openxmlformats.org/drawingml/2006/main">
               <a:ext uri="{FF2B5EF4-FFF2-40B4-BE49-F238E27FC236}">
-                <a16:creationId xmlns:a16="http://schemas.microsoft.com/office/drawing/2014/main" id="{7A7C8041-08FE-45A3-B8D0-5C94A7959A66}"/>
+                <a16:creationId xmlns:a16="http://schemas.microsoft.com/office/drawing/2014/main" id="{AD436F22-B7CD-4CA5-86BE-80A01F1AB69B}"/>
               </a:ext>
             </a:extLst>
           </p:cNvPr>
@@ -12083,7 +12083,7 @@
           <p:cNvPr id="5" name="">
             <a:extLst xmlns:a="http://schemas.openxmlformats.org/drawingml/2006/main">
               <a:ext uri="{FF2B5EF4-FFF2-40B4-BE49-F238E27FC236}">
-                <a16:creationId xmlns:a16="http://schemas.microsoft.com/office/drawing/2014/main" id="{0E43EDB9-A656-42C1-A063-AD1935ED168E}"/>
+                <a16:creationId xmlns:a16="http://schemas.microsoft.com/office/drawing/2014/main" id="{93230E2B-138E-4716-A1C0-1AF62E6F995F}"/>
               </a:ext>
             </a:extLst>
           </p:cNvPr>
@@ -12140,7 +12140,7 @@
           <p:cNvPr id="6" name="">
             <a:extLst xmlns:a="http://schemas.openxmlformats.org/drawingml/2006/main">
               <a:ext uri="{FF2B5EF4-FFF2-40B4-BE49-F238E27FC236}">
-                <a16:creationId xmlns:a16="http://schemas.microsoft.com/office/drawing/2014/main" id="{EF1602FA-DB4A-414C-893C-27F35968B838}"/>
+                <a16:creationId xmlns:a16="http://schemas.microsoft.com/office/drawing/2014/main" id="{087A8CA3-A445-434D-996A-E3B5FC4C9A24}"/>
               </a:ext>
             </a:extLst>
           </p:cNvPr>
@@ -12220,7 +12220,7 @@
           <p:cNvPr id="7" name="">
             <a:extLst xmlns:a="http://schemas.openxmlformats.org/drawingml/2006/main">
               <a:ext uri="{FF2B5EF4-FFF2-40B4-BE49-F238E27FC236}">
-                <a16:creationId xmlns:a16="http://schemas.microsoft.com/office/drawing/2014/main" id="{34C5944D-5757-48E0-BA73-8E01C39CA0C1}"/>
+                <a16:creationId xmlns:a16="http://schemas.microsoft.com/office/drawing/2014/main" id="{752775E0-E6DB-46E7-B461-FAC4CBC24899}"/>
               </a:ext>
             </a:extLst>
           </p:cNvPr>
@@ -12300,7 +12300,7 @@
           <p:cNvPr id="8" name="">
             <a:extLst xmlns:a="http://schemas.openxmlformats.org/drawingml/2006/main">
               <a:ext uri="{FF2B5EF4-FFF2-40B4-BE49-F238E27FC236}">
-                <a16:creationId xmlns:a16="http://schemas.microsoft.com/office/drawing/2014/main" id="{B53C4119-F5D2-4AFD-A4B7-43C277A02AA5}"/>
+                <a16:creationId xmlns:a16="http://schemas.microsoft.com/office/drawing/2014/main" id="{EFD652D9-EC25-4F79-8FA7-886A260EE4EC}"/>
               </a:ext>
             </a:extLst>
           </p:cNvPr>
@@ -12333,7 +12333,7 @@
           <p:cNvPr id="9" name="">
             <a:extLst xmlns:a="http://schemas.openxmlformats.org/drawingml/2006/main">
               <a:ext uri="{FF2B5EF4-FFF2-40B4-BE49-F238E27FC236}">
-                <a16:creationId xmlns:a16="http://schemas.microsoft.com/office/drawing/2014/main" id="{A85796E5-7B34-4A1A-85BD-829BF554828C}"/>
+                <a16:creationId xmlns:a16="http://schemas.microsoft.com/office/drawing/2014/main" id="{5A9669CD-1B08-4E9F-938A-86E2BDAF0E4D}"/>
               </a:ext>
             </a:extLst>
           </p:cNvPr>
@@ -12390,7 +12390,7 @@
           <p:cNvPr id="10" name="">
             <a:extLst xmlns:a="http://schemas.openxmlformats.org/drawingml/2006/main">
               <a:ext uri="{FF2B5EF4-FFF2-40B4-BE49-F238E27FC236}">
-                <a16:creationId xmlns:a16="http://schemas.microsoft.com/office/drawing/2014/main" id="{0F190094-0610-4737-873C-3339F3B2738C}"/>
+                <a16:creationId xmlns:a16="http://schemas.microsoft.com/office/drawing/2014/main" id="{3FDF0F87-FB79-40ED-86DD-F2B8D20A8C0C}"/>
               </a:ext>
             </a:extLst>
           </p:cNvPr>
@@ -12470,7 +12470,7 @@
           <p:cNvPr id="11" name="">
             <a:extLst xmlns:a="http://schemas.openxmlformats.org/drawingml/2006/main">
               <a:ext uri="{FF2B5EF4-FFF2-40B4-BE49-F238E27FC236}">
-                <a16:creationId xmlns:a16="http://schemas.microsoft.com/office/drawing/2014/main" id="{75E82139-9678-4223-B1D6-19EFF813DB49}"/>
+                <a16:creationId xmlns:a16="http://schemas.microsoft.com/office/drawing/2014/main" id="{B21DE06D-52AC-4B80-92FC-E5B941D00763}"/>
               </a:ext>
             </a:extLst>
           </p:cNvPr>
@@ -12550,7 +12550,7 @@
           <p:cNvPr id="12" name="">
             <a:extLst xmlns:a="http://schemas.openxmlformats.org/drawingml/2006/main">
               <a:ext uri="{FF2B5EF4-FFF2-40B4-BE49-F238E27FC236}">
-                <a16:creationId xmlns:a16="http://schemas.microsoft.com/office/drawing/2014/main" id="{1B6D9C15-EC28-46DD-8B67-6F6C740A4065}"/>
+                <a16:creationId xmlns:a16="http://schemas.microsoft.com/office/drawing/2014/main" id="{F124211B-5FC6-48F1-B9EA-F6FC8F2FB653}"/>
               </a:ext>
             </a:extLst>
           </p:cNvPr>
@@ -12583,7 +12583,7 @@
           <p:cNvPr id="13" name="">
             <a:extLst xmlns:a="http://schemas.openxmlformats.org/drawingml/2006/main">
               <a:ext uri="{FF2B5EF4-FFF2-40B4-BE49-F238E27FC236}">
-                <a16:creationId xmlns:a16="http://schemas.microsoft.com/office/drawing/2014/main" id="{099B6859-613B-4101-BFB7-8DCBF0A422B5}"/>
+                <a16:creationId xmlns:a16="http://schemas.microsoft.com/office/drawing/2014/main" id="{EA9CC15B-C3C9-410B-9C7C-37F4D93BE55E}"/>
               </a:ext>
             </a:extLst>
           </p:cNvPr>
@@ -12640,7 +12640,7 @@
           <p:cNvPr id="14" name="">
             <a:extLst xmlns:a="http://schemas.openxmlformats.org/drawingml/2006/main">
               <a:ext uri="{FF2B5EF4-FFF2-40B4-BE49-F238E27FC236}">
-                <a16:creationId xmlns:a16="http://schemas.microsoft.com/office/drawing/2014/main" id="{84391AB0-F7F4-4832-9EB2-C71F0EEE77B3}"/>
+                <a16:creationId xmlns:a16="http://schemas.microsoft.com/office/drawing/2014/main" id="{1199F32D-11B2-4375-A3FB-6930F12ED297}"/>
               </a:ext>
             </a:extLst>
           </p:cNvPr>
@@ -12720,7 +12720,7 @@
           <p:cNvPr id="15" name="">
             <a:extLst xmlns:a="http://schemas.openxmlformats.org/drawingml/2006/main">
               <a:ext uri="{FF2B5EF4-FFF2-40B4-BE49-F238E27FC236}">
-                <a16:creationId xmlns:a16="http://schemas.microsoft.com/office/drawing/2014/main" id="{E0D47555-F8D7-4F8B-B6AC-B12BC8D82630}"/>
+                <a16:creationId xmlns:a16="http://schemas.microsoft.com/office/drawing/2014/main" id="{A6C7D07A-5B19-40B2-8589-8A8E718B8C33}"/>
               </a:ext>
             </a:extLst>
           </p:cNvPr>
@@ -12852,7 +12852,7 @@
           <p:cNvPr id="18" name="">
             <a:extLst xmlns:a="http://schemas.openxmlformats.org/drawingml/2006/main">
               <a:ext uri="{FF2B5EF4-FFF2-40B4-BE49-F238E27FC236}">
-                <a16:creationId xmlns:a16="http://schemas.microsoft.com/office/drawing/2014/main" id="{93C6EB63-D89F-4092-BDBE-00D693CFFBEB}"/>
+                <a16:creationId xmlns:a16="http://schemas.microsoft.com/office/drawing/2014/main" id="{AB7E44A8-82E3-4B99-B49D-CF8EE63EA603}"/>
               </a:ext>
             </a:extLst>
           </p:cNvPr>
@@ -12909,7 +12909,7 @@
           <p:cNvPr id="19" name="">
             <a:extLst xmlns:a="http://schemas.openxmlformats.org/drawingml/2006/main">
               <a:ext uri="{FF2B5EF4-FFF2-40B4-BE49-F238E27FC236}">
-                <a16:creationId xmlns:a16="http://schemas.microsoft.com/office/drawing/2014/main" id="{5BA062DC-61E0-471C-B43C-39A11F3D29D2}"/>
+                <a16:creationId xmlns:a16="http://schemas.microsoft.com/office/drawing/2014/main" id="{19915A6F-5B75-4D05-AD64-FC6E75C69843}"/>
               </a:ext>
             </a:extLst>
           </p:cNvPr>
@@ -12940,7 +12940,7 @@
           <p:cNvPr id="20" name="">
             <a:extLst xmlns:a="http://schemas.openxmlformats.org/drawingml/2006/main">
               <a:ext uri="{FF2B5EF4-FFF2-40B4-BE49-F238E27FC236}">
-                <a16:creationId xmlns:a16="http://schemas.microsoft.com/office/drawing/2014/main" id="{A409BB5E-2400-43D3-A42C-1BAD64FF03D4}"/>
+                <a16:creationId xmlns:a16="http://schemas.microsoft.com/office/drawing/2014/main" id="{FDE14539-4867-4DF5-AF48-AE1F0C6201EE}"/>
               </a:ext>
             </a:extLst>
           </p:cNvPr>
@@ -12995,7 +12995,7 @@
     </p:spTree>
     <p:extLst>
       <p:ext uri="{BB962C8B-B14F-4D97-AF65-F5344CB8AC3E}">
-        <p14:creationId xmlns:p14="http://schemas.microsoft.com/office/powerpoint/2010/main" val="1656091984"/>
+        <p14:creationId xmlns:p14="http://schemas.microsoft.com/office/powerpoint/2010/main" val="1945937959"/>
       </p:ext>
     </p:extLst>
   </p:cSld>
@@ -13026,7 +13026,7 @@
           <p:cNvPr id="68" name="">
             <a:extLst xmlns:a="http://schemas.openxmlformats.org/drawingml/2006/main">
               <a:ext uri="{FF2B5EF4-FFF2-40B4-BE49-F238E27FC236}">
-                <a16:creationId xmlns:a16="http://schemas.microsoft.com/office/drawing/2014/main" id="{1913ED2E-0AD9-4C99-8110-FB3BBD179D85}"/>
+                <a16:creationId xmlns:a16="http://schemas.microsoft.com/office/drawing/2014/main" id="{F12EE687-DE19-4012-9D5E-04DCAC87C3AA}"/>
               </a:ext>
             </a:extLst>
           </p:cNvPr>
@@ -13083,7 +13083,7 @@
           <p:cNvPr id="2" name="">
             <a:extLst xmlns:a="http://schemas.openxmlformats.org/drawingml/2006/main">
               <a:ext uri="{FF2B5EF4-FFF2-40B4-BE49-F238E27FC236}">
-                <a16:creationId xmlns:a16="http://schemas.microsoft.com/office/drawing/2014/main" id="{B58B15BB-F573-424C-B856-17411AE9B688}"/>
+                <a16:creationId xmlns:a16="http://schemas.microsoft.com/office/drawing/2014/main" id="{1C27A661-1173-4EAC-9C5F-81813B34CD0F}"/>
               </a:ext>
             </a:extLst>
           </p:cNvPr>
@@ -13114,7 +13114,7 @@
           <p:cNvPr id="3" name="">
             <a:extLst xmlns:a="http://schemas.openxmlformats.org/drawingml/2006/main">
               <a:ext uri="{FF2B5EF4-FFF2-40B4-BE49-F238E27FC236}">
-                <a16:creationId xmlns:a16="http://schemas.microsoft.com/office/drawing/2014/main" id="{3095BF39-B303-46F2-BDDE-13B2DB62BE79}"/>
+                <a16:creationId xmlns:a16="http://schemas.microsoft.com/office/drawing/2014/main" id="{D42A408C-FF57-4803-8945-381FEB551F0D}"/>
               </a:ext>
             </a:extLst>
           </p:cNvPr>
@@ -13171,7 +13171,7 @@
           <p:cNvPr id="4" name="">
             <a:extLst xmlns:a="http://schemas.openxmlformats.org/drawingml/2006/main">
               <a:ext uri="{FF2B5EF4-FFF2-40B4-BE49-F238E27FC236}">
-                <a16:creationId xmlns:a16="http://schemas.microsoft.com/office/drawing/2014/main" id="{725A6844-6B4E-4B0C-B337-EAA812BE8493}"/>
+                <a16:creationId xmlns:a16="http://schemas.microsoft.com/office/drawing/2014/main" id="{2CE622F4-1B6A-4139-8894-A032B08D3692}"/>
               </a:ext>
             </a:extLst>
           </p:cNvPr>
@@ -13228,7 +13228,7 @@
           <p:cNvPr id="5" name="">
             <a:extLst xmlns:a="http://schemas.openxmlformats.org/drawingml/2006/main">
               <a:ext uri="{FF2B5EF4-FFF2-40B4-BE49-F238E27FC236}">
-                <a16:creationId xmlns:a16="http://schemas.microsoft.com/office/drawing/2014/main" id="{14052F29-8471-4E97-B878-2DA1F030ADAF}"/>
+                <a16:creationId xmlns:a16="http://schemas.microsoft.com/office/drawing/2014/main" id="{E4D567F8-B367-4219-9E12-D46D74137B08}"/>
               </a:ext>
             </a:extLst>
           </p:cNvPr>
@@ -13261,7 +13261,7 @@
           <p:cNvPr id="6" name="">
             <a:extLst xmlns:a="http://schemas.openxmlformats.org/drawingml/2006/main">
               <a:ext uri="{FF2B5EF4-FFF2-40B4-BE49-F238E27FC236}">
-                <a16:creationId xmlns:a16="http://schemas.microsoft.com/office/drawing/2014/main" id="{54608C64-A709-4E82-8373-868B62B758FD}"/>
+                <a16:creationId xmlns:a16="http://schemas.microsoft.com/office/drawing/2014/main" id="{707B1235-B684-44E7-ADA0-FA1868C6EA82}"/>
               </a:ext>
             </a:extLst>
           </p:cNvPr>
@@ -13318,7 +13318,7 @@
           <p:cNvPr id="7" name="">
             <a:extLst xmlns:a="http://schemas.openxmlformats.org/drawingml/2006/main">
               <a:ext uri="{FF2B5EF4-FFF2-40B4-BE49-F238E27FC236}">
-                <a16:creationId xmlns:a16="http://schemas.microsoft.com/office/drawing/2014/main" id="{3365E7DE-65ED-4E5D-8CCB-8BC0C5C1C1D5}"/>
+                <a16:creationId xmlns:a16="http://schemas.microsoft.com/office/drawing/2014/main" id="{280BB6E6-FD27-48BD-A8B0-943717A9DD4B}"/>
               </a:ext>
             </a:extLst>
           </p:cNvPr>
@@ -13351,7 +13351,7 @@
           <p:cNvPr id="8" name="">
             <a:extLst xmlns:a="http://schemas.openxmlformats.org/drawingml/2006/main">
               <a:ext uri="{FF2B5EF4-FFF2-40B4-BE49-F238E27FC236}">
-                <a16:creationId xmlns:a16="http://schemas.microsoft.com/office/drawing/2014/main" id="{1EDEB91A-4FF8-4EB4-BB4E-1425A150E0B3}"/>
+                <a16:creationId xmlns:a16="http://schemas.microsoft.com/office/drawing/2014/main" id="{8749EEAE-F6BB-4F4C-AF42-6E5FE4BE511D}"/>
               </a:ext>
             </a:extLst>
           </p:cNvPr>
@@ -13408,7 +13408,7 @@
           <p:cNvPr id="9" name="">
             <a:extLst xmlns:a="http://schemas.openxmlformats.org/drawingml/2006/main">
               <a:ext uri="{FF2B5EF4-FFF2-40B4-BE49-F238E27FC236}">
-                <a16:creationId xmlns:a16="http://schemas.microsoft.com/office/drawing/2014/main" id="{9F02B6DB-4CDD-4FAA-AD8F-2B7D78CFEC47}"/>
+                <a16:creationId xmlns:a16="http://schemas.microsoft.com/office/drawing/2014/main" id="{1AB82AD0-D146-446D-89A6-E992A1AECEFF}"/>
               </a:ext>
             </a:extLst>
           </p:cNvPr>
@@ -13441,7 +13441,7 @@
           <p:cNvPr id="10" name="">
             <a:extLst xmlns:a="http://schemas.openxmlformats.org/drawingml/2006/main">
               <a:ext uri="{FF2B5EF4-FFF2-40B4-BE49-F238E27FC236}">
-                <a16:creationId xmlns:a16="http://schemas.microsoft.com/office/drawing/2014/main" id="{89727570-273D-444E-BA72-1D47D3CB0AA1}"/>
+                <a16:creationId xmlns:a16="http://schemas.microsoft.com/office/drawing/2014/main" id="{DD9AF558-1EE1-4DE6-AE06-4767A2EEBFFA}"/>
               </a:ext>
             </a:extLst>
           </p:cNvPr>
@@ -13498,7 +13498,7 @@
           <p:cNvPr id="11" name="">
             <a:extLst xmlns:a="http://schemas.openxmlformats.org/drawingml/2006/main">
               <a:ext uri="{FF2B5EF4-FFF2-40B4-BE49-F238E27FC236}">
-                <a16:creationId xmlns:a16="http://schemas.microsoft.com/office/drawing/2014/main" id="{833409B2-C186-473D-900E-25A06BB5758B}"/>
+                <a16:creationId xmlns:a16="http://schemas.microsoft.com/office/drawing/2014/main" id="{411749EC-0027-4CB4-AD9D-C33289AAF1A7}"/>
               </a:ext>
             </a:extLst>
           </p:cNvPr>
@@ -13531,7 +13531,7 @@
           <p:cNvPr id="12" name="">
             <a:extLst xmlns:a="http://schemas.openxmlformats.org/drawingml/2006/main">
               <a:ext uri="{FF2B5EF4-FFF2-40B4-BE49-F238E27FC236}">
-                <a16:creationId xmlns:a16="http://schemas.microsoft.com/office/drawing/2014/main" id="{75A14A41-584D-449D-9D89-96EE28DAD569}"/>
+                <a16:creationId xmlns:a16="http://schemas.microsoft.com/office/drawing/2014/main" id="{BDDF17DE-4501-4550-81B4-22DDC47BA336}"/>
               </a:ext>
             </a:extLst>
           </p:cNvPr>
@@ -13588,7 +13588,7 @@
           <p:cNvPr id="13" name="">
             <a:extLst xmlns:a="http://schemas.openxmlformats.org/drawingml/2006/main">
               <a:ext uri="{FF2B5EF4-FFF2-40B4-BE49-F238E27FC236}">
-                <a16:creationId xmlns:a16="http://schemas.microsoft.com/office/drawing/2014/main" id="{AB121FE7-E7ED-4265-9BB8-516AB2E9A5AB}"/>
+                <a16:creationId xmlns:a16="http://schemas.microsoft.com/office/drawing/2014/main" id="{13776791-E772-41F2-A19C-8354C512025C}"/>
               </a:ext>
             </a:extLst>
           </p:cNvPr>
@@ -13621,7 +13621,7 @@
           <p:cNvPr id="14" name="">
             <a:extLst xmlns:a="http://schemas.openxmlformats.org/drawingml/2006/main">
               <a:ext uri="{FF2B5EF4-FFF2-40B4-BE49-F238E27FC236}">
-                <a16:creationId xmlns:a16="http://schemas.microsoft.com/office/drawing/2014/main" id="{AE016385-23CD-4C87-80D7-B094F874438F}"/>
+                <a16:creationId xmlns:a16="http://schemas.microsoft.com/office/drawing/2014/main" id="{978B8E39-6068-4B0F-A5CB-E8E46A5D9314}"/>
               </a:ext>
             </a:extLst>
           </p:cNvPr>
@@ -13678,7 +13678,7 @@
           <p:cNvPr id="15" name="">
             <a:extLst xmlns:a="http://schemas.openxmlformats.org/drawingml/2006/main">
               <a:ext uri="{FF2B5EF4-FFF2-40B4-BE49-F238E27FC236}">
-                <a16:creationId xmlns:a16="http://schemas.microsoft.com/office/drawing/2014/main" id="{445AB976-19EA-4D46-AECB-A54A3B391301}"/>
+                <a16:creationId xmlns:a16="http://schemas.microsoft.com/office/drawing/2014/main" id="{A93BC465-5F8C-469B-9AB0-E370A6D3E079}"/>
               </a:ext>
             </a:extLst>
           </p:cNvPr>
@@ -13711,7 +13711,7 @@
           <p:cNvPr id="16" name="">
             <a:extLst xmlns:a="http://schemas.openxmlformats.org/drawingml/2006/main">
               <a:ext uri="{FF2B5EF4-FFF2-40B4-BE49-F238E27FC236}">
-                <a16:creationId xmlns:a16="http://schemas.microsoft.com/office/drawing/2014/main" id="{133A87CC-D03C-44AF-BA46-8B008A49A3E5}"/>
+                <a16:creationId xmlns:a16="http://schemas.microsoft.com/office/drawing/2014/main" id="{B208297E-0740-46CF-81A0-20AC4BB690C1}"/>
               </a:ext>
             </a:extLst>
           </p:cNvPr>
@@ -13768,7 +13768,7 @@
           <p:cNvPr id="17" name="">
             <a:extLst xmlns:a="http://schemas.openxmlformats.org/drawingml/2006/main">
               <a:ext uri="{FF2B5EF4-FFF2-40B4-BE49-F238E27FC236}">
-                <a16:creationId xmlns:a16="http://schemas.microsoft.com/office/drawing/2014/main" id="{F8E127E7-1D7F-417F-BA10-86A3EE610AE9}"/>
+                <a16:creationId xmlns:a16="http://schemas.microsoft.com/office/drawing/2014/main" id="{F279F7B8-5C48-4298-86C3-00E5AC5FD2A1}"/>
               </a:ext>
             </a:extLst>
           </p:cNvPr>
@@ -13801,7 +13801,7 @@
           <p:cNvPr id="18" name="">
             <a:extLst xmlns:a="http://schemas.openxmlformats.org/drawingml/2006/main">
               <a:ext uri="{FF2B5EF4-FFF2-40B4-BE49-F238E27FC236}">
-                <a16:creationId xmlns:a16="http://schemas.microsoft.com/office/drawing/2014/main" id="{A7042447-7482-4ACD-8E9A-34975832E80B}"/>
+                <a16:creationId xmlns:a16="http://schemas.microsoft.com/office/drawing/2014/main" id="{A6E8FEA1-55AC-46BF-891B-A8754350AE70}"/>
               </a:ext>
             </a:extLst>
           </p:cNvPr>
@@ -13858,7 +13858,7 @@
           <p:cNvPr id="19" name="">
             <a:extLst xmlns:a="http://schemas.openxmlformats.org/drawingml/2006/main">
               <a:ext uri="{FF2B5EF4-FFF2-40B4-BE49-F238E27FC236}">
-                <a16:creationId xmlns:a16="http://schemas.microsoft.com/office/drawing/2014/main" id="{9A47BAD7-6B33-4F00-BF67-4CC58B376ADA}"/>
+                <a16:creationId xmlns:a16="http://schemas.microsoft.com/office/drawing/2014/main" id="{9020EE07-378D-4BC4-AB92-1770F871D427}"/>
               </a:ext>
             </a:extLst>
           </p:cNvPr>
@@ -13891,7 +13891,7 @@
           <p:cNvPr id="20" name="">
             <a:extLst xmlns:a="http://schemas.openxmlformats.org/drawingml/2006/main">
               <a:ext uri="{FF2B5EF4-FFF2-40B4-BE49-F238E27FC236}">
-                <a16:creationId xmlns:a16="http://schemas.microsoft.com/office/drawing/2014/main" id="{EB1D03BE-956E-4BAD-9946-A37BE08CA022}"/>
+                <a16:creationId xmlns:a16="http://schemas.microsoft.com/office/drawing/2014/main" id="{48944531-E9B6-40C1-88EB-37370E71148A}"/>
               </a:ext>
             </a:extLst>
           </p:cNvPr>
@@ -13948,7 +13948,7 @@
           <p:cNvPr id="21" name="">
             <a:extLst xmlns:a="http://schemas.openxmlformats.org/drawingml/2006/main">
               <a:ext uri="{FF2B5EF4-FFF2-40B4-BE49-F238E27FC236}">
-                <a16:creationId xmlns:a16="http://schemas.microsoft.com/office/drawing/2014/main" id="{71771346-36A0-4E31-8B59-F68EBA9F7549}"/>
+                <a16:creationId xmlns:a16="http://schemas.microsoft.com/office/drawing/2014/main" id="{D81F7B4E-3FBA-433A-A622-7CAE60CC6CD9}"/>
               </a:ext>
             </a:extLst>
           </p:cNvPr>
@@ -13979,7 +13979,7 @@
           <p:cNvPr id="22" name="">
             <a:extLst xmlns:a="http://schemas.openxmlformats.org/drawingml/2006/main">
               <a:ext uri="{FF2B5EF4-FFF2-40B4-BE49-F238E27FC236}">
-                <a16:creationId xmlns:a16="http://schemas.microsoft.com/office/drawing/2014/main" id="{BC59BCD3-58CB-4C24-8F13-99B0986A9F72}"/>
+                <a16:creationId xmlns:a16="http://schemas.microsoft.com/office/drawing/2014/main" id="{D4B3EF31-BECA-47E6-AE18-E913905702A0}"/>
               </a:ext>
             </a:extLst>
           </p:cNvPr>
@@ -14010,7 +14010,7 @@
           <p:cNvPr id="23" name="">
             <a:extLst xmlns:a="http://schemas.openxmlformats.org/drawingml/2006/main">
               <a:ext uri="{FF2B5EF4-FFF2-40B4-BE49-F238E27FC236}">
-                <a16:creationId xmlns:a16="http://schemas.microsoft.com/office/drawing/2014/main" id="{7B0C9FFF-A065-4178-9C1A-C695DA9711F3}"/>
+                <a16:creationId xmlns:a16="http://schemas.microsoft.com/office/drawing/2014/main" id="{F63581AF-C4B7-47B6-B5D8-24A33D4A8F3F}"/>
               </a:ext>
             </a:extLst>
           </p:cNvPr>
@@ -14041,7 +14041,7 @@
           <p:cNvPr id="24" name="">
             <a:extLst xmlns:a="http://schemas.openxmlformats.org/drawingml/2006/main">
               <a:ext uri="{FF2B5EF4-FFF2-40B4-BE49-F238E27FC236}">
-                <a16:creationId xmlns:a16="http://schemas.microsoft.com/office/drawing/2014/main" id="{8B0E28B4-D87C-4015-86F3-686CF166D180}"/>
+                <a16:creationId xmlns:a16="http://schemas.microsoft.com/office/drawing/2014/main" id="{CC4B9928-BA8F-46A1-978A-45E4130DEFB4}"/>
               </a:ext>
             </a:extLst>
           </p:cNvPr>
@@ -14072,7 +14072,7 @@
           <p:cNvPr id="25" name="">
             <a:extLst xmlns:a="http://schemas.openxmlformats.org/drawingml/2006/main">
               <a:ext uri="{FF2B5EF4-FFF2-40B4-BE49-F238E27FC236}">
-                <a16:creationId xmlns:a16="http://schemas.microsoft.com/office/drawing/2014/main" id="{433F1502-4332-4430-A8CB-4098D3E29A2F}"/>
+                <a16:creationId xmlns:a16="http://schemas.microsoft.com/office/drawing/2014/main" id="{1AB45130-7E6F-4687-83E2-376CF068D4E3}"/>
               </a:ext>
             </a:extLst>
           </p:cNvPr>
@@ -14103,7 +14103,7 @@
           <p:cNvPr id="26" name="">
             <a:extLst xmlns:a="http://schemas.openxmlformats.org/drawingml/2006/main">
               <a:ext uri="{FF2B5EF4-FFF2-40B4-BE49-F238E27FC236}">
-                <a16:creationId xmlns:a16="http://schemas.microsoft.com/office/drawing/2014/main" id="{01039AC8-AE80-48C1-BC92-FA1F676B4F8C}"/>
+                <a16:creationId xmlns:a16="http://schemas.microsoft.com/office/drawing/2014/main" id="{EAE418B6-B19F-41A1-9971-19B468E78019}"/>
               </a:ext>
             </a:extLst>
           </p:cNvPr>
@@ -14134,7 +14134,7 @@
           <p:cNvPr id="27" name="">
             <a:extLst xmlns:a="http://schemas.openxmlformats.org/drawingml/2006/main">
               <a:ext uri="{FF2B5EF4-FFF2-40B4-BE49-F238E27FC236}">
-                <a16:creationId xmlns:a16="http://schemas.microsoft.com/office/drawing/2014/main" id="{DC106461-F5A1-43D1-912C-29B98F8D390D}"/>
+                <a16:creationId xmlns:a16="http://schemas.microsoft.com/office/drawing/2014/main" id="{2E621272-89CE-4CA9-B3D2-2B98E5FB6C1F}"/>
               </a:ext>
             </a:extLst>
           </p:cNvPr>
@@ -14165,7 +14165,7 @@
           <p:cNvPr id="28" name="">
             <a:extLst xmlns:a="http://schemas.openxmlformats.org/drawingml/2006/main">
               <a:ext uri="{FF2B5EF4-FFF2-40B4-BE49-F238E27FC236}">
-                <a16:creationId xmlns:a16="http://schemas.microsoft.com/office/drawing/2014/main" id="{3D0CE3C6-7BC0-4BFB-B009-AA1B7E296B6F}"/>
+                <a16:creationId xmlns:a16="http://schemas.microsoft.com/office/drawing/2014/main" id="{5696F951-43E6-478C-AAF1-2BCFF9A2160D}"/>
               </a:ext>
             </a:extLst>
           </p:cNvPr>
@@ -14222,7 +14222,7 @@
           <p:cNvPr id="29" name="">
             <a:extLst xmlns:a="http://schemas.openxmlformats.org/drawingml/2006/main">
               <a:ext uri="{FF2B5EF4-FFF2-40B4-BE49-F238E27FC236}">
-                <a16:creationId xmlns:a16="http://schemas.microsoft.com/office/drawing/2014/main" id="{2592F6F5-89B4-48AA-8FE4-35B35D371619}"/>
+                <a16:creationId xmlns:a16="http://schemas.microsoft.com/office/drawing/2014/main" id="{15A17596-4722-4D70-9339-D415CE8E74C3}"/>
               </a:ext>
             </a:extLst>
           </p:cNvPr>
@@ -14279,7 +14279,7 @@
           <p:cNvPr id="30" name="">
             <a:extLst xmlns:a="http://schemas.openxmlformats.org/drawingml/2006/main">
               <a:ext uri="{FF2B5EF4-FFF2-40B4-BE49-F238E27FC236}">
-                <a16:creationId xmlns:a16="http://schemas.microsoft.com/office/drawing/2014/main" id="{D645AED1-057F-4362-8B3B-91CAC0932760}"/>
+                <a16:creationId xmlns:a16="http://schemas.microsoft.com/office/drawing/2014/main" id="{7255337F-1458-4097-BB24-40249BDCE12F}"/>
               </a:ext>
             </a:extLst>
           </p:cNvPr>
@@ -14336,7 +14336,7 @@
           <p:cNvPr id="31" name="">
             <a:extLst xmlns:a="http://schemas.openxmlformats.org/drawingml/2006/main">
               <a:ext uri="{FF2B5EF4-FFF2-40B4-BE49-F238E27FC236}">
-                <a16:creationId xmlns:a16="http://schemas.microsoft.com/office/drawing/2014/main" id="{E4C1F6DA-776A-4E33-8497-3F77125AFC7B}"/>
+                <a16:creationId xmlns:a16="http://schemas.microsoft.com/office/drawing/2014/main" id="{ABE945F4-B0FC-4A4B-A66D-4E8115100B5C}"/>
               </a:ext>
             </a:extLst>
           </p:cNvPr>
@@ -14393,7 +14393,7 @@
           <p:cNvPr id="32" name="">
             <a:extLst xmlns:a="http://schemas.openxmlformats.org/drawingml/2006/main">
               <a:ext uri="{FF2B5EF4-FFF2-40B4-BE49-F238E27FC236}">
-                <a16:creationId xmlns:a16="http://schemas.microsoft.com/office/drawing/2014/main" id="{3EADF500-B28E-4813-B97B-8C9F041B66F6}"/>
+                <a16:creationId xmlns:a16="http://schemas.microsoft.com/office/drawing/2014/main" id="{CB1A4B9D-BA55-45B4-A345-E97E80E11B06}"/>
               </a:ext>
             </a:extLst>
           </p:cNvPr>
@@ -14450,7 +14450,7 @@
           <p:cNvPr id="33" name="">
             <a:extLst xmlns:a="http://schemas.openxmlformats.org/drawingml/2006/main">
               <a:ext uri="{FF2B5EF4-FFF2-40B4-BE49-F238E27FC236}">
-                <a16:creationId xmlns:a16="http://schemas.microsoft.com/office/drawing/2014/main" id="{E7E4BE4B-4A23-43C1-A0AE-8AA14FF625CD}"/>
+                <a16:creationId xmlns:a16="http://schemas.microsoft.com/office/drawing/2014/main" id="{67212BCD-CD5C-4E88-B645-536DF471E98F}"/>
               </a:ext>
             </a:extLst>
           </p:cNvPr>
@@ -14507,7 +14507,7 @@
           <p:cNvPr id="34" name="">
             <a:extLst xmlns:a="http://schemas.openxmlformats.org/drawingml/2006/main">
               <a:ext uri="{FF2B5EF4-FFF2-40B4-BE49-F238E27FC236}">
-                <a16:creationId xmlns:a16="http://schemas.microsoft.com/office/drawing/2014/main" id="{26AEFE10-7E4F-4E8E-85E1-1747DE185B7C}"/>
+                <a16:creationId xmlns:a16="http://schemas.microsoft.com/office/drawing/2014/main" id="{1AD1030E-C209-4B05-AB60-2D76220F4D4E}"/>
               </a:ext>
             </a:extLst>
           </p:cNvPr>
@@ -14564,7 +14564,7 @@
           <p:cNvPr id="35" name="">
             <a:extLst xmlns:a="http://schemas.openxmlformats.org/drawingml/2006/main">
               <a:ext uri="{FF2B5EF4-FFF2-40B4-BE49-F238E27FC236}">
-                <a16:creationId xmlns:a16="http://schemas.microsoft.com/office/drawing/2014/main" id="{937B89AE-F73C-473D-8541-7CD5926F5AEC}"/>
+                <a16:creationId xmlns:a16="http://schemas.microsoft.com/office/drawing/2014/main" id="{A877A53E-38B9-4AAD-A4F9-A359F8E137CE}"/>
               </a:ext>
             </a:extLst>
           </p:cNvPr>
@@ -14621,7 +14621,7 @@
           <p:cNvPr id="36" name="">
             <a:extLst xmlns:a="http://schemas.openxmlformats.org/drawingml/2006/main">
               <a:ext uri="{FF2B5EF4-FFF2-40B4-BE49-F238E27FC236}">
-                <a16:creationId xmlns:a16="http://schemas.microsoft.com/office/drawing/2014/main" id="{0F514D72-6CDB-419D-86B2-2EB1CD7356E6}"/>
+                <a16:creationId xmlns:a16="http://schemas.microsoft.com/office/drawing/2014/main" id="{BD9D61EA-C9EC-4699-95D7-345B6BC8AED4}"/>
               </a:ext>
             </a:extLst>
           </p:cNvPr>
@@ -14678,7 +14678,7 @@
           <p:cNvPr id="37" name="">
             <a:extLst xmlns:a="http://schemas.openxmlformats.org/drawingml/2006/main">
               <a:ext uri="{FF2B5EF4-FFF2-40B4-BE49-F238E27FC236}">
-                <a16:creationId xmlns:a16="http://schemas.microsoft.com/office/drawing/2014/main" id="{53B185F2-D1B9-4B4A-9EE3-88D0096B25F0}"/>
+                <a16:creationId xmlns:a16="http://schemas.microsoft.com/office/drawing/2014/main" id="{E4FE9BF0-1D6A-449F-BD63-8BA8663853A8}"/>
               </a:ext>
             </a:extLst>
           </p:cNvPr>
@@ -14735,7 +14735,7 @@
           <p:cNvPr id="38" name="">
             <a:extLst xmlns:a="http://schemas.openxmlformats.org/drawingml/2006/main">
               <a:ext uri="{FF2B5EF4-FFF2-40B4-BE49-F238E27FC236}">
-                <a16:creationId xmlns:a16="http://schemas.microsoft.com/office/drawing/2014/main" id="{D563CE25-962C-4F5C-AF3D-E143FE755929}"/>
+                <a16:creationId xmlns:a16="http://schemas.microsoft.com/office/drawing/2014/main" id="{3EDF8DD1-C06A-4DC5-8E28-EA5ECC60132E}"/>
               </a:ext>
             </a:extLst>
           </p:cNvPr>
@@ -14792,7 +14792,7 @@
           <p:cNvPr id="39" name="">
             <a:extLst xmlns:a="http://schemas.openxmlformats.org/drawingml/2006/main">
               <a:ext uri="{FF2B5EF4-FFF2-40B4-BE49-F238E27FC236}">
-                <a16:creationId xmlns:a16="http://schemas.microsoft.com/office/drawing/2014/main" id="{91D4E617-A33B-456D-89B4-B883BD1688BE}"/>
+                <a16:creationId xmlns:a16="http://schemas.microsoft.com/office/drawing/2014/main" id="{51F5264B-F4F8-49A6-98C1-09B6CAF8828E}"/>
               </a:ext>
             </a:extLst>
           </p:cNvPr>
@@ -14849,7 +14849,7 @@
           <p:cNvPr id="40" name="">
             <a:extLst xmlns:a="http://schemas.openxmlformats.org/drawingml/2006/main">
               <a:ext uri="{FF2B5EF4-FFF2-40B4-BE49-F238E27FC236}">
-                <a16:creationId xmlns:a16="http://schemas.microsoft.com/office/drawing/2014/main" id="{D0612448-CB67-4A5A-9406-A9690A08AEC2}"/>
+                <a16:creationId xmlns:a16="http://schemas.microsoft.com/office/drawing/2014/main" id="{78F868B6-F1FE-44BB-9C85-314D9D2161C5}"/>
               </a:ext>
             </a:extLst>
           </p:cNvPr>
@@ -14906,7 +14906,7 @@
           <p:cNvPr id="41" name="">
             <a:extLst xmlns:a="http://schemas.openxmlformats.org/drawingml/2006/main">
               <a:ext uri="{FF2B5EF4-FFF2-40B4-BE49-F238E27FC236}">
-                <a16:creationId xmlns:a16="http://schemas.microsoft.com/office/drawing/2014/main" id="{C2695304-4EF1-40CC-A942-8E491918260E}"/>
+                <a16:creationId xmlns:a16="http://schemas.microsoft.com/office/drawing/2014/main" id="{336AB5DB-A365-4B5F-BC98-9A899F12410A}"/>
               </a:ext>
             </a:extLst>
           </p:cNvPr>
@@ -14963,7 +14963,7 @@
           <p:cNvPr id="42" name="">
             <a:extLst xmlns:a="http://schemas.openxmlformats.org/drawingml/2006/main">
               <a:ext uri="{FF2B5EF4-FFF2-40B4-BE49-F238E27FC236}">
-                <a16:creationId xmlns:a16="http://schemas.microsoft.com/office/drawing/2014/main" id="{2BF393F1-8CD5-4F87-82A5-414A6E94AF0A}"/>
+                <a16:creationId xmlns:a16="http://schemas.microsoft.com/office/drawing/2014/main" id="{960C221D-256F-415C-8814-3D64924CEB0E}"/>
               </a:ext>
             </a:extLst>
           </p:cNvPr>
@@ -14996,7 +14996,7 @@
           <p:cNvPr id="43" name="">
             <a:extLst xmlns:a="http://schemas.openxmlformats.org/drawingml/2006/main">
               <a:ext uri="{FF2B5EF4-FFF2-40B4-BE49-F238E27FC236}">
-                <a16:creationId xmlns:a16="http://schemas.microsoft.com/office/drawing/2014/main" id="{E6084419-1730-42AB-A948-5B4237A73ECA}"/>
+                <a16:creationId xmlns:a16="http://schemas.microsoft.com/office/drawing/2014/main" id="{9A06EE50-57AC-4089-BE60-211C04B270CF}"/>
               </a:ext>
             </a:extLst>
           </p:cNvPr>
@@ -15053,7 +15053,7 @@
           <p:cNvPr id="44" name="">
             <a:extLst xmlns:a="http://schemas.openxmlformats.org/drawingml/2006/main">
               <a:ext uri="{FF2B5EF4-FFF2-40B4-BE49-F238E27FC236}">
-                <a16:creationId xmlns:a16="http://schemas.microsoft.com/office/drawing/2014/main" id="{848D707B-A292-4B94-9C6D-2BDC89721D33}"/>
+                <a16:creationId xmlns:a16="http://schemas.microsoft.com/office/drawing/2014/main" id="{1624AF74-8461-4C73-AA5E-F80D2F9E43C2}"/>
               </a:ext>
             </a:extLst>
           </p:cNvPr>
@@ -15086,7 +15086,7 @@
           <p:cNvPr id="45" name="">
             <a:extLst xmlns:a="http://schemas.openxmlformats.org/drawingml/2006/main">
               <a:ext uri="{FF2B5EF4-FFF2-40B4-BE49-F238E27FC236}">
-                <a16:creationId xmlns:a16="http://schemas.microsoft.com/office/drawing/2014/main" id="{5C8AB225-969B-4BA1-AED8-74EFA3A4A67A}"/>
+                <a16:creationId xmlns:a16="http://schemas.microsoft.com/office/drawing/2014/main" id="{FC19735C-86D2-492C-85C3-FF59A91DCE03}"/>
               </a:ext>
             </a:extLst>
           </p:cNvPr>
@@ -15143,7 +15143,7 @@
           <p:cNvPr id="46" name="">
             <a:extLst xmlns:a="http://schemas.openxmlformats.org/drawingml/2006/main">
               <a:ext uri="{FF2B5EF4-FFF2-40B4-BE49-F238E27FC236}">
-                <a16:creationId xmlns:a16="http://schemas.microsoft.com/office/drawing/2014/main" id="{081ED12E-903C-4EB3-8CE0-B4557CE70E02}"/>
+                <a16:creationId xmlns:a16="http://schemas.microsoft.com/office/drawing/2014/main" id="{1D5E7C35-0232-4F40-922E-4B4F92FF7EC4}"/>
               </a:ext>
             </a:extLst>
           </p:cNvPr>
@@ -15176,7 +15176,7 @@
           <p:cNvPr id="47" name="">
             <a:extLst xmlns:a="http://schemas.openxmlformats.org/drawingml/2006/main">
               <a:ext uri="{FF2B5EF4-FFF2-40B4-BE49-F238E27FC236}">
-                <a16:creationId xmlns:a16="http://schemas.microsoft.com/office/drawing/2014/main" id="{09B8E417-494B-4BB8-BE23-9594884E00A5}"/>
+                <a16:creationId xmlns:a16="http://schemas.microsoft.com/office/drawing/2014/main" id="{2C562D33-45CC-44DE-BC04-5E28E8889087}"/>
               </a:ext>
             </a:extLst>
           </p:cNvPr>
@@ -15233,7 +15233,7 @@
           <p:cNvPr id="48" name="">
             <a:extLst xmlns:a="http://schemas.openxmlformats.org/drawingml/2006/main">
               <a:ext uri="{FF2B5EF4-FFF2-40B4-BE49-F238E27FC236}">
-                <a16:creationId xmlns:a16="http://schemas.microsoft.com/office/drawing/2014/main" id="{B334C33F-0EF8-4435-B8C2-0F99785581B7}"/>
+                <a16:creationId xmlns:a16="http://schemas.microsoft.com/office/drawing/2014/main" id="{A94F74AD-C091-4173-ADED-3EBEB208404A}"/>
               </a:ext>
             </a:extLst>
           </p:cNvPr>
@@ -15264,7 +15264,7 @@
           <p:cNvPr id="49" name="">
             <a:extLst xmlns:a="http://schemas.openxmlformats.org/drawingml/2006/main">
               <a:ext uri="{FF2B5EF4-FFF2-40B4-BE49-F238E27FC236}">
-                <a16:creationId xmlns:a16="http://schemas.microsoft.com/office/drawing/2014/main" id="{C5D14825-C2F5-4623-A069-06F16A0D952D}"/>
+                <a16:creationId xmlns:a16="http://schemas.microsoft.com/office/drawing/2014/main" id="{60B4B392-6937-4DC3-B2D3-9C762C42331B}"/>
               </a:ext>
             </a:extLst>
           </p:cNvPr>
@@ -15295,7 +15295,7 @@
           <p:cNvPr id="50" name="">
             <a:extLst xmlns:a="http://schemas.openxmlformats.org/drawingml/2006/main">
               <a:ext uri="{FF2B5EF4-FFF2-40B4-BE49-F238E27FC236}">
-                <a16:creationId xmlns:a16="http://schemas.microsoft.com/office/drawing/2014/main" id="{8BCD1260-111E-4E3D-891B-432265F8624B}"/>
+                <a16:creationId xmlns:a16="http://schemas.microsoft.com/office/drawing/2014/main" id="{BCFEAB45-353A-4F22-A5CE-CF5CF5845B1B}"/>
               </a:ext>
             </a:extLst>
           </p:cNvPr>
@@ -15352,7 +15352,7 @@
           <p:cNvPr id="51" name="">
             <a:extLst xmlns:a="http://schemas.openxmlformats.org/drawingml/2006/main">
               <a:ext uri="{FF2B5EF4-FFF2-40B4-BE49-F238E27FC236}">
-                <a16:creationId xmlns:a16="http://schemas.microsoft.com/office/drawing/2014/main" id="{22C2307A-1644-4802-BC6B-86AAE6111DDD}"/>
+                <a16:creationId xmlns:a16="http://schemas.microsoft.com/office/drawing/2014/main" id="{5E22C18C-90B7-4052-98C4-6F1A62945DEF}"/>
               </a:ext>
             </a:extLst>
           </p:cNvPr>
@@ -15409,7 +15409,7 @@
           <p:cNvPr id="52" name="">
             <a:extLst xmlns:a="http://schemas.openxmlformats.org/drawingml/2006/main">
               <a:ext uri="{FF2B5EF4-FFF2-40B4-BE49-F238E27FC236}">
-                <a16:creationId xmlns:a16="http://schemas.microsoft.com/office/drawing/2014/main" id="{3BFE4E81-F1BD-4252-BB99-895797F6B055}"/>
+                <a16:creationId xmlns:a16="http://schemas.microsoft.com/office/drawing/2014/main" id="{851EBD0A-236C-4461-BFFC-0D5F0E026D8D}"/>
               </a:ext>
             </a:extLst>
           </p:cNvPr>
@@ -15466,7 +15466,7 @@
           <p:cNvPr id="53" name="">
             <a:extLst xmlns:a="http://schemas.openxmlformats.org/drawingml/2006/main">
               <a:ext uri="{FF2B5EF4-FFF2-40B4-BE49-F238E27FC236}">
-                <a16:creationId xmlns:a16="http://schemas.microsoft.com/office/drawing/2014/main" id="{295F3B4D-1153-4AE2-8725-DD18B63EEF09}"/>
+                <a16:creationId xmlns:a16="http://schemas.microsoft.com/office/drawing/2014/main" id="{6E5F1326-5AC2-442E-B450-E3F9043070C9}"/>
               </a:ext>
             </a:extLst>
           </p:cNvPr>
@@ -15546,7 +15546,7 @@
           <p:cNvPr id="54" name="">
             <a:extLst xmlns:a="http://schemas.openxmlformats.org/drawingml/2006/main">
               <a:ext uri="{FF2B5EF4-FFF2-40B4-BE49-F238E27FC236}">
-                <a16:creationId xmlns:a16="http://schemas.microsoft.com/office/drawing/2014/main" id="{1A97A1EC-E7B6-4FAB-8009-FAF086439703}"/>
+                <a16:creationId xmlns:a16="http://schemas.microsoft.com/office/drawing/2014/main" id="{046E8389-FD2D-4456-AEDA-47EB4EF9F9F7}"/>
               </a:ext>
             </a:extLst>
           </p:cNvPr>
@@ -15579,7 +15579,7 @@
           <p:cNvPr id="55" name="">
             <a:extLst xmlns:a="http://schemas.openxmlformats.org/drawingml/2006/main">
               <a:ext uri="{FF2B5EF4-FFF2-40B4-BE49-F238E27FC236}">
-                <a16:creationId xmlns:a16="http://schemas.microsoft.com/office/drawing/2014/main" id="{CC177E48-1825-40BB-9672-3957A2701868}"/>
+                <a16:creationId xmlns:a16="http://schemas.microsoft.com/office/drawing/2014/main" id="{5455C628-698A-4762-80AD-80A96C299D5F}"/>
               </a:ext>
             </a:extLst>
           </p:cNvPr>
@@ -15636,7 +15636,7 @@
           <p:cNvPr id="56" name="">
             <a:extLst xmlns:a="http://schemas.openxmlformats.org/drawingml/2006/main">
               <a:ext uri="{FF2B5EF4-FFF2-40B4-BE49-F238E27FC236}">
-                <a16:creationId xmlns:a16="http://schemas.microsoft.com/office/drawing/2014/main" id="{8085D043-C56E-489F-9224-4A702CDFFA12}"/>
+                <a16:creationId xmlns:a16="http://schemas.microsoft.com/office/drawing/2014/main" id="{1A2D88C3-8CF8-4AB1-A4C6-29609490A146}"/>
               </a:ext>
             </a:extLst>
           </p:cNvPr>
@@ -15669,7 +15669,7 @@
           <p:cNvPr id="57" name="">
             <a:extLst xmlns:a="http://schemas.openxmlformats.org/drawingml/2006/main">
               <a:ext uri="{FF2B5EF4-FFF2-40B4-BE49-F238E27FC236}">
-                <a16:creationId xmlns:a16="http://schemas.microsoft.com/office/drawing/2014/main" id="{77BCDC66-B5D3-4D31-8C0F-A895A3721BE3}"/>
+                <a16:creationId xmlns:a16="http://schemas.microsoft.com/office/drawing/2014/main" id="{DFAE66DC-66BE-410B-8311-C830BC970CDB}"/>
               </a:ext>
             </a:extLst>
           </p:cNvPr>
@@ -15726,7 +15726,7 @@
           <p:cNvPr id="58" name="">
             <a:extLst xmlns:a="http://schemas.openxmlformats.org/drawingml/2006/main">
               <a:ext uri="{FF2B5EF4-FFF2-40B4-BE49-F238E27FC236}">
-                <a16:creationId xmlns:a16="http://schemas.microsoft.com/office/drawing/2014/main" id="{B8322899-CFAF-4D7F-A9E9-352387EE7B9D}"/>
+                <a16:creationId xmlns:a16="http://schemas.microsoft.com/office/drawing/2014/main" id="{315DDE27-2F26-4F53-8EA7-FEE04E4C8AD6}"/>
               </a:ext>
             </a:extLst>
           </p:cNvPr>
@@ -15759,7 +15759,7 @@
           <p:cNvPr id="59" name="">
             <a:extLst xmlns:a="http://schemas.openxmlformats.org/drawingml/2006/main">
               <a:ext uri="{FF2B5EF4-FFF2-40B4-BE49-F238E27FC236}">
-                <a16:creationId xmlns:a16="http://schemas.microsoft.com/office/drawing/2014/main" id="{5DFAEE0D-BD23-493D-8235-A639A07CB40C}"/>
+                <a16:creationId xmlns:a16="http://schemas.microsoft.com/office/drawing/2014/main" id="{7F88F307-FB6E-4D1B-BA5E-F79CA69123D0}"/>
               </a:ext>
             </a:extLst>
           </p:cNvPr>
@@ -15816,7 +15816,7 @@
           <p:cNvPr id="60" name="">
             <a:extLst xmlns:a="http://schemas.openxmlformats.org/drawingml/2006/main">
               <a:ext uri="{FF2B5EF4-FFF2-40B4-BE49-F238E27FC236}">
-                <a16:creationId xmlns:a16="http://schemas.microsoft.com/office/drawing/2014/main" id="{0DE4D842-8352-4E26-84E0-B98BC403117B}"/>
+                <a16:creationId xmlns:a16="http://schemas.microsoft.com/office/drawing/2014/main" id="{1F2E812C-4798-466B-AC3F-8A0CEBCA5223}"/>
               </a:ext>
             </a:extLst>
           </p:cNvPr>
@@ -15847,7 +15847,7 @@
           <p:cNvPr id="61" name="">
             <a:extLst xmlns:a="http://schemas.openxmlformats.org/drawingml/2006/main">
               <a:ext uri="{FF2B5EF4-FFF2-40B4-BE49-F238E27FC236}">
-                <a16:creationId xmlns:a16="http://schemas.microsoft.com/office/drawing/2014/main" id="{B95E51A3-7B6C-44AB-8581-E6B4D9A11E8B}"/>
+                <a16:creationId xmlns:a16="http://schemas.microsoft.com/office/drawing/2014/main" id="{06C97897-CB48-4C3E-9872-F386682170BB}"/>
               </a:ext>
             </a:extLst>
           </p:cNvPr>
@@ -15878,7 +15878,7 @@
           <p:cNvPr id="62" name="">
             <a:extLst xmlns:a="http://schemas.openxmlformats.org/drawingml/2006/main">
               <a:ext uri="{FF2B5EF4-FFF2-40B4-BE49-F238E27FC236}">
-                <a16:creationId xmlns:a16="http://schemas.microsoft.com/office/drawing/2014/main" id="{136E746E-D3D2-4FC0-9855-FBD3B53F533C}"/>
+                <a16:creationId xmlns:a16="http://schemas.microsoft.com/office/drawing/2014/main" id="{1AD718B3-2111-4430-8317-BC5979F5481C}"/>
               </a:ext>
             </a:extLst>
           </p:cNvPr>
@@ -15935,7 +15935,7 @@
           <p:cNvPr id="63" name="">
             <a:extLst xmlns:a="http://schemas.openxmlformats.org/drawingml/2006/main">
               <a:ext uri="{FF2B5EF4-FFF2-40B4-BE49-F238E27FC236}">
-                <a16:creationId xmlns:a16="http://schemas.microsoft.com/office/drawing/2014/main" id="{87ECDD02-9E1E-40CD-BDC1-A944C16239AA}"/>
+                <a16:creationId xmlns:a16="http://schemas.microsoft.com/office/drawing/2014/main" id="{D1FA39AB-1C5B-410F-99FB-656CA4254C6C}"/>
               </a:ext>
             </a:extLst>
           </p:cNvPr>
@@ -15992,7 +15992,7 @@
           <p:cNvPr id="64" name="">
             <a:extLst xmlns:a="http://schemas.openxmlformats.org/drawingml/2006/main">
               <a:ext uri="{FF2B5EF4-FFF2-40B4-BE49-F238E27FC236}">
-                <a16:creationId xmlns:a16="http://schemas.microsoft.com/office/drawing/2014/main" id="{A62EA9BB-78DE-4F79-BC9F-2E4E552677E7}"/>
+                <a16:creationId xmlns:a16="http://schemas.microsoft.com/office/drawing/2014/main" id="{E021C521-79DD-4324-B3C4-3BCD02B6113C}"/>
               </a:ext>
             </a:extLst>
           </p:cNvPr>
@@ -16023,7 +16023,7 @@
           <p:cNvPr id="65" name="">
             <a:extLst xmlns:a="http://schemas.openxmlformats.org/drawingml/2006/main">
               <a:ext uri="{FF2B5EF4-FFF2-40B4-BE49-F238E27FC236}">
-                <a16:creationId xmlns:a16="http://schemas.microsoft.com/office/drawing/2014/main" id="{24157D8E-1E2B-488A-974B-0B3070FDFE5D}"/>
+                <a16:creationId xmlns:a16="http://schemas.microsoft.com/office/drawing/2014/main" id="{DA0A0E55-AFCB-4B93-87FE-CBC073FEF19E}"/>
               </a:ext>
             </a:extLst>
           </p:cNvPr>
@@ -16080,7 +16080,7 @@
           <p:cNvPr id="66" name="">
             <a:extLst xmlns:a="http://schemas.openxmlformats.org/drawingml/2006/main">
               <a:ext uri="{FF2B5EF4-FFF2-40B4-BE49-F238E27FC236}">
-                <a16:creationId xmlns:a16="http://schemas.microsoft.com/office/drawing/2014/main" id="{1933758E-931B-4AC7-A846-10A59FDC14BE}"/>
+                <a16:creationId xmlns:a16="http://schemas.microsoft.com/office/drawing/2014/main" id="{72BEA7AA-A492-4091-A640-CC984569B4EF}"/>
               </a:ext>
             </a:extLst>
           </p:cNvPr>
@@ -16137,7 +16137,7 @@
           <p:cNvPr id="67" name="">
             <a:extLst xmlns:a="http://schemas.openxmlformats.org/drawingml/2006/main">
               <a:ext uri="{FF2B5EF4-FFF2-40B4-BE49-F238E27FC236}">
-                <a16:creationId xmlns:a16="http://schemas.microsoft.com/office/drawing/2014/main" id="{68D85165-80B0-462E-8831-515B606AE6D0}"/>
+                <a16:creationId xmlns:a16="http://schemas.microsoft.com/office/drawing/2014/main" id="{E3CAE46C-E373-4466-8DB7-6744B99030B4}"/>
               </a:ext>
             </a:extLst>
           </p:cNvPr>
@@ -16192,7 +16192,7 @@
     </p:spTree>
     <p:extLst>
       <p:ext uri="{BB962C8B-B14F-4D97-AF65-F5344CB8AC3E}">
-        <p14:creationId xmlns:p14="http://schemas.microsoft.com/office/powerpoint/2010/main" val="30354726"/>
+        <p14:creationId xmlns:p14="http://schemas.microsoft.com/office/powerpoint/2010/main" val="274858441"/>
       </p:ext>
     </p:extLst>
   </p:cSld>
@@ -16223,7 +16223,7 @@
           <p:cNvPr id="45" name="">
             <a:extLst xmlns:a="http://schemas.openxmlformats.org/drawingml/2006/main">
               <a:ext uri="{FF2B5EF4-FFF2-40B4-BE49-F238E27FC236}">
-                <a16:creationId xmlns:a16="http://schemas.microsoft.com/office/drawing/2014/main" id="{49A274A8-9A32-45A5-81B9-B60FE4D90B3C}"/>
+                <a16:creationId xmlns:a16="http://schemas.microsoft.com/office/drawing/2014/main" id="{F9270FA6-E9C9-4992-A7F9-853FFCE1407F}"/>
               </a:ext>
             </a:extLst>
           </p:cNvPr>
@@ -16280,7 +16280,7 @@
           <p:cNvPr id="2" name="">
             <a:extLst xmlns:a="http://schemas.openxmlformats.org/drawingml/2006/main">
               <a:ext uri="{FF2B5EF4-FFF2-40B4-BE49-F238E27FC236}">
-                <a16:creationId xmlns:a16="http://schemas.microsoft.com/office/drawing/2014/main" id="{09812FDB-24D9-459A-8163-CE4FC0D56FC7}"/>
+                <a16:creationId xmlns:a16="http://schemas.microsoft.com/office/drawing/2014/main" id="{9F5B2D25-86E3-4605-84B6-6E480B45ADD1}"/>
               </a:ext>
             </a:extLst>
           </p:cNvPr>
@@ -16311,7 +16311,7 @@
           <p:cNvPr id="3" name="">
             <a:extLst xmlns:a="http://schemas.openxmlformats.org/drawingml/2006/main">
               <a:ext uri="{FF2B5EF4-FFF2-40B4-BE49-F238E27FC236}">
-                <a16:creationId xmlns:a16="http://schemas.microsoft.com/office/drawing/2014/main" id="{ED169C5A-D39D-4328-A12A-259FC03897E3}"/>
+                <a16:creationId xmlns:a16="http://schemas.microsoft.com/office/drawing/2014/main" id="{6434AB66-5884-4120-A4D3-1EFDB6813DD4}"/>
               </a:ext>
             </a:extLst>
           </p:cNvPr>
@@ -16368,7 +16368,7 @@
           <p:cNvPr id="4" name="">
             <a:extLst xmlns:a="http://schemas.openxmlformats.org/drawingml/2006/main">
               <a:ext uri="{FF2B5EF4-FFF2-40B4-BE49-F238E27FC236}">
-                <a16:creationId xmlns:a16="http://schemas.microsoft.com/office/drawing/2014/main" id="{05598CD1-0B81-4CDD-8288-7ADB17EC63C3}"/>
+                <a16:creationId xmlns:a16="http://schemas.microsoft.com/office/drawing/2014/main" id="{29B4FEBC-5D59-44CD-8D8D-CFA9542F25C4}"/>
               </a:ext>
             </a:extLst>
           </p:cNvPr>
@@ -16399,7 +16399,7 @@
           <p:cNvPr id="5" name="">
             <a:extLst xmlns:a="http://schemas.openxmlformats.org/drawingml/2006/main">
               <a:ext uri="{FF2B5EF4-FFF2-40B4-BE49-F238E27FC236}">
-                <a16:creationId xmlns:a16="http://schemas.microsoft.com/office/drawing/2014/main" id="{F8B5D80C-708A-46E2-8DD1-60B4CB545A02}"/>
+                <a16:creationId xmlns:a16="http://schemas.microsoft.com/office/drawing/2014/main" id="{8B47AD10-FC9A-4796-A5F0-2E3A773EE45F}"/>
               </a:ext>
             </a:extLst>
           </p:cNvPr>
@@ -16456,7 +16456,7 @@
           <p:cNvPr id="6" name="">
             <a:extLst xmlns:a="http://schemas.openxmlformats.org/drawingml/2006/main">
               <a:ext uri="{FF2B5EF4-FFF2-40B4-BE49-F238E27FC236}">
-                <a16:creationId xmlns:a16="http://schemas.microsoft.com/office/drawing/2014/main" id="{973071E3-7FD3-428B-8CA4-BBC5DA666151}"/>
+                <a16:creationId xmlns:a16="http://schemas.microsoft.com/office/drawing/2014/main" id="{29EBF055-D1F0-4611-A537-6C2166D7ADC3}"/>
               </a:ext>
             </a:extLst>
           </p:cNvPr>
@@ -16513,7 +16513,7 @@
           <p:cNvPr id="7" name="">
             <a:extLst xmlns:a="http://schemas.openxmlformats.org/drawingml/2006/main">
               <a:ext uri="{FF2B5EF4-FFF2-40B4-BE49-F238E27FC236}">
-                <a16:creationId xmlns:a16="http://schemas.microsoft.com/office/drawing/2014/main" id="{41396745-9922-49B9-8D7E-BB4ACBC02D15}"/>
+                <a16:creationId xmlns:a16="http://schemas.microsoft.com/office/drawing/2014/main" id="{2CC710F3-D2EE-4FB7-AA46-EBF40B3B674C}"/>
               </a:ext>
             </a:extLst>
           </p:cNvPr>
@@ -16570,7 +16570,7 @@
           <p:cNvPr id="8" name="">
             <a:extLst xmlns:a="http://schemas.openxmlformats.org/drawingml/2006/main">
               <a:ext uri="{FF2B5EF4-FFF2-40B4-BE49-F238E27FC236}">
-                <a16:creationId xmlns:a16="http://schemas.microsoft.com/office/drawing/2014/main" id="{EDC3AB85-CF8E-41F8-A6D5-785760E26522}"/>
+                <a16:creationId xmlns:a16="http://schemas.microsoft.com/office/drawing/2014/main" id="{943D576E-C278-46FA-B11A-0FE51A9F927F}"/>
               </a:ext>
             </a:extLst>
           </p:cNvPr>
@@ -16627,7 +16627,7 @@
           <p:cNvPr id="9" name="">
             <a:extLst xmlns:a="http://schemas.openxmlformats.org/drawingml/2006/main">
               <a:ext uri="{FF2B5EF4-FFF2-40B4-BE49-F238E27FC236}">
-                <a16:creationId xmlns:a16="http://schemas.microsoft.com/office/drawing/2014/main" id="{8CAB71AC-9233-4366-AE9A-A1D7828DC6EE}"/>
+                <a16:creationId xmlns:a16="http://schemas.microsoft.com/office/drawing/2014/main" id="{9C44EB95-26E6-48A5-BAF1-9F2F10C9C2F1}"/>
               </a:ext>
             </a:extLst>
           </p:cNvPr>
@@ -16684,7 +16684,7 @@
           <p:cNvPr id="10" name="">
             <a:extLst xmlns:a="http://schemas.openxmlformats.org/drawingml/2006/main">
               <a:ext uri="{FF2B5EF4-FFF2-40B4-BE49-F238E27FC236}">
-                <a16:creationId xmlns:a16="http://schemas.microsoft.com/office/drawing/2014/main" id="{A84E3970-D8E2-48AB-9DDE-DEBF425F6C8D}"/>
+                <a16:creationId xmlns:a16="http://schemas.microsoft.com/office/drawing/2014/main" id="{A3637143-87AC-4924-8866-ADC9FD0EAB26}"/>
               </a:ext>
             </a:extLst>
           </p:cNvPr>
@@ -16741,7 +16741,7 @@
           <p:cNvPr id="11" name="">
             <a:extLst xmlns:a="http://schemas.openxmlformats.org/drawingml/2006/main">
               <a:ext uri="{FF2B5EF4-FFF2-40B4-BE49-F238E27FC236}">
-                <a16:creationId xmlns:a16="http://schemas.microsoft.com/office/drawing/2014/main" id="{784CCA1C-963E-459B-9D58-2230F06EA500}"/>
+                <a16:creationId xmlns:a16="http://schemas.microsoft.com/office/drawing/2014/main" id="{CF795B1E-BA01-4503-B174-51CE6F3D644F}"/>
               </a:ext>
             </a:extLst>
           </p:cNvPr>
@@ -16798,7 +16798,7 @@
           <p:cNvPr id="12" name="">
             <a:extLst xmlns:a="http://schemas.openxmlformats.org/drawingml/2006/main">
               <a:ext uri="{FF2B5EF4-FFF2-40B4-BE49-F238E27FC236}">
-                <a16:creationId xmlns:a16="http://schemas.microsoft.com/office/drawing/2014/main" id="{D6687F21-96B5-44C3-9CD0-B492AA58E8E0}"/>
+                <a16:creationId xmlns:a16="http://schemas.microsoft.com/office/drawing/2014/main" id="{351918EF-5EF2-4659-95F0-D68C1FD59E04}"/>
               </a:ext>
             </a:extLst>
           </p:cNvPr>
@@ -16855,7 +16855,7 @@
           <p:cNvPr id="13" name="">
             <a:extLst xmlns:a="http://schemas.openxmlformats.org/drawingml/2006/main">
               <a:ext uri="{FF2B5EF4-FFF2-40B4-BE49-F238E27FC236}">
-                <a16:creationId xmlns:a16="http://schemas.microsoft.com/office/drawing/2014/main" id="{485938E2-47BE-4010-B96A-40360C2D8A46}"/>
+                <a16:creationId xmlns:a16="http://schemas.microsoft.com/office/drawing/2014/main" id="{8A80F339-B6BE-4133-8990-6613B7052DDB}"/>
               </a:ext>
             </a:extLst>
           </p:cNvPr>
@@ -16935,7 +16935,7 @@
           <p:cNvPr id="14" name="">
             <a:extLst xmlns:a="http://schemas.openxmlformats.org/drawingml/2006/main">
               <a:ext uri="{FF2B5EF4-FFF2-40B4-BE49-F238E27FC236}">
-                <a16:creationId xmlns:a16="http://schemas.microsoft.com/office/drawing/2014/main" id="{E033358B-52C0-4794-BC19-3CE300EACC58}"/>
+                <a16:creationId xmlns:a16="http://schemas.microsoft.com/office/drawing/2014/main" id="{5F4E41EA-0285-46DF-8872-3F2319036066}"/>
               </a:ext>
             </a:extLst>
           </p:cNvPr>
@@ -17015,7 +17015,7 @@
           <p:cNvPr id="15" name="">
             <a:extLst xmlns:a="http://schemas.openxmlformats.org/drawingml/2006/main">
               <a:ext uri="{FF2B5EF4-FFF2-40B4-BE49-F238E27FC236}">
-                <a16:creationId xmlns:a16="http://schemas.microsoft.com/office/drawing/2014/main" id="{A339D2BE-99A8-4EA7-BF27-ED33E1603725}"/>
+                <a16:creationId xmlns:a16="http://schemas.microsoft.com/office/drawing/2014/main" id="{4308B45C-B4D0-4E00-A032-CDCB6DD400C6}"/>
               </a:ext>
             </a:extLst>
           </p:cNvPr>
@@ -17072,7 +17072,7 @@
           <p:cNvPr id="16" name="">
             <a:extLst xmlns:a="http://schemas.openxmlformats.org/drawingml/2006/main">
               <a:ext uri="{FF2B5EF4-FFF2-40B4-BE49-F238E27FC236}">
-                <a16:creationId xmlns:a16="http://schemas.microsoft.com/office/drawing/2014/main" id="{87560BC7-63DA-4450-B9F3-45D9B9109790}"/>
+                <a16:creationId xmlns:a16="http://schemas.microsoft.com/office/drawing/2014/main" id="{BFB6C987-9293-497E-96A3-61F25A3A4CAF}"/>
               </a:ext>
             </a:extLst>
           </p:cNvPr>
@@ -17129,7 +17129,7 @@
           <p:cNvPr id="17" name="">
             <a:extLst xmlns:a="http://schemas.openxmlformats.org/drawingml/2006/main">
               <a:ext uri="{FF2B5EF4-FFF2-40B4-BE49-F238E27FC236}">
-                <a16:creationId xmlns:a16="http://schemas.microsoft.com/office/drawing/2014/main" id="{6BD8FA90-5248-40D3-9B85-FF47881F92B0}"/>
+                <a16:creationId xmlns:a16="http://schemas.microsoft.com/office/drawing/2014/main" id="{3F5E234A-A723-4956-8FAC-78C3AF0E7488}"/>
               </a:ext>
             </a:extLst>
           </p:cNvPr>
@@ -17186,7 +17186,7 @@
           <p:cNvPr id="18" name="">
             <a:extLst xmlns:a="http://schemas.openxmlformats.org/drawingml/2006/main">
               <a:ext uri="{FF2B5EF4-FFF2-40B4-BE49-F238E27FC236}">
-                <a16:creationId xmlns:a16="http://schemas.microsoft.com/office/drawing/2014/main" id="{D9BF814B-4FA4-401F-9E17-293F50461BE4}"/>
+                <a16:creationId xmlns:a16="http://schemas.microsoft.com/office/drawing/2014/main" id="{E60148F5-0069-46BB-94FD-9973DA9FEB72}"/>
               </a:ext>
             </a:extLst>
           </p:cNvPr>
@@ -17243,7 +17243,7 @@
           <p:cNvPr id="19" name="">
             <a:extLst xmlns:a="http://schemas.openxmlformats.org/drawingml/2006/main">
               <a:ext uri="{FF2B5EF4-FFF2-40B4-BE49-F238E27FC236}">
-                <a16:creationId xmlns:a16="http://schemas.microsoft.com/office/drawing/2014/main" id="{972C4138-42B2-4489-A857-F585048126AE}"/>
+                <a16:creationId xmlns:a16="http://schemas.microsoft.com/office/drawing/2014/main" id="{0FCDD8E6-8701-4FE0-9487-F7790789062A}"/>
               </a:ext>
             </a:extLst>
           </p:cNvPr>
@@ -17300,7 +17300,7 @@
           <p:cNvPr id="20" name="">
             <a:extLst xmlns:a="http://schemas.openxmlformats.org/drawingml/2006/main">
               <a:ext uri="{FF2B5EF4-FFF2-40B4-BE49-F238E27FC236}">
-                <a16:creationId xmlns:a16="http://schemas.microsoft.com/office/drawing/2014/main" id="{D95D1252-7D40-4294-AD08-6B5B6033971F}"/>
+                <a16:creationId xmlns:a16="http://schemas.microsoft.com/office/drawing/2014/main" id="{9AC1BA32-B7AA-484C-BF71-A1843AAC0BB6}"/>
               </a:ext>
             </a:extLst>
           </p:cNvPr>
@@ -17357,7 +17357,7 @@
           <p:cNvPr id="21" name="">
             <a:extLst xmlns:a="http://schemas.openxmlformats.org/drawingml/2006/main">
               <a:ext uri="{FF2B5EF4-FFF2-40B4-BE49-F238E27FC236}">
-                <a16:creationId xmlns:a16="http://schemas.microsoft.com/office/drawing/2014/main" id="{27C7E63F-D549-4E81-BCA4-F147BECC5A67}"/>
+                <a16:creationId xmlns:a16="http://schemas.microsoft.com/office/drawing/2014/main" id="{1EE5D298-C571-465B-B632-F1ECD6540092}"/>
               </a:ext>
             </a:extLst>
           </p:cNvPr>
@@ -17414,7 +17414,7 @@
           <p:cNvPr id="22" name="">
             <a:extLst xmlns:a="http://schemas.openxmlformats.org/drawingml/2006/main">
               <a:ext uri="{FF2B5EF4-FFF2-40B4-BE49-F238E27FC236}">
-                <a16:creationId xmlns:a16="http://schemas.microsoft.com/office/drawing/2014/main" id="{013168BF-D769-41F8-99BF-B5751884C70B}"/>
+                <a16:creationId xmlns:a16="http://schemas.microsoft.com/office/drawing/2014/main" id="{EF4B678A-917C-466C-A65C-FEF553678303}"/>
               </a:ext>
             </a:extLst>
           </p:cNvPr>
@@ -17471,7 +17471,7 @@
           <p:cNvPr id="23" name="">
             <a:extLst xmlns:a="http://schemas.openxmlformats.org/drawingml/2006/main">
               <a:ext uri="{FF2B5EF4-FFF2-40B4-BE49-F238E27FC236}">
-                <a16:creationId xmlns:a16="http://schemas.microsoft.com/office/drawing/2014/main" id="{6FD73B51-7CF9-4E76-A083-E5F0A78D1E5D}"/>
+                <a16:creationId xmlns:a16="http://schemas.microsoft.com/office/drawing/2014/main" id="{1E1EBC40-CB5A-4B8C-8C2B-302B2F46B6C8}"/>
               </a:ext>
             </a:extLst>
           </p:cNvPr>
@@ -17528,7 +17528,7 @@
           <p:cNvPr id="24" name="">
             <a:extLst xmlns:a="http://schemas.openxmlformats.org/drawingml/2006/main">
               <a:ext uri="{FF2B5EF4-FFF2-40B4-BE49-F238E27FC236}">
-                <a16:creationId xmlns:a16="http://schemas.microsoft.com/office/drawing/2014/main" id="{4B12EF38-72A7-4EA1-A2F0-0C5369953789}"/>
+                <a16:creationId xmlns:a16="http://schemas.microsoft.com/office/drawing/2014/main" id="{A4071465-E84E-4AF1-9667-FAD95CDD1108}"/>
               </a:ext>
             </a:extLst>
           </p:cNvPr>
@@ -17585,7 +17585,7 @@
           <p:cNvPr id="25" name="">
             <a:extLst xmlns:a="http://schemas.openxmlformats.org/drawingml/2006/main">
               <a:ext uri="{FF2B5EF4-FFF2-40B4-BE49-F238E27FC236}">
-                <a16:creationId xmlns:a16="http://schemas.microsoft.com/office/drawing/2014/main" id="{3B447211-DF65-438C-AF73-B3B50B93B35C}"/>
+                <a16:creationId xmlns:a16="http://schemas.microsoft.com/office/drawing/2014/main" id="{AD03771F-E003-4556-9BFD-2996B335B87D}"/>
               </a:ext>
             </a:extLst>
           </p:cNvPr>
@@ -17665,7 +17665,7 @@
           <p:cNvPr id="26" name="">
             <a:extLst xmlns:a="http://schemas.openxmlformats.org/drawingml/2006/main">
               <a:ext uri="{FF2B5EF4-FFF2-40B4-BE49-F238E27FC236}">
-                <a16:creationId xmlns:a16="http://schemas.microsoft.com/office/drawing/2014/main" id="{A29BD75B-2514-4471-BECF-73CA640B7AF2}"/>
+                <a16:creationId xmlns:a16="http://schemas.microsoft.com/office/drawing/2014/main" id="{037690DD-B14B-4DE4-8C50-45AFD653D0C1}"/>
               </a:ext>
             </a:extLst>
           </p:cNvPr>
@@ -17722,7 +17722,7 @@
           <p:cNvPr id="27" name="">
             <a:extLst xmlns:a="http://schemas.openxmlformats.org/drawingml/2006/main">
               <a:ext uri="{FF2B5EF4-FFF2-40B4-BE49-F238E27FC236}">
-                <a16:creationId xmlns:a16="http://schemas.microsoft.com/office/drawing/2014/main" id="{0312DBAA-47E5-41B9-849D-D70F8F7867D2}"/>
+                <a16:creationId xmlns:a16="http://schemas.microsoft.com/office/drawing/2014/main" id="{86F3777E-A89E-4717-B059-D3B50D03FBF6}"/>
               </a:ext>
             </a:extLst>
           </p:cNvPr>
@@ -17753,7 +17753,7 @@
           <p:cNvPr id="28" name="">
             <a:extLst xmlns:a="http://schemas.openxmlformats.org/drawingml/2006/main">
               <a:ext uri="{FF2B5EF4-FFF2-40B4-BE49-F238E27FC236}">
-                <a16:creationId xmlns:a16="http://schemas.microsoft.com/office/drawing/2014/main" id="{42829429-DC34-423B-8CF8-20B02EFB31BC}"/>
+                <a16:creationId xmlns:a16="http://schemas.microsoft.com/office/drawing/2014/main" id="{FB3DD555-0556-4523-B3FF-BBE5DFED71BA}"/>
               </a:ext>
             </a:extLst>
           </p:cNvPr>
@@ -17810,7 +17810,7 @@
           <p:cNvPr id="29" name="">
             <a:extLst xmlns:a="http://schemas.openxmlformats.org/drawingml/2006/main">
               <a:ext uri="{FF2B5EF4-FFF2-40B4-BE49-F238E27FC236}">
-                <a16:creationId xmlns:a16="http://schemas.microsoft.com/office/drawing/2014/main" id="{785E7AA8-1052-4FBF-926F-4809A1288908}"/>
+                <a16:creationId xmlns:a16="http://schemas.microsoft.com/office/drawing/2014/main" id="{E28E9A84-9ED4-499C-A683-714D4341E2A2}"/>
               </a:ext>
             </a:extLst>
           </p:cNvPr>
@@ -17867,7 +17867,7 @@
           <p:cNvPr id="30" name="">
             <a:extLst xmlns:a="http://schemas.openxmlformats.org/drawingml/2006/main">
               <a:ext uri="{FF2B5EF4-FFF2-40B4-BE49-F238E27FC236}">
-                <a16:creationId xmlns:a16="http://schemas.microsoft.com/office/drawing/2014/main" id="{B1052593-8A41-4B92-8930-3DAF06F93379}"/>
+                <a16:creationId xmlns:a16="http://schemas.microsoft.com/office/drawing/2014/main" id="{E67941C5-22CD-46D2-8957-F1296E0DA676}"/>
               </a:ext>
             </a:extLst>
           </p:cNvPr>
@@ -17924,7 +17924,7 @@
           <p:cNvPr id="31" name="">
             <a:extLst xmlns:a="http://schemas.openxmlformats.org/drawingml/2006/main">
               <a:ext uri="{FF2B5EF4-FFF2-40B4-BE49-F238E27FC236}">
-                <a16:creationId xmlns:a16="http://schemas.microsoft.com/office/drawing/2014/main" id="{B8A96E66-5F14-4430-B817-14120F3B8310}"/>
+                <a16:creationId xmlns:a16="http://schemas.microsoft.com/office/drawing/2014/main" id="{2102F365-66E9-4327-BFCA-7DFCF6701296}"/>
               </a:ext>
             </a:extLst>
           </p:cNvPr>
@@ -17981,7 +17981,7 @@
           <p:cNvPr id="32" name="">
             <a:extLst xmlns:a="http://schemas.openxmlformats.org/drawingml/2006/main">
               <a:ext uri="{FF2B5EF4-FFF2-40B4-BE49-F238E27FC236}">
-                <a16:creationId xmlns:a16="http://schemas.microsoft.com/office/drawing/2014/main" id="{4646C594-08AF-4F81-AE55-EA706BE435CC}"/>
+                <a16:creationId xmlns:a16="http://schemas.microsoft.com/office/drawing/2014/main" id="{759E9F45-E9F3-498E-B34D-4C249E6CBD4C}"/>
               </a:ext>
             </a:extLst>
           </p:cNvPr>
@@ -18038,7 +18038,7 @@
           <p:cNvPr id="33" name="">
             <a:extLst xmlns:a="http://schemas.openxmlformats.org/drawingml/2006/main">
               <a:ext uri="{FF2B5EF4-FFF2-40B4-BE49-F238E27FC236}">
-                <a16:creationId xmlns:a16="http://schemas.microsoft.com/office/drawing/2014/main" id="{D8D8ECB7-2EDC-45F0-A64F-1A2907155292}"/>
+                <a16:creationId xmlns:a16="http://schemas.microsoft.com/office/drawing/2014/main" id="{87C2B7BD-7B0F-4A76-98D3-18DD5975FF2D}"/>
               </a:ext>
             </a:extLst>
           </p:cNvPr>
@@ -18095,7 +18095,7 @@
           <p:cNvPr id="34" name="">
             <a:extLst xmlns:a="http://schemas.openxmlformats.org/drawingml/2006/main">
               <a:ext uri="{FF2B5EF4-FFF2-40B4-BE49-F238E27FC236}">
-                <a16:creationId xmlns:a16="http://schemas.microsoft.com/office/drawing/2014/main" id="{8BEC9853-3F51-428C-8F02-A38FD73DD6D1}"/>
+                <a16:creationId xmlns:a16="http://schemas.microsoft.com/office/drawing/2014/main" id="{8D5471A9-595A-49AB-8C25-A04CF088D1D9}"/>
               </a:ext>
             </a:extLst>
           </p:cNvPr>
@@ -18152,7 +18152,7 @@
           <p:cNvPr id="35" name="">
             <a:extLst xmlns:a="http://schemas.openxmlformats.org/drawingml/2006/main">
               <a:ext uri="{FF2B5EF4-FFF2-40B4-BE49-F238E27FC236}">
-                <a16:creationId xmlns:a16="http://schemas.microsoft.com/office/drawing/2014/main" id="{0FD0309F-0F14-415D-A1AC-24F3AC9A6718}"/>
+                <a16:creationId xmlns:a16="http://schemas.microsoft.com/office/drawing/2014/main" id="{9331C576-E1E7-4A40-BD0C-8C6BBF5ED113}"/>
               </a:ext>
             </a:extLst>
           </p:cNvPr>
@@ -18209,7 +18209,7 @@
           <p:cNvPr id="36" name="">
             <a:extLst xmlns:a="http://schemas.openxmlformats.org/drawingml/2006/main">
               <a:ext uri="{FF2B5EF4-FFF2-40B4-BE49-F238E27FC236}">
-                <a16:creationId xmlns:a16="http://schemas.microsoft.com/office/drawing/2014/main" id="{4C6F045F-4F0A-4BA0-B64E-93586E7B0187}"/>
+                <a16:creationId xmlns:a16="http://schemas.microsoft.com/office/drawing/2014/main" id="{C0888DF0-710F-41D9-82D0-A7851E3CE1F8}"/>
               </a:ext>
             </a:extLst>
           </p:cNvPr>
@@ -18266,7 +18266,7 @@
           <p:cNvPr id="37" name="">
             <a:extLst xmlns:a="http://schemas.openxmlformats.org/drawingml/2006/main">
               <a:ext uri="{FF2B5EF4-FFF2-40B4-BE49-F238E27FC236}">
-                <a16:creationId xmlns:a16="http://schemas.microsoft.com/office/drawing/2014/main" id="{BD70204E-4179-43DD-8521-330F76C1792D}"/>
+                <a16:creationId xmlns:a16="http://schemas.microsoft.com/office/drawing/2014/main" id="{5A95D4BA-7A02-4C4F-ABB8-0FA283338F6B}"/>
               </a:ext>
             </a:extLst>
           </p:cNvPr>
@@ -18297,7 +18297,7 @@
           <p:cNvPr id="38" name="">
             <a:extLst xmlns:a="http://schemas.openxmlformats.org/drawingml/2006/main">
               <a:ext uri="{FF2B5EF4-FFF2-40B4-BE49-F238E27FC236}">
-                <a16:creationId xmlns:a16="http://schemas.microsoft.com/office/drawing/2014/main" id="{FB52197A-ABA9-485F-8292-A52BEF55A7F1}"/>
+                <a16:creationId xmlns:a16="http://schemas.microsoft.com/office/drawing/2014/main" id="{E145A11F-6DFE-43A9-9C34-EA9FC846160F}"/>
               </a:ext>
             </a:extLst>
           </p:cNvPr>
@@ -18354,7 +18354,7 @@
           <p:cNvPr id="39" name="">
             <a:extLst xmlns:a="http://schemas.openxmlformats.org/drawingml/2006/main">
               <a:ext uri="{FF2B5EF4-FFF2-40B4-BE49-F238E27FC236}">
-                <a16:creationId xmlns:a16="http://schemas.microsoft.com/office/drawing/2014/main" id="{82D11D1E-9822-4E83-A44D-06644E4EA542}"/>
+                <a16:creationId xmlns:a16="http://schemas.microsoft.com/office/drawing/2014/main" id="{55C64DC6-4684-4831-86C8-85507A886201}"/>
               </a:ext>
             </a:extLst>
           </p:cNvPr>
@@ -18411,7 +18411,7 @@
           <p:cNvPr id="40" name="">
             <a:extLst xmlns:a="http://schemas.openxmlformats.org/drawingml/2006/main">
               <a:ext uri="{FF2B5EF4-FFF2-40B4-BE49-F238E27FC236}">
-                <a16:creationId xmlns:a16="http://schemas.microsoft.com/office/drawing/2014/main" id="{54C82789-1BD8-4C4A-B2CC-F750C0FFBBD2}"/>
+                <a16:creationId xmlns:a16="http://schemas.microsoft.com/office/drawing/2014/main" id="{D78551D2-95E7-464C-9273-9C4AB08399E1}"/>
               </a:ext>
             </a:extLst>
           </p:cNvPr>
@@ -18468,7 +18468,7 @@
           <p:cNvPr id="41" name="">
             <a:extLst xmlns:a="http://schemas.openxmlformats.org/drawingml/2006/main">
               <a:ext uri="{FF2B5EF4-FFF2-40B4-BE49-F238E27FC236}">
-                <a16:creationId xmlns:a16="http://schemas.microsoft.com/office/drawing/2014/main" id="{E6F9B798-B99B-4F51-9E53-3E0ACADA426C}"/>
+                <a16:creationId xmlns:a16="http://schemas.microsoft.com/office/drawing/2014/main" id="{531E8B49-AEFC-425C-B581-D6BA43B7A391}"/>
               </a:ext>
             </a:extLst>
           </p:cNvPr>
@@ -18525,7 +18525,7 @@
           <p:cNvPr id="42" name="">
             <a:extLst xmlns:a="http://schemas.openxmlformats.org/drawingml/2006/main">
               <a:ext uri="{FF2B5EF4-FFF2-40B4-BE49-F238E27FC236}">
-                <a16:creationId xmlns:a16="http://schemas.microsoft.com/office/drawing/2014/main" id="{AAC17C0B-6AC1-4186-91D2-561D56ECA634}"/>
+                <a16:creationId xmlns:a16="http://schemas.microsoft.com/office/drawing/2014/main" id="{9DCC5B30-05E8-4546-9371-C56133B7AAC7}"/>
               </a:ext>
             </a:extLst>
           </p:cNvPr>
@@ -18582,7 +18582,7 @@
           <p:cNvPr id="43" name="">
             <a:extLst xmlns:a="http://schemas.openxmlformats.org/drawingml/2006/main">
               <a:ext uri="{FF2B5EF4-FFF2-40B4-BE49-F238E27FC236}">
-                <a16:creationId xmlns:a16="http://schemas.microsoft.com/office/drawing/2014/main" id="{9FB4DAA3-2999-40BE-9DA9-0BA690D8C024}"/>
+                <a16:creationId xmlns:a16="http://schemas.microsoft.com/office/drawing/2014/main" id="{99FA1114-F92A-4FD6-8B56-2616EDD9DF69}"/>
               </a:ext>
             </a:extLst>
           </p:cNvPr>
@@ -18639,7 +18639,7 @@
           <p:cNvPr id="44" name="">
             <a:extLst xmlns:a="http://schemas.openxmlformats.org/drawingml/2006/main">
               <a:ext uri="{FF2B5EF4-FFF2-40B4-BE49-F238E27FC236}">
-                <a16:creationId xmlns:a16="http://schemas.microsoft.com/office/drawing/2014/main" id="{F8DB7EB9-B309-4045-9A52-EE2051FEF5AA}"/>
+                <a16:creationId xmlns:a16="http://schemas.microsoft.com/office/drawing/2014/main" id="{95146132-C28F-4404-AD3C-6146BAE6D9C7}"/>
               </a:ext>
             </a:extLst>
           </p:cNvPr>
@@ -18694,7 +18694,7 @@
     </p:spTree>
     <p:extLst>
       <p:ext uri="{BB962C8B-B14F-4D97-AF65-F5344CB8AC3E}">
-        <p14:creationId xmlns:p14="http://schemas.microsoft.com/office/powerpoint/2010/main" val="1759166742"/>
+        <p14:creationId xmlns:p14="http://schemas.microsoft.com/office/powerpoint/2010/main" val="395171047"/>
       </p:ext>
     </p:extLst>
   </p:cSld>
@@ -18725,7 +18725,7 @@
           <p:cNvPr id="21" name="">
             <a:extLst xmlns:a="http://schemas.openxmlformats.org/drawingml/2006/main">
               <a:ext uri="{FF2B5EF4-FFF2-40B4-BE49-F238E27FC236}">
-                <a16:creationId xmlns:a16="http://schemas.microsoft.com/office/drawing/2014/main" id="{77545C36-11F7-41BC-AAEC-594A42422F9D}"/>
+                <a16:creationId xmlns:a16="http://schemas.microsoft.com/office/drawing/2014/main" id="{48719E08-CAA8-4A33-8141-0E3BB60D98E1}"/>
               </a:ext>
             </a:extLst>
           </p:cNvPr>
@@ -18782,7 +18782,7 @@
           <p:cNvPr id="2" name="">
             <a:extLst xmlns:a="http://schemas.openxmlformats.org/drawingml/2006/main">
               <a:ext uri="{FF2B5EF4-FFF2-40B4-BE49-F238E27FC236}">
-                <a16:creationId xmlns:a16="http://schemas.microsoft.com/office/drawing/2014/main" id="{2886E999-EFC1-4E23-8179-A38ACE882C1C}"/>
+                <a16:creationId xmlns:a16="http://schemas.microsoft.com/office/drawing/2014/main" id="{06AE7DD4-5B85-4B04-AE71-2406EDE659E4}"/>
               </a:ext>
             </a:extLst>
           </p:cNvPr>
@@ -18813,7 +18813,7 @@
           <p:cNvPr id="3" name="">
             <a:extLst xmlns:a="http://schemas.openxmlformats.org/drawingml/2006/main">
               <a:ext uri="{FF2B5EF4-FFF2-40B4-BE49-F238E27FC236}">
-                <a16:creationId xmlns:a16="http://schemas.microsoft.com/office/drawing/2014/main" id="{348AAFFD-D2E6-4FAA-878A-A30912049B76}"/>
+                <a16:creationId xmlns:a16="http://schemas.microsoft.com/office/drawing/2014/main" id="{AD6008B7-A3E9-4F79-8BFB-BF1FFA660FB3}"/>
               </a:ext>
             </a:extLst>
           </p:cNvPr>
@@ -18870,7 +18870,7 @@
           <p:cNvPr id="4" name="">
             <a:extLst xmlns:a="http://schemas.openxmlformats.org/drawingml/2006/main">
               <a:ext uri="{FF2B5EF4-FFF2-40B4-BE49-F238E27FC236}">
-                <a16:creationId xmlns:a16="http://schemas.microsoft.com/office/drawing/2014/main" id="{24393EB2-FA10-446D-AAC6-AEB2577FEDA3}"/>
+                <a16:creationId xmlns:a16="http://schemas.microsoft.com/office/drawing/2014/main" id="{FF26D81B-4D8F-4446-8832-F1B55C305E67}"/>
               </a:ext>
             </a:extLst>
           </p:cNvPr>
@@ -18901,7 +18901,7 @@
           <p:cNvPr id="5" name="">
             <a:extLst xmlns:a="http://schemas.openxmlformats.org/drawingml/2006/main">
               <a:ext uri="{FF2B5EF4-FFF2-40B4-BE49-F238E27FC236}">
-                <a16:creationId xmlns:a16="http://schemas.microsoft.com/office/drawing/2014/main" id="{F9CF619B-1A17-469A-8E3E-00D9ABB0E357}"/>
+                <a16:creationId xmlns:a16="http://schemas.microsoft.com/office/drawing/2014/main" id="{87D90D3C-AC8C-42DE-9F34-99BC5376C707}"/>
               </a:ext>
             </a:extLst>
           </p:cNvPr>
@@ -18932,7 +18932,7 @@
           <p:cNvPr id="6" name="">
             <a:extLst xmlns:a="http://schemas.openxmlformats.org/drawingml/2006/main">
               <a:ext uri="{FF2B5EF4-FFF2-40B4-BE49-F238E27FC236}">
-                <a16:creationId xmlns:a16="http://schemas.microsoft.com/office/drawing/2014/main" id="{49F90F02-0AFA-489F-BB6F-828A053BDBA1}"/>
+                <a16:creationId xmlns:a16="http://schemas.microsoft.com/office/drawing/2014/main" id="{4858B2AA-2ABA-4C00-847B-1C4442BEFB15}"/>
               </a:ext>
             </a:extLst>
           </p:cNvPr>
@@ -19329,7 +19329,7 @@
           <p:cNvPr id="7" name="">
             <a:extLst xmlns:a="http://schemas.openxmlformats.org/drawingml/2006/main">
               <a:ext uri="{FF2B5EF4-FFF2-40B4-BE49-F238E27FC236}">
-                <a16:creationId xmlns:a16="http://schemas.microsoft.com/office/drawing/2014/main" id="{4FFD34D8-B3CE-4341-949D-780B157F1467}"/>
+                <a16:creationId xmlns:a16="http://schemas.microsoft.com/office/drawing/2014/main" id="{A54C9949-F89C-4E02-A8AB-205F50CB6512}"/>
               </a:ext>
             </a:extLst>
           </p:cNvPr>
@@ -19360,7 +19360,7 @@
           <p:cNvPr id="8" name="">
             <a:extLst xmlns:a="http://schemas.openxmlformats.org/drawingml/2006/main">
               <a:ext uri="{FF2B5EF4-FFF2-40B4-BE49-F238E27FC236}">
-                <a16:creationId xmlns:a16="http://schemas.microsoft.com/office/drawing/2014/main" id="{100301F0-DF18-48C8-A98B-3A5D2656BF02}"/>
+                <a16:creationId xmlns:a16="http://schemas.microsoft.com/office/drawing/2014/main" id="{76992E8F-B878-4DE6-B426-2F1531933C6B}"/>
               </a:ext>
             </a:extLst>
           </p:cNvPr>
@@ -19417,7 +19417,7 @@
           <p:cNvPr id="9" name="">
             <a:extLst xmlns:a="http://schemas.openxmlformats.org/drawingml/2006/main">
               <a:ext uri="{FF2B5EF4-FFF2-40B4-BE49-F238E27FC236}">
-                <a16:creationId xmlns:a16="http://schemas.microsoft.com/office/drawing/2014/main" id="{F8451225-1C85-4BA4-B13E-AF3F56BD8D0A}"/>
+                <a16:creationId xmlns:a16="http://schemas.microsoft.com/office/drawing/2014/main" id="{8FD907C7-EAD8-43C8-9DAC-A528DAF5D71E}"/>
               </a:ext>
             </a:extLst>
           </p:cNvPr>
@@ -19474,7 +19474,7 @@
           <p:cNvPr id="10" name="">
             <a:extLst xmlns:a="http://schemas.openxmlformats.org/drawingml/2006/main">
               <a:ext uri="{FF2B5EF4-FFF2-40B4-BE49-F238E27FC236}">
-                <a16:creationId xmlns:a16="http://schemas.microsoft.com/office/drawing/2014/main" id="{596BF457-2D48-4187-9655-57186DE6BA10}"/>
+                <a16:creationId xmlns:a16="http://schemas.microsoft.com/office/drawing/2014/main" id="{01010B9B-4F56-4451-B87E-A43609541360}"/>
               </a:ext>
             </a:extLst>
           </p:cNvPr>
@@ -19554,7 +19554,7 @@
           <p:cNvPr id="11" name="">
             <a:extLst xmlns:a="http://schemas.openxmlformats.org/drawingml/2006/main">
               <a:ext uri="{FF2B5EF4-FFF2-40B4-BE49-F238E27FC236}">
-                <a16:creationId xmlns:a16="http://schemas.microsoft.com/office/drawing/2014/main" id="{AAF66544-035A-492A-AC50-69729B3C5D2D}"/>
+                <a16:creationId xmlns:a16="http://schemas.microsoft.com/office/drawing/2014/main" id="{D35CAECB-6BAD-41B9-81DF-B737AC7B4B33}"/>
               </a:ext>
             </a:extLst>
           </p:cNvPr>
@@ -19611,7 +19611,7 @@
           <p:cNvPr id="12" name="">
             <a:extLst xmlns:a="http://schemas.openxmlformats.org/drawingml/2006/main">
               <a:ext uri="{FF2B5EF4-FFF2-40B4-BE49-F238E27FC236}">
-                <a16:creationId xmlns:a16="http://schemas.microsoft.com/office/drawing/2014/main" id="{AF37BBE1-1558-45C2-8FED-2C8F706D7EC1}"/>
+                <a16:creationId xmlns:a16="http://schemas.microsoft.com/office/drawing/2014/main" id="{B823F36C-93E1-41FB-B2E1-2FDBCC930F13}"/>
               </a:ext>
             </a:extLst>
           </p:cNvPr>
@@ -19668,7 +19668,7 @@
           <p:cNvPr id="13" name="">
             <a:extLst xmlns:a="http://schemas.openxmlformats.org/drawingml/2006/main">
               <a:ext uri="{FF2B5EF4-FFF2-40B4-BE49-F238E27FC236}">
-                <a16:creationId xmlns:a16="http://schemas.microsoft.com/office/drawing/2014/main" id="{1301D508-5C60-4520-9FBC-62C3202EF775}"/>
+                <a16:creationId xmlns:a16="http://schemas.microsoft.com/office/drawing/2014/main" id="{DD934087-9E15-4CED-A935-E2C6391E245C}"/>
               </a:ext>
             </a:extLst>
           </p:cNvPr>
@@ -19725,7 +19725,7 @@
           <p:cNvPr id="14" name="">
             <a:extLst xmlns:a="http://schemas.openxmlformats.org/drawingml/2006/main">
               <a:ext uri="{FF2B5EF4-FFF2-40B4-BE49-F238E27FC236}">
-                <a16:creationId xmlns:a16="http://schemas.microsoft.com/office/drawing/2014/main" id="{CDD46459-9240-43C9-BC2C-E9F660C60D23}"/>
+                <a16:creationId xmlns:a16="http://schemas.microsoft.com/office/drawing/2014/main" id="{A091C2E9-E1FC-40A4-9EBE-E75D114554C2}"/>
               </a:ext>
             </a:extLst>
           </p:cNvPr>
@@ -19782,7 +19782,7 @@
           <p:cNvPr id="15" name="">
             <a:extLst xmlns:a="http://schemas.openxmlformats.org/drawingml/2006/main">
               <a:ext uri="{FF2B5EF4-FFF2-40B4-BE49-F238E27FC236}">
-                <a16:creationId xmlns:a16="http://schemas.microsoft.com/office/drawing/2014/main" id="{9930EBBE-8726-4F9F-A267-AEC103331FB9}"/>
+                <a16:creationId xmlns:a16="http://schemas.microsoft.com/office/drawing/2014/main" id="{35EB0765-D50E-432D-B6FD-E7C1C2061769}"/>
               </a:ext>
             </a:extLst>
           </p:cNvPr>
@@ -19839,7 +19839,7 @@
           <p:cNvPr id="16" name="">
             <a:extLst xmlns:a="http://schemas.openxmlformats.org/drawingml/2006/main">
               <a:ext uri="{FF2B5EF4-FFF2-40B4-BE49-F238E27FC236}">
-                <a16:creationId xmlns:a16="http://schemas.microsoft.com/office/drawing/2014/main" id="{775A18BC-841B-4708-B7C4-A7429ADFB4AA}"/>
+                <a16:creationId xmlns:a16="http://schemas.microsoft.com/office/drawing/2014/main" id="{CE68A504-B583-4F07-9A71-B04CA7B1DFBD}"/>
               </a:ext>
             </a:extLst>
           </p:cNvPr>
@@ -19919,7 +19919,7 @@
           <p:cNvPr id="17" name="">
             <a:extLst xmlns:a="http://schemas.openxmlformats.org/drawingml/2006/main">
               <a:ext uri="{FF2B5EF4-FFF2-40B4-BE49-F238E27FC236}">
-                <a16:creationId xmlns:a16="http://schemas.microsoft.com/office/drawing/2014/main" id="{484A86D0-E5FB-4B04-814B-E5ACF299DCF7}"/>
+                <a16:creationId xmlns:a16="http://schemas.microsoft.com/office/drawing/2014/main" id="{D41BF2DE-77B2-4405-8D85-C9E323776774}"/>
               </a:ext>
             </a:extLst>
           </p:cNvPr>
@@ -19976,7 +19976,7 @@
           <p:cNvPr id="18" name="">
             <a:extLst xmlns:a="http://schemas.openxmlformats.org/drawingml/2006/main">
               <a:ext uri="{FF2B5EF4-FFF2-40B4-BE49-F238E27FC236}">
-                <a16:creationId xmlns:a16="http://schemas.microsoft.com/office/drawing/2014/main" id="{C46530F3-8AC2-4AF5-B687-1683ADAEE990}"/>
+                <a16:creationId xmlns:a16="http://schemas.microsoft.com/office/drawing/2014/main" id="{9C9D1C15-1F1A-4B10-A357-AC314D9068DE}"/>
               </a:ext>
             </a:extLst>
           </p:cNvPr>
@@ -20033,7 +20033,7 @@
           <p:cNvPr id="19" name="">
             <a:extLst xmlns:a="http://schemas.openxmlformats.org/drawingml/2006/main">
               <a:ext uri="{FF2B5EF4-FFF2-40B4-BE49-F238E27FC236}">
-                <a16:creationId xmlns:a16="http://schemas.microsoft.com/office/drawing/2014/main" id="{3CD45131-2BF0-404F-AB07-FB732778B042}"/>
+                <a16:creationId xmlns:a16="http://schemas.microsoft.com/office/drawing/2014/main" id="{78220858-A35C-4BFD-A44B-2187CE63DDF8}"/>
               </a:ext>
             </a:extLst>
           </p:cNvPr>
@@ -20064,7 +20064,7 @@
           <p:cNvPr id="20" name="">
             <a:extLst xmlns:a="http://schemas.openxmlformats.org/drawingml/2006/main">
               <a:ext uri="{FF2B5EF4-FFF2-40B4-BE49-F238E27FC236}">
-                <a16:creationId xmlns:a16="http://schemas.microsoft.com/office/drawing/2014/main" id="{351EC217-E83B-46ED-9A98-F92C273252D9}"/>
+                <a16:creationId xmlns:a16="http://schemas.microsoft.com/office/drawing/2014/main" id="{00E82593-C067-4C41-9880-9C576D44C95F}"/>
               </a:ext>
             </a:extLst>
           </p:cNvPr>
@@ -20119,7 +20119,7 @@
     </p:spTree>
     <p:extLst>
       <p:ext uri="{BB962C8B-B14F-4D97-AF65-F5344CB8AC3E}">
-        <p14:creationId xmlns:p14="http://schemas.microsoft.com/office/powerpoint/2010/main" val="1372644464"/>
+        <p14:creationId xmlns:p14="http://schemas.microsoft.com/office/powerpoint/2010/main" val="570653259"/>
       </p:ext>
     </p:extLst>
   </p:cSld>
@@ -20150,7 +20150,7 @@
           <p:cNvPr id="24" name="">
             <a:extLst xmlns:a="http://schemas.openxmlformats.org/drawingml/2006/main">
               <a:ext uri="{FF2B5EF4-FFF2-40B4-BE49-F238E27FC236}">
-                <a16:creationId xmlns:a16="http://schemas.microsoft.com/office/drawing/2014/main" id="{BDF3841C-F7AF-418C-95D9-39C817F7ADCE}"/>
+                <a16:creationId xmlns:a16="http://schemas.microsoft.com/office/drawing/2014/main" id="{4745F1A7-6A2D-4F63-9AD4-329BF86AA520}"/>
               </a:ext>
             </a:extLst>
           </p:cNvPr>
@@ -20207,7 +20207,7 @@
           <p:cNvPr id="2" name="">
             <a:extLst xmlns:a="http://schemas.openxmlformats.org/drawingml/2006/main">
               <a:ext uri="{FF2B5EF4-FFF2-40B4-BE49-F238E27FC236}">
-                <a16:creationId xmlns:a16="http://schemas.microsoft.com/office/drawing/2014/main" id="{ADC82B60-D6DA-4448-B619-578383027BDA}"/>
+                <a16:creationId xmlns:a16="http://schemas.microsoft.com/office/drawing/2014/main" id="{702DFDB1-1238-4C05-B515-D01ACD554985}"/>
               </a:ext>
             </a:extLst>
           </p:cNvPr>
@@ -20238,7 +20238,7 @@
           <p:cNvPr id="3" name="">
             <a:extLst xmlns:a="http://schemas.openxmlformats.org/drawingml/2006/main">
               <a:ext uri="{FF2B5EF4-FFF2-40B4-BE49-F238E27FC236}">
-                <a16:creationId xmlns:a16="http://schemas.microsoft.com/office/drawing/2014/main" id="{31BDD0CA-BA3D-4E39-96D9-FB476D3E9A67}"/>
+                <a16:creationId xmlns:a16="http://schemas.microsoft.com/office/drawing/2014/main" id="{CA35A2F6-7F47-48C3-8E15-BFE6AEABAAFF}"/>
               </a:ext>
             </a:extLst>
           </p:cNvPr>
@@ -20295,7 +20295,7 @@
           <p:cNvPr id="4" name="">
             <a:extLst xmlns:a="http://schemas.openxmlformats.org/drawingml/2006/main">
               <a:ext uri="{FF2B5EF4-FFF2-40B4-BE49-F238E27FC236}">
-                <a16:creationId xmlns:a16="http://schemas.microsoft.com/office/drawing/2014/main" id="{B10EEC75-4D36-4D8C-96BC-DB20C23B628B}"/>
+                <a16:creationId xmlns:a16="http://schemas.microsoft.com/office/drawing/2014/main" id="{2C89C9BA-6AB4-4149-AABB-ADAE75652076}"/>
               </a:ext>
             </a:extLst>
           </p:cNvPr>
@@ -20352,7 +20352,7 @@
           <p:cNvPr id="5" name="">
             <a:extLst xmlns:a="http://schemas.openxmlformats.org/drawingml/2006/main">
               <a:ext uri="{FF2B5EF4-FFF2-40B4-BE49-F238E27FC236}">
-                <a16:creationId xmlns:a16="http://schemas.microsoft.com/office/drawing/2014/main" id="{941670CE-65A4-49D7-9D3E-44A2792FA027}"/>
+                <a16:creationId xmlns:a16="http://schemas.microsoft.com/office/drawing/2014/main" id="{3F5A34C9-F16B-4597-913F-2AE0FF7A4D52}"/>
               </a:ext>
             </a:extLst>
           </p:cNvPr>
@@ -20409,7 +20409,7 @@
           <p:cNvPr id="6" name="">
             <a:extLst xmlns:a="http://schemas.openxmlformats.org/drawingml/2006/main">
               <a:ext uri="{FF2B5EF4-FFF2-40B4-BE49-F238E27FC236}">
-                <a16:creationId xmlns:a16="http://schemas.microsoft.com/office/drawing/2014/main" id="{13D692FD-1C2D-450C-AC06-C705019DF846}"/>
+                <a16:creationId xmlns:a16="http://schemas.microsoft.com/office/drawing/2014/main" id="{19D55E2C-C5FA-41CD-850C-F3CFEE9B4648}"/>
               </a:ext>
             </a:extLst>
           </p:cNvPr>
@@ -20442,7 +20442,7 @@
           <p:cNvPr id="7" name="">
             <a:extLst xmlns:a="http://schemas.openxmlformats.org/drawingml/2006/main">
               <a:ext uri="{FF2B5EF4-FFF2-40B4-BE49-F238E27FC236}">
-                <a16:creationId xmlns:a16="http://schemas.microsoft.com/office/drawing/2014/main" id="{B91BFF92-D40D-481B-9DE0-072934834459}"/>
+                <a16:creationId xmlns:a16="http://schemas.microsoft.com/office/drawing/2014/main" id="{DE86E842-F69D-4C58-A59D-908A1EDCC8B4}"/>
               </a:ext>
             </a:extLst>
           </p:cNvPr>
@@ -20522,7 +20522,7 @@
           <p:cNvPr id="8" name="">
             <a:extLst xmlns:a="http://schemas.openxmlformats.org/drawingml/2006/main">
               <a:ext uri="{FF2B5EF4-FFF2-40B4-BE49-F238E27FC236}">
-                <a16:creationId xmlns:a16="http://schemas.microsoft.com/office/drawing/2014/main" id="{52BEE6FF-FF7D-4148-BD1E-2D7A479AC72C}"/>
+                <a16:creationId xmlns:a16="http://schemas.microsoft.com/office/drawing/2014/main" id="{EC6A4C67-CD6D-4D6C-9FF8-5F669F5AC49C}"/>
               </a:ext>
             </a:extLst>
           </p:cNvPr>
@@ -20625,7 +20625,7 @@
           <p:cNvPr id="9" name="">
             <a:extLst xmlns:a="http://schemas.openxmlformats.org/drawingml/2006/main">
               <a:ext uri="{FF2B5EF4-FFF2-40B4-BE49-F238E27FC236}">
-                <a16:creationId xmlns:a16="http://schemas.microsoft.com/office/drawing/2014/main" id="{FB5E77F3-337F-4DCB-B119-CE3B62A85ABD}"/>
+                <a16:creationId xmlns:a16="http://schemas.microsoft.com/office/drawing/2014/main" id="{4AF6DD97-1287-4629-B141-9FA0FA0CF42A}"/>
               </a:ext>
             </a:extLst>
           </p:cNvPr>
@@ -20658,7 +20658,7 @@
           <p:cNvPr id="10" name="">
             <a:extLst xmlns:a="http://schemas.openxmlformats.org/drawingml/2006/main">
               <a:ext uri="{FF2B5EF4-FFF2-40B4-BE49-F238E27FC236}">
-                <a16:creationId xmlns:a16="http://schemas.microsoft.com/office/drawing/2014/main" id="{A6451BD0-2442-4212-9BEE-9727FE00D3EE}"/>
+                <a16:creationId xmlns:a16="http://schemas.microsoft.com/office/drawing/2014/main" id="{F6923AD1-79AE-4E11-A556-6E11CD8B8EF3}"/>
               </a:ext>
             </a:extLst>
           </p:cNvPr>
@@ -20738,7 +20738,7 @@
           <p:cNvPr id="11" name="">
             <a:extLst xmlns:a="http://schemas.openxmlformats.org/drawingml/2006/main">
               <a:ext uri="{FF2B5EF4-FFF2-40B4-BE49-F238E27FC236}">
-                <a16:creationId xmlns:a16="http://schemas.microsoft.com/office/drawing/2014/main" id="{E711C690-8885-4BF0-BF00-A72DC0541E7C}"/>
+                <a16:creationId xmlns:a16="http://schemas.microsoft.com/office/drawing/2014/main" id="{CE8D02B5-BB9F-49AE-822A-5A69560752DB}"/>
               </a:ext>
             </a:extLst>
           </p:cNvPr>
@@ -20841,7 +20841,7 @@
           <p:cNvPr id="12" name="">
             <a:extLst xmlns:a="http://schemas.openxmlformats.org/drawingml/2006/main">
               <a:ext uri="{FF2B5EF4-FFF2-40B4-BE49-F238E27FC236}">
-                <a16:creationId xmlns:a16="http://schemas.microsoft.com/office/drawing/2014/main" id="{7E44A160-B0D1-4234-A091-A4CC7B08BD53}"/>
+                <a16:creationId xmlns:a16="http://schemas.microsoft.com/office/drawing/2014/main" id="{10FBAC5C-55DB-4943-9B13-5CE73295BE98}"/>
               </a:ext>
             </a:extLst>
           </p:cNvPr>
@@ -20874,7 +20874,7 @@
           <p:cNvPr id="13" name="">
             <a:extLst xmlns:a="http://schemas.openxmlformats.org/drawingml/2006/main">
               <a:ext uri="{FF2B5EF4-FFF2-40B4-BE49-F238E27FC236}">
-                <a16:creationId xmlns:a16="http://schemas.microsoft.com/office/drawing/2014/main" id="{3E761897-087C-47A5-A04E-D63220F6AFC9}"/>
+                <a16:creationId xmlns:a16="http://schemas.microsoft.com/office/drawing/2014/main" id="{D604CDD0-F4FB-4466-A086-0CEB2248D9FF}"/>
               </a:ext>
             </a:extLst>
           </p:cNvPr>
@@ -20954,7 +20954,7 @@
           <p:cNvPr id="14" name="">
             <a:extLst xmlns:a="http://schemas.openxmlformats.org/drawingml/2006/main">
               <a:ext uri="{FF2B5EF4-FFF2-40B4-BE49-F238E27FC236}">
-                <a16:creationId xmlns:a16="http://schemas.microsoft.com/office/drawing/2014/main" id="{8D813124-D9FF-41B5-8448-DFDA85C6FEA2}"/>
+                <a16:creationId xmlns:a16="http://schemas.microsoft.com/office/drawing/2014/main" id="{2EA5774D-928C-435F-85C8-86EBFA8C94E2}"/>
               </a:ext>
             </a:extLst>
           </p:cNvPr>
@@ -21057,7 +21057,7 @@
           <p:cNvPr id="15" name="">
             <a:extLst xmlns:a="http://schemas.openxmlformats.org/drawingml/2006/main">
               <a:ext uri="{FF2B5EF4-FFF2-40B4-BE49-F238E27FC236}">
-                <a16:creationId xmlns:a16="http://schemas.microsoft.com/office/drawing/2014/main" id="{CC1505B2-6804-42F1-A60F-FCFED8B33345}"/>
+                <a16:creationId xmlns:a16="http://schemas.microsoft.com/office/drawing/2014/main" id="{4F765BD9-976B-45C7-B94D-DEB5057D5A74}"/>
               </a:ext>
             </a:extLst>
           </p:cNvPr>
@@ -21090,7 +21090,7 @@
           <p:cNvPr id="16" name="">
             <a:extLst xmlns:a="http://schemas.openxmlformats.org/drawingml/2006/main">
               <a:ext uri="{FF2B5EF4-FFF2-40B4-BE49-F238E27FC236}">
-                <a16:creationId xmlns:a16="http://schemas.microsoft.com/office/drawing/2014/main" id="{C1082BC7-DA93-4806-8CFE-380EC3C22D97}"/>
+                <a16:creationId xmlns:a16="http://schemas.microsoft.com/office/drawing/2014/main" id="{921EA4C5-123B-422A-A62D-0520A86075D5}"/>
               </a:ext>
             </a:extLst>
           </p:cNvPr>
@@ -21170,7 +21170,7 @@
           <p:cNvPr id="17" name="">
             <a:extLst xmlns:a="http://schemas.openxmlformats.org/drawingml/2006/main">
               <a:ext uri="{FF2B5EF4-FFF2-40B4-BE49-F238E27FC236}">
-                <a16:creationId xmlns:a16="http://schemas.microsoft.com/office/drawing/2014/main" id="{AA158DEF-B1A0-4E30-B367-BF0B43A9D532}"/>
+                <a16:creationId xmlns:a16="http://schemas.microsoft.com/office/drawing/2014/main" id="{A46F67C9-DDA7-40D5-B874-7D25E40302AF}"/>
               </a:ext>
             </a:extLst>
           </p:cNvPr>
@@ -21351,7 +21351,7 @@
           <p:cNvPr id="21" name="">
             <a:extLst xmlns:a="http://schemas.openxmlformats.org/drawingml/2006/main">
               <a:ext uri="{FF2B5EF4-FFF2-40B4-BE49-F238E27FC236}">
-                <a16:creationId xmlns:a16="http://schemas.microsoft.com/office/drawing/2014/main" id="{A2107EDC-C791-4910-AAE9-FC62F020875F}"/>
+                <a16:creationId xmlns:a16="http://schemas.microsoft.com/office/drawing/2014/main" id="{9535C544-CC2A-4CDE-8F05-063AD9D223F6}"/>
               </a:ext>
             </a:extLst>
           </p:cNvPr>
@@ -21408,7 +21408,7 @@
           <p:cNvPr id="22" name="">
             <a:extLst xmlns:a="http://schemas.openxmlformats.org/drawingml/2006/main">
               <a:ext uri="{FF2B5EF4-FFF2-40B4-BE49-F238E27FC236}">
-                <a16:creationId xmlns:a16="http://schemas.microsoft.com/office/drawing/2014/main" id="{44AC5897-0AC1-458B-A1EC-A3A97AAB1102}"/>
+                <a16:creationId xmlns:a16="http://schemas.microsoft.com/office/drawing/2014/main" id="{EF1A622C-2DC3-475F-ABE4-A9C0CAE4F039}"/>
               </a:ext>
             </a:extLst>
           </p:cNvPr>
@@ -21439,7 +21439,7 @@
           <p:cNvPr id="23" name="">
             <a:extLst xmlns:a="http://schemas.openxmlformats.org/drawingml/2006/main">
               <a:ext uri="{FF2B5EF4-FFF2-40B4-BE49-F238E27FC236}">
-                <a16:creationId xmlns:a16="http://schemas.microsoft.com/office/drawing/2014/main" id="{B7C0E204-B137-4AF6-8178-E7B4093F2308}"/>
+                <a16:creationId xmlns:a16="http://schemas.microsoft.com/office/drawing/2014/main" id="{14F257EA-C488-49A8-A5A9-632811693E16}"/>
               </a:ext>
             </a:extLst>
           </p:cNvPr>
@@ -21494,7 +21494,7 @@
     </p:spTree>
     <p:extLst>
       <p:ext uri="{BB962C8B-B14F-4D97-AF65-F5344CB8AC3E}">
-        <p14:creationId xmlns:p14="http://schemas.microsoft.com/office/powerpoint/2010/main" val="1998335131"/>
+        <p14:creationId xmlns:p14="http://schemas.microsoft.com/office/powerpoint/2010/main" val="251191414"/>
       </p:ext>
     </p:extLst>
   </p:cSld>
@@ -21525,7 +21525,7 @@
           <p:cNvPr id="32" name="">
             <a:extLst xmlns:a="http://schemas.openxmlformats.org/drawingml/2006/main">
               <a:ext uri="{FF2B5EF4-FFF2-40B4-BE49-F238E27FC236}">
-                <a16:creationId xmlns:a16="http://schemas.microsoft.com/office/drawing/2014/main" id="{278D09C3-207F-4D61-BD89-A35E5CB2FBE6}"/>
+                <a16:creationId xmlns:a16="http://schemas.microsoft.com/office/drawing/2014/main" id="{789733D1-EABD-4D9F-8ECC-F911844F2356}"/>
               </a:ext>
             </a:extLst>
           </p:cNvPr>
@@ -21605,7 +21605,7 @@
           <p:cNvPr id="2" name="">
             <a:extLst xmlns:a="http://schemas.openxmlformats.org/drawingml/2006/main">
               <a:ext uri="{FF2B5EF4-FFF2-40B4-BE49-F238E27FC236}">
-                <a16:creationId xmlns:a16="http://schemas.microsoft.com/office/drawing/2014/main" id="{7D9FDBC3-D2CD-4D89-BCBC-4C2CB79E57CD}"/>
+                <a16:creationId xmlns:a16="http://schemas.microsoft.com/office/drawing/2014/main" id="{56A34B9F-E9E6-4C6D-9231-B438B699266E}"/>
               </a:ext>
             </a:extLst>
           </p:cNvPr>
@@ -21636,7 +21636,7 @@
           <p:cNvPr id="3" name="">
             <a:extLst xmlns:a="http://schemas.openxmlformats.org/drawingml/2006/main">
               <a:ext uri="{FF2B5EF4-FFF2-40B4-BE49-F238E27FC236}">
-                <a16:creationId xmlns:a16="http://schemas.microsoft.com/office/drawing/2014/main" id="{C5DBD966-B4BB-4A68-A186-BFBBABEC3C96}"/>
+                <a16:creationId xmlns:a16="http://schemas.microsoft.com/office/drawing/2014/main" id="{888254F1-4396-4422-869A-C0F0FD0C4C7F}"/>
               </a:ext>
             </a:extLst>
           </p:cNvPr>
@@ -21693,7 +21693,7 @@
           <p:cNvPr id="4" name="">
             <a:extLst xmlns:a="http://schemas.openxmlformats.org/drawingml/2006/main">
               <a:ext uri="{FF2B5EF4-FFF2-40B4-BE49-F238E27FC236}">
-                <a16:creationId xmlns:a16="http://schemas.microsoft.com/office/drawing/2014/main" id="{3DE03A46-5A85-47E6-914A-30418E9DFDB2}"/>
+                <a16:creationId xmlns:a16="http://schemas.microsoft.com/office/drawing/2014/main" id="{CCA32B5F-96EF-48C8-BDE4-6AD1C6E8FE66}"/>
               </a:ext>
             </a:extLst>
           </p:cNvPr>
@@ -21750,7 +21750,7 @@
           <p:cNvPr id="5" name="">
             <a:extLst xmlns:a="http://schemas.openxmlformats.org/drawingml/2006/main">
               <a:ext uri="{FF2B5EF4-FFF2-40B4-BE49-F238E27FC236}">
-                <a16:creationId xmlns:a16="http://schemas.microsoft.com/office/drawing/2014/main" id="{E8F62ADF-7728-47A8-A10C-04360D5DB642}"/>
+                <a16:creationId xmlns:a16="http://schemas.microsoft.com/office/drawing/2014/main" id="{37140226-C4B1-43A8-B12A-52BAA07376D3}"/>
               </a:ext>
             </a:extLst>
           </p:cNvPr>
@@ -21807,7 +21807,7 @@
           <p:cNvPr id="6" name="">
             <a:extLst xmlns:a="http://schemas.openxmlformats.org/drawingml/2006/main">
               <a:ext uri="{FF2B5EF4-FFF2-40B4-BE49-F238E27FC236}">
-                <a16:creationId xmlns:a16="http://schemas.microsoft.com/office/drawing/2014/main" id="{6914F6AE-E933-4A95-9836-98450472D511}"/>
+                <a16:creationId xmlns:a16="http://schemas.microsoft.com/office/drawing/2014/main" id="{DB3D6269-FF95-476A-9D01-2EB1F2E44D92}"/>
               </a:ext>
             </a:extLst>
           </p:cNvPr>
@@ -21864,7 +21864,7 @@
           <p:cNvPr id="7" name="">
             <a:extLst xmlns:a="http://schemas.openxmlformats.org/drawingml/2006/main">
               <a:ext uri="{FF2B5EF4-FFF2-40B4-BE49-F238E27FC236}">
-                <a16:creationId xmlns:a16="http://schemas.microsoft.com/office/drawing/2014/main" id="{3017FCCB-0748-4CCC-BC2F-5DDC28D57E3B}"/>
+                <a16:creationId xmlns:a16="http://schemas.microsoft.com/office/drawing/2014/main" id="{0C9A4D0D-87DB-4FD4-9E55-73155BED716A}"/>
               </a:ext>
             </a:extLst>
           </p:cNvPr>
@@ -21921,7 +21921,7 @@
           <p:cNvPr id="8" name="">
             <a:extLst xmlns:a="http://schemas.openxmlformats.org/drawingml/2006/main">
               <a:ext uri="{FF2B5EF4-FFF2-40B4-BE49-F238E27FC236}">
-                <a16:creationId xmlns:a16="http://schemas.microsoft.com/office/drawing/2014/main" id="{2C707BC9-1B21-4A0C-A8CC-5E0520F5415B}"/>
+                <a16:creationId xmlns:a16="http://schemas.microsoft.com/office/drawing/2014/main" id="{A7E3CFDF-FD9C-4B1F-BBFD-56DBA00F97AD}"/>
               </a:ext>
             </a:extLst>
           </p:cNvPr>
@@ -21978,7 +21978,7 @@
           <p:cNvPr id="9" name="">
             <a:extLst xmlns:a="http://schemas.openxmlformats.org/drawingml/2006/main">
               <a:ext uri="{FF2B5EF4-FFF2-40B4-BE49-F238E27FC236}">
-                <a16:creationId xmlns:a16="http://schemas.microsoft.com/office/drawing/2014/main" id="{AF3F3368-5E0E-4E7A-B60A-76E17AEDC730}"/>
+                <a16:creationId xmlns:a16="http://schemas.microsoft.com/office/drawing/2014/main" id="{085B3AA2-571F-4492-9EE4-227612F25115}"/>
               </a:ext>
             </a:extLst>
           </p:cNvPr>
@@ -22035,7 +22035,7 @@
           <p:cNvPr id="10" name="">
             <a:extLst xmlns:a="http://schemas.openxmlformats.org/drawingml/2006/main">
               <a:ext uri="{FF2B5EF4-FFF2-40B4-BE49-F238E27FC236}">
-                <a16:creationId xmlns:a16="http://schemas.microsoft.com/office/drawing/2014/main" id="{E4526631-DB9E-434B-9354-28768D79F478}"/>
+                <a16:creationId xmlns:a16="http://schemas.microsoft.com/office/drawing/2014/main" id="{B2B52880-F1F2-40BB-8DD2-31F71F2C6E85}"/>
               </a:ext>
             </a:extLst>
           </p:cNvPr>
@@ -22066,7 +22066,7 @@
           <p:cNvPr id="11" name="">
             <a:extLst xmlns:a="http://schemas.openxmlformats.org/drawingml/2006/main">
               <a:ext uri="{FF2B5EF4-FFF2-40B4-BE49-F238E27FC236}">
-                <a16:creationId xmlns:a16="http://schemas.microsoft.com/office/drawing/2014/main" id="{24AD4E69-9C97-4C98-96E5-D1919EA15C45}"/>
+                <a16:creationId xmlns:a16="http://schemas.microsoft.com/office/drawing/2014/main" id="{59121C58-B73A-49E0-9DAD-A9D0A900D1C6}"/>
               </a:ext>
             </a:extLst>
           </p:cNvPr>
@@ -22123,7 +22123,7 @@
           <p:cNvPr id="12" name="">
             <a:extLst xmlns:a="http://schemas.openxmlformats.org/drawingml/2006/main">
               <a:ext uri="{FF2B5EF4-FFF2-40B4-BE49-F238E27FC236}">
-                <a16:creationId xmlns:a16="http://schemas.microsoft.com/office/drawing/2014/main" id="{515B8B87-FF64-4B72-88F7-8F0DDD6F9130}"/>
+                <a16:creationId xmlns:a16="http://schemas.microsoft.com/office/drawing/2014/main" id="{4773D665-8A19-4552-AECF-4F3F88C5D036}"/>
               </a:ext>
             </a:extLst>
           </p:cNvPr>
@@ -22180,7 +22180,7 @@
           <p:cNvPr id="13" name="">
             <a:extLst xmlns:a="http://schemas.openxmlformats.org/drawingml/2006/main">
               <a:ext uri="{FF2B5EF4-FFF2-40B4-BE49-F238E27FC236}">
-                <a16:creationId xmlns:a16="http://schemas.microsoft.com/office/drawing/2014/main" id="{C5AD9A97-7D7F-4471-B9CF-94C5308C3F21}"/>
+                <a16:creationId xmlns:a16="http://schemas.microsoft.com/office/drawing/2014/main" id="{C54379BB-F730-4332-A636-2D176261CE67}"/>
               </a:ext>
             </a:extLst>
           </p:cNvPr>
@@ -22237,7 +22237,7 @@
           <p:cNvPr id="14" name="">
             <a:extLst xmlns:a="http://schemas.openxmlformats.org/drawingml/2006/main">
               <a:ext uri="{FF2B5EF4-FFF2-40B4-BE49-F238E27FC236}">
-                <a16:creationId xmlns:a16="http://schemas.microsoft.com/office/drawing/2014/main" id="{2E28FBFF-B5F5-49A3-8DF8-5AB5D665F080}"/>
+                <a16:creationId xmlns:a16="http://schemas.microsoft.com/office/drawing/2014/main" id="{430F1E43-C40A-4523-BF3B-60437F02AEDA}"/>
               </a:ext>
             </a:extLst>
           </p:cNvPr>
@@ -22294,7 +22294,7 @@
           <p:cNvPr id="15" name="">
             <a:extLst xmlns:a="http://schemas.openxmlformats.org/drawingml/2006/main">
               <a:ext uri="{FF2B5EF4-FFF2-40B4-BE49-F238E27FC236}">
-                <a16:creationId xmlns:a16="http://schemas.microsoft.com/office/drawing/2014/main" id="{CC0A3771-65E5-4DDC-B171-DE59B283010A}"/>
+                <a16:creationId xmlns:a16="http://schemas.microsoft.com/office/drawing/2014/main" id="{32B8D9B0-0607-44CA-9CE7-4DDB7A40B73E}"/>
               </a:ext>
             </a:extLst>
           </p:cNvPr>
@@ -22351,7 +22351,7 @@
           <p:cNvPr id="16" name="">
             <a:extLst xmlns:a="http://schemas.openxmlformats.org/drawingml/2006/main">
               <a:ext uri="{FF2B5EF4-FFF2-40B4-BE49-F238E27FC236}">
-                <a16:creationId xmlns:a16="http://schemas.microsoft.com/office/drawing/2014/main" id="{F9230BF5-B4F2-4040-98DC-AAC35C1F2CED}"/>
+                <a16:creationId xmlns:a16="http://schemas.microsoft.com/office/drawing/2014/main" id="{2938DC92-C4FA-4D6B-8E13-597071B5A0FB}"/>
               </a:ext>
             </a:extLst>
           </p:cNvPr>
@@ -22408,7 +22408,7 @@
           <p:cNvPr id="17" name="">
             <a:extLst xmlns:a="http://schemas.openxmlformats.org/drawingml/2006/main">
               <a:ext uri="{FF2B5EF4-FFF2-40B4-BE49-F238E27FC236}">
-                <a16:creationId xmlns:a16="http://schemas.microsoft.com/office/drawing/2014/main" id="{3C5DE535-36CD-4222-96DB-3E809D82699B}"/>
+                <a16:creationId xmlns:a16="http://schemas.microsoft.com/office/drawing/2014/main" id="{8F5C8FAB-BD08-4C10-9EE5-93E5D28DA52B}"/>
               </a:ext>
             </a:extLst>
           </p:cNvPr>
@@ -22465,7 +22465,7 @@
           <p:cNvPr id="18" name="">
             <a:extLst xmlns:a="http://schemas.openxmlformats.org/drawingml/2006/main">
               <a:ext uri="{FF2B5EF4-FFF2-40B4-BE49-F238E27FC236}">
-                <a16:creationId xmlns:a16="http://schemas.microsoft.com/office/drawing/2014/main" id="{66B3A6C3-76DF-4545-946C-7D1BEBA33942}"/>
+                <a16:creationId xmlns:a16="http://schemas.microsoft.com/office/drawing/2014/main" id="{9B652C58-BB95-4CF7-A19F-7A127F3242E4}"/>
               </a:ext>
             </a:extLst>
           </p:cNvPr>
@@ -22522,7 +22522,7 @@
           <p:cNvPr id="19" name="">
             <a:extLst xmlns:a="http://schemas.openxmlformats.org/drawingml/2006/main">
               <a:ext uri="{FF2B5EF4-FFF2-40B4-BE49-F238E27FC236}">
-                <a16:creationId xmlns:a16="http://schemas.microsoft.com/office/drawing/2014/main" id="{DF4714C3-E0E1-470A-87C2-DA9DF443E17F}"/>
+                <a16:creationId xmlns:a16="http://schemas.microsoft.com/office/drawing/2014/main" id="{1E77ACA4-750B-41F4-8A52-85BFDCB17EDF}"/>
               </a:ext>
             </a:extLst>
           </p:cNvPr>
@@ -22579,7 +22579,7 @@
           <p:cNvPr id="20" name="">
             <a:extLst xmlns:a="http://schemas.openxmlformats.org/drawingml/2006/main">
               <a:ext uri="{FF2B5EF4-FFF2-40B4-BE49-F238E27FC236}">
-                <a16:creationId xmlns:a16="http://schemas.microsoft.com/office/drawing/2014/main" id="{58C19518-CF54-4747-9EAD-BB89D7F75A14}"/>
+                <a16:creationId xmlns:a16="http://schemas.microsoft.com/office/drawing/2014/main" id="{4948B49D-074D-4A00-B8A0-17200B09A80D}"/>
               </a:ext>
             </a:extLst>
           </p:cNvPr>
@@ -22636,7 +22636,7 @@
           <p:cNvPr id="21" name="">
             <a:extLst xmlns:a="http://schemas.openxmlformats.org/drawingml/2006/main">
               <a:ext uri="{FF2B5EF4-FFF2-40B4-BE49-F238E27FC236}">
-                <a16:creationId xmlns:a16="http://schemas.microsoft.com/office/drawing/2014/main" id="{C90907E6-BF48-4445-96CD-0C7B89376F9F}"/>
+                <a16:creationId xmlns:a16="http://schemas.microsoft.com/office/drawing/2014/main" id="{60768A88-0B9E-4489-96BA-8D6D0307579C}"/>
               </a:ext>
             </a:extLst>
           </p:cNvPr>
@@ -22693,7 +22693,7 @@
           <p:cNvPr id="22" name="">
             <a:extLst xmlns:a="http://schemas.openxmlformats.org/drawingml/2006/main">
               <a:ext uri="{FF2B5EF4-FFF2-40B4-BE49-F238E27FC236}">
-                <a16:creationId xmlns:a16="http://schemas.microsoft.com/office/drawing/2014/main" id="{319E0C1A-18C5-4239-AF64-16A978F8B3EF}"/>
+                <a16:creationId xmlns:a16="http://schemas.microsoft.com/office/drawing/2014/main" id="{AC84E710-A7D6-42F9-89EC-6FF52D514E66}"/>
               </a:ext>
             </a:extLst>
           </p:cNvPr>
@@ -22750,7 +22750,7 @@
           <p:cNvPr id="23" name="">
             <a:extLst xmlns:a="http://schemas.openxmlformats.org/drawingml/2006/main">
               <a:ext uri="{FF2B5EF4-FFF2-40B4-BE49-F238E27FC236}">
-                <a16:creationId xmlns:a16="http://schemas.microsoft.com/office/drawing/2014/main" id="{66DB59CA-DAA1-4C50-8B5D-4DB80E100485}"/>
+                <a16:creationId xmlns:a16="http://schemas.microsoft.com/office/drawing/2014/main" id="{BFDD3D24-1C02-4202-8EEB-7362527D327C}"/>
               </a:ext>
             </a:extLst>
           </p:cNvPr>
@@ -22807,7 +22807,7 @@
           <p:cNvPr id="24" name="">
             <a:extLst xmlns:a="http://schemas.openxmlformats.org/drawingml/2006/main">
               <a:ext uri="{FF2B5EF4-FFF2-40B4-BE49-F238E27FC236}">
-                <a16:creationId xmlns:a16="http://schemas.microsoft.com/office/drawing/2014/main" id="{50BA55B2-281C-4B18-884E-1088A3856D75}"/>
+                <a16:creationId xmlns:a16="http://schemas.microsoft.com/office/drawing/2014/main" id="{86CFD67C-F6BA-4DE0-9830-C86901890F83}"/>
               </a:ext>
             </a:extLst>
           </p:cNvPr>
@@ -22864,7 +22864,7 @@
           <p:cNvPr id="25" name="">
             <a:extLst xmlns:a="http://schemas.openxmlformats.org/drawingml/2006/main">
               <a:ext uri="{FF2B5EF4-FFF2-40B4-BE49-F238E27FC236}">
-                <a16:creationId xmlns:a16="http://schemas.microsoft.com/office/drawing/2014/main" id="{C53A2F24-1844-4E35-A6EB-8192BE93D065}"/>
+                <a16:creationId xmlns:a16="http://schemas.microsoft.com/office/drawing/2014/main" id="{28C2E15E-59A5-4C27-B087-E69AAC4A71A1}"/>
               </a:ext>
             </a:extLst>
           </p:cNvPr>
@@ -22921,7 +22921,7 @@
           <p:cNvPr id="26" name="">
             <a:extLst xmlns:a="http://schemas.openxmlformats.org/drawingml/2006/main">
               <a:ext uri="{FF2B5EF4-FFF2-40B4-BE49-F238E27FC236}">
-                <a16:creationId xmlns:a16="http://schemas.microsoft.com/office/drawing/2014/main" id="{E2A6DCFB-CEEE-491B-84D5-1E1FC23B47C2}"/>
+                <a16:creationId xmlns:a16="http://schemas.microsoft.com/office/drawing/2014/main" id="{73F7ED83-51B1-4E21-86F3-DE6B9AF492CB}"/>
               </a:ext>
             </a:extLst>
           </p:cNvPr>
@@ -22978,7 +22978,7 @@
           <p:cNvPr id="27" name="">
             <a:extLst xmlns:a="http://schemas.openxmlformats.org/drawingml/2006/main">
               <a:ext uri="{FF2B5EF4-FFF2-40B4-BE49-F238E27FC236}">
-                <a16:creationId xmlns:a16="http://schemas.microsoft.com/office/drawing/2014/main" id="{C8355D16-C6D0-41D2-A064-14DEEFAE8F20}"/>
+                <a16:creationId xmlns:a16="http://schemas.microsoft.com/office/drawing/2014/main" id="{B6A8D077-1731-4CCA-8C11-747424A5B9DA}"/>
               </a:ext>
             </a:extLst>
           </p:cNvPr>
@@ -23035,7 +23035,7 @@
           <p:cNvPr id="28" name="">
             <a:extLst xmlns:a="http://schemas.openxmlformats.org/drawingml/2006/main">
               <a:ext uri="{FF2B5EF4-FFF2-40B4-BE49-F238E27FC236}">
-                <a16:creationId xmlns:a16="http://schemas.microsoft.com/office/drawing/2014/main" id="{6B7331F6-AD71-4B85-A10C-9439017E6057}"/>
+                <a16:creationId xmlns:a16="http://schemas.microsoft.com/office/drawing/2014/main" id="{581711FD-92C4-4E35-B3F1-96A66C6AC247}"/>
               </a:ext>
             </a:extLst>
           </p:cNvPr>
@@ -23092,7 +23092,7 @@
           <p:cNvPr id="29" name="">
             <a:extLst xmlns:a="http://schemas.openxmlformats.org/drawingml/2006/main">
               <a:ext uri="{FF2B5EF4-FFF2-40B4-BE49-F238E27FC236}">
-                <a16:creationId xmlns:a16="http://schemas.microsoft.com/office/drawing/2014/main" id="{A2DA2D4E-4F8B-4437-9E68-5E355B19781D}"/>
+                <a16:creationId xmlns:a16="http://schemas.microsoft.com/office/drawing/2014/main" id="{3ED05086-343C-4BBF-B34B-C8EE405E77D9}"/>
               </a:ext>
             </a:extLst>
           </p:cNvPr>
@@ -23123,7 +23123,7 @@
           <p:cNvPr id="30" name="">
             <a:extLst xmlns:a="http://schemas.openxmlformats.org/drawingml/2006/main">
               <a:ext uri="{FF2B5EF4-FFF2-40B4-BE49-F238E27FC236}">
-                <a16:creationId xmlns:a16="http://schemas.microsoft.com/office/drawing/2014/main" id="{2522DCD4-E9E8-4B0E-B287-26AB7B36C78F}"/>
+                <a16:creationId xmlns:a16="http://schemas.microsoft.com/office/drawing/2014/main" id="{C1615D1E-2EB3-4F3F-A824-5D7573A6B1F8}"/>
               </a:ext>
             </a:extLst>
           </p:cNvPr>
@@ -23180,7 +23180,7 @@
           <p:cNvPr id="31" name="">
             <a:extLst xmlns:a="http://schemas.openxmlformats.org/drawingml/2006/main">
               <a:ext uri="{FF2B5EF4-FFF2-40B4-BE49-F238E27FC236}">
-                <a16:creationId xmlns:a16="http://schemas.microsoft.com/office/drawing/2014/main" id="{C3831567-2828-4B8C-9C2D-D883889402BC}"/>
+                <a16:creationId xmlns:a16="http://schemas.microsoft.com/office/drawing/2014/main" id="{9B357117-0803-4009-BEAA-60EDF7B6CEDD}"/>
               </a:ext>
             </a:extLst>
           </p:cNvPr>
@@ -23235,7 +23235,7 @@
     </p:spTree>
     <p:extLst>
       <p:ext uri="{BB962C8B-B14F-4D97-AF65-F5344CB8AC3E}">
-        <p14:creationId xmlns:p14="http://schemas.microsoft.com/office/powerpoint/2010/main" val="940167741"/>
+        <p14:creationId xmlns:p14="http://schemas.microsoft.com/office/powerpoint/2010/main" val="585414683"/>
       </p:ext>
     </p:extLst>
   </p:cSld>
@@ -23266,7 +23266,7 @@
           <p:cNvPr id="35" name="">
             <a:extLst xmlns:a="http://schemas.openxmlformats.org/drawingml/2006/main">
               <a:ext uri="{FF2B5EF4-FFF2-40B4-BE49-F238E27FC236}">
-                <a16:creationId xmlns:a16="http://schemas.microsoft.com/office/drawing/2014/main" id="{442459A3-50CA-40A7-872D-A8B5CA671BB8}"/>
+                <a16:creationId xmlns:a16="http://schemas.microsoft.com/office/drawing/2014/main" id="{1AACAD2A-6C41-446A-B5AD-93EF388354DB}"/>
               </a:ext>
             </a:extLst>
           </p:cNvPr>
@@ -23323,7 +23323,7 @@
           <p:cNvPr id="2" name="">
             <a:extLst xmlns:a="http://schemas.openxmlformats.org/drawingml/2006/main">
               <a:ext uri="{FF2B5EF4-FFF2-40B4-BE49-F238E27FC236}">
-                <a16:creationId xmlns:a16="http://schemas.microsoft.com/office/drawing/2014/main" id="{42BBE49A-BBCC-4717-9F27-E8231F03D866}"/>
+                <a16:creationId xmlns:a16="http://schemas.microsoft.com/office/drawing/2014/main" id="{762B377C-4ED0-4166-BE2E-2F88BD22FB44}"/>
               </a:ext>
             </a:extLst>
           </p:cNvPr>
@@ -23354,7 +23354,7 @@
           <p:cNvPr id="3" name="">
             <a:extLst xmlns:a="http://schemas.openxmlformats.org/drawingml/2006/main">
               <a:ext uri="{FF2B5EF4-FFF2-40B4-BE49-F238E27FC236}">
-                <a16:creationId xmlns:a16="http://schemas.microsoft.com/office/drawing/2014/main" id="{83F1853C-3C45-428E-B875-310853A91B5E}"/>
+                <a16:creationId xmlns:a16="http://schemas.microsoft.com/office/drawing/2014/main" id="{F381374E-86F6-4B90-97FD-7C64044D6821}"/>
               </a:ext>
             </a:extLst>
           </p:cNvPr>
@@ -23411,7 +23411,7 @@
           <p:cNvPr id="4" name="">
             <a:extLst xmlns:a="http://schemas.openxmlformats.org/drawingml/2006/main">
               <a:ext uri="{FF2B5EF4-FFF2-40B4-BE49-F238E27FC236}">
-                <a16:creationId xmlns:a16="http://schemas.microsoft.com/office/drawing/2014/main" id="{BAA41698-5C05-41C4-857A-4A5AFBDE77C7}"/>
+                <a16:creationId xmlns:a16="http://schemas.microsoft.com/office/drawing/2014/main" id="{188B6260-70A5-4E97-898B-858D6868F38E}"/>
               </a:ext>
             </a:extLst>
           </p:cNvPr>
@@ -23468,7 +23468,7 @@
           <p:cNvPr id="5" name="">
             <a:extLst xmlns:a="http://schemas.openxmlformats.org/drawingml/2006/main">
               <a:ext uri="{FF2B5EF4-FFF2-40B4-BE49-F238E27FC236}">
-                <a16:creationId xmlns:a16="http://schemas.microsoft.com/office/drawing/2014/main" id="{AB79DF8F-96AD-4681-AC1B-70919A616AEB}"/>
+                <a16:creationId xmlns:a16="http://schemas.microsoft.com/office/drawing/2014/main" id="{FE7000D1-020D-47AC-9035-47922671FBE1}"/>
               </a:ext>
             </a:extLst>
           </p:cNvPr>
@@ -23525,7 +23525,7 @@
           <p:cNvPr id="6" name="">
             <a:extLst xmlns:a="http://schemas.openxmlformats.org/drawingml/2006/main">
               <a:ext uri="{FF2B5EF4-FFF2-40B4-BE49-F238E27FC236}">
-                <a16:creationId xmlns:a16="http://schemas.microsoft.com/office/drawing/2014/main" id="{75B297B4-045B-4EC4-8AB4-261B575D3357}"/>
+                <a16:creationId xmlns:a16="http://schemas.microsoft.com/office/drawing/2014/main" id="{9462C24D-2FF5-4262-90E2-763C978BBFB3}"/>
               </a:ext>
             </a:extLst>
           </p:cNvPr>
@@ -23582,7 +23582,7 @@
           <p:cNvPr id="7" name="">
             <a:extLst xmlns:a="http://schemas.openxmlformats.org/drawingml/2006/main">
               <a:ext uri="{FF2B5EF4-FFF2-40B4-BE49-F238E27FC236}">
-                <a16:creationId xmlns:a16="http://schemas.microsoft.com/office/drawing/2014/main" id="{F7A5DCDA-CCEC-47CE-BEDE-17635943CF41}"/>
+                <a16:creationId xmlns:a16="http://schemas.microsoft.com/office/drawing/2014/main" id="{D9B01F4D-D82E-4F95-836C-54A42D1FB22C}"/>
               </a:ext>
             </a:extLst>
           </p:cNvPr>
@@ -23639,7 +23639,7 @@
           <p:cNvPr id="8" name="">
             <a:extLst xmlns:a="http://schemas.openxmlformats.org/drawingml/2006/main">
               <a:ext uri="{FF2B5EF4-FFF2-40B4-BE49-F238E27FC236}">
-                <a16:creationId xmlns:a16="http://schemas.microsoft.com/office/drawing/2014/main" id="{12ED732C-8711-4D16-94E9-374BB8E849D5}"/>
+                <a16:creationId xmlns:a16="http://schemas.microsoft.com/office/drawing/2014/main" id="{69DC54F3-8FF2-487D-8A32-F37B464AADC5}"/>
               </a:ext>
             </a:extLst>
           </p:cNvPr>
@@ -23696,7 +23696,7 @@
           <p:cNvPr id="9" name="">
             <a:extLst xmlns:a="http://schemas.openxmlformats.org/drawingml/2006/main">
               <a:ext uri="{FF2B5EF4-FFF2-40B4-BE49-F238E27FC236}">
-                <a16:creationId xmlns:a16="http://schemas.microsoft.com/office/drawing/2014/main" id="{9A8A0B61-2599-4D71-BADE-79048FE64284}"/>
+                <a16:creationId xmlns:a16="http://schemas.microsoft.com/office/drawing/2014/main" id="{F441ED90-8D93-43DF-B8BF-7ABB9733E7B9}"/>
               </a:ext>
             </a:extLst>
           </p:cNvPr>
@@ -23753,7 +23753,7 @@
           <p:cNvPr id="10" name="">
             <a:extLst xmlns:a="http://schemas.openxmlformats.org/drawingml/2006/main">
               <a:ext uri="{FF2B5EF4-FFF2-40B4-BE49-F238E27FC236}">
-                <a16:creationId xmlns:a16="http://schemas.microsoft.com/office/drawing/2014/main" id="{A97F5B30-2377-465C-A9FF-176511E918A8}"/>
+                <a16:creationId xmlns:a16="http://schemas.microsoft.com/office/drawing/2014/main" id="{2A2CA0D5-EEE4-4A71-88F1-41721800AE40}"/>
               </a:ext>
             </a:extLst>
           </p:cNvPr>
@@ -23784,7 +23784,7 @@
           <p:cNvPr id="11" name="">
             <a:extLst xmlns:a="http://schemas.openxmlformats.org/drawingml/2006/main">
               <a:ext uri="{FF2B5EF4-FFF2-40B4-BE49-F238E27FC236}">
-                <a16:creationId xmlns:a16="http://schemas.microsoft.com/office/drawing/2014/main" id="{73DA3206-8F9F-41E0-83D2-B72EF613712F}"/>
+                <a16:creationId xmlns:a16="http://schemas.microsoft.com/office/drawing/2014/main" id="{947C2AA5-FAD6-4CA7-9863-831775B072A3}"/>
               </a:ext>
             </a:extLst>
           </p:cNvPr>
@@ -23815,7 +23815,7 @@
           <p:cNvPr id="12" name="">
             <a:extLst xmlns:a="http://schemas.openxmlformats.org/drawingml/2006/main">
               <a:ext uri="{FF2B5EF4-FFF2-40B4-BE49-F238E27FC236}">
-                <a16:creationId xmlns:a16="http://schemas.microsoft.com/office/drawing/2014/main" id="{CF122333-B4C7-44E7-B311-87C2F93C8F2D}"/>
+                <a16:creationId xmlns:a16="http://schemas.microsoft.com/office/drawing/2014/main" id="{60BA0080-6805-46D8-9FF2-56B7B2181E07}"/>
               </a:ext>
             </a:extLst>
           </p:cNvPr>
@@ -23848,7 +23848,7 @@
           <p:cNvPr id="13" name="">
             <a:extLst xmlns:a="http://schemas.openxmlformats.org/drawingml/2006/main">
               <a:ext uri="{FF2B5EF4-FFF2-40B4-BE49-F238E27FC236}">
-                <a16:creationId xmlns:a16="http://schemas.microsoft.com/office/drawing/2014/main" id="{A45839A4-DEF0-407B-B163-80EBA30FAF4C}"/>
+                <a16:creationId xmlns:a16="http://schemas.microsoft.com/office/drawing/2014/main" id="{28B575CD-DDA8-4894-8A9D-E10AA8B16DF0}"/>
               </a:ext>
             </a:extLst>
           </p:cNvPr>
@@ -23905,7 +23905,7 @@
           <p:cNvPr id="14" name="">
             <a:extLst xmlns:a="http://schemas.openxmlformats.org/drawingml/2006/main">
               <a:ext uri="{FF2B5EF4-FFF2-40B4-BE49-F238E27FC236}">
-                <a16:creationId xmlns:a16="http://schemas.microsoft.com/office/drawing/2014/main" id="{5E6C6707-CE03-4054-A0E6-03FBF6409961}"/>
+                <a16:creationId xmlns:a16="http://schemas.microsoft.com/office/drawing/2014/main" id="{13900B2C-DB14-4C96-849F-C4E69DE82FAC}"/>
               </a:ext>
             </a:extLst>
           </p:cNvPr>
@@ -23938,7 +23938,7 @@
           <p:cNvPr id="15" name="">
             <a:extLst xmlns:a="http://schemas.openxmlformats.org/drawingml/2006/main">
               <a:ext uri="{FF2B5EF4-FFF2-40B4-BE49-F238E27FC236}">
-                <a16:creationId xmlns:a16="http://schemas.microsoft.com/office/drawing/2014/main" id="{BF236F5E-094A-41FC-9B34-BC6149531EF4}"/>
+                <a16:creationId xmlns:a16="http://schemas.microsoft.com/office/drawing/2014/main" id="{E5C75E00-223B-4C6C-9808-97E2473B1B4E}"/>
               </a:ext>
             </a:extLst>
           </p:cNvPr>
@@ -23971,7 +23971,7 @@
           <p:cNvPr id="16" name="">
             <a:extLst xmlns:a="http://schemas.openxmlformats.org/drawingml/2006/main">
               <a:ext uri="{FF2B5EF4-FFF2-40B4-BE49-F238E27FC236}">
-                <a16:creationId xmlns:a16="http://schemas.microsoft.com/office/drawing/2014/main" id="{A6F2A8F1-FEE1-4336-8082-8077A0DED0A3}"/>
+                <a16:creationId xmlns:a16="http://schemas.microsoft.com/office/drawing/2014/main" id="{E652C72B-78A6-4917-8C1B-A0F782F46903}"/>
               </a:ext>
             </a:extLst>
           </p:cNvPr>
@@ -24004,7 +24004,7 @@
           <p:cNvPr id="17" name="">
             <a:extLst xmlns:a="http://schemas.openxmlformats.org/drawingml/2006/main">
               <a:ext uri="{FF2B5EF4-FFF2-40B4-BE49-F238E27FC236}">
-                <a16:creationId xmlns:a16="http://schemas.microsoft.com/office/drawing/2014/main" id="{AA1FE6EE-EDE3-437B-B414-8C741359132B}"/>
+                <a16:creationId xmlns:a16="http://schemas.microsoft.com/office/drawing/2014/main" id="{61E3F818-C3F5-46CA-9A8E-61F313B2527A}"/>
               </a:ext>
             </a:extLst>
           </p:cNvPr>
@@ -24037,7 +24037,7 @@
           <p:cNvPr id="18" name="">
             <a:extLst xmlns:a="http://schemas.openxmlformats.org/drawingml/2006/main">
               <a:ext uri="{FF2B5EF4-FFF2-40B4-BE49-F238E27FC236}">
-                <a16:creationId xmlns:a16="http://schemas.microsoft.com/office/drawing/2014/main" id="{3B2EF4D2-47F7-43E8-92DE-1338EA2A0FB8}"/>
+                <a16:creationId xmlns:a16="http://schemas.microsoft.com/office/drawing/2014/main" id="{6FD66EFA-6046-4981-BBCE-71A351CBAB26}"/>
               </a:ext>
             </a:extLst>
           </p:cNvPr>
@@ -24070,7 +24070,7 @@
           <p:cNvPr id="19" name="">
             <a:extLst xmlns:a="http://schemas.openxmlformats.org/drawingml/2006/main">
               <a:ext uri="{FF2B5EF4-FFF2-40B4-BE49-F238E27FC236}">
-                <a16:creationId xmlns:a16="http://schemas.microsoft.com/office/drawing/2014/main" id="{58CFB0DA-E268-40E2-A5AB-7D904596480C}"/>
+                <a16:creationId xmlns:a16="http://schemas.microsoft.com/office/drawing/2014/main" id="{6ECC8ECC-1DA0-42E1-9733-CED5FF5CA3B1}"/>
               </a:ext>
             </a:extLst>
           </p:cNvPr>
@@ -24103,7 +24103,7 @@
           <p:cNvPr id="20" name="">
             <a:extLst xmlns:a="http://schemas.openxmlformats.org/drawingml/2006/main">
               <a:ext uri="{FF2B5EF4-FFF2-40B4-BE49-F238E27FC236}">
-                <a16:creationId xmlns:a16="http://schemas.microsoft.com/office/drawing/2014/main" id="{EB86CE3A-FBFF-4A63-A087-ED14E751B85C}"/>
+                <a16:creationId xmlns:a16="http://schemas.microsoft.com/office/drawing/2014/main" id="{E7C7D6A9-A0D1-43E7-904B-C8E884AF078B}"/>
               </a:ext>
             </a:extLst>
           </p:cNvPr>
@@ -24136,7 +24136,7 @@
           <p:cNvPr id="21" name="">
             <a:extLst xmlns:a="http://schemas.openxmlformats.org/drawingml/2006/main">
               <a:ext uri="{FF2B5EF4-FFF2-40B4-BE49-F238E27FC236}">
-                <a16:creationId xmlns:a16="http://schemas.microsoft.com/office/drawing/2014/main" id="{715934ED-E370-4658-BD40-AF2372BBFC3A}"/>
+                <a16:creationId xmlns:a16="http://schemas.microsoft.com/office/drawing/2014/main" id="{BF493414-50D4-4A06-A30A-63FF4AED761E}"/>
               </a:ext>
             </a:extLst>
           </p:cNvPr>
@@ -24169,7 +24169,7 @@
           <p:cNvPr id="22" name="">
             <a:extLst xmlns:a="http://schemas.openxmlformats.org/drawingml/2006/main">
               <a:ext uri="{FF2B5EF4-FFF2-40B4-BE49-F238E27FC236}">
-                <a16:creationId xmlns:a16="http://schemas.microsoft.com/office/drawing/2014/main" id="{8F543FC0-7AE8-4021-B019-9C7FDB28A8CF}"/>
+                <a16:creationId xmlns:a16="http://schemas.microsoft.com/office/drawing/2014/main" id="{D66DBA0D-F608-4735-B96E-C2DE0D00F921}"/>
               </a:ext>
             </a:extLst>
           </p:cNvPr>
@@ -24202,7 +24202,7 @@
           <p:cNvPr id="23" name="">
             <a:extLst xmlns:a="http://schemas.openxmlformats.org/drawingml/2006/main">
               <a:ext uri="{FF2B5EF4-FFF2-40B4-BE49-F238E27FC236}">
-                <a16:creationId xmlns:a16="http://schemas.microsoft.com/office/drawing/2014/main" id="{521986A7-DE86-4214-8A0F-ED723129095A}"/>
+                <a16:creationId xmlns:a16="http://schemas.microsoft.com/office/drawing/2014/main" id="{84E4712E-9639-4056-81BF-B714E2A119BA}"/>
               </a:ext>
             </a:extLst>
           </p:cNvPr>
@@ -24235,7 +24235,7 @@
           <p:cNvPr id="24" name="">
             <a:extLst xmlns:a="http://schemas.openxmlformats.org/drawingml/2006/main">
               <a:ext uri="{FF2B5EF4-FFF2-40B4-BE49-F238E27FC236}">
-                <a16:creationId xmlns:a16="http://schemas.microsoft.com/office/drawing/2014/main" id="{32AD6E00-BFD2-415D-B544-1B8E37CA0D4C}"/>
+                <a16:creationId xmlns:a16="http://schemas.microsoft.com/office/drawing/2014/main" id="{95D701AA-11CA-494E-959D-FA147272EA92}"/>
               </a:ext>
             </a:extLst>
           </p:cNvPr>
@@ -24268,7 +24268,7 @@
           <p:cNvPr id="25" name="">
             <a:extLst xmlns:a="http://schemas.openxmlformats.org/drawingml/2006/main">
               <a:ext uri="{FF2B5EF4-FFF2-40B4-BE49-F238E27FC236}">
-                <a16:creationId xmlns:a16="http://schemas.microsoft.com/office/drawing/2014/main" id="{D61186F7-4CEF-451C-AE71-416E6CB7850B}"/>
+                <a16:creationId xmlns:a16="http://schemas.microsoft.com/office/drawing/2014/main" id="{258001CD-7981-4D3B-BB8E-F1FCC93FE6FC}"/>
               </a:ext>
             </a:extLst>
           </p:cNvPr>
@@ -24299,7 +24299,7 @@
           <p:cNvPr id="26" name="">
             <a:extLst xmlns:a="http://schemas.openxmlformats.org/drawingml/2006/main">
               <a:ext uri="{FF2B5EF4-FFF2-40B4-BE49-F238E27FC236}">
-                <a16:creationId xmlns:a16="http://schemas.microsoft.com/office/drawing/2014/main" id="{93F26FE2-DA95-44AD-915E-FF2C7FA8EA7E}"/>
+                <a16:creationId xmlns:a16="http://schemas.microsoft.com/office/drawing/2014/main" id="{4EE256D2-EF12-4915-8439-71E5629330BD}"/>
               </a:ext>
             </a:extLst>
           </p:cNvPr>
@@ -24356,7 +24356,7 @@
           <p:cNvPr id="27" name="">
             <a:extLst xmlns:a="http://schemas.openxmlformats.org/drawingml/2006/main">
               <a:ext uri="{FF2B5EF4-FFF2-40B4-BE49-F238E27FC236}">
-                <a16:creationId xmlns:a16="http://schemas.microsoft.com/office/drawing/2014/main" id="{1220E110-871F-4B6B-BDE6-1D26F5B87BB6}"/>
+                <a16:creationId xmlns:a16="http://schemas.microsoft.com/office/drawing/2014/main" id="{25620ACA-A9CE-459C-BEEF-3C92BB5026D7}"/>
               </a:ext>
             </a:extLst>
           </p:cNvPr>
@@ -24413,7 +24413,7 @@
           <p:cNvPr id="28" name="">
             <a:extLst xmlns:a="http://schemas.openxmlformats.org/drawingml/2006/main">
               <a:ext uri="{FF2B5EF4-FFF2-40B4-BE49-F238E27FC236}">
-                <a16:creationId xmlns:a16="http://schemas.microsoft.com/office/drawing/2014/main" id="{AB0BCA57-CB6C-4CD7-A0BE-691489C2454C}"/>
+                <a16:creationId xmlns:a16="http://schemas.microsoft.com/office/drawing/2014/main" id="{DF758034-0D6E-4BB4-84F0-63AF5B03C513}"/>
               </a:ext>
             </a:extLst>
           </p:cNvPr>
@@ -24470,7 +24470,7 @@
           <p:cNvPr id="29" name="">
             <a:extLst xmlns:a="http://schemas.openxmlformats.org/drawingml/2006/main">
               <a:ext uri="{FF2B5EF4-FFF2-40B4-BE49-F238E27FC236}">
-                <a16:creationId xmlns:a16="http://schemas.microsoft.com/office/drawing/2014/main" id="{2D79A8EF-4092-4DED-8D4E-2749C9EAF9D7}"/>
+                <a16:creationId xmlns:a16="http://schemas.microsoft.com/office/drawing/2014/main" id="{DDB28A62-6885-402C-9D15-0E98852E225F}"/>
               </a:ext>
             </a:extLst>
           </p:cNvPr>
@@ -24527,7 +24527,7 @@
           <p:cNvPr id="30" name="">
             <a:extLst xmlns:a="http://schemas.openxmlformats.org/drawingml/2006/main">
               <a:ext uri="{FF2B5EF4-FFF2-40B4-BE49-F238E27FC236}">
-                <a16:creationId xmlns:a16="http://schemas.microsoft.com/office/drawing/2014/main" id="{CF0815B7-3A49-4DC9-BBE9-C7D36C3FBAB3}"/>
+                <a16:creationId xmlns:a16="http://schemas.microsoft.com/office/drawing/2014/main" id="{3ECC5CA2-4438-46D9-B14B-88170412DD2E}"/>
               </a:ext>
             </a:extLst>
           </p:cNvPr>
@@ -24584,7 +24584,7 @@
           <p:cNvPr id="31" name="">
             <a:extLst xmlns:a="http://schemas.openxmlformats.org/drawingml/2006/main">
               <a:ext uri="{FF2B5EF4-FFF2-40B4-BE49-F238E27FC236}">
-                <a16:creationId xmlns:a16="http://schemas.microsoft.com/office/drawing/2014/main" id="{9B95E88F-082D-402F-AB4E-BD9EF03F12A8}"/>
+                <a16:creationId xmlns:a16="http://schemas.microsoft.com/office/drawing/2014/main" id="{05EB30CC-049A-4F39-90C6-629C1E49CD7B}"/>
               </a:ext>
             </a:extLst>
           </p:cNvPr>
@@ -24615,7 +24615,7 @@
           <p:cNvPr id="32" name="">
             <a:extLst xmlns:a="http://schemas.openxmlformats.org/drawingml/2006/main">
               <a:ext uri="{FF2B5EF4-FFF2-40B4-BE49-F238E27FC236}">
-                <a16:creationId xmlns:a16="http://schemas.microsoft.com/office/drawing/2014/main" id="{499FA9F1-7FDD-43BC-8D68-CE18D0D913D9}"/>
+                <a16:creationId xmlns:a16="http://schemas.microsoft.com/office/drawing/2014/main" id="{4F1F5D66-F02F-4D85-8528-A48776C02600}"/>
               </a:ext>
             </a:extLst>
           </p:cNvPr>
@@ -24672,7 +24672,7 @@
           <p:cNvPr id="33" name="">
             <a:extLst xmlns:a="http://schemas.openxmlformats.org/drawingml/2006/main">
               <a:ext uri="{FF2B5EF4-FFF2-40B4-BE49-F238E27FC236}">
-                <a16:creationId xmlns:a16="http://schemas.microsoft.com/office/drawing/2014/main" id="{73430D57-2564-4EA2-93B1-7843737D4362}"/>
+                <a16:creationId xmlns:a16="http://schemas.microsoft.com/office/drawing/2014/main" id="{1CE64F8D-A6C1-4D42-BA02-E446F235CF4B}"/>
               </a:ext>
             </a:extLst>
           </p:cNvPr>
@@ -24729,7 +24729,7 @@
           <p:cNvPr id="34" name="">
             <a:extLst xmlns:a="http://schemas.openxmlformats.org/drawingml/2006/main">
               <a:ext uri="{FF2B5EF4-FFF2-40B4-BE49-F238E27FC236}">
-                <a16:creationId xmlns:a16="http://schemas.microsoft.com/office/drawing/2014/main" id="{4DEFA286-44C8-4A6D-90C7-96BC457CF790}"/>
+                <a16:creationId xmlns:a16="http://schemas.microsoft.com/office/drawing/2014/main" id="{9D82AE88-E87F-4C10-AC75-9A86A8E8E66C}"/>
               </a:ext>
             </a:extLst>
           </p:cNvPr>
@@ -24784,7 +24784,7 @@
     </p:spTree>
     <p:extLst>
       <p:ext uri="{BB962C8B-B14F-4D97-AF65-F5344CB8AC3E}">
-        <p14:creationId xmlns:p14="http://schemas.microsoft.com/office/powerpoint/2010/main" val="930535152"/>
+        <p14:creationId xmlns:p14="http://schemas.microsoft.com/office/powerpoint/2010/main" val="817873464"/>
       </p:ext>
     </p:extLst>
   </p:cSld>
@@ -24815,7 +24815,7 @@
           <p:cNvPr id="48" name="">
             <a:extLst xmlns:a="http://schemas.openxmlformats.org/drawingml/2006/main">
               <a:ext uri="{FF2B5EF4-FFF2-40B4-BE49-F238E27FC236}">
-                <a16:creationId xmlns:a16="http://schemas.microsoft.com/office/drawing/2014/main" id="{D5F694A8-A28D-41F5-B034-521D4D3DD0AF}"/>
+                <a16:creationId xmlns:a16="http://schemas.microsoft.com/office/drawing/2014/main" id="{5939B287-0FB8-4E1A-9FAD-97B7CE3A9569}"/>
               </a:ext>
             </a:extLst>
           </p:cNvPr>
@@ -24872,7 +24872,7 @@
           <p:cNvPr id="2" name="">
             <a:extLst xmlns:a="http://schemas.openxmlformats.org/drawingml/2006/main">
               <a:ext uri="{FF2B5EF4-FFF2-40B4-BE49-F238E27FC236}">
-                <a16:creationId xmlns:a16="http://schemas.microsoft.com/office/drawing/2014/main" id="{257978D0-F993-49E6-98E4-59E7348A39F2}"/>
+                <a16:creationId xmlns:a16="http://schemas.microsoft.com/office/drawing/2014/main" id="{65824768-EF90-4E0D-B067-D1E54866C09D}"/>
               </a:ext>
             </a:extLst>
           </p:cNvPr>
@@ -24903,7 +24903,7 @@
           <p:cNvPr id="3" name="">
             <a:extLst xmlns:a="http://schemas.openxmlformats.org/drawingml/2006/main">
               <a:ext uri="{FF2B5EF4-FFF2-40B4-BE49-F238E27FC236}">
-                <a16:creationId xmlns:a16="http://schemas.microsoft.com/office/drawing/2014/main" id="{487F79C7-CFA8-4A2F-93FF-FE24E608C8CF}"/>
+                <a16:creationId xmlns:a16="http://schemas.microsoft.com/office/drawing/2014/main" id="{C56E9A98-C693-4F91-98D3-05FBE72DCADA}"/>
               </a:ext>
             </a:extLst>
           </p:cNvPr>
@@ -24960,7 +24960,7 @@
           <p:cNvPr id="4" name="">
             <a:extLst xmlns:a="http://schemas.openxmlformats.org/drawingml/2006/main">
               <a:ext uri="{FF2B5EF4-FFF2-40B4-BE49-F238E27FC236}">
-                <a16:creationId xmlns:a16="http://schemas.microsoft.com/office/drawing/2014/main" id="{38BB9403-BA78-4F91-AE86-EFFD7EF13D33}"/>
+                <a16:creationId xmlns:a16="http://schemas.microsoft.com/office/drawing/2014/main" id="{8FD9B005-14A4-487F-ACAE-C14AACB42DE7}"/>
               </a:ext>
             </a:extLst>
           </p:cNvPr>
@@ -25017,7 +25017,7 @@
           <p:cNvPr id="5" name="">
             <a:extLst xmlns:a="http://schemas.openxmlformats.org/drawingml/2006/main">
               <a:ext uri="{FF2B5EF4-FFF2-40B4-BE49-F238E27FC236}">
-                <a16:creationId xmlns:a16="http://schemas.microsoft.com/office/drawing/2014/main" id="{F9D6DF0F-3AE9-4E1D-9D86-8464FC4FA769}"/>
+                <a16:creationId xmlns:a16="http://schemas.microsoft.com/office/drawing/2014/main" id="{465D7A82-A74B-451C-AF7F-584114579843}"/>
               </a:ext>
             </a:extLst>
           </p:cNvPr>
@@ -25048,7 +25048,7 @@
           <p:cNvPr id="6" name="">
             <a:extLst xmlns:a="http://schemas.openxmlformats.org/drawingml/2006/main">
               <a:ext uri="{FF2B5EF4-FFF2-40B4-BE49-F238E27FC236}">
-                <a16:creationId xmlns:a16="http://schemas.microsoft.com/office/drawing/2014/main" id="{7051A8E8-A248-41A5-B7C9-0609E54D3ED6}"/>
+                <a16:creationId xmlns:a16="http://schemas.microsoft.com/office/drawing/2014/main" id="{1DAAA55E-14F2-47E8-83C6-E70EC702A96D}"/>
               </a:ext>
             </a:extLst>
           </p:cNvPr>
@@ -25105,7 +25105,7 @@
           <p:cNvPr id="7" name="">
             <a:extLst xmlns:a="http://schemas.openxmlformats.org/drawingml/2006/main">
               <a:ext uri="{FF2B5EF4-FFF2-40B4-BE49-F238E27FC236}">
-                <a16:creationId xmlns:a16="http://schemas.microsoft.com/office/drawing/2014/main" id="{186C389A-B9BF-4B1E-9FDE-44F13E2E7F98}"/>
+                <a16:creationId xmlns:a16="http://schemas.microsoft.com/office/drawing/2014/main" id="{898B544E-F918-4619-8F64-5673D92B36FB}"/>
               </a:ext>
             </a:extLst>
           </p:cNvPr>
@@ -25138,7 +25138,7 @@
           <p:cNvPr id="8" name="">
             <a:extLst xmlns:a="http://schemas.openxmlformats.org/drawingml/2006/main">
               <a:ext uri="{FF2B5EF4-FFF2-40B4-BE49-F238E27FC236}">
-                <a16:creationId xmlns:a16="http://schemas.microsoft.com/office/drawing/2014/main" id="{6B8E3604-8302-441E-986E-AE0C301EE144}"/>
+                <a16:creationId xmlns:a16="http://schemas.microsoft.com/office/drawing/2014/main" id="{59E1B5C6-7609-4371-A954-288472ECC743}"/>
               </a:ext>
             </a:extLst>
           </p:cNvPr>
@@ -25195,7 +25195,7 @@
           <p:cNvPr id="9" name="">
             <a:extLst xmlns:a="http://schemas.openxmlformats.org/drawingml/2006/main">
               <a:ext uri="{FF2B5EF4-FFF2-40B4-BE49-F238E27FC236}">
-                <a16:creationId xmlns:a16="http://schemas.microsoft.com/office/drawing/2014/main" id="{E8C8485F-EE68-4274-ACA1-548AAABA2B08}"/>
+                <a16:creationId xmlns:a16="http://schemas.microsoft.com/office/drawing/2014/main" id="{BFEB3A64-E4D9-4D1C-A07B-55157CE716FC}"/>
               </a:ext>
             </a:extLst>
           </p:cNvPr>
@@ -25228,7 +25228,7 @@
           <p:cNvPr id="10" name="">
             <a:extLst xmlns:a="http://schemas.openxmlformats.org/drawingml/2006/main">
               <a:ext uri="{FF2B5EF4-FFF2-40B4-BE49-F238E27FC236}">
-                <a16:creationId xmlns:a16="http://schemas.microsoft.com/office/drawing/2014/main" id="{DC408715-27BB-4527-BB1B-47B9AEE4DFEF}"/>
+                <a16:creationId xmlns:a16="http://schemas.microsoft.com/office/drawing/2014/main" id="{5C9FD154-2851-4B03-8DDD-CFE5365B60B1}"/>
               </a:ext>
             </a:extLst>
           </p:cNvPr>
@@ -25311,7 +25311,7 @@
           <p:cNvPr id="12" name="">
             <a:extLst xmlns:a="http://schemas.openxmlformats.org/drawingml/2006/main">
               <a:ext uri="{FF2B5EF4-FFF2-40B4-BE49-F238E27FC236}">
-                <a16:creationId xmlns:a16="http://schemas.microsoft.com/office/drawing/2014/main" id="{A9CBA1C0-C888-4AE4-BF62-281DA60CBEEB}"/>
+                <a16:creationId xmlns:a16="http://schemas.microsoft.com/office/drawing/2014/main" id="{39383CDC-61C7-49D8-B77F-87487F497A7E}"/>
               </a:ext>
             </a:extLst>
           </p:cNvPr>
@@ -25391,7 +25391,7 @@
           <p:cNvPr id="13" name="">
             <a:extLst xmlns:a="http://schemas.openxmlformats.org/drawingml/2006/main">
               <a:ext uri="{FF2B5EF4-FFF2-40B4-BE49-F238E27FC236}">
-                <a16:creationId xmlns:a16="http://schemas.microsoft.com/office/drawing/2014/main" id="{FB00DBB3-E694-4B4C-B38C-0AB165C70954}"/>
+                <a16:creationId xmlns:a16="http://schemas.microsoft.com/office/drawing/2014/main" id="{BD51B563-C937-40FF-96A6-5242F05AC7F8}"/>
               </a:ext>
             </a:extLst>
           </p:cNvPr>
@@ -25471,7 +25471,7 @@
           <p:cNvPr id="14" name="">
             <a:extLst xmlns:a="http://schemas.openxmlformats.org/drawingml/2006/main">
               <a:ext uri="{FF2B5EF4-FFF2-40B4-BE49-F238E27FC236}">
-                <a16:creationId xmlns:a16="http://schemas.microsoft.com/office/drawing/2014/main" id="{83352352-E6B4-41C1-927E-643EFC5D88DB}"/>
+                <a16:creationId xmlns:a16="http://schemas.microsoft.com/office/drawing/2014/main" id="{8751F765-D7FA-4411-B828-11EB6C316B1B}"/>
               </a:ext>
             </a:extLst>
           </p:cNvPr>
@@ -25528,7 +25528,7 @@
           <p:cNvPr id="15" name="">
             <a:extLst xmlns:a="http://schemas.openxmlformats.org/drawingml/2006/main">
               <a:ext uri="{FF2B5EF4-FFF2-40B4-BE49-F238E27FC236}">
-                <a16:creationId xmlns:a16="http://schemas.microsoft.com/office/drawing/2014/main" id="{2FF30CC1-3B22-4AFE-B0E1-B8B8FE2F524D}"/>
+                <a16:creationId xmlns:a16="http://schemas.microsoft.com/office/drawing/2014/main" id="{A2728B11-D4EF-477C-9A28-56B7A8C29CEF}"/>
               </a:ext>
             </a:extLst>
           </p:cNvPr>
@@ -25559,7 +25559,7 @@
           <p:cNvPr id="16" name="">
             <a:extLst xmlns:a="http://schemas.openxmlformats.org/drawingml/2006/main">
               <a:ext uri="{FF2B5EF4-FFF2-40B4-BE49-F238E27FC236}">
-                <a16:creationId xmlns:a16="http://schemas.microsoft.com/office/drawing/2014/main" id="{976ECC8F-88D4-42E3-B053-0B8D15931B77}"/>
+                <a16:creationId xmlns:a16="http://schemas.microsoft.com/office/drawing/2014/main" id="{DBB6236D-581C-419A-BF66-582117652E52}"/>
               </a:ext>
             </a:extLst>
           </p:cNvPr>
@@ -25590,7 +25590,7 @@
           <p:cNvPr id="17" name="">
             <a:extLst xmlns:a="http://schemas.openxmlformats.org/drawingml/2006/main">
               <a:ext uri="{FF2B5EF4-FFF2-40B4-BE49-F238E27FC236}">
-                <a16:creationId xmlns:a16="http://schemas.microsoft.com/office/drawing/2014/main" id="{C8BC3891-831C-4E5A-B7D6-B5555F811AC8}"/>
+                <a16:creationId xmlns:a16="http://schemas.microsoft.com/office/drawing/2014/main" id="{5532A6D3-AACA-448A-AF07-A31A0C4BCA88}"/>
               </a:ext>
             </a:extLst>
           </p:cNvPr>
@@ -25621,7 +25621,7 @@
           <p:cNvPr id="18" name="">
             <a:extLst xmlns:a="http://schemas.openxmlformats.org/drawingml/2006/main">
               <a:ext uri="{FF2B5EF4-FFF2-40B4-BE49-F238E27FC236}">
-                <a16:creationId xmlns:a16="http://schemas.microsoft.com/office/drawing/2014/main" id="{28BDB4F5-3587-480E-A20A-254CE43F4ABA}"/>
+                <a16:creationId xmlns:a16="http://schemas.microsoft.com/office/drawing/2014/main" id="{ECF90EB9-5E10-4081-82A1-90C14541BAE1}"/>
               </a:ext>
             </a:extLst>
           </p:cNvPr>
@@ -25652,7 +25652,7 @@
           <p:cNvPr id="19" name="">
             <a:extLst xmlns:a="http://schemas.openxmlformats.org/drawingml/2006/main">
               <a:ext uri="{FF2B5EF4-FFF2-40B4-BE49-F238E27FC236}">
-                <a16:creationId xmlns:a16="http://schemas.microsoft.com/office/drawing/2014/main" id="{3C69B873-D463-480A-9327-E5CBED007D89}"/>
+                <a16:creationId xmlns:a16="http://schemas.microsoft.com/office/drawing/2014/main" id="{B3293427-09FF-4A07-B457-2D24C588BFAA}"/>
               </a:ext>
             </a:extLst>
           </p:cNvPr>
@@ -25683,7 +25683,7 @@
           <p:cNvPr id="20" name="">
             <a:extLst xmlns:a="http://schemas.openxmlformats.org/drawingml/2006/main">
               <a:ext uri="{FF2B5EF4-FFF2-40B4-BE49-F238E27FC236}">
-                <a16:creationId xmlns:a16="http://schemas.microsoft.com/office/drawing/2014/main" id="{0E6D1022-5557-450C-8D50-749DDA256047}"/>
+                <a16:creationId xmlns:a16="http://schemas.microsoft.com/office/drawing/2014/main" id="{98FB931C-61BF-4B27-8288-AB3521EA84AC}"/>
               </a:ext>
             </a:extLst>
           </p:cNvPr>
@@ -25714,7 +25714,7 @@
           <p:cNvPr id="21" name="">
             <a:extLst xmlns:a="http://schemas.openxmlformats.org/drawingml/2006/main">
               <a:ext uri="{FF2B5EF4-FFF2-40B4-BE49-F238E27FC236}">
-                <a16:creationId xmlns:a16="http://schemas.microsoft.com/office/drawing/2014/main" id="{B83E896D-E76B-4C82-A5F1-1DDAC9C41018}"/>
+                <a16:creationId xmlns:a16="http://schemas.microsoft.com/office/drawing/2014/main" id="{1CFD42FC-447D-4FB5-B773-5A654F2C46A8}"/>
               </a:ext>
             </a:extLst>
           </p:cNvPr>
@@ -25745,7 +25745,7 @@
           <p:cNvPr id="22" name="">
             <a:extLst xmlns:a="http://schemas.openxmlformats.org/drawingml/2006/main">
               <a:ext uri="{FF2B5EF4-FFF2-40B4-BE49-F238E27FC236}">
-                <a16:creationId xmlns:a16="http://schemas.microsoft.com/office/drawing/2014/main" id="{EEFFDB33-82F1-459A-A286-6CC400C4CA21}"/>
+                <a16:creationId xmlns:a16="http://schemas.microsoft.com/office/drawing/2014/main" id="{94E4500A-2524-417D-BEDD-DDA01BCEF3DA}"/>
               </a:ext>
             </a:extLst>
           </p:cNvPr>
@@ -25776,7 +25776,7 @@
           <p:cNvPr id="23" name="">
             <a:extLst xmlns:a="http://schemas.openxmlformats.org/drawingml/2006/main">
               <a:ext uri="{FF2B5EF4-FFF2-40B4-BE49-F238E27FC236}">
-                <a16:creationId xmlns:a16="http://schemas.microsoft.com/office/drawing/2014/main" id="{63849801-77F3-4612-9AE7-A44FEFA09469}"/>
+                <a16:creationId xmlns:a16="http://schemas.microsoft.com/office/drawing/2014/main" id="{190B42A7-6E2D-4159-9477-647C68871EDB}"/>
               </a:ext>
             </a:extLst>
           </p:cNvPr>
@@ -25807,7 +25807,7 @@
           <p:cNvPr id="24" name="">
             <a:extLst xmlns:a="http://schemas.openxmlformats.org/drawingml/2006/main">
               <a:ext uri="{FF2B5EF4-FFF2-40B4-BE49-F238E27FC236}">
-                <a16:creationId xmlns:a16="http://schemas.microsoft.com/office/drawing/2014/main" id="{6AE134A8-27EC-4237-AB21-7586F239207E}"/>
+                <a16:creationId xmlns:a16="http://schemas.microsoft.com/office/drawing/2014/main" id="{8156588D-6E12-4629-AFB1-FA7B60A203B1}"/>
               </a:ext>
             </a:extLst>
           </p:cNvPr>
@@ -25838,7 +25838,7 @@
           <p:cNvPr id="25" name="">
             <a:extLst xmlns:a="http://schemas.openxmlformats.org/drawingml/2006/main">
               <a:ext uri="{FF2B5EF4-FFF2-40B4-BE49-F238E27FC236}">
-                <a16:creationId xmlns:a16="http://schemas.microsoft.com/office/drawing/2014/main" id="{A79A763A-4025-4A4A-978C-85D5FC843736}"/>
+                <a16:creationId xmlns:a16="http://schemas.microsoft.com/office/drawing/2014/main" id="{A43B04F3-B825-4AD1-8D75-410F2BA2A998}"/>
               </a:ext>
             </a:extLst>
           </p:cNvPr>
@@ -25869,7 +25869,7 @@
           <p:cNvPr id="26" name="">
             <a:extLst xmlns:a="http://schemas.openxmlformats.org/drawingml/2006/main">
               <a:ext uri="{FF2B5EF4-FFF2-40B4-BE49-F238E27FC236}">
-                <a16:creationId xmlns:a16="http://schemas.microsoft.com/office/drawing/2014/main" id="{A4D33E00-3C39-4AED-9A0D-A4EFC453123B}"/>
+                <a16:creationId xmlns:a16="http://schemas.microsoft.com/office/drawing/2014/main" id="{EDEE5549-85CC-49FE-A319-C154EF8D8752}"/>
               </a:ext>
             </a:extLst>
           </p:cNvPr>
@@ -25900,7 +25900,7 @@
           <p:cNvPr id="27" name="">
             <a:extLst xmlns:a="http://schemas.openxmlformats.org/drawingml/2006/main">
               <a:ext uri="{FF2B5EF4-FFF2-40B4-BE49-F238E27FC236}">
-                <a16:creationId xmlns:a16="http://schemas.microsoft.com/office/drawing/2014/main" id="{100E93F1-C8DB-4C55-9E29-433A83ED5D1C}"/>
+                <a16:creationId xmlns:a16="http://schemas.microsoft.com/office/drawing/2014/main" id="{D50F0290-1552-4620-B33C-76B4C4F82E53}"/>
               </a:ext>
             </a:extLst>
           </p:cNvPr>
@@ -25931,7 +25931,7 @@
           <p:cNvPr id="28" name="">
             <a:extLst xmlns:a="http://schemas.openxmlformats.org/drawingml/2006/main">
               <a:ext uri="{FF2B5EF4-FFF2-40B4-BE49-F238E27FC236}">
-                <a16:creationId xmlns:a16="http://schemas.microsoft.com/office/drawing/2014/main" id="{B6ED9DB6-B2A3-46AA-8878-67FD4F68B77E}"/>
+                <a16:creationId xmlns:a16="http://schemas.microsoft.com/office/drawing/2014/main" id="{F4865582-AEE7-4758-B81F-4D377215F019}"/>
               </a:ext>
             </a:extLst>
           </p:cNvPr>
@@ -25980,7 +25980,7 @@
           <p:cNvPr id="29" name="">
             <a:extLst xmlns:a="http://schemas.openxmlformats.org/drawingml/2006/main">
               <a:ext uri="{FF2B5EF4-FFF2-40B4-BE49-F238E27FC236}">
-                <a16:creationId xmlns:a16="http://schemas.microsoft.com/office/drawing/2014/main" id="{190E0B33-F6C9-4463-8699-7FEA0905EB4B}"/>
+                <a16:creationId xmlns:a16="http://schemas.microsoft.com/office/drawing/2014/main" id="{62C158CA-C5D0-4543-9D5F-149CA1B63ED8}"/>
               </a:ext>
             </a:extLst>
           </p:cNvPr>
@@ -26029,7 +26029,7 @@
           <p:cNvPr id="30" name="">
             <a:extLst xmlns:a="http://schemas.openxmlformats.org/drawingml/2006/main">
               <a:ext uri="{FF2B5EF4-FFF2-40B4-BE49-F238E27FC236}">
-                <a16:creationId xmlns:a16="http://schemas.microsoft.com/office/drawing/2014/main" id="{1390748E-1BBA-4B9A-9294-3042F0F3EF1E}"/>
+                <a16:creationId xmlns:a16="http://schemas.microsoft.com/office/drawing/2014/main" id="{B80C16CD-CF22-4572-9697-F0DF484E4C9E}"/>
               </a:ext>
             </a:extLst>
           </p:cNvPr>
@@ -26086,7 +26086,7 @@
           <p:cNvPr id="31" name="">
             <a:extLst xmlns:a="http://schemas.openxmlformats.org/drawingml/2006/main">
               <a:ext uri="{FF2B5EF4-FFF2-40B4-BE49-F238E27FC236}">
-                <a16:creationId xmlns:a16="http://schemas.microsoft.com/office/drawing/2014/main" id="{ECF9FF27-E890-459C-B446-8BA7ED8D43C8}"/>
+                <a16:creationId xmlns:a16="http://schemas.microsoft.com/office/drawing/2014/main" id="{8F684C34-D66D-467B-95C9-5F2036151A66}"/>
               </a:ext>
             </a:extLst>
           </p:cNvPr>
@@ -26143,7 +26143,7 @@
           <p:cNvPr id="32" name="">
             <a:extLst xmlns:a="http://schemas.openxmlformats.org/drawingml/2006/main">
               <a:ext uri="{FF2B5EF4-FFF2-40B4-BE49-F238E27FC236}">
-                <a16:creationId xmlns:a16="http://schemas.microsoft.com/office/drawing/2014/main" id="{3AFE36B5-C67C-4063-A4E2-427E2F692643}"/>
+                <a16:creationId xmlns:a16="http://schemas.microsoft.com/office/drawing/2014/main" id="{971B8301-029D-46B5-A1F5-7F693D8DAA50}"/>
               </a:ext>
             </a:extLst>
           </p:cNvPr>
@@ -26200,7 +26200,7 @@
           <p:cNvPr id="33" name="">
             <a:extLst xmlns:a="http://schemas.openxmlformats.org/drawingml/2006/main">
               <a:ext uri="{FF2B5EF4-FFF2-40B4-BE49-F238E27FC236}">
-                <a16:creationId xmlns:a16="http://schemas.microsoft.com/office/drawing/2014/main" id="{391945C4-8261-4A0D-B0AF-52C1B3FCB320}"/>
+                <a16:creationId xmlns:a16="http://schemas.microsoft.com/office/drawing/2014/main" id="{81A27F6B-6675-4907-9925-54F9E0F87ACF}"/>
               </a:ext>
             </a:extLst>
           </p:cNvPr>
@@ -26257,7 +26257,7 @@
           <p:cNvPr id="34" name="">
             <a:extLst xmlns:a="http://schemas.openxmlformats.org/drawingml/2006/main">
               <a:ext uri="{FF2B5EF4-FFF2-40B4-BE49-F238E27FC236}">
-                <a16:creationId xmlns:a16="http://schemas.microsoft.com/office/drawing/2014/main" id="{FA46776F-A605-48B3-BC40-B7CBB2CA5C0A}"/>
+                <a16:creationId xmlns:a16="http://schemas.microsoft.com/office/drawing/2014/main" id="{50FF9436-FBC2-4628-A054-321F8DD450E7}"/>
               </a:ext>
             </a:extLst>
           </p:cNvPr>
@@ -26290,7 +26290,7 @@
           <p:cNvPr id="35" name="">
             <a:extLst xmlns:a="http://schemas.openxmlformats.org/drawingml/2006/main">
               <a:ext uri="{FF2B5EF4-FFF2-40B4-BE49-F238E27FC236}">
-                <a16:creationId xmlns:a16="http://schemas.microsoft.com/office/drawing/2014/main" id="{844844D3-E6D4-4DEE-98EF-D2A111A5DEC5}"/>
+                <a16:creationId xmlns:a16="http://schemas.microsoft.com/office/drawing/2014/main" id="{155626A5-502A-46F8-8692-782DADABFB13}"/>
               </a:ext>
             </a:extLst>
           </p:cNvPr>
@@ -26347,7 +26347,7 @@
           <p:cNvPr id="36" name="">
             <a:extLst xmlns:a="http://schemas.openxmlformats.org/drawingml/2006/main">
               <a:ext uri="{FF2B5EF4-FFF2-40B4-BE49-F238E27FC236}">
-                <a16:creationId xmlns:a16="http://schemas.microsoft.com/office/drawing/2014/main" id="{7D0AFE65-C5AC-43DD-A988-41E0662B42AE}"/>
+                <a16:creationId xmlns:a16="http://schemas.microsoft.com/office/drawing/2014/main" id="{E248E694-EDC9-456B-8E86-A77A30AE0576}"/>
               </a:ext>
             </a:extLst>
           </p:cNvPr>
@@ -26404,7 +26404,7 @@
           <p:cNvPr id="37" name="">
             <a:extLst xmlns:a="http://schemas.openxmlformats.org/drawingml/2006/main">
               <a:ext uri="{FF2B5EF4-FFF2-40B4-BE49-F238E27FC236}">
-                <a16:creationId xmlns:a16="http://schemas.microsoft.com/office/drawing/2014/main" id="{6685AAF3-3EB4-4106-94C4-1F064B5FFC53}"/>
+                <a16:creationId xmlns:a16="http://schemas.microsoft.com/office/drawing/2014/main" id="{A3065723-D48D-4BBC-8AA6-BB6E93F96960}"/>
               </a:ext>
             </a:extLst>
           </p:cNvPr>
@@ -26461,7 +26461,7 @@
           <p:cNvPr id="38" name="">
             <a:extLst xmlns:a="http://schemas.openxmlformats.org/drawingml/2006/main">
               <a:ext uri="{FF2B5EF4-FFF2-40B4-BE49-F238E27FC236}">
-                <a16:creationId xmlns:a16="http://schemas.microsoft.com/office/drawing/2014/main" id="{796FD458-C1B8-45FD-B684-748A88A931AB}"/>
+                <a16:creationId xmlns:a16="http://schemas.microsoft.com/office/drawing/2014/main" id="{8835EB36-7314-42CB-BEE4-6F265E858492}"/>
               </a:ext>
             </a:extLst>
           </p:cNvPr>
@@ -26492,7 +26492,7 @@
           <p:cNvPr id="39" name="">
             <a:extLst xmlns:a="http://schemas.openxmlformats.org/drawingml/2006/main">
               <a:ext uri="{FF2B5EF4-FFF2-40B4-BE49-F238E27FC236}">
-                <a16:creationId xmlns:a16="http://schemas.microsoft.com/office/drawing/2014/main" id="{56CF267C-21F1-47E9-A54D-E9324E6A0F38}"/>
+                <a16:creationId xmlns:a16="http://schemas.microsoft.com/office/drawing/2014/main" id="{338F2E69-5005-452F-961E-D128440CCFA4}"/>
               </a:ext>
             </a:extLst>
           </p:cNvPr>
@@ -26549,7 +26549,7 @@
           <p:cNvPr id="40" name="">
             <a:extLst xmlns:a="http://schemas.openxmlformats.org/drawingml/2006/main">
               <a:ext uri="{FF2B5EF4-FFF2-40B4-BE49-F238E27FC236}">
-                <a16:creationId xmlns:a16="http://schemas.microsoft.com/office/drawing/2014/main" id="{F820BDF2-4405-442C-A821-A2CEF685ECDE}"/>
+                <a16:creationId xmlns:a16="http://schemas.microsoft.com/office/drawing/2014/main" id="{D4A0339D-4A52-4382-8F13-0A7487B7D09D}"/>
               </a:ext>
             </a:extLst>
           </p:cNvPr>
@@ -26606,7 +26606,7 @@
           <p:cNvPr id="41" name="">
             <a:extLst xmlns:a="http://schemas.openxmlformats.org/drawingml/2006/main">
               <a:ext uri="{FF2B5EF4-FFF2-40B4-BE49-F238E27FC236}">
-                <a16:creationId xmlns:a16="http://schemas.microsoft.com/office/drawing/2014/main" id="{2B819BA9-1CD8-4B3D-A433-1D69A49A8DFC}"/>
+                <a16:creationId xmlns:a16="http://schemas.microsoft.com/office/drawing/2014/main" id="{5FD3E569-850B-4269-8B27-A592935B86CD}"/>
               </a:ext>
             </a:extLst>
           </p:cNvPr>
@@ -26663,7 +26663,7 @@
           <p:cNvPr id="42" name="">
             <a:extLst xmlns:a="http://schemas.openxmlformats.org/drawingml/2006/main">
               <a:ext uri="{FF2B5EF4-FFF2-40B4-BE49-F238E27FC236}">
-                <a16:creationId xmlns:a16="http://schemas.microsoft.com/office/drawing/2014/main" id="{0FB64753-0A6D-463F-9F72-4A32B4FBC929}"/>
+                <a16:creationId xmlns:a16="http://schemas.microsoft.com/office/drawing/2014/main" id="{58E4151A-2BE4-40C4-A33D-F17D2F6DC7EC}"/>
               </a:ext>
             </a:extLst>
           </p:cNvPr>
@@ -26720,7 +26720,7 @@
           <p:cNvPr id="43" name="">
             <a:extLst xmlns:a="http://schemas.openxmlformats.org/drawingml/2006/main">
               <a:ext uri="{FF2B5EF4-FFF2-40B4-BE49-F238E27FC236}">
-                <a16:creationId xmlns:a16="http://schemas.microsoft.com/office/drawing/2014/main" id="{3D4B74B6-DC3E-4CB9-8DD4-432D3B008D6B}"/>
+                <a16:creationId xmlns:a16="http://schemas.microsoft.com/office/drawing/2014/main" id="{7C2C9416-B1CA-4484-976C-666EEBC2B006}"/>
               </a:ext>
             </a:extLst>
           </p:cNvPr>
@@ -26777,7 +26777,7 @@
           <p:cNvPr id="44" name="">
             <a:extLst xmlns:a="http://schemas.openxmlformats.org/drawingml/2006/main">
               <a:ext uri="{FF2B5EF4-FFF2-40B4-BE49-F238E27FC236}">
-                <a16:creationId xmlns:a16="http://schemas.microsoft.com/office/drawing/2014/main" id="{14A24E84-9F93-406C-A57F-7F2C67525D87}"/>
+                <a16:creationId xmlns:a16="http://schemas.microsoft.com/office/drawing/2014/main" id="{25602458-D6E1-4EC1-95C3-25C5F548841D}"/>
               </a:ext>
             </a:extLst>
           </p:cNvPr>
@@ -26834,7 +26834,7 @@
           <p:cNvPr id="45" name="">
             <a:extLst xmlns:a="http://schemas.openxmlformats.org/drawingml/2006/main">
               <a:ext uri="{FF2B5EF4-FFF2-40B4-BE49-F238E27FC236}">
-                <a16:creationId xmlns:a16="http://schemas.microsoft.com/office/drawing/2014/main" id="{0A2C3C5C-D40E-4BC2-BC25-B5040C524CD7}"/>
+                <a16:creationId xmlns:a16="http://schemas.microsoft.com/office/drawing/2014/main" id="{042E555E-82DB-4D49-A627-502B13BA4679}"/>
               </a:ext>
             </a:extLst>
           </p:cNvPr>
@@ -26891,7 +26891,7 @@
           <p:cNvPr id="46" name="">
             <a:extLst xmlns:a="http://schemas.openxmlformats.org/drawingml/2006/main">
               <a:ext uri="{FF2B5EF4-FFF2-40B4-BE49-F238E27FC236}">
-                <a16:creationId xmlns:a16="http://schemas.microsoft.com/office/drawing/2014/main" id="{D688B8F6-16B0-42DF-839C-6FBB46356EBB}"/>
+                <a16:creationId xmlns:a16="http://schemas.microsoft.com/office/drawing/2014/main" id="{797EC70B-3AAA-4994-924F-F2CE9E190018}"/>
               </a:ext>
             </a:extLst>
           </p:cNvPr>
@@ -26948,7 +26948,7 @@
           <p:cNvPr id="47" name="">
             <a:extLst xmlns:a="http://schemas.openxmlformats.org/drawingml/2006/main">
               <a:ext uri="{FF2B5EF4-FFF2-40B4-BE49-F238E27FC236}">
-                <a16:creationId xmlns:a16="http://schemas.microsoft.com/office/drawing/2014/main" id="{CCFF2A6E-72C5-4541-A932-FE11B7691E6F}"/>
+                <a16:creationId xmlns:a16="http://schemas.microsoft.com/office/drawing/2014/main" id="{7E493955-1037-464B-B293-BF26CD0E2047}"/>
               </a:ext>
             </a:extLst>
           </p:cNvPr>
@@ -27003,7 +27003,7 @@
     </p:spTree>
     <p:extLst>
       <p:ext uri="{BB962C8B-B14F-4D97-AF65-F5344CB8AC3E}">
-        <p14:creationId xmlns:p14="http://schemas.microsoft.com/office/powerpoint/2010/main" val="50298906"/>
+        <p14:creationId xmlns:p14="http://schemas.microsoft.com/office/powerpoint/2010/main" val="728035954"/>
       </p:ext>
     </p:extLst>
   </p:cSld>

</xml_diff>

<commit_message>
fix(presentation): clarify DORA shares and isolate finalizer staging
</commit_message>
<xml_diff>
--- a/assets/presentations/pmday-2026/ai-changes-both-sides.pptx
+++ b/assets/presentations/pmday-2026/ai-changes-both-sides.pptx
@@ -2,27 +2,27 @@
 <file path=ppt/presentation.xml><?xml version="1.0" encoding="utf-8"?>
 <p:presentation xmlns:p="http://schemas.openxmlformats.org/presentationml/2006/main">
   <p:sldMasterIdLst>
-    <p:sldMasterId xmlns:r="http://schemas.openxmlformats.org/officeDocument/2006/relationships" id="2147483648" r:id="R57252dacefb14f23"/>
+    <p:sldMasterId xmlns:r="http://schemas.openxmlformats.org/officeDocument/2006/relationships" id="2147483648" r:id="R77d7b5f966ea40dc"/>
   </p:sldMasterIdLst>
   <p:notesMasterIdLst>
-    <p:notesMasterId xmlns:r="http://schemas.openxmlformats.org/officeDocument/2006/relationships" r:id="Re96ea0957e124a72"/>
+    <p:notesMasterId xmlns:r="http://schemas.openxmlformats.org/officeDocument/2006/relationships" r:id="R04be28827726481a"/>
   </p:notesMasterIdLst>
   <p:sldIdLst>
-    <p:sldId xmlns:r="http://schemas.openxmlformats.org/officeDocument/2006/relationships" id="256" r:id="Rd2d854c536084de0"/>
-    <p:sldId xmlns:r="http://schemas.openxmlformats.org/officeDocument/2006/relationships" id="257" r:id="R716269322d2b4ec2"/>
-    <p:sldId xmlns:r="http://schemas.openxmlformats.org/officeDocument/2006/relationships" id="258" r:id="R886cf9a5962a447c"/>
-    <p:sldId xmlns:r="http://schemas.openxmlformats.org/officeDocument/2006/relationships" id="259" r:id="Recfb6bfa72e342da"/>
-    <p:sldId xmlns:r="http://schemas.openxmlformats.org/officeDocument/2006/relationships" id="260" r:id="R2b3c188c27984ac4"/>
-    <p:sldId xmlns:r="http://schemas.openxmlformats.org/officeDocument/2006/relationships" id="261" r:id="R92a316a178b5438c"/>
-    <p:sldId xmlns:r="http://schemas.openxmlformats.org/officeDocument/2006/relationships" id="262" r:id="R0423d38c7cdd40ed"/>
-    <p:sldId xmlns:r="http://schemas.openxmlformats.org/officeDocument/2006/relationships" id="263" r:id="R7c0a98fbd3c94d11"/>
-    <p:sldId xmlns:r="http://schemas.openxmlformats.org/officeDocument/2006/relationships" id="264" r:id="R06d73f5a09c04725"/>
-    <p:sldId xmlns:r="http://schemas.openxmlformats.org/officeDocument/2006/relationships" id="265" r:id="R45cd87882f154374"/>
-    <p:sldId xmlns:r="http://schemas.openxmlformats.org/officeDocument/2006/relationships" id="266" r:id="R3958a96e5d1a4998"/>
-    <p:sldId xmlns:r="http://schemas.openxmlformats.org/officeDocument/2006/relationships" id="267" r:id="R33a4bf339eb04b71"/>
-    <p:sldId xmlns:r="http://schemas.openxmlformats.org/officeDocument/2006/relationships" id="268" r:id="R4a003545e7d54a62"/>
-    <p:sldId xmlns:r="http://schemas.openxmlformats.org/officeDocument/2006/relationships" id="269" r:id="R4e56155c351f4727"/>
-    <p:sldId xmlns:r="http://schemas.openxmlformats.org/officeDocument/2006/relationships" id="270" r:id="Rdf96d7af4e154555"/>
+    <p:sldId xmlns:r="http://schemas.openxmlformats.org/officeDocument/2006/relationships" id="256" r:id="R0a677aadf31148fa"/>
+    <p:sldId xmlns:r="http://schemas.openxmlformats.org/officeDocument/2006/relationships" id="257" r:id="Re529b1bfe6c94bb5"/>
+    <p:sldId xmlns:r="http://schemas.openxmlformats.org/officeDocument/2006/relationships" id="258" r:id="R5338469d95fb48be"/>
+    <p:sldId xmlns:r="http://schemas.openxmlformats.org/officeDocument/2006/relationships" id="259" r:id="Rd1d5f3c465534863"/>
+    <p:sldId xmlns:r="http://schemas.openxmlformats.org/officeDocument/2006/relationships" id="260" r:id="Rce2d980faf6d45bf"/>
+    <p:sldId xmlns:r="http://schemas.openxmlformats.org/officeDocument/2006/relationships" id="261" r:id="Re97a514db26e41fc"/>
+    <p:sldId xmlns:r="http://schemas.openxmlformats.org/officeDocument/2006/relationships" id="262" r:id="R89e1b67663e344ec"/>
+    <p:sldId xmlns:r="http://schemas.openxmlformats.org/officeDocument/2006/relationships" id="263" r:id="R1ca939d77c644975"/>
+    <p:sldId xmlns:r="http://schemas.openxmlformats.org/officeDocument/2006/relationships" id="264" r:id="R04a012f9c3284cc7"/>
+    <p:sldId xmlns:r="http://schemas.openxmlformats.org/officeDocument/2006/relationships" id="265" r:id="Rc34af7d18bda4cfd"/>
+    <p:sldId xmlns:r="http://schemas.openxmlformats.org/officeDocument/2006/relationships" id="266" r:id="R904374b6ecd0447e"/>
+    <p:sldId xmlns:r="http://schemas.openxmlformats.org/officeDocument/2006/relationships" id="267" r:id="Rada2458896764b16"/>
+    <p:sldId xmlns:r="http://schemas.openxmlformats.org/officeDocument/2006/relationships" id="268" r:id="R6bbac3830afc4e6f"/>
+    <p:sldId xmlns:r="http://schemas.openxmlformats.org/officeDocument/2006/relationships" id="269" r:id="R84612743f64d4346"/>
+    <p:sldId xmlns:r="http://schemas.openxmlformats.org/officeDocument/2006/relationships" id="270" r:id="R54571d04add44e87"/>
   </p:sldIdLst>
   <p:sldSz cx="12192000" cy="6858000"/>
   <p:notesSz cx="6858000" cy="9144000"/>
@@ -3624,7 +3624,7 @@
   </p:cSld>
   <p:clrMap bg1="lt1" tx1="dk1" bg2="lt2" tx2="dk2" accent1="accent1" accent2="accent2" accent3="accent3" accent4="accent4" accent5="accent5" accent6="accent6" hlink="hlink" folHlink="folHlink"/>
   <p:sldLayoutIdLst>
-    <p:sldLayoutId id="2147483649" r:id="R0b75c7eef27048f8"/>
+    <p:sldLayoutId id="2147483649" r:id="R0e3a49f91d404705"/>
   </p:sldLayoutIdLst>
   <p:txStyles>
     <p:titleStyle>
@@ -4409,7 +4409,7 @@
           <p:cNvPr id="14" name="">
             <a:extLst xmlns:a="http://schemas.openxmlformats.org/drawingml/2006/main">
               <a:ext uri="{FF2B5EF4-FFF2-40B4-BE49-F238E27FC236}">
-                <a16:creationId xmlns:a16="http://schemas.microsoft.com/office/drawing/2014/main" id="{C1B05E4A-E3C6-4871-9F17-A96F05AF126D}"/>
+                <a16:creationId xmlns:a16="http://schemas.microsoft.com/office/drawing/2014/main" id="{6F5DBD24-A6CA-43F8-B67E-A8E10123C687}"/>
               </a:ext>
             </a:extLst>
           </p:cNvPr>
@@ -4466,7 +4466,7 @@
           <p:cNvPr id="2" name="">
             <a:extLst xmlns:a="http://schemas.openxmlformats.org/drawingml/2006/main">
               <a:ext uri="{FF2B5EF4-FFF2-40B4-BE49-F238E27FC236}">
-                <a16:creationId xmlns:a16="http://schemas.microsoft.com/office/drawing/2014/main" id="{CB72DDAD-E273-4A41-99F9-B0BBC87A05EA}"/>
+                <a16:creationId xmlns:a16="http://schemas.microsoft.com/office/drawing/2014/main" id="{F3F8982B-8D00-4EE9-8723-84CD406DDCF9}"/>
               </a:ext>
             </a:extLst>
           </p:cNvPr>
@@ -4546,7 +4546,7 @@
           <p:cNvPr id="3" name="">
             <a:extLst xmlns:a="http://schemas.openxmlformats.org/drawingml/2006/main">
               <a:ext uri="{FF2B5EF4-FFF2-40B4-BE49-F238E27FC236}">
-                <a16:creationId xmlns:a16="http://schemas.microsoft.com/office/drawing/2014/main" id="{8D81B2E8-658E-4DA9-9ADE-4AEFF89E965A}"/>
+                <a16:creationId xmlns:a16="http://schemas.microsoft.com/office/drawing/2014/main" id="{1505CB88-01EF-4232-8555-1163A16FE8FD}"/>
               </a:ext>
             </a:extLst>
           </p:cNvPr>
@@ -4607,7 +4607,7 @@
           <p:nvPr/>
         </p:nvPicPr>
         <p:blipFill>
-          <a:blip xmlns:r="http://schemas.openxmlformats.org/officeDocument/2006/relationships" xmlns:a="http://schemas.openxmlformats.org/drawingml/2006/main" r:embed="R752456a39a79417e"/>
+          <a:blip xmlns:r="http://schemas.openxmlformats.org/officeDocument/2006/relationships" xmlns:a="http://schemas.openxmlformats.org/drawingml/2006/main" r:embed="Rc765ae508fda45f4"/>
           <a:stretch xmlns:a="http://schemas.openxmlformats.org/drawingml/2006/main"/>
         </p:blipFill>
         <p:spPr>
@@ -4625,7 +4625,7 @@
           <p:cNvPr id="5" name="">
             <a:extLst xmlns:a="http://schemas.openxmlformats.org/drawingml/2006/main">
               <a:ext uri="{FF2B5EF4-FFF2-40B4-BE49-F238E27FC236}">
-                <a16:creationId xmlns:a16="http://schemas.microsoft.com/office/drawing/2014/main" id="{B32F9AD7-F472-4F28-8656-077F95D1851F}"/>
+                <a16:creationId xmlns:a16="http://schemas.microsoft.com/office/drawing/2014/main" id="{410271D8-F5E5-42EB-9B88-2B95DB3E8182}"/>
               </a:ext>
             </a:extLst>
           </p:cNvPr>
@@ -4682,7 +4682,7 @@
           <p:cNvPr id="6" name="">
             <a:extLst xmlns:a="http://schemas.openxmlformats.org/drawingml/2006/main">
               <a:ext uri="{FF2B5EF4-FFF2-40B4-BE49-F238E27FC236}">
-                <a16:creationId xmlns:a16="http://schemas.microsoft.com/office/drawing/2014/main" id="{C282D889-516F-46D7-8EFB-2AFB9D4D8CDE}"/>
+                <a16:creationId xmlns:a16="http://schemas.microsoft.com/office/drawing/2014/main" id="{CE9B797E-C52B-4966-8439-78E41B642BD0}"/>
               </a:ext>
             </a:extLst>
           </p:cNvPr>
@@ -4739,7 +4739,7 @@
           <p:cNvPr id="7" name="">
             <a:extLst xmlns:a="http://schemas.openxmlformats.org/drawingml/2006/main">
               <a:ext uri="{FF2B5EF4-FFF2-40B4-BE49-F238E27FC236}">
-                <a16:creationId xmlns:a16="http://schemas.microsoft.com/office/drawing/2014/main" id="{B0B78FDF-D60E-4CC6-AF39-7370E1C79A62}"/>
+                <a16:creationId xmlns:a16="http://schemas.microsoft.com/office/drawing/2014/main" id="{F8224464-FEBA-4FD6-8E45-DC4CAD4AA535}"/>
               </a:ext>
             </a:extLst>
           </p:cNvPr>
@@ -4796,7 +4796,7 @@
           <p:cNvPr id="8" name="">
             <a:extLst xmlns:a="http://schemas.openxmlformats.org/drawingml/2006/main">
               <a:ext uri="{FF2B5EF4-FFF2-40B4-BE49-F238E27FC236}">
-                <a16:creationId xmlns:a16="http://schemas.microsoft.com/office/drawing/2014/main" id="{9342C989-8DF5-48C0-A43A-64184E21F7C5}"/>
+                <a16:creationId xmlns:a16="http://schemas.microsoft.com/office/drawing/2014/main" id="{811DAE3A-4FDD-48A8-8E41-68C7CBFDFDA7}"/>
               </a:ext>
             </a:extLst>
           </p:cNvPr>
@@ -4853,7 +4853,7 @@
           <p:cNvPr id="9" name="">
             <a:extLst xmlns:a="http://schemas.openxmlformats.org/drawingml/2006/main">
               <a:ext uri="{FF2B5EF4-FFF2-40B4-BE49-F238E27FC236}">
-                <a16:creationId xmlns:a16="http://schemas.microsoft.com/office/drawing/2014/main" id="{011451D3-B1BD-4FB4-B46A-955EF0243642}"/>
+                <a16:creationId xmlns:a16="http://schemas.microsoft.com/office/drawing/2014/main" id="{FC783871-7604-4AA8-8A86-753C29C84462}"/>
               </a:ext>
             </a:extLst>
           </p:cNvPr>
@@ -4884,7 +4884,7 @@
           <p:cNvPr id="10" name="">
             <a:extLst xmlns:a="http://schemas.openxmlformats.org/drawingml/2006/main">
               <a:ext uri="{FF2B5EF4-FFF2-40B4-BE49-F238E27FC236}">
-                <a16:creationId xmlns:a16="http://schemas.microsoft.com/office/drawing/2014/main" id="{E46066CC-5542-4CE3-8836-7918F7EADCF9}"/>
+                <a16:creationId xmlns:a16="http://schemas.microsoft.com/office/drawing/2014/main" id="{7D44D36C-048E-4769-B4B2-5CF7CA14F85E}"/>
               </a:ext>
             </a:extLst>
           </p:cNvPr>
@@ -4941,7 +4941,7 @@
           <p:cNvPr id="11" name="">
             <a:extLst xmlns:a="http://schemas.openxmlformats.org/drawingml/2006/main">
               <a:ext uri="{FF2B5EF4-FFF2-40B4-BE49-F238E27FC236}">
-                <a16:creationId xmlns:a16="http://schemas.microsoft.com/office/drawing/2014/main" id="{392F219D-8686-4D91-A55C-166FC58BFF1E}"/>
+                <a16:creationId xmlns:a16="http://schemas.microsoft.com/office/drawing/2014/main" id="{790194FD-C53F-4F79-A94B-6AC5C5737D82}"/>
               </a:ext>
             </a:extLst>
           </p:cNvPr>
@@ -4998,7 +4998,7 @@
           <p:cNvPr id="12" name="">
             <a:extLst xmlns:a="http://schemas.openxmlformats.org/drawingml/2006/main">
               <a:ext uri="{FF2B5EF4-FFF2-40B4-BE49-F238E27FC236}">
-                <a16:creationId xmlns:a16="http://schemas.microsoft.com/office/drawing/2014/main" id="{0C5F167B-0FE2-44CC-9B54-AC016F7D5AE1}"/>
+                <a16:creationId xmlns:a16="http://schemas.microsoft.com/office/drawing/2014/main" id="{F94670D5-6C6F-4F0B-99E6-0D8E65762D39}"/>
               </a:ext>
             </a:extLst>
           </p:cNvPr>
@@ -5044,7 +5044,7 @@
                 <a:latin typeface="Arial"/>
                 <a:ea typeface="Arial"/>
                 <a:cs typeface="Arial"/>
-                <a:hlinkClick xmlns:r="http://schemas.openxmlformats.org/officeDocument/2006/relationships" r:id="R17027a26a94b4451"/>
+                <a:hlinkClick xmlns:r="http://schemas.openxmlformats.org/officeDocument/2006/relationships" r:id="Rb8e2ec0388f24d02"/>
               </a:rPr>
               <a:t>oborskyivitalii@gmail.com</a:t>
             </a:r>
@@ -5056,7 +5056,7 @@
           <p:cNvPr id="13" name="">
             <a:extLst xmlns:a="http://schemas.openxmlformats.org/drawingml/2006/main">
               <a:ext uri="{FF2B5EF4-FFF2-40B4-BE49-F238E27FC236}">
-                <a16:creationId xmlns:a16="http://schemas.microsoft.com/office/drawing/2014/main" id="{10282AA3-48A0-4553-9C0D-8D94B519398D}"/>
+                <a16:creationId xmlns:a16="http://schemas.microsoft.com/office/drawing/2014/main" id="{5E1A9AD7-EA9B-4519-B7E1-AD707EA763BC}"/>
               </a:ext>
             </a:extLst>
           </p:cNvPr>
@@ -5102,7 +5102,7 @@
                 <a:latin typeface="Arial"/>
                 <a:ea typeface="Arial"/>
                 <a:cs typeface="Arial"/>
-                <a:hlinkClick xmlns:r="http://schemas.openxmlformats.org/officeDocument/2006/relationships" r:id="R7a171b86e0804603"/>
+                <a:hlinkClick xmlns:r="http://schemas.openxmlformats.org/officeDocument/2006/relationships" r:id="Rdcb135e44fc64fb7"/>
               </a:rPr>
               <a:t>https://www.linkedin.com/in/vitaliioborskyi/</a:t>
             </a:r>
@@ -5112,7 +5112,7 @@
     </p:spTree>
     <p:extLst>
       <p:ext uri="{BB962C8B-B14F-4D97-AF65-F5344CB8AC3E}">
-        <p14:creationId xmlns:p14="http://schemas.microsoft.com/office/powerpoint/2010/main" val="1842018802"/>
+        <p14:creationId xmlns:p14="http://schemas.microsoft.com/office/powerpoint/2010/main" val="1441845840"/>
       </p:ext>
     </p:extLst>
   </p:cSld>
@@ -5143,7 +5143,7 @@
           <p:cNvPr id="49" name="">
             <a:extLst xmlns:a="http://schemas.openxmlformats.org/drawingml/2006/main">
               <a:ext uri="{FF2B5EF4-FFF2-40B4-BE49-F238E27FC236}">
-                <a16:creationId xmlns:a16="http://schemas.microsoft.com/office/drawing/2014/main" id="{CE2AA012-5D13-4276-AD36-1FD88D3E738B}"/>
+                <a16:creationId xmlns:a16="http://schemas.microsoft.com/office/drawing/2014/main" id="{4096C8E8-36E7-49DF-B751-8784F65CD6CD}"/>
               </a:ext>
             </a:extLst>
           </p:cNvPr>
@@ -5200,7 +5200,7 @@
           <p:cNvPr id="2" name="">
             <a:extLst xmlns:a="http://schemas.openxmlformats.org/drawingml/2006/main">
               <a:ext uri="{FF2B5EF4-FFF2-40B4-BE49-F238E27FC236}">
-                <a16:creationId xmlns:a16="http://schemas.microsoft.com/office/drawing/2014/main" id="{741D4CFA-90FD-49F9-8672-00BF83F39AC2}"/>
+                <a16:creationId xmlns:a16="http://schemas.microsoft.com/office/drawing/2014/main" id="{6B0694B5-DD2D-4633-A5D1-951416F82EA1}"/>
               </a:ext>
             </a:extLst>
           </p:cNvPr>
@@ -5231,7 +5231,7 @@
           <p:cNvPr id="3" name="">
             <a:extLst xmlns:a="http://schemas.openxmlformats.org/drawingml/2006/main">
               <a:ext uri="{FF2B5EF4-FFF2-40B4-BE49-F238E27FC236}">
-                <a16:creationId xmlns:a16="http://schemas.microsoft.com/office/drawing/2014/main" id="{B44CDA84-C5AC-467D-A881-1FF9F9448E99}"/>
+                <a16:creationId xmlns:a16="http://schemas.microsoft.com/office/drawing/2014/main" id="{4DF53BFA-2A66-4B84-B870-02CD6266F63F}"/>
               </a:ext>
             </a:extLst>
           </p:cNvPr>
@@ -5288,7 +5288,7 @@
           <p:cNvPr id="4" name="">
             <a:extLst xmlns:a="http://schemas.openxmlformats.org/drawingml/2006/main">
               <a:ext uri="{FF2B5EF4-FFF2-40B4-BE49-F238E27FC236}">
-                <a16:creationId xmlns:a16="http://schemas.microsoft.com/office/drawing/2014/main" id="{DB862F21-6F29-4EE1-97E1-7F2A1B70FC75}"/>
+                <a16:creationId xmlns:a16="http://schemas.microsoft.com/office/drawing/2014/main" id="{02E041D1-8907-4BF3-A513-4FBF06FD0CA7}"/>
               </a:ext>
             </a:extLst>
           </p:cNvPr>
@@ -5345,7 +5345,7 @@
           <p:cNvPr id="5" name="">
             <a:extLst xmlns:a="http://schemas.openxmlformats.org/drawingml/2006/main">
               <a:ext uri="{FF2B5EF4-FFF2-40B4-BE49-F238E27FC236}">
-                <a16:creationId xmlns:a16="http://schemas.microsoft.com/office/drawing/2014/main" id="{90E5C2A0-EB78-4E83-A9A5-72A6A9188B95}"/>
+                <a16:creationId xmlns:a16="http://schemas.microsoft.com/office/drawing/2014/main" id="{A065373C-23E9-47C2-816E-90F16DC56FCA}"/>
               </a:ext>
             </a:extLst>
           </p:cNvPr>
@@ -5402,7 +5402,7 @@
           <p:cNvPr id="6" name="">
             <a:extLst xmlns:a="http://schemas.openxmlformats.org/drawingml/2006/main">
               <a:ext uri="{FF2B5EF4-FFF2-40B4-BE49-F238E27FC236}">
-                <a16:creationId xmlns:a16="http://schemas.microsoft.com/office/drawing/2014/main" id="{C07CC6E0-C42C-4CC9-AFDD-FCAFEE25D229}"/>
+                <a16:creationId xmlns:a16="http://schemas.microsoft.com/office/drawing/2014/main" id="{539E3EEF-1612-4076-9E26-E7E4853F5B58}"/>
               </a:ext>
             </a:extLst>
           </p:cNvPr>
@@ -5482,7 +5482,7 @@
           <p:cNvPr id="7" name="">
             <a:extLst xmlns:a="http://schemas.openxmlformats.org/drawingml/2006/main">
               <a:ext uri="{FF2B5EF4-FFF2-40B4-BE49-F238E27FC236}">
-                <a16:creationId xmlns:a16="http://schemas.microsoft.com/office/drawing/2014/main" id="{334ECFB9-900A-4D13-B760-281F0C31322F}"/>
+                <a16:creationId xmlns:a16="http://schemas.microsoft.com/office/drawing/2014/main" id="{908BF6EE-48D4-4274-8594-07519A201D5D}"/>
               </a:ext>
             </a:extLst>
           </p:cNvPr>
@@ -5562,7 +5562,7 @@
           <p:cNvPr id="8" name="">
             <a:extLst xmlns:a="http://schemas.openxmlformats.org/drawingml/2006/main">
               <a:ext uri="{FF2B5EF4-FFF2-40B4-BE49-F238E27FC236}">
-                <a16:creationId xmlns:a16="http://schemas.microsoft.com/office/drawing/2014/main" id="{8DC16856-CF2F-4E13-B537-94C33A772602}"/>
+                <a16:creationId xmlns:a16="http://schemas.microsoft.com/office/drawing/2014/main" id="{11B0A31E-0D10-4F95-A81F-9F958A78D13A}"/>
               </a:ext>
             </a:extLst>
           </p:cNvPr>
@@ -5619,7 +5619,7 @@
           <p:cNvPr id="9" name="">
             <a:extLst xmlns:a="http://schemas.openxmlformats.org/drawingml/2006/main">
               <a:ext uri="{FF2B5EF4-FFF2-40B4-BE49-F238E27FC236}">
-                <a16:creationId xmlns:a16="http://schemas.microsoft.com/office/drawing/2014/main" id="{93A21487-D18D-4402-81C8-E10A80627D51}"/>
+                <a16:creationId xmlns:a16="http://schemas.microsoft.com/office/drawing/2014/main" id="{5DDD7F48-96D3-47FF-8B4E-BCEA8B47EBA1}"/>
               </a:ext>
             </a:extLst>
           </p:cNvPr>
@@ -5676,7 +5676,7 @@
           <p:cNvPr id="10" name="">
             <a:extLst xmlns:a="http://schemas.openxmlformats.org/drawingml/2006/main">
               <a:ext uri="{FF2B5EF4-FFF2-40B4-BE49-F238E27FC236}">
-                <a16:creationId xmlns:a16="http://schemas.microsoft.com/office/drawing/2014/main" id="{9E972AB0-5452-4AF2-9E11-2BC7A835F7F5}"/>
+                <a16:creationId xmlns:a16="http://schemas.microsoft.com/office/drawing/2014/main" id="{B0CAFB24-9E8A-4DAD-AC4B-E6CBDDF62F98}"/>
               </a:ext>
             </a:extLst>
           </p:cNvPr>
@@ -5707,7 +5707,7 @@
           <p:cNvPr id="11" name="">
             <a:extLst xmlns:a="http://schemas.openxmlformats.org/drawingml/2006/main">
               <a:ext uri="{FF2B5EF4-FFF2-40B4-BE49-F238E27FC236}">
-                <a16:creationId xmlns:a16="http://schemas.microsoft.com/office/drawing/2014/main" id="{1AC0D0C0-9319-4ABA-ACE9-3332DE52C78B}"/>
+                <a16:creationId xmlns:a16="http://schemas.microsoft.com/office/drawing/2014/main" id="{F92FDBA3-505A-44FA-853F-33B321DA1EFE}"/>
               </a:ext>
             </a:extLst>
           </p:cNvPr>
@@ -5740,7 +5740,7 @@
           <p:cNvPr id="12" name="">
             <a:extLst xmlns:a="http://schemas.openxmlformats.org/drawingml/2006/main">
               <a:ext uri="{FF2B5EF4-FFF2-40B4-BE49-F238E27FC236}">
-                <a16:creationId xmlns:a16="http://schemas.microsoft.com/office/drawing/2014/main" id="{ED21C1C9-00D8-4B29-967D-69396A522ACA}"/>
+                <a16:creationId xmlns:a16="http://schemas.microsoft.com/office/drawing/2014/main" id="{2F714559-542D-465E-BD5D-6BECEF6B25F2}"/>
               </a:ext>
             </a:extLst>
           </p:cNvPr>
@@ -5773,7 +5773,7 @@
           <p:cNvPr id="13" name="">
             <a:extLst xmlns:a="http://schemas.openxmlformats.org/drawingml/2006/main">
               <a:ext uri="{FF2B5EF4-FFF2-40B4-BE49-F238E27FC236}">
-                <a16:creationId xmlns:a16="http://schemas.microsoft.com/office/drawing/2014/main" id="{48D6FE59-0C8B-46E7-A476-CB4258FF6455}"/>
+                <a16:creationId xmlns:a16="http://schemas.microsoft.com/office/drawing/2014/main" id="{3FB75DEE-ECE6-4D1C-B3F1-2092BAD1E8BE}"/>
               </a:ext>
             </a:extLst>
           </p:cNvPr>
@@ -5806,7 +5806,7 @@
           <p:cNvPr id="14" name="">
             <a:extLst xmlns:a="http://schemas.openxmlformats.org/drawingml/2006/main">
               <a:ext uri="{FF2B5EF4-FFF2-40B4-BE49-F238E27FC236}">
-                <a16:creationId xmlns:a16="http://schemas.microsoft.com/office/drawing/2014/main" id="{1981AE3F-D38F-438B-8F09-B60F79778A4A}"/>
+                <a16:creationId xmlns:a16="http://schemas.microsoft.com/office/drawing/2014/main" id="{D55F55F1-C2DE-460A-BE7B-BDD2532F3CFD}"/>
               </a:ext>
             </a:extLst>
           </p:cNvPr>
@@ -5839,7 +5839,7 @@
           <p:cNvPr id="15" name="">
             <a:extLst xmlns:a="http://schemas.openxmlformats.org/drawingml/2006/main">
               <a:ext uri="{FF2B5EF4-FFF2-40B4-BE49-F238E27FC236}">
-                <a16:creationId xmlns:a16="http://schemas.microsoft.com/office/drawing/2014/main" id="{E9E8D40D-98C4-49B5-AB06-D148257AB4E3}"/>
+                <a16:creationId xmlns:a16="http://schemas.microsoft.com/office/drawing/2014/main" id="{6C44F87D-5DB8-467F-B31A-05A89D11ACA4}"/>
               </a:ext>
             </a:extLst>
           </p:cNvPr>
@@ -5872,7 +5872,7 @@
           <p:cNvPr id="16" name="">
             <a:extLst xmlns:a="http://schemas.openxmlformats.org/drawingml/2006/main">
               <a:ext uri="{FF2B5EF4-FFF2-40B4-BE49-F238E27FC236}">
-                <a16:creationId xmlns:a16="http://schemas.microsoft.com/office/drawing/2014/main" id="{F1F6691D-9CC5-4FFE-B94B-F828AABC368B}"/>
+                <a16:creationId xmlns:a16="http://schemas.microsoft.com/office/drawing/2014/main" id="{6FB701A9-305A-4662-AB0E-AE339A80B90A}"/>
               </a:ext>
             </a:extLst>
           </p:cNvPr>
@@ -5905,7 +5905,7 @@
           <p:cNvPr id="17" name="">
             <a:extLst xmlns:a="http://schemas.openxmlformats.org/drawingml/2006/main">
               <a:ext uri="{FF2B5EF4-FFF2-40B4-BE49-F238E27FC236}">
-                <a16:creationId xmlns:a16="http://schemas.microsoft.com/office/drawing/2014/main" id="{E9651285-33E0-4856-9F61-0CB5570DAB66}"/>
+                <a16:creationId xmlns:a16="http://schemas.microsoft.com/office/drawing/2014/main" id="{1D8D6CE5-A449-4B39-9D2D-12C6C8B06E32}"/>
               </a:ext>
             </a:extLst>
           </p:cNvPr>
@@ -5938,7 +5938,7 @@
           <p:cNvPr id="18" name="">
             <a:extLst xmlns:a="http://schemas.openxmlformats.org/drawingml/2006/main">
               <a:ext uri="{FF2B5EF4-FFF2-40B4-BE49-F238E27FC236}">
-                <a16:creationId xmlns:a16="http://schemas.microsoft.com/office/drawing/2014/main" id="{20D06E46-F9CD-40DF-8FA2-37B22B48297F}"/>
+                <a16:creationId xmlns:a16="http://schemas.microsoft.com/office/drawing/2014/main" id="{37043E53-91D4-47AB-A5E5-47FB88AE695A}"/>
               </a:ext>
             </a:extLst>
           </p:cNvPr>
@@ -5971,7 +5971,7 @@
           <p:cNvPr id="19" name="">
             <a:extLst xmlns:a="http://schemas.openxmlformats.org/drawingml/2006/main">
               <a:ext uri="{FF2B5EF4-FFF2-40B4-BE49-F238E27FC236}">
-                <a16:creationId xmlns:a16="http://schemas.microsoft.com/office/drawing/2014/main" id="{34D9015C-FFA9-4B4D-A933-214C458A32E2}"/>
+                <a16:creationId xmlns:a16="http://schemas.microsoft.com/office/drawing/2014/main" id="{1799E0AE-0E8B-4CE9-8D8C-69B2F9AB554F}"/>
               </a:ext>
             </a:extLst>
           </p:cNvPr>
@@ -6004,7 +6004,7 @@
           <p:cNvPr id="20" name="">
             <a:extLst xmlns:a="http://schemas.openxmlformats.org/drawingml/2006/main">
               <a:ext uri="{FF2B5EF4-FFF2-40B4-BE49-F238E27FC236}">
-                <a16:creationId xmlns:a16="http://schemas.microsoft.com/office/drawing/2014/main" id="{6DB29103-A92D-4C39-94EF-A1A316ACCEF1}"/>
+                <a16:creationId xmlns:a16="http://schemas.microsoft.com/office/drawing/2014/main" id="{5FA88079-04C3-4306-A72E-93A2F6C27B95}"/>
               </a:ext>
             </a:extLst>
           </p:cNvPr>
@@ -6037,7 +6037,7 @@
           <p:cNvPr id="21" name="">
             <a:extLst xmlns:a="http://schemas.openxmlformats.org/drawingml/2006/main">
               <a:ext uri="{FF2B5EF4-FFF2-40B4-BE49-F238E27FC236}">
-                <a16:creationId xmlns:a16="http://schemas.microsoft.com/office/drawing/2014/main" id="{08C859EC-8B2D-4E7B-B1EC-8022BACE8DB8}"/>
+                <a16:creationId xmlns:a16="http://schemas.microsoft.com/office/drawing/2014/main" id="{7A31310A-AF6E-4D6C-BE3F-4ECB43F646A6}"/>
               </a:ext>
             </a:extLst>
           </p:cNvPr>
@@ -6070,7 +6070,7 @@
           <p:cNvPr id="22" name="">
             <a:extLst xmlns:a="http://schemas.openxmlformats.org/drawingml/2006/main">
               <a:ext uri="{FF2B5EF4-FFF2-40B4-BE49-F238E27FC236}">
-                <a16:creationId xmlns:a16="http://schemas.microsoft.com/office/drawing/2014/main" id="{F9313C0B-3F81-450A-8DB9-B66045A097A0}"/>
+                <a16:creationId xmlns:a16="http://schemas.microsoft.com/office/drawing/2014/main" id="{176DC07D-D631-4168-A712-9E6E6B618F11}"/>
               </a:ext>
             </a:extLst>
           </p:cNvPr>
@@ -6103,7 +6103,7 @@
           <p:cNvPr id="23" name="">
             <a:extLst xmlns:a="http://schemas.openxmlformats.org/drawingml/2006/main">
               <a:ext uri="{FF2B5EF4-FFF2-40B4-BE49-F238E27FC236}">
-                <a16:creationId xmlns:a16="http://schemas.microsoft.com/office/drawing/2014/main" id="{11637524-60DB-45D2-9C4D-4A5B3EDDF67B}"/>
+                <a16:creationId xmlns:a16="http://schemas.microsoft.com/office/drawing/2014/main" id="{C8D6BE80-294D-4376-B3B2-B0C33DC47A76}"/>
               </a:ext>
             </a:extLst>
           </p:cNvPr>
@@ -6136,7 +6136,7 @@
           <p:cNvPr id="24" name="">
             <a:extLst xmlns:a="http://schemas.openxmlformats.org/drawingml/2006/main">
               <a:ext uri="{FF2B5EF4-FFF2-40B4-BE49-F238E27FC236}">
-                <a16:creationId xmlns:a16="http://schemas.microsoft.com/office/drawing/2014/main" id="{C81C4CE4-982B-4215-B53A-EBE05EE297FB}"/>
+                <a16:creationId xmlns:a16="http://schemas.microsoft.com/office/drawing/2014/main" id="{80279613-ED58-4DD1-860F-1240DEF33F75}"/>
               </a:ext>
             </a:extLst>
           </p:cNvPr>
@@ -6167,7 +6167,7 @@
           <p:cNvPr id="25" name="">
             <a:extLst xmlns:a="http://schemas.openxmlformats.org/drawingml/2006/main">
               <a:ext uri="{FF2B5EF4-FFF2-40B4-BE49-F238E27FC236}">
-                <a16:creationId xmlns:a16="http://schemas.microsoft.com/office/drawing/2014/main" id="{CE56DE9E-6802-4608-8487-B29EC34CD21C}"/>
+                <a16:creationId xmlns:a16="http://schemas.microsoft.com/office/drawing/2014/main" id="{B4FD44FF-DAAF-484C-8635-284E34EC9013}"/>
               </a:ext>
             </a:extLst>
           </p:cNvPr>
@@ -6198,7 +6198,7 @@
           <p:cNvPr id="26" name="">
             <a:extLst xmlns:a="http://schemas.openxmlformats.org/drawingml/2006/main">
               <a:ext uri="{FF2B5EF4-FFF2-40B4-BE49-F238E27FC236}">
-                <a16:creationId xmlns:a16="http://schemas.microsoft.com/office/drawing/2014/main" id="{4203FEC1-9320-4AD6-A59A-3D4D2E14324F}"/>
+                <a16:creationId xmlns:a16="http://schemas.microsoft.com/office/drawing/2014/main" id="{DB54AE05-D4BF-4378-BF94-93649E1C5DBA}"/>
               </a:ext>
             </a:extLst>
           </p:cNvPr>
@@ -6229,7 +6229,7 @@
           <p:cNvPr id="27" name="">
             <a:extLst xmlns:a="http://schemas.openxmlformats.org/drawingml/2006/main">
               <a:ext uri="{FF2B5EF4-FFF2-40B4-BE49-F238E27FC236}">
-                <a16:creationId xmlns:a16="http://schemas.microsoft.com/office/drawing/2014/main" id="{C0EA633E-81AA-4861-90C4-08302795CD7C}"/>
+                <a16:creationId xmlns:a16="http://schemas.microsoft.com/office/drawing/2014/main" id="{09BD2625-FE55-46CF-A055-FBEFCF30B24B}"/>
               </a:ext>
             </a:extLst>
           </p:cNvPr>
@@ -6260,7 +6260,7 @@
           <p:cNvPr id="28" name="">
             <a:extLst xmlns:a="http://schemas.openxmlformats.org/drawingml/2006/main">
               <a:ext uri="{FF2B5EF4-FFF2-40B4-BE49-F238E27FC236}">
-                <a16:creationId xmlns:a16="http://schemas.microsoft.com/office/drawing/2014/main" id="{8493B4A5-8185-4EB4-A010-31889AECA7B9}"/>
+                <a16:creationId xmlns:a16="http://schemas.microsoft.com/office/drawing/2014/main" id="{32C5E9B7-0CE3-483A-BF73-24B592C1C0F8}"/>
               </a:ext>
             </a:extLst>
           </p:cNvPr>
@@ -6363,7 +6363,7 @@
           <p:cNvPr id="29" name="">
             <a:extLst xmlns:a="http://schemas.openxmlformats.org/drawingml/2006/main">
               <a:ext uri="{FF2B5EF4-FFF2-40B4-BE49-F238E27FC236}">
-                <a16:creationId xmlns:a16="http://schemas.microsoft.com/office/drawing/2014/main" id="{612F153F-3CE2-4756-886D-47DDBB35E720}"/>
+                <a16:creationId xmlns:a16="http://schemas.microsoft.com/office/drawing/2014/main" id="{F2842654-A1A7-414B-BB74-F99CBAF42814}"/>
               </a:ext>
             </a:extLst>
           </p:cNvPr>
@@ -6420,7 +6420,7 @@
           <p:cNvPr id="30" name="">
             <a:extLst xmlns:a="http://schemas.openxmlformats.org/drawingml/2006/main">
               <a:ext uri="{FF2B5EF4-FFF2-40B4-BE49-F238E27FC236}">
-                <a16:creationId xmlns:a16="http://schemas.microsoft.com/office/drawing/2014/main" id="{78C5B85F-30E8-4E5B-A3F2-9E0B72DA9F6D}"/>
+                <a16:creationId xmlns:a16="http://schemas.microsoft.com/office/drawing/2014/main" id="{824D7C03-E74C-410C-9542-B6B84F09A098}"/>
               </a:ext>
             </a:extLst>
           </p:cNvPr>
@@ -6477,7 +6477,7 @@
           <p:cNvPr id="31" name="">
             <a:extLst xmlns:a="http://schemas.openxmlformats.org/drawingml/2006/main">
               <a:ext uri="{FF2B5EF4-FFF2-40B4-BE49-F238E27FC236}">
-                <a16:creationId xmlns:a16="http://schemas.microsoft.com/office/drawing/2014/main" id="{1ABF4651-FF8D-4364-AF14-F5CE54830D93}"/>
+                <a16:creationId xmlns:a16="http://schemas.microsoft.com/office/drawing/2014/main" id="{E94CEFE2-1475-40F3-9257-901EE1D626D1}"/>
               </a:ext>
             </a:extLst>
           </p:cNvPr>
@@ -6534,7 +6534,7 @@
           <p:cNvPr id="32" name="">
             <a:extLst xmlns:a="http://schemas.openxmlformats.org/drawingml/2006/main">
               <a:ext uri="{FF2B5EF4-FFF2-40B4-BE49-F238E27FC236}">
-                <a16:creationId xmlns:a16="http://schemas.microsoft.com/office/drawing/2014/main" id="{7E71C7D3-E967-4978-AC06-45DFC4315ABD}"/>
+                <a16:creationId xmlns:a16="http://schemas.microsoft.com/office/drawing/2014/main" id="{7927ED11-9A52-4863-93E0-A223FACBFEEF}"/>
               </a:ext>
             </a:extLst>
           </p:cNvPr>
@@ -6591,7 +6591,7 @@
           <p:cNvPr id="33" name="">
             <a:extLst xmlns:a="http://schemas.openxmlformats.org/drawingml/2006/main">
               <a:ext uri="{FF2B5EF4-FFF2-40B4-BE49-F238E27FC236}">
-                <a16:creationId xmlns:a16="http://schemas.microsoft.com/office/drawing/2014/main" id="{FF1BD36B-E101-4215-B8D9-697289CF1B31}"/>
+                <a16:creationId xmlns:a16="http://schemas.microsoft.com/office/drawing/2014/main" id="{5B9379B7-F9DA-40CB-9CFC-7CD8F1F113D7}"/>
               </a:ext>
             </a:extLst>
           </p:cNvPr>
@@ -6622,7 +6622,7 @@
           <p:cNvPr id="34" name="">
             <a:extLst xmlns:a="http://schemas.openxmlformats.org/drawingml/2006/main">
               <a:ext uri="{FF2B5EF4-FFF2-40B4-BE49-F238E27FC236}">
-                <a16:creationId xmlns:a16="http://schemas.microsoft.com/office/drawing/2014/main" id="{106390D5-4007-449B-B0AE-8C1499DBB715}"/>
+                <a16:creationId xmlns:a16="http://schemas.microsoft.com/office/drawing/2014/main" id="{330BB240-3733-4237-BCFC-0C4D1139001E}"/>
               </a:ext>
             </a:extLst>
           </p:cNvPr>
@@ -6686,7 +6686,7 @@
         </p:xfrm>
         <a:graphic xmlns:a="http://schemas.openxmlformats.org/drawingml/2006/main">
           <a:graphicData uri="http://schemas.openxmlformats.org/drawingml/2006/chart">
-            <c:chart xmlns:r="http://schemas.openxmlformats.org/officeDocument/2006/relationships" xmlns:c="http://schemas.openxmlformats.org/drawingml/2006/chart" r:id="R453f2a10e4824eca"/>
+            <c:chart xmlns:r="http://schemas.openxmlformats.org/officeDocument/2006/relationships" xmlns:c="http://schemas.openxmlformats.org/drawingml/2006/chart" r:id="R7eb9f4f78216436c"/>
           </a:graphicData>
         </a:graphic>
       </p:graphicFrame>
@@ -6695,7 +6695,7 @@
           <p:cNvPr id="36" name="">
             <a:extLst xmlns:a="http://schemas.openxmlformats.org/drawingml/2006/main">
               <a:ext uri="{FF2B5EF4-FFF2-40B4-BE49-F238E27FC236}">
-                <a16:creationId xmlns:a16="http://schemas.microsoft.com/office/drawing/2014/main" id="{D64AEF20-35E7-4B26-AFC1-FEFB59663A19}"/>
+                <a16:creationId xmlns:a16="http://schemas.microsoft.com/office/drawing/2014/main" id="{21F1C814-C8AC-4441-BA63-261B40E4531D}"/>
               </a:ext>
             </a:extLst>
           </p:cNvPr>
@@ -6752,7 +6752,7 @@
           <p:cNvPr id="37" name="">
             <a:extLst xmlns:a="http://schemas.openxmlformats.org/drawingml/2006/main">
               <a:ext uri="{FF2B5EF4-FFF2-40B4-BE49-F238E27FC236}">
-                <a16:creationId xmlns:a16="http://schemas.microsoft.com/office/drawing/2014/main" id="{52D3C545-C233-4D63-BBBE-1AA571A3A096}"/>
+                <a16:creationId xmlns:a16="http://schemas.microsoft.com/office/drawing/2014/main" id="{53C67369-1BC5-47DE-B816-03A83027BB50}"/>
               </a:ext>
             </a:extLst>
           </p:cNvPr>
@@ -6809,7 +6809,7 @@
           <p:cNvPr id="38" name="">
             <a:extLst xmlns:a="http://schemas.openxmlformats.org/drawingml/2006/main">
               <a:ext uri="{FF2B5EF4-FFF2-40B4-BE49-F238E27FC236}">
-                <a16:creationId xmlns:a16="http://schemas.microsoft.com/office/drawing/2014/main" id="{B2ED36E2-F1EC-4F2F-9349-B4E8EC76A86C}"/>
+                <a16:creationId xmlns:a16="http://schemas.microsoft.com/office/drawing/2014/main" id="{ED3869C1-51F0-47F5-B0BA-7757218ADFD9}"/>
               </a:ext>
             </a:extLst>
           </p:cNvPr>
@@ -6866,7 +6866,7 @@
           <p:cNvPr id="39" name="">
             <a:extLst xmlns:a="http://schemas.openxmlformats.org/drawingml/2006/main">
               <a:ext uri="{FF2B5EF4-FFF2-40B4-BE49-F238E27FC236}">
-                <a16:creationId xmlns:a16="http://schemas.microsoft.com/office/drawing/2014/main" id="{D5D80437-583B-401A-AC1E-0574DD14D91F}"/>
+                <a16:creationId xmlns:a16="http://schemas.microsoft.com/office/drawing/2014/main" id="{00A52129-DFCB-4EA9-8A85-AAE717B7C2F5}"/>
               </a:ext>
             </a:extLst>
           </p:cNvPr>
@@ -6897,7 +6897,7 @@
           <p:cNvPr id="40" name="">
             <a:extLst xmlns:a="http://schemas.openxmlformats.org/drawingml/2006/main">
               <a:ext uri="{FF2B5EF4-FFF2-40B4-BE49-F238E27FC236}">
-                <a16:creationId xmlns:a16="http://schemas.microsoft.com/office/drawing/2014/main" id="{C2D40787-99CA-447D-8616-DEA6BF294CBD}"/>
+                <a16:creationId xmlns:a16="http://schemas.microsoft.com/office/drawing/2014/main" id="{82820699-6BDF-4CE9-96F1-45833BE35322}"/>
               </a:ext>
             </a:extLst>
           </p:cNvPr>
@@ -6954,7 +6954,7 @@
           <p:cNvPr id="41" name="">
             <a:extLst xmlns:a="http://schemas.openxmlformats.org/drawingml/2006/main">
               <a:ext uri="{FF2B5EF4-FFF2-40B4-BE49-F238E27FC236}">
-                <a16:creationId xmlns:a16="http://schemas.microsoft.com/office/drawing/2014/main" id="{666EA8C8-F1DF-469D-A197-EEF6D9D3F76E}"/>
+                <a16:creationId xmlns:a16="http://schemas.microsoft.com/office/drawing/2014/main" id="{8E44055C-3CC9-4C27-97ED-65962D8C160C}"/>
               </a:ext>
             </a:extLst>
           </p:cNvPr>
@@ -7011,7 +7011,7 @@
           <p:cNvPr id="42" name="">
             <a:extLst xmlns:a="http://schemas.openxmlformats.org/drawingml/2006/main">
               <a:ext uri="{FF2B5EF4-FFF2-40B4-BE49-F238E27FC236}">
-                <a16:creationId xmlns:a16="http://schemas.microsoft.com/office/drawing/2014/main" id="{0E0ECD67-6937-474A-B261-9B53AAB1CFF1}"/>
+                <a16:creationId xmlns:a16="http://schemas.microsoft.com/office/drawing/2014/main" id="{7E065588-F364-431A-A2D2-3CB315D54E44}"/>
               </a:ext>
             </a:extLst>
           </p:cNvPr>
@@ -7068,7 +7068,7 @@
           <p:cNvPr id="43" name="">
             <a:extLst xmlns:a="http://schemas.openxmlformats.org/drawingml/2006/main">
               <a:ext uri="{FF2B5EF4-FFF2-40B4-BE49-F238E27FC236}">
-                <a16:creationId xmlns:a16="http://schemas.microsoft.com/office/drawing/2014/main" id="{2A7AD43A-1F5E-46DB-B46B-E3B78AC548E8}"/>
+                <a16:creationId xmlns:a16="http://schemas.microsoft.com/office/drawing/2014/main" id="{0E56C2A0-B13E-4574-B882-94EA5B4F64C9}"/>
               </a:ext>
             </a:extLst>
           </p:cNvPr>
@@ -7125,7 +7125,7 @@
           <p:cNvPr id="44" name="">
             <a:extLst xmlns:a="http://schemas.openxmlformats.org/drawingml/2006/main">
               <a:ext uri="{FF2B5EF4-FFF2-40B4-BE49-F238E27FC236}">
-                <a16:creationId xmlns:a16="http://schemas.microsoft.com/office/drawing/2014/main" id="{3F657399-F94B-4A6A-9F30-1F2FC1334F61}"/>
+                <a16:creationId xmlns:a16="http://schemas.microsoft.com/office/drawing/2014/main" id="{C98EBBEF-A3EF-4C21-9394-C495D0DBA70F}"/>
               </a:ext>
             </a:extLst>
           </p:cNvPr>
@@ -7182,7 +7182,7 @@
           <p:cNvPr id="45" name="">
             <a:extLst xmlns:a="http://schemas.openxmlformats.org/drawingml/2006/main">
               <a:ext uri="{FF2B5EF4-FFF2-40B4-BE49-F238E27FC236}">
-                <a16:creationId xmlns:a16="http://schemas.microsoft.com/office/drawing/2014/main" id="{9D48ED73-FCD2-4EFD-BA62-7640270E3397}"/>
+                <a16:creationId xmlns:a16="http://schemas.microsoft.com/office/drawing/2014/main" id="{BAD73FC2-6EF3-4DF3-B1AC-813D81AEFB6C}"/>
               </a:ext>
             </a:extLst>
           </p:cNvPr>
@@ -7239,7 +7239,7 @@
           <p:cNvPr id="46" name="">
             <a:extLst xmlns:a="http://schemas.openxmlformats.org/drawingml/2006/main">
               <a:ext uri="{FF2B5EF4-FFF2-40B4-BE49-F238E27FC236}">
-                <a16:creationId xmlns:a16="http://schemas.microsoft.com/office/drawing/2014/main" id="{4104CEC0-C62D-4808-B858-3A4ED8613DBE}"/>
+                <a16:creationId xmlns:a16="http://schemas.microsoft.com/office/drawing/2014/main" id="{B0454162-99EB-4ECF-8BC3-FB505542EA55}"/>
               </a:ext>
             </a:extLst>
           </p:cNvPr>
@@ -7296,7 +7296,7 @@
           <p:cNvPr id="47" name="">
             <a:extLst xmlns:a="http://schemas.openxmlformats.org/drawingml/2006/main">
               <a:ext uri="{FF2B5EF4-FFF2-40B4-BE49-F238E27FC236}">
-                <a16:creationId xmlns:a16="http://schemas.microsoft.com/office/drawing/2014/main" id="{83BB0B0F-E271-43B9-A98B-5F38D76DF74B}"/>
+                <a16:creationId xmlns:a16="http://schemas.microsoft.com/office/drawing/2014/main" id="{6801E986-52CD-4DC4-BFD0-D51E6A861214}"/>
               </a:ext>
             </a:extLst>
           </p:cNvPr>
@@ -7353,7 +7353,7 @@
           <p:cNvPr id="48" name="">
             <a:extLst xmlns:a="http://schemas.openxmlformats.org/drawingml/2006/main">
               <a:ext uri="{FF2B5EF4-FFF2-40B4-BE49-F238E27FC236}">
-                <a16:creationId xmlns:a16="http://schemas.microsoft.com/office/drawing/2014/main" id="{F6D57848-381E-4215-BF48-D7FF5FAE4AB8}"/>
+                <a16:creationId xmlns:a16="http://schemas.microsoft.com/office/drawing/2014/main" id="{80EFF33C-0656-4415-8EB5-99C5C9D79214}"/>
               </a:ext>
             </a:extLst>
           </p:cNvPr>
@@ -7408,7 +7408,7 @@
     </p:spTree>
     <p:extLst>
       <p:ext uri="{BB962C8B-B14F-4D97-AF65-F5344CB8AC3E}">
-        <p14:creationId xmlns:p14="http://schemas.microsoft.com/office/powerpoint/2010/main" val="379878265"/>
+        <p14:creationId xmlns:p14="http://schemas.microsoft.com/office/powerpoint/2010/main" val="1288085893"/>
       </p:ext>
     </p:extLst>
   </p:cSld>
@@ -7439,7 +7439,7 @@
           <p:cNvPr id="9" name="">
             <a:extLst xmlns:a="http://schemas.openxmlformats.org/drawingml/2006/main">
               <a:ext uri="{FF2B5EF4-FFF2-40B4-BE49-F238E27FC236}">
-                <a16:creationId xmlns:a16="http://schemas.microsoft.com/office/drawing/2014/main" id="{00C5CBA9-930C-4CBF-B2FF-032889E15A21}"/>
+                <a16:creationId xmlns:a16="http://schemas.microsoft.com/office/drawing/2014/main" id="{46DF5A70-CABB-43D0-8104-20B2830265CD}"/>
               </a:ext>
             </a:extLst>
           </p:cNvPr>
@@ -7496,7 +7496,7 @@
           <p:cNvPr id="2" name="">
             <a:extLst xmlns:a="http://schemas.openxmlformats.org/drawingml/2006/main">
               <a:ext uri="{FF2B5EF4-FFF2-40B4-BE49-F238E27FC236}">
-                <a16:creationId xmlns:a16="http://schemas.microsoft.com/office/drawing/2014/main" id="{7C9B564F-30EF-4C98-ADBB-A55B7A9E033A}"/>
+                <a16:creationId xmlns:a16="http://schemas.microsoft.com/office/drawing/2014/main" id="{CFD22F6D-9258-410E-B27B-8D0F4EB6BF95}"/>
               </a:ext>
             </a:extLst>
           </p:cNvPr>
@@ -7527,7 +7527,7 @@
           <p:cNvPr id="3" name="">
             <a:extLst xmlns:a="http://schemas.openxmlformats.org/drawingml/2006/main">
               <a:ext uri="{FF2B5EF4-FFF2-40B4-BE49-F238E27FC236}">
-                <a16:creationId xmlns:a16="http://schemas.microsoft.com/office/drawing/2014/main" id="{0B181375-ADEA-466C-8708-BC9058A9CC7C}"/>
+                <a16:creationId xmlns:a16="http://schemas.microsoft.com/office/drawing/2014/main" id="{CD42FECE-97C5-4927-8E0E-EC997377E169}"/>
               </a:ext>
             </a:extLst>
           </p:cNvPr>
@@ -7584,7 +7584,7 @@
           <p:cNvPr id="4" name="">
             <a:extLst xmlns:a="http://schemas.openxmlformats.org/drawingml/2006/main">
               <a:ext uri="{FF2B5EF4-FFF2-40B4-BE49-F238E27FC236}">
-                <a16:creationId xmlns:a16="http://schemas.microsoft.com/office/drawing/2014/main" id="{EA7F2A98-ACE5-4643-AAED-CA11E84F3D38}"/>
+                <a16:creationId xmlns:a16="http://schemas.microsoft.com/office/drawing/2014/main" id="{1BCC7E52-8FA5-4B69-91D2-93DC5177F872}"/>
               </a:ext>
             </a:extLst>
           </p:cNvPr>
@@ -7641,7 +7641,7 @@
           <p:cNvPr id="5" name="">
             <a:extLst xmlns:a="http://schemas.openxmlformats.org/drawingml/2006/main">
               <a:ext uri="{FF2B5EF4-FFF2-40B4-BE49-F238E27FC236}">
-                <a16:creationId xmlns:a16="http://schemas.microsoft.com/office/drawing/2014/main" id="{A47987C2-37F1-4EFC-BF1B-C2D331AE47A4}"/>
+                <a16:creationId xmlns:a16="http://schemas.microsoft.com/office/drawing/2014/main" id="{4A03868C-FDB1-43B5-AA73-359BEDBBE051}"/>
               </a:ext>
             </a:extLst>
           </p:cNvPr>
@@ -8210,7 +8210,7 @@
           <p:cNvPr id="7" name="">
             <a:extLst xmlns:a="http://schemas.openxmlformats.org/drawingml/2006/main">
               <a:ext uri="{FF2B5EF4-FFF2-40B4-BE49-F238E27FC236}">
-                <a16:creationId xmlns:a16="http://schemas.microsoft.com/office/drawing/2014/main" id="{A2FD24B7-10D8-4E2D-BC7D-3BFA6A87C5D6}"/>
+                <a16:creationId xmlns:a16="http://schemas.microsoft.com/office/drawing/2014/main" id="{65F09533-472C-4321-B50C-2E8DF31EFD21}"/>
               </a:ext>
             </a:extLst>
           </p:cNvPr>
@@ -8267,7 +8267,7 @@
           <p:cNvPr id="8" name="">
             <a:extLst xmlns:a="http://schemas.openxmlformats.org/drawingml/2006/main">
               <a:ext uri="{FF2B5EF4-FFF2-40B4-BE49-F238E27FC236}">
-                <a16:creationId xmlns:a16="http://schemas.microsoft.com/office/drawing/2014/main" id="{A9FE886E-E8D3-4162-84AD-2BEE46CF6CD0}"/>
+                <a16:creationId xmlns:a16="http://schemas.microsoft.com/office/drawing/2014/main" id="{EB260D3B-A3EB-40E0-89C8-64A99EFA3867}"/>
               </a:ext>
             </a:extLst>
           </p:cNvPr>
@@ -8345,7 +8345,7 @@
     </p:spTree>
     <p:extLst>
       <p:ext uri="{BB962C8B-B14F-4D97-AF65-F5344CB8AC3E}">
-        <p14:creationId xmlns:p14="http://schemas.microsoft.com/office/powerpoint/2010/main" val="604113006"/>
+        <p14:creationId xmlns:p14="http://schemas.microsoft.com/office/powerpoint/2010/main" val="859742892"/>
       </p:ext>
     </p:extLst>
   </p:cSld>
@@ -8532,7 +8532,7 @@
           <p:cNvPr id="58" name="">
             <a:extLst xmlns:a="http://schemas.openxmlformats.org/drawingml/2006/main">
               <a:ext uri="{FF2B5EF4-FFF2-40B4-BE49-F238E27FC236}">
-                <a16:creationId xmlns:a16="http://schemas.microsoft.com/office/drawing/2014/main" id="{ECA36D07-6580-408C-9728-713DAA6A14B1}"/>
+                <a16:creationId xmlns:a16="http://schemas.microsoft.com/office/drawing/2014/main" id="{D1685580-2D1F-4A9F-9B8E-233ADDC2DE6E}"/>
               </a:ext>
             </a:extLst>
           </p:cNvPr>
@@ -8589,7 +8589,7 @@
           <p:cNvPr id="2" name="">
             <a:extLst xmlns:a="http://schemas.openxmlformats.org/drawingml/2006/main">
               <a:ext uri="{FF2B5EF4-FFF2-40B4-BE49-F238E27FC236}">
-                <a16:creationId xmlns:a16="http://schemas.microsoft.com/office/drawing/2014/main" id="{48160102-DE9C-419C-BB55-4775BC82B7B6}"/>
+                <a16:creationId xmlns:a16="http://schemas.microsoft.com/office/drawing/2014/main" id="{12BA7707-C2ED-4152-A23B-10486E02AD93}"/>
               </a:ext>
             </a:extLst>
           </p:cNvPr>
@@ -8620,7 +8620,7 @@
           <p:cNvPr id="3" name="">
             <a:extLst xmlns:a="http://schemas.openxmlformats.org/drawingml/2006/main">
               <a:ext uri="{FF2B5EF4-FFF2-40B4-BE49-F238E27FC236}">
-                <a16:creationId xmlns:a16="http://schemas.microsoft.com/office/drawing/2014/main" id="{F73ADEA1-3275-43B4-828D-C90EB38BE290}"/>
+                <a16:creationId xmlns:a16="http://schemas.microsoft.com/office/drawing/2014/main" id="{721689E8-EE2D-49B2-9BDF-914D32E9BCE5}"/>
               </a:ext>
             </a:extLst>
           </p:cNvPr>
@@ -8677,7 +8677,7 @@
           <p:cNvPr id="4" name="">
             <a:extLst xmlns:a="http://schemas.openxmlformats.org/drawingml/2006/main">
               <a:ext uri="{FF2B5EF4-FFF2-40B4-BE49-F238E27FC236}">
-                <a16:creationId xmlns:a16="http://schemas.microsoft.com/office/drawing/2014/main" id="{5E24969C-70A7-4103-92F7-47E11DEC74D6}"/>
+                <a16:creationId xmlns:a16="http://schemas.microsoft.com/office/drawing/2014/main" id="{4BBD3791-5A83-448B-B1E0-69D834CD7BB2}"/>
               </a:ext>
             </a:extLst>
           </p:cNvPr>
@@ -8734,7 +8734,7 @@
           <p:cNvPr id="5" name="">
             <a:extLst xmlns:a="http://schemas.openxmlformats.org/drawingml/2006/main">
               <a:ext uri="{FF2B5EF4-FFF2-40B4-BE49-F238E27FC236}">
-                <a16:creationId xmlns:a16="http://schemas.microsoft.com/office/drawing/2014/main" id="{361F6340-3321-47C8-8F63-1E8A43E4684C}"/>
+                <a16:creationId xmlns:a16="http://schemas.microsoft.com/office/drawing/2014/main" id="{CF794562-EFCD-48E7-B673-4A54B5E941A2}"/>
               </a:ext>
             </a:extLst>
           </p:cNvPr>
@@ -8791,7 +8791,7 @@
           <p:cNvPr id="6" name="">
             <a:extLst xmlns:a="http://schemas.openxmlformats.org/drawingml/2006/main">
               <a:ext uri="{FF2B5EF4-FFF2-40B4-BE49-F238E27FC236}">
-                <a16:creationId xmlns:a16="http://schemas.microsoft.com/office/drawing/2014/main" id="{20033E2A-E41E-4971-8762-AF2A872080EE}"/>
+                <a16:creationId xmlns:a16="http://schemas.microsoft.com/office/drawing/2014/main" id="{F6F44DE8-77D2-4A5D-BB74-0B98B9923224}"/>
               </a:ext>
             </a:extLst>
           </p:cNvPr>
@@ -8848,7 +8848,7 @@
           <p:cNvPr id="7" name="">
             <a:extLst xmlns:a="http://schemas.openxmlformats.org/drawingml/2006/main">
               <a:ext uri="{FF2B5EF4-FFF2-40B4-BE49-F238E27FC236}">
-                <a16:creationId xmlns:a16="http://schemas.microsoft.com/office/drawing/2014/main" id="{9680DD5A-7089-4073-BA25-70BC49D9673A}"/>
+                <a16:creationId xmlns:a16="http://schemas.microsoft.com/office/drawing/2014/main" id="{F2A7AC9A-1A44-41BD-9205-E54FF8F59E46}"/>
               </a:ext>
             </a:extLst>
           </p:cNvPr>
@@ -8897,7 +8897,7 @@
           <p:cNvPr id="8" name="">
             <a:extLst xmlns:a="http://schemas.openxmlformats.org/drawingml/2006/main">
               <a:ext uri="{FF2B5EF4-FFF2-40B4-BE49-F238E27FC236}">
-                <a16:creationId xmlns:a16="http://schemas.microsoft.com/office/drawing/2014/main" id="{D4D74EBC-E193-4F07-AC11-1A14D137C50D}"/>
+                <a16:creationId xmlns:a16="http://schemas.microsoft.com/office/drawing/2014/main" id="{37B07775-13D4-4E6A-BB58-268666DFB516}"/>
               </a:ext>
             </a:extLst>
           </p:cNvPr>
@@ -8940,7 +8940,7 @@
           <p:cNvPr id="9" name="">
             <a:extLst xmlns:a="http://schemas.openxmlformats.org/drawingml/2006/main">
               <a:ext uri="{FF2B5EF4-FFF2-40B4-BE49-F238E27FC236}">
-                <a16:creationId xmlns:a16="http://schemas.microsoft.com/office/drawing/2014/main" id="{F1E26D8D-2933-4429-9C02-FCF19F7C46B0}"/>
+                <a16:creationId xmlns:a16="http://schemas.microsoft.com/office/drawing/2014/main" id="{24B05BF4-600F-4F4B-9E8D-FD9203647FE3}"/>
               </a:ext>
             </a:extLst>
           </p:cNvPr>
@@ -8986,7 +8986,7 @@
           <p:cNvPr id="10" name="">
             <a:extLst xmlns:a="http://schemas.openxmlformats.org/drawingml/2006/main">
               <a:ext uri="{FF2B5EF4-FFF2-40B4-BE49-F238E27FC236}">
-                <a16:creationId xmlns:a16="http://schemas.microsoft.com/office/drawing/2014/main" id="{588197D6-DF42-466A-A0B0-6C93C5B0FBE1}"/>
+                <a16:creationId xmlns:a16="http://schemas.microsoft.com/office/drawing/2014/main" id="{050B3F5D-6FB4-4B84-A02C-0C641BA3D848}"/>
               </a:ext>
             </a:extLst>
           </p:cNvPr>
@@ -9029,7 +9029,7 @@
           <p:cNvPr id="11" name="">
             <a:extLst xmlns:a="http://schemas.openxmlformats.org/drawingml/2006/main">
               <a:ext uri="{FF2B5EF4-FFF2-40B4-BE49-F238E27FC236}">
-                <a16:creationId xmlns:a16="http://schemas.microsoft.com/office/drawing/2014/main" id="{115E8E3D-E4D6-4DFB-9F19-DB90B4635260}"/>
+                <a16:creationId xmlns:a16="http://schemas.microsoft.com/office/drawing/2014/main" id="{304E8CB6-86AF-47CC-8D4E-CF0DA5062565}"/>
               </a:ext>
             </a:extLst>
           </p:cNvPr>
@@ -9075,7 +9075,7 @@
           <p:cNvPr id="12" name="">
             <a:extLst xmlns:a="http://schemas.openxmlformats.org/drawingml/2006/main">
               <a:ext uri="{FF2B5EF4-FFF2-40B4-BE49-F238E27FC236}">
-                <a16:creationId xmlns:a16="http://schemas.microsoft.com/office/drawing/2014/main" id="{DF86F5B6-9E29-4D1D-AFF6-6D2DD88A8C84}"/>
+                <a16:creationId xmlns:a16="http://schemas.microsoft.com/office/drawing/2014/main" id="{6B0EE5F9-05AA-4CCA-8C64-C9EADBC29FDA}"/>
               </a:ext>
             </a:extLst>
           </p:cNvPr>
@@ -9118,7 +9118,7 @@
           <p:cNvPr id="13" name="">
             <a:extLst xmlns:a="http://schemas.openxmlformats.org/drawingml/2006/main">
               <a:ext uri="{FF2B5EF4-FFF2-40B4-BE49-F238E27FC236}">
-                <a16:creationId xmlns:a16="http://schemas.microsoft.com/office/drawing/2014/main" id="{07038968-D9CB-4838-BE9B-73C7B8E9FD9E}"/>
+                <a16:creationId xmlns:a16="http://schemas.microsoft.com/office/drawing/2014/main" id="{C4EE3344-112E-42CE-BEA8-73F5792E17FF}"/>
               </a:ext>
             </a:extLst>
           </p:cNvPr>
@@ -9164,7 +9164,7 @@
           <p:cNvPr id="14" name="">
             <a:extLst xmlns:a="http://schemas.openxmlformats.org/drawingml/2006/main">
               <a:ext uri="{FF2B5EF4-FFF2-40B4-BE49-F238E27FC236}">
-                <a16:creationId xmlns:a16="http://schemas.microsoft.com/office/drawing/2014/main" id="{353403E0-8554-4C4D-B75D-2494DD8DA549}"/>
+                <a16:creationId xmlns:a16="http://schemas.microsoft.com/office/drawing/2014/main" id="{4A72EB5E-6705-4A3A-8146-EB2507122B8C}"/>
               </a:ext>
             </a:extLst>
           </p:cNvPr>
@@ -9207,7 +9207,7 @@
           <p:cNvPr id="15" name="">
             <a:extLst xmlns:a="http://schemas.openxmlformats.org/drawingml/2006/main">
               <a:ext uri="{FF2B5EF4-FFF2-40B4-BE49-F238E27FC236}">
-                <a16:creationId xmlns:a16="http://schemas.microsoft.com/office/drawing/2014/main" id="{5AEE6728-9E8D-4B89-9E26-874D0821BA11}"/>
+                <a16:creationId xmlns:a16="http://schemas.microsoft.com/office/drawing/2014/main" id="{4B3E6223-C6EB-4328-9D72-4A4D0DD8A33D}"/>
               </a:ext>
             </a:extLst>
           </p:cNvPr>
@@ -9259,7 +9259,7 @@
           <p:cNvPr id="16" name="">
             <a:extLst xmlns:a="http://schemas.openxmlformats.org/drawingml/2006/main">
               <a:ext uri="{FF2B5EF4-FFF2-40B4-BE49-F238E27FC236}">
-                <a16:creationId xmlns:a16="http://schemas.microsoft.com/office/drawing/2014/main" id="{A5EEFCA0-3E65-46C4-B18F-4B8F7A5D97A9}"/>
+                <a16:creationId xmlns:a16="http://schemas.microsoft.com/office/drawing/2014/main" id="{9772AAE2-B9B4-48D2-8D9C-EFCFCF99DCB4}"/>
               </a:ext>
             </a:extLst>
           </p:cNvPr>
@@ -9302,7 +9302,7 @@
           <p:cNvPr id="17" name="">
             <a:extLst xmlns:a="http://schemas.openxmlformats.org/drawingml/2006/main">
               <a:ext uri="{FF2B5EF4-FFF2-40B4-BE49-F238E27FC236}">
-                <a16:creationId xmlns:a16="http://schemas.microsoft.com/office/drawing/2014/main" id="{495CC401-F4F5-451A-AACA-166DD44F8AD1}"/>
+                <a16:creationId xmlns:a16="http://schemas.microsoft.com/office/drawing/2014/main" id="{FEF85DC0-5458-4BE4-8969-05D65E68FFB7}"/>
               </a:ext>
             </a:extLst>
           </p:cNvPr>
@@ -9335,7 +9335,7 @@
           <p:cNvPr id="18" name="">
             <a:extLst xmlns:a="http://schemas.openxmlformats.org/drawingml/2006/main">
               <a:ext uri="{FF2B5EF4-FFF2-40B4-BE49-F238E27FC236}">
-                <a16:creationId xmlns:a16="http://schemas.microsoft.com/office/drawing/2014/main" id="{C08594D2-1D80-449E-ACD9-C874A78AD400}"/>
+                <a16:creationId xmlns:a16="http://schemas.microsoft.com/office/drawing/2014/main" id="{DE24B02D-201A-4C8E-95C5-85CD54105147}"/>
               </a:ext>
             </a:extLst>
           </p:cNvPr>
@@ -9415,7 +9415,7 @@
           <p:cNvPr id="19" name="">
             <a:extLst xmlns:a="http://schemas.openxmlformats.org/drawingml/2006/main">
               <a:ext uri="{FF2B5EF4-FFF2-40B4-BE49-F238E27FC236}">
-                <a16:creationId xmlns:a16="http://schemas.microsoft.com/office/drawing/2014/main" id="{B0BCF35A-7B4C-44D3-9B21-A741B3587FFE}"/>
+                <a16:creationId xmlns:a16="http://schemas.microsoft.com/office/drawing/2014/main" id="{A50D4BF3-3D9C-490E-8A00-372185EC7C0C}"/>
               </a:ext>
             </a:extLst>
           </p:cNvPr>
@@ -9448,7 +9448,7 @@
           <p:cNvPr id="20" name="">
             <a:extLst xmlns:a="http://schemas.openxmlformats.org/drawingml/2006/main">
               <a:ext uri="{FF2B5EF4-FFF2-40B4-BE49-F238E27FC236}">
-                <a16:creationId xmlns:a16="http://schemas.microsoft.com/office/drawing/2014/main" id="{FD5F5064-8EE0-4A3E-9686-BB8C499CD584}"/>
+                <a16:creationId xmlns:a16="http://schemas.microsoft.com/office/drawing/2014/main" id="{11256B1B-DC04-49A5-A691-D17C2BDC6594}"/>
               </a:ext>
             </a:extLst>
           </p:cNvPr>
@@ -9551,7 +9551,7 @@
           <p:cNvPr id="21" name="">
             <a:extLst xmlns:a="http://schemas.openxmlformats.org/drawingml/2006/main">
               <a:ext uri="{FF2B5EF4-FFF2-40B4-BE49-F238E27FC236}">
-                <a16:creationId xmlns:a16="http://schemas.microsoft.com/office/drawing/2014/main" id="{8260888C-A6B7-43AE-9161-02CB471B2C32}"/>
+                <a16:creationId xmlns:a16="http://schemas.microsoft.com/office/drawing/2014/main" id="{9CDBE4DE-324A-4A59-8D60-DD1D9B8060DC}"/>
               </a:ext>
             </a:extLst>
           </p:cNvPr>
@@ -9584,7 +9584,7 @@
           <p:cNvPr id="22" name="">
             <a:extLst xmlns:a="http://schemas.openxmlformats.org/drawingml/2006/main">
               <a:ext uri="{FF2B5EF4-FFF2-40B4-BE49-F238E27FC236}">
-                <a16:creationId xmlns:a16="http://schemas.microsoft.com/office/drawing/2014/main" id="{CA38270F-3CA2-4F87-B4AD-2A22600ABA8F}"/>
+                <a16:creationId xmlns:a16="http://schemas.microsoft.com/office/drawing/2014/main" id="{848DDC07-43AD-448F-979B-B4B64A3E6C70}"/>
               </a:ext>
             </a:extLst>
           </p:cNvPr>
@@ -9664,7 +9664,7 @@
           <p:cNvPr id="23" name="">
             <a:extLst xmlns:a="http://schemas.openxmlformats.org/drawingml/2006/main">
               <a:ext uri="{FF2B5EF4-FFF2-40B4-BE49-F238E27FC236}">
-                <a16:creationId xmlns:a16="http://schemas.microsoft.com/office/drawing/2014/main" id="{FF3F7AC0-5091-463B-A370-81AA756167CE}"/>
+                <a16:creationId xmlns:a16="http://schemas.microsoft.com/office/drawing/2014/main" id="{E46E7D63-76F1-4B52-BEA5-093AC85CE8F3}"/>
               </a:ext>
             </a:extLst>
           </p:cNvPr>
@@ -9697,7 +9697,7 @@
           <p:cNvPr id="24" name="">
             <a:extLst xmlns:a="http://schemas.openxmlformats.org/drawingml/2006/main">
               <a:ext uri="{FF2B5EF4-FFF2-40B4-BE49-F238E27FC236}">
-                <a16:creationId xmlns:a16="http://schemas.microsoft.com/office/drawing/2014/main" id="{C425A202-CE4D-44DB-B22E-BDAACCBECCB1}"/>
+                <a16:creationId xmlns:a16="http://schemas.microsoft.com/office/drawing/2014/main" id="{EF7A57C5-58A7-43E1-84E7-EF90BD6578AE}"/>
               </a:ext>
             </a:extLst>
           </p:cNvPr>
@@ -9777,7 +9777,7 @@
           <p:cNvPr id="25" name="">
             <a:extLst xmlns:a="http://schemas.openxmlformats.org/drawingml/2006/main">
               <a:ext uri="{FF2B5EF4-FFF2-40B4-BE49-F238E27FC236}">
-                <a16:creationId xmlns:a16="http://schemas.microsoft.com/office/drawing/2014/main" id="{2959CB14-5198-406F-936B-0CE5AC6AE1DD}"/>
+                <a16:creationId xmlns:a16="http://schemas.microsoft.com/office/drawing/2014/main" id="{A846C54A-61B5-49EB-A2AA-8916F704064F}"/>
               </a:ext>
             </a:extLst>
           </p:cNvPr>
@@ -9810,7 +9810,7 @@
           <p:cNvPr id="26" name="">
             <a:extLst xmlns:a="http://schemas.openxmlformats.org/drawingml/2006/main">
               <a:ext uri="{FF2B5EF4-FFF2-40B4-BE49-F238E27FC236}">
-                <a16:creationId xmlns:a16="http://schemas.microsoft.com/office/drawing/2014/main" id="{04CC258C-AC4E-42D4-9F17-DC3C73A326C2}"/>
+                <a16:creationId xmlns:a16="http://schemas.microsoft.com/office/drawing/2014/main" id="{F6FAF461-AF04-42A6-8804-00F134B4C90F}"/>
               </a:ext>
             </a:extLst>
           </p:cNvPr>
@@ -9890,7 +9890,7 @@
           <p:cNvPr id="31" name="">
             <a:extLst xmlns:a="http://schemas.openxmlformats.org/drawingml/2006/main">
               <a:ext uri="{FF2B5EF4-FFF2-40B4-BE49-F238E27FC236}">
-                <a16:creationId xmlns:a16="http://schemas.microsoft.com/office/drawing/2014/main" id="{53F7C771-9BCC-4663-A342-55394DA9FF7F}"/>
+                <a16:creationId xmlns:a16="http://schemas.microsoft.com/office/drawing/2014/main" id="{E1C64D90-B013-4C46-99E8-CBA76B90E8A8}"/>
               </a:ext>
             </a:extLst>
           </p:cNvPr>
@@ -9923,7 +9923,7 @@
           <p:cNvPr id="32" name="">
             <a:extLst xmlns:a="http://schemas.openxmlformats.org/drawingml/2006/main">
               <a:ext uri="{FF2B5EF4-FFF2-40B4-BE49-F238E27FC236}">
-                <a16:creationId xmlns:a16="http://schemas.microsoft.com/office/drawing/2014/main" id="{97D1907B-0F2B-423A-8DEA-21F021A3B437}"/>
+                <a16:creationId xmlns:a16="http://schemas.microsoft.com/office/drawing/2014/main" id="{C50C6019-B208-4301-BBF3-B012058EBA58}"/>
               </a:ext>
             </a:extLst>
           </p:cNvPr>
@@ -10003,7 +10003,7 @@
           <p:cNvPr id="33" name="">
             <a:extLst xmlns:a="http://schemas.openxmlformats.org/drawingml/2006/main">
               <a:ext uri="{FF2B5EF4-FFF2-40B4-BE49-F238E27FC236}">
-                <a16:creationId xmlns:a16="http://schemas.microsoft.com/office/drawing/2014/main" id="{72A8325A-D9A6-4263-94CC-AEFC048314D1}"/>
+                <a16:creationId xmlns:a16="http://schemas.microsoft.com/office/drawing/2014/main" id="{D6791283-D580-4B7E-AD48-D0A17F97A193}"/>
               </a:ext>
             </a:extLst>
           </p:cNvPr>
@@ -10083,7 +10083,7 @@
           <p:cNvPr id="34" name="">
             <a:extLst xmlns:a="http://schemas.openxmlformats.org/drawingml/2006/main">
               <a:ext uri="{FF2B5EF4-FFF2-40B4-BE49-F238E27FC236}">
-                <a16:creationId xmlns:a16="http://schemas.microsoft.com/office/drawing/2014/main" id="{6A06332A-C360-46F6-A741-63D0D8A32041}"/>
+                <a16:creationId xmlns:a16="http://schemas.microsoft.com/office/drawing/2014/main" id="{740884A1-A114-498E-9E22-D4DDAF470BDA}"/>
               </a:ext>
             </a:extLst>
           </p:cNvPr>
@@ -10116,7 +10116,7 @@
           <p:cNvPr id="35" name="">
             <a:extLst xmlns:a="http://schemas.openxmlformats.org/drawingml/2006/main">
               <a:ext uri="{FF2B5EF4-FFF2-40B4-BE49-F238E27FC236}">
-                <a16:creationId xmlns:a16="http://schemas.microsoft.com/office/drawing/2014/main" id="{7E23C44A-5F14-42C1-84FC-47256A36EFCF}"/>
+                <a16:creationId xmlns:a16="http://schemas.microsoft.com/office/drawing/2014/main" id="{8800BFA1-0DCF-4D5D-ACC2-69C8A8B066A1}"/>
               </a:ext>
             </a:extLst>
           </p:cNvPr>
@@ -10173,7 +10173,7 @@
           <p:cNvPr id="36" name="">
             <a:extLst xmlns:a="http://schemas.openxmlformats.org/drawingml/2006/main">
               <a:ext uri="{FF2B5EF4-FFF2-40B4-BE49-F238E27FC236}">
-                <a16:creationId xmlns:a16="http://schemas.microsoft.com/office/drawing/2014/main" id="{D5C0A306-7177-46CC-8243-E461AC299B1C}"/>
+                <a16:creationId xmlns:a16="http://schemas.microsoft.com/office/drawing/2014/main" id="{F87B5CBC-7643-469E-A375-0665A4C26B90}"/>
               </a:ext>
             </a:extLst>
           </p:cNvPr>
@@ -10253,7 +10253,7 @@
           <p:cNvPr id="37" name="">
             <a:extLst xmlns:a="http://schemas.openxmlformats.org/drawingml/2006/main">
               <a:ext uri="{FF2B5EF4-FFF2-40B4-BE49-F238E27FC236}">
-                <a16:creationId xmlns:a16="http://schemas.microsoft.com/office/drawing/2014/main" id="{7AEBA66A-0152-47FA-B647-54A77D81ABD8}"/>
+                <a16:creationId xmlns:a16="http://schemas.microsoft.com/office/drawing/2014/main" id="{1A3C97EC-4344-4C08-9A5D-94787457A1FD}"/>
               </a:ext>
             </a:extLst>
           </p:cNvPr>
@@ -10286,7 +10286,7 @@
           <p:cNvPr id="38" name="">
             <a:extLst xmlns:a="http://schemas.openxmlformats.org/drawingml/2006/main">
               <a:ext uri="{FF2B5EF4-FFF2-40B4-BE49-F238E27FC236}">
-                <a16:creationId xmlns:a16="http://schemas.microsoft.com/office/drawing/2014/main" id="{4C01ADCE-6153-4C42-AA1F-F741DE355820}"/>
+                <a16:creationId xmlns:a16="http://schemas.microsoft.com/office/drawing/2014/main" id="{55B05C80-ECE3-459B-824A-0DAF9401B991}"/>
               </a:ext>
             </a:extLst>
           </p:cNvPr>
@@ -10366,7 +10366,7 @@
           <p:cNvPr id="39" name="">
             <a:extLst xmlns:a="http://schemas.openxmlformats.org/drawingml/2006/main">
               <a:ext uri="{FF2B5EF4-FFF2-40B4-BE49-F238E27FC236}">
-                <a16:creationId xmlns:a16="http://schemas.microsoft.com/office/drawing/2014/main" id="{5ACFEEF2-2905-4FA4-A485-81B500EA7976}"/>
+                <a16:creationId xmlns:a16="http://schemas.microsoft.com/office/drawing/2014/main" id="{7978E11A-C14A-471A-BC2B-49C1A2892816}"/>
               </a:ext>
             </a:extLst>
           </p:cNvPr>
@@ -10399,7 +10399,7 @@
           <p:cNvPr id="40" name="">
             <a:extLst xmlns:a="http://schemas.openxmlformats.org/drawingml/2006/main">
               <a:ext uri="{FF2B5EF4-FFF2-40B4-BE49-F238E27FC236}">
-                <a16:creationId xmlns:a16="http://schemas.microsoft.com/office/drawing/2014/main" id="{DFD9468A-0F57-46F0-B842-35DC38FA0850}"/>
+                <a16:creationId xmlns:a16="http://schemas.microsoft.com/office/drawing/2014/main" id="{79510CC5-E602-4BEA-81EC-84829DD7A521}"/>
               </a:ext>
             </a:extLst>
           </p:cNvPr>
@@ -10479,7 +10479,7 @@
           <p:cNvPr id="43" name="">
             <a:extLst xmlns:a="http://schemas.openxmlformats.org/drawingml/2006/main">
               <a:ext uri="{FF2B5EF4-FFF2-40B4-BE49-F238E27FC236}">
-                <a16:creationId xmlns:a16="http://schemas.microsoft.com/office/drawing/2014/main" id="{F8E54E47-A7D5-43AF-987F-3E6176367731}"/>
+                <a16:creationId xmlns:a16="http://schemas.microsoft.com/office/drawing/2014/main" id="{B6E45796-14C1-4467-8903-FC7FADFDCEB9}"/>
               </a:ext>
             </a:extLst>
           </p:cNvPr>
@@ -10536,7 +10536,7 @@
           <p:cNvPr id="44" name="">
             <a:extLst xmlns:a="http://schemas.openxmlformats.org/drawingml/2006/main">
               <a:ext uri="{FF2B5EF4-FFF2-40B4-BE49-F238E27FC236}">
-                <a16:creationId xmlns:a16="http://schemas.microsoft.com/office/drawing/2014/main" id="{2881E5CF-6BB5-410E-9567-D66ACDE22330}"/>
+                <a16:creationId xmlns:a16="http://schemas.microsoft.com/office/drawing/2014/main" id="{F2C5F20A-11F9-4E42-9448-BC6B155E876D}"/>
               </a:ext>
             </a:extLst>
           </p:cNvPr>
@@ -10567,7 +10567,7 @@
           <p:cNvPr id="45" name="">
             <a:extLst xmlns:a="http://schemas.openxmlformats.org/drawingml/2006/main">
               <a:ext uri="{FF2B5EF4-FFF2-40B4-BE49-F238E27FC236}">
-                <a16:creationId xmlns:a16="http://schemas.microsoft.com/office/drawing/2014/main" id="{89A30CFC-C568-4036-B8B0-A380A8F4CDDC}"/>
+                <a16:creationId xmlns:a16="http://schemas.microsoft.com/office/drawing/2014/main" id="{F91EB375-BD13-4C04-A27D-4CC31ABFAA76}"/>
               </a:ext>
             </a:extLst>
           </p:cNvPr>
@@ -10624,7 +10624,7 @@
           <p:cNvPr id="46" name="">
             <a:extLst xmlns:a="http://schemas.openxmlformats.org/drawingml/2006/main">
               <a:ext uri="{FF2B5EF4-FFF2-40B4-BE49-F238E27FC236}">
-                <a16:creationId xmlns:a16="http://schemas.microsoft.com/office/drawing/2014/main" id="{8F9B6298-DA45-405E-9ADA-952F2EA9A686}"/>
+                <a16:creationId xmlns:a16="http://schemas.microsoft.com/office/drawing/2014/main" id="{FF6FDED3-3CC0-4475-B364-9967E60C4136}"/>
               </a:ext>
             </a:extLst>
           </p:cNvPr>
@@ -10704,7 +10704,7 @@
           <p:cNvPr id="47" name="">
             <a:extLst xmlns:a="http://schemas.openxmlformats.org/drawingml/2006/main">
               <a:ext uri="{FF2B5EF4-FFF2-40B4-BE49-F238E27FC236}">
-                <a16:creationId xmlns:a16="http://schemas.microsoft.com/office/drawing/2014/main" id="{0AA5A0E5-31FE-4990-AD1B-FD110F39629D}"/>
+                <a16:creationId xmlns:a16="http://schemas.microsoft.com/office/drawing/2014/main" id="{2697EF52-D1F3-4794-A965-E9E4846CB724}"/>
               </a:ext>
             </a:extLst>
           </p:cNvPr>
@@ -10761,7 +10761,7 @@
           <p:cNvPr id="48" name="">
             <a:extLst xmlns:a="http://schemas.openxmlformats.org/drawingml/2006/main">
               <a:ext uri="{FF2B5EF4-FFF2-40B4-BE49-F238E27FC236}">
-                <a16:creationId xmlns:a16="http://schemas.microsoft.com/office/drawing/2014/main" id="{43202220-171C-4191-8D7B-226CF707F877}"/>
+                <a16:creationId xmlns:a16="http://schemas.microsoft.com/office/drawing/2014/main" id="{7ABEBBD2-89D0-4AA4-90B0-6243D34BAFFD}"/>
               </a:ext>
             </a:extLst>
           </p:cNvPr>
@@ -10841,7 +10841,7 @@
           <p:cNvPr id="49" name="">
             <a:extLst xmlns:a="http://schemas.openxmlformats.org/drawingml/2006/main">
               <a:ext uri="{FF2B5EF4-FFF2-40B4-BE49-F238E27FC236}">
-                <a16:creationId xmlns:a16="http://schemas.microsoft.com/office/drawing/2014/main" id="{F4A209BE-F4C3-4003-A5CD-56B52A3C57A2}"/>
+                <a16:creationId xmlns:a16="http://schemas.microsoft.com/office/drawing/2014/main" id="{A5131BB9-E0EA-49BB-95F8-BFB7525FA1B2}"/>
               </a:ext>
             </a:extLst>
           </p:cNvPr>
@@ -10898,7 +10898,7 @@
           <p:cNvPr id="50" name="">
             <a:extLst xmlns:a="http://schemas.openxmlformats.org/drawingml/2006/main">
               <a:ext uri="{FF2B5EF4-FFF2-40B4-BE49-F238E27FC236}">
-                <a16:creationId xmlns:a16="http://schemas.microsoft.com/office/drawing/2014/main" id="{47E1A177-A241-4491-ABE9-6DCC175378D9}"/>
+                <a16:creationId xmlns:a16="http://schemas.microsoft.com/office/drawing/2014/main" id="{8DC94EDF-DD4A-4DCC-87D3-9474A231AE8A}"/>
               </a:ext>
             </a:extLst>
           </p:cNvPr>
@@ -10978,7 +10978,7 @@
           <p:cNvPr id="51" name="">
             <a:extLst xmlns:a="http://schemas.openxmlformats.org/drawingml/2006/main">
               <a:ext uri="{FF2B5EF4-FFF2-40B4-BE49-F238E27FC236}">
-                <a16:creationId xmlns:a16="http://schemas.microsoft.com/office/drawing/2014/main" id="{39135E7B-E209-45AB-AA0B-A9D56C894F1A}"/>
+                <a16:creationId xmlns:a16="http://schemas.microsoft.com/office/drawing/2014/main" id="{329EEAA4-EBB4-4039-9DB7-5B5012CFC9E8}"/>
               </a:ext>
             </a:extLst>
           </p:cNvPr>
@@ -11033,7 +11033,7 @@
     </p:spTree>
     <p:extLst>
       <p:ext uri="{BB962C8B-B14F-4D97-AF65-F5344CB8AC3E}">
-        <p14:creationId xmlns:p14="http://schemas.microsoft.com/office/powerpoint/2010/main" val="160127350"/>
+        <p14:creationId xmlns:p14="http://schemas.microsoft.com/office/powerpoint/2010/main" val="1557323077"/>
       </p:ext>
     </p:extLst>
   </p:cSld>
@@ -11116,7 +11116,7 @@
           <p:cNvPr id="21" name="">
             <a:extLst xmlns:a="http://schemas.openxmlformats.org/drawingml/2006/main">
               <a:ext uri="{FF2B5EF4-FFF2-40B4-BE49-F238E27FC236}">
-                <a16:creationId xmlns:a16="http://schemas.microsoft.com/office/drawing/2014/main" id="{2720E16E-5206-425E-832C-A8C4234D5D00}"/>
+                <a16:creationId xmlns:a16="http://schemas.microsoft.com/office/drawing/2014/main" id="{FEC311F6-0BA4-4BE3-8BFD-0368004EF02D}"/>
               </a:ext>
             </a:extLst>
           </p:cNvPr>
@@ -11173,7 +11173,7 @@
           <p:cNvPr id="2" name="">
             <a:extLst xmlns:a="http://schemas.openxmlformats.org/drawingml/2006/main">
               <a:ext uri="{FF2B5EF4-FFF2-40B4-BE49-F238E27FC236}">
-                <a16:creationId xmlns:a16="http://schemas.microsoft.com/office/drawing/2014/main" id="{A991CC0F-1310-4BB5-9DF9-E64858A6E5D3}"/>
+                <a16:creationId xmlns:a16="http://schemas.microsoft.com/office/drawing/2014/main" id="{0ABB76D7-AF86-4672-A7DE-07D96532901C}"/>
               </a:ext>
             </a:extLst>
           </p:cNvPr>
@@ -11204,7 +11204,7 @@
           <p:cNvPr id="3" name="">
             <a:extLst xmlns:a="http://schemas.openxmlformats.org/drawingml/2006/main">
               <a:ext uri="{FF2B5EF4-FFF2-40B4-BE49-F238E27FC236}">
-                <a16:creationId xmlns:a16="http://schemas.microsoft.com/office/drawing/2014/main" id="{6861AAF6-9D19-4B70-9B33-0C49BA276ADC}"/>
+                <a16:creationId xmlns:a16="http://schemas.microsoft.com/office/drawing/2014/main" id="{7980B3B9-F68D-4C71-8B4C-B4F3D65C79A5}"/>
               </a:ext>
             </a:extLst>
           </p:cNvPr>
@@ -11261,7 +11261,7 @@
           <p:cNvPr id="4" name="">
             <a:extLst xmlns:a="http://schemas.openxmlformats.org/drawingml/2006/main">
               <a:ext uri="{FF2B5EF4-FFF2-40B4-BE49-F238E27FC236}">
-                <a16:creationId xmlns:a16="http://schemas.microsoft.com/office/drawing/2014/main" id="{7D42E2A4-3D81-42D3-8E40-CEEFE3DEBD21}"/>
+                <a16:creationId xmlns:a16="http://schemas.microsoft.com/office/drawing/2014/main" id="{D9F74882-D04E-42EC-863C-D0B7F2FAC039}"/>
               </a:ext>
             </a:extLst>
           </p:cNvPr>
@@ -11318,7 +11318,7 @@
           <p:cNvPr id="5" name="">
             <a:extLst xmlns:a="http://schemas.openxmlformats.org/drawingml/2006/main">
               <a:ext uri="{FF2B5EF4-FFF2-40B4-BE49-F238E27FC236}">
-                <a16:creationId xmlns:a16="http://schemas.microsoft.com/office/drawing/2014/main" id="{B379BC23-EAEE-4C6B-AB3F-D364262C81EC}"/>
+                <a16:creationId xmlns:a16="http://schemas.microsoft.com/office/drawing/2014/main" id="{38F8D421-0997-4034-9E75-C9B1CFEDEBAE}"/>
               </a:ext>
             </a:extLst>
           </p:cNvPr>
@@ -11690,7 +11690,7 @@
           <p:cNvPr id="7" name="">
             <a:extLst xmlns:a="http://schemas.openxmlformats.org/drawingml/2006/main">
               <a:ext uri="{FF2B5EF4-FFF2-40B4-BE49-F238E27FC236}">
-                <a16:creationId xmlns:a16="http://schemas.microsoft.com/office/drawing/2014/main" id="{554F3A34-393E-42CF-8A7C-E05F540A7CA2}"/>
+                <a16:creationId xmlns:a16="http://schemas.microsoft.com/office/drawing/2014/main" id="{CE34AF63-3AA9-42F3-B48D-161CF23461AB}"/>
               </a:ext>
             </a:extLst>
           </p:cNvPr>
@@ -11747,7 +11747,7 @@
           <p:cNvPr id="8" name="">
             <a:extLst xmlns:a="http://schemas.openxmlformats.org/drawingml/2006/main">
               <a:ext uri="{FF2B5EF4-FFF2-40B4-BE49-F238E27FC236}">
-                <a16:creationId xmlns:a16="http://schemas.microsoft.com/office/drawing/2014/main" id="{68B754B3-0F65-4175-BD84-3222742B8274}"/>
+                <a16:creationId xmlns:a16="http://schemas.microsoft.com/office/drawing/2014/main" id="{3ED478DE-AF82-4005-8009-5B26A939291E}"/>
               </a:ext>
             </a:extLst>
           </p:cNvPr>
@@ -11804,7 +11804,7 @@
           <p:cNvPr id="9" name="">
             <a:extLst xmlns:a="http://schemas.openxmlformats.org/drawingml/2006/main">
               <a:ext uri="{FF2B5EF4-FFF2-40B4-BE49-F238E27FC236}">
-                <a16:creationId xmlns:a16="http://schemas.microsoft.com/office/drawing/2014/main" id="{9132021E-C4F4-42EC-9334-9A2701922C82}"/>
+                <a16:creationId xmlns:a16="http://schemas.microsoft.com/office/drawing/2014/main" id="{250FFE13-3233-44F3-8330-12A487502990}"/>
               </a:ext>
             </a:extLst>
           </p:cNvPr>
@@ -11861,7 +11861,7 @@
           <p:cNvPr id="10" name="">
             <a:extLst xmlns:a="http://schemas.openxmlformats.org/drawingml/2006/main">
               <a:ext uri="{FF2B5EF4-FFF2-40B4-BE49-F238E27FC236}">
-                <a16:creationId xmlns:a16="http://schemas.microsoft.com/office/drawing/2014/main" id="{9A70A7DC-85E9-4C5E-8BA7-EE0BEC8012B1}"/>
+                <a16:creationId xmlns:a16="http://schemas.microsoft.com/office/drawing/2014/main" id="{80004D8C-CDC5-4265-ACC8-5C8BA12F2AF9}"/>
               </a:ext>
             </a:extLst>
           </p:cNvPr>
@@ -11894,7 +11894,7 @@
           <p:cNvPr id="11" name="">
             <a:extLst xmlns:a="http://schemas.openxmlformats.org/drawingml/2006/main">
               <a:ext uri="{FF2B5EF4-FFF2-40B4-BE49-F238E27FC236}">
-                <a16:creationId xmlns:a16="http://schemas.microsoft.com/office/drawing/2014/main" id="{74ABEE95-AF53-45B6-B6EF-DEA65262DBC2}"/>
+                <a16:creationId xmlns:a16="http://schemas.microsoft.com/office/drawing/2014/main" id="{8FBA0024-9B86-4A97-B367-6C1B15324238}"/>
               </a:ext>
             </a:extLst>
           </p:cNvPr>
@@ -11974,7 +11974,7 @@
           <p:cNvPr id="12" name="">
             <a:extLst xmlns:a="http://schemas.openxmlformats.org/drawingml/2006/main">
               <a:ext uri="{FF2B5EF4-FFF2-40B4-BE49-F238E27FC236}">
-                <a16:creationId xmlns:a16="http://schemas.microsoft.com/office/drawing/2014/main" id="{BAFBB309-BA41-4563-A0B5-F1F12EBE03C0}"/>
+                <a16:creationId xmlns:a16="http://schemas.microsoft.com/office/drawing/2014/main" id="{DA8FAD3F-259E-4F9C-8A64-DAABA2D26916}"/>
               </a:ext>
             </a:extLst>
           </p:cNvPr>
@@ -12007,7 +12007,7 @@
           <p:cNvPr id="13" name="">
             <a:extLst xmlns:a="http://schemas.openxmlformats.org/drawingml/2006/main">
               <a:ext uri="{FF2B5EF4-FFF2-40B4-BE49-F238E27FC236}">
-                <a16:creationId xmlns:a16="http://schemas.microsoft.com/office/drawing/2014/main" id="{A859F9BD-CBE3-4CEA-846C-881C849341E0}"/>
+                <a16:creationId xmlns:a16="http://schemas.microsoft.com/office/drawing/2014/main" id="{92948546-50A7-4669-96BE-35916C18A1A3}"/>
               </a:ext>
             </a:extLst>
           </p:cNvPr>
@@ -12087,7 +12087,7 @@
           <p:cNvPr id="14" name="">
             <a:extLst xmlns:a="http://schemas.openxmlformats.org/drawingml/2006/main">
               <a:ext uri="{FF2B5EF4-FFF2-40B4-BE49-F238E27FC236}">
-                <a16:creationId xmlns:a16="http://schemas.microsoft.com/office/drawing/2014/main" id="{773E3511-7E2F-4BD9-A628-A668CA6C1556}"/>
+                <a16:creationId xmlns:a16="http://schemas.microsoft.com/office/drawing/2014/main" id="{A38E9854-08E8-4B7C-A02B-2175620239BE}"/>
               </a:ext>
             </a:extLst>
           </p:cNvPr>
@@ -12120,7 +12120,7 @@
           <p:cNvPr id="15" name="">
             <a:extLst xmlns:a="http://schemas.openxmlformats.org/drawingml/2006/main">
               <a:ext uri="{FF2B5EF4-FFF2-40B4-BE49-F238E27FC236}">
-                <a16:creationId xmlns:a16="http://schemas.microsoft.com/office/drawing/2014/main" id="{1B57BC7B-8D85-4BE8-9BE6-408A72CC76CA}"/>
+                <a16:creationId xmlns:a16="http://schemas.microsoft.com/office/drawing/2014/main" id="{86B84E03-B357-476E-AD5E-38954A0B2A3D}"/>
               </a:ext>
             </a:extLst>
           </p:cNvPr>
@@ -12200,7 +12200,7 @@
           <p:cNvPr id="18" name="">
             <a:extLst xmlns:a="http://schemas.openxmlformats.org/drawingml/2006/main">
               <a:ext uri="{FF2B5EF4-FFF2-40B4-BE49-F238E27FC236}">
-                <a16:creationId xmlns:a16="http://schemas.microsoft.com/office/drawing/2014/main" id="{D6B73BEF-4E1B-403C-87D4-878FAE463400}"/>
+                <a16:creationId xmlns:a16="http://schemas.microsoft.com/office/drawing/2014/main" id="{AD4DB840-6821-4523-B67F-74E0B7CFE352}"/>
               </a:ext>
             </a:extLst>
           </p:cNvPr>
@@ -12255,7 +12255,7 @@
     </p:spTree>
     <p:extLst>
       <p:ext uri="{BB962C8B-B14F-4D97-AF65-F5344CB8AC3E}">
-        <p14:creationId xmlns:p14="http://schemas.microsoft.com/office/powerpoint/2010/main" val="1582643430"/>
+        <p14:creationId xmlns:p14="http://schemas.microsoft.com/office/powerpoint/2010/main" val="553218717"/>
       </p:ext>
     </p:extLst>
   </p:cSld>
@@ -12390,7 +12390,7 @@
           <p:cNvPr id="47" name="">
             <a:extLst xmlns:a="http://schemas.openxmlformats.org/drawingml/2006/main">
               <a:ext uri="{FF2B5EF4-FFF2-40B4-BE49-F238E27FC236}">
-                <a16:creationId xmlns:a16="http://schemas.microsoft.com/office/drawing/2014/main" id="{16D4C641-856B-4B9D-B9FD-31D002F7A276}"/>
+                <a16:creationId xmlns:a16="http://schemas.microsoft.com/office/drawing/2014/main" id="{170182DE-530E-46E1-A769-307D97B3E529}"/>
               </a:ext>
             </a:extLst>
           </p:cNvPr>
@@ -12470,7 +12470,7 @@
           <p:cNvPr id="2" name="">
             <a:extLst xmlns:a="http://schemas.openxmlformats.org/drawingml/2006/main">
               <a:ext uri="{FF2B5EF4-FFF2-40B4-BE49-F238E27FC236}">
-                <a16:creationId xmlns:a16="http://schemas.microsoft.com/office/drawing/2014/main" id="{7DDEFB61-8A73-4771-9B3E-E9C4DE9F9D6A}"/>
+                <a16:creationId xmlns:a16="http://schemas.microsoft.com/office/drawing/2014/main" id="{809C3BD0-D33A-47CD-AFEC-A63F6DFBC99F}"/>
               </a:ext>
             </a:extLst>
           </p:cNvPr>
@@ -12501,7 +12501,7 @@
           <p:cNvPr id="3" name="">
             <a:extLst xmlns:a="http://schemas.openxmlformats.org/drawingml/2006/main">
               <a:ext uri="{FF2B5EF4-FFF2-40B4-BE49-F238E27FC236}">
-                <a16:creationId xmlns:a16="http://schemas.microsoft.com/office/drawing/2014/main" id="{102B31AD-1042-4B09-8451-E684F0CAC9AF}"/>
+                <a16:creationId xmlns:a16="http://schemas.microsoft.com/office/drawing/2014/main" id="{3FF54B52-FD18-4D14-938F-A25C3104C4C1}"/>
               </a:ext>
             </a:extLst>
           </p:cNvPr>
@@ -12558,7 +12558,7 @@
           <p:cNvPr id="4" name="">
             <a:extLst xmlns:a="http://schemas.openxmlformats.org/drawingml/2006/main">
               <a:ext uri="{FF2B5EF4-FFF2-40B4-BE49-F238E27FC236}">
-                <a16:creationId xmlns:a16="http://schemas.microsoft.com/office/drawing/2014/main" id="{B84A3DC0-897A-4BBA-84B7-9F048F7CA202}"/>
+                <a16:creationId xmlns:a16="http://schemas.microsoft.com/office/drawing/2014/main" id="{51471388-747D-4F7D-BEA2-DAFEC1E84C94}"/>
               </a:ext>
             </a:extLst>
           </p:cNvPr>
@@ -12615,7 +12615,7 @@
           <p:cNvPr id="5" name="">
             <a:extLst xmlns:a="http://schemas.openxmlformats.org/drawingml/2006/main">
               <a:ext uri="{FF2B5EF4-FFF2-40B4-BE49-F238E27FC236}">
-                <a16:creationId xmlns:a16="http://schemas.microsoft.com/office/drawing/2014/main" id="{DD6BB690-0231-482C-9266-FE82149D3408}"/>
+                <a16:creationId xmlns:a16="http://schemas.microsoft.com/office/drawing/2014/main" id="{1A9C47FF-1BFA-4633-A4E8-A6B1E8A92E43}"/>
               </a:ext>
             </a:extLst>
           </p:cNvPr>
@@ -12672,7 +12672,7 @@
           <p:cNvPr id="6" name="">
             <a:extLst xmlns:a="http://schemas.openxmlformats.org/drawingml/2006/main">
               <a:ext uri="{FF2B5EF4-FFF2-40B4-BE49-F238E27FC236}">
-                <a16:creationId xmlns:a16="http://schemas.microsoft.com/office/drawing/2014/main" id="{136D535A-0F77-46A2-B410-B2CF28BE3240}"/>
+                <a16:creationId xmlns:a16="http://schemas.microsoft.com/office/drawing/2014/main" id="{F06F93F6-975B-445E-9930-CD5CE249FBA9}"/>
               </a:ext>
             </a:extLst>
           </p:cNvPr>
@@ -12752,7 +12752,7 @@
           <p:cNvPr id="7" name="">
             <a:extLst xmlns:a="http://schemas.openxmlformats.org/drawingml/2006/main">
               <a:ext uri="{FF2B5EF4-FFF2-40B4-BE49-F238E27FC236}">
-                <a16:creationId xmlns:a16="http://schemas.microsoft.com/office/drawing/2014/main" id="{DE43F2D6-1A5A-4C70-9E0B-5EE61715A813}"/>
+                <a16:creationId xmlns:a16="http://schemas.microsoft.com/office/drawing/2014/main" id="{06453C83-A82F-42D2-9144-A43D3BA6316E}"/>
               </a:ext>
             </a:extLst>
           </p:cNvPr>
@@ -12809,7 +12809,7 @@
           <p:cNvPr id="8" name="">
             <a:extLst xmlns:a="http://schemas.openxmlformats.org/drawingml/2006/main">
               <a:ext uri="{FF2B5EF4-FFF2-40B4-BE49-F238E27FC236}">
-                <a16:creationId xmlns:a16="http://schemas.microsoft.com/office/drawing/2014/main" id="{D4293997-3276-4AAE-A494-8FB6899394F1}"/>
+                <a16:creationId xmlns:a16="http://schemas.microsoft.com/office/drawing/2014/main" id="{4CA1006B-3283-4F9E-A620-66AEBDF3E9AA}"/>
               </a:ext>
             </a:extLst>
           </p:cNvPr>
@@ -12889,7 +12889,7 @@
           <p:cNvPr id="9" name="">
             <a:extLst xmlns:a="http://schemas.openxmlformats.org/drawingml/2006/main">
               <a:ext uri="{FF2B5EF4-FFF2-40B4-BE49-F238E27FC236}">
-                <a16:creationId xmlns:a16="http://schemas.microsoft.com/office/drawing/2014/main" id="{8190596D-7C13-4F88-9C4D-CBCDE5373C2E}"/>
+                <a16:creationId xmlns:a16="http://schemas.microsoft.com/office/drawing/2014/main" id="{8DEA02F9-ED8C-48C8-904D-83132E642D91}"/>
               </a:ext>
             </a:extLst>
           </p:cNvPr>
@@ -12920,7 +12920,7 @@
           <p:cNvPr id="10" name="">
             <a:extLst xmlns:a="http://schemas.openxmlformats.org/drawingml/2006/main">
               <a:ext uri="{FF2B5EF4-FFF2-40B4-BE49-F238E27FC236}">
-                <a16:creationId xmlns:a16="http://schemas.microsoft.com/office/drawing/2014/main" id="{575E9BC8-F856-4AD7-AB7E-7F87E7F9BF04}"/>
+                <a16:creationId xmlns:a16="http://schemas.microsoft.com/office/drawing/2014/main" id="{A6194FEE-6F65-4188-85BB-4BC2C49CAA58}"/>
               </a:ext>
             </a:extLst>
           </p:cNvPr>
@@ -12953,7 +12953,7 @@
           <p:cNvPr id="11" name="">
             <a:extLst xmlns:a="http://schemas.openxmlformats.org/drawingml/2006/main">
               <a:ext uri="{FF2B5EF4-FFF2-40B4-BE49-F238E27FC236}">
-                <a16:creationId xmlns:a16="http://schemas.microsoft.com/office/drawing/2014/main" id="{CBC0EEA9-A93F-45DF-80E8-37395C75A4F7}"/>
+                <a16:creationId xmlns:a16="http://schemas.microsoft.com/office/drawing/2014/main" id="{ED3B1A6A-1E18-463E-B1C1-987CA3DA022D}"/>
               </a:ext>
             </a:extLst>
           </p:cNvPr>
@@ -13033,7 +13033,7 @@
           <p:cNvPr id="12" name="">
             <a:extLst xmlns:a="http://schemas.openxmlformats.org/drawingml/2006/main">
               <a:ext uri="{FF2B5EF4-FFF2-40B4-BE49-F238E27FC236}">
-                <a16:creationId xmlns:a16="http://schemas.microsoft.com/office/drawing/2014/main" id="{0420086A-1285-4D78-9332-C4CCE71B0FD1}"/>
+                <a16:creationId xmlns:a16="http://schemas.microsoft.com/office/drawing/2014/main" id="{D4D04DD6-38F0-4ECC-B7E5-D4236AE911BD}"/>
               </a:ext>
             </a:extLst>
           </p:cNvPr>
@@ -13066,7 +13066,7 @@
           <p:cNvPr id="13" name="">
             <a:extLst xmlns:a="http://schemas.openxmlformats.org/drawingml/2006/main">
               <a:ext uri="{FF2B5EF4-FFF2-40B4-BE49-F238E27FC236}">
-                <a16:creationId xmlns:a16="http://schemas.microsoft.com/office/drawing/2014/main" id="{38C79E55-8C98-4DB0-B16F-B968F7886553}"/>
+                <a16:creationId xmlns:a16="http://schemas.microsoft.com/office/drawing/2014/main" id="{2300DB8F-0E9A-4873-B9FC-76DDF512EC2B}"/>
               </a:ext>
             </a:extLst>
           </p:cNvPr>
@@ -13146,7 +13146,7 @@
           <p:cNvPr id="14" name="">
             <a:extLst xmlns:a="http://schemas.openxmlformats.org/drawingml/2006/main">
               <a:ext uri="{FF2B5EF4-FFF2-40B4-BE49-F238E27FC236}">
-                <a16:creationId xmlns:a16="http://schemas.microsoft.com/office/drawing/2014/main" id="{8030DF62-52A3-4D1C-9ED9-05510FC3821E}"/>
+                <a16:creationId xmlns:a16="http://schemas.microsoft.com/office/drawing/2014/main" id="{06C2B5F6-D9D4-4F41-97A8-497C80E571D9}"/>
               </a:ext>
             </a:extLst>
           </p:cNvPr>
@@ -13179,7 +13179,7 @@
           <p:cNvPr id="15" name="">
             <a:extLst xmlns:a="http://schemas.openxmlformats.org/drawingml/2006/main">
               <a:ext uri="{FF2B5EF4-FFF2-40B4-BE49-F238E27FC236}">
-                <a16:creationId xmlns:a16="http://schemas.microsoft.com/office/drawing/2014/main" id="{0CC1A73A-F833-42B7-A874-F9B1D800673E}"/>
+                <a16:creationId xmlns:a16="http://schemas.microsoft.com/office/drawing/2014/main" id="{3E108C0D-C934-4696-A9D0-C8E8D67676F1}"/>
               </a:ext>
             </a:extLst>
           </p:cNvPr>
@@ -13259,7 +13259,7 @@
           <p:cNvPr id="16" name="">
             <a:extLst xmlns:a="http://schemas.openxmlformats.org/drawingml/2006/main">
               <a:ext uri="{FF2B5EF4-FFF2-40B4-BE49-F238E27FC236}">
-                <a16:creationId xmlns:a16="http://schemas.microsoft.com/office/drawing/2014/main" id="{0D974FB8-1603-4390-A434-257D41E38549}"/>
+                <a16:creationId xmlns:a16="http://schemas.microsoft.com/office/drawing/2014/main" id="{3BD634B4-C597-45B3-BE06-8198491C4C3D}"/>
               </a:ext>
             </a:extLst>
           </p:cNvPr>
@@ -13292,7 +13292,7 @@
           <p:cNvPr id="17" name="">
             <a:extLst xmlns:a="http://schemas.openxmlformats.org/drawingml/2006/main">
               <a:ext uri="{FF2B5EF4-FFF2-40B4-BE49-F238E27FC236}">
-                <a16:creationId xmlns:a16="http://schemas.microsoft.com/office/drawing/2014/main" id="{4690C95E-F438-415C-BE78-861B2847C8E1}"/>
+                <a16:creationId xmlns:a16="http://schemas.microsoft.com/office/drawing/2014/main" id="{031EEA97-47E2-49CA-A4DC-4BA36AFD79C2}"/>
               </a:ext>
             </a:extLst>
           </p:cNvPr>
@@ -13372,7 +13372,7 @@
           <p:cNvPr id="22" name="">
             <a:extLst xmlns:a="http://schemas.openxmlformats.org/drawingml/2006/main">
               <a:ext uri="{FF2B5EF4-FFF2-40B4-BE49-F238E27FC236}">
-                <a16:creationId xmlns:a16="http://schemas.microsoft.com/office/drawing/2014/main" id="{E7B341B6-2427-42D2-BAC0-B3C35BD49106}"/>
+                <a16:creationId xmlns:a16="http://schemas.microsoft.com/office/drawing/2014/main" id="{A39BEEBB-7D92-45DC-9076-414DD84E884F}"/>
               </a:ext>
             </a:extLst>
           </p:cNvPr>
@@ -13452,7 +13452,7 @@
           <p:cNvPr id="23" name="">
             <a:extLst xmlns:a="http://schemas.openxmlformats.org/drawingml/2006/main">
               <a:ext uri="{FF2B5EF4-FFF2-40B4-BE49-F238E27FC236}">
-                <a16:creationId xmlns:a16="http://schemas.microsoft.com/office/drawing/2014/main" id="{8B849349-1615-4204-B4E5-827B866C6D48}"/>
+                <a16:creationId xmlns:a16="http://schemas.microsoft.com/office/drawing/2014/main" id="{AC3C71AE-C822-48DC-B53A-9B9D2524ED3A}"/>
               </a:ext>
             </a:extLst>
           </p:cNvPr>
@@ -13483,7 +13483,7 @@
           <p:cNvPr id="24" name="">
             <a:extLst xmlns:a="http://schemas.openxmlformats.org/drawingml/2006/main">
               <a:ext uri="{FF2B5EF4-FFF2-40B4-BE49-F238E27FC236}">
-                <a16:creationId xmlns:a16="http://schemas.microsoft.com/office/drawing/2014/main" id="{E2FB0A0F-B5AD-4A07-B259-EAB8D6EE41CF}"/>
+                <a16:creationId xmlns:a16="http://schemas.microsoft.com/office/drawing/2014/main" id="{B9A1F4B1-0086-4E4C-A270-D45D7DA5A702}"/>
               </a:ext>
             </a:extLst>
           </p:cNvPr>
@@ -13540,7 +13540,7 @@
           <p:cNvPr id="25" name="">
             <a:extLst xmlns:a="http://schemas.openxmlformats.org/drawingml/2006/main">
               <a:ext uri="{FF2B5EF4-FFF2-40B4-BE49-F238E27FC236}">
-                <a16:creationId xmlns:a16="http://schemas.microsoft.com/office/drawing/2014/main" id="{F96D5A72-CEA3-480B-A30B-37DCAA961B51}"/>
+                <a16:creationId xmlns:a16="http://schemas.microsoft.com/office/drawing/2014/main" id="{E3ADD602-0879-482D-BBCB-CC4002E57463}"/>
               </a:ext>
             </a:extLst>
           </p:cNvPr>
@@ -13597,7 +13597,7 @@
           <p:cNvPr id="26" name="">
             <a:extLst xmlns:a="http://schemas.openxmlformats.org/drawingml/2006/main">
               <a:ext uri="{FF2B5EF4-FFF2-40B4-BE49-F238E27FC236}">
-                <a16:creationId xmlns:a16="http://schemas.microsoft.com/office/drawing/2014/main" id="{F7C63610-C7EA-41CA-B8AA-232BE27D143E}"/>
+                <a16:creationId xmlns:a16="http://schemas.microsoft.com/office/drawing/2014/main" id="{2C61F2A1-87CF-4326-8178-D0330F73479C}"/>
               </a:ext>
             </a:extLst>
           </p:cNvPr>
@@ -13677,7 +13677,7 @@
           <p:cNvPr id="27" name="">
             <a:extLst xmlns:a="http://schemas.openxmlformats.org/drawingml/2006/main">
               <a:ext uri="{FF2B5EF4-FFF2-40B4-BE49-F238E27FC236}">
-                <a16:creationId xmlns:a16="http://schemas.microsoft.com/office/drawing/2014/main" id="{E11AC4C2-DC84-4EF8-BF08-60AC26D284CD}"/>
+                <a16:creationId xmlns:a16="http://schemas.microsoft.com/office/drawing/2014/main" id="{66169787-6371-45E6-8F30-594FDC4D97BF}"/>
               </a:ext>
             </a:extLst>
           </p:cNvPr>
@@ -13734,7 +13734,7 @@
           <p:cNvPr id="28" name="">
             <a:extLst xmlns:a="http://schemas.openxmlformats.org/drawingml/2006/main">
               <a:ext uri="{FF2B5EF4-FFF2-40B4-BE49-F238E27FC236}">
-                <a16:creationId xmlns:a16="http://schemas.microsoft.com/office/drawing/2014/main" id="{5499DA95-C96C-4DCE-B370-284D8CDC6510}"/>
+                <a16:creationId xmlns:a16="http://schemas.microsoft.com/office/drawing/2014/main" id="{2C0127B5-5BFC-4A77-98E0-528655D69525}"/>
               </a:ext>
             </a:extLst>
           </p:cNvPr>
@@ -13814,7 +13814,7 @@
           <p:cNvPr id="29" name="">
             <a:extLst xmlns:a="http://schemas.openxmlformats.org/drawingml/2006/main">
               <a:ext uri="{FF2B5EF4-FFF2-40B4-BE49-F238E27FC236}">
-                <a16:creationId xmlns:a16="http://schemas.microsoft.com/office/drawing/2014/main" id="{5D24C85B-6FFF-4CEC-B90F-5141BE586CE7}"/>
+                <a16:creationId xmlns:a16="http://schemas.microsoft.com/office/drawing/2014/main" id="{6D363AF3-EF7A-45A2-96AB-271BCD1373BD}"/>
               </a:ext>
             </a:extLst>
           </p:cNvPr>
@@ -13871,7 +13871,7 @@
           <p:cNvPr id="30" name="">
             <a:extLst xmlns:a="http://schemas.openxmlformats.org/drawingml/2006/main">
               <a:ext uri="{FF2B5EF4-FFF2-40B4-BE49-F238E27FC236}">
-                <a16:creationId xmlns:a16="http://schemas.microsoft.com/office/drawing/2014/main" id="{2228EC1D-777E-458A-A46B-949EDFA42311}"/>
+                <a16:creationId xmlns:a16="http://schemas.microsoft.com/office/drawing/2014/main" id="{98527CC0-5CAB-4E3B-95FE-8296FD9F79ED}"/>
               </a:ext>
             </a:extLst>
           </p:cNvPr>
@@ -13951,7 +13951,7 @@
           <p:cNvPr id="31" name="">
             <a:extLst xmlns:a="http://schemas.openxmlformats.org/drawingml/2006/main">
               <a:ext uri="{FF2B5EF4-FFF2-40B4-BE49-F238E27FC236}">
-                <a16:creationId xmlns:a16="http://schemas.microsoft.com/office/drawing/2014/main" id="{57357417-952A-4EE3-9F1A-50E5C7C159A2}"/>
+                <a16:creationId xmlns:a16="http://schemas.microsoft.com/office/drawing/2014/main" id="{12433076-78FC-4165-A25B-ADAD3BBBFD75}"/>
               </a:ext>
             </a:extLst>
           </p:cNvPr>
@@ -14008,7 +14008,7 @@
           <p:cNvPr id="32" name="">
             <a:extLst xmlns:a="http://schemas.openxmlformats.org/drawingml/2006/main">
               <a:ext uri="{FF2B5EF4-FFF2-40B4-BE49-F238E27FC236}">
-                <a16:creationId xmlns:a16="http://schemas.microsoft.com/office/drawing/2014/main" id="{A89EB006-AF31-4C7B-82A9-A5903164701F}"/>
+                <a16:creationId xmlns:a16="http://schemas.microsoft.com/office/drawing/2014/main" id="{9F93CF28-7216-4610-B4D6-4C6090B9FD84}"/>
               </a:ext>
             </a:extLst>
           </p:cNvPr>
@@ -14088,7 +14088,7 @@
           <p:cNvPr id="33" name="">
             <a:extLst xmlns:a="http://schemas.openxmlformats.org/drawingml/2006/main">
               <a:ext uri="{FF2B5EF4-FFF2-40B4-BE49-F238E27FC236}">
-                <a16:creationId xmlns:a16="http://schemas.microsoft.com/office/drawing/2014/main" id="{ABC5FD93-8491-4A0F-A488-F8D721F48D39}"/>
+                <a16:creationId xmlns:a16="http://schemas.microsoft.com/office/drawing/2014/main" id="{7BFA8973-0A47-49A4-A71F-855E7DE78B8A}"/>
               </a:ext>
             </a:extLst>
           </p:cNvPr>
@@ -14121,7 +14121,7 @@
           <p:cNvPr id="34" name="">
             <a:extLst xmlns:a="http://schemas.openxmlformats.org/drawingml/2006/main">
               <a:ext uri="{FF2B5EF4-FFF2-40B4-BE49-F238E27FC236}">
-                <a16:creationId xmlns:a16="http://schemas.microsoft.com/office/drawing/2014/main" id="{7A2651CF-BD4D-4902-AADA-A9BE37900A9F}"/>
+                <a16:creationId xmlns:a16="http://schemas.microsoft.com/office/drawing/2014/main" id="{9A5A03A6-318B-431B-8959-802BD316710B}"/>
               </a:ext>
             </a:extLst>
           </p:cNvPr>
@@ -14178,7 +14178,7 @@
           <p:cNvPr id="35" name="">
             <a:extLst xmlns:a="http://schemas.openxmlformats.org/drawingml/2006/main">
               <a:ext uri="{FF2B5EF4-FFF2-40B4-BE49-F238E27FC236}">
-                <a16:creationId xmlns:a16="http://schemas.microsoft.com/office/drawing/2014/main" id="{DDB63495-71AC-4D16-ADC6-BD106275DC8E}"/>
+                <a16:creationId xmlns:a16="http://schemas.microsoft.com/office/drawing/2014/main" id="{9E874958-636C-4C1B-8A2D-4195EBEE64B0}"/>
               </a:ext>
             </a:extLst>
           </p:cNvPr>
@@ -14258,7 +14258,7 @@
           <p:cNvPr id="36" name="">
             <a:extLst xmlns:a="http://schemas.openxmlformats.org/drawingml/2006/main">
               <a:ext uri="{FF2B5EF4-FFF2-40B4-BE49-F238E27FC236}">
-                <a16:creationId xmlns:a16="http://schemas.microsoft.com/office/drawing/2014/main" id="{7B563398-8897-4D2C-8CF8-2C9126942B8D}"/>
+                <a16:creationId xmlns:a16="http://schemas.microsoft.com/office/drawing/2014/main" id="{7DA22560-E3C5-42EB-B84F-96A408B09FFC}"/>
               </a:ext>
             </a:extLst>
           </p:cNvPr>
@@ -14289,7 +14289,7 @@
           <p:cNvPr id="37" name="">
             <a:extLst xmlns:a="http://schemas.openxmlformats.org/drawingml/2006/main">
               <a:ext uri="{FF2B5EF4-FFF2-40B4-BE49-F238E27FC236}">
-                <a16:creationId xmlns:a16="http://schemas.microsoft.com/office/drawing/2014/main" id="{A6CAA25A-A106-4CA3-916B-C0837C310965}"/>
+                <a16:creationId xmlns:a16="http://schemas.microsoft.com/office/drawing/2014/main" id="{93DB000B-6703-4662-86E3-160BDC79DC90}"/>
               </a:ext>
             </a:extLst>
           </p:cNvPr>
@@ -14346,7 +14346,7 @@
           <p:cNvPr id="38" name="">
             <a:extLst xmlns:a="http://schemas.openxmlformats.org/drawingml/2006/main">
               <a:ext uri="{FF2B5EF4-FFF2-40B4-BE49-F238E27FC236}">
-                <a16:creationId xmlns:a16="http://schemas.microsoft.com/office/drawing/2014/main" id="{04E5BA03-CD47-4ADE-B3C2-02B47E91D0D4}"/>
+                <a16:creationId xmlns:a16="http://schemas.microsoft.com/office/drawing/2014/main" id="{3D38765A-38EE-4AE2-8B71-5C7CD8DB8883}"/>
               </a:ext>
             </a:extLst>
           </p:cNvPr>
@@ -14403,7 +14403,7 @@
           <p:cNvPr id="39" name="">
             <a:extLst xmlns:a="http://schemas.openxmlformats.org/drawingml/2006/main">
               <a:ext uri="{FF2B5EF4-FFF2-40B4-BE49-F238E27FC236}">
-                <a16:creationId xmlns:a16="http://schemas.microsoft.com/office/drawing/2014/main" id="{0EFD40D1-C6FC-424D-BA20-82A6E550AA51}"/>
+                <a16:creationId xmlns:a16="http://schemas.microsoft.com/office/drawing/2014/main" id="{B13F6478-D183-4CC4-A055-03FE7863E651}"/>
               </a:ext>
             </a:extLst>
           </p:cNvPr>
@@ -14460,7 +14460,7 @@
           <p:cNvPr id="40" name="">
             <a:extLst xmlns:a="http://schemas.openxmlformats.org/drawingml/2006/main">
               <a:ext uri="{FF2B5EF4-FFF2-40B4-BE49-F238E27FC236}">
-                <a16:creationId xmlns:a16="http://schemas.microsoft.com/office/drawing/2014/main" id="{DC67BECA-69D9-4C89-96F7-372F09F563D0}"/>
+                <a16:creationId xmlns:a16="http://schemas.microsoft.com/office/drawing/2014/main" id="{514B155E-AE14-4CFD-8F79-D4DF5DB9FCD4}"/>
               </a:ext>
             </a:extLst>
           </p:cNvPr>
@@ -14517,7 +14517,7 @@
           <p:cNvPr id="41" name="">
             <a:extLst xmlns:a="http://schemas.openxmlformats.org/drawingml/2006/main">
               <a:ext uri="{FF2B5EF4-FFF2-40B4-BE49-F238E27FC236}">
-                <a16:creationId xmlns:a16="http://schemas.microsoft.com/office/drawing/2014/main" id="{6A08260D-4505-47A6-927D-9822756D9567}"/>
+                <a16:creationId xmlns:a16="http://schemas.microsoft.com/office/drawing/2014/main" id="{800149B4-82D4-4883-94B9-C46F0F7A542A}"/>
               </a:ext>
             </a:extLst>
           </p:cNvPr>
@@ -14574,7 +14574,7 @@
           <p:cNvPr id="42" name="">
             <a:extLst xmlns:a="http://schemas.openxmlformats.org/drawingml/2006/main">
               <a:ext uri="{FF2B5EF4-FFF2-40B4-BE49-F238E27FC236}">
-                <a16:creationId xmlns:a16="http://schemas.microsoft.com/office/drawing/2014/main" id="{40AA6DFF-5139-4E86-8D8E-276999270967}"/>
+                <a16:creationId xmlns:a16="http://schemas.microsoft.com/office/drawing/2014/main" id="{F8660A65-DBF8-4C32-94F5-81D3AE131B96}"/>
               </a:ext>
             </a:extLst>
           </p:cNvPr>
@@ -14629,7 +14629,7 @@
     </p:spTree>
     <p:extLst>
       <p:ext uri="{BB962C8B-B14F-4D97-AF65-F5344CB8AC3E}">
-        <p14:creationId xmlns:p14="http://schemas.microsoft.com/office/powerpoint/2010/main" val="1175132963"/>
+        <p14:creationId xmlns:p14="http://schemas.microsoft.com/office/powerpoint/2010/main" val="48240125"/>
       </p:ext>
     </p:extLst>
   </p:cSld>
@@ -14660,7 +14660,7 @@
           <p:cNvPr id="21" name="">
             <a:extLst xmlns:a="http://schemas.openxmlformats.org/drawingml/2006/main">
               <a:ext uri="{FF2B5EF4-FFF2-40B4-BE49-F238E27FC236}">
-                <a16:creationId xmlns:a16="http://schemas.microsoft.com/office/drawing/2014/main" id="{86119ED2-3FEB-42D3-B530-6BA50D50D32E}"/>
+                <a16:creationId xmlns:a16="http://schemas.microsoft.com/office/drawing/2014/main" id="{322D4994-5BB9-45EF-AFFE-3A5A43E81545}"/>
               </a:ext>
             </a:extLst>
           </p:cNvPr>
@@ -14717,7 +14717,7 @@
           <p:cNvPr id="2" name="">
             <a:extLst xmlns:a="http://schemas.openxmlformats.org/drawingml/2006/main">
               <a:ext uri="{FF2B5EF4-FFF2-40B4-BE49-F238E27FC236}">
-                <a16:creationId xmlns:a16="http://schemas.microsoft.com/office/drawing/2014/main" id="{ED5A554B-C0EB-43DA-AEF7-6801DF199A85}"/>
+                <a16:creationId xmlns:a16="http://schemas.microsoft.com/office/drawing/2014/main" id="{DA8479BD-1E68-4753-9355-3C00FEF0571B}"/>
               </a:ext>
             </a:extLst>
           </p:cNvPr>
@@ -14748,7 +14748,7 @@
           <p:cNvPr id="3" name="">
             <a:extLst xmlns:a="http://schemas.openxmlformats.org/drawingml/2006/main">
               <a:ext uri="{FF2B5EF4-FFF2-40B4-BE49-F238E27FC236}">
-                <a16:creationId xmlns:a16="http://schemas.microsoft.com/office/drawing/2014/main" id="{662E24C8-4EB0-44A6-AB5B-3DCD73659D4C}"/>
+                <a16:creationId xmlns:a16="http://schemas.microsoft.com/office/drawing/2014/main" id="{B1EB4E2C-8CC5-4308-B10C-F8DF93C928C9}"/>
               </a:ext>
             </a:extLst>
           </p:cNvPr>
@@ -14805,7 +14805,7 @@
           <p:cNvPr id="4" name="">
             <a:extLst xmlns:a="http://schemas.openxmlformats.org/drawingml/2006/main">
               <a:ext uri="{FF2B5EF4-FFF2-40B4-BE49-F238E27FC236}">
-                <a16:creationId xmlns:a16="http://schemas.microsoft.com/office/drawing/2014/main" id="{8E6D5E0A-CEE9-4A3D-85B4-E4034D6E3C6E}"/>
+                <a16:creationId xmlns:a16="http://schemas.microsoft.com/office/drawing/2014/main" id="{D7BA731F-ED72-4311-AB42-6E23F3CEF81C}"/>
               </a:ext>
             </a:extLst>
           </p:cNvPr>
@@ -14862,7 +14862,7 @@
           <p:cNvPr id="5" name="">
             <a:extLst xmlns:a="http://schemas.openxmlformats.org/drawingml/2006/main">
               <a:ext uri="{FF2B5EF4-FFF2-40B4-BE49-F238E27FC236}">
-                <a16:creationId xmlns:a16="http://schemas.microsoft.com/office/drawing/2014/main" id="{7B9421F5-EA6D-42B0-9206-56767EB7EA1E}"/>
+                <a16:creationId xmlns:a16="http://schemas.microsoft.com/office/drawing/2014/main" id="{2EF4D987-4D33-4C15-A7CA-E836FF277D83}"/>
               </a:ext>
             </a:extLst>
           </p:cNvPr>
@@ -14919,7 +14919,7 @@
           <p:cNvPr id="6" name="">
             <a:extLst xmlns:a="http://schemas.openxmlformats.org/drawingml/2006/main">
               <a:ext uri="{FF2B5EF4-FFF2-40B4-BE49-F238E27FC236}">
-                <a16:creationId xmlns:a16="http://schemas.microsoft.com/office/drawing/2014/main" id="{AC3B98A8-0DEE-43C3-895C-2B6E948AD8F2}"/>
+                <a16:creationId xmlns:a16="http://schemas.microsoft.com/office/drawing/2014/main" id="{6C8F24D6-3C08-42B7-9DE3-C7A27327DE83}"/>
               </a:ext>
             </a:extLst>
           </p:cNvPr>
@@ -15003,7 +15003,7 @@
           <p:nvPr/>
         </p:nvPicPr>
         <p:blipFill>
-          <a:blip xmlns:r="http://schemas.openxmlformats.org/officeDocument/2006/relationships" xmlns:a="http://schemas.openxmlformats.org/drawingml/2006/main" r:embed="R80e071b309794530"/>
+          <a:blip xmlns:r="http://schemas.openxmlformats.org/officeDocument/2006/relationships" xmlns:a="http://schemas.openxmlformats.org/drawingml/2006/main" r:embed="Rd9a7dd4852bb4418"/>
           <a:stretch xmlns:a="http://schemas.openxmlformats.org/drawingml/2006/main"/>
         </p:blipFill>
         <p:spPr>
@@ -15021,7 +15021,7 @@
           <p:cNvPr id="8" name="">
             <a:extLst xmlns:a="http://schemas.openxmlformats.org/drawingml/2006/main">
               <a:ext uri="{FF2B5EF4-FFF2-40B4-BE49-F238E27FC236}">
-                <a16:creationId xmlns:a16="http://schemas.microsoft.com/office/drawing/2014/main" id="{DBAC4099-368E-4D94-8486-58DF0B8DAB9E}"/>
+                <a16:creationId xmlns:a16="http://schemas.microsoft.com/office/drawing/2014/main" id="{C1541F21-0554-4FCA-BD0B-5D08E27DCFF1}"/>
               </a:ext>
             </a:extLst>
           </p:cNvPr>
@@ -15067,7 +15067,7 @@
                 <a:latin typeface="Arial"/>
                 <a:ea typeface="Arial"/>
                 <a:cs typeface="Arial"/>
-                <a:hlinkClick xmlns:r="http://schemas.openxmlformats.org/officeDocument/2006/relationships" r:id="Rf1f89aa43b224a61"/>
+                <a:hlinkClick xmlns:r="http://schemas.openxmlformats.org/officeDocument/2006/relationships" r:id="R56f2279741084637"/>
               </a:rPr>
               <a:t>github.com/UncertaintyArchitectureGroup/</a:t>
             </a:r>
@@ -15079,7 +15079,7 @@
           <p:cNvPr id="9" name="">
             <a:extLst xmlns:a="http://schemas.openxmlformats.org/drawingml/2006/main">
               <a:ext uri="{FF2B5EF4-FFF2-40B4-BE49-F238E27FC236}">
-                <a16:creationId xmlns:a16="http://schemas.microsoft.com/office/drawing/2014/main" id="{D5589D01-AEB9-4E41-B42F-6DDF5ECFC31A}"/>
+                <a16:creationId xmlns:a16="http://schemas.microsoft.com/office/drawing/2014/main" id="{E896D860-3BA6-48A5-AA93-8F17E4B50397}"/>
               </a:ext>
             </a:extLst>
           </p:cNvPr>
@@ -15125,7 +15125,7 @@
                 <a:latin typeface="Arial"/>
                 <a:ea typeface="Arial"/>
                 <a:cs typeface="Arial"/>
-                <a:hlinkClick xmlns:r="http://schemas.openxmlformats.org/officeDocument/2006/relationships" r:id="R0cb4232a2dbf467f"/>
+                <a:hlinkClick xmlns:r="http://schemas.openxmlformats.org/officeDocument/2006/relationships" r:id="R8cc7f0da27ff4222"/>
               </a:rPr>
               <a:t>uncertainty-architecture</a:t>
             </a:r>
@@ -15137,7 +15137,7 @@
           <p:cNvPr id="10" name="">
             <a:extLst xmlns:a="http://schemas.openxmlformats.org/drawingml/2006/main">
               <a:ext uri="{FF2B5EF4-FFF2-40B4-BE49-F238E27FC236}">
-                <a16:creationId xmlns:a16="http://schemas.microsoft.com/office/drawing/2014/main" id="{90830647-DE18-418A-88A3-F6465DB1128E}"/>
+                <a16:creationId xmlns:a16="http://schemas.microsoft.com/office/drawing/2014/main" id="{EB268DBF-EB27-46DC-92FB-89FD6547AD83}"/>
               </a:ext>
             </a:extLst>
           </p:cNvPr>
@@ -15194,7 +15194,7 @@
           <p:cNvPr id="11" name="">
             <a:extLst xmlns:a="http://schemas.openxmlformats.org/drawingml/2006/main">
               <a:ext uri="{FF2B5EF4-FFF2-40B4-BE49-F238E27FC236}">
-                <a16:creationId xmlns:a16="http://schemas.microsoft.com/office/drawing/2014/main" id="{89C08C47-746F-4706-B908-DCC8B49C2507}"/>
+                <a16:creationId xmlns:a16="http://schemas.microsoft.com/office/drawing/2014/main" id="{828D8C03-D8EA-45E5-A99D-7D8B5476BD43}"/>
               </a:ext>
             </a:extLst>
           </p:cNvPr>
@@ -15251,7 +15251,7 @@
           <p:cNvPr id="12" name="">
             <a:extLst xmlns:a="http://schemas.openxmlformats.org/drawingml/2006/main">
               <a:ext uri="{FF2B5EF4-FFF2-40B4-BE49-F238E27FC236}">
-                <a16:creationId xmlns:a16="http://schemas.microsoft.com/office/drawing/2014/main" id="{787CCDF6-18FD-4BDF-99B4-9B2B348DC80D}"/>
+                <a16:creationId xmlns:a16="http://schemas.microsoft.com/office/drawing/2014/main" id="{5D6B02AB-84EA-4291-8B80-87A4BE908876}"/>
               </a:ext>
             </a:extLst>
           </p:cNvPr>
@@ -15335,7 +15335,7 @@
           <p:nvPr/>
         </p:nvPicPr>
         <p:blipFill>
-          <a:blip xmlns:r="http://schemas.openxmlformats.org/officeDocument/2006/relationships" xmlns:a="http://schemas.openxmlformats.org/drawingml/2006/main" r:embed="R67ee99641e074be5"/>
+          <a:blip xmlns:r="http://schemas.openxmlformats.org/officeDocument/2006/relationships" xmlns:a="http://schemas.openxmlformats.org/drawingml/2006/main" r:embed="R85dfc790f32e4e17"/>
           <a:stretch xmlns:a="http://schemas.openxmlformats.org/drawingml/2006/main"/>
         </p:blipFill>
         <p:spPr>
@@ -15353,7 +15353,7 @@
           <p:cNvPr id="14" name="">
             <a:extLst xmlns:a="http://schemas.openxmlformats.org/drawingml/2006/main">
               <a:ext uri="{FF2B5EF4-FFF2-40B4-BE49-F238E27FC236}">
-                <a16:creationId xmlns:a16="http://schemas.microsoft.com/office/drawing/2014/main" id="{D605B198-2771-429E-88EB-498BA90CA7D2}"/>
+                <a16:creationId xmlns:a16="http://schemas.microsoft.com/office/drawing/2014/main" id="{726958F5-6C47-4715-B8B5-414D7E00354B}"/>
               </a:ext>
             </a:extLst>
           </p:cNvPr>
@@ -15399,7 +15399,7 @@
                 <a:latin typeface="Arial"/>
                 <a:ea typeface="Arial"/>
                 <a:cs typeface="Arial"/>
-                <a:hlinkClick xmlns:r="http://schemas.openxmlformats.org/officeDocument/2006/relationships" r:id="Rb3d6c167f91f4b5d"/>
+                <a:hlinkClick xmlns:r="http://schemas.openxmlformats.org/officeDocument/2006/relationships" r:id="Rc16d36a67a7e44da"/>
               </a:rPr>
               <a:t>github.com/UncertaintyArchitectureGroup/</a:t>
             </a:r>
@@ -15411,7 +15411,7 @@
           <p:cNvPr id="15" name="">
             <a:extLst xmlns:a="http://schemas.openxmlformats.org/drawingml/2006/main">
               <a:ext uri="{FF2B5EF4-FFF2-40B4-BE49-F238E27FC236}">
-                <a16:creationId xmlns:a16="http://schemas.microsoft.com/office/drawing/2014/main" id="{B2117A08-C5C1-4E56-A930-68650B10BB64}"/>
+                <a16:creationId xmlns:a16="http://schemas.microsoft.com/office/drawing/2014/main" id="{1B7F464D-9420-422B-B168-781C781C508D}"/>
               </a:ext>
             </a:extLst>
           </p:cNvPr>
@@ -15457,7 +15457,7 @@
                 <a:latin typeface="Arial"/>
                 <a:ea typeface="Arial"/>
                 <a:cs typeface="Arial"/>
-                <a:hlinkClick xmlns:r="http://schemas.openxmlformats.org/officeDocument/2006/relationships" r:id="Rf827061a85a34841"/>
+                <a:hlinkClick xmlns:r="http://schemas.openxmlformats.org/officeDocument/2006/relationships" r:id="R7d31488fd7734e60"/>
               </a:rPr>
               <a:t>The-Subprime-Code-Crisis</a:t>
             </a:r>
@@ -15469,7 +15469,7 @@
           <p:cNvPr id="16" name="">
             <a:extLst xmlns:a="http://schemas.openxmlformats.org/drawingml/2006/main">
               <a:ext uri="{FF2B5EF4-FFF2-40B4-BE49-F238E27FC236}">
-                <a16:creationId xmlns:a16="http://schemas.microsoft.com/office/drawing/2014/main" id="{93B0A770-F623-41C5-84B0-930BF5D909CD}"/>
+                <a16:creationId xmlns:a16="http://schemas.microsoft.com/office/drawing/2014/main" id="{3325BE22-4AD5-40FF-8F77-A365DF18198A}"/>
               </a:ext>
             </a:extLst>
           </p:cNvPr>
@@ -15500,7 +15500,7 @@
           <p:cNvPr id="17" name="">
             <a:extLst xmlns:a="http://schemas.openxmlformats.org/drawingml/2006/main">
               <a:ext uri="{FF2B5EF4-FFF2-40B4-BE49-F238E27FC236}">
-                <a16:creationId xmlns:a16="http://schemas.microsoft.com/office/drawing/2014/main" id="{C34D149A-73FA-457F-869B-95324530F11C}"/>
+                <a16:creationId xmlns:a16="http://schemas.microsoft.com/office/drawing/2014/main" id="{41B9CDE1-C775-423E-917C-B094A8C52CA8}"/>
               </a:ext>
             </a:extLst>
           </p:cNvPr>
@@ -15531,7 +15531,7 @@
           <p:cNvPr id="18" name="">
             <a:extLst xmlns:a="http://schemas.openxmlformats.org/drawingml/2006/main">
               <a:ext uri="{FF2B5EF4-FFF2-40B4-BE49-F238E27FC236}">
-                <a16:creationId xmlns:a16="http://schemas.microsoft.com/office/drawing/2014/main" id="{69700764-0957-44A6-88B4-CEFD0FBA99B5}"/>
+                <a16:creationId xmlns:a16="http://schemas.microsoft.com/office/drawing/2014/main" id="{63625B3D-CEFC-4685-A7A7-2427885A1D0C}"/>
               </a:ext>
             </a:extLst>
           </p:cNvPr>
@@ -15588,7 +15588,7 @@
           <p:cNvPr id="19" name="">
             <a:extLst xmlns:a="http://schemas.openxmlformats.org/drawingml/2006/main">
               <a:ext uri="{FF2B5EF4-FFF2-40B4-BE49-F238E27FC236}">
-                <a16:creationId xmlns:a16="http://schemas.microsoft.com/office/drawing/2014/main" id="{871AE956-013E-4B2C-8F2B-E8DBAEE0ADCD}"/>
+                <a16:creationId xmlns:a16="http://schemas.microsoft.com/office/drawing/2014/main" id="{305933A6-58D7-4A58-A021-6150F51AC716}"/>
               </a:ext>
             </a:extLst>
           </p:cNvPr>
@@ -15634,7 +15634,7 @@
                 <a:latin typeface="Arial"/>
                 <a:ea typeface="Arial"/>
                 <a:cs typeface="Arial"/>
-                <a:hlinkClick xmlns:r="http://schemas.openxmlformats.org/officeDocument/2006/relationships" r:id="R4dbbd2d3dc374171"/>
+                <a:hlinkClick xmlns:r="http://schemas.openxmlformats.org/officeDocument/2006/relationships" r:id="Raeb7bbae3b19404f"/>
               </a:rPr>
               <a:t>oborskyivitalii@gmail.com</a:t>
             </a:r>
@@ -15646,7 +15646,7 @@
           <p:cNvPr id="20" name="">
             <a:extLst xmlns:a="http://schemas.openxmlformats.org/drawingml/2006/main">
               <a:ext uri="{FF2B5EF4-FFF2-40B4-BE49-F238E27FC236}">
-                <a16:creationId xmlns:a16="http://schemas.microsoft.com/office/drawing/2014/main" id="{A640F011-41D5-48A4-B7CE-B9B64E67D2CD}"/>
+                <a16:creationId xmlns:a16="http://schemas.microsoft.com/office/drawing/2014/main" id="{A839D3FE-64D5-45D8-B2DD-43186EF6E9F0}"/>
               </a:ext>
             </a:extLst>
           </p:cNvPr>
@@ -15692,7 +15692,7 @@
                 <a:latin typeface="Arial"/>
                 <a:ea typeface="Arial"/>
                 <a:cs typeface="Arial"/>
-                <a:hlinkClick xmlns:r="http://schemas.openxmlformats.org/officeDocument/2006/relationships" r:id="R45f12a51f4cf4665"/>
+                <a:hlinkClick xmlns:r="http://schemas.openxmlformats.org/officeDocument/2006/relationships" r:id="R9df8d43fee184339"/>
               </a:rPr>
               <a:t>https://www.linkedin.com/in/vitaliioborskyi/</a:t>
             </a:r>
@@ -15702,7 +15702,7 @@
     </p:spTree>
     <p:extLst>
       <p:ext uri="{BB962C8B-B14F-4D97-AF65-F5344CB8AC3E}">
-        <p14:creationId xmlns:p14="http://schemas.microsoft.com/office/powerpoint/2010/main" val="1048853581"/>
+        <p14:creationId xmlns:p14="http://schemas.microsoft.com/office/powerpoint/2010/main" val="1796911505"/>
       </p:ext>
     </p:extLst>
   </p:cSld>
@@ -15785,7 +15785,7 @@
           <p:cNvPr id="23" name="">
             <a:extLst xmlns:a="http://schemas.openxmlformats.org/drawingml/2006/main">
               <a:ext uri="{FF2B5EF4-FFF2-40B4-BE49-F238E27FC236}">
-                <a16:creationId xmlns:a16="http://schemas.microsoft.com/office/drawing/2014/main" id="{528AAC6B-B99B-4385-931C-78B86A9311FB}"/>
+                <a16:creationId xmlns:a16="http://schemas.microsoft.com/office/drawing/2014/main" id="{C6D0BA3C-043D-4F59-914B-D6CF3E5F93A3}"/>
               </a:ext>
             </a:extLst>
           </p:cNvPr>
@@ -15842,7 +15842,7 @@
           <p:cNvPr id="2" name="">
             <a:extLst xmlns:a="http://schemas.openxmlformats.org/drawingml/2006/main">
               <a:ext uri="{FF2B5EF4-FFF2-40B4-BE49-F238E27FC236}">
-                <a16:creationId xmlns:a16="http://schemas.microsoft.com/office/drawing/2014/main" id="{F1E8D5CB-D6D5-4E16-908F-65B8B1B19817}"/>
+                <a16:creationId xmlns:a16="http://schemas.microsoft.com/office/drawing/2014/main" id="{99D68A37-6F52-4BAD-BB3D-C8FF4EF6FA95}"/>
               </a:ext>
             </a:extLst>
           </p:cNvPr>
@@ -15873,7 +15873,7 @@
           <p:cNvPr id="3" name="">
             <a:extLst xmlns:a="http://schemas.openxmlformats.org/drawingml/2006/main">
               <a:ext uri="{FF2B5EF4-FFF2-40B4-BE49-F238E27FC236}">
-                <a16:creationId xmlns:a16="http://schemas.microsoft.com/office/drawing/2014/main" id="{32841CC1-88AE-4291-954B-82DA3AD18096}"/>
+                <a16:creationId xmlns:a16="http://schemas.microsoft.com/office/drawing/2014/main" id="{25352DC6-6057-4BEF-AD69-621446488C80}"/>
               </a:ext>
             </a:extLst>
           </p:cNvPr>
@@ -15930,7 +15930,7 @@
           <p:cNvPr id="4" name="">
             <a:extLst xmlns:a="http://schemas.openxmlformats.org/drawingml/2006/main">
               <a:ext uri="{FF2B5EF4-FFF2-40B4-BE49-F238E27FC236}">
-                <a16:creationId xmlns:a16="http://schemas.microsoft.com/office/drawing/2014/main" id="{537DAD96-CA39-4CB1-ACC9-C577EF897ED2}"/>
+                <a16:creationId xmlns:a16="http://schemas.microsoft.com/office/drawing/2014/main" id="{C43BB7B5-16A9-4AD3-9F3D-C9E14FF20342}"/>
               </a:ext>
             </a:extLst>
           </p:cNvPr>
@@ -15963,7 +15963,7 @@
           <p:cNvPr id="5" name="">
             <a:extLst xmlns:a="http://schemas.openxmlformats.org/drawingml/2006/main">
               <a:ext uri="{FF2B5EF4-FFF2-40B4-BE49-F238E27FC236}">
-                <a16:creationId xmlns:a16="http://schemas.microsoft.com/office/drawing/2014/main" id="{33B26C84-E8AF-4583-988A-31B2420B5C2F}"/>
+                <a16:creationId xmlns:a16="http://schemas.microsoft.com/office/drawing/2014/main" id="{A5CEEE56-2E77-49CC-99D4-0841679A99B6}"/>
               </a:ext>
             </a:extLst>
           </p:cNvPr>
@@ -16020,7 +16020,7 @@
           <p:cNvPr id="6" name="">
             <a:extLst xmlns:a="http://schemas.openxmlformats.org/drawingml/2006/main">
               <a:ext uri="{FF2B5EF4-FFF2-40B4-BE49-F238E27FC236}">
-                <a16:creationId xmlns:a16="http://schemas.microsoft.com/office/drawing/2014/main" id="{0449133D-F05D-451F-8524-B4F169BFAD42}"/>
+                <a16:creationId xmlns:a16="http://schemas.microsoft.com/office/drawing/2014/main" id="{57CCDFE5-3814-4608-AB5F-6EBC31BA6359}"/>
               </a:ext>
             </a:extLst>
           </p:cNvPr>
@@ -16100,7 +16100,7 @@
           <p:cNvPr id="7" name="">
             <a:extLst xmlns:a="http://schemas.openxmlformats.org/drawingml/2006/main">
               <a:ext uri="{FF2B5EF4-FFF2-40B4-BE49-F238E27FC236}">
-                <a16:creationId xmlns:a16="http://schemas.microsoft.com/office/drawing/2014/main" id="{6AE9DD88-A2E3-4AFB-B2C0-699D11E865F5}"/>
+                <a16:creationId xmlns:a16="http://schemas.microsoft.com/office/drawing/2014/main" id="{F1CB8C13-D99D-4A1F-BF3F-04408ADECF1D}"/>
               </a:ext>
             </a:extLst>
           </p:cNvPr>
@@ -16180,7 +16180,7 @@
           <p:cNvPr id="8" name="">
             <a:extLst xmlns:a="http://schemas.openxmlformats.org/drawingml/2006/main">
               <a:ext uri="{FF2B5EF4-FFF2-40B4-BE49-F238E27FC236}">
-                <a16:creationId xmlns:a16="http://schemas.microsoft.com/office/drawing/2014/main" id="{97279A77-22A7-4C04-B433-8C3860C4AFEA}"/>
+                <a16:creationId xmlns:a16="http://schemas.microsoft.com/office/drawing/2014/main" id="{EB26B06F-71AC-457C-B1B6-C5AEFB3A4D86}"/>
               </a:ext>
             </a:extLst>
           </p:cNvPr>
@@ -16213,7 +16213,7 @@
           <p:cNvPr id="9" name="">
             <a:extLst xmlns:a="http://schemas.openxmlformats.org/drawingml/2006/main">
               <a:ext uri="{FF2B5EF4-FFF2-40B4-BE49-F238E27FC236}">
-                <a16:creationId xmlns:a16="http://schemas.microsoft.com/office/drawing/2014/main" id="{1E15BC9E-F3D5-479F-89A4-8BFA9576AEDD}"/>
+                <a16:creationId xmlns:a16="http://schemas.microsoft.com/office/drawing/2014/main" id="{048AA86A-D8D9-4089-A82A-0BC840D4B970}"/>
               </a:ext>
             </a:extLst>
           </p:cNvPr>
@@ -16270,7 +16270,7 @@
           <p:cNvPr id="10" name="">
             <a:extLst xmlns:a="http://schemas.openxmlformats.org/drawingml/2006/main">
               <a:ext uri="{FF2B5EF4-FFF2-40B4-BE49-F238E27FC236}">
-                <a16:creationId xmlns:a16="http://schemas.microsoft.com/office/drawing/2014/main" id="{F05103E1-6535-4F3C-9CB7-0FBE01AAB533}"/>
+                <a16:creationId xmlns:a16="http://schemas.microsoft.com/office/drawing/2014/main" id="{CCA529F2-8403-4623-9554-0DA6B317DD64}"/>
               </a:ext>
             </a:extLst>
           </p:cNvPr>
@@ -16350,7 +16350,7 @@
           <p:cNvPr id="11" name="">
             <a:extLst xmlns:a="http://schemas.openxmlformats.org/drawingml/2006/main">
               <a:ext uri="{FF2B5EF4-FFF2-40B4-BE49-F238E27FC236}">
-                <a16:creationId xmlns:a16="http://schemas.microsoft.com/office/drawing/2014/main" id="{7067B0C2-139F-4474-A7E3-524E77511E7A}"/>
+                <a16:creationId xmlns:a16="http://schemas.microsoft.com/office/drawing/2014/main" id="{56683976-58F6-4A8F-8003-61291074ED0A}"/>
               </a:ext>
             </a:extLst>
           </p:cNvPr>
@@ -16430,7 +16430,7 @@
           <p:cNvPr id="12" name="">
             <a:extLst xmlns:a="http://schemas.openxmlformats.org/drawingml/2006/main">
               <a:ext uri="{FF2B5EF4-FFF2-40B4-BE49-F238E27FC236}">
-                <a16:creationId xmlns:a16="http://schemas.microsoft.com/office/drawing/2014/main" id="{C7F66E2C-8CA8-4004-984F-C750B517D1C2}"/>
+                <a16:creationId xmlns:a16="http://schemas.microsoft.com/office/drawing/2014/main" id="{263DB042-8BF0-4274-A16F-907EC1118D28}"/>
               </a:ext>
             </a:extLst>
           </p:cNvPr>
@@ -16463,7 +16463,7 @@
           <p:cNvPr id="13" name="">
             <a:extLst xmlns:a="http://schemas.openxmlformats.org/drawingml/2006/main">
               <a:ext uri="{FF2B5EF4-FFF2-40B4-BE49-F238E27FC236}">
-                <a16:creationId xmlns:a16="http://schemas.microsoft.com/office/drawing/2014/main" id="{0E26E167-78E6-47E9-B8D9-DD3DA723A068}"/>
+                <a16:creationId xmlns:a16="http://schemas.microsoft.com/office/drawing/2014/main" id="{98D904B2-F5D1-48DD-AE87-A5378482DB8E}"/>
               </a:ext>
             </a:extLst>
           </p:cNvPr>
@@ -16520,7 +16520,7 @@
           <p:cNvPr id="14" name="">
             <a:extLst xmlns:a="http://schemas.openxmlformats.org/drawingml/2006/main">
               <a:ext uri="{FF2B5EF4-FFF2-40B4-BE49-F238E27FC236}">
-                <a16:creationId xmlns:a16="http://schemas.microsoft.com/office/drawing/2014/main" id="{963527B5-6DFA-4865-BEE4-757D9CAB6F36}"/>
+                <a16:creationId xmlns:a16="http://schemas.microsoft.com/office/drawing/2014/main" id="{40A50871-3FE5-4C5D-A18F-FC10BC560399}"/>
               </a:ext>
             </a:extLst>
           </p:cNvPr>
@@ -16600,7 +16600,7 @@
           <p:cNvPr id="15" name="">
             <a:extLst xmlns:a="http://schemas.openxmlformats.org/drawingml/2006/main">
               <a:ext uri="{FF2B5EF4-FFF2-40B4-BE49-F238E27FC236}">
-                <a16:creationId xmlns:a16="http://schemas.microsoft.com/office/drawing/2014/main" id="{25E6673B-ADE2-43C2-8FB1-BBFE77C9A06D}"/>
+                <a16:creationId xmlns:a16="http://schemas.microsoft.com/office/drawing/2014/main" id="{3AB339AC-D5C5-4E8F-882F-9BA49199B2C0}"/>
               </a:ext>
             </a:extLst>
           </p:cNvPr>
@@ -16680,7 +16680,7 @@
           <p:cNvPr id="18" name="">
             <a:extLst xmlns:a="http://schemas.openxmlformats.org/drawingml/2006/main">
               <a:ext uri="{FF2B5EF4-FFF2-40B4-BE49-F238E27FC236}">
-                <a16:creationId xmlns:a16="http://schemas.microsoft.com/office/drawing/2014/main" id="{82BC17CF-13A4-4648-BFF8-1F7E95E42480}"/>
+                <a16:creationId xmlns:a16="http://schemas.microsoft.com/office/drawing/2014/main" id="{E322AEC5-967C-48AF-8066-5EB2B1B5DDF5}"/>
               </a:ext>
             </a:extLst>
           </p:cNvPr>
@@ -16737,7 +16737,7 @@
           <p:cNvPr id="19" name="">
             <a:extLst xmlns:a="http://schemas.openxmlformats.org/drawingml/2006/main">
               <a:ext uri="{FF2B5EF4-FFF2-40B4-BE49-F238E27FC236}">
-                <a16:creationId xmlns:a16="http://schemas.microsoft.com/office/drawing/2014/main" id="{D6039A2F-15D4-4E5B-A596-DCD87C0D5996}"/>
+                <a16:creationId xmlns:a16="http://schemas.microsoft.com/office/drawing/2014/main" id="{E0613D3D-1D36-48DC-9A30-D514F85A0B03}"/>
               </a:ext>
             </a:extLst>
           </p:cNvPr>
@@ -16768,7 +16768,7 @@
           <p:cNvPr id="20" name="">
             <a:extLst xmlns:a="http://schemas.openxmlformats.org/drawingml/2006/main">
               <a:ext uri="{FF2B5EF4-FFF2-40B4-BE49-F238E27FC236}">
-                <a16:creationId xmlns:a16="http://schemas.microsoft.com/office/drawing/2014/main" id="{4BDB6D5D-4FC3-49AE-8806-7599E082CC63}"/>
+                <a16:creationId xmlns:a16="http://schemas.microsoft.com/office/drawing/2014/main" id="{147EF6D8-A554-42E4-9B35-3E4A4CB256F3}"/>
               </a:ext>
             </a:extLst>
           </p:cNvPr>
@@ -16846,7 +16846,7 @@
     </p:spTree>
     <p:extLst>
       <p:ext uri="{BB962C8B-B14F-4D97-AF65-F5344CB8AC3E}">
-        <p14:creationId xmlns:p14="http://schemas.microsoft.com/office/powerpoint/2010/main" val="540402472"/>
+        <p14:creationId xmlns:p14="http://schemas.microsoft.com/office/powerpoint/2010/main" val="274031009"/>
       </p:ext>
     </p:extLst>
   </p:cSld>
@@ -16877,7 +16877,7 @@
           <p:cNvPr id="68" name="">
             <a:extLst xmlns:a="http://schemas.openxmlformats.org/drawingml/2006/main">
               <a:ext uri="{FF2B5EF4-FFF2-40B4-BE49-F238E27FC236}">
-                <a16:creationId xmlns:a16="http://schemas.microsoft.com/office/drawing/2014/main" id="{A1354CCA-C40C-4213-93F7-925EFC9DE84E}"/>
+                <a16:creationId xmlns:a16="http://schemas.microsoft.com/office/drawing/2014/main" id="{FAD794EC-2038-4704-99DE-AB5C9D31B366}"/>
               </a:ext>
             </a:extLst>
           </p:cNvPr>
@@ -16934,7 +16934,7 @@
           <p:cNvPr id="2" name="">
             <a:extLst xmlns:a="http://schemas.openxmlformats.org/drawingml/2006/main">
               <a:ext uri="{FF2B5EF4-FFF2-40B4-BE49-F238E27FC236}">
-                <a16:creationId xmlns:a16="http://schemas.microsoft.com/office/drawing/2014/main" id="{8E7E36C9-3FE4-43DD-9A3C-1A4012B49938}"/>
+                <a16:creationId xmlns:a16="http://schemas.microsoft.com/office/drawing/2014/main" id="{DD833353-FCBC-4F3B-BEFD-E724AF5ACBB0}"/>
               </a:ext>
             </a:extLst>
           </p:cNvPr>
@@ -16965,7 +16965,7 @@
           <p:cNvPr id="3" name="">
             <a:extLst xmlns:a="http://schemas.openxmlformats.org/drawingml/2006/main">
               <a:ext uri="{FF2B5EF4-FFF2-40B4-BE49-F238E27FC236}">
-                <a16:creationId xmlns:a16="http://schemas.microsoft.com/office/drawing/2014/main" id="{A87ACF9A-0176-4198-A03A-29D0664C531F}"/>
+                <a16:creationId xmlns:a16="http://schemas.microsoft.com/office/drawing/2014/main" id="{9E52480B-F9FE-4D2B-83A0-89F795EA2437}"/>
               </a:ext>
             </a:extLst>
           </p:cNvPr>
@@ -17022,7 +17022,7 @@
           <p:cNvPr id="4" name="">
             <a:extLst xmlns:a="http://schemas.openxmlformats.org/drawingml/2006/main">
               <a:ext uri="{FF2B5EF4-FFF2-40B4-BE49-F238E27FC236}">
-                <a16:creationId xmlns:a16="http://schemas.microsoft.com/office/drawing/2014/main" id="{627A1F68-1D44-4249-92CF-928C1B736EF3}"/>
+                <a16:creationId xmlns:a16="http://schemas.microsoft.com/office/drawing/2014/main" id="{1A09DF6F-7876-42AF-AA79-E02D260FFD5E}"/>
               </a:ext>
             </a:extLst>
           </p:cNvPr>
@@ -17079,7 +17079,7 @@
           <p:cNvPr id="5" name="">
             <a:extLst xmlns:a="http://schemas.openxmlformats.org/drawingml/2006/main">
               <a:ext uri="{FF2B5EF4-FFF2-40B4-BE49-F238E27FC236}">
-                <a16:creationId xmlns:a16="http://schemas.microsoft.com/office/drawing/2014/main" id="{E992B187-249D-4A1C-9E02-2FCEC8C47C45}"/>
+                <a16:creationId xmlns:a16="http://schemas.microsoft.com/office/drawing/2014/main" id="{0F7B0828-00D4-4AC2-B78F-E571D35D44EA}"/>
               </a:ext>
             </a:extLst>
           </p:cNvPr>
@@ -17112,7 +17112,7 @@
           <p:cNvPr id="6" name="">
             <a:extLst xmlns:a="http://schemas.openxmlformats.org/drawingml/2006/main">
               <a:ext uri="{FF2B5EF4-FFF2-40B4-BE49-F238E27FC236}">
-                <a16:creationId xmlns:a16="http://schemas.microsoft.com/office/drawing/2014/main" id="{F1E72BEC-E43F-446E-AD48-7B357E67ECB6}"/>
+                <a16:creationId xmlns:a16="http://schemas.microsoft.com/office/drawing/2014/main" id="{0E7767C3-CD05-40F3-BAF4-D071E4D8ACBD}"/>
               </a:ext>
             </a:extLst>
           </p:cNvPr>
@@ -17169,7 +17169,7 @@
           <p:cNvPr id="7" name="">
             <a:extLst xmlns:a="http://schemas.openxmlformats.org/drawingml/2006/main">
               <a:ext uri="{FF2B5EF4-FFF2-40B4-BE49-F238E27FC236}">
-                <a16:creationId xmlns:a16="http://schemas.microsoft.com/office/drawing/2014/main" id="{D7D85792-7380-49E7-B367-3B07E457105F}"/>
+                <a16:creationId xmlns:a16="http://schemas.microsoft.com/office/drawing/2014/main" id="{7896ABEA-9883-4558-81B7-0160C86ADDA8}"/>
               </a:ext>
             </a:extLst>
           </p:cNvPr>
@@ -17202,7 +17202,7 @@
           <p:cNvPr id="8" name="">
             <a:extLst xmlns:a="http://schemas.openxmlformats.org/drawingml/2006/main">
               <a:ext uri="{FF2B5EF4-FFF2-40B4-BE49-F238E27FC236}">
-                <a16:creationId xmlns:a16="http://schemas.microsoft.com/office/drawing/2014/main" id="{3B88B8EA-D193-40B9-AE70-E6D96D929C80}"/>
+                <a16:creationId xmlns:a16="http://schemas.microsoft.com/office/drawing/2014/main" id="{D132B709-0E49-4835-897E-61A122E79D14}"/>
               </a:ext>
             </a:extLst>
           </p:cNvPr>
@@ -17259,7 +17259,7 @@
           <p:cNvPr id="9" name="">
             <a:extLst xmlns:a="http://schemas.openxmlformats.org/drawingml/2006/main">
               <a:ext uri="{FF2B5EF4-FFF2-40B4-BE49-F238E27FC236}">
-                <a16:creationId xmlns:a16="http://schemas.microsoft.com/office/drawing/2014/main" id="{59993043-DBCA-4EAB-8FBB-4F0D7874BEBC}"/>
+                <a16:creationId xmlns:a16="http://schemas.microsoft.com/office/drawing/2014/main" id="{6101CFD0-CA53-481C-A615-02CF5923E728}"/>
               </a:ext>
             </a:extLst>
           </p:cNvPr>
@@ -17292,7 +17292,7 @@
           <p:cNvPr id="10" name="">
             <a:extLst xmlns:a="http://schemas.openxmlformats.org/drawingml/2006/main">
               <a:ext uri="{FF2B5EF4-FFF2-40B4-BE49-F238E27FC236}">
-                <a16:creationId xmlns:a16="http://schemas.microsoft.com/office/drawing/2014/main" id="{C708644C-4285-4B09-9025-44C5D1642887}"/>
+                <a16:creationId xmlns:a16="http://schemas.microsoft.com/office/drawing/2014/main" id="{56051758-BD46-4E32-BE22-304CE75501CA}"/>
               </a:ext>
             </a:extLst>
           </p:cNvPr>
@@ -17349,7 +17349,7 @@
           <p:cNvPr id="11" name="">
             <a:extLst xmlns:a="http://schemas.openxmlformats.org/drawingml/2006/main">
               <a:ext uri="{FF2B5EF4-FFF2-40B4-BE49-F238E27FC236}">
-                <a16:creationId xmlns:a16="http://schemas.microsoft.com/office/drawing/2014/main" id="{1409C426-A203-4732-AD9D-7654FCEBEB89}"/>
+                <a16:creationId xmlns:a16="http://schemas.microsoft.com/office/drawing/2014/main" id="{6ADE3CA0-4F44-4C79-8244-29106FEFDA44}"/>
               </a:ext>
             </a:extLst>
           </p:cNvPr>
@@ -17382,7 +17382,7 @@
           <p:cNvPr id="12" name="">
             <a:extLst xmlns:a="http://schemas.openxmlformats.org/drawingml/2006/main">
               <a:ext uri="{FF2B5EF4-FFF2-40B4-BE49-F238E27FC236}">
-                <a16:creationId xmlns:a16="http://schemas.microsoft.com/office/drawing/2014/main" id="{50FCB825-8290-46AB-9B2A-551E59E59812}"/>
+                <a16:creationId xmlns:a16="http://schemas.microsoft.com/office/drawing/2014/main" id="{A35916A5-FFA2-434E-9BC2-7D0E3DA7C828}"/>
               </a:ext>
             </a:extLst>
           </p:cNvPr>
@@ -17439,7 +17439,7 @@
           <p:cNvPr id="13" name="">
             <a:extLst xmlns:a="http://schemas.openxmlformats.org/drawingml/2006/main">
               <a:ext uri="{FF2B5EF4-FFF2-40B4-BE49-F238E27FC236}">
-                <a16:creationId xmlns:a16="http://schemas.microsoft.com/office/drawing/2014/main" id="{5C76C649-1123-442C-B94C-AB18A4EDCE31}"/>
+                <a16:creationId xmlns:a16="http://schemas.microsoft.com/office/drawing/2014/main" id="{1FAC332B-FC31-402F-8359-27AF5F9F483F}"/>
               </a:ext>
             </a:extLst>
           </p:cNvPr>
@@ -17472,7 +17472,7 @@
           <p:cNvPr id="14" name="">
             <a:extLst xmlns:a="http://schemas.openxmlformats.org/drawingml/2006/main">
               <a:ext uri="{FF2B5EF4-FFF2-40B4-BE49-F238E27FC236}">
-                <a16:creationId xmlns:a16="http://schemas.microsoft.com/office/drawing/2014/main" id="{0BD77D60-D66C-4AA6-B702-7F29F2E58F41}"/>
+                <a16:creationId xmlns:a16="http://schemas.microsoft.com/office/drawing/2014/main" id="{A68ED7CD-5BBB-46F0-B941-BAC10F5526FE}"/>
               </a:ext>
             </a:extLst>
           </p:cNvPr>
@@ -17529,7 +17529,7 @@
           <p:cNvPr id="15" name="">
             <a:extLst xmlns:a="http://schemas.openxmlformats.org/drawingml/2006/main">
               <a:ext uri="{FF2B5EF4-FFF2-40B4-BE49-F238E27FC236}">
-                <a16:creationId xmlns:a16="http://schemas.microsoft.com/office/drawing/2014/main" id="{42B76301-D1EF-42AA-BF23-32443061D278}"/>
+                <a16:creationId xmlns:a16="http://schemas.microsoft.com/office/drawing/2014/main" id="{C26DC578-C302-4CED-87A0-AA83F5FB00C5}"/>
               </a:ext>
             </a:extLst>
           </p:cNvPr>
@@ -17562,7 +17562,7 @@
           <p:cNvPr id="16" name="">
             <a:extLst xmlns:a="http://schemas.openxmlformats.org/drawingml/2006/main">
               <a:ext uri="{FF2B5EF4-FFF2-40B4-BE49-F238E27FC236}">
-                <a16:creationId xmlns:a16="http://schemas.microsoft.com/office/drawing/2014/main" id="{9B3BA5BF-7C1D-428C-B593-3C8516F1872A}"/>
+                <a16:creationId xmlns:a16="http://schemas.microsoft.com/office/drawing/2014/main" id="{CE6529C3-78DD-41A1-B1AB-8CEF54AAB9C6}"/>
               </a:ext>
             </a:extLst>
           </p:cNvPr>
@@ -17619,7 +17619,7 @@
           <p:cNvPr id="17" name="">
             <a:extLst xmlns:a="http://schemas.openxmlformats.org/drawingml/2006/main">
               <a:ext uri="{FF2B5EF4-FFF2-40B4-BE49-F238E27FC236}">
-                <a16:creationId xmlns:a16="http://schemas.microsoft.com/office/drawing/2014/main" id="{5F4FAABA-2D8B-4310-8FDB-62901B0FDC71}"/>
+                <a16:creationId xmlns:a16="http://schemas.microsoft.com/office/drawing/2014/main" id="{B69FF806-91FD-4371-86B3-6B1916AF0EC8}"/>
               </a:ext>
             </a:extLst>
           </p:cNvPr>
@@ -17652,7 +17652,7 @@
           <p:cNvPr id="18" name="">
             <a:extLst xmlns:a="http://schemas.openxmlformats.org/drawingml/2006/main">
               <a:ext uri="{FF2B5EF4-FFF2-40B4-BE49-F238E27FC236}">
-                <a16:creationId xmlns:a16="http://schemas.microsoft.com/office/drawing/2014/main" id="{96F011C6-9FBA-48A0-B3E8-450070E58BDE}"/>
+                <a16:creationId xmlns:a16="http://schemas.microsoft.com/office/drawing/2014/main" id="{8F7569C8-B649-4988-B322-BAB38B83FA8B}"/>
               </a:ext>
             </a:extLst>
           </p:cNvPr>
@@ -17709,7 +17709,7 @@
           <p:cNvPr id="19" name="">
             <a:extLst xmlns:a="http://schemas.openxmlformats.org/drawingml/2006/main">
               <a:ext uri="{FF2B5EF4-FFF2-40B4-BE49-F238E27FC236}">
-                <a16:creationId xmlns:a16="http://schemas.microsoft.com/office/drawing/2014/main" id="{41C709A8-411B-450F-AAE3-BABE4E20E619}"/>
+                <a16:creationId xmlns:a16="http://schemas.microsoft.com/office/drawing/2014/main" id="{1DC64ADC-8970-4ABF-8269-798B9CA28C0F}"/>
               </a:ext>
             </a:extLst>
           </p:cNvPr>
@@ -17742,7 +17742,7 @@
           <p:cNvPr id="20" name="">
             <a:extLst xmlns:a="http://schemas.openxmlformats.org/drawingml/2006/main">
               <a:ext uri="{FF2B5EF4-FFF2-40B4-BE49-F238E27FC236}">
-                <a16:creationId xmlns:a16="http://schemas.microsoft.com/office/drawing/2014/main" id="{F9E912E1-1197-448E-9D87-2C7C514BAE4D}"/>
+                <a16:creationId xmlns:a16="http://schemas.microsoft.com/office/drawing/2014/main" id="{DC150C06-9A50-4F4C-AE36-39DE66D9D137}"/>
               </a:ext>
             </a:extLst>
           </p:cNvPr>
@@ -17799,7 +17799,7 @@
           <p:cNvPr id="21" name="">
             <a:extLst xmlns:a="http://schemas.openxmlformats.org/drawingml/2006/main">
               <a:ext uri="{FF2B5EF4-FFF2-40B4-BE49-F238E27FC236}">
-                <a16:creationId xmlns:a16="http://schemas.microsoft.com/office/drawing/2014/main" id="{10AB8FEC-0D9D-4808-94F0-9587A30369DD}"/>
+                <a16:creationId xmlns:a16="http://schemas.microsoft.com/office/drawing/2014/main" id="{77024F76-0980-41F1-9DB5-F3334BF1097A}"/>
               </a:ext>
             </a:extLst>
           </p:cNvPr>
@@ -17830,7 +17830,7 @@
           <p:cNvPr id="22" name="">
             <a:extLst xmlns:a="http://schemas.openxmlformats.org/drawingml/2006/main">
               <a:ext uri="{FF2B5EF4-FFF2-40B4-BE49-F238E27FC236}">
-                <a16:creationId xmlns:a16="http://schemas.microsoft.com/office/drawing/2014/main" id="{D29527AE-FA94-4955-8E40-C6427AA934D9}"/>
+                <a16:creationId xmlns:a16="http://schemas.microsoft.com/office/drawing/2014/main" id="{D219E03E-4017-4CA3-BFF6-BF0E48C0A1D4}"/>
               </a:ext>
             </a:extLst>
           </p:cNvPr>
@@ -17861,7 +17861,7 @@
           <p:cNvPr id="23" name="">
             <a:extLst xmlns:a="http://schemas.openxmlformats.org/drawingml/2006/main">
               <a:ext uri="{FF2B5EF4-FFF2-40B4-BE49-F238E27FC236}">
-                <a16:creationId xmlns:a16="http://schemas.microsoft.com/office/drawing/2014/main" id="{691EAA89-DB2F-40FF-A966-3D8D1985C0E4}"/>
+                <a16:creationId xmlns:a16="http://schemas.microsoft.com/office/drawing/2014/main" id="{7CCCEF0F-C5F2-40CA-92A0-281F8C1B3B18}"/>
               </a:ext>
             </a:extLst>
           </p:cNvPr>
@@ -17892,7 +17892,7 @@
           <p:cNvPr id="24" name="">
             <a:extLst xmlns:a="http://schemas.openxmlformats.org/drawingml/2006/main">
               <a:ext uri="{FF2B5EF4-FFF2-40B4-BE49-F238E27FC236}">
-                <a16:creationId xmlns:a16="http://schemas.microsoft.com/office/drawing/2014/main" id="{9690FEC8-29CC-4E21-B42D-26279341B6F2}"/>
+                <a16:creationId xmlns:a16="http://schemas.microsoft.com/office/drawing/2014/main" id="{970A7504-E46B-4B5F-B338-6CA567DD7C06}"/>
               </a:ext>
             </a:extLst>
           </p:cNvPr>
@@ -17923,7 +17923,7 @@
           <p:cNvPr id="25" name="">
             <a:extLst xmlns:a="http://schemas.openxmlformats.org/drawingml/2006/main">
               <a:ext uri="{FF2B5EF4-FFF2-40B4-BE49-F238E27FC236}">
-                <a16:creationId xmlns:a16="http://schemas.microsoft.com/office/drawing/2014/main" id="{D41A9235-63E7-4028-AD95-E8D00A7036A8}"/>
+                <a16:creationId xmlns:a16="http://schemas.microsoft.com/office/drawing/2014/main" id="{8366E64C-2B95-459C-AA5F-1A4106E19852}"/>
               </a:ext>
             </a:extLst>
           </p:cNvPr>
@@ -17954,7 +17954,7 @@
           <p:cNvPr id="26" name="">
             <a:extLst xmlns:a="http://schemas.openxmlformats.org/drawingml/2006/main">
               <a:ext uri="{FF2B5EF4-FFF2-40B4-BE49-F238E27FC236}">
-                <a16:creationId xmlns:a16="http://schemas.microsoft.com/office/drawing/2014/main" id="{DE2D8FF9-0378-4914-99D5-DD7D76FEAEA9}"/>
+                <a16:creationId xmlns:a16="http://schemas.microsoft.com/office/drawing/2014/main" id="{238FC8DD-D7FC-4BA4-93E0-865AF0C8E1D1}"/>
               </a:ext>
             </a:extLst>
           </p:cNvPr>
@@ -17985,7 +17985,7 @@
           <p:cNvPr id="27" name="">
             <a:extLst xmlns:a="http://schemas.openxmlformats.org/drawingml/2006/main">
               <a:ext uri="{FF2B5EF4-FFF2-40B4-BE49-F238E27FC236}">
-                <a16:creationId xmlns:a16="http://schemas.microsoft.com/office/drawing/2014/main" id="{9035D3E3-7FCA-4F6B-8330-EA97697BEE39}"/>
+                <a16:creationId xmlns:a16="http://schemas.microsoft.com/office/drawing/2014/main" id="{FF53C49E-D4ED-4844-A27C-D48A7BB940E8}"/>
               </a:ext>
             </a:extLst>
           </p:cNvPr>
@@ -18016,7 +18016,7 @@
           <p:cNvPr id="28" name="">
             <a:extLst xmlns:a="http://schemas.openxmlformats.org/drawingml/2006/main">
               <a:ext uri="{FF2B5EF4-FFF2-40B4-BE49-F238E27FC236}">
-                <a16:creationId xmlns:a16="http://schemas.microsoft.com/office/drawing/2014/main" id="{5A3EB2BB-B8C9-48B6-8D65-37A173EB31C3}"/>
+                <a16:creationId xmlns:a16="http://schemas.microsoft.com/office/drawing/2014/main" id="{D919320F-59F2-4AD5-B161-9A99D115106C}"/>
               </a:ext>
             </a:extLst>
           </p:cNvPr>
@@ -18073,7 +18073,7 @@
           <p:cNvPr id="29" name="">
             <a:extLst xmlns:a="http://schemas.openxmlformats.org/drawingml/2006/main">
               <a:ext uri="{FF2B5EF4-FFF2-40B4-BE49-F238E27FC236}">
-                <a16:creationId xmlns:a16="http://schemas.microsoft.com/office/drawing/2014/main" id="{F99D40F4-44A4-4BD4-9CE7-8DC078A17D36}"/>
+                <a16:creationId xmlns:a16="http://schemas.microsoft.com/office/drawing/2014/main" id="{43DBF3E1-69C6-4230-AEDC-73F2F6C55E77}"/>
               </a:ext>
             </a:extLst>
           </p:cNvPr>
@@ -18130,7 +18130,7 @@
           <p:cNvPr id="30" name="">
             <a:extLst xmlns:a="http://schemas.openxmlformats.org/drawingml/2006/main">
               <a:ext uri="{FF2B5EF4-FFF2-40B4-BE49-F238E27FC236}">
-                <a16:creationId xmlns:a16="http://schemas.microsoft.com/office/drawing/2014/main" id="{61B79944-E39A-487D-B94F-60DEFCC2E7B0}"/>
+                <a16:creationId xmlns:a16="http://schemas.microsoft.com/office/drawing/2014/main" id="{62737337-B99F-40B2-AA11-D3AAE91BA046}"/>
               </a:ext>
             </a:extLst>
           </p:cNvPr>
@@ -18187,7 +18187,7 @@
           <p:cNvPr id="31" name="">
             <a:extLst xmlns:a="http://schemas.openxmlformats.org/drawingml/2006/main">
               <a:ext uri="{FF2B5EF4-FFF2-40B4-BE49-F238E27FC236}">
-                <a16:creationId xmlns:a16="http://schemas.microsoft.com/office/drawing/2014/main" id="{A979DAA3-DB7A-402A-AA60-CF6F5470E3B3}"/>
+                <a16:creationId xmlns:a16="http://schemas.microsoft.com/office/drawing/2014/main" id="{C06D505E-E54E-4957-9831-B61C6B6AFF1E}"/>
               </a:ext>
             </a:extLst>
           </p:cNvPr>
@@ -18244,7 +18244,7 @@
           <p:cNvPr id="32" name="">
             <a:extLst xmlns:a="http://schemas.openxmlformats.org/drawingml/2006/main">
               <a:ext uri="{FF2B5EF4-FFF2-40B4-BE49-F238E27FC236}">
-                <a16:creationId xmlns:a16="http://schemas.microsoft.com/office/drawing/2014/main" id="{4CCBE470-C802-40AA-AFCF-18426F7ACE2D}"/>
+                <a16:creationId xmlns:a16="http://schemas.microsoft.com/office/drawing/2014/main" id="{C1EFFA35-0A20-4C0F-91D4-8A62B50244B2}"/>
               </a:ext>
             </a:extLst>
           </p:cNvPr>
@@ -18301,7 +18301,7 @@
           <p:cNvPr id="33" name="">
             <a:extLst xmlns:a="http://schemas.openxmlformats.org/drawingml/2006/main">
               <a:ext uri="{FF2B5EF4-FFF2-40B4-BE49-F238E27FC236}">
-                <a16:creationId xmlns:a16="http://schemas.microsoft.com/office/drawing/2014/main" id="{BE8DB58F-4CF2-4F17-A875-DAAA856D7D25}"/>
+                <a16:creationId xmlns:a16="http://schemas.microsoft.com/office/drawing/2014/main" id="{29F76A2B-102D-4F33-A1EC-D07F8ADA9BA2}"/>
               </a:ext>
             </a:extLst>
           </p:cNvPr>
@@ -18358,7 +18358,7 @@
           <p:cNvPr id="34" name="">
             <a:extLst xmlns:a="http://schemas.openxmlformats.org/drawingml/2006/main">
               <a:ext uri="{FF2B5EF4-FFF2-40B4-BE49-F238E27FC236}">
-                <a16:creationId xmlns:a16="http://schemas.microsoft.com/office/drawing/2014/main" id="{FE1549CB-E6F3-447B-A9BF-DEBF414A72C0}"/>
+                <a16:creationId xmlns:a16="http://schemas.microsoft.com/office/drawing/2014/main" id="{70FF997D-01B2-49B1-811D-DA478B3E64FE}"/>
               </a:ext>
             </a:extLst>
           </p:cNvPr>
@@ -18415,7 +18415,7 @@
           <p:cNvPr id="35" name="">
             <a:extLst xmlns:a="http://schemas.openxmlformats.org/drawingml/2006/main">
               <a:ext uri="{FF2B5EF4-FFF2-40B4-BE49-F238E27FC236}">
-                <a16:creationId xmlns:a16="http://schemas.microsoft.com/office/drawing/2014/main" id="{0A32D04A-CECC-4023-B6D4-565A490E97CF}"/>
+                <a16:creationId xmlns:a16="http://schemas.microsoft.com/office/drawing/2014/main" id="{1752A399-143F-45C3-813C-3B56ECC90915}"/>
               </a:ext>
             </a:extLst>
           </p:cNvPr>
@@ -18472,7 +18472,7 @@
           <p:cNvPr id="36" name="">
             <a:extLst xmlns:a="http://schemas.openxmlformats.org/drawingml/2006/main">
               <a:ext uri="{FF2B5EF4-FFF2-40B4-BE49-F238E27FC236}">
-                <a16:creationId xmlns:a16="http://schemas.microsoft.com/office/drawing/2014/main" id="{F03558B4-D89A-481E-B6B4-3ADC873FB4F3}"/>
+                <a16:creationId xmlns:a16="http://schemas.microsoft.com/office/drawing/2014/main" id="{DBA71DAF-CF51-45CA-8961-16E9A726C823}"/>
               </a:ext>
             </a:extLst>
           </p:cNvPr>
@@ -18529,7 +18529,7 @@
           <p:cNvPr id="37" name="">
             <a:extLst xmlns:a="http://schemas.openxmlformats.org/drawingml/2006/main">
               <a:ext uri="{FF2B5EF4-FFF2-40B4-BE49-F238E27FC236}">
-                <a16:creationId xmlns:a16="http://schemas.microsoft.com/office/drawing/2014/main" id="{3B10185D-E384-4606-A9EE-FAD187499796}"/>
+                <a16:creationId xmlns:a16="http://schemas.microsoft.com/office/drawing/2014/main" id="{92C894C4-1BC9-4C95-B0B8-2ED3E2EFFA0E}"/>
               </a:ext>
             </a:extLst>
           </p:cNvPr>
@@ -18586,7 +18586,7 @@
           <p:cNvPr id="38" name="">
             <a:extLst xmlns:a="http://schemas.openxmlformats.org/drawingml/2006/main">
               <a:ext uri="{FF2B5EF4-FFF2-40B4-BE49-F238E27FC236}">
-                <a16:creationId xmlns:a16="http://schemas.microsoft.com/office/drawing/2014/main" id="{2F39F9BF-2BA4-4423-B34A-C0C938C1FE62}"/>
+                <a16:creationId xmlns:a16="http://schemas.microsoft.com/office/drawing/2014/main" id="{844D2C45-F5D0-4FA1-8686-0EAA94376DEC}"/>
               </a:ext>
             </a:extLst>
           </p:cNvPr>
@@ -18643,7 +18643,7 @@
           <p:cNvPr id="39" name="">
             <a:extLst xmlns:a="http://schemas.openxmlformats.org/drawingml/2006/main">
               <a:ext uri="{FF2B5EF4-FFF2-40B4-BE49-F238E27FC236}">
-                <a16:creationId xmlns:a16="http://schemas.microsoft.com/office/drawing/2014/main" id="{EC10EBC2-A795-4764-941F-05FDEF65C124}"/>
+                <a16:creationId xmlns:a16="http://schemas.microsoft.com/office/drawing/2014/main" id="{38F82894-2AC7-4D50-86E6-A7F66149B5A9}"/>
               </a:ext>
             </a:extLst>
           </p:cNvPr>
@@ -18700,7 +18700,7 @@
           <p:cNvPr id="40" name="">
             <a:extLst xmlns:a="http://schemas.openxmlformats.org/drawingml/2006/main">
               <a:ext uri="{FF2B5EF4-FFF2-40B4-BE49-F238E27FC236}">
-                <a16:creationId xmlns:a16="http://schemas.microsoft.com/office/drawing/2014/main" id="{836468BA-4C91-401A-AAB5-001B396DE500}"/>
+                <a16:creationId xmlns:a16="http://schemas.microsoft.com/office/drawing/2014/main" id="{31A81BB5-E927-493B-B8D1-6A41DCA9317C}"/>
               </a:ext>
             </a:extLst>
           </p:cNvPr>
@@ -18757,7 +18757,7 @@
           <p:cNvPr id="41" name="">
             <a:extLst xmlns:a="http://schemas.openxmlformats.org/drawingml/2006/main">
               <a:ext uri="{FF2B5EF4-FFF2-40B4-BE49-F238E27FC236}">
-                <a16:creationId xmlns:a16="http://schemas.microsoft.com/office/drawing/2014/main" id="{2F681EEE-40F8-451B-BCC5-665CF76407D6}"/>
+                <a16:creationId xmlns:a16="http://schemas.microsoft.com/office/drawing/2014/main" id="{7032DCAA-FC49-497C-9271-26A1D725C4F1}"/>
               </a:ext>
             </a:extLst>
           </p:cNvPr>
@@ -18814,7 +18814,7 @@
           <p:cNvPr id="42" name="">
             <a:extLst xmlns:a="http://schemas.openxmlformats.org/drawingml/2006/main">
               <a:ext uri="{FF2B5EF4-FFF2-40B4-BE49-F238E27FC236}">
-                <a16:creationId xmlns:a16="http://schemas.microsoft.com/office/drawing/2014/main" id="{C3976B42-E7FD-41B1-A2C3-63D52E0F2D69}"/>
+                <a16:creationId xmlns:a16="http://schemas.microsoft.com/office/drawing/2014/main" id="{614BFCF3-B358-40F7-9F4E-267EC3D119D0}"/>
               </a:ext>
             </a:extLst>
           </p:cNvPr>
@@ -18847,7 +18847,7 @@
           <p:cNvPr id="43" name="">
             <a:extLst xmlns:a="http://schemas.openxmlformats.org/drawingml/2006/main">
               <a:ext uri="{FF2B5EF4-FFF2-40B4-BE49-F238E27FC236}">
-                <a16:creationId xmlns:a16="http://schemas.microsoft.com/office/drawing/2014/main" id="{E02F9740-C8EE-4D95-801F-BAB5AC78642C}"/>
+                <a16:creationId xmlns:a16="http://schemas.microsoft.com/office/drawing/2014/main" id="{B7116F83-25C9-4D46-A479-6F1F8CB27DBE}"/>
               </a:ext>
             </a:extLst>
           </p:cNvPr>
@@ -18904,7 +18904,7 @@
           <p:cNvPr id="44" name="">
             <a:extLst xmlns:a="http://schemas.openxmlformats.org/drawingml/2006/main">
               <a:ext uri="{FF2B5EF4-FFF2-40B4-BE49-F238E27FC236}">
-                <a16:creationId xmlns:a16="http://schemas.microsoft.com/office/drawing/2014/main" id="{ED7696E2-947D-463C-B594-A63085A19475}"/>
+                <a16:creationId xmlns:a16="http://schemas.microsoft.com/office/drawing/2014/main" id="{30A77A28-81A2-4867-B07F-E0048000EFB3}"/>
               </a:ext>
             </a:extLst>
           </p:cNvPr>
@@ -18937,7 +18937,7 @@
           <p:cNvPr id="45" name="">
             <a:extLst xmlns:a="http://schemas.openxmlformats.org/drawingml/2006/main">
               <a:ext uri="{FF2B5EF4-FFF2-40B4-BE49-F238E27FC236}">
-                <a16:creationId xmlns:a16="http://schemas.microsoft.com/office/drawing/2014/main" id="{6F75E043-A663-4E5B-9843-26E1414FD74E}"/>
+                <a16:creationId xmlns:a16="http://schemas.microsoft.com/office/drawing/2014/main" id="{B97E0E09-D0CF-4A38-8C62-13001203611D}"/>
               </a:ext>
             </a:extLst>
           </p:cNvPr>
@@ -18994,7 +18994,7 @@
           <p:cNvPr id="46" name="">
             <a:extLst xmlns:a="http://schemas.openxmlformats.org/drawingml/2006/main">
               <a:ext uri="{FF2B5EF4-FFF2-40B4-BE49-F238E27FC236}">
-                <a16:creationId xmlns:a16="http://schemas.microsoft.com/office/drawing/2014/main" id="{C710D817-8A93-4BA1-B27B-7A984D4A382E}"/>
+                <a16:creationId xmlns:a16="http://schemas.microsoft.com/office/drawing/2014/main" id="{3909F4C7-EFA4-425F-9496-C1911D0676BD}"/>
               </a:ext>
             </a:extLst>
           </p:cNvPr>
@@ -19027,7 +19027,7 @@
           <p:cNvPr id="47" name="">
             <a:extLst xmlns:a="http://schemas.openxmlformats.org/drawingml/2006/main">
               <a:ext uri="{FF2B5EF4-FFF2-40B4-BE49-F238E27FC236}">
-                <a16:creationId xmlns:a16="http://schemas.microsoft.com/office/drawing/2014/main" id="{FEF13508-F7BD-4907-AA07-022163631076}"/>
+                <a16:creationId xmlns:a16="http://schemas.microsoft.com/office/drawing/2014/main" id="{864E302B-E59A-419C-B933-F8563E84AB91}"/>
               </a:ext>
             </a:extLst>
           </p:cNvPr>
@@ -19084,7 +19084,7 @@
           <p:cNvPr id="48" name="">
             <a:extLst xmlns:a="http://schemas.openxmlformats.org/drawingml/2006/main">
               <a:ext uri="{FF2B5EF4-FFF2-40B4-BE49-F238E27FC236}">
-                <a16:creationId xmlns:a16="http://schemas.microsoft.com/office/drawing/2014/main" id="{191F3FEB-0C13-4C82-90B2-60F5E9FB2672}"/>
+                <a16:creationId xmlns:a16="http://schemas.microsoft.com/office/drawing/2014/main" id="{4AB6E477-8E18-4427-A01C-3EA5304BFCA4}"/>
               </a:ext>
             </a:extLst>
           </p:cNvPr>
@@ -19115,7 +19115,7 @@
           <p:cNvPr id="49" name="">
             <a:extLst xmlns:a="http://schemas.openxmlformats.org/drawingml/2006/main">
               <a:ext uri="{FF2B5EF4-FFF2-40B4-BE49-F238E27FC236}">
-                <a16:creationId xmlns:a16="http://schemas.microsoft.com/office/drawing/2014/main" id="{F3EA1BA7-F064-4706-AF53-E389567AC4A0}"/>
+                <a16:creationId xmlns:a16="http://schemas.microsoft.com/office/drawing/2014/main" id="{615F4943-3F74-45A7-B2AD-579E5290B4B7}"/>
               </a:ext>
             </a:extLst>
           </p:cNvPr>
@@ -19146,7 +19146,7 @@
           <p:cNvPr id="50" name="">
             <a:extLst xmlns:a="http://schemas.openxmlformats.org/drawingml/2006/main">
               <a:ext uri="{FF2B5EF4-FFF2-40B4-BE49-F238E27FC236}">
-                <a16:creationId xmlns:a16="http://schemas.microsoft.com/office/drawing/2014/main" id="{77D6B1EB-6AE2-4596-BE78-472C5F60B16E}"/>
+                <a16:creationId xmlns:a16="http://schemas.microsoft.com/office/drawing/2014/main" id="{B1D2B8FE-C185-4EBD-B65C-626839C76AB5}"/>
               </a:ext>
             </a:extLst>
           </p:cNvPr>
@@ -19203,7 +19203,7 @@
           <p:cNvPr id="51" name="">
             <a:extLst xmlns:a="http://schemas.openxmlformats.org/drawingml/2006/main">
               <a:ext uri="{FF2B5EF4-FFF2-40B4-BE49-F238E27FC236}">
-                <a16:creationId xmlns:a16="http://schemas.microsoft.com/office/drawing/2014/main" id="{61008C5D-8195-47B0-9175-0F5AA885A0D7}"/>
+                <a16:creationId xmlns:a16="http://schemas.microsoft.com/office/drawing/2014/main" id="{81FECEFC-7ADD-411F-A837-B126A6B16A19}"/>
               </a:ext>
             </a:extLst>
           </p:cNvPr>
@@ -19260,7 +19260,7 @@
           <p:cNvPr id="52" name="">
             <a:extLst xmlns:a="http://schemas.openxmlformats.org/drawingml/2006/main">
               <a:ext uri="{FF2B5EF4-FFF2-40B4-BE49-F238E27FC236}">
-                <a16:creationId xmlns:a16="http://schemas.microsoft.com/office/drawing/2014/main" id="{40495763-BAE1-4A18-8B1B-69DD0954E9E2}"/>
+                <a16:creationId xmlns:a16="http://schemas.microsoft.com/office/drawing/2014/main" id="{2841D30B-1BB1-48DA-9253-1FE641B4FDB6}"/>
               </a:ext>
             </a:extLst>
           </p:cNvPr>
@@ -19317,7 +19317,7 @@
           <p:cNvPr id="53" name="">
             <a:extLst xmlns:a="http://schemas.openxmlformats.org/drawingml/2006/main">
               <a:ext uri="{FF2B5EF4-FFF2-40B4-BE49-F238E27FC236}">
-                <a16:creationId xmlns:a16="http://schemas.microsoft.com/office/drawing/2014/main" id="{5EB02011-362D-479E-B566-DFEC4A22DC34}"/>
+                <a16:creationId xmlns:a16="http://schemas.microsoft.com/office/drawing/2014/main" id="{65A69212-2345-42F8-A628-0421B0D28D0C}"/>
               </a:ext>
             </a:extLst>
           </p:cNvPr>
@@ -19397,7 +19397,7 @@
           <p:cNvPr id="54" name="">
             <a:extLst xmlns:a="http://schemas.openxmlformats.org/drawingml/2006/main">
               <a:ext uri="{FF2B5EF4-FFF2-40B4-BE49-F238E27FC236}">
-                <a16:creationId xmlns:a16="http://schemas.microsoft.com/office/drawing/2014/main" id="{299607FE-AD5C-4A2F-925E-D69336BADCA1}"/>
+                <a16:creationId xmlns:a16="http://schemas.microsoft.com/office/drawing/2014/main" id="{78DC7368-2C2C-473E-884C-463CC688FEF8}"/>
               </a:ext>
             </a:extLst>
           </p:cNvPr>
@@ -19430,7 +19430,7 @@
           <p:cNvPr id="55" name="">
             <a:extLst xmlns:a="http://schemas.openxmlformats.org/drawingml/2006/main">
               <a:ext uri="{FF2B5EF4-FFF2-40B4-BE49-F238E27FC236}">
-                <a16:creationId xmlns:a16="http://schemas.microsoft.com/office/drawing/2014/main" id="{5B48B001-1048-4BDA-B2C3-15BF9B7A55E3}"/>
+                <a16:creationId xmlns:a16="http://schemas.microsoft.com/office/drawing/2014/main" id="{8E2F2439-7329-4E2F-ABB3-B4961813D50F}"/>
               </a:ext>
             </a:extLst>
           </p:cNvPr>
@@ -19487,7 +19487,7 @@
           <p:cNvPr id="56" name="">
             <a:extLst xmlns:a="http://schemas.openxmlformats.org/drawingml/2006/main">
               <a:ext uri="{FF2B5EF4-FFF2-40B4-BE49-F238E27FC236}">
-                <a16:creationId xmlns:a16="http://schemas.microsoft.com/office/drawing/2014/main" id="{8FD6F51E-A5E4-4133-BACE-F36D65E2B100}"/>
+                <a16:creationId xmlns:a16="http://schemas.microsoft.com/office/drawing/2014/main" id="{47E1E873-3269-4290-B85C-64226A0F0021}"/>
               </a:ext>
             </a:extLst>
           </p:cNvPr>
@@ -19520,7 +19520,7 @@
           <p:cNvPr id="57" name="">
             <a:extLst xmlns:a="http://schemas.openxmlformats.org/drawingml/2006/main">
               <a:ext uri="{FF2B5EF4-FFF2-40B4-BE49-F238E27FC236}">
-                <a16:creationId xmlns:a16="http://schemas.microsoft.com/office/drawing/2014/main" id="{99195CED-F542-4EC6-BD0E-98BB1695A402}"/>
+                <a16:creationId xmlns:a16="http://schemas.microsoft.com/office/drawing/2014/main" id="{8DA19831-2DEC-4B1B-98F5-ED8AF4478F59}"/>
               </a:ext>
             </a:extLst>
           </p:cNvPr>
@@ -19577,7 +19577,7 @@
           <p:cNvPr id="58" name="">
             <a:extLst xmlns:a="http://schemas.openxmlformats.org/drawingml/2006/main">
               <a:ext uri="{FF2B5EF4-FFF2-40B4-BE49-F238E27FC236}">
-                <a16:creationId xmlns:a16="http://schemas.microsoft.com/office/drawing/2014/main" id="{3A4279D1-2C3F-4AA0-BA91-E6D8F99C3A36}"/>
+                <a16:creationId xmlns:a16="http://schemas.microsoft.com/office/drawing/2014/main" id="{C4C6EA9B-297C-44BA-89CA-4680CE05C268}"/>
               </a:ext>
             </a:extLst>
           </p:cNvPr>
@@ -19610,7 +19610,7 @@
           <p:cNvPr id="59" name="">
             <a:extLst xmlns:a="http://schemas.openxmlformats.org/drawingml/2006/main">
               <a:ext uri="{FF2B5EF4-FFF2-40B4-BE49-F238E27FC236}">
-                <a16:creationId xmlns:a16="http://schemas.microsoft.com/office/drawing/2014/main" id="{FD528255-11E8-4A66-A460-7BDA4DEA1955}"/>
+                <a16:creationId xmlns:a16="http://schemas.microsoft.com/office/drawing/2014/main" id="{87D2DE9D-B41B-428B-97F7-78CFD7A53842}"/>
               </a:ext>
             </a:extLst>
           </p:cNvPr>
@@ -19667,7 +19667,7 @@
           <p:cNvPr id="60" name="">
             <a:extLst xmlns:a="http://schemas.openxmlformats.org/drawingml/2006/main">
               <a:ext uri="{FF2B5EF4-FFF2-40B4-BE49-F238E27FC236}">
-                <a16:creationId xmlns:a16="http://schemas.microsoft.com/office/drawing/2014/main" id="{EACE4950-750B-4534-BF2A-613592D1423E}"/>
+                <a16:creationId xmlns:a16="http://schemas.microsoft.com/office/drawing/2014/main" id="{D4833AFA-DDD2-458D-9C98-073979725D05}"/>
               </a:ext>
             </a:extLst>
           </p:cNvPr>
@@ -19698,7 +19698,7 @@
           <p:cNvPr id="61" name="">
             <a:extLst xmlns:a="http://schemas.openxmlformats.org/drawingml/2006/main">
               <a:ext uri="{FF2B5EF4-FFF2-40B4-BE49-F238E27FC236}">
-                <a16:creationId xmlns:a16="http://schemas.microsoft.com/office/drawing/2014/main" id="{E4FFA6C9-63FC-4C0A-95D7-A07C3563CC98}"/>
+                <a16:creationId xmlns:a16="http://schemas.microsoft.com/office/drawing/2014/main" id="{C3A1DD67-43A1-41A4-97A6-65CEA7237EA3}"/>
               </a:ext>
             </a:extLst>
           </p:cNvPr>
@@ -19729,7 +19729,7 @@
           <p:cNvPr id="62" name="">
             <a:extLst xmlns:a="http://schemas.openxmlformats.org/drawingml/2006/main">
               <a:ext uri="{FF2B5EF4-FFF2-40B4-BE49-F238E27FC236}">
-                <a16:creationId xmlns:a16="http://schemas.microsoft.com/office/drawing/2014/main" id="{3CA735E8-88E6-443E-B479-902EAE5F74EF}"/>
+                <a16:creationId xmlns:a16="http://schemas.microsoft.com/office/drawing/2014/main" id="{55EEC234-F52D-4D97-A2C2-7877CA62BD31}"/>
               </a:ext>
             </a:extLst>
           </p:cNvPr>
@@ -19786,7 +19786,7 @@
           <p:cNvPr id="63" name="">
             <a:extLst xmlns:a="http://schemas.openxmlformats.org/drawingml/2006/main">
               <a:ext uri="{FF2B5EF4-FFF2-40B4-BE49-F238E27FC236}">
-                <a16:creationId xmlns:a16="http://schemas.microsoft.com/office/drawing/2014/main" id="{2260C6C9-A1DB-4542-B072-4578C811C446}"/>
+                <a16:creationId xmlns:a16="http://schemas.microsoft.com/office/drawing/2014/main" id="{6B3625C8-030D-4C74-8479-00CAC1186B45}"/>
               </a:ext>
             </a:extLst>
           </p:cNvPr>
@@ -19843,7 +19843,7 @@
           <p:cNvPr id="64" name="">
             <a:extLst xmlns:a="http://schemas.openxmlformats.org/drawingml/2006/main">
               <a:ext uri="{FF2B5EF4-FFF2-40B4-BE49-F238E27FC236}">
-                <a16:creationId xmlns:a16="http://schemas.microsoft.com/office/drawing/2014/main" id="{1375D999-F66F-48EB-AB6A-9DED30B6FCF1}"/>
+                <a16:creationId xmlns:a16="http://schemas.microsoft.com/office/drawing/2014/main" id="{E242F1D9-5A15-4867-8E73-5762F5BC01F9}"/>
               </a:ext>
             </a:extLst>
           </p:cNvPr>
@@ -19874,7 +19874,7 @@
           <p:cNvPr id="65" name="">
             <a:extLst xmlns:a="http://schemas.openxmlformats.org/drawingml/2006/main">
               <a:ext uri="{FF2B5EF4-FFF2-40B4-BE49-F238E27FC236}">
-                <a16:creationId xmlns:a16="http://schemas.microsoft.com/office/drawing/2014/main" id="{3601FCB2-4FFF-4D06-913D-35399C3EBFEC}"/>
+                <a16:creationId xmlns:a16="http://schemas.microsoft.com/office/drawing/2014/main" id="{8ABECD70-2D6F-43C2-9B47-55E90DB9EE6E}"/>
               </a:ext>
             </a:extLst>
           </p:cNvPr>
@@ -19931,7 +19931,7 @@
           <p:cNvPr id="66" name="">
             <a:extLst xmlns:a="http://schemas.openxmlformats.org/drawingml/2006/main">
               <a:ext uri="{FF2B5EF4-FFF2-40B4-BE49-F238E27FC236}">
-                <a16:creationId xmlns:a16="http://schemas.microsoft.com/office/drawing/2014/main" id="{B891E0CF-C8F5-4919-B615-9D2D084CEFA4}"/>
+                <a16:creationId xmlns:a16="http://schemas.microsoft.com/office/drawing/2014/main" id="{FBD64121-E19E-4D58-96EE-8DEB0505361F}"/>
               </a:ext>
             </a:extLst>
           </p:cNvPr>
@@ -19988,7 +19988,7 @@
           <p:cNvPr id="67" name="">
             <a:extLst xmlns:a="http://schemas.openxmlformats.org/drawingml/2006/main">
               <a:ext uri="{FF2B5EF4-FFF2-40B4-BE49-F238E27FC236}">
-                <a16:creationId xmlns:a16="http://schemas.microsoft.com/office/drawing/2014/main" id="{BA894D7F-BCAA-410D-BDB1-BC32CB56A1B2}"/>
+                <a16:creationId xmlns:a16="http://schemas.microsoft.com/office/drawing/2014/main" id="{DEC6A5C7-9F8C-4A89-BC56-EFAB2452465F}"/>
               </a:ext>
             </a:extLst>
           </p:cNvPr>
@@ -20043,7 +20043,7 @@
     </p:spTree>
     <p:extLst>
       <p:ext uri="{BB962C8B-B14F-4D97-AF65-F5344CB8AC3E}">
-        <p14:creationId xmlns:p14="http://schemas.microsoft.com/office/powerpoint/2010/main" val="911927030"/>
+        <p14:creationId xmlns:p14="http://schemas.microsoft.com/office/powerpoint/2010/main" val="430036407"/>
       </p:ext>
     </p:extLst>
   </p:cSld>
@@ -20074,7 +20074,7 @@
           <p:cNvPr id="40" name="">
             <a:extLst xmlns:a="http://schemas.openxmlformats.org/drawingml/2006/main">
               <a:ext uri="{FF2B5EF4-FFF2-40B4-BE49-F238E27FC236}">
-                <a16:creationId xmlns:a16="http://schemas.microsoft.com/office/drawing/2014/main" id="{06E837D1-4DD1-48FC-9289-FD7B22F0B112}"/>
+                <a16:creationId xmlns:a16="http://schemas.microsoft.com/office/drawing/2014/main" id="{5D2DFD1B-23D8-4DA0-862E-105B98048279}"/>
               </a:ext>
             </a:extLst>
           </p:cNvPr>
@@ -20131,7 +20131,7 @@
           <p:cNvPr id="2" name="">
             <a:extLst xmlns:a="http://schemas.openxmlformats.org/drawingml/2006/main">
               <a:ext uri="{FF2B5EF4-FFF2-40B4-BE49-F238E27FC236}">
-                <a16:creationId xmlns:a16="http://schemas.microsoft.com/office/drawing/2014/main" id="{B73C072F-EFF3-4DE1-A9A8-1911D3ED1498}"/>
+                <a16:creationId xmlns:a16="http://schemas.microsoft.com/office/drawing/2014/main" id="{D0F6FC83-1EF3-4074-8543-48CDA9E876D2}"/>
               </a:ext>
             </a:extLst>
           </p:cNvPr>
@@ -20162,7 +20162,7 @@
           <p:cNvPr id="3" name="">
             <a:extLst xmlns:a="http://schemas.openxmlformats.org/drawingml/2006/main">
               <a:ext uri="{FF2B5EF4-FFF2-40B4-BE49-F238E27FC236}">
-                <a16:creationId xmlns:a16="http://schemas.microsoft.com/office/drawing/2014/main" id="{F2596C2C-CF0B-4364-9AE2-BFC9F2143169}"/>
+                <a16:creationId xmlns:a16="http://schemas.microsoft.com/office/drawing/2014/main" id="{BA28DB65-FBEE-47DE-81CA-9E3D035A6B15}"/>
               </a:ext>
             </a:extLst>
           </p:cNvPr>
@@ -20219,7 +20219,7 @@
           <p:cNvPr id="4" name="">
             <a:extLst xmlns:a="http://schemas.openxmlformats.org/drawingml/2006/main">
               <a:ext uri="{FF2B5EF4-FFF2-40B4-BE49-F238E27FC236}">
-                <a16:creationId xmlns:a16="http://schemas.microsoft.com/office/drawing/2014/main" id="{EEEAFD35-F2FD-4B62-8B71-9E362C3E337A}"/>
+                <a16:creationId xmlns:a16="http://schemas.microsoft.com/office/drawing/2014/main" id="{03DC1413-D0EF-4AAE-A7BE-65D5A8795C07}"/>
               </a:ext>
             </a:extLst>
           </p:cNvPr>
@@ -20276,7 +20276,7 @@
           <p:cNvPr id="5" name="">
             <a:extLst xmlns:a="http://schemas.openxmlformats.org/drawingml/2006/main">
               <a:ext uri="{FF2B5EF4-FFF2-40B4-BE49-F238E27FC236}">
-                <a16:creationId xmlns:a16="http://schemas.microsoft.com/office/drawing/2014/main" id="{ADAB9E40-259A-4665-A806-80E06F42D942}"/>
+                <a16:creationId xmlns:a16="http://schemas.microsoft.com/office/drawing/2014/main" id="{3141AC38-9BFE-4BAE-ACE7-F4B3BC522F2D}"/>
               </a:ext>
             </a:extLst>
           </p:cNvPr>
@@ -20307,7 +20307,7 @@
           <p:cNvPr id="6" name="">
             <a:extLst xmlns:a="http://schemas.openxmlformats.org/drawingml/2006/main">
               <a:ext uri="{FF2B5EF4-FFF2-40B4-BE49-F238E27FC236}">
-                <a16:creationId xmlns:a16="http://schemas.microsoft.com/office/drawing/2014/main" id="{A8359180-69AB-4F53-816F-2C81F3CC3901}"/>
+                <a16:creationId xmlns:a16="http://schemas.microsoft.com/office/drawing/2014/main" id="{CD120600-9349-4891-88D6-115C988A9D4D}"/>
               </a:ext>
             </a:extLst>
           </p:cNvPr>
@@ -20364,7 +20364,7 @@
           <p:cNvPr id="7" name="">
             <a:extLst xmlns:a="http://schemas.openxmlformats.org/drawingml/2006/main">
               <a:ext uri="{FF2B5EF4-FFF2-40B4-BE49-F238E27FC236}">
-                <a16:creationId xmlns:a16="http://schemas.microsoft.com/office/drawing/2014/main" id="{3039C84D-F3FA-488D-AEF8-913C97ED2F4F}"/>
+                <a16:creationId xmlns:a16="http://schemas.microsoft.com/office/drawing/2014/main" id="{4FDAF2B5-B626-4D44-A465-829C57C8E053}"/>
               </a:ext>
             </a:extLst>
           </p:cNvPr>
@@ -20421,7 +20421,7 @@
           <p:cNvPr id="8" name="">
             <a:extLst xmlns:a="http://schemas.openxmlformats.org/drawingml/2006/main">
               <a:ext uri="{FF2B5EF4-FFF2-40B4-BE49-F238E27FC236}">
-                <a16:creationId xmlns:a16="http://schemas.microsoft.com/office/drawing/2014/main" id="{19C3AD07-1500-435C-8741-66C5E13A1D04}"/>
+                <a16:creationId xmlns:a16="http://schemas.microsoft.com/office/drawing/2014/main" id="{D782CD67-8636-47A0-9A0B-FA8F4D622EA2}"/>
               </a:ext>
             </a:extLst>
           </p:cNvPr>
@@ -20478,7 +20478,7 @@
           <p:cNvPr id="9" name="">
             <a:extLst xmlns:a="http://schemas.openxmlformats.org/drawingml/2006/main">
               <a:ext uri="{FF2B5EF4-FFF2-40B4-BE49-F238E27FC236}">
-                <a16:creationId xmlns:a16="http://schemas.microsoft.com/office/drawing/2014/main" id="{4EC13811-89D7-4F49-9BDB-2F39CD14DCD3}"/>
+                <a16:creationId xmlns:a16="http://schemas.microsoft.com/office/drawing/2014/main" id="{AE9038B3-E8AD-422F-A424-4F2FDE85F1D9}"/>
               </a:ext>
             </a:extLst>
           </p:cNvPr>
@@ -20535,7 +20535,7 @@
           <p:cNvPr id="10" name="">
             <a:extLst xmlns:a="http://schemas.openxmlformats.org/drawingml/2006/main">
               <a:ext uri="{FF2B5EF4-FFF2-40B4-BE49-F238E27FC236}">
-                <a16:creationId xmlns:a16="http://schemas.microsoft.com/office/drawing/2014/main" id="{1C0AD475-B45B-497E-851D-4B52C5F850BF}"/>
+                <a16:creationId xmlns:a16="http://schemas.microsoft.com/office/drawing/2014/main" id="{63CCFAB3-3D48-4FED-AE3A-DADEDFD00F35}"/>
               </a:ext>
             </a:extLst>
           </p:cNvPr>
@@ -20592,7 +20592,7 @@
           <p:cNvPr id="11" name="">
             <a:extLst xmlns:a="http://schemas.openxmlformats.org/drawingml/2006/main">
               <a:ext uri="{FF2B5EF4-FFF2-40B4-BE49-F238E27FC236}">
-                <a16:creationId xmlns:a16="http://schemas.microsoft.com/office/drawing/2014/main" id="{DDC528E9-C1FB-4A6A-9659-3D70C1448D09}"/>
+                <a16:creationId xmlns:a16="http://schemas.microsoft.com/office/drawing/2014/main" id="{98690DCF-D994-4818-B02E-B8FE5AC597A1}"/>
               </a:ext>
             </a:extLst>
           </p:cNvPr>
@@ -20649,7 +20649,7 @@
           <p:cNvPr id="12" name="">
             <a:extLst xmlns:a="http://schemas.openxmlformats.org/drawingml/2006/main">
               <a:ext uri="{FF2B5EF4-FFF2-40B4-BE49-F238E27FC236}">
-                <a16:creationId xmlns:a16="http://schemas.microsoft.com/office/drawing/2014/main" id="{BC023E71-4F6E-4F85-B7D5-E470725DD9D0}"/>
+                <a16:creationId xmlns:a16="http://schemas.microsoft.com/office/drawing/2014/main" id="{EAF0B9F8-D02C-4805-AA41-094D0FC54DCB}"/>
               </a:ext>
             </a:extLst>
           </p:cNvPr>
@@ -20706,7 +20706,7 @@
           <p:cNvPr id="13" name="">
             <a:extLst xmlns:a="http://schemas.openxmlformats.org/drawingml/2006/main">
               <a:ext uri="{FF2B5EF4-FFF2-40B4-BE49-F238E27FC236}">
-                <a16:creationId xmlns:a16="http://schemas.microsoft.com/office/drawing/2014/main" id="{B3C36073-22F4-4108-B2A1-3129BC0B437A}"/>
+                <a16:creationId xmlns:a16="http://schemas.microsoft.com/office/drawing/2014/main" id="{44A6E0D6-DAAC-467E-9224-381E67E524B6}"/>
               </a:ext>
             </a:extLst>
           </p:cNvPr>
@@ -20763,7 +20763,7 @@
           <p:cNvPr id="14" name="">
             <a:extLst xmlns:a="http://schemas.openxmlformats.org/drawingml/2006/main">
               <a:ext uri="{FF2B5EF4-FFF2-40B4-BE49-F238E27FC236}">
-                <a16:creationId xmlns:a16="http://schemas.microsoft.com/office/drawing/2014/main" id="{1717FC28-AAEB-4383-A174-65F1E8BA0FB9}"/>
+                <a16:creationId xmlns:a16="http://schemas.microsoft.com/office/drawing/2014/main" id="{68C17D00-80DF-49DE-91C0-25129D5FDBCE}"/>
               </a:ext>
             </a:extLst>
           </p:cNvPr>
@@ -20843,7 +20843,7 @@
           <p:cNvPr id="15" name="">
             <a:extLst xmlns:a="http://schemas.openxmlformats.org/drawingml/2006/main">
               <a:ext uri="{FF2B5EF4-FFF2-40B4-BE49-F238E27FC236}">
-                <a16:creationId xmlns:a16="http://schemas.microsoft.com/office/drawing/2014/main" id="{A67D39BB-1983-464A-A151-24E66AEE8218}"/>
+                <a16:creationId xmlns:a16="http://schemas.microsoft.com/office/drawing/2014/main" id="{87A936E8-FCDA-4823-8327-15AC6C5ACE68}"/>
               </a:ext>
             </a:extLst>
           </p:cNvPr>
@@ -20900,7 +20900,7 @@
           <p:cNvPr id="16" name="">
             <a:extLst xmlns:a="http://schemas.openxmlformats.org/drawingml/2006/main">
               <a:ext uri="{FF2B5EF4-FFF2-40B4-BE49-F238E27FC236}">
-                <a16:creationId xmlns:a16="http://schemas.microsoft.com/office/drawing/2014/main" id="{E8BB00CB-3D50-44B3-8803-3D9CDAB5AD3B}"/>
+                <a16:creationId xmlns:a16="http://schemas.microsoft.com/office/drawing/2014/main" id="{2C22ED37-2FC7-49F9-9126-9E7649B9F20B}"/>
               </a:ext>
             </a:extLst>
           </p:cNvPr>
@@ -20957,7 +20957,7 @@
           <p:cNvPr id="17" name="">
             <a:extLst xmlns:a="http://schemas.openxmlformats.org/drawingml/2006/main">
               <a:ext uri="{FF2B5EF4-FFF2-40B4-BE49-F238E27FC236}">
-                <a16:creationId xmlns:a16="http://schemas.microsoft.com/office/drawing/2014/main" id="{E2798D11-CED0-466D-9A93-18BAFFC5B81B}"/>
+                <a16:creationId xmlns:a16="http://schemas.microsoft.com/office/drawing/2014/main" id="{2C4E441D-7E3C-446E-B705-5199C3C3C00A}"/>
               </a:ext>
             </a:extLst>
           </p:cNvPr>
@@ -21014,7 +21014,7 @@
           <p:cNvPr id="18" name="">
             <a:extLst xmlns:a="http://schemas.openxmlformats.org/drawingml/2006/main">
               <a:ext uri="{FF2B5EF4-FFF2-40B4-BE49-F238E27FC236}">
-                <a16:creationId xmlns:a16="http://schemas.microsoft.com/office/drawing/2014/main" id="{EA7F2D8C-BF8B-46E4-95FD-5A39FC2B6024}"/>
+                <a16:creationId xmlns:a16="http://schemas.microsoft.com/office/drawing/2014/main" id="{C08C848D-4A0A-4B2C-B6AA-9CB910D2300D}"/>
               </a:ext>
             </a:extLst>
           </p:cNvPr>
@@ -21071,7 +21071,7 @@
           <p:cNvPr id="19" name="">
             <a:extLst xmlns:a="http://schemas.openxmlformats.org/drawingml/2006/main">
               <a:ext uri="{FF2B5EF4-FFF2-40B4-BE49-F238E27FC236}">
-                <a16:creationId xmlns:a16="http://schemas.microsoft.com/office/drawing/2014/main" id="{2FE93D71-92C8-4547-B1C8-3A5B7D363DE2}"/>
+                <a16:creationId xmlns:a16="http://schemas.microsoft.com/office/drawing/2014/main" id="{B7901632-9DA3-4C35-8198-8528F5898739}"/>
               </a:ext>
             </a:extLst>
           </p:cNvPr>
@@ -21128,7 +21128,7 @@
           <p:cNvPr id="20" name="">
             <a:extLst xmlns:a="http://schemas.openxmlformats.org/drawingml/2006/main">
               <a:ext uri="{FF2B5EF4-FFF2-40B4-BE49-F238E27FC236}">
-                <a16:creationId xmlns:a16="http://schemas.microsoft.com/office/drawing/2014/main" id="{0B846724-348A-4767-A9E7-378328F5B566}"/>
+                <a16:creationId xmlns:a16="http://schemas.microsoft.com/office/drawing/2014/main" id="{60AB2631-07DC-4E82-AF0F-183E586791D6}"/>
               </a:ext>
             </a:extLst>
           </p:cNvPr>
@@ -21208,7 +21208,7 @@
           <p:cNvPr id="21" name="">
             <a:extLst xmlns:a="http://schemas.openxmlformats.org/drawingml/2006/main">
               <a:ext uri="{FF2B5EF4-FFF2-40B4-BE49-F238E27FC236}">
-                <a16:creationId xmlns:a16="http://schemas.microsoft.com/office/drawing/2014/main" id="{5F85E6B5-82A2-4B21-8C41-1370B34543AD}"/>
+                <a16:creationId xmlns:a16="http://schemas.microsoft.com/office/drawing/2014/main" id="{0D46F468-96DF-4244-8BB5-9CAF30D88280}"/>
               </a:ext>
             </a:extLst>
           </p:cNvPr>
@@ -21265,7 +21265,7 @@
           <p:cNvPr id="22" name="">
             <a:extLst xmlns:a="http://schemas.openxmlformats.org/drawingml/2006/main">
               <a:ext uri="{FF2B5EF4-FFF2-40B4-BE49-F238E27FC236}">
-                <a16:creationId xmlns:a16="http://schemas.microsoft.com/office/drawing/2014/main" id="{2257CE7F-CA4E-46FC-A48E-0ACDC96ECF2A}"/>
+                <a16:creationId xmlns:a16="http://schemas.microsoft.com/office/drawing/2014/main" id="{15F276B9-0363-46F5-806A-FB51ADB20B34}"/>
               </a:ext>
             </a:extLst>
           </p:cNvPr>
@@ -21312,7 +21312,7 @@
                 <a:ea typeface="Arial"/>
                 <a:cs typeface="Arial"/>
               </a:rPr>
-              <a:t>SELF-REPORTED: &gt;80% productivity ↑</a:t>
+              <a:t>Respondents reporting improvement:</a:t>
             </a:r>
           </a:p>
           <a:p xmlns:a="http://schemas.openxmlformats.org/drawingml/2006/main">
@@ -21335,7 +21335,7 @@
                 <a:ea typeface="Arial"/>
                 <a:cs typeface="Arial"/>
               </a:rPr>
-              <a:t>59% code quality ↑</a:t>
+              <a:t>Productivity &gt;80% · Code quality 59%</a:t>
             </a:r>
           </a:p>
         </p:txBody>
@@ -21345,7 +21345,7 @@
           <p:cNvPr id="23" name="">
             <a:extLst xmlns:a="http://schemas.openxmlformats.org/drawingml/2006/main">
               <a:ext uri="{FF2B5EF4-FFF2-40B4-BE49-F238E27FC236}">
-                <a16:creationId xmlns:a16="http://schemas.microsoft.com/office/drawing/2014/main" id="{B6CB929B-FB86-44D9-A3C3-510E41377D4A}"/>
+                <a16:creationId xmlns:a16="http://schemas.microsoft.com/office/drawing/2014/main" id="{0182A840-F863-4CA4-82CA-1FBC4EDFC66A}"/>
               </a:ext>
             </a:extLst>
           </p:cNvPr>
@@ -21402,7 +21402,7 @@
           <p:cNvPr id="24" name="">
             <a:extLst xmlns:a="http://schemas.openxmlformats.org/drawingml/2006/main">
               <a:ext uri="{FF2B5EF4-FFF2-40B4-BE49-F238E27FC236}">
-                <a16:creationId xmlns:a16="http://schemas.microsoft.com/office/drawing/2014/main" id="{920B14BF-53D9-4D4C-ABE6-A2965892298B}"/>
+                <a16:creationId xmlns:a16="http://schemas.microsoft.com/office/drawing/2014/main" id="{E903ECBC-6848-4A93-8A3E-EE7F5F7E2C1E}"/>
               </a:ext>
             </a:extLst>
           </p:cNvPr>
@@ -21459,7 +21459,7 @@
           <p:cNvPr id="25" name="">
             <a:extLst xmlns:a="http://schemas.openxmlformats.org/drawingml/2006/main">
               <a:ext uri="{FF2B5EF4-FFF2-40B4-BE49-F238E27FC236}">
-                <a16:creationId xmlns:a16="http://schemas.microsoft.com/office/drawing/2014/main" id="{BC3B6CE7-4B7B-4C96-A8EE-E450AA015BA9}"/>
+                <a16:creationId xmlns:a16="http://schemas.microsoft.com/office/drawing/2014/main" id="{0665B7C4-B331-4860-8C33-0C12540CD25E}"/>
               </a:ext>
             </a:extLst>
           </p:cNvPr>
@@ -21516,7 +21516,7 @@
           <p:cNvPr id="26" name="">
             <a:extLst xmlns:a="http://schemas.openxmlformats.org/drawingml/2006/main">
               <a:ext uri="{FF2B5EF4-FFF2-40B4-BE49-F238E27FC236}">
-                <a16:creationId xmlns:a16="http://schemas.microsoft.com/office/drawing/2014/main" id="{592C2A3F-5568-4469-BBA5-58A90A362563}"/>
+                <a16:creationId xmlns:a16="http://schemas.microsoft.com/office/drawing/2014/main" id="{806CD37B-5529-46A6-8EE6-0E65C7A48BE9}"/>
               </a:ext>
             </a:extLst>
           </p:cNvPr>
@@ -21547,7 +21547,7 @@
           <p:cNvPr id="27" name="">
             <a:extLst xmlns:a="http://schemas.openxmlformats.org/drawingml/2006/main">
               <a:ext uri="{FF2B5EF4-FFF2-40B4-BE49-F238E27FC236}">
-                <a16:creationId xmlns:a16="http://schemas.microsoft.com/office/drawing/2014/main" id="{6E610400-EDAE-46F2-9BBF-003B31C5E41B}"/>
+                <a16:creationId xmlns:a16="http://schemas.microsoft.com/office/drawing/2014/main" id="{BFF90E6A-EC93-422C-8545-F841E489BC81}"/>
               </a:ext>
             </a:extLst>
           </p:cNvPr>
@@ -21867,7 +21867,7 @@
           <p:cNvPr id="29" name="">
             <a:extLst xmlns:a="http://schemas.openxmlformats.org/drawingml/2006/main">
               <a:ext uri="{FF2B5EF4-FFF2-40B4-BE49-F238E27FC236}">
-                <a16:creationId xmlns:a16="http://schemas.microsoft.com/office/drawing/2014/main" id="{86697306-71D1-4A42-A0E9-2F1779837839}"/>
+                <a16:creationId xmlns:a16="http://schemas.microsoft.com/office/drawing/2014/main" id="{F5EE1500-4B5C-47EF-9403-A10EB3027CEE}"/>
               </a:ext>
             </a:extLst>
           </p:cNvPr>
@@ -21924,7 +21924,7 @@
           <p:cNvPr id="30" name="">
             <a:extLst xmlns:a="http://schemas.openxmlformats.org/drawingml/2006/main">
               <a:ext uri="{FF2B5EF4-FFF2-40B4-BE49-F238E27FC236}">
-                <a16:creationId xmlns:a16="http://schemas.microsoft.com/office/drawing/2014/main" id="{222FA0AB-C676-4D8D-B4FC-3BC5620D69F6}"/>
+                <a16:creationId xmlns:a16="http://schemas.microsoft.com/office/drawing/2014/main" id="{9264C81D-09AD-41EB-8F63-028A526DCC76}"/>
               </a:ext>
             </a:extLst>
           </p:cNvPr>
@@ -21981,7 +21981,7 @@
           <p:cNvPr id="31" name="">
             <a:extLst xmlns:a="http://schemas.openxmlformats.org/drawingml/2006/main">
               <a:ext uri="{FF2B5EF4-FFF2-40B4-BE49-F238E27FC236}">
-                <a16:creationId xmlns:a16="http://schemas.microsoft.com/office/drawing/2014/main" id="{5AC438C3-763B-4B3F-9FC4-5D942906D70D}"/>
+                <a16:creationId xmlns:a16="http://schemas.microsoft.com/office/drawing/2014/main" id="{E09859F7-8260-4235-9991-22F870BDFBFC}"/>
               </a:ext>
             </a:extLst>
           </p:cNvPr>
@@ -22012,7 +22012,7 @@
           <p:cNvPr id="32" name="">
             <a:extLst xmlns:a="http://schemas.openxmlformats.org/drawingml/2006/main">
               <a:ext uri="{FF2B5EF4-FFF2-40B4-BE49-F238E27FC236}">
-                <a16:creationId xmlns:a16="http://schemas.microsoft.com/office/drawing/2014/main" id="{2BB6966E-2DE8-4D00-BF2F-A5CA5C7F5DE0}"/>
+                <a16:creationId xmlns:a16="http://schemas.microsoft.com/office/drawing/2014/main" id="{BCE50901-83C2-4EBD-8494-C75681CFBED9}"/>
               </a:ext>
             </a:extLst>
           </p:cNvPr>
@@ -22069,7 +22069,7 @@
           <p:cNvPr id="33" name="">
             <a:extLst xmlns:a="http://schemas.openxmlformats.org/drawingml/2006/main">
               <a:ext uri="{FF2B5EF4-FFF2-40B4-BE49-F238E27FC236}">
-                <a16:creationId xmlns:a16="http://schemas.microsoft.com/office/drawing/2014/main" id="{C76DB5E2-9928-414A-9D42-AF120BF0F8D9}"/>
+                <a16:creationId xmlns:a16="http://schemas.microsoft.com/office/drawing/2014/main" id="{FD80D0FA-7B21-437C-937C-565229B22D0C}"/>
               </a:ext>
             </a:extLst>
           </p:cNvPr>
@@ -22126,7 +22126,7 @@
           <p:cNvPr id="34" name="">
             <a:extLst xmlns:a="http://schemas.openxmlformats.org/drawingml/2006/main">
               <a:ext uri="{FF2B5EF4-FFF2-40B4-BE49-F238E27FC236}">
-                <a16:creationId xmlns:a16="http://schemas.microsoft.com/office/drawing/2014/main" id="{D4C7E9A2-82E0-4F3E-AE52-55E479E59810}"/>
+                <a16:creationId xmlns:a16="http://schemas.microsoft.com/office/drawing/2014/main" id="{3F967FAA-FEF0-4A45-B788-99A409A98171}"/>
               </a:ext>
             </a:extLst>
           </p:cNvPr>
@@ -22183,7 +22183,7 @@
           <p:cNvPr id="35" name="">
             <a:extLst xmlns:a="http://schemas.openxmlformats.org/drawingml/2006/main">
               <a:ext uri="{FF2B5EF4-FFF2-40B4-BE49-F238E27FC236}">
-                <a16:creationId xmlns:a16="http://schemas.microsoft.com/office/drawing/2014/main" id="{39853363-4953-43D8-BFD1-8312F1AEBCD7}"/>
+                <a16:creationId xmlns:a16="http://schemas.microsoft.com/office/drawing/2014/main" id="{AFCEA862-9C53-4900-A1B9-7FE9748E37BD}"/>
               </a:ext>
             </a:extLst>
           </p:cNvPr>
@@ -22240,7 +22240,7 @@
           <p:cNvPr id="36" name="">
             <a:extLst xmlns:a="http://schemas.openxmlformats.org/drawingml/2006/main">
               <a:ext uri="{FF2B5EF4-FFF2-40B4-BE49-F238E27FC236}">
-                <a16:creationId xmlns:a16="http://schemas.microsoft.com/office/drawing/2014/main" id="{F420C08B-DC25-436B-97FE-633C899CB3D0}"/>
+                <a16:creationId xmlns:a16="http://schemas.microsoft.com/office/drawing/2014/main" id="{E3FF626B-6639-4197-BF52-5594AFDC817B}"/>
               </a:ext>
             </a:extLst>
           </p:cNvPr>
@@ -22297,7 +22297,7 @@
           <p:cNvPr id="37" name="">
             <a:extLst xmlns:a="http://schemas.openxmlformats.org/drawingml/2006/main">
               <a:ext uri="{FF2B5EF4-FFF2-40B4-BE49-F238E27FC236}">
-                <a16:creationId xmlns:a16="http://schemas.microsoft.com/office/drawing/2014/main" id="{73381187-A567-4860-BBCE-4EF16025840B}"/>
+                <a16:creationId xmlns:a16="http://schemas.microsoft.com/office/drawing/2014/main" id="{E84F1321-0644-4FB3-A496-E028A6862104}"/>
               </a:ext>
             </a:extLst>
           </p:cNvPr>
@@ -22354,7 +22354,7 @@
           <p:cNvPr id="38" name="">
             <a:extLst xmlns:a="http://schemas.openxmlformats.org/drawingml/2006/main">
               <a:ext uri="{FF2B5EF4-FFF2-40B4-BE49-F238E27FC236}">
-                <a16:creationId xmlns:a16="http://schemas.microsoft.com/office/drawing/2014/main" id="{395C211A-31C5-487C-A802-DE9D4B9F7333}"/>
+                <a16:creationId xmlns:a16="http://schemas.microsoft.com/office/drawing/2014/main" id="{1EBA12CE-7F34-43C6-8A11-9FB2DF554E79}"/>
               </a:ext>
             </a:extLst>
           </p:cNvPr>
@@ -22411,7 +22411,7 @@
           <p:cNvPr id="39" name="">
             <a:extLst xmlns:a="http://schemas.openxmlformats.org/drawingml/2006/main">
               <a:ext uri="{FF2B5EF4-FFF2-40B4-BE49-F238E27FC236}">
-                <a16:creationId xmlns:a16="http://schemas.microsoft.com/office/drawing/2014/main" id="{1D498211-EB21-4683-A448-C54DF66BA9B7}"/>
+                <a16:creationId xmlns:a16="http://schemas.microsoft.com/office/drawing/2014/main" id="{A60D3B73-1608-471A-B06F-8B7B51175D45}"/>
               </a:ext>
             </a:extLst>
           </p:cNvPr>
@@ -22466,7 +22466,7 @@
     </p:spTree>
     <p:extLst>
       <p:ext uri="{BB962C8B-B14F-4D97-AF65-F5344CB8AC3E}">
-        <p14:creationId xmlns:p14="http://schemas.microsoft.com/office/powerpoint/2010/main" val="1984156607"/>
+        <p14:creationId xmlns:p14="http://schemas.microsoft.com/office/powerpoint/2010/main" val="382677822"/>
       </p:ext>
     </p:extLst>
   </p:cSld>
@@ -22497,7 +22497,7 @@
           <p:cNvPr id="21" name="">
             <a:extLst xmlns:a="http://schemas.openxmlformats.org/drawingml/2006/main">
               <a:ext uri="{FF2B5EF4-FFF2-40B4-BE49-F238E27FC236}">
-                <a16:creationId xmlns:a16="http://schemas.microsoft.com/office/drawing/2014/main" id="{359F2DE4-BDF7-4CCB-9B05-B9B2A06525A7}"/>
+                <a16:creationId xmlns:a16="http://schemas.microsoft.com/office/drawing/2014/main" id="{20F61564-7EC1-48B1-B159-6BACB6611A38}"/>
               </a:ext>
             </a:extLst>
           </p:cNvPr>
@@ -22554,7 +22554,7 @@
           <p:cNvPr id="2" name="">
             <a:extLst xmlns:a="http://schemas.openxmlformats.org/drawingml/2006/main">
               <a:ext uri="{FF2B5EF4-FFF2-40B4-BE49-F238E27FC236}">
-                <a16:creationId xmlns:a16="http://schemas.microsoft.com/office/drawing/2014/main" id="{E44F9311-59F1-4AB6-927E-DE2DCFBBC608}"/>
+                <a16:creationId xmlns:a16="http://schemas.microsoft.com/office/drawing/2014/main" id="{3BDD678B-3C22-4322-8383-45EA4270DE8D}"/>
               </a:ext>
             </a:extLst>
           </p:cNvPr>
@@ -22585,7 +22585,7 @@
           <p:cNvPr id="3" name="">
             <a:extLst xmlns:a="http://schemas.openxmlformats.org/drawingml/2006/main">
               <a:ext uri="{FF2B5EF4-FFF2-40B4-BE49-F238E27FC236}">
-                <a16:creationId xmlns:a16="http://schemas.microsoft.com/office/drawing/2014/main" id="{66406525-CA56-459B-8689-C0373797B035}"/>
+                <a16:creationId xmlns:a16="http://schemas.microsoft.com/office/drawing/2014/main" id="{6FF9C4C5-E915-430D-9401-EBF6976EB629}"/>
               </a:ext>
             </a:extLst>
           </p:cNvPr>
@@ -22642,7 +22642,7 @@
           <p:cNvPr id="4" name="">
             <a:extLst xmlns:a="http://schemas.openxmlformats.org/drawingml/2006/main">
               <a:ext uri="{FF2B5EF4-FFF2-40B4-BE49-F238E27FC236}">
-                <a16:creationId xmlns:a16="http://schemas.microsoft.com/office/drawing/2014/main" id="{FE8F07DE-5DB1-41C4-A918-63B2CFA82925}"/>
+                <a16:creationId xmlns:a16="http://schemas.microsoft.com/office/drawing/2014/main" id="{0D0C3C3A-CC8D-4C98-BF13-7C70C48E229C}"/>
               </a:ext>
             </a:extLst>
           </p:cNvPr>
@@ -22673,7 +22673,7 @@
           <p:cNvPr id="5" name="">
             <a:extLst xmlns:a="http://schemas.openxmlformats.org/drawingml/2006/main">
               <a:ext uri="{FF2B5EF4-FFF2-40B4-BE49-F238E27FC236}">
-                <a16:creationId xmlns:a16="http://schemas.microsoft.com/office/drawing/2014/main" id="{CF949BCB-DAAE-461B-8E3D-45EB5AD9231F}"/>
+                <a16:creationId xmlns:a16="http://schemas.microsoft.com/office/drawing/2014/main" id="{991D6D29-2A47-4B87-81AE-5098D8F68A8C}"/>
               </a:ext>
             </a:extLst>
           </p:cNvPr>
@@ -22704,7 +22704,7 @@
           <p:cNvPr id="6" name="">
             <a:extLst xmlns:a="http://schemas.openxmlformats.org/drawingml/2006/main">
               <a:ext uri="{FF2B5EF4-FFF2-40B4-BE49-F238E27FC236}">
-                <a16:creationId xmlns:a16="http://schemas.microsoft.com/office/drawing/2014/main" id="{C54E1EDA-C811-44DE-9630-EB66AD9B8129}"/>
+                <a16:creationId xmlns:a16="http://schemas.microsoft.com/office/drawing/2014/main" id="{F6F4BC3C-187B-4B5A-871D-B2331E2232C8}"/>
               </a:ext>
             </a:extLst>
           </p:cNvPr>
@@ -23101,7 +23101,7 @@
           <p:cNvPr id="7" name="">
             <a:extLst xmlns:a="http://schemas.openxmlformats.org/drawingml/2006/main">
               <a:ext uri="{FF2B5EF4-FFF2-40B4-BE49-F238E27FC236}">
-                <a16:creationId xmlns:a16="http://schemas.microsoft.com/office/drawing/2014/main" id="{16C5C4F9-2CD4-407B-AA3C-DC4B277E911B}"/>
+                <a16:creationId xmlns:a16="http://schemas.microsoft.com/office/drawing/2014/main" id="{8730F7C4-4241-44EE-84AF-1CE2D9FD8C11}"/>
               </a:ext>
             </a:extLst>
           </p:cNvPr>
@@ -23132,7 +23132,7 @@
           <p:cNvPr id="8" name="">
             <a:extLst xmlns:a="http://schemas.openxmlformats.org/drawingml/2006/main">
               <a:ext uri="{FF2B5EF4-FFF2-40B4-BE49-F238E27FC236}">
-                <a16:creationId xmlns:a16="http://schemas.microsoft.com/office/drawing/2014/main" id="{130818D2-A256-4093-B2EA-C2EE9E7A9569}"/>
+                <a16:creationId xmlns:a16="http://schemas.microsoft.com/office/drawing/2014/main" id="{5C96F6D3-6918-4344-9F4A-1A32145868C7}"/>
               </a:ext>
             </a:extLst>
           </p:cNvPr>
@@ -23189,7 +23189,7 @@
           <p:cNvPr id="9" name="">
             <a:extLst xmlns:a="http://schemas.openxmlformats.org/drawingml/2006/main">
               <a:ext uri="{FF2B5EF4-FFF2-40B4-BE49-F238E27FC236}">
-                <a16:creationId xmlns:a16="http://schemas.microsoft.com/office/drawing/2014/main" id="{F528BAB4-7F0D-4BF2-ADD1-BBB35C84999B}"/>
+                <a16:creationId xmlns:a16="http://schemas.microsoft.com/office/drawing/2014/main" id="{6529C8D8-2625-4144-82BF-F5D39D5E0843}"/>
               </a:ext>
             </a:extLst>
           </p:cNvPr>
@@ -23246,7 +23246,7 @@
           <p:cNvPr id="10" name="">
             <a:extLst xmlns:a="http://schemas.openxmlformats.org/drawingml/2006/main">
               <a:ext uri="{FF2B5EF4-FFF2-40B4-BE49-F238E27FC236}">
-                <a16:creationId xmlns:a16="http://schemas.microsoft.com/office/drawing/2014/main" id="{DAFFD87B-AC52-4124-939A-9DDB5838EB48}"/>
+                <a16:creationId xmlns:a16="http://schemas.microsoft.com/office/drawing/2014/main" id="{60F02E5C-C357-4DE1-B9F3-89DD844538C5}"/>
               </a:ext>
             </a:extLst>
           </p:cNvPr>
@@ -23326,7 +23326,7 @@
           <p:cNvPr id="11" name="">
             <a:extLst xmlns:a="http://schemas.openxmlformats.org/drawingml/2006/main">
               <a:ext uri="{FF2B5EF4-FFF2-40B4-BE49-F238E27FC236}">
-                <a16:creationId xmlns:a16="http://schemas.microsoft.com/office/drawing/2014/main" id="{B3EC228B-5AA3-4995-8ED0-02B5AD6D322A}"/>
+                <a16:creationId xmlns:a16="http://schemas.microsoft.com/office/drawing/2014/main" id="{7185BB0D-B86F-431A-9EE5-4672C31D6F01}"/>
               </a:ext>
             </a:extLst>
           </p:cNvPr>
@@ -23383,7 +23383,7 @@
           <p:cNvPr id="12" name="">
             <a:extLst xmlns:a="http://schemas.openxmlformats.org/drawingml/2006/main">
               <a:ext uri="{FF2B5EF4-FFF2-40B4-BE49-F238E27FC236}">
-                <a16:creationId xmlns:a16="http://schemas.microsoft.com/office/drawing/2014/main" id="{4934D12C-D703-43FE-A2B1-63BA0DA4E92D}"/>
+                <a16:creationId xmlns:a16="http://schemas.microsoft.com/office/drawing/2014/main" id="{688D689A-6FF0-41CE-A459-AE95817EDE68}"/>
               </a:ext>
             </a:extLst>
           </p:cNvPr>
@@ -23440,7 +23440,7 @@
           <p:cNvPr id="13" name="">
             <a:extLst xmlns:a="http://schemas.openxmlformats.org/drawingml/2006/main">
               <a:ext uri="{FF2B5EF4-FFF2-40B4-BE49-F238E27FC236}">
-                <a16:creationId xmlns:a16="http://schemas.microsoft.com/office/drawing/2014/main" id="{39F49AE5-6E78-4F83-8909-27E787F4C9BA}"/>
+                <a16:creationId xmlns:a16="http://schemas.microsoft.com/office/drawing/2014/main" id="{590344D4-2F13-4B21-93EF-16FF0B9B246D}"/>
               </a:ext>
             </a:extLst>
           </p:cNvPr>
@@ -23497,7 +23497,7 @@
           <p:cNvPr id="14" name="">
             <a:extLst xmlns:a="http://schemas.openxmlformats.org/drawingml/2006/main">
               <a:ext uri="{FF2B5EF4-FFF2-40B4-BE49-F238E27FC236}">
-                <a16:creationId xmlns:a16="http://schemas.microsoft.com/office/drawing/2014/main" id="{646377A5-F702-4779-8970-F1FA601ECDFB}"/>
+                <a16:creationId xmlns:a16="http://schemas.microsoft.com/office/drawing/2014/main" id="{E5F9F1C3-202F-4F5F-BD0E-F92712140D3A}"/>
               </a:ext>
             </a:extLst>
           </p:cNvPr>
@@ -23554,7 +23554,7 @@
           <p:cNvPr id="15" name="">
             <a:extLst xmlns:a="http://schemas.openxmlformats.org/drawingml/2006/main">
               <a:ext uri="{FF2B5EF4-FFF2-40B4-BE49-F238E27FC236}">
-                <a16:creationId xmlns:a16="http://schemas.microsoft.com/office/drawing/2014/main" id="{9E6925B9-D562-4F8D-8932-B2C9E6945D78}"/>
+                <a16:creationId xmlns:a16="http://schemas.microsoft.com/office/drawing/2014/main" id="{0C7EFD6C-EEDD-4008-97F5-B66FDC3F16F4}"/>
               </a:ext>
             </a:extLst>
           </p:cNvPr>
@@ -23611,7 +23611,7 @@
           <p:cNvPr id="16" name="">
             <a:extLst xmlns:a="http://schemas.openxmlformats.org/drawingml/2006/main">
               <a:ext uri="{FF2B5EF4-FFF2-40B4-BE49-F238E27FC236}">
-                <a16:creationId xmlns:a16="http://schemas.microsoft.com/office/drawing/2014/main" id="{909785F8-67E0-4FF9-BBFA-ABBF9D31D7A3}"/>
+                <a16:creationId xmlns:a16="http://schemas.microsoft.com/office/drawing/2014/main" id="{ACF33074-DA5E-4A2D-ABD7-316E110F171B}"/>
               </a:ext>
             </a:extLst>
           </p:cNvPr>
@@ -23691,7 +23691,7 @@
           <p:cNvPr id="17" name="">
             <a:extLst xmlns:a="http://schemas.openxmlformats.org/drawingml/2006/main">
               <a:ext uri="{FF2B5EF4-FFF2-40B4-BE49-F238E27FC236}">
-                <a16:creationId xmlns:a16="http://schemas.microsoft.com/office/drawing/2014/main" id="{F3C54784-338C-455C-ACE2-C6BA0C00FF62}"/>
+                <a16:creationId xmlns:a16="http://schemas.microsoft.com/office/drawing/2014/main" id="{278790C6-9478-43CC-A0A3-00B574B0F9CE}"/>
               </a:ext>
             </a:extLst>
           </p:cNvPr>
@@ -23748,7 +23748,7 @@
           <p:cNvPr id="18" name="">
             <a:extLst xmlns:a="http://schemas.openxmlformats.org/drawingml/2006/main">
               <a:ext uri="{FF2B5EF4-FFF2-40B4-BE49-F238E27FC236}">
-                <a16:creationId xmlns:a16="http://schemas.microsoft.com/office/drawing/2014/main" id="{9663B751-82BA-40F7-8658-55D7DF5C0807}"/>
+                <a16:creationId xmlns:a16="http://schemas.microsoft.com/office/drawing/2014/main" id="{13262338-56D5-4079-AF5D-13D306205415}"/>
               </a:ext>
             </a:extLst>
           </p:cNvPr>
@@ -23805,7 +23805,7 @@
           <p:cNvPr id="19" name="">
             <a:extLst xmlns:a="http://schemas.openxmlformats.org/drawingml/2006/main">
               <a:ext uri="{FF2B5EF4-FFF2-40B4-BE49-F238E27FC236}">
-                <a16:creationId xmlns:a16="http://schemas.microsoft.com/office/drawing/2014/main" id="{ADFBDEDA-8BB1-4B7D-B8F8-3A7003165C0C}"/>
+                <a16:creationId xmlns:a16="http://schemas.microsoft.com/office/drawing/2014/main" id="{C7E794E0-9EBF-4AA4-9202-4A3798358511}"/>
               </a:ext>
             </a:extLst>
           </p:cNvPr>
@@ -23836,7 +23836,7 @@
           <p:cNvPr id="20" name="">
             <a:extLst xmlns:a="http://schemas.openxmlformats.org/drawingml/2006/main">
               <a:ext uri="{FF2B5EF4-FFF2-40B4-BE49-F238E27FC236}">
-                <a16:creationId xmlns:a16="http://schemas.microsoft.com/office/drawing/2014/main" id="{A0507F9F-1018-4EE1-B13B-D1EAD27ABEDC}"/>
+                <a16:creationId xmlns:a16="http://schemas.microsoft.com/office/drawing/2014/main" id="{DF37E198-CED7-4202-AE33-750A2A444B6E}"/>
               </a:ext>
             </a:extLst>
           </p:cNvPr>
@@ -23891,7 +23891,7 @@
     </p:spTree>
     <p:extLst>
       <p:ext uri="{BB962C8B-B14F-4D97-AF65-F5344CB8AC3E}">
-        <p14:creationId xmlns:p14="http://schemas.microsoft.com/office/powerpoint/2010/main" val="1366016290"/>
+        <p14:creationId xmlns:p14="http://schemas.microsoft.com/office/powerpoint/2010/main" val="326020407"/>
       </p:ext>
     </p:extLst>
   </p:cSld>
@@ -24000,7 +24000,7 @@
           <p:cNvPr id="27" name="">
             <a:extLst xmlns:a="http://schemas.openxmlformats.org/drawingml/2006/main">
               <a:ext uri="{FF2B5EF4-FFF2-40B4-BE49-F238E27FC236}">
-                <a16:creationId xmlns:a16="http://schemas.microsoft.com/office/drawing/2014/main" id="{7E2FAE62-A2C7-4FC4-8C88-7796509EE73B}"/>
+                <a16:creationId xmlns:a16="http://schemas.microsoft.com/office/drawing/2014/main" id="{4C93A4C7-D1DD-408B-9125-29CC35148FF1}"/>
               </a:ext>
             </a:extLst>
           </p:cNvPr>
@@ -24057,7 +24057,7 @@
           <p:cNvPr id="2" name="">
             <a:extLst xmlns:a="http://schemas.openxmlformats.org/drawingml/2006/main">
               <a:ext uri="{FF2B5EF4-FFF2-40B4-BE49-F238E27FC236}">
-                <a16:creationId xmlns:a16="http://schemas.microsoft.com/office/drawing/2014/main" id="{9E38B0EA-E07A-40C9-8CDD-50885E8F5703}"/>
+                <a16:creationId xmlns:a16="http://schemas.microsoft.com/office/drawing/2014/main" id="{BEF2AE8E-86EA-46AF-8CBD-FB2470F6C84B}"/>
               </a:ext>
             </a:extLst>
           </p:cNvPr>
@@ -24088,7 +24088,7 @@
           <p:cNvPr id="3" name="">
             <a:extLst xmlns:a="http://schemas.openxmlformats.org/drawingml/2006/main">
               <a:ext uri="{FF2B5EF4-FFF2-40B4-BE49-F238E27FC236}">
-                <a16:creationId xmlns:a16="http://schemas.microsoft.com/office/drawing/2014/main" id="{979040E2-AA93-4DA4-89B0-4B8CBAC7267D}"/>
+                <a16:creationId xmlns:a16="http://schemas.microsoft.com/office/drawing/2014/main" id="{46D7CDAF-CDE8-464C-BE94-6387832B4259}"/>
               </a:ext>
             </a:extLst>
           </p:cNvPr>
@@ -24145,7 +24145,7 @@
           <p:cNvPr id="4" name="">
             <a:extLst xmlns:a="http://schemas.openxmlformats.org/drawingml/2006/main">
               <a:ext uri="{FF2B5EF4-FFF2-40B4-BE49-F238E27FC236}">
-                <a16:creationId xmlns:a16="http://schemas.microsoft.com/office/drawing/2014/main" id="{15303E96-51B9-490A-915F-43EA5EEEF9CF}"/>
+                <a16:creationId xmlns:a16="http://schemas.microsoft.com/office/drawing/2014/main" id="{7E452C44-B7F5-45AC-8702-06740CE045B8}"/>
               </a:ext>
             </a:extLst>
           </p:cNvPr>
@@ -24202,7 +24202,7 @@
           <p:cNvPr id="5" name="">
             <a:extLst xmlns:a="http://schemas.openxmlformats.org/drawingml/2006/main">
               <a:ext uri="{FF2B5EF4-FFF2-40B4-BE49-F238E27FC236}">
-                <a16:creationId xmlns:a16="http://schemas.microsoft.com/office/drawing/2014/main" id="{38A2E14D-3151-4B9F-B884-80177F071EA4}"/>
+                <a16:creationId xmlns:a16="http://schemas.microsoft.com/office/drawing/2014/main" id="{039DA01A-30FB-4A3A-9A8B-77F0D89D5B7D}"/>
               </a:ext>
             </a:extLst>
           </p:cNvPr>
@@ -24259,7 +24259,7 @@
           <p:cNvPr id="6" name="">
             <a:extLst xmlns:a="http://schemas.openxmlformats.org/drawingml/2006/main">
               <a:ext uri="{FF2B5EF4-FFF2-40B4-BE49-F238E27FC236}">
-                <a16:creationId xmlns:a16="http://schemas.microsoft.com/office/drawing/2014/main" id="{D38C0195-D24C-4FD9-86D8-B9A30E31E652}"/>
+                <a16:creationId xmlns:a16="http://schemas.microsoft.com/office/drawing/2014/main" id="{F8790911-742A-408D-BA47-5ADF8B20C934}"/>
               </a:ext>
             </a:extLst>
           </p:cNvPr>
@@ -24292,7 +24292,7 @@
           <p:cNvPr id="7" name="">
             <a:extLst xmlns:a="http://schemas.openxmlformats.org/drawingml/2006/main">
               <a:ext uri="{FF2B5EF4-FFF2-40B4-BE49-F238E27FC236}">
-                <a16:creationId xmlns:a16="http://schemas.microsoft.com/office/drawing/2014/main" id="{A9433845-7404-4FA3-87F3-D6CB037F51FF}"/>
+                <a16:creationId xmlns:a16="http://schemas.microsoft.com/office/drawing/2014/main" id="{984ABAA3-BB3C-4B96-887F-F806FB92F4CC}"/>
               </a:ext>
             </a:extLst>
           </p:cNvPr>
@@ -24372,7 +24372,7 @@
           <p:cNvPr id="8" name="">
             <a:extLst xmlns:a="http://schemas.openxmlformats.org/drawingml/2006/main">
               <a:ext uri="{FF2B5EF4-FFF2-40B4-BE49-F238E27FC236}">
-                <a16:creationId xmlns:a16="http://schemas.microsoft.com/office/drawing/2014/main" id="{D30EE51F-021E-4FAD-95C6-5A828DCFECDC}"/>
+                <a16:creationId xmlns:a16="http://schemas.microsoft.com/office/drawing/2014/main" id="{EAC303D5-88A5-4DB1-A81B-0BC45B92E279}"/>
               </a:ext>
             </a:extLst>
           </p:cNvPr>
@@ -24475,7 +24475,7 @@
           <p:cNvPr id="9" name="">
             <a:extLst xmlns:a="http://schemas.openxmlformats.org/drawingml/2006/main">
               <a:ext uri="{FF2B5EF4-FFF2-40B4-BE49-F238E27FC236}">
-                <a16:creationId xmlns:a16="http://schemas.microsoft.com/office/drawing/2014/main" id="{245E8FCE-2351-4721-B40E-A13468C91D29}"/>
+                <a16:creationId xmlns:a16="http://schemas.microsoft.com/office/drawing/2014/main" id="{A428AD2D-94BD-4553-84CB-12C18B56F193}"/>
               </a:ext>
             </a:extLst>
           </p:cNvPr>
@@ -24508,7 +24508,7 @@
           <p:cNvPr id="10" name="">
             <a:extLst xmlns:a="http://schemas.openxmlformats.org/drawingml/2006/main">
               <a:ext uri="{FF2B5EF4-FFF2-40B4-BE49-F238E27FC236}">
-                <a16:creationId xmlns:a16="http://schemas.microsoft.com/office/drawing/2014/main" id="{52490546-75A2-425A-9A28-D9CE5100EC8C}"/>
+                <a16:creationId xmlns:a16="http://schemas.microsoft.com/office/drawing/2014/main" id="{DBED9205-E7C6-4D3C-BD8A-AFFCCA3ED749}"/>
               </a:ext>
             </a:extLst>
           </p:cNvPr>
@@ -24588,7 +24588,7 @@
           <p:cNvPr id="11" name="">
             <a:extLst xmlns:a="http://schemas.openxmlformats.org/drawingml/2006/main">
               <a:ext uri="{FF2B5EF4-FFF2-40B4-BE49-F238E27FC236}">
-                <a16:creationId xmlns:a16="http://schemas.microsoft.com/office/drawing/2014/main" id="{43C1A760-A917-45CC-9AAD-BF9AD8DE3CB3}"/>
+                <a16:creationId xmlns:a16="http://schemas.microsoft.com/office/drawing/2014/main" id="{36D55289-0A4A-4E10-9981-A3B8765D8901}"/>
               </a:ext>
             </a:extLst>
           </p:cNvPr>
@@ -24691,7 +24691,7 @@
           <p:cNvPr id="12" name="">
             <a:extLst xmlns:a="http://schemas.openxmlformats.org/drawingml/2006/main">
               <a:ext uri="{FF2B5EF4-FFF2-40B4-BE49-F238E27FC236}">
-                <a16:creationId xmlns:a16="http://schemas.microsoft.com/office/drawing/2014/main" id="{67D306E6-C4A0-4F53-BF15-3197F82802E6}"/>
+                <a16:creationId xmlns:a16="http://schemas.microsoft.com/office/drawing/2014/main" id="{353E379D-0F3A-4F4D-B5B7-F086746826AF}"/>
               </a:ext>
             </a:extLst>
           </p:cNvPr>
@@ -24724,7 +24724,7 @@
           <p:cNvPr id="13" name="">
             <a:extLst xmlns:a="http://schemas.openxmlformats.org/drawingml/2006/main">
               <a:ext uri="{FF2B5EF4-FFF2-40B4-BE49-F238E27FC236}">
-                <a16:creationId xmlns:a16="http://schemas.microsoft.com/office/drawing/2014/main" id="{9C581F2D-3B8D-4D7F-87C9-8588F53B31D4}"/>
+                <a16:creationId xmlns:a16="http://schemas.microsoft.com/office/drawing/2014/main" id="{BBD0F470-3B00-4051-81A9-E0B1D870C1C9}"/>
               </a:ext>
             </a:extLst>
           </p:cNvPr>
@@ -24804,7 +24804,7 @@
           <p:cNvPr id="14" name="">
             <a:extLst xmlns:a="http://schemas.openxmlformats.org/drawingml/2006/main">
               <a:ext uri="{FF2B5EF4-FFF2-40B4-BE49-F238E27FC236}">
-                <a16:creationId xmlns:a16="http://schemas.microsoft.com/office/drawing/2014/main" id="{3D2C5C07-EDC6-4590-A30E-57CE8BA2B0F3}"/>
+                <a16:creationId xmlns:a16="http://schemas.microsoft.com/office/drawing/2014/main" id="{0190C4F9-487D-4104-BC1F-443ECCDD3ADF}"/>
               </a:ext>
             </a:extLst>
           </p:cNvPr>
@@ -24907,7 +24907,7 @@
           <p:cNvPr id="15" name="">
             <a:extLst xmlns:a="http://schemas.openxmlformats.org/drawingml/2006/main">
               <a:ext uri="{FF2B5EF4-FFF2-40B4-BE49-F238E27FC236}">
-                <a16:creationId xmlns:a16="http://schemas.microsoft.com/office/drawing/2014/main" id="{3A9E5E90-B83C-462C-8000-C5A3AA90C58A}"/>
+                <a16:creationId xmlns:a16="http://schemas.microsoft.com/office/drawing/2014/main" id="{0C4716BD-13E3-4288-B727-A897B058ABFF}"/>
               </a:ext>
             </a:extLst>
           </p:cNvPr>
@@ -24940,7 +24940,7 @@
           <p:cNvPr id="16" name="">
             <a:extLst xmlns:a="http://schemas.openxmlformats.org/drawingml/2006/main">
               <a:ext uri="{FF2B5EF4-FFF2-40B4-BE49-F238E27FC236}">
-                <a16:creationId xmlns:a16="http://schemas.microsoft.com/office/drawing/2014/main" id="{3E3CBFDF-0660-4D37-B234-AAF919FAB333}"/>
+                <a16:creationId xmlns:a16="http://schemas.microsoft.com/office/drawing/2014/main" id="{4A09126C-86DC-46B9-A0BE-9DA0C2FD4BFD}"/>
               </a:ext>
             </a:extLst>
           </p:cNvPr>
@@ -25020,7 +25020,7 @@
           <p:cNvPr id="17" name="">
             <a:extLst xmlns:a="http://schemas.openxmlformats.org/drawingml/2006/main">
               <a:ext uri="{FF2B5EF4-FFF2-40B4-BE49-F238E27FC236}">
-                <a16:creationId xmlns:a16="http://schemas.microsoft.com/office/drawing/2014/main" id="{8AAB9412-BCA6-4BDC-AD91-238408E08BD8}"/>
+                <a16:creationId xmlns:a16="http://schemas.microsoft.com/office/drawing/2014/main" id="{E51D87FF-3B37-4DDA-A41C-BBFFD5F924F7}"/>
               </a:ext>
             </a:extLst>
           </p:cNvPr>
@@ -25123,7 +25123,7 @@
           <p:cNvPr id="21" name="">
             <a:extLst xmlns:a="http://schemas.openxmlformats.org/drawingml/2006/main">
               <a:ext uri="{FF2B5EF4-FFF2-40B4-BE49-F238E27FC236}">
-                <a16:creationId xmlns:a16="http://schemas.microsoft.com/office/drawing/2014/main" id="{E7E92A7A-4E06-44E5-B99C-D808ED1E2116}"/>
+                <a16:creationId xmlns:a16="http://schemas.microsoft.com/office/drawing/2014/main" id="{E6F85D1C-F936-405D-83E1-C9C2DBBFD6E3}"/>
               </a:ext>
             </a:extLst>
           </p:cNvPr>
@@ -25180,7 +25180,7 @@
           <p:cNvPr id="22" name="">
             <a:extLst xmlns:a="http://schemas.openxmlformats.org/drawingml/2006/main">
               <a:ext uri="{FF2B5EF4-FFF2-40B4-BE49-F238E27FC236}">
-                <a16:creationId xmlns:a16="http://schemas.microsoft.com/office/drawing/2014/main" id="{A89890FD-E676-4461-8605-D98005A69FDB}"/>
+                <a16:creationId xmlns:a16="http://schemas.microsoft.com/office/drawing/2014/main" id="{114C4E5D-1E29-4435-AB5B-E8BE5FEE7A8E}"/>
               </a:ext>
             </a:extLst>
           </p:cNvPr>
@@ -25211,7 +25211,7 @@
           <p:cNvPr id="23" name="">
             <a:extLst xmlns:a="http://schemas.openxmlformats.org/drawingml/2006/main">
               <a:ext uri="{FF2B5EF4-FFF2-40B4-BE49-F238E27FC236}">
-                <a16:creationId xmlns:a16="http://schemas.microsoft.com/office/drawing/2014/main" id="{4C3EAD00-EC8A-4CBC-B77C-1A238DCBC77E}"/>
+                <a16:creationId xmlns:a16="http://schemas.microsoft.com/office/drawing/2014/main" id="{18745FC6-D28F-4A3F-8B61-E94E0DECC884}"/>
               </a:ext>
             </a:extLst>
           </p:cNvPr>
@@ -25266,7 +25266,7 @@
     </p:spTree>
     <p:extLst>
       <p:ext uri="{BB962C8B-B14F-4D97-AF65-F5344CB8AC3E}">
-        <p14:creationId xmlns:p14="http://schemas.microsoft.com/office/powerpoint/2010/main" val="1211795677"/>
+        <p14:creationId xmlns:p14="http://schemas.microsoft.com/office/powerpoint/2010/main" val="416428602"/>
       </p:ext>
     </p:extLst>
   </p:cSld>
@@ -25297,7 +25297,7 @@
           <p:cNvPr id="32" name="">
             <a:extLst xmlns:a="http://schemas.openxmlformats.org/drawingml/2006/main">
               <a:ext uri="{FF2B5EF4-FFF2-40B4-BE49-F238E27FC236}">
-                <a16:creationId xmlns:a16="http://schemas.microsoft.com/office/drawing/2014/main" id="{D8974CD1-FDF2-473A-86F7-5C11C4159F2F}"/>
+                <a16:creationId xmlns:a16="http://schemas.microsoft.com/office/drawing/2014/main" id="{58193453-7990-4B7C-9819-A81F6404FA9D}"/>
               </a:ext>
             </a:extLst>
           </p:cNvPr>
@@ -25377,7 +25377,7 @@
           <p:cNvPr id="2" name="">
             <a:extLst xmlns:a="http://schemas.openxmlformats.org/drawingml/2006/main">
               <a:ext uri="{FF2B5EF4-FFF2-40B4-BE49-F238E27FC236}">
-                <a16:creationId xmlns:a16="http://schemas.microsoft.com/office/drawing/2014/main" id="{36AAE4B1-E1AD-4587-97F1-E5015CCCA6CA}"/>
+                <a16:creationId xmlns:a16="http://schemas.microsoft.com/office/drawing/2014/main" id="{2A60C43F-71EC-4F45-BB95-90CF31E1B1BD}"/>
               </a:ext>
             </a:extLst>
           </p:cNvPr>
@@ -25408,7 +25408,7 @@
           <p:cNvPr id="3" name="">
             <a:extLst xmlns:a="http://schemas.openxmlformats.org/drawingml/2006/main">
               <a:ext uri="{FF2B5EF4-FFF2-40B4-BE49-F238E27FC236}">
-                <a16:creationId xmlns:a16="http://schemas.microsoft.com/office/drawing/2014/main" id="{6E723DA9-6A9D-40C6-BAEF-7BF230A2AE22}"/>
+                <a16:creationId xmlns:a16="http://schemas.microsoft.com/office/drawing/2014/main" id="{760797D8-5887-4329-8327-FB3AB5F1B2E7}"/>
               </a:ext>
             </a:extLst>
           </p:cNvPr>
@@ -25465,7 +25465,7 @@
           <p:cNvPr id="4" name="">
             <a:extLst xmlns:a="http://schemas.openxmlformats.org/drawingml/2006/main">
               <a:ext uri="{FF2B5EF4-FFF2-40B4-BE49-F238E27FC236}">
-                <a16:creationId xmlns:a16="http://schemas.microsoft.com/office/drawing/2014/main" id="{89F218EE-303A-42B4-BD38-8F3620CE0E5B}"/>
+                <a16:creationId xmlns:a16="http://schemas.microsoft.com/office/drawing/2014/main" id="{D087E1AF-FDA4-4946-936D-176EEFFAA147}"/>
               </a:ext>
             </a:extLst>
           </p:cNvPr>
@@ -25522,7 +25522,7 @@
           <p:cNvPr id="5" name="">
             <a:extLst xmlns:a="http://schemas.openxmlformats.org/drawingml/2006/main">
               <a:ext uri="{FF2B5EF4-FFF2-40B4-BE49-F238E27FC236}">
-                <a16:creationId xmlns:a16="http://schemas.microsoft.com/office/drawing/2014/main" id="{868C9854-FCA0-43BA-B25C-447A490CD98C}"/>
+                <a16:creationId xmlns:a16="http://schemas.microsoft.com/office/drawing/2014/main" id="{0FA6B746-B350-435E-B2C2-E470A18DA275}"/>
               </a:ext>
             </a:extLst>
           </p:cNvPr>
@@ -25579,7 +25579,7 @@
           <p:cNvPr id="6" name="">
             <a:extLst xmlns:a="http://schemas.openxmlformats.org/drawingml/2006/main">
               <a:ext uri="{FF2B5EF4-FFF2-40B4-BE49-F238E27FC236}">
-                <a16:creationId xmlns:a16="http://schemas.microsoft.com/office/drawing/2014/main" id="{FAD9B65A-09E2-40C8-AAFF-4D98912DDBAA}"/>
+                <a16:creationId xmlns:a16="http://schemas.microsoft.com/office/drawing/2014/main" id="{24BE07E1-86D8-4BF0-86C5-68D0A0DD6B56}"/>
               </a:ext>
             </a:extLst>
           </p:cNvPr>
@@ -25636,7 +25636,7 @@
           <p:cNvPr id="7" name="">
             <a:extLst xmlns:a="http://schemas.openxmlformats.org/drawingml/2006/main">
               <a:ext uri="{FF2B5EF4-FFF2-40B4-BE49-F238E27FC236}">
-                <a16:creationId xmlns:a16="http://schemas.microsoft.com/office/drawing/2014/main" id="{29A4B8A2-1F92-4DEB-A5AC-151C5336B776}"/>
+                <a16:creationId xmlns:a16="http://schemas.microsoft.com/office/drawing/2014/main" id="{19A85357-7E94-4543-B18D-503D912898F4}"/>
               </a:ext>
             </a:extLst>
           </p:cNvPr>
@@ -25693,7 +25693,7 @@
           <p:cNvPr id="8" name="">
             <a:extLst xmlns:a="http://schemas.openxmlformats.org/drawingml/2006/main">
               <a:ext uri="{FF2B5EF4-FFF2-40B4-BE49-F238E27FC236}">
-                <a16:creationId xmlns:a16="http://schemas.microsoft.com/office/drawing/2014/main" id="{636CB5ED-D24A-4179-911F-4DBF0E428060}"/>
+                <a16:creationId xmlns:a16="http://schemas.microsoft.com/office/drawing/2014/main" id="{7AD3A518-7691-49EA-82AC-BCC21D393751}"/>
               </a:ext>
             </a:extLst>
           </p:cNvPr>
@@ -25750,7 +25750,7 @@
           <p:cNvPr id="9" name="">
             <a:extLst xmlns:a="http://schemas.openxmlformats.org/drawingml/2006/main">
               <a:ext uri="{FF2B5EF4-FFF2-40B4-BE49-F238E27FC236}">
-                <a16:creationId xmlns:a16="http://schemas.microsoft.com/office/drawing/2014/main" id="{9F5729C1-BEFF-451F-AFE9-B2D7190CD14D}"/>
+                <a16:creationId xmlns:a16="http://schemas.microsoft.com/office/drawing/2014/main" id="{262DC350-232B-499C-AC14-E584FEF80CB0}"/>
               </a:ext>
             </a:extLst>
           </p:cNvPr>
@@ -25807,7 +25807,7 @@
           <p:cNvPr id="10" name="">
             <a:extLst xmlns:a="http://schemas.openxmlformats.org/drawingml/2006/main">
               <a:ext uri="{FF2B5EF4-FFF2-40B4-BE49-F238E27FC236}">
-                <a16:creationId xmlns:a16="http://schemas.microsoft.com/office/drawing/2014/main" id="{B96638E0-00A0-44D7-9A2D-BEF700E503D7}"/>
+                <a16:creationId xmlns:a16="http://schemas.microsoft.com/office/drawing/2014/main" id="{7DBB225B-43CD-4ECE-B131-901C9959417B}"/>
               </a:ext>
             </a:extLst>
           </p:cNvPr>
@@ -25838,7 +25838,7 @@
           <p:cNvPr id="11" name="">
             <a:extLst xmlns:a="http://schemas.openxmlformats.org/drawingml/2006/main">
               <a:ext uri="{FF2B5EF4-FFF2-40B4-BE49-F238E27FC236}">
-                <a16:creationId xmlns:a16="http://schemas.microsoft.com/office/drawing/2014/main" id="{6F562CD0-3878-43CE-9AC5-45A2B205EE3E}"/>
+                <a16:creationId xmlns:a16="http://schemas.microsoft.com/office/drawing/2014/main" id="{B28F4104-4037-4D59-B54C-336D6C70FAB0}"/>
               </a:ext>
             </a:extLst>
           </p:cNvPr>
@@ -25895,7 +25895,7 @@
           <p:cNvPr id="12" name="">
             <a:extLst xmlns:a="http://schemas.openxmlformats.org/drawingml/2006/main">
               <a:ext uri="{FF2B5EF4-FFF2-40B4-BE49-F238E27FC236}">
-                <a16:creationId xmlns:a16="http://schemas.microsoft.com/office/drawing/2014/main" id="{BED15175-A84E-4973-B275-B64D97840F8F}"/>
+                <a16:creationId xmlns:a16="http://schemas.microsoft.com/office/drawing/2014/main" id="{59915334-0C09-4853-8E82-C42B5F2CED7A}"/>
               </a:ext>
             </a:extLst>
           </p:cNvPr>
@@ -25952,7 +25952,7 @@
           <p:cNvPr id="13" name="">
             <a:extLst xmlns:a="http://schemas.openxmlformats.org/drawingml/2006/main">
               <a:ext uri="{FF2B5EF4-FFF2-40B4-BE49-F238E27FC236}">
-                <a16:creationId xmlns:a16="http://schemas.microsoft.com/office/drawing/2014/main" id="{ECC34BBA-1688-49ED-BFF1-76286E2CFAA6}"/>
+                <a16:creationId xmlns:a16="http://schemas.microsoft.com/office/drawing/2014/main" id="{BDE8F7A5-B3A1-4920-B7F3-7C14AC5A2BF0}"/>
               </a:ext>
             </a:extLst>
           </p:cNvPr>
@@ -26032,7 +26032,7 @@
           <p:cNvPr id="14" name="">
             <a:extLst xmlns:a="http://schemas.openxmlformats.org/drawingml/2006/main">
               <a:ext uri="{FF2B5EF4-FFF2-40B4-BE49-F238E27FC236}">
-                <a16:creationId xmlns:a16="http://schemas.microsoft.com/office/drawing/2014/main" id="{DAD93B6B-7329-432C-872C-045E9DA6DC53}"/>
+                <a16:creationId xmlns:a16="http://schemas.microsoft.com/office/drawing/2014/main" id="{898EECFE-F030-4363-8BC4-7F39B0B35D82}"/>
               </a:ext>
             </a:extLst>
           </p:cNvPr>
@@ -26089,7 +26089,7 @@
           <p:cNvPr id="15" name="">
             <a:extLst xmlns:a="http://schemas.openxmlformats.org/drawingml/2006/main">
               <a:ext uri="{FF2B5EF4-FFF2-40B4-BE49-F238E27FC236}">
-                <a16:creationId xmlns:a16="http://schemas.microsoft.com/office/drawing/2014/main" id="{D25DC5CB-9237-4B2C-8065-31AFED592D28}"/>
+                <a16:creationId xmlns:a16="http://schemas.microsoft.com/office/drawing/2014/main" id="{57C00EED-B101-45DC-92EB-557AE3B5BD46}"/>
               </a:ext>
             </a:extLst>
           </p:cNvPr>
@@ -26169,7 +26169,7 @@
           <p:cNvPr id="16" name="">
             <a:extLst xmlns:a="http://schemas.openxmlformats.org/drawingml/2006/main">
               <a:ext uri="{FF2B5EF4-FFF2-40B4-BE49-F238E27FC236}">
-                <a16:creationId xmlns:a16="http://schemas.microsoft.com/office/drawing/2014/main" id="{B54E737E-473D-4112-A3E0-85E4C1741D0D}"/>
+                <a16:creationId xmlns:a16="http://schemas.microsoft.com/office/drawing/2014/main" id="{0F342B70-9C33-42CC-AB63-1085458EE2F3}"/>
               </a:ext>
             </a:extLst>
           </p:cNvPr>
@@ -26226,7 +26226,7 @@
           <p:cNvPr id="17" name="">
             <a:extLst xmlns:a="http://schemas.openxmlformats.org/drawingml/2006/main">
               <a:ext uri="{FF2B5EF4-FFF2-40B4-BE49-F238E27FC236}">
-                <a16:creationId xmlns:a16="http://schemas.microsoft.com/office/drawing/2014/main" id="{FAAECC23-AA4B-4399-BA55-D77297FE18F7}"/>
+                <a16:creationId xmlns:a16="http://schemas.microsoft.com/office/drawing/2014/main" id="{BCF4A1DA-940D-4918-B78A-8036DD993C26}"/>
               </a:ext>
             </a:extLst>
           </p:cNvPr>
@@ -26306,7 +26306,7 @@
           <p:cNvPr id="18" name="">
             <a:extLst xmlns:a="http://schemas.openxmlformats.org/drawingml/2006/main">
               <a:ext uri="{FF2B5EF4-FFF2-40B4-BE49-F238E27FC236}">
-                <a16:creationId xmlns:a16="http://schemas.microsoft.com/office/drawing/2014/main" id="{95501AA4-1B8E-4030-A528-7B74D7515674}"/>
+                <a16:creationId xmlns:a16="http://schemas.microsoft.com/office/drawing/2014/main" id="{26342FD9-579F-4A05-9FD3-B95029C80A0D}"/>
               </a:ext>
             </a:extLst>
           </p:cNvPr>
@@ -26363,7 +26363,7 @@
           <p:cNvPr id="19" name="">
             <a:extLst xmlns:a="http://schemas.openxmlformats.org/drawingml/2006/main">
               <a:ext uri="{FF2B5EF4-FFF2-40B4-BE49-F238E27FC236}">
-                <a16:creationId xmlns:a16="http://schemas.microsoft.com/office/drawing/2014/main" id="{7A97B95F-E795-44BF-A881-AE47157E4463}"/>
+                <a16:creationId xmlns:a16="http://schemas.microsoft.com/office/drawing/2014/main" id="{394B3661-D124-4A24-8A06-C2EABFC75F46}"/>
               </a:ext>
             </a:extLst>
           </p:cNvPr>
@@ -26443,7 +26443,7 @@
           <p:cNvPr id="20" name="">
             <a:extLst xmlns:a="http://schemas.openxmlformats.org/drawingml/2006/main">
               <a:ext uri="{FF2B5EF4-FFF2-40B4-BE49-F238E27FC236}">
-                <a16:creationId xmlns:a16="http://schemas.microsoft.com/office/drawing/2014/main" id="{26165DA1-1167-4BB1-9422-8B7EAB5828EF}"/>
+                <a16:creationId xmlns:a16="http://schemas.microsoft.com/office/drawing/2014/main" id="{A490A3DB-D7E1-468C-A5B1-6603F51E98B9}"/>
               </a:ext>
             </a:extLst>
           </p:cNvPr>
@@ -26500,7 +26500,7 @@
           <p:cNvPr id="21" name="">
             <a:extLst xmlns:a="http://schemas.openxmlformats.org/drawingml/2006/main">
               <a:ext uri="{FF2B5EF4-FFF2-40B4-BE49-F238E27FC236}">
-                <a16:creationId xmlns:a16="http://schemas.microsoft.com/office/drawing/2014/main" id="{87BED242-6465-4E13-A50B-CEDBFBCCF204}"/>
+                <a16:creationId xmlns:a16="http://schemas.microsoft.com/office/drawing/2014/main" id="{DB20BE35-EA50-4092-A854-E55A45C3AA3B}"/>
               </a:ext>
             </a:extLst>
           </p:cNvPr>
@@ -26557,7 +26557,7 @@
           <p:cNvPr id="22" name="">
             <a:extLst xmlns:a="http://schemas.openxmlformats.org/drawingml/2006/main">
               <a:ext uri="{FF2B5EF4-FFF2-40B4-BE49-F238E27FC236}">
-                <a16:creationId xmlns:a16="http://schemas.microsoft.com/office/drawing/2014/main" id="{893E4452-F49A-4B98-964F-54B3CA5F4911}"/>
+                <a16:creationId xmlns:a16="http://schemas.microsoft.com/office/drawing/2014/main" id="{9E17DB60-2903-4167-9E6B-3223EF85D9AB}"/>
               </a:ext>
             </a:extLst>
           </p:cNvPr>
@@ -26637,7 +26637,7 @@
           <p:cNvPr id="23" name="">
             <a:extLst xmlns:a="http://schemas.openxmlformats.org/drawingml/2006/main">
               <a:ext uri="{FF2B5EF4-FFF2-40B4-BE49-F238E27FC236}">
-                <a16:creationId xmlns:a16="http://schemas.microsoft.com/office/drawing/2014/main" id="{44F3C87E-7B26-4EED-8EEB-57D1042F0E0D}"/>
+                <a16:creationId xmlns:a16="http://schemas.microsoft.com/office/drawing/2014/main" id="{56E86402-EBC5-48BA-931B-B2062E360B57}"/>
               </a:ext>
             </a:extLst>
           </p:cNvPr>
@@ -26694,7 +26694,7 @@
           <p:cNvPr id="24" name="">
             <a:extLst xmlns:a="http://schemas.openxmlformats.org/drawingml/2006/main">
               <a:ext uri="{FF2B5EF4-FFF2-40B4-BE49-F238E27FC236}">
-                <a16:creationId xmlns:a16="http://schemas.microsoft.com/office/drawing/2014/main" id="{DC6A0FF9-5C66-45C9-A9C9-675A1B187E33}"/>
+                <a16:creationId xmlns:a16="http://schemas.microsoft.com/office/drawing/2014/main" id="{3E29A5C5-700F-4FA2-9C51-03450034E97C}"/>
               </a:ext>
             </a:extLst>
           </p:cNvPr>
@@ -26774,7 +26774,7 @@
           <p:cNvPr id="25" name="">
             <a:extLst xmlns:a="http://schemas.openxmlformats.org/drawingml/2006/main">
               <a:ext uri="{FF2B5EF4-FFF2-40B4-BE49-F238E27FC236}">
-                <a16:creationId xmlns:a16="http://schemas.microsoft.com/office/drawing/2014/main" id="{8EA51821-6C8D-4B85-B51C-47CC383C332C}"/>
+                <a16:creationId xmlns:a16="http://schemas.microsoft.com/office/drawing/2014/main" id="{6B209835-BC15-4966-8FCC-24281E7AFF9D}"/>
               </a:ext>
             </a:extLst>
           </p:cNvPr>
@@ -26831,7 +26831,7 @@
           <p:cNvPr id="26" name="">
             <a:extLst xmlns:a="http://schemas.openxmlformats.org/drawingml/2006/main">
               <a:ext uri="{FF2B5EF4-FFF2-40B4-BE49-F238E27FC236}">
-                <a16:creationId xmlns:a16="http://schemas.microsoft.com/office/drawing/2014/main" id="{F5E5D3EA-BFF2-41E5-9696-F4D734A9ECD7}"/>
+                <a16:creationId xmlns:a16="http://schemas.microsoft.com/office/drawing/2014/main" id="{4D6E1E8E-1C2C-4E1C-BC3B-29E98F387726}"/>
               </a:ext>
             </a:extLst>
           </p:cNvPr>
@@ -26911,7 +26911,7 @@
           <p:cNvPr id="27" name="">
             <a:extLst xmlns:a="http://schemas.openxmlformats.org/drawingml/2006/main">
               <a:ext uri="{FF2B5EF4-FFF2-40B4-BE49-F238E27FC236}">
-                <a16:creationId xmlns:a16="http://schemas.microsoft.com/office/drawing/2014/main" id="{06F55743-5F0E-4894-9EC8-D3AA700524CC}"/>
+                <a16:creationId xmlns:a16="http://schemas.microsoft.com/office/drawing/2014/main" id="{C768F2B9-3BFB-46E1-938C-6942E2E75133}"/>
               </a:ext>
             </a:extLst>
           </p:cNvPr>
@@ -26968,7 +26968,7 @@
           <p:cNvPr id="28" name="">
             <a:extLst xmlns:a="http://schemas.openxmlformats.org/drawingml/2006/main">
               <a:ext uri="{FF2B5EF4-FFF2-40B4-BE49-F238E27FC236}">
-                <a16:creationId xmlns:a16="http://schemas.microsoft.com/office/drawing/2014/main" id="{81538DEC-2D44-4EB2-9FF8-C5D7BC956B14}"/>
+                <a16:creationId xmlns:a16="http://schemas.microsoft.com/office/drawing/2014/main" id="{4FB3584E-08EE-4247-BEAD-7A061FC40CB1}"/>
               </a:ext>
             </a:extLst>
           </p:cNvPr>
@@ -27048,7 +27048,7 @@
           <p:cNvPr id="29" name="">
             <a:extLst xmlns:a="http://schemas.openxmlformats.org/drawingml/2006/main">
               <a:ext uri="{FF2B5EF4-FFF2-40B4-BE49-F238E27FC236}">
-                <a16:creationId xmlns:a16="http://schemas.microsoft.com/office/drawing/2014/main" id="{45FE5266-6EE1-4F74-9046-5323A21CB242}"/>
+                <a16:creationId xmlns:a16="http://schemas.microsoft.com/office/drawing/2014/main" id="{1C70EBAD-55D8-43F6-8B31-81FB15D3B1A9}"/>
               </a:ext>
             </a:extLst>
           </p:cNvPr>
@@ -27079,7 +27079,7 @@
           <p:cNvPr id="30" name="">
             <a:extLst xmlns:a="http://schemas.openxmlformats.org/drawingml/2006/main">
               <a:ext uri="{FF2B5EF4-FFF2-40B4-BE49-F238E27FC236}">
-                <a16:creationId xmlns:a16="http://schemas.microsoft.com/office/drawing/2014/main" id="{31E39309-1B2E-435B-8056-12DF5B89CB96}"/>
+                <a16:creationId xmlns:a16="http://schemas.microsoft.com/office/drawing/2014/main" id="{539146E0-32BA-4F6A-8A42-55CD9861B301}"/>
               </a:ext>
             </a:extLst>
           </p:cNvPr>
@@ -27136,7 +27136,7 @@
           <p:cNvPr id="31" name="">
             <a:extLst xmlns:a="http://schemas.openxmlformats.org/drawingml/2006/main">
               <a:ext uri="{FF2B5EF4-FFF2-40B4-BE49-F238E27FC236}">
-                <a16:creationId xmlns:a16="http://schemas.microsoft.com/office/drawing/2014/main" id="{D82695D2-25C6-4CB4-AB2D-FD3A30607DF8}"/>
+                <a16:creationId xmlns:a16="http://schemas.microsoft.com/office/drawing/2014/main" id="{256FD84E-5225-40F3-8B96-A707D85C24E4}"/>
               </a:ext>
             </a:extLst>
           </p:cNvPr>
@@ -27191,7 +27191,7 @@
     </p:spTree>
     <p:extLst>
       <p:ext uri="{BB962C8B-B14F-4D97-AF65-F5344CB8AC3E}">
-        <p14:creationId xmlns:p14="http://schemas.microsoft.com/office/powerpoint/2010/main" val="637884542"/>
+        <p14:creationId xmlns:p14="http://schemas.microsoft.com/office/powerpoint/2010/main" val="1686489309"/>
       </p:ext>
     </p:extLst>
   </p:cSld>
@@ -27222,7 +27222,7 @@
           <p:cNvPr id="35" name="">
             <a:extLst xmlns:a="http://schemas.openxmlformats.org/drawingml/2006/main">
               <a:ext uri="{FF2B5EF4-FFF2-40B4-BE49-F238E27FC236}">
-                <a16:creationId xmlns:a16="http://schemas.microsoft.com/office/drawing/2014/main" id="{1B87452D-A0C8-48E1-A6D6-8886E065D054}"/>
+                <a16:creationId xmlns:a16="http://schemas.microsoft.com/office/drawing/2014/main" id="{027AD5CF-4B35-48C1-8665-7EB1620F1E12}"/>
               </a:ext>
             </a:extLst>
           </p:cNvPr>
@@ -27279,7 +27279,7 @@
           <p:cNvPr id="2" name="">
             <a:extLst xmlns:a="http://schemas.openxmlformats.org/drawingml/2006/main">
               <a:ext uri="{FF2B5EF4-FFF2-40B4-BE49-F238E27FC236}">
-                <a16:creationId xmlns:a16="http://schemas.microsoft.com/office/drawing/2014/main" id="{0F071BBB-FAE7-4A3C-9797-9C57F1A8519B}"/>
+                <a16:creationId xmlns:a16="http://schemas.microsoft.com/office/drawing/2014/main" id="{39E9C270-32FB-42D6-B96E-3E844B7EA278}"/>
               </a:ext>
             </a:extLst>
           </p:cNvPr>
@@ -27310,7 +27310,7 @@
           <p:cNvPr id="3" name="">
             <a:extLst xmlns:a="http://schemas.openxmlformats.org/drawingml/2006/main">
               <a:ext uri="{FF2B5EF4-FFF2-40B4-BE49-F238E27FC236}">
-                <a16:creationId xmlns:a16="http://schemas.microsoft.com/office/drawing/2014/main" id="{3EF7B18D-4502-4F30-AC3F-63E50834D758}"/>
+                <a16:creationId xmlns:a16="http://schemas.microsoft.com/office/drawing/2014/main" id="{24D6E4DF-3E00-4EF3-A2DE-49507443E59D}"/>
               </a:ext>
             </a:extLst>
           </p:cNvPr>
@@ -27367,7 +27367,7 @@
           <p:cNvPr id="4" name="">
             <a:extLst xmlns:a="http://schemas.openxmlformats.org/drawingml/2006/main">
               <a:ext uri="{FF2B5EF4-FFF2-40B4-BE49-F238E27FC236}">
-                <a16:creationId xmlns:a16="http://schemas.microsoft.com/office/drawing/2014/main" id="{3A7BECB4-A87F-4C40-BA22-90F8F524095F}"/>
+                <a16:creationId xmlns:a16="http://schemas.microsoft.com/office/drawing/2014/main" id="{8E2641A1-04BA-42B4-9FB9-E8F961617BBE}"/>
               </a:ext>
             </a:extLst>
           </p:cNvPr>
@@ -27424,7 +27424,7 @@
           <p:cNvPr id="5" name="">
             <a:extLst xmlns:a="http://schemas.openxmlformats.org/drawingml/2006/main">
               <a:ext uri="{FF2B5EF4-FFF2-40B4-BE49-F238E27FC236}">
-                <a16:creationId xmlns:a16="http://schemas.microsoft.com/office/drawing/2014/main" id="{93ED601E-F665-4134-B304-70425798C66D}"/>
+                <a16:creationId xmlns:a16="http://schemas.microsoft.com/office/drawing/2014/main" id="{6C5430E3-7834-4E1C-B50F-6C7B1D93FA78}"/>
               </a:ext>
             </a:extLst>
           </p:cNvPr>
@@ -27481,7 +27481,7 @@
           <p:cNvPr id="6" name="">
             <a:extLst xmlns:a="http://schemas.openxmlformats.org/drawingml/2006/main">
               <a:ext uri="{FF2B5EF4-FFF2-40B4-BE49-F238E27FC236}">
-                <a16:creationId xmlns:a16="http://schemas.microsoft.com/office/drawing/2014/main" id="{C2E5FADD-1FBA-40E2-B8EE-413DD9DBC998}"/>
+                <a16:creationId xmlns:a16="http://schemas.microsoft.com/office/drawing/2014/main" id="{963B3263-7C0F-42CE-A4F2-FB524FD09C07}"/>
               </a:ext>
             </a:extLst>
           </p:cNvPr>
@@ -27538,7 +27538,7 @@
           <p:cNvPr id="7" name="">
             <a:extLst xmlns:a="http://schemas.openxmlformats.org/drawingml/2006/main">
               <a:ext uri="{FF2B5EF4-FFF2-40B4-BE49-F238E27FC236}">
-                <a16:creationId xmlns:a16="http://schemas.microsoft.com/office/drawing/2014/main" id="{92EF5FC8-B166-422A-B48F-15C272238BBF}"/>
+                <a16:creationId xmlns:a16="http://schemas.microsoft.com/office/drawing/2014/main" id="{F580E137-7388-476F-9908-F0E9C2E7F98F}"/>
               </a:ext>
             </a:extLst>
           </p:cNvPr>
@@ -27595,7 +27595,7 @@
           <p:cNvPr id="8" name="">
             <a:extLst xmlns:a="http://schemas.openxmlformats.org/drawingml/2006/main">
               <a:ext uri="{FF2B5EF4-FFF2-40B4-BE49-F238E27FC236}">
-                <a16:creationId xmlns:a16="http://schemas.microsoft.com/office/drawing/2014/main" id="{319EC1A8-A73B-4A15-B1DA-127ABBA9003C}"/>
+                <a16:creationId xmlns:a16="http://schemas.microsoft.com/office/drawing/2014/main" id="{827F9455-9819-4F1B-921D-3B191D7432CC}"/>
               </a:ext>
             </a:extLst>
           </p:cNvPr>
@@ -27652,7 +27652,7 @@
           <p:cNvPr id="9" name="">
             <a:extLst xmlns:a="http://schemas.openxmlformats.org/drawingml/2006/main">
               <a:ext uri="{FF2B5EF4-FFF2-40B4-BE49-F238E27FC236}">
-                <a16:creationId xmlns:a16="http://schemas.microsoft.com/office/drawing/2014/main" id="{E4040546-1C60-4065-862F-B9E27100263B}"/>
+                <a16:creationId xmlns:a16="http://schemas.microsoft.com/office/drawing/2014/main" id="{6C38F2A9-F223-4042-ABCA-091EABFE97E4}"/>
               </a:ext>
             </a:extLst>
           </p:cNvPr>
@@ -27709,7 +27709,7 @@
           <p:cNvPr id="10" name="">
             <a:extLst xmlns:a="http://schemas.openxmlformats.org/drawingml/2006/main">
               <a:ext uri="{FF2B5EF4-FFF2-40B4-BE49-F238E27FC236}">
-                <a16:creationId xmlns:a16="http://schemas.microsoft.com/office/drawing/2014/main" id="{0A220C4D-18B8-44CB-B82D-73B8760BEFF4}"/>
+                <a16:creationId xmlns:a16="http://schemas.microsoft.com/office/drawing/2014/main" id="{103BF9B1-8D72-4F55-B2BA-16C2728E23B2}"/>
               </a:ext>
             </a:extLst>
           </p:cNvPr>
@@ -27740,7 +27740,7 @@
           <p:cNvPr id="11" name="">
             <a:extLst xmlns:a="http://schemas.openxmlformats.org/drawingml/2006/main">
               <a:ext uri="{FF2B5EF4-FFF2-40B4-BE49-F238E27FC236}">
-                <a16:creationId xmlns:a16="http://schemas.microsoft.com/office/drawing/2014/main" id="{C20B61C6-EAB7-48D9-B849-C2CA3F9BE65D}"/>
+                <a16:creationId xmlns:a16="http://schemas.microsoft.com/office/drawing/2014/main" id="{9183152E-C4C6-45C1-BD49-69D261C38476}"/>
               </a:ext>
             </a:extLst>
           </p:cNvPr>
@@ -27771,7 +27771,7 @@
           <p:cNvPr id="12" name="">
             <a:extLst xmlns:a="http://schemas.openxmlformats.org/drawingml/2006/main">
               <a:ext uri="{FF2B5EF4-FFF2-40B4-BE49-F238E27FC236}">
-                <a16:creationId xmlns:a16="http://schemas.microsoft.com/office/drawing/2014/main" id="{C66AA8AB-C294-44DE-B620-F9FC55AA49AA}"/>
+                <a16:creationId xmlns:a16="http://schemas.microsoft.com/office/drawing/2014/main" id="{BC43FFE6-BDC5-4C13-BFAE-123FE3277878}"/>
               </a:ext>
             </a:extLst>
           </p:cNvPr>
@@ -27804,7 +27804,7 @@
           <p:cNvPr id="13" name="">
             <a:extLst xmlns:a="http://schemas.openxmlformats.org/drawingml/2006/main">
               <a:ext uri="{FF2B5EF4-FFF2-40B4-BE49-F238E27FC236}">
-                <a16:creationId xmlns:a16="http://schemas.microsoft.com/office/drawing/2014/main" id="{567D7DFD-3245-47E3-B7AF-DF25853242D0}"/>
+                <a16:creationId xmlns:a16="http://schemas.microsoft.com/office/drawing/2014/main" id="{43CC66CE-2A09-4117-8745-4D60CFF5366F}"/>
               </a:ext>
             </a:extLst>
           </p:cNvPr>
@@ -27861,7 +27861,7 @@
           <p:cNvPr id="14" name="">
             <a:extLst xmlns:a="http://schemas.openxmlformats.org/drawingml/2006/main">
               <a:ext uri="{FF2B5EF4-FFF2-40B4-BE49-F238E27FC236}">
-                <a16:creationId xmlns:a16="http://schemas.microsoft.com/office/drawing/2014/main" id="{408F2386-C01C-424E-9713-CA6F0086EC5E}"/>
+                <a16:creationId xmlns:a16="http://schemas.microsoft.com/office/drawing/2014/main" id="{4B75E753-6868-44CF-AF8E-49764C1F798A}"/>
               </a:ext>
             </a:extLst>
           </p:cNvPr>
@@ -27894,7 +27894,7 @@
           <p:cNvPr id="15" name="">
             <a:extLst xmlns:a="http://schemas.openxmlformats.org/drawingml/2006/main">
               <a:ext uri="{FF2B5EF4-FFF2-40B4-BE49-F238E27FC236}">
-                <a16:creationId xmlns:a16="http://schemas.microsoft.com/office/drawing/2014/main" id="{01E5C8D1-CDD4-4C50-BCFD-F9083912A72C}"/>
+                <a16:creationId xmlns:a16="http://schemas.microsoft.com/office/drawing/2014/main" id="{4467089B-3833-4849-85AE-4402A357C9C5}"/>
               </a:ext>
             </a:extLst>
           </p:cNvPr>
@@ -27927,7 +27927,7 @@
           <p:cNvPr id="16" name="">
             <a:extLst xmlns:a="http://schemas.openxmlformats.org/drawingml/2006/main">
               <a:ext uri="{FF2B5EF4-FFF2-40B4-BE49-F238E27FC236}">
-                <a16:creationId xmlns:a16="http://schemas.microsoft.com/office/drawing/2014/main" id="{E1859E8D-8CF4-4F6E-B2BA-3DE647010F35}"/>
+                <a16:creationId xmlns:a16="http://schemas.microsoft.com/office/drawing/2014/main" id="{794E76F9-E99D-4F76-9CFB-963066E412B1}"/>
               </a:ext>
             </a:extLst>
           </p:cNvPr>
@@ -27960,7 +27960,7 @@
           <p:cNvPr id="17" name="">
             <a:extLst xmlns:a="http://schemas.openxmlformats.org/drawingml/2006/main">
               <a:ext uri="{FF2B5EF4-FFF2-40B4-BE49-F238E27FC236}">
-                <a16:creationId xmlns:a16="http://schemas.microsoft.com/office/drawing/2014/main" id="{D2132758-98F0-42F3-B79B-F496DF9BC18C}"/>
+                <a16:creationId xmlns:a16="http://schemas.microsoft.com/office/drawing/2014/main" id="{007AC055-6707-4BD3-8513-061D61CFBFC5}"/>
               </a:ext>
             </a:extLst>
           </p:cNvPr>
@@ -27993,7 +27993,7 @@
           <p:cNvPr id="18" name="">
             <a:extLst xmlns:a="http://schemas.openxmlformats.org/drawingml/2006/main">
               <a:ext uri="{FF2B5EF4-FFF2-40B4-BE49-F238E27FC236}">
-                <a16:creationId xmlns:a16="http://schemas.microsoft.com/office/drawing/2014/main" id="{6DB913CB-1225-4D8E-920D-90B2411E2B3A}"/>
+                <a16:creationId xmlns:a16="http://schemas.microsoft.com/office/drawing/2014/main" id="{55D8F64F-042A-4F5A-8133-A8D10F3E925B}"/>
               </a:ext>
             </a:extLst>
           </p:cNvPr>
@@ -28026,7 +28026,7 @@
           <p:cNvPr id="19" name="">
             <a:extLst xmlns:a="http://schemas.openxmlformats.org/drawingml/2006/main">
               <a:ext uri="{FF2B5EF4-FFF2-40B4-BE49-F238E27FC236}">
-                <a16:creationId xmlns:a16="http://schemas.microsoft.com/office/drawing/2014/main" id="{454CFD10-A69C-43CF-AEF9-CDEFB318DFFF}"/>
+                <a16:creationId xmlns:a16="http://schemas.microsoft.com/office/drawing/2014/main" id="{7D81B7EC-8348-41AE-B5D7-2CD42A1343C4}"/>
               </a:ext>
             </a:extLst>
           </p:cNvPr>
@@ -28059,7 +28059,7 @@
           <p:cNvPr id="20" name="">
             <a:extLst xmlns:a="http://schemas.openxmlformats.org/drawingml/2006/main">
               <a:ext uri="{FF2B5EF4-FFF2-40B4-BE49-F238E27FC236}">
-                <a16:creationId xmlns:a16="http://schemas.microsoft.com/office/drawing/2014/main" id="{AB5F629B-930E-4379-B30A-4D5531988CE4}"/>
+                <a16:creationId xmlns:a16="http://schemas.microsoft.com/office/drawing/2014/main" id="{6B4D827B-FC31-4B19-98F6-6AE80E0FA142}"/>
               </a:ext>
             </a:extLst>
           </p:cNvPr>
@@ -28092,7 +28092,7 @@
           <p:cNvPr id="21" name="">
             <a:extLst xmlns:a="http://schemas.openxmlformats.org/drawingml/2006/main">
               <a:ext uri="{FF2B5EF4-FFF2-40B4-BE49-F238E27FC236}">
-                <a16:creationId xmlns:a16="http://schemas.microsoft.com/office/drawing/2014/main" id="{B7F10701-502F-4E3A-93E3-9A4A6CA20209}"/>
+                <a16:creationId xmlns:a16="http://schemas.microsoft.com/office/drawing/2014/main" id="{6EE250B4-226A-407D-B7F9-E35DE10A56D0}"/>
               </a:ext>
             </a:extLst>
           </p:cNvPr>
@@ -28125,7 +28125,7 @@
           <p:cNvPr id="22" name="">
             <a:extLst xmlns:a="http://schemas.openxmlformats.org/drawingml/2006/main">
               <a:ext uri="{FF2B5EF4-FFF2-40B4-BE49-F238E27FC236}">
-                <a16:creationId xmlns:a16="http://schemas.microsoft.com/office/drawing/2014/main" id="{4EF8C2F4-1BF7-4822-BE68-9B5BA83D580B}"/>
+                <a16:creationId xmlns:a16="http://schemas.microsoft.com/office/drawing/2014/main" id="{F9ED95BE-690A-4935-A44F-9D266B736EF7}"/>
               </a:ext>
             </a:extLst>
           </p:cNvPr>
@@ -28158,7 +28158,7 @@
           <p:cNvPr id="23" name="">
             <a:extLst xmlns:a="http://schemas.openxmlformats.org/drawingml/2006/main">
               <a:ext uri="{FF2B5EF4-FFF2-40B4-BE49-F238E27FC236}">
-                <a16:creationId xmlns:a16="http://schemas.microsoft.com/office/drawing/2014/main" id="{A3887DE5-17AC-4AE7-B333-32725B53C017}"/>
+                <a16:creationId xmlns:a16="http://schemas.microsoft.com/office/drawing/2014/main" id="{637137B1-BA1E-4531-8DB3-03D141663AC5}"/>
               </a:ext>
             </a:extLst>
           </p:cNvPr>
@@ -28191,7 +28191,7 @@
           <p:cNvPr id="24" name="">
             <a:extLst xmlns:a="http://schemas.openxmlformats.org/drawingml/2006/main">
               <a:ext uri="{FF2B5EF4-FFF2-40B4-BE49-F238E27FC236}">
-                <a16:creationId xmlns:a16="http://schemas.microsoft.com/office/drawing/2014/main" id="{EA19B4A4-A46F-4538-89F4-C0137B997F60}"/>
+                <a16:creationId xmlns:a16="http://schemas.microsoft.com/office/drawing/2014/main" id="{0FFF65FC-AB00-4C35-BE9C-B0F2A5BFD2DD}"/>
               </a:ext>
             </a:extLst>
           </p:cNvPr>
@@ -28224,7 +28224,7 @@
           <p:cNvPr id="25" name="">
             <a:extLst xmlns:a="http://schemas.openxmlformats.org/drawingml/2006/main">
               <a:ext uri="{FF2B5EF4-FFF2-40B4-BE49-F238E27FC236}">
-                <a16:creationId xmlns:a16="http://schemas.microsoft.com/office/drawing/2014/main" id="{CB02C254-0CCF-4113-B248-BB9EDEEB5FAB}"/>
+                <a16:creationId xmlns:a16="http://schemas.microsoft.com/office/drawing/2014/main" id="{47D92507-B5C4-4105-9143-BD35426DA043}"/>
               </a:ext>
             </a:extLst>
           </p:cNvPr>
@@ -28255,7 +28255,7 @@
           <p:cNvPr id="26" name="">
             <a:extLst xmlns:a="http://schemas.openxmlformats.org/drawingml/2006/main">
               <a:ext uri="{FF2B5EF4-FFF2-40B4-BE49-F238E27FC236}">
-                <a16:creationId xmlns:a16="http://schemas.microsoft.com/office/drawing/2014/main" id="{4F784E1B-0962-4B46-B53C-03EBFB8059AD}"/>
+                <a16:creationId xmlns:a16="http://schemas.microsoft.com/office/drawing/2014/main" id="{2B340D92-7A2A-4B93-B2D2-8C5D29729BBE}"/>
               </a:ext>
             </a:extLst>
           </p:cNvPr>
@@ -28312,7 +28312,7 @@
           <p:cNvPr id="27" name="">
             <a:extLst xmlns:a="http://schemas.openxmlformats.org/drawingml/2006/main">
               <a:ext uri="{FF2B5EF4-FFF2-40B4-BE49-F238E27FC236}">
-                <a16:creationId xmlns:a16="http://schemas.microsoft.com/office/drawing/2014/main" id="{B1C0CEDD-9567-48C2-8811-A6B9BA1AA217}"/>
+                <a16:creationId xmlns:a16="http://schemas.microsoft.com/office/drawing/2014/main" id="{7533BD27-1176-4945-8C39-01CBAF724368}"/>
               </a:ext>
             </a:extLst>
           </p:cNvPr>
@@ -28369,7 +28369,7 @@
           <p:cNvPr id="28" name="">
             <a:extLst xmlns:a="http://schemas.openxmlformats.org/drawingml/2006/main">
               <a:ext uri="{FF2B5EF4-FFF2-40B4-BE49-F238E27FC236}">
-                <a16:creationId xmlns:a16="http://schemas.microsoft.com/office/drawing/2014/main" id="{5E8B6465-515D-4776-ABEF-3D9E25DD70C8}"/>
+                <a16:creationId xmlns:a16="http://schemas.microsoft.com/office/drawing/2014/main" id="{E0932ACB-2053-46E0-ABAE-A8EF8B91FE85}"/>
               </a:ext>
             </a:extLst>
           </p:cNvPr>
@@ -28426,7 +28426,7 @@
           <p:cNvPr id="29" name="">
             <a:extLst xmlns:a="http://schemas.openxmlformats.org/drawingml/2006/main">
               <a:ext uri="{FF2B5EF4-FFF2-40B4-BE49-F238E27FC236}">
-                <a16:creationId xmlns:a16="http://schemas.microsoft.com/office/drawing/2014/main" id="{42FA0EEC-CEF0-4DB0-948B-B1D0EA0F005F}"/>
+                <a16:creationId xmlns:a16="http://schemas.microsoft.com/office/drawing/2014/main" id="{940E5FBD-D575-4A11-B45E-F1D4C8012E41}"/>
               </a:ext>
             </a:extLst>
           </p:cNvPr>
@@ -28483,7 +28483,7 @@
           <p:cNvPr id="30" name="">
             <a:extLst xmlns:a="http://schemas.openxmlformats.org/drawingml/2006/main">
               <a:ext uri="{FF2B5EF4-FFF2-40B4-BE49-F238E27FC236}">
-                <a16:creationId xmlns:a16="http://schemas.microsoft.com/office/drawing/2014/main" id="{EDAE2F33-BC79-430F-AD78-057DD0E263B5}"/>
+                <a16:creationId xmlns:a16="http://schemas.microsoft.com/office/drawing/2014/main" id="{796CA344-D56E-4C0A-9677-D010091DD667}"/>
               </a:ext>
             </a:extLst>
           </p:cNvPr>
@@ -28540,7 +28540,7 @@
           <p:cNvPr id="31" name="">
             <a:extLst xmlns:a="http://schemas.openxmlformats.org/drawingml/2006/main">
               <a:ext uri="{FF2B5EF4-FFF2-40B4-BE49-F238E27FC236}">
-                <a16:creationId xmlns:a16="http://schemas.microsoft.com/office/drawing/2014/main" id="{A2B7D5AD-5FFB-4B12-9EEB-B7FE43DA26E9}"/>
+                <a16:creationId xmlns:a16="http://schemas.microsoft.com/office/drawing/2014/main" id="{F2B352B5-8201-42E4-B069-4748DA0A7E7B}"/>
               </a:ext>
             </a:extLst>
           </p:cNvPr>
@@ -28571,7 +28571,7 @@
           <p:cNvPr id="32" name="">
             <a:extLst xmlns:a="http://schemas.openxmlformats.org/drawingml/2006/main">
               <a:ext uri="{FF2B5EF4-FFF2-40B4-BE49-F238E27FC236}">
-                <a16:creationId xmlns:a16="http://schemas.microsoft.com/office/drawing/2014/main" id="{41A1D022-BDE7-4070-8ED3-8EDD70779285}"/>
+                <a16:creationId xmlns:a16="http://schemas.microsoft.com/office/drawing/2014/main" id="{E8F4C9C0-B83F-4A91-9ABA-5710F2475B31}"/>
               </a:ext>
             </a:extLst>
           </p:cNvPr>
@@ -28651,7 +28651,7 @@
           <p:cNvPr id="33" name="">
             <a:extLst xmlns:a="http://schemas.openxmlformats.org/drawingml/2006/main">
               <a:ext uri="{FF2B5EF4-FFF2-40B4-BE49-F238E27FC236}">
-                <a16:creationId xmlns:a16="http://schemas.microsoft.com/office/drawing/2014/main" id="{12764EEB-3184-4FC9-8A85-5762F177A6DF}"/>
+                <a16:creationId xmlns:a16="http://schemas.microsoft.com/office/drawing/2014/main" id="{E4D30C3D-6786-446A-A789-146D7172FF53}"/>
               </a:ext>
             </a:extLst>
           </p:cNvPr>
@@ -28708,7 +28708,7 @@
           <p:cNvPr id="34" name="">
             <a:extLst xmlns:a="http://schemas.openxmlformats.org/drawingml/2006/main">
               <a:ext uri="{FF2B5EF4-FFF2-40B4-BE49-F238E27FC236}">
-                <a16:creationId xmlns:a16="http://schemas.microsoft.com/office/drawing/2014/main" id="{F6B8442C-5836-4AD0-A1DD-6215E9FB9AB9}"/>
+                <a16:creationId xmlns:a16="http://schemas.microsoft.com/office/drawing/2014/main" id="{F34D82E6-EE8D-4D08-B9FC-FD7DED291172}"/>
               </a:ext>
             </a:extLst>
           </p:cNvPr>
@@ -28763,7 +28763,7 @@
     </p:spTree>
     <p:extLst>
       <p:ext uri="{BB962C8B-B14F-4D97-AF65-F5344CB8AC3E}">
-        <p14:creationId xmlns:p14="http://schemas.microsoft.com/office/powerpoint/2010/main" val="794678658"/>
+        <p14:creationId xmlns:p14="http://schemas.microsoft.com/office/powerpoint/2010/main" val="645092531"/>
       </p:ext>
     </p:extLst>
   </p:cSld>
@@ -28820,7 +28820,7 @@
           <p:cNvPr id="53" name="">
             <a:extLst xmlns:a="http://schemas.openxmlformats.org/drawingml/2006/main">
               <a:ext uri="{FF2B5EF4-FFF2-40B4-BE49-F238E27FC236}">
-                <a16:creationId xmlns:a16="http://schemas.microsoft.com/office/drawing/2014/main" id="{CA662135-362B-4590-9F58-9F28E40AE865}"/>
+                <a16:creationId xmlns:a16="http://schemas.microsoft.com/office/drawing/2014/main" id="{513142D7-0D47-4C16-A2B0-6D48E01A688F}"/>
               </a:ext>
             </a:extLst>
           </p:cNvPr>
@@ -28877,7 +28877,7 @@
           <p:cNvPr id="2" name="">
             <a:extLst xmlns:a="http://schemas.openxmlformats.org/drawingml/2006/main">
               <a:ext uri="{FF2B5EF4-FFF2-40B4-BE49-F238E27FC236}">
-                <a16:creationId xmlns:a16="http://schemas.microsoft.com/office/drawing/2014/main" id="{7D6B736C-F2EA-48A5-A6D9-4124EB1E6AD0}"/>
+                <a16:creationId xmlns:a16="http://schemas.microsoft.com/office/drawing/2014/main" id="{40570848-A269-43BD-9274-8A86C6CF0DDA}"/>
               </a:ext>
             </a:extLst>
           </p:cNvPr>
@@ -28908,7 +28908,7 @@
           <p:cNvPr id="3" name="">
             <a:extLst xmlns:a="http://schemas.openxmlformats.org/drawingml/2006/main">
               <a:ext uri="{FF2B5EF4-FFF2-40B4-BE49-F238E27FC236}">
-                <a16:creationId xmlns:a16="http://schemas.microsoft.com/office/drawing/2014/main" id="{AC55C5C2-32D7-48CE-832E-508D9F63DBFB}"/>
+                <a16:creationId xmlns:a16="http://schemas.microsoft.com/office/drawing/2014/main" id="{D1A5C5D8-5C54-4BC9-927B-10E60C879394}"/>
               </a:ext>
             </a:extLst>
           </p:cNvPr>
@@ -28965,7 +28965,7 @@
           <p:cNvPr id="4" name="">
             <a:extLst xmlns:a="http://schemas.openxmlformats.org/drawingml/2006/main">
               <a:ext uri="{FF2B5EF4-FFF2-40B4-BE49-F238E27FC236}">
-                <a16:creationId xmlns:a16="http://schemas.microsoft.com/office/drawing/2014/main" id="{6B512E54-AC87-4CA7-B930-72E5FA03926D}"/>
+                <a16:creationId xmlns:a16="http://schemas.microsoft.com/office/drawing/2014/main" id="{12D13C8A-2AA9-4647-95ED-96682A5022D8}"/>
               </a:ext>
             </a:extLst>
           </p:cNvPr>
@@ -29022,7 +29022,7 @@
           <p:cNvPr id="5" name="">
             <a:extLst xmlns:a="http://schemas.openxmlformats.org/drawingml/2006/main">
               <a:ext uri="{FF2B5EF4-FFF2-40B4-BE49-F238E27FC236}">
-                <a16:creationId xmlns:a16="http://schemas.microsoft.com/office/drawing/2014/main" id="{67255ADA-2255-4CF6-B7CA-3EC09EC01208}"/>
+                <a16:creationId xmlns:a16="http://schemas.microsoft.com/office/drawing/2014/main" id="{E148C61D-3094-4103-8016-1EF489878AF5}"/>
               </a:ext>
             </a:extLst>
           </p:cNvPr>
@@ -29053,7 +29053,7 @@
           <p:cNvPr id="6" name="">
             <a:extLst xmlns:a="http://schemas.openxmlformats.org/drawingml/2006/main">
               <a:ext uri="{FF2B5EF4-FFF2-40B4-BE49-F238E27FC236}">
-                <a16:creationId xmlns:a16="http://schemas.microsoft.com/office/drawing/2014/main" id="{D42B4C1F-7423-47CA-85CE-88E763C62048}"/>
+                <a16:creationId xmlns:a16="http://schemas.microsoft.com/office/drawing/2014/main" id="{596D99EA-8648-4D63-8A5E-BB1313B8B473}"/>
               </a:ext>
             </a:extLst>
           </p:cNvPr>
@@ -29110,7 +29110,7 @@
           <p:cNvPr id="7" name="">
             <a:extLst xmlns:a="http://schemas.openxmlformats.org/drawingml/2006/main">
               <a:ext uri="{FF2B5EF4-FFF2-40B4-BE49-F238E27FC236}">
-                <a16:creationId xmlns:a16="http://schemas.microsoft.com/office/drawing/2014/main" id="{84E175EF-391E-43DF-9A42-A2585AC483C3}"/>
+                <a16:creationId xmlns:a16="http://schemas.microsoft.com/office/drawing/2014/main" id="{09C4179A-5869-46C8-81F2-D3D841D9D5B2}"/>
               </a:ext>
             </a:extLst>
           </p:cNvPr>
@@ -29143,7 +29143,7 @@
           <p:cNvPr id="8" name="">
             <a:extLst xmlns:a="http://schemas.openxmlformats.org/drawingml/2006/main">
               <a:ext uri="{FF2B5EF4-FFF2-40B4-BE49-F238E27FC236}">
-                <a16:creationId xmlns:a16="http://schemas.microsoft.com/office/drawing/2014/main" id="{AB118EC2-079F-41BC-8E4B-B2E3F3A76257}"/>
+                <a16:creationId xmlns:a16="http://schemas.microsoft.com/office/drawing/2014/main" id="{ECB252E6-3B1D-4BC3-A881-B08A4D285611}"/>
               </a:ext>
             </a:extLst>
           </p:cNvPr>
@@ -29200,7 +29200,7 @@
           <p:cNvPr id="9" name="">
             <a:extLst xmlns:a="http://schemas.openxmlformats.org/drawingml/2006/main">
               <a:ext uri="{FF2B5EF4-FFF2-40B4-BE49-F238E27FC236}">
-                <a16:creationId xmlns:a16="http://schemas.microsoft.com/office/drawing/2014/main" id="{83DDE96C-395A-4944-B4E9-34674DD2F909}"/>
+                <a16:creationId xmlns:a16="http://schemas.microsoft.com/office/drawing/2014/main" id="{264BA04F-5E29-44EA-8D1F-CB80CF05BC97}"/>
               </a:ext>
             </a:extLst>
           </p:cNvPr>
@@ -29233,7 +29233,7 @@
           <p:cNvPr id="10" name="">
             <a:extLst xmlns:a="http://schemas.openxmlformats.org/drawingml/2006/main">
               <a:ext uri="{FF2B5EF4-FFF2-40B4-BE49-F238E27FC236}">
-                <a16:creationId xmlns:a16="http://schemas.microsoft.com/office/drawing/2014/main" id="{A847706B-58D7-4476-9A42-1ACF9981917A}"/>
+                <a16:creationId xmlns:a16="http://schemas.microsoft.com/office/drawing/2014/main" id="{B85C51C9-0AC9-4C24-9965-9F517A3DE551}"/>
               </a:ext>
             </a:extLst>
           </p:cNvPr>
@@ -29290,7 +29290,7 @@
           <p:cNvPr id="12" name="">
             <a:extLst xmlns:a="http://schemas.openxmlformats.org/drawingml/2006/main">
               <a:ext uri="{FF2B5EF4-FFF2-40B4-BE49-F238E27FC236}">
-                <a16:creationId xmlns:a16="http://schemas.microsoft.com/office/drawing/2014/main" id="{EA01150B-AEBE-4E92-A08E-6DCA0C8AACF6}"/>
+                <a16:creationId xmlns:a16="http://schemas.microsoft.com/office/drawing/2014/main" id="{701EF340-1F4B-472A-80F0-A436D8857B85}"/>
               </a:ext>
             </a:extLst>
           </p:cNvPr>
@@ -29321,7 +29321,7 @@
           <p:cNvPr id="13" name="">
             <a:extLst xmlns:a="http://schemas.openxmlformats.org/drawingml/2006/main">
               <a:ext uri="{FF2B5EF4-FFF2-40B4-BE49-F238E27FC236}">
-                <a16:creationId xmlns:a16="http://schemas.microsoft.com/office/drawing/2014/main" id="{9AADF9A8-B98A-4D81-9DFA-494385442F0A}"/>
+                <a16:creationId xmlns:a16="http://schemas.microsoft.com/office/drawing/2014/main" id="{244001B8-7B1E-4F31-8253-F8FD6E2D373B}"/>
               </a:ext>
             </a:extLst>
           </p:cNvPr>
@@ -29352,7 +29352,7 @@
           <p:cNvPr id="14" name="">
             <a:extLst xmlns:a="http://schemas.openxmlformats.org/drawingml/2006/main">
               <a:ext uri="{FF2B5EF4-FFF2-40B4-BE49-F238E27FC236}">
-                <a16:creationId xmlns:a16="http://schemas.microsoft.com/office/drawing/2014/main" id="{345E27AE-6F38-4389-ACA1-FAAF1CC79CDA}"/>
+                <a16:creationId xmlns:a16="http://schemas.microsoft.com/office/drawing/2014/main" id="{C243DC4E-4547-4BF9-BE81-30168565ACE4}"/>
               </a:ext>
             </a:extLst>
           </p:cNvPr>
@@ -29383,7 +29383,7 @@
           <p:cNvPr id="15" name="">
             <a:extLst xmlns:a="http://schemas.openxmlformats.org/drawingml/2006/main">
               <a:ext uri="{FF2B5EF4-FFF2-40B4-BE49-F238E27FC236}">
-                <a16:creationId xmlns:a16="http://schemas.microsoft.com/office/drawing/2014/main" id="{E47FC73C-A098-490F-B431-81465B38D5EB}"/>
+                <a16:creationId xmlns:a16="http://schemas.microsoft.com/office/drawing/2014/main" id="{A7A35EE0-852E-4484-AE34-7C6CD0EB8077}"/>
               </a:ext>
             </a:extLst>
           </p:cNvPr>
@@ -29414,7 +29414,7 @@
           <p:cNvPr id="16" name="">
             <a:extLst xmlns:a="http://schemas.openxmlformats.org/drawingml/2006/main">
               <a:ext uri="{FF2B5EF4-FFF2-40B4-BE49-F238E27FC236}">
-                <a16:creationId xmlns:a16="http://schemas.microsoft.com/office/drawing/2014/main" id="{35B1D974-9D4D-4D36-8022-B2D6C49C2180}"/>
+                <a16:creationId xmlns:a16="http://schemas.microsoft.com/office/drawing/2014/main" id="{FEB487ED-9528-4DBD-901A-690D23294583}"/>
               </a:ext>
             </a:extLst>
           </p:cNvPr>
@@ -29494,7 +29494,7 @@
           <p:cNvPr id="17" name="">
             <a:extLst xmlns:a="http://schemas.openxmlformats.org/drawingml/2006/main">
               <a:ext uri="{FF2B5EF4-FFF2-40B4-BE49-F238E27FC236}">
-                <a16:creationId xmlns:a16="http://schemas.microsoft.com/office/drawing/2014/main" id="{34866C83-08E6-4243-BB10-C0002E68E557}"/>
+                <a16:creationId xmlns:a16="http://schemas.microsoft.com/office/drawing/2014/main" id="{1F7534AE-8779-41FE-840F-C6218BB5D250}"/>
               </a:ext>
             </a:extLst>
           </p:cNvPr>
@@ -29574,7 +29574,7 @@
           <p:cNvPr id="18" name="">
             <a:extLst xmlns:a="http://schemas.openxmlformats.org/drawingml/2006/main">
               <a:ext uri="{FF2B5EF4-FFF2-40B4-BE49-F238E27FC236}">
-                <a16:creationId xmlns:a16="http://schemas.microsoft.com/office/drawing/2014/main" id="{32D0154E-8546-4A34-A718-C2CA0CB70385}"/>
+                <a16:creationId xmlns:a16="http://schemas.microsoft.com/office/drawing/2014/main" id="{37A3300E-2682-4265-B2C8-3B882119516F}"/>
               </a:ext>
             </a:extLst>
           </p:cNvPr>
@@ -29631,7 +29631,7 @@
           <p:cNvPr id="19" name="">
             <a:extLst xmlns:a="http://schemas.openxmlformats.org/drawingml/2006/main">
               <a:ext uri="{FF2B5EF4-FFF2-40B4-BE49-F238E27FC236}">
-                <a16:creationId xmlns:a16="http://schemas.microsoft.com/office/drawing/2014/main" id="{F8ED492D-01F7-4817-B695-0F7D608A4D89}"/>
+                <a16:creationId xmlns:a16="http://schemas.microsoft.com/office/drawing/2014/main" id="{BB6F9419-C26B-4138-BA9D-E6644D5C0749}"/>
               </a:ext>
             </a:extLst>
           </p:cNvPr>
@@ -29688,7 +29688,7 @@
           <p:cNvPr id="20" name="">
             <a:extLst xmlns:a="http://schemas.openxmlformats.org/drawingml/2006/main">
               <a:ext uri="{FF2B5EF4-FFF2-40B4-BE49-F238E27FC236}">
-                <a16:creationId xmlns:a16="http://schemas.microsoft.com/office/drawing/2014/main" id="{D64C3FE7-7FC4-4391-A60B-F527879AA72B}"/>
+                <a16:creationId xmlns:a16="http://schemas.microsoft.com/office/drawing/2014/main" id="{3CB91018-0635-46B8-BF0E-390F84092954}"/>
               </a:ext>
             </a:extLst>
           </p:cNvPr>
@@ -29719,7 +29719,7 @@
           <p:cNvPr id="21" name="">
             <a:extLst xmlns:a="http://schemas.openxmlformats.org/drawingml/2006/main">
               <a:ext uri="{FF2B5EF4-FFF2-40B4-BE49-F238E27FC236}">
-                <a16:creationId xmlns:a16="http://schemas.microsoft.com/office/drawing/2014/main" id="{E57D1708-1F02-4EFF-B905-EAF4A9A03B0F}"/>
+                <a16:creationId xmlns:a16="http://schemas.microsoft.com/office/drawing/2014/main" id="{610C1865-D9F6-4585-AD2D-57A56ED83D14}"/>
               </a:ext>
             </a:extLst>
           </p:cNvPr>
@@ -29750,7 +29750,7 @@
           <p:cNvPr id="22" name="">
             <a:extLst xmlns:a="http://schemas.openxmlformats.org/drawingml/2006/main">
               <a:ext uri="{FF2B5EF4-FFF2-40B4-BE49-F238E27FC236}">
-                <a16:creationId xmlns:a16="http://schemas.microsoft.com/office/drawing/2014/main" id="{ACF08BBA-7670-4205-A2E9-431615CDD979}"/>
+                <a16:creationId xmlns:a16="http://schemas.microsoft.com/office/drawing/2014/main" id="{298DF2B7-C07D-42E7-8014-5C9D6EEB0B61}"/>
               </a:ext>
             </a:extLst>
           </p:cNvPr>
@@ -29781,7 +29781,7 @@
           <p:cNvPr id="23" name="">
             <a:extLst xmlns:a="http://schemas.openxmlformats.org/drawingml/2006/main">
               <a:ext uri="{FF2B5EF4-FFF2-40B4-BE49-F238E27FC236}">
-                <a16:creationId xmlns:a16="http://schemas.microsoft.com/office/drawing/2014/main" id="{B8347EB5-2595-4928-918A-AB5B443A133C}"/>
+                <a16:creationId xmlns:a16="http://schemas.microsoft.com/office/drawing/2014/main" id="{D3B3268B-788A-44C9-94F1-DD565411F270}"/>
               </a:ext>
             </a:extLst>
           </p:cNvPr>
@@ -29812,7 +29812,7 @@
           <p:cNvPr id="24" name="">
             <a:extLst xmlns:a="http://schemas.openxmlformats.org/drawingml/2006/main">
               <a:ext uri="{FF2B5EF4-FFF2-40B4-BE49-F238E27FC236}">
-                <a16:creationId xmlns:a16="http://schemas.microsoft.com/office/drawing/2014/main" id="{5C7CA0A4-D4EC-4402-A6D6-C382126698B4}"/>
+                <a16:creationId xmlns:a16="http://schemas.microsoft.com/office/drawing/2014/main" id="{2AC5018C-62C3-48AB-A532-6F3DEA693D63}"/>
               </a:ext>
             </a:extLst>
           </p:cNvPr>
@@ -29843,7 +29843,7 @@
           <p:cNvPr id="25" name="">
             <a:extLst xmlns:a="http://schemas.openxmlformats.org/drawingml/2006/main">
               <a:ext uri="{FF2B5EF4-FFF2-40B4-BE49-F238E27FC236}">
-                <a16:creationId xmlns:a16="http://schemas.microsoft.com/office/drawing/2014/main" id="{62413687-92F8-46DF-9A69-2478D8E14190}"/>
+                <a16:creationId xmlns:a16="http://schemas.microsoft.com/office/drawing/2014/main" id="{02388104-2CB3-494E-ABD0-7E73F2D532C4}"/>
               </a:ext>
             </a:extLst>
           </p:cNvPr>
@@ -29874,7 +29874,7 @@
           <p:cNvPr id="26" name="">
             <a:extLst xmlns:a="http://schemas.openxmlformats.org/drawingml/2006/main">
               <a:ext uri="{FF2B5EF4-FFF2-40B4-BE49-F238E27FC236}">
-                <a16:creationId xmlns:a16="http://schemas.microsoft.com/office/drawing/2014/main" id="{5B0D2FC1-C6DD-4F13-8A79-E5959B40B7FA}"/>
+                <a16:creationId xmlns:a16="http://schemas.microsoft.com/office/drawing/2014/main" id="{A61ED211-690F-48FB-B67D-4EA06772726F}"/>
               </a:ext>
             </a:extLst>
           </p:cNvPr>
@@ -29905,7 +29905,7 @@
           <p:cNvPr id="27" name="">
             <a:extLst xmlns:a="http://schemas.openxmlformats.org/drawingml/2006/main">
               <a:ext uri="{FF2B5EF4-FFF2-40B4-BE49-F238E27FC236}">
-                <a16:creationId xmlns:a16="http://schemas.microsoft.com/office/drawing/2014/main" id="{8C1FFFF8-45DC-468D-8330-4FF1AC6139B4}"/>
+                <a16:creationId xmlns:a16="http://schemas.microsoft.com/office/drawing/2014/main" id="{97E86127-A38E-4B5D-8339-9BFE4072A2ED}"/>
               </a:ext>
             </a:extLst>
           </p:cNvPr>
@@ -29936,7 +29936,7 @@
           <p:cNvPr id="28" name="">
             <a:extLst xmlns:a="http://schemas.openxmlformats.org/drawingml/2006/main">
               <a:ext uri="{FF2B5EF4-FFF2-40B4-BE49-F238E27FC236}">
-                <a16:creationId xmlns:a16="http://schemas.microsoft.com/office/drawing/2014/main" id="{B2C4A3B4-C77C-4DBD-BE0E-2BBAD1E00DE0}"/>
+                <a16:creationId xmlns:a16="http://schemas.microsoft.com/office/drawing/2014/main" id="{E0126A5C-85D3-45B8-AA01-DB5CE0773A79}"/>
               </a:ext>
             </a:extLst>
           </p:cNvPr>
@@ -29967,7 +29967,7 @@
           <p:cNvPr id="29" name="">
             <a:extLst xmlns:a="http://schemas.openxmlformats.org/drawingml/2006/main">
               <a:ext uri="{FF2B5EF4-FFF2-40B4-BE49-F238E27FC236}">
-                <a16:creationId xmlns:a16="http://schemas.microsoft.com/office/drawing/2014/main" id="{8E747E15-1B90-4B58-96B6-94FF3787EBEC}"/>
+                <a16:creationId xmlns:a16="http://schemas.microsoft.com/office/drawing/2014/main" id="{FE159F45-DB5F-47F7-BB7C-A42274DB4F72}"/>
               </a:ext>
             </a:extLst>
           </p:cNvPr>
@@ -29998,7 +29998,7 @@
           <p:cNvPr id="30" name="">
             <a:extLst xmlns:a="http://schemas.openxmlformats.org/drawingml/2006/main">
               <a:ext uri="{FF2B5EF4-FFF2-40B4-BE49-F238E27FC236}">
-                <a16:creationId xmlns:a16="http://schemas.microsoft.com/office/drawing/2014/main" id="{46BAFC4F-A32D-4A1C-958F-A612C7FA52AB}"/>
+                <a16:creationId xmlns:a16="http://schemas.microsoft.com/office/drawing/2014/main" id="{3DD8BE8D-FFB9-4FCB-9129-263575DD1B9E}"/>
               </a:ext>
             </a:extLst>
           </p:cNvPr>
@@ -30047,7 +30047,7 @@
           <p:cNvPr id="31" name="">
             <a:extLst xmlns:a="http://schemas.openxmlformats.org/drawingml/2006/main">
               <a:ext uri="{FF2B5EF4-FFF2-40B4-BE49-F238E27FC236}">
-                <a16:creationId xmlns:a16="http://schemas.microsoft.com/office/drawing/2014/main" id="{DE798E46-1080-4B07-9E86-08288B5B83BF}"/>
+                <a16:creationId xmlns:a16="http://schemas.microsoft.com/office/drawing/2014/main" id="{F9F98C83-1BD6-4814-AAA2-6DAAE6C29426}"/>
               </a:ext>
             </a:extLst>
           </p:cNvPr>
@@ -30096,7 +30096,7 @@
           <p:cNvPr id="32" name="">
             <a:extLst xmlns:a="http://schemas.openxmlformats.org/drawingml/2006/main">
               <a:ext uri="{FF2B5EF4-FFF2-40B4-BE49-F238E27FC236}">
-                <a16:creationId xmlns:a16="http://schemas.microsoft.com/office/drawing/2014/main" id="{43F9D73D-5545-4857-8FE8-E93359B52926}"/>
+                <a16:creationId xmlns:a16="http://schemas.microsoft.com/office/drawing/2014/main" id="{7890D6B4-12D4-41B3-A2CD-E369DF192C42}"/>
               </a:ext>
             </a:extLst>
           </p:cNvPr>
@@ -30153,7 +30153,7 @@
           <p:cNvPr id="33" name="">
             <a:extLst xmlns:a="http://schemas.openxmlformats.org/drawingml/2006/main">
               <a:ext uri="{FF2B5EF4-FFF2-40B4-BE49-F238E27FC236}">
-                <a16:creationId xmlns:a16="http://schemas.microsoft.com/office/drawing/2014/main" id="{9F967C45-A0C0-4CC5-8BAD-6F3F34FBB49E}"/>
+                <a16:creationId xmlns:a16="http://schemas.microsoft.com/office/drawing/2014/main" id="{F6E1B97D-6543-4543-96CD-4E3E8DA95805}"/>
               </a:ext>
             </a:extLst>
           </p:cNvPr>
@@ -30210,7 +30210,7 @@
           <p:cNvPr id="34" name="">
             <a:extLst xmlns:a="http://schemas.openxmlformats.org/drawingml/2006/main">
               <a:ext uri="{FF2B5EF4-FFF2-40B4-BE49-F238E27FC236}">
-                <a16:creationId xmlns:a16="http://schemas.microsoft.com/office/drawing/2014/main" id="{20396103-94E3-48F4-8C5C-8FB8C9F47EA1}"/>
+                <a16:creationId xmlns:a16="http://schemas.microsoft.com/office/drawing/2014/main" id="{BE12721F-F688-4806-8649-6115EE96A3F0}"/>
               </a:ext>
             </a:extLst>
           </p:cNvPr>
@@ -30243,7 +30243,7 @@
           <p:cNvPr id="35" name="">
             <a:extLst xmlns:a="http://schemas.openxmlformats.org/drawingml/2006/main">
               <a:ext uri="{FF2B5EF4-FFF2-40B4-BE49-F238E27FC236}">
-                <a16:creationId xmlns:a16="http://schemas.microsoft.com/office/drawing/2014/main" id="{6C15A39B-B78C-4C5B-8C2E-7288ADA8436C}"/>
+                <a16:creationId xmlns:a16="http://schemas.microsoft.com/office/drawing/2014/main" id="{CDE4D5A8-806C-49B5-86BA-7164D7EBAC45}"/>
               </a:ext>
             </a:extLst>
           </p:cNvPr>
@@ -30300,7 +30300,7 @@
           <p:cNvPr id="36" name="">
             <a:extLst xmlns:a="http://schemas.openxmlformats.org/drawingml/2006/main">
               <a:ext uri="{FF2B5EF4-FFF2-40B4-BE49-F238E27FC236}">
-                <a16:creationId xmlns:a16="http://schemas.microsoft.com/office/drawing/2014/main" id="{556F3C47-CAFC-47A7-B924-E6477F9418AE}"/>
+                <a16:creationId xmlns:a16="http://schemas.microsoft.com/office/drawing/2014/main" id="{A154BDAE-7AEE-424F-922C-9D2A8EF79DFA}"/>
               </a:ext>
             </a:extLst>
           </p:cNvPr>
@@ -30333,7 +30333,7 @@
           <p:cNvPr id="37" name="">
             <a:extLst xmlns:a="http://schemas.openxmlformats.org/drawingml/2006/main">
               <a:ext uri="{FF2B5EF4-FFF2-40B4-BE49-F238E27FC236}">
-                <a16:creationId xmlns:a16="http://schemas.microsoft.com/office/drawing/2014/main" id="{B5FE35EF-D22B-468F-91C5-AC73044DD83C}"/>
+                <a16:creationId xmlns:a16="http://schemas.microsoft.com/office/drawing/2014/main" id="{12A01D30-7680-4C06-A1E5-EC3E1D09D491}"/>
               </a:ext>
             </a:extLst>
           </p:cNvPr>
@@ -30390,7 +30390,7 @@
           <p:cNvPr id="38" name="">
             <a:extLst xmlns:a="http://schemas.openxmlformats.org/drawingml/2006/main">
               <a:ext uri="{FF2B5EF4-FFF2-40B4-BE49-F238E27FC236}">
-                <a16:creationId xmlns:a16="http://schemas.microsoft.com/office/drawing/2014/main" id="{87EBF289-53E1-43D9-A4F0-B0E5F1439ED7}"/>
+                <a16:creationId xmlns:a16="http://schemas.microsoft.com/office/drawing/2014/main" id="{8DAE10F2-44E0-468F-824C-199D90E454E9}"/>
               </a:ext>
             </a:extLst>
           </p:cNvPr>
@@ -30423,7 +30423,7 @@
           <p:cNvPr id="39" name="">
             <a:extLst xmlns:a="http://schemas.openxmlformats.org/drawingml/2006/main">
               <a:ext uri="{FF2B5EF4-FFF2-40B4-BE49-F238E27FC236}">
-                <a16:creationId xmlns:a16="http://schemas.microsoft.com/office/drawing/2014/main" id="{9656F133-1112-4216-973B-3AC1C0FC7D7C}"/>
+                <a16:creationId xmlns:a16="http://schemas.microsoft.com/office/drawing/2014/main" id="{61B14132-065F-47C8-AFD5-1167F4B4D656}"/>
               </a:ext>
             </a:extLst>
           </p:cNvPr>
@@ -30480,7 +30480,7 @@
           <p:cNvPr id="40" name="">
             <a:extLst xmlns:a="http://schemas.openxmlformats.org/drawingml/2006/main">
               <a:ext uri="{FF2B5EF4-FFF2-40B4-BE49-F238E27FC236}">
-                <a16:creationId xmlns:a16="http://schemas.microsoft.com/office/drawing/2014/main" id="{8BC1834C-FC3F-4D61-A77D-3FA1A6FAC9C9}"/>
+                <a16:creationId xmlns:a16="http://schemas.microsoft.com/office/drawing/2014/main" id="{72F4F25C-4284-4B13-A879-00D248839E88}"/>
               </a:ext>
             </a:extLst>
           </p:cNvPr>
@@ -30513,7 +30513,7 @@
           <p:cNvPr id="41" name="">
             <a:extLst xmlns:a="http://schemas.openxmlformats.org/drawingml/2006/main">
               <a:ext uri="{FF2B5EF4-FFF2-40B4-BE49-F238E27FC236}">
-                <a16:creationId xmlns:a16="http://schemas.microsoft.com/office/drawing/2014/main" id="{2CC10B65-3CF1-4D9E-AEB6-3E6E60DFD6F2}"/>
+                <a16:creationId xmlns:a16="http://schemas.microsoft.com/office/drawing/2014/main" id="{CD4D5F8A-EDA8-4F2D-97EB-423FD3308B9E}"/>
               </a:ext>
             </a:extLst>
           </p:cNvPr>
@@ -30593,7 +30593,7 @@
           <p:cNvPr id="42" name="">
             <a:extLst xmlns:a="http://schemas.openxmlformats.org/drawingml/2006/main">
               <a:ext uri="{FF2B5EF4-FFF2-40B4-BE49-F238E27FC236}">
-                <a16:creationId xmlns:a16="http://schemas.microsoft.com/office/drawing/2014/main" id="{646A9B63-33AE-47DA-BB66-003197E60CEF}"/>
+                <a16:creationId xmlns:a16="http://schemas.microsoft.com/office/drawing/2014/main" id="{A148C1ED-ADED-4E6A-A461-2B7D65AA2A0A}"/>
               </a:ext>
             </a:extLst>
           </p:cNvPr>
@@ -30650,7 +30650,7 @@
           <p:cNvPr id="43" name="">
             <a:extLst xmlns:a="http://schemas.openxmlformats.org/drawingml/2006/main">
               <a:ext uri="{FF2B5EF4-FFF2-40B4-BE49-F238E27FC236}">
-                <a16:creationId xmlns:a16="http://schemas.microsoft.com/office/drawing/2014/main" id="{56DB227C-784E-42F6-8136-A3CBF166C22A}"/>
+                <a16:creationId xmlns:a16="http://schemas.microsoft.com/office/drawing/2014/main" id="{4F37898C-C8B3-44D0-8C44-2568EA8C3B2F}"/>
               </a:ext>
             </a:extLst>
           </p:cNvPr>
@@ -30707,7 +30707,7 @@
           <p:cNvPr id="44" name="">
             <a:extLst xmlns:a="http://schemas.openxmlformats.org/drawingml/2006/main">
               <a:ext uri="{FF2B5EF4-FFF2-40B4-BE49-F238E27FC236}">
-                <a16:creationId xmlns:a16="http://schemas.microsoft.com/office/drawing/2014/main" id="{24ADA11A-2FF7-4FD4-A0A8-1CFF94B53156}"/>
+                <a16:creationId xmlns:a16="http://schemas.microsoft.com/office/drawing/2014/main" id="{035C667D-730D-4127-A5DC-2EF071314307}"/>
               </a:ext>
             </a:extLst>
           </p:cNvPr>
@@ -30764,7 +30764,7 @@
           <p:cNvPr id="45" name="">
             <a:extLst xmlns:a="http://schemas.openxmlformats.org/drawingml/2006/main">
               <a:ext uri="{FF2B5EF4-FFF2-40B4-BE49-F238E27FC236}">
-                <a16:creationId xmlns:a16="http://schemas.microsoft.com/office/drawing/2014/main" id="{FB52EF49-292A-43DC-A271-BA3917DD71C1}"/>
+                <a16:creationId xmlns:a16="http://schemas.microsoft.com/office/drawing/2014/main" id="{655237BE-12A6-4E4C-BBB6-180ED1298B9B}"/>
               </a:ext>
             </a:extLst>
           </p:cNvPr>
@@ -30795,7 +30795,7 @@
           <p:cNvPr id="46" name="">
             <a:extLst xmlns:a="http://schemas.openxmlformats.org/drawingml/2006/main">
               <a:ext uri="{FF2B5EF4-FFF2-40B4-BE49-F238E27FC236}">
-                <a16:creationId xmlns:a16="http://schemas.microsoft.com/office/drawing/2014/main" id="{BA263ABB-7780-400C-B78D-43AC5B669D5D}"/>
+                <a16:creationId xmlns:a16="http://schemas.microsoft.com/office/drawing/2014/main" id="{E0088C29-CDF9-4E15-A624-77A1C14C30E6}"/>
               </a:ext>
             </a:extLst>
           </p:cNvPr>
@@ -30852,7 +30852,7 @@
           <p:cNvPr id="47" name="">
             <a:extLst xmlns:a="http://schemas.openxmlformats.org/drawingml/2006/main">
               <a:ext uri="{FF2B5EF4-FFF2-40B4-BE49-F238E27FC236}">
-                <a16:creationId xmlns:a16="http://schemas.microsoft.com/office/drawing/2014/main" id="{4D2D7EE4-D051-49B7-976F-E82D4723C2F1}"/>
+                <a16:creationId xmlns:a16="http://schemas.microsoft.com/office/drawing/2014/main" id="{3A9933E4-DD46-4352-88B8-8108EE83CDC6}"/>
               </a:ext>
             </a:extLst>
           </p:cNvPr>
@@ -30909,7 +30909,7 @@
           <p:cNvPr id="48" name="">
             <a:extLst xmlns:a="http://schemas.openxmlformats.org/drawingml/2006/main">
               <a:ext uri="{FF2B5EF4-FFF2-40B4-BE49-F238E27FC236}">
-                <a16:creationId xmlns:a16="http://schemas.microsoft.com/office/drawing/2014/main" id="{8EB3A568-D6FE-46F5-B17F-CE334AC7C17C}"/>
+                <a16:creationId xmlns:a16="http://schemas.microsoft.com/office/drawing/2014/main" id="{2AF5423B-3FCB-4435-B061-6880C4509F60}"/>
               </a:ext>
             </a:extLst>
           </p:cNvPr>
@@ -30966,7 +30966,7 @@
           <p:cNvPr id="49" name="">
             <a:extLst xmlns:a="http://schemas.openxmlformats.org/drawingml/2006/main">
               <a:ext uri="{FF2B5EF4-FFF2-40B4-BE49-F238E27FC236}">
-                <a16:creationId xmlns:a16="http://schemas.microsoft.com/office/drawing/2014/main" id="{82CF06E4-ACC3-4D2B-AF8E-F0D17EBE2A74}"/>
+                <a16:creationId xmlns:a16="http://schemas.microsoft.com/office/drawing/2014/main" id="{8F267AED-5FF4-4AC6-A0C1-BC921AECDE5D}"/>
               </a:ext>
             </a:extLst>
           </p:cNvPr>
@@ -31023,7 +31023,7 @@
           <p:cNvPr id="50" name="">
             <a:extLst xmlns:a="http://schemas.openxmlformats.org/drawingml/2006/main">
               <a:ext uri="{FF2B5EF4-FFF2-40B4-BE49-F238E27FC236}">
-                <a16:creationId xmlns:a16="http://schemas.microsoft.com/office/drawing/2014/main" id="{4CB8C319-D726-479F-B9F3-5D5753D1C5CD}"/>
+                <a16:creationId xmlns:a16="http://schemas.microsoft.com/office/drawing/2014/main" id="{E101482A-E799-4F8D-AA73-7281ED6B527A}"/>
               </a:ext>
             </a:extLst>
           </p:cNvPr>
@@ -31080,7 +31080,7 @@
           <p:cNvPr id="51" name="">
             <a:extLst xmlns:a="http://schemas.openxmlformats.org/drawingml/2006/main">
               <a:ext uri="{FF2B5EF4-FFF2-40B4-BE49-F238E27FC236}">
-                <a16:creationId xmlns:a16="http://schemas.microsoft.com/office/drawing/2014/main" id="{8F3E39D7-1809-473A-95BF-A5B22A21735D}"/>
+                <a16:creationId xmlns:a16="http://schemas.microsoft.com/office/drawing/2014/main" id="{BEE3C33C-DBD3-43DB-A716-836621CAC4D6}"/>
               </a:ext>
             </a:extLst>
           </p:cNvPr>
@@ -31135,7 +31135,7 @@
     </p:spTree>
     <p:extLst>
       <p:ext uri="{BB962C8B-B14F-4D97-AF65-F5344CB8AC3E}">
-        <p14:creationId xmlns:p14="http://schemas.microsoft.com/office/powerpoint/2010/main" val="84175384"/>
+        <p14:creationId xmlns:p14="http://schemas.microsoft.com/office/powerpoint/2010/main" val="697095126"/>
       </p:ext>
     </p:extLst>
   </p:cSld>

</xml_diff>